<commit_message>
PPTX: Nicht-BÜ ehrlich einordnen - nicht alle 1.034 sind Fehlrouting
Nach User-Feedback: nicht behaupten, dass alle 1.034 Nicht-BÜ-Mails heute
falsch geroutet werden. Nachgewiesen ist v.a. das KV-Fehlrouting.

Folie 11 (Ableitungs-Trichter):
- Ast 1 zeigt jetzt Segment-Zahlen: KV 161 | Spam/leer 331 | Komposit 413 |
  Leben 93 | Sonst 36
- Einordnung kursiv: 'Bekanntes Fehlrouting v.a. KV; Spam/leer trivial;
  Komposit-Reminder laeuft heute schon'
- Kernaussage + Take-away entsprechend praezisiert

Folie 11a (Routing):
- Summary-Box: 'Klar adressierbar: KV 161 + Spam/leer 331 = ~490 Mails;
  Komposit/Leben-Keine-BÜ 247 = weiteres Potenzial - Reminder dort schon gut'
- Kernaussage 'Wichtig zur Einordnung: nicht alle 1.034 werden heute falsch
  geroutet - nachgewiesen ist v.a. die KV-Luecke'
- Take-away: ~490 statt ~800 (ehrlich), Spam-Zahl 343->331 korrigiert

https://claude.ai/code/session_01UknXtYp2XECsQDonCZuxSt
</commit_message>
<xml_diff>
--- a/ERGO-Mengengeruest-2Slides-Berichtslook.pptx
+++ b/ERGO-Mengengeruest-2Slides-Berichtslook.pptx
@@ -4432,7 +4432,7 @@
         <p:spPr>
           <a:xfrm>
             <a:off x="3017520" y="3035808"/>
-            <a:ext cx="5029200" cy="1051560"/>
+            <a:ext cx="5029200" cy="1188720"/>
           </a:xfrm>
           <a:prstGeom prst="rect">
             <a:avLst/>
@@ -4477,8 +4477,8 @@
         </p:nvSpPr>
         <p:spPr>
           <a:xfrm>
-            <a:off x="3200400" y="3108960"/>
-            <a:ext cx="4663440" cy="310896"/>
+            <a:off x="3200400" y="3090672"/>
+            <a:ext cx="4663440" cy="292608"/>
           </a:xfrm>
           <a:prstGeom prst="rect">
             <a:avLst/>
@@ -4493,13 +4493,13 @@
           <a:p>
             <a:pPr algn="l"/>
             <a:r>
-              <a:rPr sz="1400" b="1" i="0" u="none">
+              <a:rPr sz="1300" b="1" i="0" u="none">
                 <a:solidFill>
                   <a:srgbClr val="C86E10"/>
                 </a:solidFill>
                 <a:latin typeface="Calibri"/>
               </a:rPr>
-              <a:t>1.034 Nicht-BÜ-Mails  (20,5 %)</a:t>
+              <a:t>1.034 Nicht-BÜ-Mails  (20,5 %) – nach Segment:</a:t>
             </a:r>
           </a:p>
         </p:txBody>
@@ -4512,8 +4512,8 @@
         </p:nvSpPr>
         <p:spPr>
           <a:xfrm>
-            <a:off x="3200400" y="3447288"/>
-            <a:ext cx="4663440" cy="292608"/>
+            <a:off x="3200400" y="3401568"/>
+            <a:ext cx="4663440" cy="274320"/>
           </a:xfrm>
           <a:prstGeom prst="rect">
             <a:avLst/>
@@ -4534,7 +4534,7 @@
                 </a:solidFill>
                 <a:latin typeface="Calibri"/>
               </a:rPr>
-              <a:t>705 Keine BÜ (falscher Kanal)  +  329 BÜ-Reminder</a:t>
+              <a:t>KV 161   ·   Spam/Sparten-leer 331   ·   Komposit 413   ·   Leben 93   ·   Sonst 36</a:t>
             </a:r>
           </a:p>
         </p:txBody>
@@ -4547,8 +4547,8 @@
         </p:nvSpPr>
         <p:spPr>
           <a:xfrm>
-            <a:off x="3200400" y="3749040"/>
-            <a:ext cx="4663440" cy="292608"/>
+            <a:off x="3200400" y="3675888"/>
+            <a:ext cx="4663440" cy="274320"/>
           </a:xfrm>
           <a:prstGeom prst="rect">
             <a:avLst/>
@@ -4563,6 +4563,41 @@
           <a:p>
             <a:pPr algn="l"/>
             <a:r>
+              <a:rPr sz="1000" b="0" i="1" u="none">
+                <a:solidFill>
+                  <a:srgbClr val="666666"/>
+                </a:solidFill>
+                <a:latin typeface="Calibri"/>
+              </a:rPr>
+              <a:t>Bekanntes Fehlrouting v.a. KV; Spam/leer trivial; Komposit-Reminder laeuft heute schon</a:t>
+            </a:r>
+          </a:p>
+        </p:txBody>
+      </p:sp>
+      <p:sp>
+        <p:nvSpPr>
+          <p:cNvPr id="40" name="TextBox 39"/>
+          <p:cNvSpPr txBox="1"/>
+          <p:nvPr/>
+        </p:nvSpPr>
+        <p:spPr>
+          <a:xfrm>
+            <a:off x="3200400" y="3931920"/>
+            <a:ext cx="4663440" cy="274320"/>
+          </a:xfrm>
+          <a:prstGeom prst="rect">
+            <a:avLst/>
+          </a:prstGeom>
+          <a:noFill/>
+        </p:spPr>
+        <p:txBody>
+          <a:bodyPr wrap="square" lIns="36000" rIns="36000" tIns="18000" bIns="18000" anchor="t">
+            <a:spAutoFit/>
+          </a:bodyPr>
+          <a:lstStyle/>
+          <a:p>
+            <a:pPr algn="l"/>
+            <a:r>
               <a:rPr sz="1200" b="1" i="0" u="none">
                 <a:solidFill>
                   <a:srgbClr val="9C060F"/>
@@ -4576,14 +4611,14 @@
       </p:sp>
       <p:sp>
         <p:nvSpPr>
-          <p:cNvPr id="40" name="Rectangle 39"/>
+          <p:cNvPr id="41" name="Rectangle 40"/>
           <p:cNvSpPr/>
           <p:nvPr/>
         </p:nvSpPr>
         <p:spPr>
           <a:xfrm>
-            <a:off x="3017520" y="4251960"/>
-            <a:ext cx="5029200" cy="1234440"/>
+            <a:off x="3017520" y="4361688"/>
+            <a:ext cx="5029200" cy="1188720"/>
           </a:xfrm>
           <a:prstGeom prst="rect">
             <a:avLst/>
@@ -4622,13 +4657,13 @@
       </p:sp>
       <p:sp>
         <p:nvSpPr>
-          <p:cNvPr id="41" name="TextBox 40"/>
-          <p:cNvSpPr txBox="1"/>
-          <p:nvPr/>
-        </p:nvSpPr>
-        <p:spPr>
-          <a:xfrm>
-            <a:off x="3200400" y="4325112"/>
+          <p:cNvPr id="42" name="TextBox 41"/>
+          <p:cNvSpPr txBox="1"/>
+          <p:nvPr/>
+        </p:nvSpPr>
+        <p:spPr>
+          <a:xfrm>
+            <a:off x="3200400" y="4434840"/>
             <a:ext cx="4663440" cy="310896"/>
           </a:xfrm>
           <a:prstGeom prst="rect">
@@ -4657,13 +4692,13 @@
       </p:sp>
       <p:sp>
         <p:nvSpPr>
-          <p:cNvPr id="42" name="TextBox 41"/>
-          <p:cNvSpPr txBox="1"/>
-          <p:nvPr/>
-        </p:nvSpPr>
-        <p:spPr>
-          <a:xfrm>
-            <a:off x="3200400" y="4663440"/>
+          <p:cNvPr id="43" name="TextBox 42"/>
+          <p:cNvSpPr txBox="1"/>
+          <p:nvPr/>
+        </p:nvSpPr>
+        <p:spPr>
+          <a:xfrm>
+            <a:off x="3200400" y="4773168"/>
             <a:ext cx="4663440" cy="457200"/>
           </a:xfrm>
           <a:prstGeom prst="rect">
@@ -4692,13 +4727,13 @@
       </p:sp>
       <p:sp>
         <p:nvSpPr>
-          <p:cNvPr id="43" name="TextBox 42"/>
-          <p:cNvSpPr txBox="1"/>
-          <p:nvPr/>
-        </p:nvSpPr>
-        <p:spPr>
-          <a:xfrm>
-            <a:off x="3200400" y="5148072"/>
+          <p:cNvPr id="44" name="TextBox 43"/>
+          <p:cNvSpPr txBox="1"/>
+          <p:nvPr/>
+        </p:nvSpPr>
+        <p:spPr>
+          <a:xfrm>
+            <a:off x="3200400" y="5257800"/>
             <a:ext cx="4663440" cy="292608"/>
           </a:xfrm>
           <a:prstGeom prst="rect">
@@ -4727,13 +4762,13 @@
       </p:sp>
       <p:sp>
         <p:nvSpPr>
-          <p:cNvPr id="44" name="Right Arrow 43"/>
+          <p:cNvPr id="45" name="Right Arrow 44"/>
           <p:cNvSpPr/>
           <p:nvPr/>
         </p:nvSpPr>
         <p:spPr>
           <a:xfrm>
-            <a:off x="2514600" y="3904488"/>
+            <a:off x="2514600" y="4041648"/>
             <a:ext cx="457200" cy="274320"/>
           </a:xfrm>
           <a:prstGeom prst="rightArrow">
@@ -4771,13 +4806,13 @@
       </p:sp>
       <p:sp>
         <p:nvSpPr>
-          <p:cNvPr id="45" name="Right Arrow 44"/>
+          <p:cNvPr id="46" name="Right Arrow 45"/>
           <p:cNvSpPr/>
           <p:nvPr/>
         </p:nvSpPr>
         <p:spPr>
           <a:xfrm>
-            <a:off x="2514600" y="4389120"/>
+            <a:off x="2514600" y="4498848"/>
             <a:ext cx="457200" cy="274320"/>
           </a:xfrm>
           <a:prstGeom prst="rightArrow">
@@ -4815,7 +4850,7 @@
       </p:sp>
       <p:sp>
         <p:nvSpPr>
-          <p:cNvPr id="46" name="Rectangle 45"/>
+          <p:cNvPr id="47" name="Rectangle 46"/>
           <p:cNvSpPr/>
           <p:nvPr/>
         </p:nvSpPr>
@@ -4859,7 +4894,7 @@
       </p:sp>
       <p:sp>
         <p:nvSpPr>
-          <p:cNvPr id="47" name="Oval 46"/>
+          <p:cNvPr id="48" name="Oval 47"/>
           <p:cNvSpPr/>
           <p:nvPr/>
         </p:nvSpPr>
@@ -4903,7 +4938,7 @@
       </p:sp>
       <p:sp>
         <p:nvSpPr>
-          <p:cNvPr id="48" name="TextBox 47"/>
+          <p:cNvPr id="49" name="TextBox 48"/>
           <p:cNvSpPr txBox="1"/>
           <p:nvPr/>
         </p:nvSpPr>
@@ -4938,7 +4973,7 @@
       </p:sp>
       <p:sp>
         <p:nvSpPr>
-          <p:cNvPr id="49" name="TextBox 48"/>
+          <p:cNvPr id="50" name="TextBox 49"/>
           <p:cNvSpPr txBox="1"/>
           <p:nvPr/>
         </p:nvSpPr>
@@ -4982,7 +5017,7 @@
       </p:sp>
       <p:sp>
         <p:nvSpPr>
-          <p:cNvPr id="50" name="Oval 49"/>
+          <p:cNvPr id="51" name="Oval 50"/>
           <p:cNvSpPr/>
           <p:nvPr/>
         </p:nvSpPr>
@@ -5026,7 +5061,7 @@
       </p:sp>
       <p:sp>
         <p:nvSpPr>
-          <p:cNvPr id="51" name="TextBox 50"/>
+          <p:cNvPr id="52" name="TextBox 51"/>
           <p:cNvSpPr txBox="1"/>
           <p:nvPr/>
         </p:nvSpPr>
@@ -5061,7 +5096,7 @@
       </p:sp>
       <p:sp>
         <p:nvSpPr>
-          <p:cNvPr id="52" name="TextBox 51"/>
+          <p:cNvPr id="53" name="TextBox 52"/>
           <p:cNvSpPr txBox="1"/>
           <p:nvPr/>
         </p:nvSpPr>
@@ -5105,7 +5140,7 @@
       </p:sp>
       <p:sp>
         <p:nvSpPr>
-          <p:cNvPr id="53" name="Oval 52"/>
+          <p:cNvPr id="54" name="Oval 53"/>
           <p:cNvSpPr/>
           <p:nvPr/>
         </p:nvSpPr>
@@ -5149,7 +5184,7 @@
       </p:sp>
       <p:sp>
         <p:nvSpPr>
-          <p:cNvPr id="54" name="TextBox 53"/>
+          <p:cNvPr id="55" name="TextBox 54"/>
           <p:cNvSpPr txBox="1"/>
           <p:nvPr/>
         </p:nvSpPr>
@@ -5184,7 +5219,7 @@
       </p:sp>
       <p:sp>
         <p:nvSpPr>
-          <p:cNvPr id="55" name="TextBox 54"/>
+          <p:cNvPr id="56" name="TextBox 55"/>
           <p:cNvSpPr txBox="1"/>
           <p:nvPr/>
         </p:nvSpPr>
@@ -5221,14 +5256,14 @@
                 </a:solidFill>
                 <a:latin typeface="Calibri"/>
               </a:rPr>
-              <a:t>Status-Split zeigt 1.034 Nicht-BÜ-Mails (705 Keine BÜ + 329 Reminder) → falsches Routing.</a:t>
-            </a:r>
-          </a:p>
-        </p:txBody>
-      </p:sp>
-      <p:sp>
-        <p:nvSpPr>
-          <p:cNvPr id="56" name="Oval 55"/>
+              <a:t>1.034 Mails sind keine neue BÜ – bekanntes Fehlrouting v.a. in KV (161), Spam/leer (331) trivial filterbar.</a:t>
+            </a:r>
+          </a:p>
+        </p:txBody>
+      </p:sp>
+      <p:sp>
+        <p:nvSpPr>
+          <p:cNvPr id="57" name="Oval 56"/>
           <p:cNvSpPr/>
           <p:nvPr/>
         </p:nvSpPr>
@@ -5272,7 +5307,7 @@
       </p:sp>
       <p:sp>
         <p:nvSpPr>
-          <p:cNvPr id="57" name="TextBox 56"/>
+          <p:cNvPr id="58" name="TextBox 57"/>
           <p:cNvSpPr txBox="1"/>
           <p:nvPr/>
         </p:nvSpPr>
@@ -5307,7 +5342,7 @@
       </p:sp>
       <p:sp>
         <p:nvSpPr>
-          <p:cNvPr id="58" name="TextBox 57"/>
+          <p:cNvPr id="59" name="TextBox 58"/>
           <p:cNvSpPr txBox="1"/>
           <p:nvPr/>
         </p:nvSpPr>
@@ -5351,7 +5386,7 @@
       </p:sp>
       <p:sp>
         <p:nvSpPr>
-          <p:cNvPr id="59" name="Oval 58"/>
+          <p:cNvPr id="60" name="Oval 59"/>
           <p:cNvSpPr/>
           <p:nvPr/>
         </p:nvSpPr>
@@ -5395,7 +5430,7 @@
       </p:sp>
       <p:sp>
         <p:nvSpPr>
-          <p:cNvPr id="60" name="TextBox 59"/>
+          <p:cNvPr id="61" name="TextBox 60"/>
           <p:cNvSpPr txBox="1"/>
           <p:nvPr/>
         </p:nvSpPr>
@@ -5430,7 +5465,7 @@
       </p:sp>
       <p:sp>
         <p:nvSpPr>
-          <p:cNvPr id="61" name="TextBox 60"/>
+          <p:cNvPr id="62" name="TextBox 61"/>
           <p:cNvSpPr txBox="1"/>
           <p:nvPr/>
         </p:nvSpPr>
@@ -5474,7 +5509,7 @@
       </p:sp>
       <p:sp>
         <p:nvSpPr>
-          <p:cNvPr id="62" name="TextBox 61"/>
+          <p:cNvPr id="63" name="TextBox 62"/>
           <p:cNvSpPr txBox="1"/>
           <p:nvPr/>
         </p:nvSpPr>
@@ -5509,7 +5544,7 @@
       </p:sp>
       <p:sp>
         <p:nvSpPr>
-          <p:cNvPr id="63" name="Rectangle 62"/>
+          <p:cNvPr id="64" name="Rectangle 63"/>
           <p:cNvSpPr/>
           <p:nvPr/>
         </p:nvSpPr>
@@ -5553,7 +5588,7 @@
       </p:sp>
       <p:sp>
         <p:nvSpPr>
-          <p:cNvPr id="64" name="TextBox 63"/>
+          <p:cNvPr id="65" name="TextBox 64"/>
           <p:cNvSpPr txBox="1"/>
           <p:nvPr/>
         </p:nvSpPr>
@@ -5581,7 +5616,7 @@
                 </a:solidFill>
                 <a:latin typeface="Calibri"/>
               </a:rPr>
-              <a:t>TAKE-AWAY:  Aus dem Status-Split des Mengengeruests folgen zwei Hebel: 1.034 Nicht-BÜ-Mails → Routing (11a); 4.000 BÜ-Mails buendeln sich zu 2.495 Vorgaengen → Clustering &amp; Arbeitsvorrats-Steuerung (11b).</a:t>
+              <a:t>TAKE-AWAY:  Aus dem Status-Split folgen zwei Hebel: Nicht-BÜ-Mails → besseres Routing, bekanntes Fehlrouting v.a. in KV (11a); 4.000 BÜ-Mails buendeln sich zu 2.495 Vorgaengen → Clustering &amp; Arbeitsvorrats-Steuerung (11b).</a:t>
             </a:r>
           </a:p>
         </p:txBody>
@@ -7651,7 +7686,7 @@
                 </a:solidFill>
                 <a:latin typeface="Calibri"/>
               </a:rPr>
-              <a:t>343</a:t>
+              <a:t>331</a:t>
             </a:r>
           </a:p>
         </p:txBody>
@@ -7686,7 +7721,7 @@
                 </a:solidFill>
                 <a:latin typeface="Calibri"/>
               </a:rPr>
-              <a:t>343 (100 %)</a:t>
+              <a:t>331 (100 %)</a:t>
             </a:r>
           </a:p>
         </p:txBody>
@@ -7835,7 +7870,7 @@
                 </a:solidFill>
                 <a:latin typeface="Calibri"/>
               </a:rPr>
-              <a:t>343 Mails (trivial)</a:t>
+              <a:t>331 Mails (trivial)</a:t>
             </a:r>
           </a:p>
         </p:txBody>
@@ -8256,7 +8291,7 @@
                 </a:solidFill>
                 <a:latin typeface="Calibri"/>
               </a:rPr>
-              <a:t>Gesamt 1.034 Nicht-BÜ-Mails / Woche  –  Komposit-Reminder (221) heute schon gut gefiltert  -&gt;  realer Verbesserungs-Hebel ~800 Mails / Woche</a:t>
+              <a:t>Klar adressierbar: KV-Fehlrouting 161 + Spam/Sparten-leer 331 = ~490 Mails / Woche.  Komposit/Leben-Keine-BÜ (247) = weiteres Potenzial – Reminder dort heute schon gut.</a:t>
             </a:r>
           </a:p>
         </p:txBody>
@@ -8546,7 +8581,7 @@
                 </a:solidFill>
                 <a:latin typeface="Calibri"/>
               </a:rPr>
-              <a:t>343 Mails (33 % der Nicht-BÜ) sind trivial mit Header-/Absender-Regeln auszufiltern.</a:t>
+              <a:t>331 Mails (Sparte nicht erkennbar) sind trivial mit Header-/Absender-Regeln auszufiltern.</a:t>
             </a:r>
           </a:p>
         </p:txBody>
@@ -8660,7 +8695,7 @@
                 </a:solidFill>
                 <a:latin typeface="Calibri"/>
               </a:rPr>
-              <a:t>Komposit-Reminder OK: </a:t>
+              <a:t>Komposit laeuft heute weitgehend: </a:t>
             </a:r>
             <a:r>
               <a:rPr sz="1100">
@@ -8669,7 +8704,7 @@
                 </a:solidFill>
                 <a:latin typeface="Calibri"/>
               </a:rPr>
-              <a:t>221 Komposit-Reminder werden heute schon gut erkannt – kein neuer Hebel.</a:t>
+              <a:t>221 Komposit-Reminder werden heute schon gut erkannt – kein nachgewiesenes Fehlrouting.</a:t>
             </a:r>
           </a:p>
         </p:txBody>
@@ -8783,7 +8818,7 @@
                 </a:solidFill>
                 <a:latin typeface="Calibri"/>
               </a:rPr>
-              <a:t>Routing-Wirkung: </a:t>
+              <a:t>Wichtig zur Einordnung: </a:t>
             </a:r>
             <a:r>
               <a:rPr sz="1100">
@@ -8792,7 +8827,7 @@
                 </a:solidFill>
                 <a:latin typeface="Calibri"/>
               </a:rPr>
-              <a:t>Strukturierte Vorqualifizierung leitet Nicht-BÜ-Mails direkt in das richtige Fachpostfach.</a:t>
+              <a:t>Nicht alle 1.034 Mails werden heute falsch geroutet – nachgewiesen ist v.a. die KV-Luecke.</a:t>
             </a:r>
           </a:p>
         </p:txBody>
@@ -8915,7 +8950,7 @@
                 </a:solidFill>
                 <a:latin typeface="Calibri"/>
               </a:rPr>
-              <a:t>1) Spam/leer-Filter  2) KV-Triage aufbauen  3) Komposit-Keine-BÜ routen.</a:t>
+              <a:t>1) Spam/leer-Filter  2) KV-Triage aufbauen  3) Komposit/Leben-Keine-BÜ pruefen.</a:t>
             </a:r>
           </a:p>
         </p:txBody>
@@ -9029,7 +9064,7 @@
                 </a:solidFill>
                 <a:latin typeface="Calibri"/>
               </a:rPr>
-              <a:t>TAKE-AWAY:  Routing-Hebel ~800 Mails / Woche (-16 %) – Schwerpunkt KV-Triage und Spam/Sparten-leer; Basis ist die strukturierte Vorqualifizierung jeder Eingangsmail.</a:t>
+              <a:t>TAKE-AWAY:  Klar adressierbarer Routing-Hebel ~490 Mails / Woche (KV-Fehlrouting 161 + Spam/leer 331); Komposit/Leben mit weiterem Potenzial, aber dort laeuft das Routing heute teils schon.</a:t>
             </a:r>
           </a:p>
         </p:txBody>

</xml_diff>

<commit_message>
PPTX 11a: Fehlrouting als Segment-Tabelle (Sparte x Status)
Statt nur Summenzeile jetzt echte Segment-Tabelle der 240 MV-Fehlrouting-
Mails: Sparte | Reminder(mit MV) | Keine BÜ(mit MV) | Summe | Anteil
  Komposit 135+20=155 (65%) | KV 40+7=47 (20%) | Leben 29+2=31 (13%) |
  Mehrere/Unbek. 6+1=7 (3%) | Gesamt 210+30=240
Hinweis: Mechanismus in allen Sparten gleich, Reminder dominieren.

https://claude.ai/code/session_01UknXtYp2XECsQDonCZuxSt
</commit_message>
<xml_diff>
--- a/ERGO-Mengengeruest-2Slides-Berichtslook.pptx
+++ b/ERGO-Mengengeruest-2Slides-Berichtslook.pptx
@@ -6422,7 +6422,7 @@
         <p:spPr>
           <a:xfrm>
             <a:off x="411480" y="3520440"/>
-            <a:ext cx="2468880" cy="365760"/>
+            <a:ext cx="2103120" cy="365760"/>
           </a:xfrm>
           <a:prstGeom prst="rect">
             <a:avLst/>
@@ -6443,7 +6443,7 @@
                 </a:solidFill>
                 <a:latin typeface="Calibri"/>
               </a:rPr>
-              <a:t>Was die Mail wirklich ist</a:t>
+              <a:t>Sparte</a:t>
             </a:r>
           </a:p>
         </p:txBody>
@@ -6456,8 +6456,8 @@
         </p:nvSpPr>
         <p:spPr>
           <a:xfrm>
-            <a:off x="2880360" y="3520440"/>
-            <a:ext cx="1371600" cy="365760"/>
+            <a:off x="2514600" y="3520440"/>
+            <a:ext cx="1691640" cy="365760"/>
           </a:xfrm>
           <a:prstGeom prst="rect">
             <a:avLst/>
@@ -6478,7 +6478,7 @@
                 </a:solidFill>
                 <a:latin typeface="Calibri"/>
               </a:rPr>
-              <a:t>Mails / Wo</a:t>
+              <a:t>Reminder (mit MV)</a:t>
             </a:r>
           </a:p>
         </p:txBody>
@@ -6491,8 +6491,8 @@
         </p:nvSpPr>
         <p:spPr>
           <a:xfrm>
-            <a:off x="4251960" y="3520440"/>
-            <a:ext cx="1965960" cy="365760"/>
+            <a:off x="4206240" y="3520440"/>
+            <a:ext cx="1691640" cy="365760"/>
           </a:xfrm>
           <a:prstGeom prst="rect">
             <a:avLst/>
@@ -6513,7 +6513,7 @@
                 </a:solidFill>
                 <a:latin typeface="Calibri"/>
               </a:rPr>
-              <a:t>warum es Fehlrouting ist</a:t>
+              <a:t>Keine BÜ (mit MV)</a:t>
             </a:r>
           </a:p>
         </p:txBody>
@@ -6526,8 +6526,8 @@
         </p:nvSpPr>
         <p:spPr>
           <a:xfrm>
-            <a:off x="6217920" y="3520440"/>
-            <a:ext cx="1828800" cy="365760"/>
+            <a:off x="5897880" y="3520440"/>
+            <a:ext cx="1234440" cy="365760"/>
           </a:xfrm>
           <a:prstGeom prst="rect">
             <a:avLst/>
@@ -6548,21 +6548,56 @@
                 </a:solidFill>
                 <a:latin typeface="Calibri"/>
               </a:rPr>
-              <a:t>KI erkennt</a:t>
-            </a:r>
-          </a:p>
-        </p:txBody>
-      </p:sp>
-      <p:sp>
-        <p:nvSpPr>
-          <p:cNvPr id="26" name="Rectangle 25"/>
+              <a:t>Summe / Wo</a:t>
+            </a:r>
+          </a:p>
+        </p:txBody>
+      </p:sp>
+      <p:sp>
+        <p:nvSpPr>
+          <p:cNvPr id="26" name="TextBox 25"/>
+          <p:cNvSpPr txBox="1"/>
+          <p:nvPr/>
+        </p:nvSpPr>
+        <p:spPr>
+          <a:xfrm>
+            <a:off x="7132320" y="3520440"/>
+            <a:ext cx="914400" cy="365760"/>
+          </a:xfrm>
+          <a:prstGeom prst="rect">
+            <a:avLst/>
+          </a:prstGeom>
+          <a:noFill/>
+        </p:spPr>
+        <p:txBody>
+          <a:bodyPr wrap="square" lIns="36000" rIns="36000" tIns="18000" bIns="18000" anchor="ctr">
+            <a:spAutoFit/>
+          </a:bodyPr>
+          <a:lstStyle/>
+          <a:p>
+            <a:pPr algn="ctr"/>
+            <a:r>
+              <a:rPr sz="1000" b="1" i="0" u="none">
+                <a:solidFill>
+                  <a:srgbClr val="FFFFFF"/>
+                </a:solidFill>
+                <a:latin typeface="Calibri"/>
+              </a:rPr>
+              <a:t>Anteil</a:t>
+            </a:r>
+          </a:p>
+        </p:txBody>
+      </p:sp>
+      <p:sp>
+        <p:nvSpPr>
+          <p:cNvPr id="27" name="Rectangle 26"/>
           <p:cNvSpPr/>
           <p:nvPr/>
         </p:nvSpPr>
         <p:spPr>
           <a:xfrm>
             <a:off x="411480" y="3886200"/>
-            <a:ext cx="7635240" cy="457200"/>
+            <a:ext cx="7635240" cy="365760"/>
           </a:xfrm>
           <a:prstGeom prst="rect">
             <a:avLst/>
@@ -6599,14 +6634,277 @@
       </p:sp>
       <p:sp>
         <p:nvSpPr>
-          <p:cNvPr id="27" name="Rectangle 26"/>
+          <p:cNvPr id="28" name="Rectangle 27"/>
           <p:cNvSpPr/>
           <p:nvPr/>
         </p:nvSpPr>
         <p:spPr>
           <a:xfrm>
             <a:off x="411480" y="3886200"/>
-            <a:ext cx="109728" cy="457200"/>
+            <a:ext cx="109728" cy="365760"/>
+          </a:xfrm>
+          <a:prstGeom prst="rect">
+            <a:avLst/>
+          </a:prstGeom>
+          <a:solidFill>
+            <a:srgbClr val="888888"/>
+          </a:solidFill>
+          <a:ln>
+            <a:noFill/>
+          </a:ln>
+          <a:effectLst/>
+        </p:spPr>
+        <p:style>
+          <a:lnRef idx="1">
+            <a:schemeClr val="accent1"/>
+          </a:lnRef>
+          <a:fillRef idx="3">
+            <a:schemeClr val="accent1"/>
+          </a:fillRef>
+          <a:effectRef idx="2">
+            <a:schemeClr val="accent1"/>
+          </a:effectRef>
+          <a:fontRef idx="minor">
+            <a:schemeClr val="lt1"/>
+          </a:fontRef>
+        </p:style>
+        <p:txBody>
+          <a:bodyPr rtlCol="0" anchor="ctr"/>
+          <a:lstStyle/>
+          <a:p>
+            <a:pPr algn="ctr"/>
+          </a:p>
+        </p:txBody>
+      </p:sp>
+      <p:sp>
+        <p:nvSpPr>
+          <p:cNvPr id="29" name="TextBox 28"/>
+          <p:cNvSpPr txBox="1"/>
+          <p:nvPr/>
+        </p:nvSpPr>
+        <p:spPr>
+          <a:xfrm>
+            <a:off x="539496" y="3886200"/>
+            <a:ext cx="1975104" cy="365760"/>
+          </a:xfrm>
+          <a:prstGeom prst="rect">
+            <a:avLst/>
+          </a:prstGeom>
+          <a:noFill/>
+        </p:spPr>
+        <p:txBody>
+          <a:bodyPr wrap="square" lIns="36000" rIns="36000" tIns="18000" bIns="18000" anchor="ctr">
+            <a:spAutoFit/>
+          </a:bodyPr>
+          <a:lstStyle/>
+          <a:p>
+            <a:pPr algn="l"/>
+            <a:r>
+              <a:rPr sz="1100" b="1" i="0" u="none">
+                <a:solidFill>
+                  <a:srgbClr val="333333"/>
+                </a:solidFill>
+                <a:latin typeface="Calibri"/>
+              </a:rPr>
+              <a:t>Komposit</a:t>
+            </a:r>
+          </a:p>
+        </p:txBody>
+      </p:sp>
+      <p:sp>
+        <p:nvSpPr>
+          <p:cNvPr id="30" name="TextBox 29"/>
+          <p:cNvSpPr txBox="1"/>
+          <p:nvPr/>
+        </p:nvSpPr>
+        <p:spPr>
+          <a:xfrm>
+            <a:off x="2514600" y="3886200"/>
+            <a:ext cx="1691640" cy="365760"/>
+          </a:xfrm>
+          <a:prstGeom prst="rect">
+            <a:avLst/>
+          </a:prstGeom>
+          <a:noFill/>
+        </p:spPr>
+        <p:txBody>
+          <a:bodyPr wrap="square" lIns="36000" rIns="36000" tIns="18000" bIns="18000" anchor="ctr">
+            <a:spAutoFit/>
+          </a:bodyPr>
+          <a:lstStyle/>
+          <a:p>
+            <a:pPr algn="ctr"/>
+            <a:r>
+              <a:rPr sz="1100" b="0" i="0" u="none">
+                <a:solidFill>
+                  <a:srgbClr val="333333"/>
+                </a:solidFill>
+                <a:latin typeface="Calibri"/>
+              </a:rPr>
+              <a:t>135</a:t>
+            </a:r>
+          </a:p>
+        </p:txBody>
+      </p:sp>
+      <p:sp>
+        <p:nvSpPr>
+          <p:cNvPr id="31" name="TextBox 30"/>
+          <p:cNvSpPr txBox="1"/>
+          <p:nvPr/>
+        </p:nvSpPr>
+        <p:spPr>
+          <a:xfrm>
+            <a:off x="4206240" y="3886200"/>
+            <a:ext cx="1691640" cy="365760"/>
+          </a:xfrm>
+          <a:prstGeom prst="rect">
+            <a:avLst/>
+          </a:prstGeom>
+          <a:noFill/>
+        </p:spPr>
+        <p:txBody>
+          <a:bodyPr wrap="square" lIns="36000" rIns="36000" tIns="18000" bIns="18000" anchor="ctr">
+            <a:spAutoFit/>
+          </a:bodyPr>
+          <a:lstStyle/>
+          <a:p>
+            <a:pPr algn="ctr"/>
+            <a:r>
+              <a:rPr sz="1100" b="0" i="0" u="none">
+                <a:solidFill>
+                  <a:srgbClr val="333333"/>
+                </a:solidFill>
+                <a:latin typeface="Calibri"/>
+              </a:rPr>
+              <a:t>20</a:t>
+            </a:r>
+          </a:p>
+        </p:txBody>
+      </p:sp>
+      <p:sp>
+        <p:nvSpPr>
+          <p:cNvPr id="32" name="TextBox 31"/>
+          <p:cNvSpPr txBox="1"/>
+          <p:nvPr/>
+        </p:nvSpPr>
+        <p:spPr>
+          <a:xfrm>
+            <a:off x="5897880" y="3886200"/>
+            <a:ext cx="1234440" cy="365760"/>
+          </a:xfrm>
+          <a:prstGeom prst="rect">
+            <a:avLst/>
+          </a:prstGeom>
+          <a:noFill/>
+        </p:spPr>
+        <p:txBody>
+          <a:bodyPr wrap="square" lIns="36000" rIns="36000" tIns="18000" bIns="18000" anchor="ctr">
+            <a:spAutoFit/>
+          </a:bodyPr>
+          <a:lstStyle/>
+          <a:p>
+            <a:pPr algn="ctr"/>
+            <a:r>
+              <a:rPr sz="1100" b="1" i="0" u="none">
+                <a:solidFill>
+                  <a:srgbClr val="333333"/>
+                </a:solidFill>
+                <a:latin typeface="Calibri"/>
+              </a:rPr>
+              <a:t>155</a:t>
+            </a:r>
+          </a:p>
+        </p:txBody>
+      </p:sp>
+      <p:sp>
+        <p:nvSpPr>
+          <p:cNvPr id="33" name="TextBox 32"/>
+          <p:cNvSpPr txBox="1"/>
+          <p:nvPr/>
+        </p:nvSpPr>
+        <p:spPr>
+          <a:xfrm>
+            <a:off x="7132320" y="3886200"/>
+            <a:ext cx="914400" cy="365760"/>
+          </a:xfrm>
+          <a:prstGeom prst="rect">
+            <a:avLst/>
+          </a:prstGeom>
+          <a:noFill/>
+        </p:spPr>
+        <p:txBody>
+          <a:bodyPr wrap="square" lIns="36000" rIns="36000" tIns="18000" bIns="18000" anchor="ctr">
+            <a:spAutoFit/>
+          </a:bodyPr>
+          <a:lstStyle/>
+          <a:p>
+            <a:pPr algn="ctr"/>
+            <a:r>
+              <a:rPr sz="1100" b="0" i="0" u="none">
+                <a:solidFill>
+                  <a:srgbClr val="333333"/>
+                </a:solidFill>
+                <a:latin typeface="Calibri"/>
+              </a:rPr>
+              <a:t>65 %</a:t>
+            </a:r>
+          </a:p>
+        </p:txBody>
+      </p:sp>
+      <p:sp>
+        <p:nvSpPr>
+          <p:cNvPr id="34" name="Rectangle 33"/>
+          <p:cNvSpPr/>
+          <p:nvPr/>
+        </p:nvSpPr>
+        <p:spPr>
+          <a:xfrm>
+            <a:off x="411480" y="4251960"/>
+            <a:ext cx="7635240" cy="365760"/>
+          </a:xfrm>
+          <a:prstGeom prst="rect">
+            <a:avLst/>
+          </a:prstGeom>
+          <a:solidFill>
+            <a:srgbClr val="F1F1F1"/>
+          </a:solidFill>
+          <a:ln>
+            <a:noFill/>
+          </a:ln>
+          <a:effectLst/>
+        </p:spPr>
+        <p:style>
+          <a:lnRef idx="1">
+            <a:schemeClr val="accent1"/>
+          </a:lnRef>
+          <a:fillRef idx="3">
+            <a:schemeClr val="accent1"/>
+          </a:fillRef>
+          <a:effectRef idx="2">
+            <a:schemeClr val="accent1"/>
+          </a:effectRef>
+          <a:fontRef idx="minor">
+            <a:schemeClr val="lt1"/>
+          </a:fontRef>
+        </p:style>
+        <p:txBody>
+          <a:bodyPr rtlCol="0" anchor="ctr"/>
+          <a:lstStyle/>
+          <a:p>
+            <a:pPr algn="ctr"/>
+          </a:p>
+        </p:txBody>
+      </p:sp>
+      <p:sp>
+        <p:nvSpPr>
+          <p:cNvPr id="35" name="Rectangle 34"/>
+          <p:cNvSpPr/>
+          <p:nvPr/>
+        </p:nvSpPr>
+        <p:spPr>
+          <a:xfrm>
+            <a:off x="411480" y="4251960"/>
+            <a:ext cx="109728" cy="365760"/>
           </a:xfrm>
           <a:prstGeom prst="rect">
             <a:avLst/>
@@ -6643,14 +6941,14 @@
       </p:sp>
       <p:sp>
         <p:nvSpPr>
-          <p:cNvPr id="28" name="TextBox 27"/>
-          <p:cNvSpPr txBox="1"/>
-          <p:nvPr/>
-        </p:nvSpPr>
-        <p:spPr>
-          <a:xfrm>
-            <a:off x="539496" y="3886200"/>
-            <a:ext cx="2340864" cy="457200"/>
+          <p:cNvPr id="36" name="TextBox 35"/>
+          <p:cNvSpPr txBox="1"/>
+          <p:nvPr/>
+        </p:nvSpPr>
+        <p:spPr>
+          <a:xfrm>
+            <a:off x="539496" y="4251960"/>
+            <a:ext cx="1975104" cy="365760"/>
           </a:xfrm>
           <a:prstGeom prst="rect">
             <a:avLst/>
@@ -6665,27 +6963,62 @@
           <a:p>
             <a:pPr algn="l"/>
             <a:r>
+              <a:rPr sz="1100" b="1" i="0" u="none">
+                <a:solidFill>
+                  <a:srgbClr val="333333"/>
+                </a:solidFill>
+                <a:latin typeface="Calibri"/>
+              </a:rPr>
+              <a:t>KV</a:t>
+            </a:r>
+          </a:p>
+        </p:txBody>
+      </p:sp>
+      <p:sp>
+        <p:nvSpPr>
+          <p:cNvPr id="37" name="TextBox 36"/>
+          <p:cNvSpPr txBox="1"/>
+          <p:nvPr/>
+        </p:nvSpPr>
+        <p:spPr>
+          <a:xfrm>
+            <a:off x="2514600" y="4251960"/>
+            <a:ext cx="1691640" cy="365760"/>
+          </a:xfrm>
+          <a:prstGeom prst="rect">
+            <a:avLst/>
+          </a:prstGeom>
+          <a:noFill/>
+        </p:spPr>
+        <p:txBody>
+          <a:bodyPr wrap="square" lIns="36000" rIns="36000" tIns="18000" bIns="18000" anchor="ctr">
+            <a:spAutoFit/>
+          </a:bodyPr>
+          <a:lstStyle/>
+          <a:p>
+            <a:pPr algn="ctr"/>
+            <a:r>
               <a:rPr sz="1100" b="0" i="0" u="none">
                 <a:solidFill>
                   <a:srgbClr val="333333"/>
                 </a:solidFill>
                 <a:latin typeface="Calibri"/>
               </a:rPr>
-              <a:t>BÜ-Reminder (mit MV)</a:t>
-            </a:r>
-          </a:p>
-        </p:txBody>
-      </p:sp>
-      <p:sp>
-        <p:nvSpPr>
-          <p:cNvPr id="29" name="TextBox 28"/>
-          <p:cNvSpPr txBox="1"/>
-          <p:nvPr/>
-        </p:nvSpPr>
-        <p:spPr>
-          <a:xfrm>
-            <a:off x="2880360" y="3886200"/>
-            <a:ext cx="1371600" cy="457200"/>
+              <a:t>40</a:t>
+            </a:r>
+          </a:p>
+        </p:txBody>
+      </p:sp>
+      <p:sp>
+        <p:nvSpPr>
+          <p:cNvPr id="38" name="TextBox 37"/>
+          <p:cNvSpPr txBox="1"/>
+          <p:nvPr/>
+        </p:nvSpPr>
+        <p:spPr>
+          <a:xfrm>
+            <a:off x="4206240" y="4251960"/>
+            <a:ext cx="1691640" cy="365760"/>
           </a:xfrm>
           <a:prstGeom prst="rect">
             <a:avLst/>
@@ -6700,27 +7033,62 @@
           <a:p>
             <a:pPr algn="ctr"/>
             <a:r>
+              <a:rPr sz="1100" b="0" i="0" u="none">
+                <a:solidFill>
+                  <a:srgbClr val="333333"/>
+                </a:solidFill>
+                <a:latin typeface="Calibri"/>
+              </a:rPr>
+              <a:t>7</a:t>
+            </a:r>
+          </a:p>
+        </p:txBody>
+      </p:sp>
+      <p:sp>
+        <p:nvSpPr>
+          <p:cNvPr id="39" name="TextBox 38"/>
+          <p:cNvSpPr txBox="1"/>
+          <p:nvPr/>
+        </p:nvSpPr>
+        <p:spPr>
+          <a:xfrm>
+            <a:off x="5897880" y="4251960"/>
+            <a:ext cx="1234440" cy="365760"/>
+          </a:xfrm>
+          <a:prstGeom prst="rect">
+            <a:avLst/>
+          </a:prstGeom>
+          <a:noFill/>
+        </p:spPr>
+        <p:txBody>
+          <a:bodyPr wrap="square" lIns="36000" rIns="36000" tIns="18000" bIns="18000" anchor="ctr">
+            <a:spAutoFit/>
+          </a:bodyPr>
+          <a:lstStyle/>
+          <a:p>
+            <a:pPr algn="ctr"/>
+            <a:r>
               <a:rPr sz="1100" b="1" i="0" u="none">
                 <a:solidFill>
                   <a:srgbClr val="333333"/>
                 </a:solidFill>
                 <a:latin typeface="Calibri"/>
               </a:rPr>
-              <a:t>210</a:t>
-            </a:r>
-          </a:p>
-        </p:txBody>
-      </p:sp>
-      <p:sp>
-        <p:nvSpPr>
-          <p:cNvPr id="30" name="TextBox 29"/>
-          <p:cNvSpPr txBox="1"/>
-          <p:nvPr/>
-        </p:nvSpPr>
-        <p:spPr>
-          <a:xfrm>
-            <a:off x="4251960" y="3886200"/>
-            <a:ext cx="1965960" cy="457200"/>
+              <a:t>47</a:t>
+            </a:r>
+          </a:p>
+        </p:txBody>
+      </p:sp>
+      <p:sp>
+        <p:nvSpPr>
+          <p:cNvPr id="40" name="TextBox 39"/>
+          <p:cNvSpPr txBox="1"/>
+          <p:nvPr/>
+        </p:nvSpPr>
+        <p:spPr>
+          <a:xfrm>
+            <a:off x="7132320" y="4251960"/>
+            <a:ext cx="914400" cy="365760"/>
           </a:xfrm>
           <a:prstGeom prst="rect">
             <a:avLst/>
@@ -6733,29 +7101,187 @@
           </a:bodyPr>
           <a:lstStyle/>
           <a:p>
+            <a:pPr algn="ctr"/>
+            <a:r>
+              <a:rPr sz="1100" b="0" i="0" u="none">
+                <a:solidFill>
+                  <a:srgbClr val="333333"/>
+                </a:solidFill>
+                <a:latin typeface="Calibri"/>
+              </a:rPr>
+              <a:t>20 %</a:t>
+            </a:r>
+          </a:p>
+        </p:txBody>
+      </p:sp>
+      <p:sp>
+        <p:nvSpPr>
+          <p:cNvPr id="41" name="Rectangle 40"/>
+          <p:cNvSpPr/>
+          <p:nvPr/>
+        </p:nvSpPr>
+        <p:spPr>
+          <a:xfrm>
+            <a:off x="411480" y="4617720"/>
+            <a:ext cx="7635240" cy="365760"/>
+          </a:xfrm>
+          <a:prstGeom prst="rect">
+            <a:avLst/>
+          </a:prstGeom>
+          <a:solidFill>
+            <a:srgbClr val="FFFFFF"/>
+          </a:solidFill>
+          <a:ln>
+            <a:noFill/>
+          </a:ln>
+          <a:effectLst/>
+        </p:spPr>
+        <p:style>
+          <a:lnRef idx="1">
+            <a:schemeClr val="accent1"/>
+          </a:lnRef>
+          <a:fillRef idx="3">
+            <a:schemeClr val="accent1"/>
+          </a:fillRef>
+          <a:effectRef idx="2">
+            <a:schemeClr val="accent1"/>
+          </a:effectRef>
+          <a:fontRef idx="minor">
+            <a:schemeClr val="lt1"/>
+          </a:fontRef>
+        </p:style>
+        <p:txBody>
+          <a:bodyPr rtlCol="0" anchor="ctr"/>
+          <a:lstStyle/>
+          <a:p>
+            <a:pPr algn="ctr"/>
+          </a:p>
+        </p:txBody>
+      </p:sp>
+      <p:sp>
+        <p:nvSpPr>
+          <p:cNvPr id="42" name="Rectangle 41"/>
+          <p:cNvSpPr/>
+          <p:nvPr/>
+        </p:nvSpPr>
+        <p:spPr>
+          <a:xfrm>
+            <a:off x="411480" y="4617720"/>
+            <a:ext cx="109728" cy="365760"/>
+          </a:xfrm>
+          <a:prstGeom prst="rect">
+            <a:avLst/>
+          </a:prstGeom>
+          <a:solidFill>
+            <a:srgbClr val="C86E10"/>
+          </a:solidFill>
+          <a:ln>
+            <a:noFill/>
+          </a:ln>
+          <a:effectLst/>
+        </p:spPr>
+        <p:style>
+          <a:lnRef idx="1">
+            <a:schemeClr val="accent1"/>
+          </a:lnRef>
+          <a:fillRef idx="3">
+            <a:schemeClr val="accent1"/>
+          </a:fillRef>
+          <a:effectRef idx="2">
+            <a:schemeClr val="accent1"/>
+          </a:effectRef>
+          <a:fontRef idx="minor">
+            <a:schemeClr val="lt1"/>
+          </a:fontRef>
+        </p:style>
+        <p:txBody>
+          <a:bodyPr rtlCol="0" anchor="ctr"/>
+          <a:lstStyle/>
+          <a:p>
+            <a:pPr algn="ctr"/>
+          </a:p>
+        </p:txBody>
+      </p:sp>
+      <p:sp>
+        <p:nvSpPr>
+          <p:cNvPr id="43" name="TextBox 42"/>
+          <p:cNvSpPr txBox="1"/>
+          <p:nvPr/>
+        </p:nvSpPr>
+        <p:spPr>
+          <a:xfrm>
+            <a:off x="539496" y="4617720"/>
+            <a:ext cx="1975104" cy="365760"/>
+          </a:xfrm>
+          <a:prstGeom prst="rect">
+            <a:avLst/>
+          </a:prstGeom>
+          <a:noFill/>
+        </p:spPr>
+        <p:txBody>
+          <a:bodyPr wrap="square" lIns="36000" rIns="36000" tIns="18000" bIns="18000" anchor="ctr">
+            <a:spAutoFit/>
+          </a:bodyPr>
+          <a:lstStyle/>
+          <a:p>
             <a:pPr algn="l"/>
             <a:r>
+              <a:rPr sz="1100" b="1" i="0" u="none">
+                <a:solidFill>
+                  <a:srgbClr val="333333"/>
+                </a:solidFill>
+                <a:latin typeface="Calibri"/>
+              </a:rPr>
+              <a:t>Leben</a:t>
+            </a:r>
+          </a:p>
+        </p:txBody>
+      </p:sp>
+      <p:sp>
+        <p:nvSpPr>
+          <p:cNvPr id="44" name="TextBox 43"/>
+          <p:cNvSpPr txBox="1"/>
+          <p:nvPr/>
+        </p:nvSpPr>
+        <p:spPr>
+          <a:xfrm>
+            <a:off x="2514600" y="4617720"/>
+            <a:ext cx="1691640" cy="365760"/>
+          </a:xfrm>
+          <a:prstGeom prst="rect">
+            <a:avLst/>
+          </a:prstGeom>
+          <a:noFill/>
+        </p:spPr>
+        <p:txBody>
+          <a:bodyPr wrap="square" lIns="36000" rIns="36000" tIns="18000" bIns="18000" anchor="ctr">
+            <a:spAutoFit/>
+          </a:bodyPr>
+          <a:lstStyle/>
+          <a:p>
+            <a:pPr algn="ctr"/>
+            <a:r>
               <a:rPr sz="1100" b="0" i="0" u="none">
                 <a:solidFill>
                   <a:srgbClr val="333333"/>
                 </a:solidFill>
                 <a:latin typeface="Calibri"/>
               </a:rPr>
-              <a:t>Wiedervorlage – kein neuer Vorgang</a:t>
-            </a:r>
-          </a:p>
-        </p:txBody>
-      </p:sp>
-      <p:sp>
-        <p:nvSpPr>
-          <p:cNvPr id="31" name="TextBox 30"/>
-          <p:cNvSpPr txBox="1"/>
-          <p:nvPr/>
-        </p:nvSpPr>
-        <p:spPr>
-          <a:xfrm>
-            <a:off x="6217920" y="3886200"/>
-            <a:ext cx="1828800" cy="457200"/>
+              <a:t>29</a:t>
+            </a:r>
+          </a:p>
+        </p:txBody>
+      </p:sp>
+      <p:sp>
+        <p:nvSpPr>
+          <p:cNvPr id="45" name="TextBox 44"/>
+          <p:cNvSpPr txBox="1"/>
+          <p:nvPr/>
+        </p:nvSpPr>
+        <p:spPr>
+          <a:xfrm>
+            <a:off x="4206240" y="4617720"/>
+            <a:ext cx="1691640" cy="365760"/>
           </a:xfrm>
           <a:prstGeom prst="rect">
             <a:avLst/>
@@ -6768,7 +7294,7 @@
           </a:bodyPr>
           <a:lstStyle/>
           <a:p>
-            <a:pPr algn="l"/>
+            <a:pPr algn="ctr"/>
             <a:r>
               <a:rPr sz="1100" b="0" i="0" u="none">
                 <a:solidFill>
@@ -6776,21 +7302,91 @@
                 </a:solidFill>
                 <a:latin typeface="Calibri"/>
               </a:rPr>
-              <a:t>Status = Reminder</a:t>
-            </a:r>
-          </a:p>
-        </p:txBody>
-      </p:sp>
-      <p:sp>
-        <p:nvSpPr>
-          <p:cNvPr id="32" name="Rectangle 31"/>
+              <a:t>2</a:t>
+            </a:r>
+          </a:p>
+        </p:txBody>
+      </p:sp>
+      <p:sp>
+        <p:nvSpPr>
+          <p:cNvPr id="46" name="TextBox 45"/>
+          <p:cNvSpPr txBox="1"/>
+          <p:nvPr/>
+        </p:nvSpPr>
+        <p:spPr>
+          <a:xfrm>
+            <a:off x="5897880" y="4617720"/>
+            <a:ext cx="1234440" cy="365760"/>
+          </a:xfrm>
+          <a:prstGeom prst="rect">
+            <a:avLst/>
+          </a:prstGeom>
+          <a:noFill/>
+        </p:spPr>
+        <p:txBody>
+          <a:bodyPr wrap="square" lIns="36000" rIns="36000" tIns="18000" bIns="18000" anchor="ctr">
+            <a:spAutoFit/>
+          </a:bodyPr>
+          <a:lstStyle/>
+          <a:p>
+            <a:pPr algn="ctr"/>
+            <a:r>
+              <a:rPr sz="1100" b="1" i="0" u="none">
+                <a:solidFill>
+                  <a:srgbClr val="333333"/>
+                </a:solidFill>
+                <a:latin typeface="Calibri"/>
+              </a:rPr>
+              <a:t>31</a:t>
+            </a:r>
+          </a:p>
+        </p:txBody>
+      </p:sp>
+      <p:sp>
+        <p:nvSpPr>
+          <p:cNvPr id="47" name="TextBox 46"/>
+          <p:cNvSpPr txBox="1"/>
+          <p:nvPr/>
+        </p:nvSpPr>
+        <p:spPr>
+          <a:xfrm>
+            <a:off x="7132320" y="4617720"/>
+            <a:ext cx="914400" cy="365760"/>
+          </a:xfrm>
+          <a:prstGeom prst="rect">
+            <a:avLst/>
+          </a:prstGeom>
+          <a:noFill/>
+        </p:spPr>
+        <p:txBody>
+          <a:bodyPr wrap="square" lIns="36000" rIns="36000" tIns="18000" bIns="18000" anchor="ctr">
+            <a:spAutoFit/>
+          </a:bodyPr>
+          <a:lstStyle/>
+          <a:p>
+            <a:pPr algn="ctr"/>
+            <a:r>
+              <a:rPr sz="1100" b="0" i="0" u="none">
+                <a:solidFill>
+                  <a:srgbClr val="333333"/>
+                </a:solidFill>
+                <a:latin typeface="Calibri"/>
+              </a:rPr>
+              <a:t>13 %</a:t>
+            </a:r>
+          </a:p>
+        </p:txBody>
+      </p:sp>
+      <p:sp>
+        <p:nvSpPr>
+          <p:cNvPr id="48" name="Rectangle 47"/>
           <p:cNvSpPr/>
           <p:nvPr/>
         </p:nvSpPr>
         <p:spPr>
           <a:xfrm>
-            <a:off x="411480" y="4343400"/>
-            <a:ext cx="7635240" cy="457200"/>
+            <a:off x="411480" y="4983480"/>
+            <a:ext cx="7635240" cy="365760"/>
           </a:xfrm>
           <a:prstGeom prst="rect">
             <a:avLst/>
@@ -6827,20 +7423,20 @@
       </p:sp>
       <p:sp>
         <p:nvSpPr>
-          <p:cNvPr id="33" name="Rectangle 32"/>
+          <p:cNvPr id="49" name="Rectangle 48"/>
           <p:cNvSpPr/>
           <p:nvPr/>
         </p:nvSpPr>
         <p:spPr>
           <a:xfrm>
-            <a:off x="411480" y="4343400"/>
-            <a:ext cx="109728" cy="457200"/>
+            <a:off x="411480" y="4983480"/>
+            <a:ext cx="109728" cy="365760"/>
           </a:xfrm>
           <a:prstGeom prst="rect">
             <a:avLst/>
           </a:prstGeom>
           <a:solidFill>
-            <a:srgbClr val="C86E10"/>
+            <a:srgbClr val="888888"/>
           </a:solidFill>
           <a:ln>
             <a:noFill/>
@@ -6871,14 +7467,14 @@
       </p:sp>
       <p:sp>
         <p:nvSpPr>
-          <p:cNvPr id="34" name="TextBox 33"/>
-          <p:cNvSpPr txBox="1"/>
-          <p:nvPr/>
-        </p:nvSpPr>
-        <p:spPr>
-          <a:xfrm>
-            <a:off x="539496" y="4343400"/>
-            <a:ext cx="2340864" cy="457200"/>
+          <p:cNvPr id="50" name="TextBox 49"/>
+          <p:cNvSpPr txBox="1"/>
+          <p:nvPr/>
+        </p:nvSpPr>
+        <p:spPr>
+          <a:xfrm>
+            <a:off x="539496" y="4983480"/>
+            <a:ext cx="1975104" cy="365760"/>
           </a:xfrm>
           <a:prstGeom prst="rect">
             <a:avLst/>
@@ -6893,27 +7489,62 @@
           <a:p>
             <a:pPr algn="l"/>
             <a:r>
+              <a:rPr sz="1100" b="1" i="0" u="none">
+                <a:solidFill>
+                  <a:srgbClr val="333333"/>
+                </a:solidFill>
+                <a:latin typeface="Calibri"/>
+              </a:rPr>
+              <a:t>Mehrere/Unbekannt</a:t>
+            </a:r>
+          </a:p>
+        </p:txBody>
+      </p:sp>
+      <p:sp>
+        <p:nvSpPr>
+          <p:cNvPr id="51" name="TextBox 50"/>
+          <p:cNvSpPr txBox="1"/>
+          <p:nvPr/>
+        </p:nvSpPr>
+        <p:spPr>
+          <a:xfrm>
+            <a:off x="2514600" y="4983480"/>
+            <a:ext cx="1691640" cy="365760"/>
+          </a:xfrm>
+          <a:prstGeom prst="rect">
+            <a:avLst/>
+          </a:prstGeom>
+          <a:noFill/>
+        </p:spPr>
+        <p:txBody>
+          <a:bodyPr wrap="square" lIns="36000" rIns="36000" tIns="18000" bIns="18000" anchor="ctr">
+            <a:spAutoFit/>
+          </a:bodyPr>
+          <a:lstStyle/>
+          <a:p>
+            <a:pPr algn="ctr"/>
+            <a:r>
               <a:rPr sz="1100" b="0" i="0" u="none">
                 <a:solidFill>
                   <a:srgbClr val="333333"/>
                 </a:solidFill>
                 <a:latin typeface="Calibri"/>
               </a:rPr>
-              <a:t>Keine BÜ (mit MV)</a:t>
-            </a:r>
-          </a:p>
-        </p:txBody>
-      </p:sp>
-      <p:sp>
-        <p:nvSpPr>
-          <p:cNvPr id="35" name="TextBox 34"/>
-          <p:cNvSpPr txBox="1"/>
-          <p:nvPr/>
-        </p:nvSpPr>
-        <p:spPr>
-          <a:xfrm>
-            <a:off x="2880360" y="4343400"/>
-            <a:ext cx="1371600" cy="457200"/>
+              <a:t>6</a:t>
+            </a:r>
+          </a:p>
+        </p:txBody>
+      </p:sp>
+      <p:sp>
+        <p:nvSpPr>
+          <p:cNvPr id="52" name="TextBox 51"/>
+          <p:cNvSpPr txBox="1"/>
+          <p:nvPr/>
+        </p:nvSpPr>
+        <p:spPr>
+          <a:xfrm>
+            <a:off x="4206240" y="4983480"/>
+            <a:ext cx="1691640" cy="365760"/>
           </a:xfrm>
           <a:prstGeom prst="rect">
             <a:avLst/>
@@ -6928,12 +7559,231 @@
           <a:p>
             <a:pPr algn="ctr"/>
             <a:r>
+              <a:rPr sz="1100" b="0" i="0" u="none">
+                <a:solidFill>
+                  <a:srgbClr val="333333"/>
+                </a:solidFill>
+                <a:latin typeface="Calibri"/>
+              </a:rPr>
+              <a:t>1</a:t>
+            </a:r>
+          </a:p>
+        </p:txBody>
+      </p:sp>
+      <p:sp>
+        <p:nvSpPr>
+          <p:cNvPr id="53" name="TextBox 52"/>
+          <p:cNvSpPr txBox="1"/>
+          <p:nvPr/>
+        </p:nvSpPr>
+        <p:spPr>
+          <a:xfrm>
+            <a:off x="5897880" y="4983480"/>
+            <a:ext cx="1234440" cy="365760"/>
+          </a:xfrm>
+          <a:prstGeom prst="rect">
+            <a:avLst/>
+          </a:prstGeom>
+          <a:noFill/>
+        </p:spPr>
+        <p:txBody>
+          <a:bodyPr wrap="square" lIns="36000" rIns="36000" tIns="18000" bIns="18000" anchor="ctr">
+            <a:spAutoFit/>
+          </a:bodyPr>
+          <a:lstStyle/>
+          <a:p>
+            <a:pPr algn="ctr"/>
+            <a:r>
               <a:rPr sz="1100" b="1" i="0" u="none">
                 <a:solidFill>
                   <a:srgbClr val="333333"/>
                 </a:solidFill>
                 <a:latin typeface="Calibri"/>
               </a:rPr>
+              <a:t>7</a:t>
+            </a:r>
+          </a:p>
+        </p:txBody>
+      </p:sp>
+      <p:sp>
+        <p:nvSpPr>
+          <p:cNvPr id="54" name="TextBox 53"/>
+          <p:cNvSpPr txBox="1"/>
+          <p:nvPr/>
+        </p:nvSpPr>
+        <p:spPr>
+          <a:xfrm>
+            <a:off x="7132320" y="4983480"/>
+            <a:ext cx="914400" cy="365760"/>
+          </a:xfrm>
+          <a:prstGeom prst="rect">
+            <a:avLst/>
+          </a:prstGeom>
+          <a:noFill/>
+        </p:spPr>
+        <p:txBody>
+          <a:bodyPr wrap="square" lIns="36000" rIns="36000" tIns="18000" bIns="18000" anchor="ctr">
+            <a:spAutoFit/>
+          </a:bodyPr>
+          <a:lstStyle/>
+          <a:p>
+            <a:pPr algn="ctr"/>
+            <a:r>
+              <a:rPr sz="1100" b="0" i="0" u="none">
+                <a:solidFill>
+                  <a:srgbClr val="333333"/>
+                </a:solidFill>
+                <a:latin typeface="Calibri"/>
+              </a:rPr>
+              <a:t>3 %</a:t>
+            </a:r>
+          </a:p>
+        </p:txBody>
+      </p:sp>
+      <p:sp>
+        <p:nvSpPr>
+          <p:cNvPr id="55" name="Rectangle 54"/>
+          <p:cNvSpPr/>
+          <p:nvPr/>
+        </p:nvSpPr>
+        <p:spPr>
+          <a:xfrm>
+            <a:off x="411480" y="5349240"/>
+            <a:ext cx="7635240" cy="347472"/>
+          </a:xfrm>
+          <a:prstGeom prst="rect">
+            <a:avLst/>
+          </a:prstGeom>
+          <a:solidFill>
+            <a:srgbClr val="006B77"/>
+          </a:solidFill>
+          <a:ln>
+            <a:noFill/>
+          </a:ln>
+          <a:effectLst/>
+        </p:spPr>
+        <p:style>
+          <a:lnRef idx="1">
+            <a:schemeClr val="accent1"/>
+          </a:lnRef>
+          <a:fillRef idx="3">
+            <a:schemeClr val="accent1"/>
+          </a:fillRef>
+          <a:effectRef idx="2">
+            <a:schemeClr val="accent1"/>
+          </a:effectRef>
+          <a:fontRef idx="minor">
+            <a:schemeClr val="lt1"/>
+          </a:fontRef>
+        </p:style>
+        <p:txBody>
+          <a:bodyPr rtlCol="0" anchor="ctr"/>
+          <a:lstStyle/>
+          <a:p>
+            <a:pPr algn="ctr"/>
+          </a:p>
+        </p:txBody>
+      </p:sp>
+      <p:sp>
+        <p:nvSpPr>
+          <p:cNvPr id="56" name="TextBox 55"/>
+          <p:cNvSpPr txBox="1"/>
+          <p:nvPr/>
+        </p:nvSpPr>
+        <p:spPr>
+          <a:xfrm>
+            <a:off x="539496" y="5349240"/>
+            <a:ext cx="1975104" cy="347472"/>
+          </a:xfrm>
+          <a:prstGeom prst="rect">
+            <a:avLst/>
+          </a:prstGeom>
+          <a:noFill/>
+        </p:spPr>
+        <p:txBody>
+          <a:bodyPr wrap="square" lIns="36000" rIns="36000" tIns="18000" bIns="18000" anchor="ctr">
+            <a:spAutoFit/>
+          </a:bodyPr>
+          <a:lstStyle/>
+          <a:p>
+            <a:pPr algn="l"/>
+            <a:r>
+              <a:rPr sz="1100" b="1" i="0" u="none">
+                <a:solidFill>
+                  <a:srgbClr val="FFFFFF"/>
+                </a:solidFill>
+                <a:latin typeface="Calibri"/>
+              </a:rPr>
+              <a:t>Gesamt</a:t>
+            </a:r>
+          </a:p>
+        </p:txBody>
+      </p:sp>
+      <p:sp>
+        <p:nvSpPr>
+          <p:cNvPr id="57" name="TextBox 56"/>
+          <p:cNvSpPr txBox="1"/>
+          <p:nvPr/>
+        </p:nvSpPr>
+        <p:spPr>
+          <a:xfrm>
+            <a:off x="2514600" y="5349240"/>
+            <a:ext cx="1691640" cy="347472"/>
+          </a:xfrm>
+          <a:prstGeom prst="rect">
+            <a:avLst/>
+          </a:prstGeom>
+          <a:noFill/>
+        </p:spPr>
+        <p:txBody>
+          <a:bodyPr wrap="square" lIns="36000" rIns="36000" tIns="18000" bIns="18000" anchor="ctr">
+            <a:spAutoFit/>
+          </a:bodyPr>
+          <a:lstStyle/>
+          <a:p>
+            <a:pPr algn="ctr"/>
+            <a:r>
+              <a:rPr sz="1100" b="1" i="0" u="none">
+                <a:solidFill>
+                  <a:srgbClr val="FFFFFF"/>
+                </a:solidFill>
+                <a:latin typeface="Calibri"/>
+              </a:rPr>
+              <a:t>210</a:t>
+            </a:r>
+          </a:p>
+        </p:txBody>
+      </p:sp>
+      <p:sp>
+        <p:nvSpPr>
+          <p:cNvPr id="58" name="TextBox 57"/>
+          <p:cNvSpPr txBox="1"/>
+          <p:nvPr/>
+        </p:nvSpPr>
+        <p:spPr>
+          <a:xfrm>
+            <a:off x="4206240" y="5349240"/>
+            <a:ext cx="1691640" cy="347472"/>
+          </a:xfrm>
+          <a:prstGeom prst="rect">
+            <a:avLst/>
+          </a:prstGeom>
+          <a:noFill/>
+        </p:spPr>
+        <p:txBody>
+          <a:bodyPr wrap="square" lIns="36000" rIns="36000" tIns="18000" bIns="18000" anchor="ctr">
+            <a:spAutoFit/>
+          </a:bodyPr>
+          <a:lstStyle/>
+          <a:p>
+            <a:pPr algn="ctr"/>
+            <a:r>
+              <a:rPr sz="1100" b="1" i="0" u="none">
+                <a:solidFill>
+                  <a:srgbClr val="FFFFFF"/>
+                </a:solidFill>
+                <a:latin typeface="Calibri"/>
+              </a:rPr>
               <a:t>30</a:t>
             </a:r>
           </a:p>
@@ -6941,14 +7791,14 @@
       </p:sp>
       <p:sp>
         <p:nvSpPr>
-          <p:cNvPr id="36" name="TextBox 35"/>
-          <p:cNvSpPr txBox="1"/>
-          <p:nvPr/>
-        </p:nvSpPr>
-        <p:spPr>
-          <a:xfrm>
-            <a:off x="4251960" y="4343400"/>
-            <a:ext cx="1965960" cy="457200"/>
+          <p:cNvPr id="59" name="TextBox 58"/>
+          <p:cNvSpPr txBox="1"/>
+          <p:nvPr/>
+        </p:nvSpPr>
+        <p:spPr>
+          <a:xfrm>
+            <a:off x="5897880" y="5349240"/>
+            <a:ext cx="1234440" cy="347472"/>
           </a:xfrm>
           <a:prstGeom prst="rect">
             <a:avLst/>
@@ -6961,64 +7811,99 @@
           </a:bodyPr>
           <a:lstStyle/>
           <a:p>
+            <a:pPr algn="ctr"/>
+            <a:r>
+              <a:rPr sz="1100" b="1" i="0" u="none">
+                <a:solidFill>
+                  <a:srgbClr val="FFFFFF"/>
+                </a:solidFill>
+                <a:latin typeface="Calibri"/>
+              </a:rPr>
+              <a:t>240</a:t>
+            </a:r>
+          </a:p>
+        </p:txBody>
+      </p:sp>
+      <p:sp>
+        <p:nvSpPr>
+          <p:cNvPr id="60" name="TextBox 59"/>
+          <p:cNvSpPr txBox="1"/>
+          <p:nvPr/>
+        </p:nvSpPr>
+        <p:spPr>
+          <a:xfrm>
+            <a:off x="7132320" y="5349240"/>
+            <a:ext cx="914400" cy="347472"/>
+          </a:xfrm>
+          <a:prstGeom prst="rect">
+            <a:avLst/>
+          </a:prstGeom>
+          <a:noFill/>
+        </p:spPr>
+        <p:txBody>
+          <a:bodyPr wrap="square" lIns="36000" rIns="36000" tIns="18000" bIns="18000" anchor="ctr">
+            <a:spAutoFit/>
+          </a:bodyPr>
+          <a:lstStyle/>
+          <a:p>
+            <a:pPr algn="ctr"/>
+            <a:r>
+              <a:rPr sz="1100" b="1" i="0" u="none">
+                <a:solidFill>
+                  <a:srgbClr val="FFFFFF"/>
+                </a:solidFill>
+                <a:latin typeface="Calibri"/>
+              </a:rPr>
+              <a:t>100 %</a:t>
+            </a:r>
+          </a:p>
+        </p:txBody>
+      </p:sp>
+      <p:sp>
+        <p:nvSpPr>
+          <p:cNvPr id="61" name="TextBox 60"/>
+          <p:cNvSpPr txBox="1"/>
+          <p:nvPr/>
+        </p:nvSpPr>
+        <p:spPr>
+          <a:xfrm>
+            <a:off x="411480" y="5733288"/>
+            <a:ext cx="7635240" cy="274320"/>
+          </a:xfrm>
+          <a:prstGeom prst="rect">
+            <a:avLst/>
+          </a:prstGeom>
+          <a:noFill/>
+        </p:spPr>
+        <p:txBody>
+          <a:bodyPr wrap="square" lIns="36000" rIns="36000" tIns="18000" bIns="18000" anchor="t">
+            <a:spAutoFit/>
+          </a:bodyPr>
+          <a:lstStyle/>
+          <a:p>
             <a:pPr algn="l"/>
             <a:r>
-              <a:rPr sz="1100" b="0" i="0" u="none">
-                <a:solidFill>
-                  <a:srgbClr val="333333"/>
-                </a:solidFill>
-                <a:latin typeface="Calibri"/>
-              </a:rPr>
-              <a:t>Anfrage / Antrag-Aenderung</a:t>
-            </a:r>
-          </a:p>
-        </p:txBody>
-      </p:sp>
-      <p:sp>
-        <p:nvSpPr>
-          <p:cNvPr id="37" name="TextBox 36"/>
-          <p:cNvSpPr txBox="1"/>
-          <p:nvPr/>
-        </p:nvSpPr>
-        <p:spPr>
-          <a:xfrm>
-            <a:off x="6217920" y="4343400"/>
-            <a:ext cx="1828800" cy="457200"/>
-          </a:xfrm>
-          <a:prstGeom prst="rect">
-            <a:avLst/>
-          </a:prstGeom>
-          <a:noFill/>
-        </p:spPr>
-        <p:txBody>
-          <a:bodyPr wrap="square" lIns="36000" rIns="36000" tIns="18000" bIns="18000" anchor="ctr">
-            <a:spAutoFit/>
-          </a:bodyPr>
-          <a:lstStyle/>
-          <a:p>
-            <a:pPr algn="l"/>
-            <a:r>
-              <a:rPr sz="1100" b="0" i="0" u="none">
-                <a:solidFill>
-                  <a:srgbClr val="333333"/>
-                </a:solidFill>
-                <a:latin typeface="Calibri"/>
-              </a:rPr>
-              <a:t>Status = Keine BÜ</a:t>
-            </a:r>
-          </a:p>
-        </p:txBody>
-      </p:sp>
-      <p:sp>
-        <p:nvSpPr>
-          <p:cNvPr id="38" name="Rectangle 37"/>
+              <a:rPr sz="1000" b="0" i="1" u="none">
+                <a:solidFill>
+                  <a:srgbClr val="666666"/>
+                </a:solidFill>
+                <a:latin typeface="Calibri"/>
+              </a:rPr>
+              <a:t>Mechanismus identisch in allen Sparten: MV im Anhang → BÜ-Vorgang. Reminder (210) dominieren klar.</a:t>
+            </a:r>
+          </a:p>
+        </p:txBody>
+      </p:sp>
+      <p:sp>
+        <p:nvSpPr>
+          <p:cNvPr id="62" name="Rectangle 61"/>
           <p:cNvSpPr/>
           <p:nvPr/>
         </p:nvSpPr>
         <p:spPr>
           <a:xfrm>
-            <a:off x="411480" y="4800600"/>
-            <a:ext cx="7635240" cy="365760"/>
+            <a:off x="8229600" y="2240280"/>
+            <a:ext cx="3611880" cy="3611880"/>
           </a:xfrm>
           <a:prstGeom prst="rect">
             <a:avLst/>
@@ -7055,86 +7940,7 @@
       </p:sp>
       <p:sp>
         <p:nvSpPr>
-          <p:cNvPr id="39" name="TextBox 38"/>
-          <p:cNvSpPr txBox="1"/>
-          <p:nvPr/>
-        </p:nvSpPr>
-        <p:spPr>
-          <a:xfrm>
-            <a:off x="539496" y="4800600"/>
-            <a:ext cx="7360920" cy="365760"/>
-          </a:xfrm>
-          <a:prstGeom prst="rect">
-            <a:avLst/>
-          </a:prstGeom>
-          <a:noFill/>
-        </p:spPr>
-        <p:txBody>
-          <a:bodyPr wrap="square" lIns="36000" rIns="36000" tIns="18000" bIns="18000" anchor="ctr">
-            <a:spAutoFit/>
-          </a:bodyPr>
-          <a:lstStyle/>
-          <a:p>
-            <a:pPr algn="l"/>
-            <a:r>
-              <a:rPr sz="1100" b="1" i="0" u="none">
-                <a:solidFill>
-                  <a:srgbClr val="006B77"/>
-                </a:solidFill>
-                <a:latin typeface="Calibri"/>
-              </a:rPr>
-              <a:t>Summe Fehlrouting: 240 Mails / Woche  –  nach Sparte: Komposit 155 · KV 47 · Leben 31 · Sonst 7</a:t>
-            </a:r>
-          </a:p>
-        </p:txBody>
-      </p:sp>
-      <p:sp>
-        <p:nvSpPr>
-          <p:cNvPr id="40" name="Rectangle 39"/>
-          <p:cNvSpPr/>
-          <p:nvPr/>
-        </p:nvSpPr>
-        <p:spPr>
-          <a:xfrm>
-            <a:off x="8229600" y="2240280"/>
-            <a:ext cx="3611880" cy="3611880"/>
-          </a:xfrm>
-          <a:prstGeom prst="rect">
-            <a:avLst/>
-          </a:prstGeom>
-          <a:solidFill>
-            <a:srgbClr val="CFE6E9"/>
-          </a:solidFill>
-          <a:ln>
-            <a:noFill/>
-          </a:ln>
-          <a:effectLst/>
-        </p:spPr>
-        <p:style>
-          <a:lnRef idx="1">
-            <a:schemeClr val="accent1"/>
-          </a:lnRef>
-          <a:fillRef idx="3">
-            <a:schemeClr val="accent1"/>
-          </a:fillRef>
-          <a:effectRef idx="2">
-            <a:schemeClr val="accent1"/>
-          </a:effectRef>
-          <a:fontRef idx="minor">
-            <a:schemeClr val="lt1"/>
-          </a:fontRef>
-        </p:style>
-        <p:txBody>
-          <a:bodyPr rtlCol="0" anchor="ctr"/>
-          <a:lstStyle/>
-          <a:p>
-            <a:pPr algn="ctr"/>
-          </a:p>
-        </p:txBody>
-      </p:sp>
-      <p:sp>
-        <p:nvSpPr>
-          <p:cNvPr id="41" name="Oval 40"/>
+          <p:cNvPr id="63" name="Oval 62"/>
           <p:cNvSpPr/>
           <p:nvPr/>
         </p:nvSpPr>
@@ -7178,7 +7984,7 @@
       </p:sp>
       <p:sp>
         <p:nvSpPr>
-          <p:cNvPr id="42" name="TextBox 41"/>
+          <p:cNvPr id="64" name="TextBox 63"/>
           <p:cNvSpPr txBox="1"/>
           <p:nvPr/>
         </p:nvSpPr>
@@ -7213,7 +8019,7 @@
       </p:sp>
       <p:sp>
         <p:nvSpPr>
-          <p:cNvPr id="43" name="TextBox 42"/>
+          <p:cNvPr id="65" name="TextBox 64"/>
           <p:cNvSpPr txBox="1"/>
           <p:nvPr/>
         </p:nvSpPr>
@@ -7257,7 +8063,7 @@
       </p:sp>
       <p:sp>
         <p:nvSpPr>
-          <p:cNvPr id="44" name="Oval 43"/>
+          <p:cNvPr id="66" name="Oval 65"/>
           <p:cNvSpPr/>
           <p:nvPr/>
         </p:nvSpPr>
@@ -7301,7 +8107,7 @@
       </p:sp>
       <p:sp>
         <p:nvSpPr>
-          <p:cNvPr id="45" name="TextBox 44"/>
+          <p:cNvPr id="67" name="TextBox 66"/>
           <p:cNvSpPr txBox="1"/>
           <p:nvPr/>
         </p:nvSpPr>
@@ -7336,7 +8142,7 @@
       </p:sp>
       <p:sp>
         <p:nvSpPr>
-          <p:cNvPr id="46" name="TextBox 45"/>
+          <p:cNvPr id="68" name="TextBox 67"/>
           <p:cNvSpPr txBox="1"/>
           <p:nvPr/>
         </p:nvSpPr>
@@ -7380,7 +8186,7 @@
       </p:sp>
       <p:sp>
         <p:nvSpPr>
-          <p:cNvPr id="47" name="Oval 46"/>
+          <p:cNvPr id="69" name="Oval 68"/>
           <p:cNvSpPr/>
           <p:nvPr/>
         </p:nvSpPr>
@@ -7424,7 +8230,7 @@
       </p:sp>
       <p:sp>
         <p:nvSpPr>
-          <p:cNvPr id="48" name="TextBox 47"/>
+          <p:cNvPr id="70" name="TextBox 69"/>
           <p:cNvSpPr txBox="1"/>
           <p:nvPr/>
         </p:nvSpPr>
@@ -7459,7 +8265,7 @@
       </p:sp>
       <p:sp>
         <p:nvSpPr>
-          <p:cNvPr id="49" name="TextBox 48"/>
+          <p:cNvPr id="71" name="TextBox 70"/>
           <p:cNvSpPr txBox="1"/>
           <p:nvPr/>
         </p:nvSpPr>
@@ -7503,7 +8309,7 @@
       </p:sp>
       <p:sp>
         <p:nvSpPr>
-          <p:cNvPr id="50" name="Oval 49"/>
+          <p:cNvPr id="72" name="Oval 71"/>
           <p:cNvSpPr/>
           <p:nvPr/>
         </p:nvSpPr>
@@ -7547,7 +8353,7 @@
       </p:sp>
       <p:sp>
         <p:nvSpPr>
-          <p:cNvPr id="51" name="TextBox 50"/>
+          <p:cNvPr id="73" name="TextBox 72"/>
           <p:cNvSpPr txBox="1"/>
           <p:nvPr/>
         </p:nvSpPr>
@@ -7582,7 +8388,7 @@
       </p:sp>
       <p:sp>
         <p:nvSpPr>
-          <p:cNvPr id="52" name="TextBox 51"/>
+          <p:cNvPr id="74" name="TextBox 73"/>
           <p:cNvSpPr txBox="1"/>
           <p:nvPr/>
         </p:nvSpPr>
@@ -7626,7 +8432,7 @@
       </p:sp>
       <p:sp>
         <p:nvSpPr>
-          <p:cNvPr id="53" name="Oval 52"/>
+          <p:cNvPr id="75" name="Oval 74"/>
           <p:cNvSpPr/>
           <p:nvPr/>
         </p:nvSpPr>
@@ -7670,7 +8476,7 @@
       </p:sp>
       <p:sp>
         <p:nvSpPr>
-          <p:cNvPr id="54" name="TextBox 53"/>
+          <p:cNvPr id="76" name="TextBox 75"/>
           <p:cNvSpPr txBox="1"/>
           <p:nvPr/>
         </p:nvSpPr>
@@ -7705,7 +8511,7 @@
       </p:sp>
       <p:sp>
         <p:nvSpPr>
-          <p:cNvPr id="55" name="TextBox 54"/>
+          <p:cNvPr id="77" name="TextBox 76"/>
           <p:cNvSpPr txBox="1"/>
           <p:nvPr/>
         </p:nvSpPr>
@@ -7749,7 +8555,7 @@
       </p:sp>
       <p:sp>
         <p:nvSpPr>
-          <p:cNvPr id="56" name="TextBox 55"/>
+          <p:cNvPr id="78" name="TextBox 77"/>
           <p:cNvSpPr txBox="1"/>
           <p:nvPr/>
         </p:nvSpPr>
@@ -7784,7 +8590,7 @@
       </p:sp>
       <p:sp>
         <p:nvSpPr>
-          <p:cNvPr id="57" name="Rectangle 56"/>
+          <p:cNvPr id="79" name="Rectangle 78"/>
           <p:cNvSpPr/>
           <p:nvPr/>
         </p:nvSpPr>
@@ -7828,7 +8634,7 @@
       </p:sp>
       <p:sp>
         <p:nvSpPr>
-          <p:cNvPr id="58" name="TextBox 57"/>
+          <p:cNvPr id="80" name="TextBox 79"/>
           <p:cNvSpPr txBox="1"/>
           <p:nvPr/>
         </p:nvSpPr>

</xml_diff>

<commit_message>
PPTX Folie 11: Status-Tabelle (Gesamt/KV/Komposit/Leben) statt Text-Trichter
Linker Bereich von Folie 11 jetzt als angeforderte Tabelle:
Spalten: Status/Woche | Gesamt | KV | Komposit | Leben
Zeilen:
  Gesamt Mails                 5.034 / 1.308 / 2.502 / 755
  Neue BÜ                      4.000 / 1.147 / 2.089 / 662
  Keine BÜ                       705 /   112 /   192 /  55
    davon mit MV im Anhang*       30 /     7 /    20 /   2
  BÜ-Reminder                    329 /    49 /   221 /  38
    davon mit MV im Anhang*      210 /    40 /   135 /  29
MV-Zeilen amber hervorgehoben (= potentielles Falschrouting, Summe 240).
Fussnote + zwei Hebel-Callouts (Hebel 1 Routing / Hebel 2 Clustering).

https://claude.ai/code/session_01UknXtYp2XECsQDonCZuxSt
</commit_message>
<xml_diff>
--- a/ERGO-Mengengeruest-2Slides-Berichtslook.pptx
+++ b/ERGO-Mengengeruest-2Slides-Berichtslook.pptx
@@ -4317,14 +4317,14 @@
         </p:nvSpPr>
         <p:spPr>
           <a:xfrm>
-            <a:off x="411480" y="3813048"/>
-            <a:ext cx="2103120" cy="914400"/>
+            <a:off x="411480" y="3008376"/>
+            <a:ext cx="7635240" cy="329184"/>
           </a:xfrm>
           <a:prstGeom prst="rect">
             <a:avLst/>
           </a:prstGeom>
           <a:solidFill>
-            <a:srgbClr val="333333"/>
+            <a:srgbClr val="006B77"/>
           </a:solidFill>
           <a:ln>
             <a:noFill/>
@@ -4361,29 +4361,29 @@
         </p:nvSpPr>
         <p:spPr>
           <a:xfrm>
-            <a:off x="411480" y="3904488"/>
-            <a:ext cx="2103120" cy="411480"/>
-          </a:xfrm>
-          <a:prstGeom prst="rect">
-            <a:avLst/>
-          </a:prstGeom>
-          <a:noFill/>
-        </p:spPr>
-        <p:txBody>
-          <a:bodyPr wrap="square" lIns="36000" rIns="36000" tIns="18000" bIns="18000" anchor="t">
-            <a:spAutoFit/>
-          </a:bodyPr>
-          <a:lstStyle/>
-          <a:p>
-            <a:pPr algn="ctr"/>
-            <a:r>
-              <a:rPr sz="2800" b="1" i="0" u="none">
+            <a:off x="411480" y="3008376"/>
+            <a:ext cx="2788920" cy="329184"/>
+          </a:xfrm>
+          <a:prstGeom prst="rect">
+            <a:avLst/>
+          </a:prstGeom>
+          <a:noFill/>
+        </p:spPr>
+        <p:txBody>
+          <a:bodyPr wrap="square" lIns="36000" rIns="36000" tIns="18000" bIns="18000" anchor="ctr">
+            <a:spAutoFit/>
+          </a:bodyPr>
+          <a:lstStyle/>
+          <a:p>
+            <a:pPr algn="l"/>
+            <a:r>
+              <a:rPr sz="1100" b="1" i="0" u="none">
                 <a:solidFill>
                   <a:srgbClr val="FFFFFF"/>
                 </a:solidFill>
                 <a:latin typeface="Calibri"/>
               </a:rPr>
-              <a:t>5.034</a:t>
+              <a:t>Status / Woche</a:t>
             </a:r>
           </a:p>
         </p:txBody>
@@ -4396,54 +4396,157 @@
         </p:nvSpPr>
         <p:spPr>
           <a:xfrm>
-            <a:off x="411480" y="4343400"/>
-            <a:ext cx="2103120" cy="292608"/>
-          </a:xfrm>
-          <a:prstGeom prst="rect">
-            <a:avLst/>
-          </a:prstGeom>
-          <a:noFill/>
-        </p:spPr>
-        <p:txBody>
-          <a:bodyPr wrap="square" lIns="36000" rIns="36000" tIns="18000" bIns="18000" anchor="t">
-            <a:spAutoFit/>
-          </a:bodyPr>
-          <a:lstStyle/>
-          <a:p>
-            <a:pPr algn="ctr"/>
-            <a:r>
-              <a:rPr sz="1100" b="0" i="0" u="none">
+            <a:off x="3200400" y="3008376"/>
+            <a:ext cx="1234440" cy="329184"/>
+          </a:xfrm>
+          <a:prstGeom prst="rect">
+            <a:avLst/>
+          </a:prstGeom>
+          <a:noFill/>
+        </p:spPr>
+        <p:txBody>
+          <a:bodyPr wrap="square" lIns="36000" rIns="36000" tIns="18000" bIns="18000" anchor="ctr">
+            <a:spAutoFit/>
+          </a:bodyPr>
+          <a:lstStyle/>
+          <a:p>
+            <a:pPr algn="ctr"/>
+            <a:r>
+              <a:rPr sz="1100" b="1" i="0" u="none">
                 <a:solidFill>
                   <a:srgbClr val="FFFFFF"/>
                 </a:solidFill>
                 <a:latin typeface="Calibri"/>
               </a:rPr>
-              <a:t>Mails / Woche</a:t>
-            </a:r>
-          </a:p>
-        </p:txBody>
-      </p:sp>
-      <p:sp>
-        <p:nvSpPr>
-          <p:cNvPr id="36" name="Rectangle 35"/>
+              <a:t>Gesamt</a:t>
+            </a:r>
+          </a:p>
+        </p:txBody>
+      </p:sp>
+      <p:sp>
+        <p:nvSpPr>
+          <p:cNvPr id="36" name="TextBox 35"/>
+          <p:cNvSpPr txBox="1"/>
+          <p:nvPr/>
+        </p:nvSpPr>
+        <p:spPr>
+          <a:xfrm>
+            <a:off x="4434840" y="3008376"/>
+            <a:ext cx="1188720" cy="329184"/>
+          </a:xfrm>
+          <a:prstGeom prst="rect">
+            <a:avLst/>
+          </a:prstGeom>
+          <a:noFill/>
+        </p:spPr>
+        <p:txBody>
+          <a:bodyPr wrap="square" lIns="36000" rIns="36000" tIns="18000" bIns="18000" anchor="ctr">
+            <a:spAutoFit/>
+          </a:bodyPr>
+          <a:lstStyle/>
+          <a:p>
+            <a:pPr algn="ctr"/>
+            <a:r>
+              <a:rPr sz="1100" b="1" i="0" u="none">
+                <a:solidFill>
+                  <a:srgbClr val="FFFFFF"/>
+                </a:solidFill>
+                <a:latin typeface="Calibri"/>
+              </a:rPr>
+              <a:t>KV</a:t>
+            </a:r>
+          </a:p>
+        </p:txBody>
+      </p:sp>
+      <p:sp>
+        <p:nvSpPr>
+          <p:cNvPr id="37" name="TextBox 36"/>
+          <p:cNvSpPr txBox="1"/>
+          <p:nvPr/>
+        </p:nvSpPr>
+        <p:spPr>
+          <a:xfrm>
+            <a:off x="5623560" y="3008376"/>
+            <a:ext cx="1371600" cy="329184"/>
+          </a:xfrm>
+          <a:prstGeom prst="rect">
+            <a:avLst/>
+          </a:prstGeom>
+          <a:noFill/>
+        </p:spPr>
+        <p:txBody>
+          <a:bodyPr wrap="square" lIns="36000" rIns="36000" tIns="18000" bIns="18000" anchor="ctr">
+            <a:spAutoFit/>
+          </a:bodyPr>
+          <a:lstStyle/>
+          <a:p>
+            <a:pPr algn="ctr"/>
+            <a:r>
+              <a:rPr sz="1100" b="1" i="0" u="none">
+                <a:solidFill>
+                  <a:srgbClr val="FFFFFF"/>
+                </a:solidFill>
+                <a:latin typeface="Calibri"/>
+              </a:rPr>
+              <a:t>Komposit</a:t>
+            </a:r>
+          </a:p>
+        </p:txBody>
+      </p:sp>
+      <p:sp>
+        <p:nvSpPr>
+          <p:cNvPr id="38" name="TextBox 37"/>
+          <p:cNvSpPr txBox="1"/>
+          <p:nvPr/>
+        </p:nvSpPr>
+        <p:spPr>
+          <a:xfrm>
+            <a:off x="6995160" y="3008376"/>
+            <a:ext cx="1051560" cy="329184"/>
+          </a:xfrm>
+          <a:prstGeom prst="rect">
+            <a:avLst/>
+          </a:prstGeom>
+          <a:noFill/>
+        </p:spPr>
+        <p:txBody>
+          <a:bodyPr wrap="square" lIns="36000" rIns="36000" tIns="18000" bIns="18000" anchor="ctr">
+            <a:spAutoFit/>
+          </a:bodyPr>
+          <a:lstStyle/>
+          <a:p>
+            <a:pPr algn="ctr"/>
+            <a:r>
+              <a:rPr sz="1100" b="1" i="0" u="none">
+                <a:solidFill>
+                  <a:srgbClr val="FFFFFF"/>
+                </a:solidFill>
+                <a:latin typeface="Calibri"/>
+              </a:rPr>
+              <a:t>Leben</a:t>
+            </a:r>
+          </a:p>
+        </p:txBody>
+      </p:sp>
+      <p:sp>
+        <p:nvSpPr>
+          <p:cNvPr id="39" name="Rectangle 38"/>
           <p:cNvSpPr/>
           <p:nvPr/>
         </p:nvSpPr>
         <p:spPr>
           <a:xfrm>
-            <a:off x="3017520" y="3035808"/>
-            <a:ext cx="5029200" cy="1188720"/>
+            <a:off x="411480" y="3337560"/>
+            <a:ext cx="7635240" cy="315468"/>
           </a:xfrm>
           <a:prstGeom prst="rect">
             <a:avLst/>
           </a:prstGeom>
           <a:solidFill>
-            <a:srgbClr val="FDE2C4"/>
+            <a:srgbClr val="E9EFF1"/>
           </a:solidFill>
-          <a:ln w="15875">
-            <a:solidFill>
-              <a:srgbClr val="C86E10"/>
-            </a:solidFill>
+          <a:ln>
+            <a:noFill/>
           </a:ln>
           <a:effectLst/>
         </p:spPr>
@@ -4471,165 +4574,198 @@
       </p:sp>
       <p:sp>
         <p:nvSpPr>
-          <p:cNvPr id="37" name="TextBox 36"/>
-          <p:cNvSpPr txBox="1"/>
-          <p:nvPr/>
-        </p:nvSpPr>
-        <p:spPr>
-          <a:xfrm>
-            <a:off x="3200400" y="3090672"/>
-            <a:ext cx="4663440" cy="292608"/>
-          </a:xfrm>
-          <a:prstGeom prst="rect">
-            <a:avLst/>
-          </a:prstGeom>
-          <a:noFill/>
-        </p:spPr>
-        <p:txBody>
-          <a:bodyPr wrap="square" lIns="36000" rIns="36000" tIns="18000" bIns="18000" anchor="t">
+          <p:cNvPr id="40" name="TextBox 39"/>
+          <p:cNvSpPr txBox="1"/>
+          <p:nvPr/>
+        </p:nvSpPr>
+        <p:spPr>
+          <a:xfrm>
+            <a:off x="521208" y="3337560"/>
+            <a:ext cx="2679192" cy="315468"/>
+          </a:xfrm>
+          <a:prstGeom prst="rect">
+            <a:avLst/>
+          </a:prstGeom>
+          <a:noFill/>
+        </p:spPr>
+        <p:txBody>
+          <a:bodyPr wrap="square" lIns="36000" rIns="36000" tIns="18000" bIns="18000" anchor="ctr">
             <a:spAutoFit/>
           </a:bodyPr>
           <a:lstStyle/>
           <a:p>
             <a:pPr algn="l"/>
             <a:r>
-              <a:rPr sz="1300" b="1" i="0" u="none">
-                <a:solidFill>
-                  <a:srgbClr val="C86E10"/>
-                </a:solidFill>
-                <a:latin typeface="Calibri"/>
-              </a:rPr>
-              <a:t>1.034 Nicht-BÜ-Mails  (20,5 %)</a:t>
-            </a:r>
-          </a:p>
-        </p:txBody>
-      </p:sp>
-      <p:sp>
-        <p:nvSpPr>
-          <p:cNvPr id="38" name="TextBox 37"/>
-          <p:cNvSpPr txBox="1"/>
-          <p:nvPr/>
-        </p:nvSpPr>
-        <p:spPr>
-          <a:xfrm>
-            <a:off x="3200400" y="3401568"/>
-            <a:ext cx="4663440" cy="274320"/>
-          </a:xfrm>
-          <a:prstGeom prst="rect">
-            <a:avLst/>
-          </a:prstGeom>
-          <a:noFill/>
-        </p:spPr>
-        <p:txBody>
-          <a:bodyPr wrap="square" lIns="36000" rIns="36000" tIns="18000" bIns="18000" anchor="t">
-            <a:spAutoFit/>
-          </a:bodyPr>
-          <a:lstStyle/>
-          <a:p>
-            <a:pPr algn="l"/>
-            <a:r>
-              <a:rPr sz="1100" b="0" i="0" u="none">
+              <a:rPr sz="1100" b="1" i="0" u="none">
                 <a:solidFill>
                   <a:srgbClr val="333333"/>
                 </a:solidFill>
                 <a:latin typeface="Calibri"/>
               </a:rPr>
-              <a:t>davon 240 mit Maklervollmacht im Anhang (210 Reminder + 30 Keine BÜ)</a:t>
-            </a:r>
-          </a:p>
-        </p:txBody>
-      </p:sp>
-      <p:sp>
-        <p:nvSpPr>
-          <p:cNvPr id="39" name="TextBox 38"/>
-          <p:cNvSpPr txBox="1"/>
-          <p:nvPr/>
-        </p:nvSpPr>
-        <p:spPr>
-          <a:xfrm>
-            <a:off x="3200400" y="3675888"/>
-            <a:ext cx="4663440" cy="274320"/>
-          </a:xfrm>
-          <a:prstGeom prst="rect">
-            <a:avLst/>
-          </a:prstGeom>
-          <a:noFill/>
-        </p:spPr>
-        <p:txBody>
-          <a:bodyPr wrap="square" lIns="36000" rIns="36000" tIns="18000" bIns="18000" anchor="t">
-            <a:spAutoFit/>
-          </a:bodyPr>
-          <a:lstStyle/>
-          <a:p>
-            <a:pPr algn="l"/>
-            <a:r>
-              <a:rPr sz="1000" b="0" i="1" u="none">
-                <a:solidFill>
-                  <a:srgbClr val="666666"/>
-                </a:solidFill>
-                <a:latin typeface="Calibri"/>
-              </a:rPr>
-              <a:t>Regel 'MV im Anhang → BÜ' legt sie heute faelschlich als BÜ-Vorgang an</a:t>
-            </a:r>
-          </a:p>
-        </p:txBody>
-      </p:sp>
-      <p:sp>
-        <p:nvSpPr>
-          <p:cNvPr id="40" name="TextBox 39"/>
-          <p:cNvSpPr txBox="1"/>
-          <p:nvPr/>
-        </p:nvSpPr>
-        <p:spPr>
-          <a:xfrm>
-            <a:off x="3200400" y="3931920"/>
-            <a:ext cx="4663440" cy="274320"/>
-          </a:xfrm>
-          <a:prstGeom prst="rect">
-            <a:avLst/>
-          </a:prstGeom>
-          <a:noFill/>
-        </p:spPr>
-        <p:txBody>
-          <a:bodyPr wrap="square" lIns="36000" rIns="36000" tIns="18000" bIns="18000" anchor="t">
-            <a:spAutoFit/>
-          </a:bodyPr>
-          <a:lstStyle/>
-          <a:p>
-            <a:pPr algn="l"/>
-            <a:r>
-              <a:rPr sz="1200" b="1" i="0" u="none">
-                <a:solidFill>
-                  <a:srgbClr val="9C060F"/>
-                </a:solidFill>
-                <a:latin typeface="Calibri"/>
-              </a:rPr>
-              <a:t>→  HEBEL 1: Routing / Vorqualifizierung  (Folie 11a)</a:t>
-            </a:r>
-          </a:p>
-        </p:txBody>
-      </p:sp>
-      <p:sp>
-        <p:nvSpPr>
-          <p:cNvPr id="41" name="Rectangle 40"/>
+              <a:t>Gesamt Mails</a:t>
+            </a:r>
+          </a:p>
+        </p:txBody>
+      </p:sp>
+      <p:sp>
+        <p:nvSpPr>
+          <p:cNvPr id="41" name="TextBox 40"/>
+          <p:cNvSpPr txBox="1"/>
+          <p:nvPr/>
+        </p:nvSpPr>
+        <p:spPr>
+          <a:xfrm>
+            <a:off x="3200400" y="3337560"/>
+            <a:ext cx="1234440" cy="315468"/>
+          </a:xfrm>
+          <a:prstGeom prst="rect">
+            <a:avLst/>
+          </a:prstGeom>
+          <a:noFill/>
+        </p:spPr>
+        <p:txBody>
+          <a:bodyPr wrap="square" lIns="36000" rIns="36000" tIns="18000" bIns="18000" anchor="ctr">
+            <a:spAutoFit/>
+          </a:bodyPr>
+          <a:lstStyle/>
+          <a:p>
+            <a:pPr algn="ctr"/>
+            <a:r>
+              <a:rPr sz="1100" b="1" i="0" u="none">
+                <a:solidFill>
+                  <a:srgbClr val="333333"/>
+                </a:solidFill>
+                <a:latin typeface="Calibri"/>
+              </a:rPr>
+              <a:t>5.034</a:t>
+            </a:r>
+          </a:p>
+        </p:txBody>
+      </p:sp>
+      <p:sp>
+        <p:nvSpPr>
+          <p:cNvPr id="42" name="TextBox 41"/>
+          <p:cNvSpPr txBox="1"/>
+          <p:nvPr/>
+        </p:nvSpPr>
+        <p:spPr>
+          <a:xfrm>
+            <a:off x="4434840" y="3337560"/>
+            <a:ext cx="1188720" cy="315468"/>
+          </a:xfrm>
+          <a:prstGeom prst="rect">
+            <a:avLst/>
+          </a:prstGeom>
+          <a:noFill/>
+        </p:spPr>
+        <p:txBody>
+          <a:bodyPr wrap="square" lIns="36000" rIns="36000" tIns="18000" bIns="18000" anchor="ctr">
+            <a:spAutoFit/>
+          </a:bodyPr>
+          <a:lstStyle/>
+          <a:p>
+            <a:pPr algn="ctr"/>
+            <a:r>
+              <a:rPr sz="1100" b="1" i="0" u="none">
+                <a:solidFill>
+                  <a:srgbClr val="333333"/>
+                </a:solidFill>
+                <a:latin typeface="Calibri"/>
+              </a:rPr>
+              <a:t>1.308</a:t>
+            </a:r>
+          </a:p>
+        </p:txBody>
+      </p:sp>
+      <p:sp>
+        <p:nvSpPr>
+          <p:cNvPr id="43" name="TextBox 42"/>
+          <p:cNvSpPr txBox="1"/>
+          <p:nvPr/>
+        </p:nvSpPr>
+        <p:spPr>
+          <a:xfrm>
+            <a:off x="5623560" y="3337560"/>
+            <a:ext cx="1371600" cy="315468"/>
+          </a:xfrm>
+          <a:prstGeom prst="rect">
+            <a:avLst/>
+          </a:prstGeom>
+          <a:noFill/>
+        </p:spPr>
+        <p:txBody>
+          <a:bodyPr wrap="square" lIns="36000" rIns="36000" tIns="18000" bIns="18000" anchor="ctr">
+            <a:spAutoFit/>
+          </a:bodyPr>
+          <a:lstStyle/>
+          <a:p>
+            <a:pPr algn="ctr"/>
+            <a:r>
+              <a:rPr sz="1100" b="1" i="0" u="none">
+                <a:solidFill>
+                  <a:srgbClr val="333333"/>
+                </a:solidFill>
+                <a:latin typeface="Calibri"/>
+              </a:rPr>
+              <a:t>2.502</a:t>
+            </a:r>
+          </a:p>
+        </p:txBody>
+      </p:sp>
+      <p:sp>
+        <p:nvSpPr>
+          <p:cNvPr id="44" name="TextBox 43"/>
+          <p:cNvSpPr txBox="1"/>
+          <p:nvPr/>
+        </p:nvSpPr>
+        <p:spPr>
+          <a:xfrm>
+            <a:off x="6995160" y="3337560"/>
+            <a:ext cx="1051560" cy="315468"/>
+          </a:xfrm>
+          <a:prstGeom prst="rect">
+            <a:avLst/>
+          </a:prstGeom>
+          <a:noFill/>
+        </p:spPr>
+        <p:txBody>
+          <a:bodyPr wrap="square" lIns="36000" rIns="36000" tIns="18000" bIns="18000" anchor="ctr">
+            <a:spAutoFit/>
+          </a:bodyPr>
+          <a:lstStyle/>
+          <a:p>
+            <a:pPr algn="ctr"/>
+            <a:r>
+              <a:rPr sz="1100" b="1" i="0" u="none">
+                <a:solidFill>
+                  <a:srgbClr val="333333"/>
+                </a:solidFill>
+                <a:latin typeface="Calibri"/>
+              </a:rPr>
+              <a:t>755</a:t>
+            </a:r>
+          </a:p>
+        </p:txBody>
+      </p:sp>
+      <p:sp>
+        <p:nvSpPr>
+          <p:cNvPr id="45" name="Rectangle 44"/>
           <p:cNvSpPr/>
           <p:nvPr/>
         </p:nvSpPr>
         <p:spPr>
           <a:xfrm>
-            <a:off x="3017520" y="4361688"/>
-            <a:ext cx="5029200" cy="1188720"/>
+            <a:off x="411480" y="3653028"/>
+            <a:ext cx="7635240" cy="315468"/>
           </a:xfrm>
           <a:prstGeom prst="rect">
             <a:avLst/>
           </a:prstGeom>
           <a:solidFill>
-            <a:srgbClr val="CFE6E9"/>
+            <a:srgbClr val="F1F1F1"/>
           </a:solidFill>
-          <a:ln w="15875">
-            <a:solidFill>
-              <a:srgbClr val="008793"/>
-            </a:solidFill>
+          <a:ln>
+            <a:noFill/>
           </a:ln>
           <a:effectLst/>
         </p:spPr>
@@ -4657,57 +4793,241 @@
       </p:sp>
       <p:sp>
         <p:nvSpPr>
-          <p:cNvPr id="42" name="TextBox 41"/>
-          <p:cNvSpPr txBox="1"/>
-          <p:nvPr/>
-        </p:nvSpPr>
-        <p:spPr>
-          <a:xfrm>
-            <a:off x="3200400" y="4434840"/>
-            <a:ext cx="4663440" cy="310896"/>
-          </a:xfrm>
-          <a:prstGeom prst="rect">
-            <a:avLst/>
-          </a:prstGeom>
-          <a:noFill/>
-        </p:spPr>
-        <p:txBody>
-          <a:bodyPr wrap="square" lIns="36000" rIns="36000" tIns="18000" bIns="18000" anchor="t">
+          <p:cNvPr id="46" name="TextBox 45"/>
+          <p:cNvSpPr txBox="1"/>
+          <p:nvPr/>
+        </p:nvSpPr>
+        <p:spPr>
+          <a:xfrm>
+            <a:off x="521208" y="3653028"/>
+            <a:ext cx="2679192" cy="315468"/>
+          </a:xfrm>
+          <a:prstGeom prst="rect">
+            <a:avLst/>
+          </a:prstGeom>
+          <a:noFill/>
+        </p:spPr>
+        <p:txBody>
+          <a:bodyPr wrap="square" lIns="36000" rIns="36000" tIns="18000" bIns="18000" anchor="ctr">
             <a:spAutoFit/>
           </a:bodyPr>
           <a:lstStyle/>
           <a:p>
             <a:pPr algn="l"/>
             <a:r>
-              <a:rPr sz="1400" b="1" i="0" u="none">
-                <a:solidFill>
-                  <a:srgbClr val="006B77"/>
-                </a:solidFill>
-                <a:latin typeface="Calibri"/>
-              </a:rPr>
-              <a:t>4.000 BÜ-Anfrage-Mails  (79,5 %)</a:t>
-            </a:r>
-          </a:p>
-        </p:txBody>
-      </p:sp>
-      <p:sp>
-        <p:nvSpPr>
-          <p:cNvPr id="43" name="TextBox 42"/>
-          <p:cNvSpPr txBox="1"/>
-          <p:nvPr/>
-        </p:nvSpPr>
-        <p:spPr>
-          <a:xfrm>
-            <a:off x="3200400" y="4773168"/>
-            <a:ext cx="4663440" cy="457200"/>
-          </a:xfrm>
-          <a:prstGeom prst="rect">
-            <a:avLst/>
-          </a:prstGeom>
-          <a:noFill/>
-        </p:spPr>
-        <p:txBody>
-          <a:bodyPr wrap="square" lIns="36000" rIns="36000" tIns="18000" bIns="18000" anchor="t">
+              <a:rPr sz="1100" b="0" i="0" u="none">
+                <a:solidFill>
+                  <a:srgbClr val="333333"/>
+                </a:solidFill>
+                <a:latin typeface="Calibri"/>
+              </a:rPr>
+              <a:t>Neue BÜ (echte BÜ-Anfragen)</a:t>
+            </a:r>
+          </a:p>
+        </p:txBody>
+      </p:sp>
+      <p:sp>
+        <p:nvSpPr>
+          <p:cNvPr id="47" name="TextBox 46"/>
+          <p:cNvSpPr txBox="1"/>
+          <p:nvPr/>
+        </p:nvSpPr>
+        <p:spPr>
+          <a:xfrm>
+            <a:off x="3200400" y="3653028"/>
+            <a:ext cx="1234440" cy="315468"/>
+          </a:xfrm>
+          <a:prstGeom prst="rect">
+            <a:avLst/>
+          </a:prstGeom>
+          <a:noFill/>
+        </p:spPr>
+        <p:txBody>
+          <a:bodyPr wrap="square" lIns="36000" rIns="36000" tIns="18000" bIns="18000" anchor="ctr">
+            <a:spAutoFit/>
+          </a:bodyPr>
+          <a:lstStyle/>
+          <a:p>
+            <a:pPr algn="ctr"/>
+            <a:r>
+              <a:rPr sz="1100" b="1" i="0" u="none">
+                <a:solidFill>
+                  <a:srgbClr val="333333"/>
+                </a:solidFill>
+                <a:latin typeface="Calibri"/>
+              </a:rPr>
+              <a:t>4.000</a:t>
+            </a:r>
+          </a:p>
+        </p:txBody>
+      </p:sp>
+      <p:sp>
+        <p:nvSpPr>
+          <p:cNvPr id="48" name="TextBox 47"/>
+          <p:cNvSpPr txBox="1"/>
+          <p:nvPr/>
+        </p:nvSpPr>
+        <p:spPr>
+          <a:xfrm>
+            <a:off x="4434840" y="3653028"/>
+            <a:ext cx="1188720" cy="315468"/>
+          </a:xfrm>
+          <a:prstGeom prst="rect">
+            <a:avLst/>
+          </a:prstGeom>
+          <a:noFill/>
+        </p:spPr>
+        <p:txBody>
+          <a:bodyPr wrap="square" lIns="36000" rIns="36000" tIns="18000" bIns="18000" anchor="ctr">
+            <a:spAutoFit/>
+          </a:bodyPr>
+          <a:lstStyle/>
+          <a:p>
+            <a:pPr algn="ctr"/>
+            <a:r>
+              <a:rPr sz="1100" b="0" i="0" u="none">
+                <a:solidFill>
+                  <a:srgbClr val="333333"/>
+                </a:solidFill>
+                <a:latin typeface="Calibri"/>
+              </a:rPr>
+              <a:t>1.147</a:t>
+            </a:r>
+          </a:p>
+        </p:txBody>
+      </p:sp>
+      <p:sp>
+        <p:nvSpPr>
+          <p:cNvPr id="49" name="TextBox 48"/>
+          <p:cNvSpPr txBox="1"/>
+          <p:nvPr/>
+        </p:nvSpPr>
+        <p:spPr>
+          <a:xfrm>
+            <a:off x="5623560" y="3653028"/>
+            <a:ext cx="1371600" cy="315468"/>
+          </a:xfrm>
+          <a:prstGeom prst="rect">
+            <a:avLst/>
+          </a:prstGeom>
+          <a:noFill/>
+        </p:spPr>
+        <p:txBody>
+          <a:bodyPr wrap="square" lIns="36000" rIns="36000" tIns="18000" bIns="18000" anchor="ctr">
+            <a:spAutoFit/>
+          </a:bodyPr>
+          <a:lstStyle/>
+          <a:p>
+            <a:pPr algn="ctr"/>
+            <a:r>
+              <a:rPr sz="1100" b="0" i="0" u="none">
+                <a:solidFill>
+                  <a:srgbClr val="333333"/>
+                </a:solidFill>
+                <a:latin typeface="Calibri"/>
+              </a:rPr>
+              <a:t>2.089</a:t>
+            </a:r>
+          </a:p>
+        </p:txBody>
+      </p:sp>
+      <p:sp>
+        <p:nvSpPr>
+          <p:cNvPr id="50" name="TextBox 49"/>
+          <p:cNvSpPr txBox="1"/>
+          <p:nvPr/>
+        </p:nvSpPr>
+        <p:spPr>
+          <a:xfrm>
+            <a:off x="6995160" y="3653028"/>
+            <a:ext cx="1051560" cy="315468"/>
+          </a:xfrm>
+          <a:prstGeom prst="rect">
+            <a:avLst/>
+          </a:prstGeom>
+          <a:noFill/>
+        </p:spPr>
+        <p:txBody>
+          <a:bodyPr wrap="square" lIns="36000" rIns="36000" tIns="18000" bIns="18000" anchor="ctr">
+            <a:spAutoFit/>
+          </a:bodyPr>
+          <a:lstStyle/>
+          <a:p>
+            <a:pPr algn="ctr"/>
+            <a:r>
+              <a:rPr sz="1100" b="0" i="0" u="none">
+                <a:solidFill>
+                  <a:srgbClr val="333333"/>
+                </a:solidFill>
+                <a:latin typeface="Calibri"/>
+              </a:rPr>
+              <a:t>662</a:t>
+            </a:r>
+          </a:p>
+        </p:txBody>
+      </p:sp>
+      <p:sp>
+        <p:nvSpPr>
+          <p:cNvPr id="51" name="Rectangle 50"/>
+          <p:cNvSpPr/>
+          <p:nvPr/>
+        </p:nvSpPr>
+        <p:spPr>
+          <a:xfrm>
+            <a:off x="411480" y="3968496"/>
+            <a:ext cx="7635240" cy="315468"/>
+          </a:xfrm>
+          <a:prstGeom prst="rect">
+            <a:avLst/>
+          </a:prstGeom>
+          <a:solidFill>
+            <a:srgbClr val="FFFFFF"/>
+          </a:solidFill>
+          <a:ln>
+            <a:noFill/>
+          </a:ln>
+          <a:effectLst/>
+        </p:spPr>
+        <p:style>
+          <a:lnRef idx="1">
+            <a:schemeClr val="accent1"/>
+          </a:lnRef>
+          <a:fillRef idx="3">
+            <a:schemeClr val="accent1"/>
+          </a:fillRef>
+          <a:effectRef idx="2">
+            <a:schemeClr val="accent1"/>
+          </a:effectRef>
+          <a:fontRef idx="minor">
+            <a:schemeClr val="lt1"/>
+          </a:fontRef>
+        </p:style>
+        <p:txBody>
+          <a:bodyPr rtlCol="0" anchor="ctr"/>
+          <a:lstStyle/>
+          <a:p>
+            <a:pPr algn="ctr"/>
+          </a:p>
+        </p:txBody>
+      </p:sp>
+      <p:sp>
+        <p:nvSpPr>
+          <p:cNvPr id="52" name="TextBox 51"/>
+          <p:cNvSpPr txBox="1"/>
+          <p:nvPr/>
+        </p:nvSpPr>
+        <p:spPr>
+          <a:xfrm>
+            <a:off x="521208" y="3968496"/>
+            <a:ext cx="2679192" cy="315468"/>
+          </a:xfrm>
+          <a:prstGeom prst="rect">
+            <a:avLst/>
+          </a:prstGeom>
+          <a:noFill/>
+        </p:spPr>
+        <p:txBody>
+          <a:bodyPr wrap="square" lIns="36000" rIns="36000" tIns="18000" bIns="18000" anchor="ctr">
             <a:spAutoFit/>
           </a:bodyPr>
           <a:lstStyle/>
@@ -4720,58 +5040,207 @@
                 </a:solidFill>
                 <a:latin typeface="Calibri"/>
               </a:rPr>
-              <a:t>buendeln sich zu nur 2.495 Vorgaengen  ·  619 Kunden mit mehreren Vertraegen beim selben Makler</a:t>
-            </a:r>
-          </a:p>
-        </p:txBody>
-      </p:sp>
-      <p:sp>
-        <p:nvSpPr>
-          <p:cNvPr id="44" name="TextBox 43"/>
-          <p:cNvSpPr txBox="1"/>
-          <p:nvPr/>
-        </p:nvSpPr>
-        <p:spPr>
-          <a:xfrm>
-            <a:off x="3200400" y="5257800"/>
-            <a:ext cx="4663440" cy="292608"/>
-          </a:xfrm>
-          <a:prstGeom prst="rect">
-            <a:avLst/>
-          </a:prstGeom>
-          <a:noFill/>
-        </p:spPr>
-        <p:txBody>
-          <a:bodyPr wrap="square" lIns="36000" rIns="36000" tIns="18000" bIns="18000" anchor="t">
-            <a:spAutoFit/>
-          </a:bodyPr>
-          <a:lstStyle/>
-          <a:p>
-            <a:pPr algn="l"/>
-            <a:r>
-              <a:rPr sz="1200" b="1" i="0" u="none">
-                <a:solidFill>
-                  <a:srgbClr val="9C060F"/>
-                </a:solidFill>
-                <a:latin typeface="Calibri"/>
-              </a:rPr>
-              <a:t>→  HEBEL 2: Clustering / Arbeitsvorrats-Steuerung  (Folie 11b)</a:t>
-            </a:r>
-          </a:p>
-        </p:txBody>
-      </p:sp>
-      <p:sp>
-        <p:nvSpPr>
-          <p:cNvPr id="45" name="Right Arrow 44"/>
+              <a:t>Keine BÜ</a:t>
+            </a:r>
+          </a:p>
+        </p:txBody>
+      </p:sp>
+      <p:sp>
+        <p:nvSpPr>
+          <p:cNvPr id="53" name="TextBox 52"/>
+          <p:cNvSpPr txBox="1"/>
+          <p:nvPr/>
+        </p:nvSpPr>
+        <p:spPr>
+          <a:xfrm>
+            <a:off x="3200400" y="3968496"/>
+            <a:ext cx="1234440" cy="315468"/>
+          </a:xfrm>
+          <a:prstGeom prst="rect">
+            <a:avLst/>
+          </a:prstGeom>
+          <a:noFill/>
+        </p:spPr>
+        <p:txBody>
+          <a:bodyPr wrap="square" lIns="36000" rIns="36000" tIns="18000" bIns="18000" anchor="ctr">
+            <a:spAutoFit/>
+          </a:bodyPr>
+          <a:lstStyle/>
+          <a:p>
+            <a:pPr algn="ctr"/>
+            <a:r>
+              <a:rPr sz="1100" b="1" i="0" u="none">
+                <a:solidFill>
+                  <a:srgbClr val="333333"/>
+                </a:solidFill>
+                <a:latin typeface="Calibri"/>
+              </a:rPr>
+              <a:t>705</a:t>
+            </a:r>
+          </a:p>
+        </p:txBody>
+      </p:sp>
+      <p:sp>
+        <p:nvSpPr>
+          <p:cNvPr id="54" name="TextBox 53"/>
+          <p:cNvSpPr txBox="1"/>
+          <p:nvPr/>
+        </p:nvSpPr>
+        <p:spPr>
+          <a:xfrm>
+            <a:off x="4434840" y="3968496"/>
+            <a:ext cx="1188720" cy="315468"/>
+          </a:xfrm>
+          <a:prstGeom prst="rect">
+            <a:avLst/>
+          </a:prstGeom>
+          <a:noFill/>
+        </p:spPr>
+        <p:txBody>
+          <a:bodyPr wrap="square" lIns="36000" rIns="36000" tIns="18000" bIns="18000" anchor="ctr">
+            <a:spAutoFit/>
+          </a:bodyPr>
+          <a:lstStyle/>
+          <a:p>
+            <a:pPr algn="ctr"/>
+            <a:r>
+              <a:rPr sz="1100" b="0" i="0" u="none">
+                <a:solidFill>
+                  <a:srgbClr val="333333"/>
+                </a:solidFill>
+                <a:latin typeface="Calibri"/>
+              </a:rPr>
+              <a:t>112</a:t>
+            </a:r>
+          </a:p>
+        </p:txBody>
+      </p:sp>
+      <p:sp>
+        <p:nvSpPr>
+          <p:cNvPr id="55" name="TextBox 54"/>
+          <p:cNvSpPr txBox="1"/>
+          <p:nvPr/>
+        </p:nvSpPr>
+        <p:spPr>
+          <a:xfrm>
+            <a:off x="5623560" y="3968496"/>
+            <a:ext cx="1371600" cy="315468"/>
+          </a:xfrm>
+          <a:prstGeom prst="rect">
+            <a:avLst/>
+          </a:prstGeom>
+          <a:noFill/>
+        </p:spPr>
+        <p:txBody>
+          <a:bodyPr wrap="square" lIns="36000" rIns="36000" tIns="18000" bIns="18000" anchor="ctr">
+            <a:spAutoFit/>
+          </a:bodyPr>
+          <a:lstStyle/>
+          <a:p>
+            <a:pPr algn="ctr"/>
+            <a:r>
+              <a:rPr sz="1100" b="0" i="0" u="none">
+                <a:solidFill>
+                  <a:srgbClr val="333333"/>
+                </a:solidFill>
+                <a:latin typeface="Calibri"/>
+              </a:rPr>
+              <a:t>192</a:t>
+            </a:r>
+          </a:p>
+        </p:txBody>
+      </p:sp>
+      <p:sp>
+        <p:nvSpPr>
+          <p:cNvPr id="56" name="TextBox 55"/>
+          <p:cNvSpPr txBox="1"/>
+          <p:nvPr/>
+        </p:nvSpPr>
+        <p:spPr>
+          <a:xfrm>
+            <a:off x="6995160" y="3968496"/>
+            <a:ext cx="1051560" cy="315468"/>
+          </a:xfrm>
+          <a:prstGeom prst="rect">
+            <a:avLst/>
+          </a:prstGeom>
+          <a:noFill/>
+        </p:spPr>
+        <p:txBody>
+          <a:bodyPr wrap="square" lIns="36000" rIns="36000" tIns="18000" bIns="18000" anchor="ctr">
+            <a:spAutoFit/>
+          </a:bodyPr>
+          <a:lstStyle/>
+          <a:p>
+            <a:pPr algn="ctr"/>
+            <a:r>
+              <a:rPr sz="1100" b="0" i="0" u="none">
+                <a:solidFill>
+                  <a:srgbClr val="333333"/>
+                </a:solidFill>
+                <a:latin typeface="Calibri"/>
+              </a:rPr>
+              <a:t>55</a:t>
+            </a:r>
+          </a:p>
+        </p:txBody>
+      </p:sp>
+      <p:sp>
+        <p:nvSpPr>
+          <p:cNvPr id="57" name="Rectangle 56"/>
           <p:cNvSpPr/>
           <p:nvPr/>
         </p:nvSpPr>
         <p:spPr>
           <a:xfrm>
-            <a:off x="2514600" y="4041648"/>
-            <a:ext cx="457200" cy="274320"/>
-          </a:xfrm>
-          <a:prstGeom prst="rightArrow">
+            <a:off x="411480" y="4283964"/>
+            <a:ext cx="7635240" cy="315468"/>
+          </a:xfrm>
+          <a:prstGeom prst="rect">
+            <a:avLst/>
+          </a:prstGeom>
+          <a:solidFill>
+            <a:srgbClr val="FDE2C4"/>
+          </a:solidFill>
+          <a:ln>
+            <a:noFill/>
+          </a:ln>
+          <a:effectLst/>
+        </p:spPr>
+        <p:style>
+          <a:lnRef idx="1">
+            <a:schemeClr val="accent1"/>
+          </a:lnRef>
+          <a:fillRef idx="3">
+            <a:schemeClr val="accent1"/>
+          </a:fillRef>
+          <a:effectRef idx="2">
+            <a:schemeClr val="accent1"/>
+          </a:effectRef>
+          <a:fontRef idx="minor">
+            <a:schemeClr val="lt1"/>
+          </a:fontRef>
+        </p:style>
+        <p:txBody>
+          <a:bodyPr rtlCol="0" anchor="ctr"/>
+          <a:lstStyle/>
+          <a:p>
+            <a:pPr algn="ctr"/>
+          </a:p>
+        </p:txBody>
+      </p:sp>
+      <p:sp>
+        <p:nvSpPr>
+          <p:cNvPr id="58" name="Rectangle 57"/>
+          <p:cNvSpPr/>
+          <p:nvPr/>
+        </p:nvSpPr>
+        <p:spPr>
+          <a:xfrm>
+            <a:off x="411480" y="4283964"/>
+            <a:ext cx="91440" cy="315468"/>
+          </a:xfrm>
+          <a:prstGeom prst="rect">
             <a:avLst/>
           </a:prstGeom>
           <a:solidFill>
@@ -4806,16 +5275,914 @@
       </p:sp>
       <p:sp>
         <p:nvSpPr>
-          <p:cNvPr id="46" name="Right Arrow 45"/>
+          <p:cNvPr id="59" name="TextBox 58"/>
+          <p:cNvSpPr txBox="1"/>
+          <p:nvPr/>
+        </p:nvSpPr>
+        <p:spPr>
+          <a:xfrm>
+            <a:off x="521208" y="4283964"/>
+            <a:ext cx="2679192" cy="315468"/>
+          </a:xfrm>
+          <a:prstGeom prst="rect">
+            <a:avLst/>
+          </a:prstGeom>
+          <a:noFill/>
+        </p:spPr>
+        <p:txBody>
+          <a:bodyPr wrap="square" lIns="36000" rIns="36000" tIns="18000" bIns="18000" anchor="ctr">
+            <a:spAutoFit/>
+          </a:bodyPr>
+          <a:lstStyle/>
+          <a:p>
+            <a:pPr algn="l"/>
+            <a:r>
+              <a:rPr sz="1100" b="1" i="1" u="none">
+                <a:solidFill>
+                  <a:srgbClr val="C86E10"/>
+                </a:solidFill>
+                <a:latin typeface="Calibri"/>
+              </a:rPr>
+              <a:t>   davon mit MV im Anhang*</a:t>
+            </a:r>
+          </a:p>
+        </p:txBody>
+      </p:sp>
+      <p:sp>
+        <p:nvSpPr>
+          <p:cNvPr id="60" name="TextBox 59"/>
+          <p:cNvSpPr txBox="1"/>
+          <p:nvPr/>
+        </p:nvSpPr>
+        <p:spPr>
+          <a:xfrm>
+            <a:off x="3200400" y="4283964"/>
+            <a:ext cx="1234440" cy="315468"/>
+          </a:xfrm>
+          <a:prstGeom prst="rect">
+            <a:avLst/>
+          </a:prstGeom>
+          <a:noFill/>
+        </p:spPr>
+        <p:txBody>
+          <a:bodyPr wrap="square" lIns="36000" rIns="36000" tIns="18000" bIns="18000" anchor="ctr">
+            <a:spAutoFit/>
+          </a:bodyPr>
+          <a:lstStyle/>
+          <a:p>
+            <a:pPr algn="ctr"/>
+            <a:r>
+              <a:rPr sz="1100" b="1" i="1" u="none">
+                <a:solidFill>
+                  <a:srgbClr val="C86E10"/>
+                </a:solidFill>
+                <a:latin typeface="Calibri"/>
+              </a:rPr>
+              <a:t>30</a:t>
+            </a:r>
+          </a:p>
+        </p:txBody>
+      </p:sp>
+      <p:sp>
+        <p:nvSpPr>
+          <p:cNvPr id="61" name="TextBox 60"/>
+          <p:cNvSpPr txBox="1"/>
+          <p:nvPr/>
+        </p:nvSpPr>
+        <p:spPr>
+          <a:xfrm>
+            <a:off x="4434840" y="4283964"/>
+            <a:ext cx="1188720" cy="315468"/>
+          </a:xfrm>
+          <a:prstGeom prst="rect">
+            <a:avLst/>
+          </a:prstGeom>
+          <a:noFill/>
+        </p:spPr>
+        <p:txBody>
+          <a:bodyPr wrap="square" lIns="36000" rIns="36000" tIns="18000" bIns="18000" anchor="ctr">
+            <a:spAutoFit/>
+          </a:bodyPr>
+          <a:lstStyle/>
+          <a:p>
+            <a:pPr algn="ctr"/>
+            <a:r>
+              <a:rPr sz="1100" b="1" i="1" u="none">
+                <a:solidFill>
+                  <a:srgbClr val="C86E10"/>
+                </a:solidFill>
+                <a:latin typeface="Calibri"/>
+              </a:rPr>
+              <a:t>7</a:t>
+            </a:r>
+          </a:p>
+        </p:txBody>
+      </p:sp>
+      <p:sp>
+        <p:nvSpPr>
+          <p:cNvPr id="62" name="TextBox 61"/>
+          <p:cNvSpPr txBox="1"/>
+          <p:nvPr/>
+        </p:nvSpPr>
+        <p:spPr>
+          <a:xfrm>
+            <a:off x="5623560" y="4283964"/>
+            <a:ext cx="1371600" cy="315468"/>
+          </a:xfrm>
+          <a:prstGeom prst="rect">
+            <a:avLst/>
+          </a:prstGeom>
+          <a:noFill/>
+        </p:spPr>
+        <p:txBody>
+          <a:bodyPr wrap="square" lIns="36000" rIns="36000" tIns="18000" bIns="18000" anchor="ctr">
+            <a:spAutoFit/>
+          </a:bodyPr>
+          <a:lstStyle/>
+          <a:p>
+            <a:pPr algn="ctr"/>
+            <a:r>
+              <a:rPr sz="1100" b="1" i="1" u="none">
+                <a:solidFill>
+                  <a:srgbClr val="C86E10"/>
+                </a:solidFill>
+                <a:latin typeface="Calibri"/>
+              </a:rPr>
+              <a:t>20</a:t>
+            </a:r>
+          </a:p>
+        </p:txBody>
+      </p:sp>
+      <p:sp>
+        <p:nvSpPr>
+          <p:cNvPr id="63" name="TextBox 62"/>
+          <p:cNvSpPr txBox="1"/>
+          <p:nvPr/>
+        </p:nvSpPr>
+        <p:spPr>
+          <a:xfrm>
+            <a:off x="6995160" y="4283964"/>
+            <a:ext cx="1051560" cy="315468"/>
+          </a:xfrm>
+          <a:prstGeom prst="rect">
+            <a:avLst/>
+          </a:prstGeom>
+          <a:noFill/>
+        </p:spPr>
+        <p:txBody>
+          <a:bodyPr wrap="square" lIns="36000" rIns="36000" tIns="18000" bIns="18000" anchor="ctr">
+            <a:spAutoFit/>
+          </a:bodyPr>
+          <a:lstStyle/>
+          <a:p>
+            <a:pPr algn="ctr"/>
+            <a:r>
+              <a:rPr sz="1100" b="1" i="1" u="none">
+                <a:solidFill>
+                  <a:srgbClr val="C86E10"/>
+                </a:solidFill>
+                <a:latin typeface="Calibri"/>
+              </a:rPr>
+              <a:t>2</a:t>
+            </a:r>
+          </a:p>
+        </p:txBody>
+      </p:sp>
+      <p:sp>
+        <p:nvSpPr>
+          <p:cNvPr id="64" name="Rectangle 63"/>
           <p:cNvSpPr/>
           <p:nvPr/>
         </p:nvSpPr>
         <p:spPr>
           <a:xfrm>
-            <a:off x="2514600" y="4498848"/>
-            <a:ext cx="457200" cy="274320"/>
-          </a:xfrm>
-          <a:prstGeom prst="rightArrow">
+            <a:off x="411480" y="4599432"/>
+            <a:ext cx="7635240" cy="315468"/>
+          </a:xfrm>
+          <a:prstGeom prst="rect">
+            <a:avLst/>
+          </a:prstGeom>
+          <a:solidFill>
+            <a:srgbClr val="FFFFFF"/>
+          </a:solidFill>
+          <a:ln>
+            <a:noFill/>
+          </a:ln>
+          <a:effectLst/>
+        </p:spPr>
+        <p:style>
+          <a:lnRef idx="1">
+            <a:schemeClr val="accent1"/>
+          </a:lnRef>
+          <a:fillRef idx="3">
+            <a:schemeClr val="accent1"/>
+          </a:fillRef>
+          <a:effectRef idx="2">
+            <a:schemeClr val="accent1"/>
+          </a:effectRef>
+          <a:fontRef idx="minor">
+            <a:schemeClr val="lt1"/>
+          </a:fontRef>
+        </p:style>
+        <p:txBody>
+          <a:bodyPr rtlCol="0" anchor="ctr"/>
+          <a:lstStyle/>
+          <a:p>
+            <a:pPr algn="ctr"/>
+          </a:p>
+        </p:txBody>
+      </p:sp>
+      <p:sp>
+        <p:nvSpPr>
+          <p:cNvPr id="65" name="TextBox 64"/>
+          <p:cNvSpPr txBox="1"/>
+          <p:nvPr/>
+        </p:nvSpPr>
+        <p:spPr>
+          <a:xfrm>
+            <a:off x="521208" y="4599432"/>
+            <a:ext cx="2679192" cy="315468"/>
+          </a:xfrm>
+          <a:prstGeom prst="rect">
+            <a:avLst/>
+          </a:prstGeom>
+          <a:noFill/>
+        </p:spPr>
+        <p:txBody>
+          <a:bodyPr wrap="square" lIns="36000" rIns="36000" tIns="18000" bIns="18000" anchor="ctr">
+            <a:spAutoFit/>
+          </a:bodyPr>
+          <a:lstStyle/>
+          <a:p>
+            <a:pPr algn="l"/>
+            <a:r>
+              <a:rPr sz="1100" b="0" i="0" u="none">
+                <a:solidFill>
+                  <a:srgbClr val="333333"/>
+                </a:solidFill>
+                <a:latin typeface="Calibri"/>
+              </a:rPr>
+              <a:t>BÜ-Reminder</a:t>
+            </a:r>
+          </a:p>
+        </p:txBody>
+      </p:sp>
+      <p:sp>
+        <p:nvSpPr>
+          <p:cNvPr id="66" name="TextBox 65"/>
+          <p:cNvSpPr txBox="1"/>
+          <p:nvPr/>
+        </p:nvSpPr>
+        <p:spPr>
+          <a:xfrm>
+            <a:off x="3200400" y="4599432"/>
+            <a:ext cx="1234440" cy="315468"/>
+          </a:xfrm>
+          <a:prstGeom prst="rect">
+            <a:avLst/>
+          </a:prstGeom>
+          <a:noFill/>
+        </p:spPr>
+        <p:txBody>
+          <a:bodyPr wrap="square" lIns="36000" rIns="36000" tIns="18000" bIns="18000" anchor="ctr">
+            <a:spAutoFit/>
+          </a:bodyPr>
+          <a:lstStyle/>
+          <a:p>
+            <a:pPr algn="ctr"/>
+            <a:r>
+              <a:rPr sz="1100" b="1" i="0" u="none">
+                <a:solidFill>
+                  <a:srgbClr val="333333"/>
+                </a:solidFill>
+                <a:latin typeface="Calibri"/>
+              </a:rPr>
+              <a:t>329</a:t>
+            </a:r>
+          </a:p>
+        </p:txBody>
+      </p:sp>
+      <p:sp>
+        <p:nvSpPr>
+          <p:cNvPr id="67" name="TextBox 66"/>
+          <p:cNvSpPr txBox="1"/>
+          <p:nvPr/>
+        </p:nvSpPr>
+        <p:spPr>
+          <a:xfrm>
+            <a:off x="4434840" y="4599432"/>
+            <a:ext cx="1188720" cy="315468"/>
+          </a:xfrm>
+          <a:prstGeom prst="rect">
+            <a:avLst/>
+          </a:prstGeom>
+          <a:noFill/>
+        </p:spPr>
+        <p:txBody>
+          <a:bodyPr wrap="square" lIns="36000" rIns="36000" tIns="18000" bIns="18000" anchor="ctr">
+            <a:spAutoFit/>
+          </a:bodyPr>
+          <a:lstStyle/>
+          <a:p>
+            <a:pPr algn="ctr"/>
+            <a:r>
+              <a:rPr sz="1100" b="0" i="0" u="none">
+                <a:solidFill>
+                  <a:srgbClr val="333333"/>
+                </a:solidFill>
+                <a:latin typeface="Calibri"/>
+              </a:rPr>
+              <a:t>49</a:t>
+            </a:r>
+          </a:p>
+        </p:txBody>
+      </p:sp>
+      <p:sp>
+        <p:nvSpPr>
+          <p:cNvPr id="68" name="TextBox 67"/>
+          <p:cNvSpPr txBox="1"/>
+          <p:nvPr/>
+        </p:nvSpPr>
+        <p:spPr>
+          <a:xfrm>
+            <a:off x="5623560" y="4599432"/>
+            <a:ext cx="1371600" cy="315468"/>
+          </a:xfrm>
+          <a:prstGeom prst="rect">
+            <a:avLst/>
+          </a:prstGeom>
+          <a:noFill/>
+        </p:spPr>
+        <p:txBody>
+          <a:bodyPr wrap="square" lIns="36000" rIns="36000" tIns="18000" bIns="18000" anchor="ctr">
+            <a:spAutoFit/>
+          </a:bodyPr>
+          <a:lstStyle/>
+          <a:p>
+            <a:pPr algn="ctr"/>
+            <a:r>
+              <a:rPr sz="1100" b="0" i="0" u="none">
+                <a:solidFill>
+                  <a:srgbClr val="333333"/>
+                </a:solidFill>
+                <a:latin typeface="Calibri"/>
+              </a:rPr>
+              <a:t>221</a:t>
+            </a:r>
+          </a:p>
+        </p:txBody>
+      </p:sp>
+      <p:sp>
+        <p:nvSpPr>
+          <p:cNvPr id="69" name="TextBox 68"/>
+          <p:cNvSpPr txBox="1"/>
+          <p:nvPr/>
+        </p:nvSpPr>
+        <p:spPr>
+          <a:xfrm>
+            <a:off x="6995160" y="4599432"/>
+            <a:ext cx="1051560" cy="315468"/>
+          </a:xfrm>
+          <a:prstGeom prst="rect">
+            <a:avLst/>
+          </a:prstGeom>
+          <a:noFill/>
+        </p:spPr>
+        <p:txBody>
+          <a:bodyPr wrap="square" lIns="36000" rIns="36000" tIns="18000" bIns="18000" anchor="ctr">
+            <a:spAutoFit/>
+          </a:bodyPr>
+          <a:lstStyle/>
+          <a:p>
+            <a:pPr algn="ctr"/>
+            <a:r>
+              <a:rPr sz="1100" b="0" i="0" u="none">
+                <a:solidFill>
+                  <a:srgbClr val="333333"/>
+                </a:solidFill>
+                <a:latin typeface="Calibri"/>
+              </a:rPr>
+              <a:t>38</a:t>
+            </a:r>
+          </a:p>
+        </p:txBody>
+      </p:sp>
+      <p:sp>
+        <p:nvSpPr>
+          <p:cNvPr id="70" name="Rectangle 69"/>
+          <p:cNvSpPr/>
+          <p:nvPr/>
+        </p:nvSpPr>
+        <p:spPr>
+          <a:xfrm>
+            <a:off x="411480" y="4914900"/>
+            <a:ext cx="7635240" cy="315468"/>
+          </a:xfrm>
+          <a:prstGeom prst="rect">
+            <a:avLst/>
+          </a:prstGeom>
+          <a:solidFill>
+            <a:srgbClr val="FDE2C4"/>
+          </a:solidFill>
+          <a:ln>
+            <a:noFill/>
+          </a:ln>
+          <a:effectLst/>
+        </p:spPr>
+        <p:style>
+          <a:lnRef idx="1">
+            <a:schemeClr val="accent1"/>
+          </a:lnRef>
+          <a:fillRef idx="3">
+            <a:schemeClr val="accent1"/>
+          </a:fillRef>
+          <a:effectRef idx="2">
+            <a:schemeClr val="accent1"/>
+          </a:effectRef>
+          <a:fontRef idx="minor">
+            <a:schemeClr val="lt1"/>
+          </a:fontRef>
+        </p:style>
+        <p:txBody>
+          <a:bodyPr rtlCol="0" anchor="ctr"/>
+          <a:lstStyle/>
+          <a:p>
+            <a:pPr algn="ctr"/>
+          </a:p>
+        </p:txBody>
+      </p:sp>
+      <p:sp>
+        <p:nvSpPr>
+          <p:cNvPr id="71" name="Rectangle 70"/>
+          <p:cNvSpPr/>
+          <p:nvPr/>
+        </p:nvSpPr>
+        <p:spPr>
+          <a:xfrm>
+            <a:off x="411480" y="4914900"/>
+            <a:ext cx="91440" cy="315468"/>
+          </a:xfrm>
+          <a:prstGeom prst="rect">
+            <a:avLst/>
+          </a:prstGeom>
+          <a:solidFill>
+            <a:srgbClr val="C86E10"/>
+          </a:solidFill>
+          <a:ln>
+            <a:noFill/>
+          </a:ln>
+          <a:effectLst/>
+        </p:spPr>
+        <p:style>
+          <a:lnRef idx="1">
+            <a:schemeClr val="accent1"/>
+          </a:lnRef>
+          <a:fillRef idx="3">
+            <a:schemeClr val="accent1"/>
+          </a:fillRef>
+          <a:effectRef idx="2">
+            <a:schemeClr val="accent1"/>
+          </a:effectRef>
+          <a:fontRef idx="minor">
+            <a:schemeClr val="lt1"/>
+          </a:fontRef>
+        </p:style>
+        <p:txBody>
+          <a:bodyPr rtlCol="0" anchor="ctr"/>
+          <a:lstStyle/>
+          <a:p>
+            <a:pPr algn="ctr"/>
+          </a:p>
+        </p:txBody>
+      </p:sp>
+      <p:sp>
+        <p:nvSpPr>
+          <p:cNvPr id="72" name="TextBox 71"/>
+          <p:cNvSpPr txBox="1"/>
+          <p:nvPr/>
+        </p:nvSpPr>
+        <p:spPr>
+          <a:xfrm>
+            <a:off x="521208" y="4914900"/>
+            <a:ext cx="2679192" cy="315468"/>
+          </a:xfrm>
+          <a:prstGeom prst="rect">
+            <a:avLst/>
+          </a:prstGeom>
+          <a:noFill/>
+        </p:spPr>
+        <p:txBody>
+          <a:bodyPr wrap="square" lIns="36000" rIns="36000" tIns="18000" bIns="18000" anchor="ctr">
+            <a:spAutoFit/>
+          </a:bodyPr>
+          <a:lstStyle/>
+          <a:p>
+            <a:pPr algn="l"/>
+            <a:r>
+              <a:rPr sz="1100" b="1" i="1" u="none">
+                <a:solidFill>
+                  <a:srgbClr val="C86E10"/>
+                </a:solidFill>
+                <a:latin typeface="Calibri"/>
+              </a:rPr>
+              <a:t>   davon mit MV im Anhang*</a:t>
+            </a:r>
+          </a:p>
+        </p:txBody>
+      </p:sp>
+      <p:sp>
+        <p:nvSpPr>
+          <p:cNvPr id="73" name="TextBox 72"/>
+          <p:cNvSpPr txBox="1"/>
+          <p:nvPr/>
+        </p:nvSpPr>
+        <p:spPr>
+          <a:xfrm>
+            <a:off x="3200400" y="4914900"/>
+            <a:ext cx="1234440" cy="315468"/>
+          </a:xfrm>
+          <a:prstGeom prst="rect">
+            <a:avLst/>
+          </a:prstGeom>
+          <a:noFill/>
+        </p:spPr>
+        <p:txBody>
+          <a:bodyPr wrap="square" lIns="36000" rIns="36000" tIns="18000" bIns="18000" anchor="ctr">
+            <a:spAutoFit/>
+          </a:bodyPr>
+          <a:lstStyle/>
+          <a:p>
+            <a:pPr algn="ctr"/>
+            <a:r>
+              <a:rPr sz="1100" b="1" i="1" u="none">
+                <a:solidFill>
+                  <a:srgbClr val="C86E10"/>
+                </a:solidFill>
+                <a:latin typeface="Calibri"/>
+              </a:rPr>
+              <a:t>210</a:t>
+            </a:r>
+          </a:p>
+        </p:txBody>
+      </p:sp>
+      <p:sp>
+        <p:nvSpPr>
+          <p:cNvPr id="74" name="TextBox 73"/>
+          <p:cNvSpPr txBox="1"/>
+          <p:nvPr/>
+        </p:nvSpPr>
+        <p:spPr>
+          <a:xfrm>
+            <a:off x="4434840" y="4914900"/>
+            <a:ext cx="1188720" cy="315468"/>
+          </a:xfrm>
+          <a:prstGeom prst="rect">
+            <a:avLst/>
+          </a:prstGeom>
+          <a:noFill/>
+        </p:spPr>
+        <p:txBody>
+          <a:bodyPr wrap="square" lIns="36000" rIns="36000" tIns="18000" bIns="18000" anchor="ctr">
+            <a:spAutoFit/>
+          </a:bodyPr>
+          <a:lstStyle/>
+          <a:p>
+            <a:pPr algn="ctr"/>
+            <a:r>
+              <a:rPr sz="1100" b="1" i="1" u="none">
+                <a:solidFill>
+                  <a:srgbClr val="C86E10"/>
+                </a:solidFill>
+                <a:latin typeface="Calibri"/>
+              </a:rPr>
+              <a:t>40</a:t>
+            </a:r>
+          </a:p>
+        </p:txBody>
+      </p:sp>
+      <p:sp>
+        <p:nvSpPr>
+          <p:cNvPr id="75" name="TextBox 74"/>
+          <p:cNvSpPr txBox="1"/>
+          <p:nvPr/>
+        </p:nvSpPr>
+        <p:spPr>
+          <a:xfrm>
+            <a:off x="5623560" y="4914900"/>
+            <a:ext cx="1371600" cy="315468"/>
+          </a:xfrm>
+          <a:prstGeom prst="rect">
+            <a:avLst/>
+          </a:prstGeom>
+          <a:noFill/>
+        </p:spPr>
+        <p:txBody>
+          <a:bodyPr wrap="square" lIns="36000" rIns="36000" tIns="18000" bIns="18000" anchor="ctr">
+            <a:spAutoFit/>
+          </a:bodyPr>
+          <a:lstStyle/>
+          <a:p>
+            <a:pPr algn="ctr"/>
+            <a:r>
+              <a:rPr sz="1100" b="1" i="1" u="none">
+                <a:solidFill>
+                  <a:srgbClr val="C86E10"/>
+                </a:solidFill>
+                <a:latin typeface="Calibri"/>
+              </a:rPr>
+              <a:t>135</a:t>
+            </a:r>
+          </a:p>
+        </p:txBody>
+      </p:sp>
+      <p:sp>
+        <p:nvSpPr>
+          <p:cNvPr id="76" name="TextBox 75"/>
+          <p:cNvSpPr txBox="1"/>
+          <p:nvPr/>
+        </p:nvSpPr>
+        <p:spPr>
+          <a:xfrm>
+            <a:off x="6995160" y="4914900"/>
+            <a:ext cx="1051560" cy="315468"/>
+          </a:xfrm>
+          <a:prstGeom prst="rect">
+            <a:avLst/>
+          </a:prstGeom>
+          <a:noFill/>
+        </p:spPr>
+        <p:txBody>
+          <a:bodyPr wrap="square" lIns="36000" rIns="36000" tIns="18000" bIns="18000" anchor="ctr">
+            <a:spAutoFit/>
+          </a:bodyPr>
+          <a:lstStyle/>
+          <a:p>
+            <a:pPr algn="ctr"/>
+            <a:r>
+              <a:rPr sz="1100" b="1" i="1" u="none">
+                <a:solidFill>
+                  <a:srgbClr val="C86E10"/>
+                </a:solidFill>
+                <a:latin typeface="Calibri"/>
+              </a:rPr>
+              <a:t>29</a:t>
+            </a:r>
+          </a:p>
+        </p:txBody>
+      </p:sp>
+      <p:sp>
+        <p:nvSpPr>
+          <p:cNvPr id="77" name="TextBox 76"/>
+          <p:cNvSpPr txBox="1"/>
+          <p:nvPr/>
+        </p:nvSpPr>
+        <p:spPr>
+          <a:xfrm>
+            <a:off x="411480" y="5248656"/>
+            <a:ext cx="7635240" cy="256032"/>
+          </a:xfrm>
+          <a:prstGeom prst="rect">
+            <a:avLst/>
+          </a:prstGeom>
+          <a:noFill/>
+        </p:spPr>
+        <p:txBody>
+          <a:bodyPr wrap="square" lIns="36000" rIns="36000" tIns="18000" bIns="18000" anchor="t">
+            <a:spAutoFit/>
+          </a:bodyPr>
+          <a:lstStyle/>
+          <a:p>
+            <a:pPr algn="l"/>
+            <a:r>
+              <a:rPr sz="900" b="0" i="1" u="none">
+                <a:solidFill>
+                  <a:srgbClr val="666666"/>
+                </a:solidFill>
+                <a:latin typeface="Calibri"/>
+              </a:rPr>
+              <a:t>* MV im Anhang ohne neue BÜ = potentielles Falschrouting (Regel 'MV → BÜ-Vorgang'). Summe 240 Mails / Woche → Hebel 1 (Folie 11a).</a:t>
+            </a:r>
+          </a:p>
+        </p:txBody>
+      </p:sp>
+      <p:sp>
+        <p:nvSpPr>
+          <p:cNvPr id="78" name="Rectangle 77"/>
+          <p:cNvSpPr/>
+          <p:nvPr/>
+        </p:nvSpPr>
+        <p:spPr>
+          <a:xfrm>
+            <a:off x="411480" y="5541264"/>
+            <a:ext cx="3726180" cy="457200"/>
+          </a:xfrm>
+          <a:prstGeom prst="rect">
+            <a:avLst/>
+          </a:prstGeom>
+          <a:solidFill>
+            <a:srgbClr val="FDE2C4"/>
+          </a:solidFill>
+          <a:ln w="12700">
+            <a:solidFill>
+              <a:srgbClr val="C86E10"/>
+            </a:solidFill>
+          </a:ln>
+          <a:effectLst/>
+        </p:spPr>
+        <p:style>
+          <a:lnRef idx="1">
+            <a:schemeClr val="accent1"/>
+          </a:lnRef>
+          <a:fillRef idx="3">
+            <a:schemeClr val="accent1"/>
+          </a:fillRef>
+          <a:effectRef idx="2">
+            <a:schemeClr val="accent1"/>
+          </a:effectRef>
+          <a:fontRef idx="minor">
+            <a:schemeClr val="lt1"/>
+          </a:fontRef>
+        </p:style>
+        <p:txBody>
+          <a:bodyPr rtlCol="0" anchor="ctr"/>
+          <a:lstStyle/>
+          <a:p>
+            <a:pPr algn="ctr"/>
+          </a:p>
+        </p:txBody>
+      </p:sp>
+      <p:sp>
+        <p:nvSpPr>
+          <p:cNvPr id="79" name="TextBox 78"/>
+          <p:cNvSpPr txBox="1"/>
+          <p:nvPr/>
+        </p:nvSpPr>
+        <p:spPr>
+          <a:xfrm>
+            <a:off x="521208" y="5541264"/>
+            <a:ext cx="3543300" cy="457200"/>
+          </a:xfrm>
+          <a:prstGeom prst="rect">
+            <a:avLst/>
+          </a:prstGeom>
+          <a:noFill/>
+        </p:spPr>
+        <p:txBody>
+          <a:bodyPr wrap="square" lIns="36000" rIns="36000" tIns="18000" bIns="18000" anchor="ctr">
+            <a:spAutoFit/>
+          </a:bodyPr>
+          <a:lstStyle/>
+          <a:p>
+            <a:pPr algn="l"/>
+            <a:r>
+              <a:rPr sz="1100" b="1" i="0" u="none">
+                <a:solidFill>
+                  <a:srgbClr val="9C060F"/>
+                </a:solidFill>
+                <a:latin typeface="Calibri"/>
+              </a:rPr>
+              <a:t>HEBEL 1: Routing – 240 MV-Fehlrouter (11a)</a:t>
+            </a:r>
+          </a:p>
+        </p:txBody>
+      </p:sp>
+      <p:sp>
+        <p:nvSpPr>
+          <p:cNvPr id="80" name="Rectangle 79"/>
+          <p:cNvSpPr/>
+          <p:nvPr/>
+        </p:nvSpPr>
+        <p:spPr>
+          <a:xfrm>
+            <a:off x="4320540" y="5541264"/>
+            <a:ext cx="3726180" cy="457200"/>
+          </a:xfrm>
+          <a:prstGeom prst="rect">
+            <a:avLst/>
+          </a:prstGeom>
+          <a:solidFill>
+            <a:srgbClr val="CFE6E9"/>
+          </a:solidFill>
+          <a:ln w="12700">
+            <a:solidFill>
+              <a:srgbClr val="008793"/>
+            </a:solidFill>
+          </a:ln>
+          <a:effectLst/>
+        </p:spPr>
+        <p:style>
+          <a:lnRef idx="1">
+            <a:schemeClr val="accent1"/>
+          </a:lnRef>
+          <a:fillRef idx="3">
+            <a:schemeClr val="accent1"/>
+          </a:fillRef>
+          <a:effectRef idx="2">
+            <a:schemeClr val="accent1"/>
+          </a:effectRef>
+          <a:fontRef idx="minor">
+            <a:schemeClr val="lt1"/>
+          </a:fontRef>
+        </p:style>
+        <p:txBody>
+          <a:bodyPr rtlCol="0" anchor="ctr"/>
+          <a:lstStyle/>
+          <a:p>
+            <a:pPr algn="ctr"/>
+          </a:p>
+        </p:txBody>
+      </p:sp>
+      <p:sp>
+        <p:nvSpPr>
+          <p:cNvPr id="81" name="TextBox 80"/>
+          <p:cNvSpPr txBox="1"/>
+          <p:nvPr/>
+        </p:nvSpPr>
+        <p:spPr>
+          <a:xfrm>
+            <a:off x="4430268" y="5541264"/>
+            <a:ext cx="3543300" cy="457200"/>
+          </a:xfrm>
+          <a:prstGeom prst="rect">
+            <a:avLst/>
+          </a:prstGeom>
+          <a:noFill/>
+        </p:spPr>
+        <p:txBody>
+          <a:bodyPr wrap="square" lIns="36000" rIns="36000" tIns="18000" bIns="18000" anchor="ctr">
+            <a:spAutoFit/>
+          </a:bodyPr>
+          <a:lstStyle/>
+          <a:p>
+            <a:pPr algn="l"/>
+            <a:r>
+              <a:rPr sz="1100" b="1" i="0" u="none">
+                <a:solidFill>
+                  <a:srgbClr val="006B77"/>
+                </a:solidFill>
+                <a:latin typeface="Calibri"/>
+              </a:rPr>
+              <a:t>HEBEL 2: Clustering / Steuerung (11b)</a:t>
+            </a:r>
+          </a:p>
+        </p:txBody>
+      </p:sp>
+      <p:sp>
+        <p:nvSpPr>
+          <p:cNvPr id="82" name="Rectangle 81"/>
+          <p:cNvSpPr/>
+          <p:nvPr/>
+        </p:nvSpPr>
+        <p:spPr>
+          <a:xfrm>
+            <a:off x="8229600" y="2240280"/>
+            <a:ext cx="3611880" cy="3611880"/>
+          </a:xfrm>
+          <a:prstGeom prst="rect">
+            <a:avLst/>
+          </a:prstGeom>
+          <a:solidFill>
+            <a:srgbClr val="CFE6E9"/>
+          </a:solidFill>
+          <a:ln>
+            <a:noFill/>
+          </a:ln>
+          <a:effectLst/>
+        </p:spPr>
+        <p:style>
+          <a:lnRef idx="1">
+            <a:schemeClr val="accent1"/>
+          </a:lnRef>
+          <a:fillRef idx="3">
+            <a:schemeClr val="accent1"/>
+          </a:fillRef>
+          <a:effectRef idx="2">
+            <a:schemeClr val="accent1"/>
+          </a:effectRef>
+          <a:fontRef idx="minor">
+            <a:schemeClr val="lt1"/>
+          </a:fontRef>
+        </p:style>
+        <p:txBody>
+          <a:bodyPr rtlCol="0" anchor="ctr"/>
+          <a:lstStyle/>
+          <a:p>
+            <a:pPr algn="ctr"/>
+          </a:p>
+        </p:txBody>
+      </p:sp>
+      <p:sp>
+        <p:nvSpPr>
+          <p:cNvPr id="83" name="Oval 82"/>
+          <p:cNvSpPr/>
+          <p:nvPr/>
+        </p:nvSpPr>
+        <p:spPr>
+          <a:xfrm>
+            <a:off x="8366760" y="2450592"/>
+            <a:ext cx="384048" cy="384048"/>
+          </a:xfrm>
+          <a:prstGeom prst="ellipse">
             <a:avLst/>
           </a:prstGeom>
           <a:solidFill>
@@ -4850,57 +6217,92 @@
       </p:sp>
       <p:sp>
         <p:nvSpPr>
-          <p:cNvPr id="47" name="Rectangle 46"/>
+          <p:cNvPr id="84" name="TextBox 83"/>
+          <p:cNvSpPr txBox="1"/>
+          <p:nvPr/>
+        </p:nvSpPr>
+        <p:spPr>
+          <a:xfrm>
+            <a:off x="8366760" y="2450592"/>
+            <a:ext cx="384048" cy="384048"/>
+          </a:xfrm>
+          <a:prstGeom prst="rect">
+            <a:avLst/>
+          </a:prstGeom>
+          <a:noFill/>
+        </p:spPr>
+        <p:txBody>
+          <a:bodyPr wrap="square" lIns="36000" rIns="36000" tIns="18000" bIns="18000" anchor="ctr">
+            <a:spAutoFit/>
+          </a:bodyPr>
+          <a:lstStyle/>
+          <a:p>
+            <a:pPr algn="ctr"/>
+            <a:r>
+              <a:rPr sz="1500" b="1" i="0" u="none">
+                <a:solidFill>
+                  <a:srgbClr val="FFFFFF"/>
+                </a:solidFill>
+                <a:latin typeface="Calibri"/>
+              </a:rPr>
+              <a:t>1</a:t>
+            </a:r>
+          </a:p>
+        </p:txBody>
+      </p:sp>
+      <p:sp>
+        <p:nvSpPr>
+          <p:cNvPr id="85" name="TextBox 84"/>
+          <p:cNvSpPr txBox="1"/>
+          <p:nvPr/>
+        </p:nvSpPr>
+        <p:spPr>
+          <a:xfrm>
+            <a:off x="8869680" y="2404872"/>
+            <a:ext cx="2834640" cy="656539"/>
+          </a:xfrm>
+          <a:prstGeom prst="rect">
+            <a:avLst/>
+          </a:prstGeom>
+          <a:noFill/>
+        </p:spPr>
+        <p:txBody>
+          <a:bodyPr wrap="square" lIns="36000" rIns="36000" tIns="0" bIns="0">
+            <a:spAutoFit/>
+          </a:bodyPr>
+          <a:lstStyle/>
+          <a:p>
+            <a:pPr algn="l"/>
+            <a:r>
+              <a:rPr sz="1100" b="1">
+                <a:solidFill>
+                  <a:srgbClr val="333333"/>
+                </a:solidFill>
+                <a:latin typeface="Calibri"/>
+              </a:rPr>
+              <a:t>Mengengeruest 1 Woche: </a:t>
+            </a:r>
+            <a:r>
+              <a:rPr sz="1100">
+                <a:solidFill>
+                  <a:srgbClr val="333333"/>
+                </a:solidFill>
+                <a:latin typeface="Calibri"/>
+              </a:rPr>
+              <a:t>5.034 Mails, Vollerhebung 13.–20.04.2026; 94 % ueber ein Sammel-Postfach. Hochrechnung ~260.000 / Jahr.</a:t>
+            </a:r>
+          </a:p>
+        </p:txBody>
+      </p:sp>
+      <p:sp>
+        <p:nvSpPr>
+          <p:cNvPr id="86" name="Oval 85"/>
           <p:cNvSpPr/>
           <p:nvPr/>
         </p:nvSpPr>
         <p:spPr>
           <a:xfrm>
-            <a:off x="8229600" y="2240280"/>
-            <a:ext cx="3611880" cy="3611880"/>
-          </a:xfrm>
-          <a:prstGeom prst="rect">
-            <a:avLst/>
-          </a:prstGeom>
-          <a:solidFill>
-            <a:srgbClr val="CFE6E9"/>
-          </a:solidFill>
-          <a:ln>
-            <a:noFill/>
-          </a:ln>
-          <a:effectLst/>
-        </p:spPr>
-        <p:style>
-          <a:lnRef idx="1">
-            <a:schemeClr val="accent1"/>
-          </a:lnRef>
-          <a:fillRef idx="3">
-            <a:schemeClr val="accent1"/>
-          </a:fillRef>
-          <a:effectRef idx="2">
-            <a:schemeClr val="accent1"/>
-          </a:effectRef>
-          <a:fontRef idx="minor">
-            <a:schemeClr val="lt1"/>
-          </a:fontRef>
-        </p:style>
-        <p:txBody>
-          <a:bodyPr rtlCol="0" anchor="ctr"/>
-          <a:lstStyle/>
-          <a:p>
-            <a:pPr algn="ctr"/>
-          </a:p>
-        </p:txBody>
-      </p:sp>
-      <p:sp>
-        <p:nvSpPr>
-          <p:cNvPr id="48" name="Oval 47"/>
-          <p:cNvSpPr/>
-          <p:nvPr/>
-        </p:nvSpPr>
-        <p:spPr>
-          <a:xfrm>
-            <a:off x="8366760" y="2450592"/>
+            <a:off x="8366760" y="3107131"/>
             <a:ext cx="384048" cy="384048"/>
           </a:xfrm>
           <a:prstGeom prst="ellipse">
@@ -4938,13 +6340,13 @@
       </p:sp>
       <p:sp>
         <p:nvSpPr>
-          <p:cNvPr id="49" name="TextBox 48"/>
-          <p:cNvSpPr txBox="1"/>
-          <p:nvPr/>
-        </p:nvSpPr>
-        <p:spPr>
-          <a:xfrm>
-            <a:off x="8366760" y="2450592"/>
+          <p:cNvPr id="87" name="TextBox 86"/>
+          <p:cNvSpPr txBox="1"/>
+          <p:nvPr/>
+        </p:nvSpPr>
+        <p:spPr>
+          <a:xfrm>
+            <a:off x="8366760" y="3107131"/>
             <a:ext cx="384048" cy="384048"/>
           </a:xfrm>
           <a:prstGeom prst="rect">
@@ -4966,20 +6368,20 @@
                 </a:solidFill>
                 <a:latin typeface="Calibri"/>
               </a:rPr>
-              <a:t>1</a:t>
-            </a:r>
-          </a:p>
-        </p:txBody>
-      </p:sp>
-      <p:sp>
-        <p:nvSpPr>
-          <p:cNvPr id="50" name="TextBox 49"/>
-          <p:cNvSpPr txBox="1"/>
-          <p:nvPr/>
-        </p:nvSpPr>
-        <p:spPr>
-          <a:xfrm>
-            <a:off x="8869680" y="2404872"/>
+              <a:t>2</a:t>
+            </a:r>
+          </a:p>
+        </p:txBody>
+      </p:sp>
+      <p:sp>
+        <p:nvSpPr>
+          <p:cNvPr id="88" name="TextBox 87"/>
+          <p:cNvSpPr txBox="1"/>
+          <p:nvPr/>
+        </p:nvSpPr>
+        <p:spPr>
+          <a:xfrm>
+            <a:off x="8869680" y="3061411"/>
             <a:ext cx="2834640" cy="656539"/>
           </a:xfrm>
           <a:prstGeom prst="rect">
@@ -5001,7 +6403,7 @@
                 </a:solidFill>
                 <a:latin typeface="Calibri"/>
               </a:rPr>
-              <a:t>Mengengeruest 1 Woche: </a:t>
+              <a:t>Strukturierte Extraktion: </a:t>
             </a:r>
             <a:r>
               <a:rPr sz="1100">
@@ -5010,20 +6412,20 @@
                 </a:solidFill>
                 <a:latin typeface="Calibri"/>
               </a:rPr>
-              <a:t>5.034 Mails, Vollerhebung 13.–20.04.2026; 94 % ueber ein Sammel-Postfach. Hochrechnung ~260.000 / Jahr.</a:t>
-            </a:r>
-          </a:p>
-        </p:txBody>
-      </p:sp>
-      <p:sp>
-        <p:nvSpPr>
-          <p:cNvPr id="51" name="Oval 50"/>
+              <a:t>KI erstellt je Mail ein Beiblatt mit 50 Feldern – VNR, Sparte, Pool, Status, Vorgangs-Cluster immer gleich.</a:t>
+            </a:r>
+          </a:p>
+        </p:txBody>
+      </p:sp>
+      <p:sp>
+        <p:nvSpPr>
+          <p:cNvPr id="89" name="Oval 88"/>
           <p:cNvSpPr/>
           <p:nvPr/>
         </p:nvSpPr>
         <p:spPr>
           <a:xfrm>
-            <a:off x="8366760" y="3107131"/>
+            <a:off x="8366760" y="3763670"/>
             <a:ext cx="384048" cy="384048"/>
           </a:xfrm>
           <a:prstGeom prst="ellipse">
@@ -5061,13 +6463,13 @@
       </p:sp>
       <p:sp>
         <p:nvSpPr>
-          <p:cNvPr id="52" name="TextBox 51"/>
-          <p:cNvSpPr txBox="1"/>
-          <p:nvPr/>
-        </p:nvSpPr>
-        <p:spPr>
-          <a:xfrm>
-            <a:off x="8366760" y="3107131"/>
+          <p:cNvPr id="90" name="TextBox 89"/>
+          <p:cNvSpPr txBox="1"/>
+          <p:nvPr/>
+        </p:nvSpPr>
+        <p:spPr>
+          <a:xfrm>
+            <a:off x="8366760" y="3763670"/>
             <a:ext cx="384048" cy="384048"/>
           </a:xfrm>
           <a:prstGeom prst="rect">
@@ -5089,20 +6491,20 @@
                 </a:solidFill>
                 <a:latin typeface="Calibri"/>
               </a:rPr>
-              <a:t>2</a:t>
-            </a:r>
-          </a:p>
-        </p:txBody>
-      </p:sp>
-      <p:sp>
-        <p:nvSpPr>
-          <p:cNvPr id="53" name="TextBox 52"/>
-          <p:cNvSpPr txBox="1"/>
-          <p:nvPr/>
-        </p:nvSpPr>
-        <p:spPr>
-          <a:xfrm>
-            <a:off x="8869680" y="3061411"/>
+              <a:t>3</a:t>
+            </a:r>
+          </a:p>
+        </p:txBody>
+      </p:sp>
+      <p:sp>
+        <p:nvSpPr>
+          <p:cNvPr id="91" name="TextBox 90"/>
+          <p:cNvSpPr txBox="1"/>
+          <p:nvPr/>
+        </p:nvSpPr>
+        <p:spPr>
+          <a:xfrm>
+            <a:off x="8869680" y="3717950"/>
             <a:ext cx="2834640" cy="656539"/>
           </a:xfrm>
           <a:prstGeom prst="rect">
@@ -5124,7 +6526,7 @@
                 </a:solidFill>
                 <a:latin typeface="Calibri"/>
               </a:rPr>
-              <a:t>Strukturierte Extraktion: </a:t>
+              <a:t>Ableitung Hebel 1: </a:t>
             </a:r>
             <a:r>
               <a:rPr sz="1100">
@@ -5133,20 +6535,20 @@
                 </a:solidFill>
                 <a:latin typeface="Calibri"/>
               </a:rPr>
-              <a:t>KI erstellt je Mail ein Beiblatt mit 50 Feldern – VNR, Sparte, Pool, Status, Vorgangs-Cluster immer gleich.</a:t>
-            </a:r>
-          </a:p>
-        </p:txBody>
-      </p:sp>
-      <p:sp>
-        <p:nvSpPr>
-          <p:cNvPr id="54" name="Oval 53"/>
+              <a:t>1.034 Mails sind keine neue BÜ; 240 haengen eine MV an und werden durch die Regel 'MV → BÜ' falsch angelegt.</a:t>
+            </a:r>
+          </a:p>
+        </p:txBody>
+      </p:sp>
+      <p:sp>
+        <p:nvSpPr>
+          <p:cNvPr id="92" name="Oval 91"/>
           <p:cNvSpPr/>
           <p:nvPr/>
         </p:nvSpPr>
         <p:spPr>
           <a:xfrm>
-            <a:off x="8366760" y="3763670"/>
+            <a:off x="8366760" y="4420209"/>
             <a:ext cx="384048" cy="384048"/>
           </a:xfrm>
           <a:prstGeom prst="ellipse">
@@ -5184,13 +6586,13 @@
       </p:sp>
       <p:sp>
         <p:nvSpPr>
-          <p:cNvPr id="55" name="TextBox 54"/>
-          <p:cNvSpPr txBox="1"/>
-          <p:nvPr/>
-        </p:nvSpPr>
-        <p:spPr>
-          <a:xfrm>
-            <a:off x="8366760" y="3763670"/>
+          <p:cNvPr id="93" name="TextBox 92"/>
+          <p:cNvSpPr txBox="1"/>
+          <p:nvPr/>
+        </p:nvSpPr>
+        <p:spPr>
+          <a:xfrm>
+            <a:off x="8366760" y="4420209"/>
             <a:ext cx="384048" cy="384048"/>
           </a:xfrm>
           <a:prstGeom prst="rect">
@@ -5212,20 +6614,20 @@
                 </a:solidFill>
                 <a:latin typeface="Calibri"/>
               </a:rPr>
-              <a:t>3</a:t>
-            </a:r>
-          </a:p>
-        </p:txBody>
-      </p:sp>
-      <p:sp>
-        <p:nvSpPr>
-          <p:cNvPr id="56" name="TextBox 55"/>
-          <p:cNvSpPr txBox="1"/>
-          <p:nvPr/>
-        </p:nvSpPr>
-        <p:spPr>
-          <a:xfrm>
-            <a:off x="8869680" y="3717950"/>
+              <a:t>4</a:t>
+            </a:r>
+          </a:p>
+        </p:txBody>
+      </p:sp>
+      <p:sp>
+        <p:nvSpPr>
+          <p:cNvPr id="94" name="TextBox 93"/>
+          <p:cNvSpPr txBox="1"/>
+          <p:nvPr/>
+        </p:nvSpPr>
+        <p:spPr>
+          <a:xfrm>
+            <a:off x="8869680" y="4374489"/>
             <a:ext cx="2834640" cy="656539"/>
           </a:xfrm>
           <a:prstGeom prst="rect">
@@ -5247,7 +6649,7 @@
                 </a:solidFill>
                 <a:latin typeface="Calibri"/>
               </a:rPr>
-              <a:t>Ableitung Hebel 1: </a:t>
+              <a:t>Ableitung Hebel 2: </a:t>
             </a:r>
             <a:r>
               <a:rPr sz="1100">
@@ -5256,20 +6658,20 @@
                 </a:solidFill>
                 <a:latin typeface="Calibri"/>
               </a:rPr>
-              <a:t>1.034 Mails sind keine neue BÜ; 240 haengen eine MV an und werden durch die Regel 'MV → BÜ' falsch angelegt.</a:t>
-            </a:r>
-          </a:p>
-        </p:txBody>
-      </p:sp>
-      <p:sp>
-        <p:nvSpPr>
-          <p:cNvPr id="57" name="Oval 56"/>
+              <a:t>4.000 BÜ-Mails verteilen sich auf nur 2.495 Vorgaenge → Buendelung / Steuerung moeglich.</a:t>
+            </a:r>
+          </a:p>
+        </p:txBody>
+      </p:sp>
+      <p:sp>
+        <p:nvSpPr>
+          <p:cNvPr id="95" name="Oval 94"/>
           <p:cNvSpPr/>
           <p:nvPr/>
         </p:nvSpPr>
         <p:spPr>
           <a:xfrm>
-            <a:off x="8366760" y="4420209"/>
+            <a:off x="8366760" y="5076748"/>
             <a:ext cx="384048" cy="384048"/>
           </a:xfrm>
           <a:prstGeom prst="ellipse">
@@ -5307,87 +6709,8 @@
       </p:sp>
       <p:sp>
         <p:nvSpPr>
-          <p:cNvPr id="58" name="TextBox 57"/>
-          <p:cNvSpPr txBox="1"/>
-          <p:nvPr/>
-        </p:nvSpPr>
-        <p:spPr>
-          <a:xfrm>
-            <a:off x="8366760" y="4420209"/>
-            <a:ext cx="384048" cy="384048"/>
-          </a:xfrm>
-          <a:prstGeom prst="rect">
-            <a:avLst/>
-          </a:prstGeom>
-          <a:noFill/>
-        </p:spPr>
-        <p:txBody>
-          <a:bodyPr wrap="square" lIns="36000" rIns="36000" tIns="18000" bIns="18000" anchor="ctr">
-            <a:spAutoFit/>
-          </a:bodyPr>
-          <a:lstStyle/>
-          <a:p>
-            <a:pPr algn="ctr"/>
-            <a:r>
-              <a:rPr sz="1500" b="1" i="0" u="none">
-                <a:solidFill>
-                  <a:srgbClr val="FFFFFF"/>
-                </a:solidFill>
-                <a:latin typeface="Calibri"/>
-              </a:rPr>
-              <a:t>4</a:t>
-            </a:r>
-          </a:p>
-        </p:txBody>
-      </p:sp>
-      <p:sp>
-        <p:nvSpPr>
-          <p:cNvPr id="59" name="TextBox 58"/>
-          <p:cNvSpPr txBox="1"/>
-          <p:nvPr/>
-        </p:nvSpPr>
-        <p:spPr>
-          <a:xfrm>
-            <a:off x="8869680" y="4374489"/>
-            <a:ext cx="2834640" cy="656539"/>
-          </a:xfrm>
-          <a:prstGeom prst="rect">
-            <a:avLst/>
-          </a:prstGeom>
-          <a:noFill/>
-        </p:spPr>
-        <p:txBody>
-          <a:bodyPr wrap="square" lIns="36000" rIns="36000" tIns="0" bIns="0">
-            <a:spAutoFit/>
-          </a:bodyPr>
-          <a:lstStyle/>
-          <a:p>
-            <a:pPr algn="l"/>
-            <a:r>
-              <a:rPr sz="1100" b="1">
-                <a:solidFill>
-                  <a:srgbClr val="333333"/>
-                </a:solidFill>
-                <a:latin typeface="Calibri"/>
-              </a:rPr>
-              <a:t>Ableitung Hebel 2: </a:t>
-            </a:r>
-            <a:r>
-              <a:rPr sz="1100">
-                <a:solidFill>
-                  <a:srgbClr val="333333"/>
-                </a:solidFill>
-                <a:latin typeface="Calibri"/>
-              </a:rPr>
-              <a:t>4.000 BÜ-Mails verteilen sich auf nur 2.495 Vorgaenge → Buendelung / Steuerung moeglich.</a:t>
-            </a:r>
-          </a:p>
-        </p:txBody>
-      </p:sp>
-      <p:sp>
-        <p:nvSpPr>
-          <p:cNvPr id="60" name="Oval 59"/>
-          <p:cNvSpPr/>
+          <p:cNvPr id="96" name="TextBox 95"/>
+          <p:cNvSpPr txBox="1"/>
           <p:nvPr/>
         </p:nvSpPr>
         <p:spPr>
@@ -5395,50 +6718,6 @@
             <a:off x="8366760" y="5076748"/>
             <a:ext cx="384048" cy="384048"/>
           </a:xfrm>
-          <a:prstGeom prst="ellipse">
-            <a:avLst/>
-          </a:prstGeom>
-          <a:solidFill>
-            <a:srgbClr val="008793"/>
-          </a:solidFill>
-          <a:ln>
-            <a:noFill/>
-          </a:ln>
-          <a:effectLst/>
-        </p:spPr>
-        <p:style>
-          <a:lnRef idx="1">
-            <a:schemeClr val="accent1"/>
-          </a:lnRef>
-          <a:fillRef idx="3">
-            <a:schemeClr val="accent1"/>
-          </a:fillRef>
-          <a:effectRef idx="2">
-            <a:schemeClr val="accent1"/>
-          </a:effectRef>
-          <a:fontRef idx="minor">
-            <a:schemeClr val="lt1"/>
-          </a:fontRef>
-        </p:style>
-        <p:txBody>
-          <a:bodyPr rtlCol="0" anchor="ctr"/>
-          <a:lstStyle/>
-          <a:p>
-            <a:pPr algn="ctr"/>
-          </a:p>
-        </p:txBody>
-      </p:sp>
-      <p:sp>
-        <p:nvSpPr>
-          <p:cNvPr id="61" name="TextBox 60"/>
-          <p:cNvSpPr txBox="1"/>
-          <p:nvPr/>
-        </p:nvSpPr>
-        <p:spPr>
-          <a:xfrm>
-            <a:off x="8366760" y="5076748"/>
-            <a:ext cx="384048" cy="384048"/>
-          </a:xfrm>
           <a:prstGeom prst="rect">
             <a:avLst/>
           </a:prstGeom>
@@ -5465,7 +6744,7 @@
       </p:sp>
       <p:sp>
         <p:nvSpPr>
-          <p:cNvPr id="62" name="TextBox 61"/>
+          <p:cNvPr id="97" name="TextBox 96"/>
           <p:cNvSpPr txBox="1"/>
           <p:nvPr/>
         </p:nvSpPr>
@@ -5509,7 +6788,7 @@
       </p:sp>
       <p:sp>
         <p:nvSpPr>
-          <p:cNvPr id="63" name="TextBox 62"/>
+          <p:cNvPr id="98" name="TextBox 97"/>
           <p:cNvSpPr txBox="1"/>
           <p:nvPr/>
         </p:nvSpPr>
@@ -5544,7 +6823,7 @@
       </p:sp>
       <p:sp>
         <p:nvSpPr>
-          <p:cNvPr id="64" name="Rectangle 63"/>
+          <p:cNvPr id="99" name="Rectangle 98"/>
           <p:cNvSpPr/>
           <p:nvPr/>
         </p:nvSpPr>
@@ -5588,7 +6867,7 @@
       </p:sp>
       <p:sp>
         <p:nvSpPr>
-          <p:cNvPr id="65" name="TextBox 64"/>
+          <p:cNvPr id="100" name="TextBox 99"/>
           <p:cNvSpPr txBox="1"/>
           <p:nvPr/>
         </p:nvSpPr>

</xml_diff>

<commit_message>
PPTX 11b: Gesamt-Zeile ergaenzt + Mehr/Unbek korrigiert
- Neue Kopfzeile 'Gesamt': 4.000 BÜ-Mails, 2.008 in Mehrfach-Vorgang (50 %)
- Mehr/Unbek korrigiert: 102 BÜ-Mails / 15 in Mehrfach (15 %)
  (vorher faelschlich 239 / 26)
- Zeilenhoehe leicht reduziert fuer 5 Zeilen

https://claude.ai/code/session_01UknXtYp2XECsQDonCZuxSt
</commit_message>
<xml_diff>
--- a/ERGO-Mengengeruest-2Slides-Berichtslook.pptx
+++ b/ERGO-Mengengeruest-2Slides-Berichtslook.pptx
@@ -10806,7 +10806,226 @@
         <p:spPr>
           <a:xfrm>
             <a:off x="411480" y="2990088"/>
-            <a:ext cx="7635240" cy="457200"/>
+            <a:ext cx="7635240" cy="402336"/>
+          </a:xfrm>
+          <a:prstGeom prst="rect">
+            <a:avLst/>
+          </a:prstGeom>
+          <a:solidFill>
+            <a:srgbClr val="E9EFF1"/>
+          </a:solidFill>
+          <a:ln>
+            <a:noFill/>
+          </a:ln>
+          <a:effectLst/>
+        </p:spPr>
+        <p:style>
+          <a:lnRef idx="1">
+            <a:schemeClr val="accent1"/>
+          </a:lnRef>
+          <a:fillRef idx="3">
+            <a:schemeClr val="accent1"/>
+          </a:fillRef>
+          <a:effectRef idx="2">
+            <a:schemeClr val="accent1"/>
+          </a:effectRef>
+          <a:fontRef idx="minor">
+            <a:schemeClr val="lt1"/>
+          </a:fontRef>
+        </p:style>
+        <p:txBody>
+          <a:bodyPr rtlCol="0" anchor="ctr"/>
+          <a:lstStyle/>
+          <a:p>
+            <a:pPr algn="ctr"/>
+          </a:p>
+        </p:txBody>
+      </p:sp>
+      <p:sp>
+        <p:nvSpPr>
+          <p:cNvPr id="25" name="TextBox 24"/>
+          <p:cNvSpPr txBox="1"/>
+          <p:nvPr/>
+        </p:nvSpPr>
+        <p:spPr>
+          <a:xfrm>
+            <a:off x="521208" y="2990088"/>
+            <a:ext cx="1307592" cy="402336"/>
+          </a:xfrm>
+          <a:prstGeom prst="rect">
+            <a:avLst/>
+          </a:prstGeom>
+          <a:noFill/>
+        </p:spPr>
+        <p:txBody>
+          <a:bodyPr wrap="square" lIns="36000" rIns="36000" tIns="18000" bIns="18000" anchor="ctr">
+            <a:spAutoFit/>
+          </a:bodyPr>
+          <a:lstStyle/>
+          <a:p>
+            <a:pPr algn="l"/>
+            <a:r>
+              <a:rPr sz="1100" b="1" i="0" u="none">
+                <a:solidFill>
+                  <a:srgbClr val="333333"/>
+                </a:solidFill>
+                <a:latin typeface="Calibri"/>
+              </a:rPr>
+              <a:t>Gesamt</a:t>
+            </a:r>
+          </a:p>
+        </p:txBody>
+      </p:sp>
+      <p:sp>
+        <p:nvSpPr>
+          <p:cNvPr id="26" name="TextBox 25"/>
+          <p:cNvSpPr txBox="1"/>
+          <p:nvPr/>
+        </p:nvSpPr>
+        <p:spPr>
+          <a:xfrm>
+            <a:off x="1828800" y="2990088"/>
+            <a:ext cx="1143000" cy="402336"/>
+          </a:xfrm>
+          <a:prstGeom prst="rect">
+            <a:avLst/>
+          </a:prstGeom>
+          <a:noFill/>
+        </p:spPr>
+        <p:txBody>
+          <a:bodyPr wrap="square" lIns="36000" rIns="36000" tIns="18000" bIns="18000" anchor="ctr">
+            <a:spAutoFit/>
+          </a:bodyPr>
+          <a:lstStyle/>
+          <a:p>
+            <a:pPr algn="ctr"/>
+            <a:r>
+              <a:rPr sz="1100" b="1" i="0" u="none">
+                <a:solidFill>
+                  <a:srgbClr val="333333"/>
+                </a:solidFill>
+                <a:latin typeface="Calibri"/>
+              </a:rPr>
+              <a:t>4.000</a:t>
+            </a:r>
+          </a:p>
+        </p:txBody>
+      </p:sp>
+      <p:sp>
+        <p:nvSpPr>
+          <p:cNvPr id="27" name="TextBox 26"/>
+          <p:cNvSpPr txBox="1"/>
+          <p:nvPr/>
+        </p:nvSpPr>
+        <p:spPr>
+          <a:xfrm>
+            <a:off x="2971800" y="2990088"/>
+            <a:ext cx="1874519" cy="402336"/>
+          </a:xfrm>
+          <a:prstGeom prst="rect">
+            <a:avLst/>
+          </a:prstGeom>
+          <a:noFill/>
+        </p:spPr>
+        <p:txBody>
+          <a:bodyPr wrap="square" lIns="36000" rIns="36000" tIns="18000" bIns="18000" anchor="ctr">
+            <a:spAutoFit/>
+          </a:bodyPr>
+          <a:lstStyle/>
+          <a:p>
+            <a:pPr algn="ctr"/>
+            <a:r>
+              <a:rPr sz="1100" b="1" i="0" u="none">
+                <a:solidFill>
+                  <a:srgbClr val="333333"/>
+                </a:solidFill>
+                <a:latin typeface="Calibri"/>
+              </a:rPr>
+              <a:t>2.008 Mails (50 %)</a:t>
+            </a:r>
+          </a:p>
+        </p:txBody>
+      </p:sp>
+      <p:sp>
+        <p:nvSpPr>
+          <p:cNvPr id="28" name="TextBox 27"/>
+          <p:cNvSpPr txBox="1"/>
+          <p:nvPr/>
+        </p:nvSpPr>
+        <p:spPr>
+          <a:xfrm>
+            <a:off x="4846319" y="2990088"/>
+            <a:ext cx="1783080" cy="402336"/>
+          </a:xfrm>
+          <a:prstGeom prst="rect">
+            <a:avLst/>
+          </a:prstGeom>
+          <a:noFill/>
+        </p:spPr>
+        <p:txBody>
+          <a:bodyPr wrap="square" lIns="36000" rIns="36000" tIns="18000" bIns="18000" anchor="ctr">
+            <a:spAutoFit/>
+          </a:bodyPr>
+          <a:lstStyle/>
+          <a:p>
+            <a:pPr algn="ctr"/>
+            <a:r>
+              <a:rPr sz="1100" b="1" i="0" u="none">
+                <a:solidFill>
+                  <a:srgbClr val="333333"/>
+                </a:solidFill>
+                <a:latin typeface="Calibri"/>
+              </a:rPr>
+              <a:t>teils gemappt</a:t>
+            </a:r>
+          </a:p>
+        </p:txBody>
+      </p:sp>
+      <p:sp>
+        <p:nvSpPr>
+          <p:cNvPr id="29" name="TextBox 28"/>
+          <p:cNvSpPr txBox="1"/>
+          <p:nvPr/>
+        </p:nvSpPr>
+        <p:spPr>
+          <a:xfrm>
+            <a:off x="6629399" y="2990088"/>
+            <a:ext cx="1417320" cy="402336"/>
+          </a:xfrm>
+          <a:prstGeom prst="rect">
+            <a:avLst/>
+          </a:prstGeom>
+          <a:noFill/>
+        </p:spPr>
+        <p:txBody>
+          <a:bodyPr wrap="square" lIns="36000" rIns="36000" tIns="18000" bIns="18000" anchor="ctr">
+            <a:spAutoFit/>
+          </a:bodyPr>
+          <a:lstStyle/>
+          <a:p>
+            <a:pPr algn="ctr"/>
+            <a:r>
+              <a:rPr sz="1100" b="1" i="0" u="none">
+                <a:solidFill>
+                  <a:srgbClr val="333333"/>
+                </a:solidFill>
+                <a:latin typeface="Calibri"/>
+              </a:rPr>
+              <a:t>—</a:t>
+            </a:r>
+          </a:p>
+        </p:txBody>
+      </p:sp>
+      <p:sp>
+        <p:nvSpPr>
+          <p:cNvPr id="30" name="Rectangle 29"/>
+          <p:cNvSpPr/>
+          <p:nvPr/>
+        </p:nvSpPr>
+        <p:spPr>
+          <a:xfrm>
+            <a:off x="411480" y="3392424"/>
+            <a:ext cx="7635240" cy="402336"/>
           </a:xfrm>
           <a:prstGeom prst="rect">
             <a:avLst/>
@@ -10843,14 +11062,14 @@
       </p:sp>
       <p:sp>
         <p:nvSpPr>
-          <p:cNvPr id="25" name="Rectangle 24"/>
+          <p:cNvPr id="31" name="Rectangle 30"/>
           <p:cNvSpPr/>
           <p:nvPr/>
         </p:nvSpPr>
         <p:spPr>
           <a:xfrm>
-            <a:off x="411480" y="2990088"/>
-            <a:ext cx="109728" cy="457200"/>
+            <a:off x="411480" y="3392424"/>
+            <a:ext cx="109728" cy="402336"/>
           </a:xfrm>
           <a:prstGeom prst="rect">
             <a:avLst/>
@@ -10887,14 +11106,14 @@
       </p:sp>
       <p:sp>
         <p:nvSpPr>
-          <p:cNvPr id="26" name="TextBox 25"/>
-          <p:cNvSpPr txBox="1"/>
-          <p:nvPr/>
-        </p:nvSpPr>
-        <p:spPr>
-          <a:xfrm>
-            <a:off x="521208" y="2990088"/>
-            <a:ext cx="1307592" cy="457200"/>
+          <p:cNvPr id="32" name="TextBox 31"/>
+          <p:cNvSpPr txBox="1"/>
+          <p:nvPr/>
+        </p:nvSpPr>
+        <p:spPr>
+          <a:xfrm>
+            <a:off x="521208" y="3392424"/>
+            <a:ext cx="1307592" cy="402336"/>
           </a:xfrm>
           <a:prstGeom prst="rect">
             <a:avLst/>
@@ -10922,14 +11141,14 @@
       </p:sp>
       <p:sp>
         <p:nvSpPr>
-          <p:cNvPr id="27" name="TextBox 26"/>
-          <p:cNvSpPr txBox="1"/>
-          <p:nvPr/>
-        </p:nvSpPr>
-        <p:spPr>
-          <a:xfrm>
-            <a:off x="1828800" y="2990088"/>
-            <a:ext cx="1143000" cy="457200"/>
+          <p:cNvPr id="33" name="TextBox 32"/>
+          <p:cNvSpPr txBox="1"/>
+          <p:nvPr/>
+        </p:nvSpPr>
+        <p:spPr>
+          <a:xfrm>
+            <a:off x="1828800" y="3392424"/>
+            <a:ext cx="1143000" cy="402336"/>
           </a:xfrm>
           <a:prstGeom prst="rect">
             <a:avLst/>
@@ -10957,14 +11176,14 @@
       </p:sp>
       <p:sp>
         <p:nvSpPr>
-          <p:cNvPr id="28" name="TextBox 27"/>
-          <p:cNvSpPr txBox="1"/>
-          <p:nvPr/>
-        </p:nvSpPr>
-        <p:spPr>
-          <a:xfrm>
-            <a:off x="2971800" y="2990088"/>
-            <a:ext cx="1874519" cy="457200"/>
+          <p:cNvPr id="34" name="TextBox 33"/>
+          <p:cNvSpPr txBox="1"/>
+          <p:nvPr/>
+        </p:nvSpPr>
+        <p:spPr>
+          <a:xfrm>
+            <a:off x="2971800" y="3392424"/>
+            <a:ext cx="1874519" cy="402336"/>
           </a:xfrm>
           <a:prstGeom prst="rect">
             <a:avLst/>
@@ -10992,14 +11211,14 @@
       </p:sp>
       <p:sp>
         <p:nvSpPr>
-          <p:cNvPr id="29" name="TextBox 28"/>
-          <p:cNvSpPr txBox="1"/>
-          <p:nvPr/>
-        </p:nvSpPr>
-        <p:spPr>
-          <a:xfrm>
-            <a:off x="4846319" y="2990088"/>
-            <a:ext cx="1783080" cy="457200"/>
+          <p:cNvPr id="35" name="TextBox 34"/>
+          <p:cNvSpPr txBox="1"/>
+          <p:nvPr/>
+        </p:nvSpPr>
+        <p:spPr>
+          <a:xfrm>
+            <a:off x="4846319" y="3392424"/>
+            <a:ext cx="1783080" cy="402336"/>
           </a:xfrm>
           <a:prstGeom prst="rect">
             <a:avLst/>
@@ -11027,14 +11246,14 @@
       </p:sp>
       <p:sp>
         <p:nvSpPr>
-          <p:cNvPr id="30" name="Rectangle 29"/>
+          <p:cNvPr id="36" name="Rectangle 35"/>
           <p:cNvSpPr/>
           <p:nvPr/>
         </p:nvSpPr>
         <p:spPr>
           <a:xfrm>
-            <a:off x="6675119" y="3081528"/>
-            <a:ext cx="1325880" cy="274320"/>
+            <a:off x="6675119" y="3465576"/>
+            <a:ext cx="1325880" cy="256032"/>
           </a:xfrm>
           <a:prstGeom prst="rect">
             <a:avLst/>
@@ -11071,14 +11290,14 @@
       </p:sp>
       <p:sp>
         <p:nvSpPr>
-          <p:cNvPr id="31" name="TextBox 30"/>
-          <p:cNvSpPr txBox="1"/>
-          <p:nvPr/>
-        </p:nvSpPr>
-        <p:spPr>
-          <a:xfrm>
-            <a:off x="6629399" y="2990088"/>
-            <a:ext cx="1417320" cy="457200"/>
+          <p:cNvPr id="37" name="TextBox 36"/>
+          <p:cNvSpPr txBox="1"/>
+          <p:nvPr/>
+        </p:nvSpPr>
+        <p:spPr>
+          <a:xfrm>
+            <a:off x="6629399" y="3392424"/>
+            <a:ext cx="1417320" cy="402336"/>
           </a:xfrm>
           <a:prstGeom prst="rect">
             <a:avLst/>
@@ -11106,14 +11325,321 @@
       </p:sp>
       <p:sp>
         <p:nvSpPr>
-          <p:cNvPr id="32" name="Rectangle 31"/>
+          <p:cNvPr id="38" name="Rectangle 37"/>
           <p:cNvSpPr/>
           <p:nvPr/>
         </p:nvSpPr>
         <p:spPr>
           <a:xfrm>
-            <a:off x="411480" y="3447288"/>
-            <a:ext cx="7635240" cy="457200"/>
+            <a:off x="411480" y="3794760"/>
+            <a:ext cx="7635240" cy="402336"/>
+          </a:xfrm>
+          <a:prstGeom prst="rect">
+            <a:avLst/>
+          </a:prstGeom>
+          <a:solidFill>
+            <a:srgbClr val="FFFFFF"/>
+          </a:solidFill>
+          <a:ln>
+            <a:noFill/>
+          </a:ln>
+          <a:effectLst/>
+        </p:spPr>
+        <p:style>
+          <a:lnRef idx="1">
+            <a:schemeClr val="accent1"/>
+          </a:lnRef>
+          <a:fillRef idx="3">
+            <a:schemeClr val="accent1"/>
+          </a:fillRef>
+          <a:effectRef idx="2">
+            <a:schemeClr val="accent1"/>
+          </a:effectRef>
+          <a:fontRef idx="minor">
+            <a:schemeClr val="lt1"/>
+          </a:fontRef>
+        </p:style>
+        <p:txBody>
+          <a:bodyPr rtlCol="0" anchor="ctr"/>
+          <a:lstStyle/>
+          <a:p>
+            <a:pPr algn="ctr"/>
+          </a:p>
+        </p:txBody>
+      </p:sp>
+      <p:sp>
+        <p:nvSpPr>
+          <p:cNvPr id="39" name="Rectangle 38"/>
+          <p:cNvSpPr/>
+          <p:nvPr/>
+        </p:nvSpPr>
+        <p:spPr>
+          <a:xfrm>
+            <a:off x="411480" y="3794760"/>
+            <a:ext cx="109728" cy="402336"/>
+          </a:xfrm>
+          <a:prstGeom prst="rect">
+            <a:avLst/>
+          </a:prstGeom>
+          <a:solidFill>
+            <a:srgbClr val="888888"/>
+          </a:solidFill>
+          <a:ln>
+            <a:noFill/>
+          </a:ln>
+          <a:effectLst/>
+        </p:spPr>
+        <p:style>
+          <a:lnRef idx="1">
+            <a:schemeClr val="accent1"/>
+          </a:lnRef>
+          <a:fillRef idx="3">
+            <a:schemeClr val="accent1"/>
+          </a:fillRef>
+          <a:effectRef idx="2">
+            <a:schemeClr val="accent1"/>
+          </a:effectRef>
+          <a:fontRef idx="minor">
+            <a:schemeClr val="lt1"/>
+          </a:fontRef>
+        </p:style>
+        <p:txBody>
+          <a:bodyPr rtlCol="0" anchor="ctr"/>
+          <a:lstStyle/>
+          <a:p>
+            <a:pPr algn="ctr"/>
+          </a:p>
+        </p:txBody>
+      </p:sp>
+      <p:sp>
+        <p:nvSpPr>
+          <p:cNvPr id="40" name="TextBox 39"/>
+          <p:cNvSpPr txBox="1"/>
+          <p:nvPr/>
+        </p:nvSpPr>
+        <p:spPr>
+          <a:xfrm>
+            <a:off x="521208" y="3794760"/>
+            <a:ext cx="1307592" cy="402336"/>
+          </a:xfrm>
+          <a:prstGeom prst="rect">
+            <a:avLst/>
+          </a:prstGeom>
+          <a:noFill/>
+        </p:spPr>
+        <p:txBody>
+          <a:bodyPr wrap="square" lIns="36000" rIns="36000" tIns="18000" bIns="18000" anchor="ctr">
+            <a:spAutoFit/>
+          </a:bodyPr>
+          <a:lstStyle/>
+          <a:p>
+            <a:pPr algn="l"/>
+            <a:r>
+              <a:rPr sz="1100" b="1" i="0" u="none">
+                <a:solidFill>
+                  <a:srgbClr val="333333"/>
+                </a:solidFill>
+                <a:latin typeface="Calibri"/>
+              </a:rPr>
+              <a:t>Komposit</a:t>
+            </a:r>
+          </a:p>
+        </p:txBody>
+      </p:sp>
+      <p:sp>
+        <p:nvSpPr>
+          <p:cNvPr id="41" name="TextBox 40"/>
+          <p:cNvSpPr txBox="1"/>
+          <p:nvPr/>
+        </p:nvSpPr>
+        <p:spPr>
+          <a:xfrm>
+            <a:off x="1828800" y="3794760"/>
+            <a:ext cx="1143000" cy="402336"/>
+          </a:xfrm>
+          <a:prstGeom prst="rect">
+            <a:avLst/>
+          </a:prstGeom>
+          <a:noFill/>
+        </p:spPr>
+        <p:txBody>
+          <a:bodyPr wrap="square" lIns="36000" rIns="36000" tIns="18000" bIns="18000" anchor="ctr">
+            <a:spAutoFit/>
+          </a:bodyPr>
+          <a:lstStyle/>
+          <a:p>
+            <a:pPr algn="ctr"/>
+            <a:r>
+              <a:rPr sz="1100" b="0" i="0" u="none">
+                <a:solidFill>
+                  <a:srgbClr val="333333"/>
+                </a:solidFill>
+                <a:latin typeface="Calibri"/>
+              </a:rPr>
+              <a:t>2.089</a:t>
+            </a:r>
+          </a:p>
+        </p:txBody>
+      </p:sp>
+      <p:sp>
+        <p:nvSpPr>
+          <p:cNvPr id="42" name="TextBox 41"/>
+          <p:cNvSpPr txBox="1"/>
+          <p:nvPr/>
+        </p:nvSpPr>
+        <p:spPr>
+          <a:xfrm>
+            <a:off x="2971800" y="3794760"/>
+            <a:ext cx="1874519" cy="402336"/>
+          </a:xfrm>
+          <a:prstGeom prst="rect">
+            <a:avLst/>
+          </a:prstGeom>
+          <a:noFill/>
+        </p:spPr>
+        <p:txBody>
+          <a:bodyPr wrap="square" lIns="36000" rIns="36000" tIns="18000" bIns="18000" anchor="ctr">
+            <a:spAutoFit/>
+          </a:bodyPr>
+          <a:lstStyle/>
+          <a:p>
+            <a:pPr algn="ctr"/>
+            <a:r>
+              <a:rPr sz="1100" b="0" i="0" u="none">
+                <a:solidFill>
+                  <a:srgbClr val="333333"/>
+                </a:solidFill>
+                <a:latin typeface="Calibri"/>
+              </a:rPr>
+              <a:t>1.362 Mails (65 %)</a:t>
+            </a:r>
+          </a:p>
+        </p:txBody>
+      </p:sp>
+      <p:sp>
+        <p:nvSpPr>
+          <p:cNvPr id="43" name="TextBox 42"/>
+          <p:cNvSpPr txBox="1"/>
+          <p:nvPr/>
+        </p:nvSpPr>
+        <p:spPr>
+          <a:xfrm>
+            <a:off x="4846319" y="3794760"/>
+            <a:ext cx="1783080" cy="402336"/>
+          </a:xfrm>
+          <a:prstGeom prst="rect">
+            <a:avLst/>
+          </a:prstGeom>
+          <a:noFill/>
+        </p:spPr>
+        <p:txBody>
+          <a:bodyPr wrap="square" lIns="36000" rIns="36000" tIns="18000" bIns="18000" anchor="ctr">
+            <a:spAutoFit/>
+          </a:bodyPr>
+          <a:lstStyle/>
+          <a:p>
+            <a:pPr algn="ctr"/>
+            <a:r>
+              <a:rPr sz="1100" b="0" i="0" u="none">
+                <a:solidFill>
+                  <a:srgbClr val="333333"/>
+                </a:solidFill>
+                <a:latin typeface="Calibri"/>
+              </a:rPr>
+              <a:t>bereits gemappt</a:t>
+            </a:r>
+          </a:p>
+        </p:txBody>
+      </p:sp>
+      <p:sp>
+        <p:nvSpPr>
+          <p:cNvPr id="44" name="Rectangle 43"/>
+          <p:cNvSpPr/>
+          <p:nvPr/>
+        </p:nvSpPr>
+        <p:spPr>
+          <a:xfrm>
+            <a:off x="6675119" y="3867912"/>
+            <a:ext cx="1325880" cy="256032"/>
+          </a:xfrm>
+          <a:prstGeom prst="rect">
+            <a:avLst/>
+          </a:prstGeom>
+          <a:solidFill>
+            <a:srgbClr val="888888"/>
+          </a:solidFill>
+          <a:ln>
+            <a:noFill/>
+          </a:ln>
+          <a:effectLst/>
+        </p:spPr>
+        <p:style>
+          <a:lnRef idx="1">
+            <a:schemeClr val="accent1"/>
+          </a:lnRef>
+          <a:fillRef idx="3">
+            <a:schemeClr val="accent1"/>
+          </a:fillRef>
+          <a:effectRef idx="2">
+            <a:schemeClr val="accent1"/>
+          </a:effectRef>
+          <a:fontRef idx="minor">
+            <a:schemeClr val="lt1"/>
+          </a:fontRef>
+        </p:style>
+        <p:txBody>
+          <a:bodyPr rtlCol="0" anchor="ctr"/>
+          <a:lstStyle/>
+          <a:p>
+            <a:pPr algn="ctr"/>
+          </a:p>
+        </p:txBody>
+      </p:sp>
+      <p:sp>
+        <p:nvSpPr>
+          <p:cNvPr id="45" name="TextBox 44"/>
+          <p:cNvSpPr txBox="1"/>
+          <p:nvPr/>
+        </p:nvSpPr>
+        <p:spPr>
+          <a:xfrm>
+            <a:off x="6629399" y="3794760"/>
+            <a:ext cx="1417320" cy="402336"/>
+          </a:xfrm>
+          <a:prstGeom prst="rect">
+            <a:avLst/>
+          </a:prstGeom>
+          <a:noFill/>
+        </p:spPr>
+        <p:txBody>
+          <a:bodyPr wrap="square" lIns="36000" rIns="36000" tIns="18000" bIns="18000" anchor="ctr">
+            <a:spAutoFit/>
+          </a:bodyPr>
+          <a:lstStyle/>
+          <a:p>
+            <a:pPr algn="ctr"/>
+            <a:r>
+              <a:rPr sz="1000" b="1" i="0" u="none">
+                <a:solidFill>
+                  <a:srgbClr val="FFFFFF"/>
+                </a:solidFill>
+                <a:latin typeface="Calibri"/>
+              </a:rPr>
+              <a:t>gering</a:t>
+            </a:r>
+          </a:p>
+        </p:txBody>
+      </p:sp>
+      <p:sp>
+        <p:nvSpPr>
+          <p:cNvPr id="46" name="Rectangle 45"/>
+          <p:cNvSpPr/>
+          <p:nvPr/>
+        </p:nvSpPr>
+        <p:spPr>
+          <a:xfrm>
+            <a:off x="411480" y="4197096"/>
+            <a:ext cx="7635240" cy="402336"/>
           </a:xfrm>
           <a:prstGeom prst="rect">
             <a:avLst/>
@@ -11150,14 +11676,14 @@
       </p:sp>
       <p:sp>
         <p:nvSpPr>
-          <p:cNvPr id="33" name="Rectangle 32"/>
+          <p:cNvPr id="47" name="Rectangle 46"/>
           <p:cNvSpPr/>
           <p:nvPr/>
         </p:nvSpPr>
         <p:spPr>
           <a:xfrm>
-            <a:off x="411480" y="3447288"/>
-            <a:ext cx="109728" cy="457200"/>
+            <a:off x="411480" y="4197096"/>
+            <a:ext cx="109728" cy="402336"/>
           </a:xfrm>
           <a:prstGeom prst="rect">
             <a:avLst/>
@@ -11194,14 +11720,14 @@
       </p:sp>
       <p:sp>
         <p:nvSpPr>
-          <p:cNvPr id="34" name="TextBox 33"/>
-          <p:cNvSpPr txBox="1"/>
-          <p:nvPr/>
-        </p:nvSpPr>
-        <p:spPr>
-          <a:xfrm>
-            <a:off x="521208" y="3447288"/>
-            <a:ext cx="1307592" cy="457200"/>
+          <p:cNvPr id="48" name="TextBox 47"/>
+          <p:cNvSpPr txBox="1"/>
+          <p:nvPr/>
+        </p:nvSpPr>
+        <p:spPr>
+          <a:xfrm>
+            <a:off x="521208" y="4197096"/>
+            <a:ext cx="1307592" cy="402336"/>
           </a:xfrm>
           <a:prstGeom prst="rect">
             <a:avLst/>
@@ -11222,21 +11748,21 @@
                 </a:solidFill>
                 <a:latin typeface="Calibri"/>
               </a:rPr>
-              <a:t>Komposit</a:t>
-            </a:r>
-          </a:p>
-        </p:txBody>
-      </p:sp>
-      <p:sp>
-        <p:nvSpPr>
-          <p:cNvPr id="35" name="TextBox 34"/>
-          <p:cNvSpPr txBox="1"/>
-          <p:nvPr/>
-        </p:nvSpPr>
-        <p:spPr>
-          <a:xfrm>
-            <a:off x="1828800" y="3447288"/>
-            <a:ext cx="1143000" cy="457200"/>
+              <a:t>Leben</a:t>
+            </a:r>
+          </a:p>
+        </p:txBody>
+      </p:sp>
+      <p:sp>
+        <p:nvSpPr>
+          <p:cNvPr id="49" name="TextBox 48"/>
+          <p:cNvSpPr txBox="1"/>
+          <p:nvPr/>
+        </p:nvSpPr>
+        <p:spPr>
+          <a:xfrm>
+            <a:off x="1828800" y="4197096"/>
+            <a:ext cx="1143000" cy="402336"/>
           </a:xfrm>
           <a:prstGeom prst="rect">
             <a:avLst/>
@@ -11257,21 +11783,21 @@
                 </a:solidFill>
                 <a:latin typeface="Calibri"/>
               </a:rPr>
-              <a:t>2.089</a:t>
-            </a:r>
-          </a:p>
-        </p:txBody>
-      </p:sp>
-      <p:sp>
-        <p:nvSpPr>
-          <p:cNvPr id="36" name="TextBox 35"/>
-          <p:cNvSpPr txBox="1"/>
-          <p:nvPr/>
-        </p:nvSpPr>
-        <p:spPr>
-          <a:xfrm>
-            <a:off x="2971800" y="3447288"/>
-            <a:ext cx="1874519" cy="457200"/>
+              <a:t>662</a:t>
+            </a:r>
+          </a:p>
+        </p:txBody>
+      </p:sp>
+      <p:sp>
+        <p:nvSpPr>
+          <p:cNvPr id="50" name="TextBox 49"/>
+          <p:cNvSpPr txBox="1"/>
+          <p:nvPr/>
+        </p:nvSpPr>
+        <p:spPr>
+          <a:xfrm>
+            <a:off x="2971800" y="4197096"/>
+            <a:ext cx="1874519" cy="402336"/>
           </a:xfrm>
           <a:prstGeom prst="rect">
             <a:avLst/>
@@ -11292,21 +11818,21 @@
                 </a:solidFill>
                 <a:latin typeface="Calibri"/>
               </a:rPr>
-              <a:t>1.362 Mails (65 %)</a:t>
-            </a:r>
-          </a:p>
-        </p:txBody>
-      </p:sp>
-      <p:sp>
-        <p:nvSpPr>
-          <p:cNvPr id="37" name="TextBox 36"/>
-          <p:cNvSpPr txBox="1"/>
-          <p:nvPr/>
-        </p:nvSpPr>
-        <p:spPr>
-          <a:xfrm>
-            <a:off x="4846319" y="3447288"/>
-            <a:ext cx="1783080" cy="457200"/>
+              <a:t>314 Mails (47 %)</a:t>
+            </a:r>
+          </a:p>
+        </p:txBody>
+      </p:sp>
+      <p:sp>
+        <p:nvSpPr>
+          <p:cNvPr id="51" name="TextBox 50"/>
+          <p:cNvSpPr txBox="1"/>
+          <p:nvPr/>
+        </p:nvSpPr>
+        <p:spPr>
+          <a:xfrm>
+            <a:off x="4846319" y="4197096"/>
+            <a:ext cx="1783080" cy="402336"/>
           </a:xfrm>
           <a:prstGeom prst="rect">
             <a:avLst/>
@@ -11327,21 +11853,21 @@
                 </a:solidFill>
                 <a:latin typeface="Calibri"/>
               </a:rPr>
-              <a:t>bereits gemappt</a:t>
-            </a:r>
-          </a:p>
-        </p:txBody>
-      </p:sp>
-      <p:sp>
-        <p:nvSpPr>
-          <p:cNvPr id="38" name="Rectangle 37"/>
+              <a:t>weitgehend gemappt</a:t>
+            </a:r>
+          </a:p>
+        </p:txBody>
+      </p:sp>
+      <p:sp>
+        <p:nvSpPr>
+          <p:cNvPr id="52" name="Rectangle 51"/>
           <p:cNvSpPr/>
           <p:nvPr/>
         </p:nvSpPr>
         <p:spPr>
           <a:xfrm>
-            <a:off x="6675119" y="3538728"/>
-            <a:ext cx="1325880" cy="274320"/>
+            <a:off x="6675119" y="4270248"/>
+            <a:ext cx="1325880" cy="256032"/>
           </a:xfrm>
           <a:prstGeom prst="rect">
             <a:avLst/>
@@ -11378,14 +11904,14 @@
       </p:sp>
       <p:sp>
         <p:nvSpPr>
-          <p:cNvPr id="39" name="TextBox 38"/>
-          <p:cNvSpPr txBox="1"/>
-          <p:nvPr/>
-        </p:nvSpPr>
-        <p:spPr>
-          <a:xfrm>
-            <a:off x="6629399" y="3447288"/>
-            <a:ext cx="1417320" cy="457200"/>
+          <p:cNvPr id="53" name="TextBox 52"/>
+          <p:cNvSpPr txBox="1"/>
+          <p:nvPr/>
+        </p:nvSpPr>
+        <p:spPr>
+          <a:xfrm>
+            <a:off x="6629399" y="4197096"/>
+            <a:ext cx="1417320" cy="402336"/>
           </a:xfrm>
           <a:prstGeom prst="rect">
             <a:avLst/>
@@ -11413,14 +11939,14 @@
       </p:sp>
       <p:sp>
         <p:nvSpPr>
-          <p:cNvPr id="40" name="Rectangle 39"/>
+          <p:cNvPr id="54" name="Rectangle 53"/>
           <p:cNvSpPr/>
           <p:nvPr/>
         </p:nvSpPr>
         <p:spPr>
           <a:xfrm>
-            <a:off x="411480" y="3904488"/>
-            <a:ext cx="7635240" cy="457200"/>
+            <a:off x="411480" y="4599432"/>
+            <a:ext cx="7635240" cy="402336"/>
           </a:xfrm>
           <a:prstGeom prst="rect">
             <a:avLst/>
@@ -11457,14 +11983,14 @@
       </p:sp>
       <p:sp>
         <p:nvSpPr>
-          <p:cNvPr id="41" name="Rectangle 40"/>
+          <p:cNvPr id="55" name="Rectangle 54"/>
           <p:cNvSpPr/>
           <p:nvPr/>
         </p:nvSpPr>
         <p:spPr>
           <a:xfrm>
-            <a:off x="411480" y="3904488"/>
-            <a:ext cx="109728" cy="457200"/>
+            <a:off x="411480" y="4599432"/>
+            <a:ext cx="109728" cy="402336"/>
           </a:xfrm>
           <a:prstGeom prst="rect">
             <a:avLst/>
@@ -11501,14 +12027,14 @@
       </p:sp>
       <p:sp>
         <p:nvSpPr>
-          <p:cNvPr id="42" name="TextBox 41"/>
-          <p:cNvSpPr txBox="1"/>
-          <p:nvPr/>
-        </p:nvSpPr>
-        <p:spPr>
-          <a:xfrm>
-            <a:off x="521208" y="3904488"/>
-            <a:ext cx="1307592" cy="457200"/>
+          <p:cNvPr id="56" name="TextBox 55"/>
+          <p:cNvSpPr txBox="1"/>
+          <p:nvPr/>
+        </p:nvSpPr>
+        <p:spPr>
+          <a:xfrm>
+            <a:off x="521208" y="4599432"/>
+            <a:ext cx="1307592" cy="402336"/>
           </a:xfrm>
           <a:prstGeom prst="rect">
             <a:avLst/>
@@ -11529,21 +12055,21 @@
                 </a:solidFill>
                 <a:latin typeface="Calibri"/>
               </a:rPr>
-              <a:t>Leben</a:t>
-            </a:r>
-          </a:p>
-        </p:txBody>
-      </p:sp>
-      <p:sp>
-        <p:nvSpPr>
-          <p:cNvPr id="43" name="TextBox 42"/>
-          <p:cNvSpPr txBox="1"/>
-          <p:nvPr/>
-        </p:nvSpPr>
-        <p:spPr>
-          <a:xfrm>
-            <a:off x="1828800" y="3904488"/>
-            <a:ext cx="1143000" cy="457200"/>
+              <a:t>Mehr/Unbek.</a:t>
+            </a:r>
+          </a:p>
+        </p:txBody>
+      </p:sp>
+      <p:sp>
+        <p:nvSpPr>
+          <p:cNvPr id="57" name="TextBox 56"/>
+          <p:cNvSpPr txBox="1"/>
+          <p:nvPr/>
+        </p:nvSpPr>
+        <p:spPr>
+          <a:xfrm>
+            <a:off x="1828800" y="4599432"/>
+            <a:ext cx="1143000" cy="402336"/>
           </a:xfrm>
           <a:prstGeom prst="rect">
             <a:avLst/>
@@ -11564,21 +12090,21 @@
                 </a:solidFill>
                 <a:latin typeface="Calibri"/>
               </a:rPr>
-              <a:t>662</a:t>
-            </a:r>
-          </a:p>
-        </p:txBody>
-      </p:sp>
-      <p:sp>
-        <p:nvSpPr>
-          <p:cNvPr id="44" name="TextBox 43"/>
-          <p:cNvSpPr txBox="1"/>
-          <p:nvPr/>
-        </p:nvSpPr>
-        <p:spPr>
-          <a:xfrm>
-            <a:off x="2971800" y="3904488"/>
-            <a:ext cx="1874519" cy="457200"/>
+              <a:t>102</a:t>
+            </a:r>
+          </a:p>
+        </p:txBody>
+      </p:sp>
+      <p:sp>
+        <p:nvSpPr>
+          <p:cNvPr id="58" name="TextBox 57"/>
+          <p:cNvSpPr txBox="1"/>
+          <p:nvPr/>
+        </p:nvSpPr>
+        <p:spPr>
+          <a:xfrm>
+            <a:off x="2971800" y="4599432"/>
+            <a:ext cx="1874519" cy="402336"/>
           </a:xfrm>
           <a:prstGeom prst="rect">
             <a:avLst/>
@@ -11599,21 +12125,21 @@
                 </a:solidFill>
                 <a:latin typeface="Calibri"/>
               </a:rPr>
-              <a:t>314 Mails (47 %)</a:t>
-            </a:r>
-          </a:p>
-        </p:txBody>
-      </p:sp>
-      <p:sp>
-        <p:nvSpPr>
-          <p:cNvPr id="45" name="TextBox 44"/>
-          <p:cNvSpPr txBox="1"/>
-          <p:nvPr/>
-        </p:nvSpPr>
-        <p:spPr>
-          <a:xfrm>
-            <a:off x="4846319" y="3904488"/>
-            <a:ext cx="1783080" cy="457200"/>
+              <a:t>15 Mails (15 %)</a:t>
+            </a:r>
+          </a:p>
+        </p:txBody>
+      </p:sp>
+      <p:sp>
+        <p:nvSpPr>
+          <p:cNvPr id="59" name="TextBox 58"/>
+          <p:cNvSpPr txBox="1"/>
+          <p:nvPr/>
+        </p:nvSpPr>
+        <p:spPr>
+          <a:xfrm>
+            <a:off x="4846319" y="4599432"/>
+            <a:ext cx="1783080" cy="402336"/>
           </a:xfrm>
           <a:prstGeom prst="rect">
             <a:avLst/>
@@ -11634,21 +12160,21 @@
                 </a:solidFill>
                 <a:latin typeface="Calibri"/>
               </a:rPr>
-              <a:t>weitgehend gemappt</a:t>
-            </a:r>
-          </a:p>
-        </p:txBody>
-      </p:sp>
-      <p:sp>
-        <p:nvSpPr>
-          <p:cNvPr id="46" name="Rectangle 45"/>
+              <a:t>uneinheitlich</a:t>
+            </a:r>
+          </a:p>
+        </p:txBody>
+      </p:sp>
+      <p:sp>
+        <p:nvSpPr>
+          <p:cNvPr id="60" name="Rectangle 59"/>
           <p:cNvSpPr/>
           <p:nvPr/>
         </p:nvSpPr>
         <p:spPr>
           <a:xfrm>
-            <a:off x="6675119" y="3995928"/>
-            <a:ext cx="1325880" cy="274320"/>
+            <a:off x="6675119" y="4672584"/>
+            <a:ext cx="1325880" cy="256032"/>
           </a:xfrm>
           <a:prstGeom prst="rect">
             <a:avLst/>
@@ -11685,14 +12211,14 @@
       </p:sp>
       <p:sp>
         <p:nvSpPr>
-          <p:cNvPr id="47" name="TextBox 46"/>
-          <p:cNvSpPr txBox="1"/>
-          <p:nvPr/>
-        </p:nvSpPr>
-        <p:spPr>
-          <a:xfrm>
-            <a:off x="6629399" y="3904488"/>
-            <a:ext cx="1417320" cy="457200"/>
+          <p:cNvPr id="61" name="TextBox 60"/>
+          <p:cNvSpPr txBox="1"/>
+          <p:nvPr/>
+        </p:nvSpPr>
+        <p:spPr>
+          <a:xfrm>
+            <a:off x="6629399" y="4599432"/>
+            <a:ext cx="1417320" cy="402336"/>
           </a:xfrm>
           <a:prstGeom prst="rect">
             <a:avLst/>
@@ -11713,327 +12239,20 @@
                 </a:solidFill>
                 <a:latin typeface="Calibri"/>
               </a:rPr>
-              <a:t>gering</a:t>
-            </a:r>
-          </a:p>
-        </p:txBody>
-      </p:sp>
-      <p:sp>
-        <p:nvSpPr>
-          <p:cNvPr id="48" name="Rectangle 47"/>
+              <a:t>klein</a:t>
+            </a:r>
+          </a:p>
+        </p:txBody>
+      </p:sp>
+      <p:sp>
+        <p:nvSpPr>
+          <p:cNvPr id="62" name="Rectangle 61"/>
           <p:cNvSpPr/>
           <p:nvPr/>
         </p:nvSpPr>
         <p:spPr>
           <a:xfrm>
-            <a:off x="411480" y="4361688"/>
-            <a:ext cx="7635240" cy="457200"/>
-          </a:xfrm>
-          <a:prstGeom prst="rect">
-            <a:avLst/>
-          </a:prstGeom>
-          <a:solidFill>
-            <a:srgbClr val="F1F1F1"/>
-          </a:solidFill>
-          <a:ln>
-            <a:noFill/>
-          </a:ln>
-          <a:effectLst/>
-        </p:spPr>
-        <p:style>
-          <a:lnRef idx="1">
-            <a:schemeClr val="accent1"/>
-          </a:lnRef>
-          <a:fillRef idx="3">
-            <a:schemeClr val="accent1"/>
-          </a:fillRef>
-          <a:effectRef idx="2">
-            <a:schemeClr val="accent1"/>
-          </a:effectRef>
-          <a:fontRef idx="minor">
-            <a:schemeClr val="lt1"/>
-          </a:fontRef>
-        </p:style>
-        <p:txBody>
-          <a:bodyPr rtlCol="0" anchor="ctr"/>
-          <a:lstStyle/>
-          <a:p>
-            <a:pPr algn="ctr"/>
-          </a:p>
-        </p:txBody>
-      </p:sp>
-      <p:sp>
-        <p:nvSpPr>
-          <p:cNvPr id="49" name="Rectangle 48"/>
-          <p:cNvSpPr/>
-          <p:nvPr/>
-        </p:nvSpPr>
-        <p:spPr>
-          <a:xfrm>
-            <a:off x="411480" y="4361688"/>
-            <a:ext cx="109728" cy="457200"/>
-          </a:xfrm>
-          <a:prstGeom prst="rect">
-            <a:avLst/>
-          </a:prstGeom>
-          <a:solidFill>
-            <a:srgbClr val="888888"/>
-          </a:solidFill>
-          <a:ln>
-            <a:noFill/>
-          </a:ln>
-          <a:effectLst/>
-        </p:spPr>
-        <p:style>
-          <a:lnRef idx="1">
-            <a:schemeClr val="accent1"/>
-          </a:lnRef>
-          <a:fillRef idx="3">
-            <a:schemeClr val="accent1"/>
-          </a:fillRef>
-          <a:effectRef idx="2">
-            <a:schemeClr val="accent1"/>
-          </a:effectRef>
-          <a:fontRef idx="minor">
-            <a:schemeClr val="lt1"/>
-          </a:fontRef>
-        </p:style>
-        <p:txBody>
-          <a:bodyPr rtlCol="0" anchor="ctr"/>
-          <a:lstStyle/>
-          <a:p>
-            <a:pPr algn="ctr"/>
-          </a:p>
-        </p:txBody>
-      </p:sp>
-      <p:sp>
-        <p:nvSpPr>
-          <p:cNvPr id="50" name="TextBox 49"/>
-          <p:cNvSpPr txBox="1"/>
-          <p:nvPr/>
-        </p:nvSpPr>
-        <p:spPr>
-          <a:xfrm>
-            <a:off x="521208" y="4361688"/>
-            <a:ext cx="1307592" cy="457200"/>
-          </a:xfrm>
-          <a:prstGeom prst="rect">
-            <a:avLst/>
-          </a:prstGeom>
-          <a:noFill/>
-        </p:spPr>
-        <p:txBody>
-          <a:bodyPr wrap="square" lIns="36000" rIns="36000" tIns="18000" bIns="18000" anchor="ctr">
-            <a:spAutoFit/>
-          </a:bodyPr>
-          <a:lstStyle/>
-          <a:p>
-            <a:pPr algn="l"/>
-            <a:r>
-              <a:rPr sz="1100" b="1" i="0" u="none">
-                <a:solidFill>
-                  <a:srgbClr val="333333"/>
-                </a:solidFill>
-                <a:latin typeface="Calibri"/>
-              </a:rPr>
-              <a:t>Mehr/Unbek.</a:t>
-            </a:r>
-          </a:p>
-        </p:txBody>
-      </p:sp>
-      <p:sp>
-        <p:nvSpPr>
-          <p:cNvPr id="51" name="TextBox 50"/>
-          <p:cNvSpPr txBox="1"/>
-          <p:nvPr/>
-        </p:nvSpPr>
-        <p:spPr>
-          <a:xfrm>
-            <a:off x="1828800" y="4361688"/>
-            <a:ext cx="1143000" cy="457200"/>
-          </a:xfrm>
-          <a:prstGeom prst="rect">
-            <a:avLst/>
-          </a:prstGeom>
-          <a:noFill/>
-        </p:spPr>
-        <p:txBody>
-          <a:bodyPr wrap="square" lIns="36000" rIns="36000" tIns="18000" bIns="18000" anchor="ctr">
-            <a:spAutoFit/>
-          </a:bodyPr>
-          <a:lstStyle/>
-          <a:p>
-            <a:pPr algn="ctr"/>
-            <a:r>
-              <a:rPr sz="1100" b="0" i="0" u="none">
-                <a:solidFill>
-                  <a:srgbClr val="333333"/>
-                </a:solidFill>
-                <a:latin typeface="Calibri"/>
-              </a:rPr>
-              <a:t>239</a:t>
-            </a:r>
-          </a:p>
-        </p:txBody>
-      </p:sp>
-      <p:sp>
-        <p:nvSpPr>
-          <p:cNvPr id="52" name="TextBox 51"/>
-          <p:cNvSpPr txBox="1"/>
-          <p:nvPr/>
-        </p:nvSpPr>
-        <p:spPr>
-          <a:xfrm>
-            <a:off x="2971800" y="4361688"/>
-            <a:ext cx="1874519" cy="457200"/>
-          </a:xfrm>
-          <a:prstGeom prst="rect">
-            <a:avLst/>
-          </a:prstGeom>
-          <a:noFill/>
-        </p:spPr>
-        <p:txBody>
-          <a:bodyPr wrap="square" lIns="36000" rIns="36000" tIns="18000" bIns="18000" anchor="ctr">
-            <a:spAutoFit/>
-          </a:bodyPr>
-          <a:lstStyle/>
-          <a:p>
-            <a:pPr algn="ctr"/>
-            <a:r>
-              <a:rPr sz="1100" b="0" i="0" u="none">
-                <a:solidFill>
-                  <a:srgbClr val="333333"/>
-                </a:solidFill>
-                <a:latin typeface="Calibri"/>
-              </a:rPr>
-              <a:t>26 Mails</a:t>
-            </a:r>
-          </a:p>
-        </p:txBody>
-      </p:sp>
-      <p:sp>
-        <p:nvSpPr>
-          <p:cNvPr id="53" name="TextBox 52"/>
-          <p:cNvSpPr txBox="1"/>
-          <p:nvPr/>
-        </p:nvSpPr>
-        <p:spPr>
-          <a:xfrm>
-            <a:off x="4846319" y="4361688"/>
-            <a:ext cx="1783080" cy="457200"/>
-          </a:xfrm>
-          <a:prstGeom prst="rect">
-            <a:avLst/>
-          </a:prstGeom>
-          <a:noFill/>
-        </p:spPr>
-        <p:txBody>
-          <a:bodyPr wrap="square" lIns="36000" rIns="36000" tIns="18000" bIns="18000" anchor="ctr">
-            <a:spAutoFit/>
-          </a:bodyPr>
-          <a:lstStyle/>
-          <a:p>
-            <a:pPr algn="ctr"/>
-            <a:r>
-              <a:rPr sz="1100" b="0" i="0" u="none">
-                <a:solidFill>
-                  <a:srgbClr val="333333"/>
-                </a:solidFill>
-                <a:latin typeface="Calibri"/>
-              </a:rPr>
-              <a:t>uneinheitlich</a:t>
-            </a:r>
-          </a:p>
-        </p:txBody>
-      </p:sp>
-      <p:sp>
-        <p:nvSpPr>
-          <p:cNvPr id="54" name="Rectangle 53"/>
-          <p:cNvSpPr/>
-          <p:nvPr/>
-        </p:nvSpPr>
-        <p:spPr>
-          <a:xfrm>
-            <a:off x="6675119" y="4453128"/>
-            <a:ext cx="1325880" cy="274320"/>
-          </a:xfrm>
-          <a:prstGeom prst="rect">
-            <a:avLst/>
-          </a:prstGeom>
-          <a:solidFill>
-            <a:srgbClr val="888888"/>
-          </a:solidFill>
-          <a:ln>
-            <a:noFill/>
-          </a:ln>
-          <a:effectLst/>
-        </p:spPr>
-        <p:style>
-          <a:lnRef idx="1">
-            <a:schemeClr val="accent1"/>
-          </a:lnRef>
-          <a:fillRef idx="3">
-            <a:schemeClr val="accent1"/>
-          </a:fillRef>
-          <a:effectRef idx="2">
-            <a:schemeClr val="accent1"/>
-          </a:effectRef>
-          <a:fontRef idx="minor">
-            <a:schemeClr val="lt1"/>
-          </a:fontRef>
-        </p:style>
-        <p:txBody>
-          <a:bodyPr rtlCol="0" anchor="ctr"/>
-          <a:lstStyle/>
-          <a:p>
-            <a:pPr algn="ctr"/>
-          </a:p>
-        </p:txBody>
-      </p:sp>
-      <p:sp>
-        <p:nvSpPr>
-          <p:cNvPr id="55" name="TextBox 54"/>
-          <p:cNvSpPr txBox="1"/>
-          <p:nvPr/>
-        </p:nvSpPr>
-        <p:spPr>
-          <a:xfrm>
-            <a:off x="6629399" y="4361688"/>
-            <a:ext cx="1417320" cy="457200"/>
-          </a:xfrm>
-          <a:prstGeom prst="rect">
-            <a:avLst/>
-          </a:prstGeom>
-          <a:noFill/>
-        </p:spPr>
-        <p:txBody>
-          <a:bodyPr wrap="square" lIns="36000" rIns="36000" tIns="18000" bIns="18000" anchor="ctr">
-            <a:spAutoFit/>
-          </a:bodyPr>
-          <a:lstStyle/>
-          <a:p>
-            <a:pPr algn="ctr"/>
-            <a:r>
-              <a:rPr sz="1000" b="1" i="0" u="none">
-                <a:solidFill>
-                  <a:srgbClr val="FFFFFF"/>
-                </a:solidFill>
-                <a:latin typeface="Calibri"/>
-              </a:rPr>
-              <a:t>klein</a:t>
-            </a:r>
-          </a:p>
-        </p:txBody>
-      </p:sp>
-      <p:sp>
-        <p:nvSpPr>
-          <p:cNvPr id="56" name="Rectangle 55"/>
-          <p:cNvSpPr/>
-          <p:nvPr/>
-        </p:nvSpPr>
-        <p:spPr>
-          <a:xfrm>
-            <a:off x="411480" y="4956048"/>
+            <a:off x="411480" y="5138928"/>
             <a:ext cx="7635240" cy="914400"/>
           </a:xfrm>
           <a:prstGeom prst="rect">
@@ -12071,13 +12290,13 @@
       </p:sp>
       <p:sp>
         <p:nvSpPr>
-          <p:cNvPr id="57" name="TextBox 56"/>
-          <p:cNvSpPr txBox="1"/>
-          <p:nvPr/>
-        </p:nvSpPr>
-        <p:spPr>
-          <a:xfrm>
-            <a:off x="594360" y="5029200"/>
+          <p:cNvPr id="63" name="TextBox 62"/>
+          <p:cNvSpPr txBox="1"/>
+          <p:nvPr/>
+        </p:nvSpPr>
+        <p:spPr>
+          <a:xfrm>
+            <a:off x="594360" y="5212080"/>
             <a:ext cx="7269480" cy="274320"/>
           </a:xfrm>
           <a:prstGeom prst="rect">
@@ -12106,13 +12325,13 @@
       </p:sp>
       <p:sp>
         <p:nvSpPr>
-          <p:cNvPr id="58" name="TextBox 57"/>
-          <p:cNvSpPr txBox="1"/>
-          <p:nvPr/>
-        </p:nvSpPr>
-        <p:spPr>
-          <a:xfrm>
-            <a:off x="594360" y="5340096"/>
+          <p:cNvPr id="64" name="TextBox 63"/>
+          <p:cNvSpPr txBox="1"/>
+          <p:nvPr/>
+        </p:nvSpPr>
+        <p:spPr>
+          <a:xfrm>
+            <a:off x="594360" y="5522976"/>
             <a:ext cx="7269480" cy="502920"/>
           </a:xfrm>
           <a:prstGeom prst="rect">
@@ -12141,7 +12360,7 @@
       </p:sp>
       <p:sp>
         <p:nvSpPr>
-          <p:cNvPr id="59" name="Rectangle 58"/>
+          <p:cNvPr id="65" name="Rectangle 64"/>
           <p:cNvSpPr/>
           <p:nvPr/>
         </p:nvSpPr>
@@ -12185,7 +12404,7 @@
       </p:sp>
       <p:sp>
         <p:nvSpPr>
-          <p:cNvPr id="60" name="Oval 59"/>
+          <p:cNvPr id="66" name="Oval 65"/>
           <p:cNvSpPr/>
           <p:nvPr/>
         </p:nvSpPr>
@@ -12229,7 +12448,7 @@
       </p:sp>
       <p:sp>
         <p:nvSpPr>
-          <p:cNvPr id="61" name="TextBox 60"/>
+          <p:cNvPr id="67" name="TextBox 66"/>
           <p:cNvSpPr txBox="1"/>
           <p:nvPr/>
         </p:nvSpPr>
@@ -12264,7 +12483,7 @@
       </p:sp>
       <p:sp>
         <p:nvSpPr>
-          <p:cNvPr id="62" name="TextBox 61"/>
+          <p:cNvPr id="68" name="TextBox 67"/>
           <p:cNvSpPr txBox="1"/>
           <p:nvPr/>
         </p:nvSpPr>
@@ -12308,7 +12527,7 @@
       </p:sp>
       <p:sp>
         <p:nvSpPr>
-          <p:cNvPr id="63" name="Oval 62"/>
+          <p:cNvPr id="69" name="Oval 68"/>
           <p:cNvSpPr/>
           <p:nvPr/>
         </p:nvSpPr>
@@ -12352,7 +12571,7 @@
       </p:sp>
       <p:sp>
         <p:nvSpPr>
-          <p:cNvPr id="64" name="TextBox 63"/>
+          <p:cNvPr id="70" name="TextBox 69"/>
           <p:cNvSpPr txBox="1"/>
           <p:nvPr/>
         </p:nvSpPr>
@@ -12387,7 +12606,7 @@
       </p:sp>
       <p:sp>
         <p:nvSpPr>
-          <p:cNvPr id="65" name="TextBox 64"/>
+          <p:cNvPr id="71" name="TextBox 70"/>
           <p:cNvSpPr txBox="1"/>
           <p:nvPr/>
         </p:nvSpPr>
@@ -12431,7 +12650,7 @@
       </p:sp>
       <p:sp>
         <p:nvSpPr>
-          <p:cNvPr id="66" name="Oval 65"/>
+          <p:cNvPr id="72" name="Oval 71"/>
           <p:cNvSpPr/>
           <p:nvPr/>
         </p:nvSpPr>
@@ -12475,7 +12694,7 @@
       </p:sp>
       <p:sp>
         <p:nvSpPr>
-          <p:cNvPr id="67" name="TextBox 66"/>
+          <p:cNvPr id="73" name="TextBox 72"/>
           <p:cNvSpPr txBox="1"/>
           <p:nvPr/>
         </p:nvSpPr>
@@ -12510,7 +12729,7 @@
       </p:sp>
       <p:sp>
         <p:nvSpPr>
-          <p:cNvPr id="68" name="TextBox 67"/>
+          <p:cNvPr id="74" name="TextBox 73"/>
           <p:cNvSpPr txBox="1"/>
           <p:nvPr/>
         </p:nvSpPr>
@@ -12554,7 +12773,7 @@
       </p:sp>
       <p:sp>
         <p:nvSpPr>
-          <p:cNvPr id="69" name="Oval 68"/>
+          <p:cNvPr id="75" name="Oval 74"/>
           <p:cNvSpPr/>
           <p:nvPr/>
         </p:nvSpPr>
@@ -12598,7 +12817,7 @@
       </p:sp>
       <p:sp>
         <p:nvSpPr>
-          <p:cNvPr id="70" name="TextBox 69"/>
+          <p:cNvPr id="76" name="TextBox 75"/>
           <p:cNvSpPr txBox="1"/>
           <p:nvPr/>
         </p:nvSpPr>
@@ -12633,7 +12852,7 @@
       </p:sp>
       <p:sp>
         <p:nvSpPr>
-          <p:cNvPr id="71" name="TextBox 70"/>
+          <p:cNvPr id="77" name="TextBox 76"/>
           <p:cNvSpPr txBox="1"/>
           <p:nvPr/>
         </p:nvSpPr>
@@ -12677,7 +12896,7 @@
       </p:sp>
       <p:sp>
         <p:nvSpPr>
-          <p:cNvPr id="72" name="Oval 71"/>
+          <p:cNvPr id="78" name="Oval 77"/>
           <p:cNvSpPr/>
           <p:nvPr/>
         </p:nvSpPr>
@@ -12721,7 +12940,7 @@
       </p:sp>
       <p:sp>
         <p:nvSpPr>
-          <p:cNvPr id="73" name="TextBox 72"/>
+          <p:cNvPr id="79" name="TextBox 78"/>
           <p:cNvSpPr txBox="1"/>
           <p:nvPr/>
         </p:nvSpPr>
@@ -12756,7 +12975,7 @@
       </p:sp>
       <p:sp>
         <p:nvSpPr>
-          <p:cNvPr id="74" name="TextBox 73"/>
+          <p:cNvPr id="80" name="TextBox 79"/>
           <p:cNvSpPr txBox="1"/>
           <p:nvPr/>
         </p:nvSpPr>
@@ -12800,7 +13019,7 @@
       </p:sp>
       <p:sp>
         <p:nvSpPr>
-          <p:cNvPr id="75" name="TextBox 74"/>
+          <p:cNvPr id="81" name="TextBox 80"/>
           <p:cNvSpPr txBox="1"/>
           <p:nvPr/>
         </p:nvSpPr>
@@ -12835,7 +13054,7 @@
       </p:sp>
       <p:sp>
         <p:nvSpPr>
-          <p:cNvPr id="76" name="Rectangle 75"/>
+          <p:cNvPr id="82" name="Rectangle 81"/>
           <p:cNvSpPr/>
           <p:nvPr/>
         </p:nvSpPr>
@@ -12879,7 +13098,7 @@
       </p:sp>
       <p:sp>
         <p:nvSpPr>
-          <p:cNvPr id="77" name="TextBox 76"/>
+          <p:cNvPr id="83" name="TextBox 82"/>
           <p:cNvSpPr txBox="1"/>
           <p:nvPr/>
         </p:nvSpPr>

</xml_diff>

<commit_message>
PPTX Folie 11: Tabelle umsortiert + 2 Ergaenzungs-Kennzahlen
- Reihenfolge: Gesamt Mails -> Keine BÜ (+MV) -> Reminder (+MV) -> Neue BÜ
  (Neue BÜ jetzt als letzte Status-Zeile, teal hervorgehoben)
- Neue Ergaenzungs-Zeilen je Sparte:
  * Anteil Top-5-Makler:  Gesamt 57% / KV 68% / Komposit 60% / Leben 67%
  * Anteil in Cluster (weitere Mails Makler+Kunde):
    Gesamt 47% / KV 31% / Komposit 63% / Leben 47%
- Top-5-Pools: JDC, Fonds Finanz, blau direkt, DEMA, vfm Service
- Hebel-Callout-Bars entfernt (Platz fuer Ergaenzungszeilen; Hebel stehen
  weiter in Kernaussagen + Take-away), Fussnote verweist auf 11a/11b

https://claude.ai/code/session_01UknXtYp2XECsQDonCZuxSt
</commit_message>
<xml_diff>
--- a/ERGO-Mengengeruest-2Slides-Berichtslook.pptx
+++ b/ERGO-Mengengeruest-2Slides-Berichtslook.pptx
@@ -4537,7 +4537,7 @@
         <p:spPr>
           <a:xfrm>
             <a:off x="411480" y="3337560"/>
-            <a:ext cx="7635240" cy="315468"/>
+            <a:ext cx="7635240" cy="278892"/>
           </a:xfrm>
           <a:prstGeom prst="rect">
             <a:avLst/>
@@ -4581,7 +4581,7 @@
         <p:spPr>
           <a:xfrm>
             <a:off x="521208" y="3337560"/>
-            <a:ext cx="2679192" cy="315468"/>
+            <a:ext cx="2679192" cy="278892"/>
           </a:xfrm>
           <a:prstGeom prst="rect">
             <a:avLst/>
@@ -4616,7 +4616,7 @@
         <p:spPr>
           <a:xfrm>
             <a:off x="3200400" y="3337560"/>
-            <a:ext cx="1234440" cy="315468"/>
+            <a:ext cx="1234440" cy="278892"/>
           </a:xfrm>
           <a:prstGeom prst="rect">
             <a:avLst/>
@@ -4651,7 +4651,7 @@
         <p:spPr>
           <a:xfrm>
             <a:off x="4434840" y="3337560"/>
-            <a:ext cx="1188720" cy="315468"/>
+            <a:ext cx="1188720" cy="278892"/>
           </a:xfrm>
           <a:prstGeom prst="rect">
             <a:avLst/>
@@ -4686,7 +4686,7 @@
         <p:spPr>
           <a:xfrm>
             <a:off x="5623560" y="3337560"/>
-            <a:ext cx="1371600" cy="315468"/>
+            <a:ext cx="1371600" cy="278892"/>
           </a:xfrm>
           <a:prstGeom prst="rect">
             <a:avLst/>
@@ -4721,7 +4721,7 @@
         <p:spPr>
           <a:xfrm>
             <a:off x="6995160" y="3337560"/>
-            <a:ext cx="1051560" cy="315468"/>
+            <a:ext cx="1051560" cy="278892"/>
           </a:xfrm>
           <a:prstGeom prst="rect">
             <a:avLst/>
@@ -4755,227 +4755,8 @@
         </p:nvSpPr>
         <p:spPr>
           <a:xfrm>
-            <a:off x="411480" y="3653028"/>
-            <a:ext cx="7635240" cy="315468"/>
-          </a:xfrm>
-          <a:prstGeom prst="rect">
-            <a:avLst/>
-          </a:prstGeom>
-          <a:solidFill>
-            <a:srgbClr val="F1F1F1"/>
-          </a:solidFill>
-          <a:ln>
-            <a:noFill/>
-          </a:ln>
-          <a:effectLst/>
-        </p:spPr>
-        <p:style>
-          <a:lnRef idx="1">
-            <a:schemeClr val="accent1"/>
-          </a:lnRef>
-          <a:fillRef idx="3">
-            <a:schemeClr val="accent1"/>
-          </a:fillRef>
-          <a:effectRef idx="2">
-            <a:schemeClr val="accent1"/>
-          </a:effectRef>
-          <a:fontRef idx="minor">
-            <a:schemeClr val="lt1"/>
-          </a:fontRef>
-        </p:style>
-        <p:txBody>
-          <a:bodyPr rtlCol="0" anchor="ctr"/>
-          <a:lstStyle/>
-          <a:p>
-            <a:pPr algn="ctr"/>
-          </a:p>
-        </p:txBody>
-      </p:sp>
-      <p:sp>
-        <p:nvSpPr>
-          <p:cNvPr id="46" name="TextBox 45"/>
-          <p:cNvSpPr txBox="1"/>
-          <p:nvPr/>
-        </p:nvSpPr>
-        <p:spPr>
-          <a:xfrm>
-            <a:off x="521208" y="3653028"/>
-            <a:ext cx="2679192" cy="315468"/>
-          </a:xfrm>
-          <a:prstGeom prst="rect">
-            <a:avLst/>
-          </a:prstGeom>
-          <a:noFill/>
-        </p:spPr>
-        <p:txBody>
-          <a:bodyPr wrap="square" lIns="36000" rIns="36000" tIns="18000" bIns="18000" anchor="ctr">
-            <a:spAutoFit/>
-          </a:bodyPr>
-          <a:lstStyle/>
-          <a:p>
-            <a:pPr algn="l"/>
-            <a:r>
-              <a:rPr sz="1100" b="0" i="0" u="none">
-                <a:solidFill>
-                  <a:srgbClr val="333333"/>
-                </a:solidFill>
-                <a:latin typeface="Calibri"/>
-              </a:rPr>
-              <a:t>Neue BÜ (echte BÜ-Anfragen)</a:t>
-            </a:r>
-          </a:p>
-        </p:txBody>
-      </p:sp>
-      <p:sp>
-        <p:nvSpPr>
-          <p:cNvPr id="47" name="TextBox 46"/>
-          <p:cNvSpPr txBox="1"/>
-          <p:nvPr/>
-        </p:nvSpPr>
-        <p:spPr>
-          <a:xfrm>
-            <a:off x="3200400" y="3653028"/>
-            <a:ext cx="1234440" cy="315468"/>
-          </a:xfrm>
-          <a:prstGeom prst="rect">
-            <a:avLst/>
-          </a:prstGeom>
-          <a:noFill/>
-        </p:spPr>
-        <p:txBody>
-          <a:bodyPr wrap="square" lIns="36000" rIns="36000" tIns="18000" bIns="18000" anchor="ctr">
-            <a:spAutoFit/>
-          </a:bodyPr>
-          <a:lstStyle/>
-          <a:p>
-            <a:pPr algn="ctr"/>
-            <a:r>
-              <a:rPr sz="1100" b="1" i="0" u="none">
-                <a:solidFill>
-                  <a:srgbClr val="333333"/>
-                </a:solidFill>
-                <a:latin typeface="Calibri"/>
-              </a:rPr>
-              <a:t>4.000</a:t>
-            </a:r>
-          </a:p>
-        </p:txBody>
-      </p:sp>
-      <p:sp>
-        <p:nvSpPr>
-          <p:cNvPr id="48" name="TextBox 47"/>
-          <p:cNvSpPr txBox="1"/>
-          <p:nvPr/>
-        </p:nvSpPr>
-        <p:spPr>
-          <a:xfrm>
-            <a:off x="4434840" y="3653028"/>
-            <a:ext cx="1188720" cy="315468"/>
-          </a:xfrm>
-          <a:prstGeom prst="rect">
-            <a:avLst/>
-          </a:prstGeom>
-          <a:noFill/>
-        </p:spPr>
-        <p:txBody>
-          <a:bodyPr wrap="square" lIns="36000" rIns="36000" tIns="18000" bIns="18000" anchor="ctr">
-            <a:spAutoFit/>
-          </a:bodyPr>
-          <a:lstStyle/>
-          <a:p>
-            <a:pPr algn="ctr"/>
-            <a:r>
-              <a:rPr sz="1100" b="0" i="0" u="none">
-                <a:solidFill>
-                  <a:srgbClr val="333333"/>
-                </a:solidFill>
-                <a:latin typeface="Calibri"/>
-              </a:rPr>
-              <a:t>1.147</a:t>
-            </a:r>
-          </a:p>
-        </p:txBody>
-      </p:sp>
-      <p:sp>
-        <p:nvSpPr>
-          <p:cNvPr id="49" name="TextBox 48"/>
-          <p:cNvSpPr txBox="1"/>
-          <p:nvPr/>
-        </p:nvSpPr>
-        <p:spPr>
-          <a:xfrm>
-            <a:off x="5623560" y="3653028"/>
-            <a:ext cx="1371600" cy="315468"/>
-          </a:xfrm>
-          <a:prstGeom prst="rect">
-            <a:avLst/>
-          </a:prstGeom>
-          <a:noFill/>
-        </p:spPr>
-        <p:txBody>
-          <a:bodyPr wrap="square" lIns="36000" rIns="36000" tIns="18000" bIns="18000" anchor="ctr">
-            <a:spAutoFit/>
-          </a:bodyPr>
-          <a:lstStyle/>
-          <a:p>
-            <a:pPr algn="ctr"/>
-            <a:r>
-              <a:rPr sz="1100" b="0" i="0" u="none">
-                <a:solidFill>
-                  <a:srgbClr val="333333"/>
-                </a:solidFill>
-                <a:latin typeface="Calibri"/>
-              </a:rPr>
-              <a:t>2.089</a:t>
-            </a:r>
-          </a:p>
-        </p:txBody>
-      </p:sp>
-      <p:sp>
-        <p:nvSpPr>
-          <p:cNvPr id="50" name="TextBox 49"/>
-          <p:cNvSpPr txBox="1"/>
-          <p:nvPr/>
-        </p:nvSpPr>
-        <p:spPr>
-          <a:xfrm>
-            <a:off x="6995160" y="3653028"/>
-            <a:ext cx="1051560" cy="315468"/>
-          </a:xfrm>
-          <a:prstGeom prst="rect">
-            <a:avLst/>
-          </a:prstGeom>
-          <a:noFill/>
-        </p:spPr>
-        <p:txBody>
-          <a:bodyPr wrap="square" lIns="36000" rIns="36000" tIns="18000" bIns="18000" anchor="ctr">
-            <a:spAutoFit/>
-          </a:bodyPr>
-          <a:lstStyle/>
-          <a:p>
-            <a:pPr algn="ctr"/>
-            <a:r>
-              <a:rPr sz="1100" b="0" i="0" u="none">
-                <a:solidFill>
-                  <a:srgbClr val="333333"/>
-                </a:solidFill>
-                <a:latin typeface="Calibri"/>
-              </a:rPr>
-              <a:t>662</a:t>
-            </a:r>
-          </a:p>
-        </p:txBody>
-      </p:sp>
-      <p:sp>
-        <p:nvSpPr>
-          <p:cNvPr id="51" name="Rectangle 50"/>
-          <p:cNvSpPr/>
-          <p:nvPr/>
-        </p:nvSpPr>
-        <p:spPr>
-          <a:xfrm>
-            <a:off x="411480" y="3968496"/>
-            <a:ext cx="7635240" cy="315468"/>
+            <a:off x="411480" y="3616452"/>
+            <a:ext cx="7635240" cy="278892"/>
           </a:xfrm>
           <a:prstGeom prst="rect">
             <a:avLst/>
@@ -5012,14 +4793,14 @@
       </p:sp>
       <p:sp>
         <p:nvSpPr>
-          <p:cNvPr id="52" name="TextBox 51"/>
-          <p:cNvSpPr txBox="1"/>
-          <p:nvPr/>
-        </p:nvSpPr>
-        <p:spPr>
-          <a:xfrm>
-            <a:off x="521208" y="3968496"/>
-            <a:ext cx="2679192" cy="315468"/>
+          <p:cNvPr id="46" name="TextBox 45"/>
+          <p:cNvSpPr txBox="1"/>
+          <p:nvPr/>
+        </p:nvSpPr>
+        <p:spPr>
+          <a:xfrm>
+            <a:off x="521208" y="3616452"/>
+            <a:ext cx="2679192" cy="278892"/>
           </a:xfrm>
           <a:prstGeom prst="rect">
             <a:avLst/>
@@ -5040,21 +4821,21 @@
                 </a:solidFill>
                 <a:latin typeface="Calibri"/>
               </a:rPr>
-              <a:t>Keine BÜ</a:t>
-            </a:r>
-          </a:p>
-        </p:txBody>
-      </p:sp>
-      <p:sp>
-        <p:nvSpPr>
-          <p:cNvPr id="53" name="TextBox 52"/>
-          <p:cNvSpPr txBox="1"/>
-          <p:nvPr/>
-        </p:nvSpPr>
-        <p:spPr>
-          <a:xfrm>
-            <a:off x="3200400" y="3968496"/>
-            <a:ext cx="1234440" cy="315468"/>
+              <a:t>Keine BÜ (falscher Kanal)</a:t>
+            </a:r>
+          </a:p>
+        </p:txBody>
+      </p:sp>
+      <p:sp>
+        <p:nvSpPr>
+          <p:cNvPr id="47" name="TextBox 46"/>
+          <p:cNvSpPr txBox="1"/>
+          <p:nvPr/>
+        </p:nvSpPr>
+        <p:spPr>
+          <a:xfrm>
+            <a:off x="3200400" y="3616452"/>
+            <a:ext cx="1234440" cy="278892"/>
           </a:xfrm>
           <a:prstGeom prst="rect">
             <a:avLst/>
@@ -5082,14 +4863,14 @@
       </p:sp>
       <p:sp>
         <p:nvSpPr>
-          <p:cNvPr id="54" name="TextBox 53"/>
-          <p:cNvSpPr txBox="1"/>
-          <p:nvPr/>
-        </p:nvSpPr>
-        <p:spPr>
-          <a:xfrm>
-            <a:off x="4434840" y="3968496"/>
-            <a:ext cx="1188720" cy="315468"/>
+          <p:cNvPr id="48" name="TextBox 47"/>
+          <p:cNvSpPr txBox="1"/>
+          <p:nvPr/>
+        </p:nvSpPr>
+        <p:spPr>
+          <a:xfrm>
+            <a:off x="4434840" y="3616452"/>
+            <a:ext cx="1188720" cy="278892"/>
           </a:xfrm>
           <a:prstGeom prst="rect">
             <a:avLst/>
@@ -5117,14 +4898,14 @@
       </p:sp>
       <p:sp>
         <p:nvSpPr>
-          <p:cNvPr id="55" name="TextBox 54"/>
-          <p:cNvSpPr txBox="1"/>
-          <p:nvPr/>
-        </p:nvSpPr>
-        <p:spPr>
-          <a:xfrm>
-            <a:off x="5623560" y="3968496"/>
-            <a:ext cx="1371600" cy="315468"/>
+          <p:cNvPr id="49" name="TextBox 48"/>
+          <p:cNvSpPr txBox="1"/>
+          <p:nvPr/>
+        </p:nvSpPr>
+        <p:spPr>
+          <a:xfrm>
+            <a:off x="5623560" y="3616452"/>
+            <a:ext cx="1371600" cy="278892"/>
           </a:xfrm>
           <a:prstGeom prst="rect">
             <a:avLst/>
@@ -5152,14 +4933,14 @@
       </p:sp>
       <p:sp>
         <p:nvSpPr>
-          <p:cNvPr id="56" name="TextBox 55"/>
-          <p:cNvSpPr txBox="1"/>
-          <p:nvPr/>
-        </p:nvSpPr>
-        <p:spPr>
-          <a:xfrm>
-            <a:off x="6995160" y="3968496"/>
-            <a:ext cx="1051560" cy="315468"/>
+          <p:cNvPr id="50" name="TextBox 49"/>
+          <p:cNvSpPr txBox="1"/>
+          <p:nvPr/>
+        </p:nvSpPr>
+        <p:spPr>
+          <a:xfrm>
+            <a:off x="6995160" y="3616452"/>
+            <a:ext cx="1051560" cy="278892"/>
           </a:xfrm>
           <a:prstGeom prst="rect">
             <a:avLst/>
@@ -5187,14 +4968,14 @@
       </p:sp>
       <p:sp>
         <p:nvSpPr>
-          <p:cNvPr id="57" name="Rectangle 56"/>
+          <p:cNvPr id="51" name="Rectangle 50"/>
           <p:cNvSpPr/>
           <p:nvPr/>
         </p:nvSpPr>
         <p:spPr>
           <a:xfrm>
-            <a:off x="411480" y="4283964"/>
-            <a:ext cx="7635240" cy="315468"/>
+            <a:off x="411480" y="3895344"/>
+            <a:ext cx="7635240" cy="278892"/>
           </a:xfrm>
           <a:prstGeom prst="rect">
             <a:avLst/>
@@ -5231,14 +5012,14 @@
       </p:sp>
       <p:sp>
         <p:nvSpPr>
-          <p:cNvPr id="58" name="Rectangle 57"/>
+          <p:cNvPr id="52" name="Rectangle 51"/>
           <p:cNvSpPr/>
           <p:nvPr/>
         </p:nvSpPr>
         <p:spPr>
           <a:xfrm>
-            <a:off x="411480" y="4283964"/>
-            <a:ext cx="91440" cy="315468"/>
+            <a:off x="411480" y="3895344"/>
+            <a:ext cx="91440" cy="278892"/>
           </a:xfrm>
           <a:prstGeom prst="rect">
             <a:avLst/>
@@ -5275,14 +5056,14 @@
       </p:sp>
       <p:sp>
         <p:nvSpPr>
-          <p:cNvPr id="59" name="TextBox 58"/>
-          <p:cNvSpPr txBox="1"/>
-          <p:nvPr/>
-        </p:nvSpPr>
-        <p:spPr>
-          <a:xfrm>
-            <a:off x="521208" y="4283964"/>
-            <a:ext cx="2679192" cy="315468"/>
+          <p:cNvPr id="53" name="TextBox 52"/>
+          <p:cNvSpPr txBox="1"/>
+          <p:nvPr/>
+        </p:nvSpPr>
+        <p:spPr>
+          <a:xfrm>
+            <a:off x="521208" y="3895344"/>
+            <a:ext cx="2679192" cy="278892"/>
           </a:xfrm>
           <a:prstGeom prst="rect">
             <a:avLst/>
@@ -5310,14 +5091,14 @@
       </p:sp>
       <p:sp>
         <p:nvSpPr>
-          <p:cNvPr id="60" name="TextBox 59"/>
-          <p:cNvSpPr txBox="1"/>
-          <p:nvPr/>
-        </p:nvSpPr>
-        <p:spPr>
-          <a:xfrm>
-            <a:off x="3200400" y="4283964"/>
-            <a:ext cx="1234440" cy="315468"/>
+          <p:cNvPr id="54" name="TextBox 53"/>
+          <p:cNvSpPr txBox="1"/>
+          <p:nvPr/>
+        </p:nvSpPr>
+        <p:spPr>
+          <a:xfrm>
+            <a:off x="3200400" y="3895344"/>
+            <a:ext cx="1234440" cy="278892"/>
           </a:xfrm>
           <a:prstGeom prst="rect">
             <a:avLst/>
@@ -5345,14 +5126,14 @@
       </p:sp>
       <p:sp>
         <p:nvSpPr>
-          <p:cNvPr id="61" name="TextBox 60"/>
-          <p:cNvSpPr txBox="1"/>
-          <p:nvPr/>
-        </p:nvSpPr>
-        <p:spPr>
-          <a:xfrm>
-            <a:off x="4434840" y="4283964"/>
-            <a:ext cx="1188720" cy="315468"/>
+          <p:cNvPr id="55" name="TextBox 54"/>
+          <p:cNvSpPr txBox="1"/>
+          <p:nvPr/>
+        </p:nvSpPr>
+        <p:spPr>
+          <a:xfrm>
+            <a:off x="4434840" y="3895344"/>
+            <a:ext cx="1188720" cy="278892"/>
           </a:xfrm>
           <a:prstGeom prst="rect">
             <a:avLst/>
@@ -5380,14 +5161,14 @@
       </p:sp>
       <p:sp>
         <p:nvSpPr>
-          <p:cNvPr id="62" name="TextBox 61"/>
-          <p:cNvSpPr txBox="1"/>
-          <p:nvPr/>
-        </p:nvSpPr>
-        <p:spPr>
-          <a:xfrm>
-            <a:off x="5623560" y="4283964"/>
-            <a:ext cx="1371600" cy="315468"/>
+          <p:cNvPr id="56" name="TextBox 55"/>
+          <p:cNvSpPr txBox="1"/>
+          <p:nvPr/>
+        </p:nvSpPr>
+        <p:spPr>
+          <a:xfrm>
+            <a:off x="5623560" y="3895344"/>
+            <a:ext cx="1371600" cy="278892"/>
           </a:xfrm>
           <a:prstGeom prst="rect">
             <a:avLst/>
@@ -5415,14 +5196,14 @@
       </p:sp>
       <p:sp>
         <p:nvSpPr>
-          <p:cNvPr id="63" name="TextBox 62"/>
-          <p:cNvSpPr txBox="1"/>
-          <p:nvPr/>
-        </p:nvSpPr>
-        <p:spPr>
-          <a:xfrm>
-            <a:off x="6995160" y="4283964"/>
-            <a:ext cx="1051560" cy="315468"/>
+          <p:cNvPr id="57" name="TextBox 56"/>
+          <p:cNvSpPr txBox="1"/>
+          <p:nvPr/>
+        </p:nvSpPr>
+        <p:spPr>
+          <a:xfrm>
+            <a:off x="6995160" y="3895344"/>
+            <a:ext cx="1051560" cy="278892"/>
           </a:xfrm>
           <a:prstGeom prst="rect">
             <a:avLst/>
@@ -5450,14 +5231,14 @@
       </p:sp>
       <p:sp>
         <p:nvSpPr>
-          <p:cNvPr id="64" name="Rectangle 63"/>
+          <p:cNvPr id="58" name="Rectangle 57"/>
           <p:cNvSpPr/>
           <p:nvPr/>
         </p:nvSpPr>
         <p:spPr>
           <a:xfrm>
-            <a:off x="411480" y="4599432"/>
-            <a:ext cx="7635240" cy="315468"/>
+            <a:off x="411480" y="4174236"/>
+            <a:ext cx="7635240" cy="278892"/>
           </a:xfrm>
           <a:prstGeom prst="rect">
             <a:avLst/>
@@ -5494,14 +5275,14 @@
       </p:sp>
       <p:sp>
         <p:nvSpPr>
-          <p:cNvPr id="65" name="TextBox 64"/>
-          <p:cNvSpPr txBox="1"/>
-          <p:nvPr/>
-        </p:nvSpPr>
-        <p:spPr>
-          <a:xfrm>
-            <a:off x="521208" y="4599432"/>
-            <a:ext cx="2679192" cy="315468"/>
+          <p:cNvPr id="59" name="TextBox 58"/>
+          <p:cNvSpPr txBox="1"/>
+          <p:nvPr/>
+        </p:nvSpPr>
+        <p:spPr>
+          <a:xfrm>
+            <a:off x="521208" y="4174236"/>
+            <a:ext cx="2679192" cy="278892"/>
           </a:xfrm>
           <a:prstGeom prst="rect">
             <a:avLst/>
@@ -5529,14 +5310,14 @@
       </p:sp>
       <p:sp>
         <p:nvSpPr>
-          <p:cNvPr id="66" name="TextBox 65"/>
-          <p:cNvSpPr txBox="1"/>
-          <p:nvPr/>
-        </p:nvSpPr>
-        <p:spPr>
-          <a:xfrm>
-            <a:off x="3200400" y="4599432"/>
-            <a:ext cx="1234440" cy="315468"/>
+          <p:cNvPr id="60" name="TextBox 59"/>
+          <p:cNvSpPr txBox="1"/>
+          <p:nvPr/>
+        </p:nvSpPr>
+        <p:spPr>
+          <a:xfrm>
+            <a:off x="3200400" y="4174236"/>
+            <a:ext cx="1234440" cy="278892"/>
           </a:xfrm>
           <a:prstGeom prst="rect">
             <a:avLst/>
@@ -5564,14 +5345,14 @@
       </p:sp>
       <p:sp>
         <p:nvSpPr>
-          <p:cNvPr id="67" name="TextBox 66"/>
-          <p:cNvSpPr txBox="1"/>
-          <p:nvPr/>
-        </p:nvSpPr>
-        <p:spPr>
-          <a:xfrm>
-            <a:off x="4434840" y="4599432"/>
-            <a:ext cx="1188720" cy="315468"/>
+          <p:cNvPr id="61" name="TextBox 60"/>
+          <p:cNvSpPr txBox="1"/>
+          <p:nvPr/>
+        </p:nvSpPr>
+        <p:spPr>
+          <a:xfrm>
+            <a:off x="4434840" y="4174236"/>
+            <a:ext cx="1188720" cy="278892"/>
           </a:xfrm>
           <a:prstGeom prst="rect">
             <a:avLst/>
@@ -5599,14 +5380,14 @@
       </p:sp>
       <p:sp>
         <p:nvSpPr>
-          <p:cNvPr id="68" name="TextBox 67"/>
-          <p:cNvSpPr txBox="1"/>
-          <p:nvPr/>
-        </p:nvSpPr>
-        <p:spPr>
-          <a:xfrm>
-            <a:off x="5623560" y="4599432"/>
-            <a:ext cx="1371600" cy="315468"/>
+          <p:cNvPr id="62" name="TextBox 61"/>
+          <p:cNvSpPr txBox="1"/>
+          <p:nvPr/>
+        </p:nvSpPr>
+        <p:spPr>
+          <a:xfrm>
+            <a:off x="5623560" y="4174236"/>
+            <a:ext cx="1371600" cy="278892"/>
           </a:xfrm>
           <a:prstGeom prst="rect">
             <a:avLst/>
@@ -5634,14 +5415,14 @@
       </p:sp>
       <p:sp>
         <p:nvSpPr>
-          <p:cNvPr id="69" name="TextBox 68"/>
-          <p:cNvSpPr txBox="1"/>
-          <p:nvPr/>
-        </p:nvSpPr>
-        <p:spPr>
-          <a:xfrm>
-            <a:off x="6995160" y="4599432"/>
-            <a:ext cx="1051560" cy="315468"/>
+          <p:cNvPr id="63" name="TextBox 62"/>
+          <p:cNvSpPr txBox="1"/>
+          <p:nvPr/>
+        </p:nvSpPr>
+        <p:spPr>
+          <a:xfrm>
+            <a:off x="6995160" y="4174236"/>
+            <a:ext cx="1051560" cy="278892"/>
           </a:xfrm>
           <a:prstGeom prst="rect">
             <a:avLst/>
@@ -5669,14 +5450,14 @@
       </p:sp>
       <p:sp>
         <p:nvSpPr>
-          <p:cNvPr id="70" name="Rectangle 69"/>
+          <p:cNvPr id="64" name="Rectangle 63"/>
           <p:cNvSpPr/>
           <p:nvPr/>
         </p:nvSpPr>
         <p:spPr>
           <a:xfrm>
-            <a:off x="411480" y="4914900"/>
-            <a:ext cx="7635240" cy="315468"/>
+            <a:off x="411480" y="4453128"/>
+            <a:ext cx="7635240" cy="278892"/>
           </a:xfrm>
           <a:prstGeom prst="rect">
             <a:avLst/>
@@ -5713,14 +5494,14 @@
       </p:sp>
       <p:sp>
         <p:nvSpPr>
-          <p:cNvPr id="71" name="Rectangle 70"/>
+          <p:cNvPr id="65" name="Rectangle 64"/>
           <p:cNvSpPr/>
           <p:nvPr/>
         </p:nvSpPr>
         <p:spPr>
           <a:xfrm>
-            <a:off x="411480" y="4914900"/>
-            <a:ext cx="91440" cy="315468"/>
+            <a:off x="411480" y="4453128"/>
+            <a:ext cx="91440" cy="278892"/>
           </a:xfrm>
           <a:prstGeom prst="rect">
             <a:avLst/>
@@ -5757,14 +5538,14 @@
       </p:sp>
       <p:sp>
         <p:nvSpPr>
-          <p:cNvPr id="72" name="TextBox 71"/>
-          <p:cNvSpPr txBox="1"/>
-          <p:nvPr/>
-        </p:nvSpPr>
-        <p:spPr>
-          <a:xfrm>
-            <a:off x="521208" y="4914900"/>
-            <a:ext cx="2679192" cy="315468"/>
+          <p:cNvPr id="66" name="TextBox 65"/>
+          <p:cNvSpPr txBox="1"/>
+          <p:nvPr/>
+        </p:nvSpPr>
+        <p:spPr>
+          <a:xfrm>
+            <a:off x="521208" y="4453128"/>
+            <a:ext cx="2679192" cy="278892"/>
           </a:xfrm>
           <a:prstGeom prst="rect">
             <a:avLst/>
@@ -5792,14 +5573,14 @@
       </p:sp>
       <p:sp>
         <p:nvSpPr>
-          <p:cNvPr id="73" name="TextBox 72"/>
-          <p:cNvSpPr txBox="1"/>
-          <p:nvPr/>
-        </p:nvSpPr>
-        <p:spPr>
-          <a:xfrm>
-            <a:off x="3200400" y="4914900"/>
-            <a:ext cx="1234440" cy="315468"/>
+          <p:cNvPr id="67" name="TextBox 66"/>
+          <p:cNvSpPr txBox="1"/>
+          <p:nvPr/>
+        </p:nvSpPr>
+        <p:spPr>
+          <a:xfrm>
+            <a:off x="3200400" y="4453128"/>
+            <a:ext cx="1234440" cy="278892"/>
           </a:xfrm>
           <a:prstGeom prst="rect">
             <a:avLst/>
@@ -5827,14 +5608,14 @@
       </p:sp>
       <p:sp>
         <p:nvSpPr>
-          <p:cNvPr id="74" name="TextBox 73"/>
-          <p:cNvSpPr txBox="1"/>
-          <p:nvPr/>
-        </p:nvSpPr>
-        <p:spPr>
-          <a:xfrm>
-            <a:off x="4434840" y="4914900"/>
-            <a:ext cx="1188720" cy="315468"/>
+          <p:cNvPr id="68" name="TextBox 67"/>
+          <p:cNvSpPr txBox="1"/>
+          <p:nvPr/>
+        </p:nvSpPr>
+        <p:spPr>
+          <a:xfrm>
+            <a:off x="4434840" y="4453128"/>
+            <a:ext cx="1188720" cy="278892"/>
           </a:xfrm>
           <a:prstGeom prst="rect">
             <a:avLst/>
@@ -5862,14 +5643,14 @@
       </p:sp>
       <p:sp>
         <p:nvSpPr>
-          <p:cNvPr id="75" name="TextBox 74"/>
-          <p:cNvSpPr txBox="1"/>
-          <p:nvPr/>
-        </p:nvSpPr>
-        <p:spPr>
-          <a:xfrm>
-            <a:off x="5623560" y="4914900"/>
-            <a:ext cx="1371600" cy="315468"/>
+          <p:cNvPr id="69" name="TextBox 68"/>
+          <p:cNvSpPr txBox="1"/>
+          <p:nvPr/>
+        </p:nvSpPr>
+        <p:spPr>
+          <a:xfrm>
+            <a:off x="5623560" y="4453128"/>
+            <a:ext cx="1371600" cy="278892"/>
           </a:xfrm>
           <a:prstGeom prst="rect">
             <a:avLst/>
@@ -5897,14 +5678,14 @@
       </p:sp>
       <p:sp>
         <p:nvSpPr>
-          <p:cNvPr id="76" name="TextBox 75"/>
-          <p:cNvSpPr txBox="1"/>
-          <p:nvPr/>
-        </p:nvSpPr>
-        <p:spPr>
-          <a:xfrm>
-            <a:off x="6995160" y="4914900"/>
-            <a:ext cx="1051560" cy="315468"/>
+          <p:cNvPr id="70" name="TextBox 69"/>
+          <p:cNvSpPr txBox="1"/>
+          <p:nvPr/>
+        </p:nvSpPr>
+        <p:spPr>
+          <a:xfrm>
+            <a:off x="6995160" y="4453128"/>
+            <a:ext cx="1051560" cy="278892"/>
           </a:xfrm>
           <a:prstGeom prst="rect">
             <a:avLst/>
@@ -5932,211 +5713,14 @@
       </p:sp>
       <p:sp>
         <p:nvSpPr>
-          <p:cNvPr id="77" name="TextBox 76"/>
-          <p:cNvSpPr txBox="1"/>
-          <p:nvPr/>
-        </p:nvSpPr>
-        <p:spPr>
-          <a:xfrm>
-            <a:off x="411480" y="5248656"/>
-            <a:ext cx="7635240" cy="256032"/>
-          </a:xfrm>
-          <a:prstGeom prst="rect">
-            <a:avLst/>
-          </a:prstGeom>
-          <a:noFill/>
-        </p:spPr>
-        <p:txBody>
-          <a:bodyPr wrap="square" lIns="36000" rIns="36000" tIns="18000" bIns="18000" anchor="t">
-            <a:spAutoFit/>
-          </a:bodyPr>
-          <a:lstStyle/>
-          <a:p>
-            <a:pPr algn="l"/>
-            <a:r>
-              <a:rPr sz="900" b="0" i="1" u="none">
-                <a:solidFill>
-                  <a:srgbClr val="666666"/>
-                </a:solidFill>
-                <a:latin typeface="Calibri"/>
-              </a:rPr>
-              <a:t>* MV im Anhang ohne neue BÜ = potentielles Falschrouting (Regel 'MV → BÜ-Vorgang'). Summe 240 Mails / Woche → Hebel 1 (Folie 11a).</a:t>
-            </a:r>
-          </a:p>
-        </p:txBody>
-      </p:sp>
-      <p:sp>
-        <p:nvSpPr>
-          <p:cNvPr id="78" name="Rectangle 77"/>
+          <p:cNvPr id="71" name="Rectangle 70"/>
           <p:cNvSpPr/>
           <p:nvPr/>
         </p:nvSpPr>
         <p:spPr>
           <a:xfrm>
-            <a:off x="411480" y="5541264"/>
-            <a:ext cx="3726180" cy="457200"/>
-          </a:xfrm>
-          <a:prstGeom prst="rect">
-            <a:avLst/>
-          </a:prstGeom>
-          <a:solidFill>
-            <a:srgbClr val="FDE2C4"/>
-          </a:solidFill>
-          <a:ln w="12700">
-            <a:solidFill>
-              <a:srgbClr val="C86E10"/>
-            </a:solidFill>
-          </a:ln>
-          <a:effectLst/>
-        </p:spPr>
-        <p:style>
-          <a:lnRef idx="1">
-            <a:schemeClr val="accent1"/>
-          </a:lnRef>
-          <a:fillRef idx="3">
-            <a:schemeClr val="accent1"/>
-          </a:fillRef>
-          <a:effectRef idx="2">
-            <a:schemeClr val="accent1"/>
-          </a:effectRef>
-          <a:fontRef idx="minor">
-            <a:schemeClr val="lt1"/>
-          </a:fontRef>
-        </p:style>
-        <p:txBody>
-          <a:bodyPr rtlCol="0" anchor="ctr"/>
-          <a:lstStyle/>
-          <a:p>
-            <a:pPr algn="ctr"/>
-          </a:p>
-        </p:txBody>
-      </p:sp>
-      <p:sp>
-        <p:nvSpPr>
-          <p:cNvPr id="79" name="TextBox 78"/>
-          <p:cNvSpPr txBox="1"/>
-          <p:nvPr/>
-        </p:nvSpPr>
-        <p:spPr>
-          <a:xfrm>
-            <a:off x="521208" y="5541264"/>
-            <a:ext cx="3543300" cy="457200"/>
-          </a:xfrm>
-          <a:prstGeom prst="rect">
-            <a:avLst/>
-          </a:prstGeom>
-          <a:noFill/>
-        </p:spPr>
-        <p:txBody>
-          <a:bodyPr wrap="square" lIns="36000" rIns="36000" tIns="18000" bIns="18000" anchor="ctr">
-            <a:spAutoFit/>
-          </a:bodyPr>
-          <a:lstStyle/>
-          <a:p>
-            <a:pPr algn="l"/>
-            <a:r>
-              <a:rPr sz="1100" b="1" i="0" u="none">
-                <a:solidFill>
-                  <a:srgbClr val="9C060F"/>
-                </a:solidFill>
-                <a:latin typeface="Calibri"/>
-              </a:rPr>
-              <a:t>HEBEL 1: Routing – 240 MV-Fehlrouter (11a)</a:t>
-            </a:r>
-          </a:p>
-        </p:txBody>
-      </p:sp>
-      <p:sp>
-        <p:nvSpPr>
-          <p:cNvPr id="80" name="Rectangle 79"/>
-          <p:cNvSpPr/>
-          <p:nvPr/>
-        </p:nvSpPr>
-        <p:spPr>
-          <a:xfrm>
-            <a:off x="4320540" y="5541264"/>
-            <a:ext cx="3726180" cy="457200"/>
-          </a:xfrm>
-          <a:prstGeom prst="rect">
-            <a:avLst/>
-          </a:prstGeom>
-          <a:solidFill>
-            <a:srgbClr val="CFE6E9"/>
-          </a:solidFill>
-          <a:ln w="12700">
-            <a:solidFill>
-              <a:srgbClr val="008793"/>
-            </a:solidFill>
-          </a:ln>
-          <a:effectLst/>
-        </p:spPr>
-        <p:style>
-          <a:lnRef idx="1">
-            <a:schemeClr val="accent1"/>
-          </a:lnRef>
-          <a:fillRef idx="3">
-            <a:schemeClr val="accent1"/>
-          </a:fillRef>
-          <a:effectRef idx="2">
-            <a:schemeClr val="accent1"/>
-          </a:effectRef>
-          <a:fontRef idx="minor">
-            <a:schemeClr val="lt1"/>
-          </a:fontRef>
-        </p:style>
-        <p:txBody>
-          <a:bodyPr rtlCol="0" anchor="ctr"/>
-          <a:lstStyle/>
-          <a:p>
-            <a:pPr algn="ctr"/>
-          </a:p>
-        </p:txBody>
-      </p:sp>
-      <p:sp>
-        <p:nvSpPr>
-          <p:cNvPr id="81" name="TextBox 80"/>
-          <p:cNvSpPr txBox="1"/>
-          <p:nvPr/>
-        </p:nvSpPr>
-        <p:spPr>
-          <a:xfrm>
-            <a:off x="4430268" y="5541264"/>
-            <a:ext cx="3543300" cy="457200"/>
-          </a:xfrm>
-          <a:prstGeom prst="rect">
-            <a:avLst/>
-          </a:prstGeom>
-          <a:noFill/>
-        </p:spPr>
-        <p:txBody>
-          <a:bodyPr wrap="square" lIns="36000" rIns="36000" tIns="18000" bIns="18000" anchor="ctr">
-            <a:spAutoFit/>
-          </a:bodyPr>
-          <a:lstStyle/>
-          <a:p>
-            <a:pPr algn="l"/>
-            <a:r>
-              <a:rPr sz="1100" b="1" i="0" u="none">
-                <a:solidFill>
-                  <a:srgbClr val="006B77"/>
-                </a:solidFill>
-                <a:latin typeface="Calibri"/>
-              </a:rPr>
-              <a:t>HEBEL 2: Clustering / Steuerung (11b)</a:t>
-            </a:r>
-          </a:p>
-        </p:txBody>
-      </p:sp>
-      <p:sp>
-        <p:nvSpPr>
-          <p:cNvPr id="82" name="Rectangle 81"/>
-          <p:cNvSpPr/>
-          <p:nvPr/>
-        </p:nvSpPr>
-        <p:spPr>
-          <a:xfrm>
-            <a:off x="8229600" y="2240280"/>
-            <a:ext cx="3611880" cy="3611880"/>
+            <a:off x="411480" y="4732020"/>
+            <a:ext cx="7635240" cy="278892"/>
           </a:xfrm>
           <a:prstGeom prst="rect">
             <a:avLst/>
@@ -6173,16 +5757,16 @@
       </p:sp>
       <p:sp>
         <p:nvSpPr>
-          <p:cNvPr id="83" name="Oval 82"/>
+          <p:cNvPr id="72" name="Rectangle 71"/>
           <p:cNvSpPr/>
           <p:nvPr/>
         </p:nvSpPr>
         <p:spPr>
           <a:xfrm>
-            <a:off x="8366760" y="2450592"/>
-            <a:ext cx="384048" cy="384048"/>
-          </a:xfrm>
-          <a:prstGeom prst="ellipse">
+            <a:off x="411480" y="4732020"/>
+            <a:ext cx="91440" cy="278892"/>
+          </a:xfrm>
+          <a:prstGeom prst="rect">
             <a:avLst/>
           </a:prstGeom>
           <a:solidFill>
@@ -6217,92 +5801,705 @@
       </p:sp>
       <p:sp>
         <p:nvSpPr>
-          <p:cNvPr id="84" name="TextBox 83"/>
-          <p:cNvSpPr txBox="1"/>
+          <p:cNvPr id="73" name="TextBox 72"/>
+          <p:cNvSpPr txBox="1"/>
+          <p:nvPr/>
+        </p:nvSpPr>
+        <p:spPr>
+          <a:xfrm>
+            <a:off x="521208" y="4732020"/>
+            <a:ext cx="2679192" cy="278892"/>
+          </a:xfrm>
+          <a:prstGeom prst="rect">
+            <a:avLst/>
+          </a:prstGeom>
+          <a:noFill/>
+        </p:spPr>
+        <p:txBody>
+          <a:bodyPr wrap="square" lIns="36000" rIns="36000" tIns="18000" bIns="18000" anchor="ctr">
+            <a:spAutoFit/>
+          </a:bodyPr>
+          <a:lstStyle/>
+          <a:p>
+            <a:pPr algn="l"/>
+            <a:r>
+              <a:rPr sz="1100" b="1" i="0" u="none">
+                <a:solidFill>
+                  <a:srgbClr val="006B77"/>
+                </a:solidFill>
+                <a:latin typeface="Calibri"/>
+              </a:rPr>
+              <a:t>Neue BÜ (echte BÜ-Anfragen)</a:t>
+            </a:r>
+          </a:p>
+        </p:txBody>
+      </p:sp>
+      <p:sp>
+        <p:nvSpPr>
+          <p:cNvPr id="74" name="TextBox 73"/>
+          <p:cNvSpPr txBox="1"/>
+          <p:nvPr/>
+        </p:nvSpPr>
+        <p:spPr>
+          <a:xfrm>
+            <a:off x="3200400" y="4732020"/>
+            <a:ext cx="1234440" cy="278892"/>
+          </a:xfrm>
+          <a:prstGeom prst="rect">
+            <a:avLst/>
+          </a:prstGeom>
+          <a:noFill/>
+        </p:spPr>
+        <p:txBody>
+          <a:bodyPr wrap="square" lIns="36000" rIns="36000" tIns="18000" bIns="18000" anchor="ctr">
+            <a:spAutoFit/>
+          </a:bodyPr>
+          <a:lstStyle/>
+          <a:p>
+            <a:pPr algn="ctr"/>
+            <a:r>
+              <a:rPr sz="1100" b="1" i="0" u="none">
+                <a:solidFill>
+                  <a:srgbClr val="006B77"/>
+                </a:solidFill>
+                <a:latin typeface="Calibri"/>
+              </a:rPr>
+              <a:t>4.000</a:t>
+            </a:r>
+          </a:p>
+        </p:txBody>
+      </p:sp>
+      <p:sp>
+        <p:nvSpPr>
+          <p:cNvPr id="75" name="TextBox 74"/>
+          <p:cNvSpPr txBox="1"/>
+          <p:nvPr/>
+        </p:nvSpPr>
+        <p:spPr>
+          <a:xfrm>
+            <a:off x="4434840" y="4732020"/>
+            <a:ext cx="1188720" cy="278892"/>
+          </a:xfrm>
+          <a:prstGeom prst="rect">
+            <a:avLst/>
+          </a:prstGeom>
+          <a:noFill/>
+        </p:spPr>
+        <p:txBody>
+          <a:bodyPr wrap="square" lIns="36000" rIns="36000" tIns="18000" bIns="18000" anchor="ctr">
+            <a:spAutoFit/>
+          </a:bodyPr>
+          <a:lstStyle/>
+          <a:p>
+            <a:pPr algn="ctr"/>
+            <a:r>
+              <a:rPr sz="1100" b="1" i="0" u="none">
+                <a:solidFill>
+                  <a:srgbClr val="006B77"/>
+                </a:solidFill>
+                <a:latin typeface="Calibri"/>
+              </a:rPr>
+              <a:t>1.147</a:t>
+            </a:r>
+          </a:p>
+        </p:txBody>
+      </p:sp>
+      <p:sp>
+        <p:nvSpPr>
+          <p:cNvPr id="76" name="TextBox 75"/>
+          <p:cNvSpPr txBox="1"/>
+          <p:nvPr/>
+        </p:nvSpPr>
+        <p:spPr>
+          <a:xfrm>
+            <a:off x="5623560" y="4732020"/>
+            <a:ext cx="1371600" cy="278892"/>
+          </a:xfrm>
+          <a:prstGeom prst="rect">
+            <a:avLst/>
+          </a:prstGeom>
+          <a:noFill/>
+        </p:spPr>
+        <p:txBody>
+          <a:bodyPr wrap="square" lIns="36000" rIns="36000" tIns="18000" bIns="18000" anchor="ctr">
+            <a:spAutoFit/>
+          </a:bodyPr>
+          <a:lstStyle/>
+          <a:p>
+            <a:pPr algn="ctr"/>
+            <a:r>
+              <a:rPr sz="1100" b="1" i="0" u="none">
+                <a:solidFill>
+                  <a:srgbClr val="006B77"/>
+                </a:solidFill>
+                <a:latin typeface="Calibri"/>
+              </a:rPr>
+              <a:t>2.089</a:t>
+            </a:r>
+          </a:p>
+        </p:txBody>
+      </p:sp>
+      <p:sp>
+        <p:nvSpPr>
+          <p:cNvPr id="77" name="TextBox 76"/>
+          <p:cNvSpPr txBox="1"/>
+          <p:nvPr/>
+        </p:nvSpPr>
+        <p:spPr>
+          <a:xfrm>
+            <a:off x="6995160" y="4732020"/>
+            <a:ext cx="1051560" cy="278892"/>
+          </a:xfrm>
+          <a:prstGeom prst="rect">
+            <a:avLst/>
+          </a:prstGeom>
+          <a:noFill/>
+        </p:spPr>
+        <p:txBody>
+          <a:bodyPr wrap="square" lIns="36000" rIns="36000" tIns="18000" bIns="18000" anchor="ctr">
+            <a:spAutoFit/>
+          </a:bodyPr>
+          <a:lstStyle/>
+          <a:p>
+            <a:pPr algn="ctr"/>
+            <a:r>
+              <a:rPr sz="1100" b="1" i="0" u="none">
+                <a:solidFill>
+                  <a:srgbClr val="006B77"/>
+                </a:solidFill>
+                <a:latin typeface="Calibri"/>
+              </a:rPr>
+              <a:t>662</a:t>
+            </a:r>
+          </a:p>
+        </p:txBody>
+      </p:sp>
+      <p:sp>
+        <p:nvSpPr>
+          <p:cNvPr id="78" name="Rectangle 77"/>
+          <p:cNvSpPr/>
+          <p:nvPr/>
+        </p:nvSpPr>
+        <p:spPr>
+          <a:xfrm>
+            <a:off x="411480" y="5010912"/>
+            <a:ext cx="7635240" cy="278892"/>
+          </a:xfrm>
+          <a:prstGeom prst="rect">
+            <a:avLst/>
+          </a:prstGeom>
+          <a:solidFill>
+            <a:srgbClr val="F3F6F7"/>
+          </a:solidFill>
+          <a:ln>
+            <a:noFill/>
+          </a:ln>
+          <a:effectLst/>
+        </p:spPr>
+        <p:style>
+          <a:lnRef idx="1">
+            <a:schemeClr val="accent1"/>
+          </a:lnRef>
+          <a:fillRef idx="3">
+            <a:schemeClr val="accent1"/>
+          </a:fillRef>
+          <a:effectRef idx="2">
+            <a:schemeClr val="accent1"/>
+          </a:effectRef>
+          <a:fontRef idx="minor">
+            <a:schemeClr val="lt1"/>
+          </a:fontRef>
+        </p:style>
+        <p:txBody>
+          <a:bodyPr rtlCol="0" anchor="ctr"/>
+          <a:lstStyle/>
+          <a:p>
+            <a:pPr algn="ctr"/>
+          </a:p>
+        </p:txBody>
+      </p:sp>
+      <p:sp>
+        <p:nvSpPr>
+          <p:cNvPr id="79" name="TextBox 78"/>
+          <p:cNvSpPr txBox="1"/>
+          <p:nvPr/>
+        </p:nvSpPr>
+        <p:spPr>
+          <a:xfrm>
+            <a:off x="521208" y="5010912"/>
+            <a:ext cx="2679192" cy="278892"/>
+          </a:xfrm>
+          <a:prstGeom prst="rect">
+            <a:avLst/>
+          </a:prstGeom>
+          <a:noFill/>
+        </p:spPr>
+        <p:txBody>
+          <a:bodyPr wrap="square" lIns="36000" rIns="36000" tIns="18000" bIns="18000" anchor="ctr">
+            <a:spAutoFit/>
+          </a:bodyPr>
+          <a:lstStyle/>
+          <a:p>
+            <a:pPr algn="l"/>
+            <a:r>
+              <a:rPr sz="1000" b="0" i="1" u="none">
+                <a:solidFill>
+                  <a:srgbClr val="666666"/>
+                </a:solidFill>
+                <a:latin typeface="Calibri"/>
+              </a:rPr>
+              <a:t>Anteil Top-5-Makler</a:t>
+            </a:r>
+          </a:p>
+        </p:txBody>
+      </p:sp>
+      <p:sp>
+        <p:nvSpPr>
+          <p:cNvPr id="80" name="TextBox 79"/>
+          <p:cNvSpPr txBox="1"/>
+          <p:nvPr/>
+        </p:nvSpPr>
+        <p:spPr>
+          <a:xfrm>
+            <a:off x="3200400" y="5010912"/>
+            <a:ext cx="1234440" cy="278892"/>
+          </a:xfrm>
+          <a:prstGeom prst="rect">
+            <a:avLst/>
+          </a:prstGeom>
+          <a:noFill/>
+        </p:spPr>
+        <p:txBody>
+          <a:bodyPr wrap="square" lIns="36000" rIns="36000" tIns="18000" bIns="18000" anchor="ctr">
+            <a:spAutoFit/>
+          </a:bodyPr>
+          <a:lstStyle/>
+          <a:p>
+            <a:pPr algn="ctr"/>
+            <a:r>
+              <a:rPr sz="1100" b="1" i="1" u="none">
+                <a:solidFill>
+                  <a:srgbClr val="666666"/>
+                </a:solidFill>
+                <a:latin typeface="Calibri"/>
+              </a:rPr>
+              <a:t>57 %</a:t>
+            </a:r>
+          </a:p>
+        </p:txBody>
+      </p:sp>
+      <p:sp>
+        <p:nvSpPr>
+          <p:cNvPr id="81" name="TextBox 80"/>
+          <p:cNvSpPr txBox="1"/>
+          <p:nvPr/>
+        </p:nvSpPr>
+        <p:spPr>
+          <a:xfrm>
+            <a:off x="4434840" y="5010912"/>
+            <a:ext cx="1188720" cy="278892"/>
+          </a:xfrm>
+          <a:prstGeom prst="rect">
+            <a:avLst/>
+          </a:prstGeom>
+          <a:noFill/>
+        </p:spPr>
+        <p:txBody>
+          <a:bodyPr wrap="square" lIns="36000" rIns="36000" tIns="18000" bIns="18000" anchor="ctr">
+            <a:spAutoFit/>
+          </a:bodyPr>
+          <a:lstStyle/>
+          <a:p>
+            <a:pPr algn="ctr"/>
+            <a:r>
+              <a:rPr sz="1100" b="0" i="1" u="none">
+                <a:solidFill>
+                  <a:srgbClr val="666666"/>
+                </a:solidFill>
+                <a:latin typeface="Calibri"/>
+              </a:rPr>
+              <a:t>68 %</a:t>
+            </a:r>
+          </a:p>
+        </p:txBody>
+      </p:sp>
+      <p:sp>
+        <p:nvSpPr>
+          <p:cNvPr id="82" name="TextBox 81"/>
+          <p:cNvSpPr txBox="1"/>
+          <p:nvPr/>
+        </p:nvSpPr>
+        <p:spPr>
+          <a:xfrm>
+            <a:off x="5623560" y="5010912"/>
+            <a:ext cx="1371600" cy="278892"/>
+          </a:xfrm>
+          <a:prstGeom prst="rect">
+            <a:avLst/>
+          </a:prstGeom>
+          <a:noFill/>
+        </p:spPr>
+        <p:txBody>
+          <a:bodyPr wrap="square" lIns="36000" rIns="36000" tIns="18000" bIns="18000" anchor="ctr">
+            <a:spAutoFit/>
+          </a:bodyPr>
+          <a:lstStyle/>
+          <a:p>
+            <a:pPr algn="ctr"/>
+            <a:r>
+              <a:rPr sz="1100" b="0" i="1" u="none">
+                <a:solidFill>
+                  <a:srgbClr val="666666"/>
+                </a:solidFill>
+                <a:latin typeface="Calibri"/>
+              </a:rPr>
+              <a:t>60 %</a:t>
+            </a:r>
+          </a:p>
+        </p:txBody>
+      </p:sp>
+      <p:sp>
+        <p:nvSpPr>
+          <p:cNvPr id="83" name="TextBox 82"/>
+          <p:cNvSpPr txBox="1"/>
+          <p:nvPr/>
+        </p:nvSpPr>
+        <p:spPr>
+          <a:xfrm>
+            <a:off x="6995160" y="5010912"/>
+            <a:ext cx="1051560" cy="278892"/>
+          </a:xfrm>
+          <a:prstGeom prst="rect">
+            <a:avLst/>
+          </a:prstGeom>
+          <a:noFill/>
+        </p:spPr>
+        <p:txBody>
+          <a:bodyPr wrap="square" lIns="36000" rIns="36000" tIns="18000" bIns="18000" anchor="ctr">
+            <a:spAutoFit/>
+          </a:bodyPr>
+          <a:lstStyle/>
+          <a:p>
+            <a:pPr algn="ctr"/>
+            <a:r>
+              <a:rPr sz="1100" b="0" i="1" u="none">
+                <a:solidFill>
+                  <a:srgbClr val="666666"/>
+                </a:solidFill>
+                <a:latin typeface="Calibri"/>
+              </a:rPr>
+              <a:t>67 %</a:t>
+            </a:r>
+          </a:p>
+        </p:txBody>
+      </p:sp>
+      <p:sp>
+        <p:nvSpPr>
+          <p:cNvPr id="84" name="Rectangle 83"/>
+          <p:cNvSpPr/>
+          <p:nvPr/>
+        </p:nvSpPr>
+        <p:spPr>
+          <a:xfrm>
+            <a:off x="411480" y="5289804"/>
+            <a:ext cx="7635240" cy="278892"/>
+          </a:xfrm>
+          <a:prstGeom prst="rect">
+            <a:avLst/>
+          </a:prstGeom>
+          <a:solidFill>
+            <a:srgbClr val="F3F6F7"/>
+          </a:solidFill>
+          <a:ln>
+            <a:noFill/>
+          </a:ln>
+          <a:effectLst/>
+        </p:spPr>
+        <p:style>
+          <a:lnRef idx="1">
+            <a:schemeClr val="accent1"/>
+          </a:lnRef>
+          <a:fillRef idx="3">
+            <a:schemeClr val="accent1"/>
+          </a:fillRef>
+          <a:effectRef idx="2">
+            <a:schemeClr val="accent1"/>
+          </a:effectRef>
+          <a:fontRef idx="minor">
+            <a:schemeClr val="lt1"/>
+          </a:fontRef>
+        </p:style>
+        <p:txBody>
+          <a:bodyPr rtlCol="0" anchor="ctr"/>
+          <a:lstStyle/>
+          <a:p>
+            <a:pPr algn="ctr"/>
+          </a:p>
+        </p:txBody>
+      </p:sp>
+      <p:sp>
+        <p:nvSpPr>
+          <p:cNvPr id="85" name="TextBox 84"/>
+          <p:cNvSpPr txBox="1"/>
+          <p:nvPr/>
+        </p:nvSpPr>
+        <p:spPr>
+          <a:xfrm>
+            <a:off x="521208" y="5289804"/>
+            <a:ext cx="2679192" cy="278892"/>
+          </a:xfrm>
+          <a:prstGeom prst="rect">
+            <a:avLst/>
+          </a:prstGeom>
+          <a:noFill/>
+        </p:spPr>
+        <p:txBody>
+          <a:bodyPr wrap="square" lIns="36000" rIns="36000" tIns="18000" bIns="18000" anchor="ctr">
+            <a:spAutoFit/>
+          </a:bodyPr>
+          <a:lstStyle/>
+          <a:p>
+            <a:pPr algn="l"/>
+            <a:r>
+              <a:rPr sz="1000" b="0" i="1" u="none">
+                <a:solidFill>
+                  <a:srgbClr val="666666"/>
+                </a:solidFill>
+                <a:latin typeface="Calibri"/>
+              </a:rPr>
+              <a:t>Anteil in Cluster (weitere Mails Makler+Kunde)</a:t>
+            </a:r>
+          </a:p>
+        </p:txBody>
+      </p:sp>
+      <p:sp>
+        <p:nvSpPr>
+          <p:cNvPr id="86" name="TextBox 85"/>
+          <p:cNvSpPr txBox="1"/>
+          <p:nvPr/>
+        </p:nvSpPr>
+        <p:spPr>
+          <a:xfrm>
+            <a:off x="3200400" y="5289804"/>
+            <a:ext cx="1234440" cy="278892"/>
+          </a:xfrm>
+          <a:prstGeom prst="rect">
+            <a:avLst/>
+          </a:prstGeom>
+          <a:noFill/>
+        </p:spPr>
+        <p:txBody>
+          <a:bodyPr wrap="square" lIns="36000" rIns="36000" tIns="18000" bIns="18000" anchor="ctr">
+            <a:spAutoFit/>
+          </a:bodyPr>
+          <a:lstStyle/>
+          <a:p>
+            <a:pPr algn="ctr"/>
+            <a:r>
+              <a:rPr sz="1100" b="1" i="1" u="none">
+                <a:solidFill>
+                  <a:srgbClr val="666666"/>
+                </a:solidFill>
+                <a:latin typeface="Calibri"/>
+              </a:rPr>
+              <a:t>47 %</a:t>
+            </a:r>
+          </a:p>
+        </p:txBody>
+      </p:sp>
+      <p:sp>
+        <p:nvSpPr>
+          <p:cNvPr id="87" name="TextBox 86"/>
+          <p:cNvSpPr txBox="1"/>
+          <p:nvPr/>
+        </p:nvSpPr>
+        <p:spPr>
+          <a:xfrm>
+            <a:off x="4434840" y="5289804"/>
+            <a:ext cx="1188720" cy="278892"/>
+          </a:xfrm>
+          <a:prstGeom prst="rect">
+            <a:avLst/>
+          </a:prstGeom>
+          <a:noFill/>
+        </p:spPr>
+        <p:txBody>
+          <a:bodyPr wrap="square" lIns="36000" rIns="36000" tIns="18000" bIns="18000" anchor="ctr">
+            <a:spAutoFit/>
+          </a:bodyPr>
+          <a:lstStyle/>
+          <a:p>
+            <a:pPr algn="ctr"/>
+            <a:r>
+              <a:rPr sz="1100" b="0" i="1" u="none">
+                <a:solidFill>
+                  <a:srgbClr val="666666"/>
+                </a:solidFill>
+                <a:latin typeface="Calibri"/>
+              </a:rPr>
+              <a:t>31 %</a:t>
+            </a:r>
+          </a:p>
+        </p:txBody>
+      </p:sp>
+      <p:sp>
+        <p:nvSpPr>
+          <p:cNvPr id="88" name="TextBox 87"/>
+          <p:cNvSpPr txBox="1"/>
+          <p:nvPr/>
+        </p:nvSpPr>
+        <p:spPr>
+          <a:xfrm>
+            <a:off x="5623560" y="5289804"/>
+            <a:ext cx="1371600" cy="278892"/>
+          </a:xfrm>
+          <a:prstGeom prst="rect">
+            <a:avLst/>
+          </a:prstGeom>
+          <a:noFill/>
+        </p:spPr>
+        <p:txBody>
+          <a:bodyPr wrap="square" lIns="36000" rIns="36000" tIns="18000" bIns="18000" anchor="ctr">
+            <a:spAutoFit/>
+          </a:bodyPr>
+          <a:lstStyle/>
+          <a:p>
+            <a:pPr algn="ctr"/>
+            <a:r>
+              <a:rPr sz="1100" b="0" i="1" u="none">
+                <a:solidFill>
+                  <a:srgbClr val="666666"/>
+                </a:solidFill>
+                <a:latin typeface="Calibri"/>
+              </a:rPr>
+              <a:t>63 %</a:t>
+            </a:r>
+          </a:p>
+        </p:txBody>
+      </p:sp>
+      <p:sp>
+        <p:nvSpPr>
+          <p:cNvPr id="89" name="TextBox 88"/>
+          <p:cNvSpPr txBox="1"/>
+          <p:nvPr/>
+        </p:nvSpPr>
+        <p:spPr>
+          <a:xfrm>
+            <a:off x="6995160" y="5289804"/>
+            <a:ext cx="1051560" cy="278892"/>
+          </a:xfrm>
+          <a:prstGeom prst="rect">
+            <a:avLst/>
+          </a:prstGeom>
+          <a:noFill/>
+        </p:spPr>
+        <p:txBody>
+          <a:bodyPr wrap="square" lIns="36000" rIns="36000" tIns="18000" bIns="18000" anchor="ctr">
+            <a:spAutoFit/>
+          </a:bodyPr>
+          <a:lstStyle/>
+          <a:p>
+            <a:pPr algn="ctr"/>
+            <a:r>
+              <a:rPr sz="1100" b="0" i="1" u="none">
+                <a:solidFill>
+                  <a:srgbClr val="666666"/>
+                </a:solidFill>
+                <a:latin typeface="Calibri"/>
+              </a:rPr>
+              <a:t>47 %</a:t>
+            </a:r>
+          </a:p>
+        </p:txBody>
+      </p:sp>
+      <p:sp>
+        <p:nvSpPr>
+          <p:cNvPr id="90" name="TextBox 89"/>
+          <p:cNvSpPr txBox="1"/>
+          <p:nvPr/>
+        </p:nvSpPr>
+        <p:spPr>
+          <a:xfrm>
+            <a:off x="411480" y="5577840"/>
+            <a:ext cx="7635240" cy="237744"/>
+          </a:xfrm>
+          <a:prstGeom prst="rect">
+            <a:avLst/>
+          </a:prstGeom>
+          <a:noFill/>
+        </p:spPr>
+        <p:txBody>
+          <a:bodyPr wrap="square" lIns="36000" rIns="36000" tIns="18000" bIns="18000" anchor="t">
+            <a:spAutoFit/>
+          </a:bodyPr>
+          <a:lstStyle/>
+          <a:p>
+            <a:pPr algn="l"/>
+            <a:r>
+              <a:rPr sz="900" b="0" i="1" u="none">
+                <a:solidFill>
+                  <a:srgbClr val="666666"/>
+                </a:solidFill>
+                <a:latin typeface="Calibri"/>
+              </a:rPr>
+              <a:t>* MV im Anhang ohne neue BÜ = potentielles Falschrouting (240 / Wo → Hebel 1, 11a).  Cluster-Anteil &amp; Top-5-Makler → Hebel 2 (Arbeitsvorrats-Steuerung, 11b).</a:t>
+            </a:r>
+          </a:p>
+        </p:txBody>
+      </p:sp>
+      <p:sp>
+        <p:nvSpPr>
+          <p:cNvPr id="91" name="Rectangle 90"/>
+          <p:cNvSpPr/>
+          <p:nvPr/>
+        </p:nvSpPr>
+        <p:spPr>
+          <a:xfrm>
+            <a:off x="8229600" y="2240280"/>
+            <a:ext cx="3611880" cy="3611880"/>
+          </a:xfrm>
+          <a:prstGeom prst="rect">
+            <a:avLst/>
+          </a:prstGeom>
+          <a:solidFill>
+            <a:srgbClr val="CFE6E9"/>
+          </a:solidFill>
+          <a:ln>
+            <a:noFill/>
+          </a:ln>
+          <a:effectLst/>
+        </p:spPr>
+        <p:style>
+          <a:lnRef idx="1">
+            <a:schemeClr val="accent1"/>
+          </a:lnRef>
+          <a:fillRef idx="3">
+            <a:schemeClr val="accent1"/>
+          </a:fillRef>
+          <a:effectRef idx="2">
+            <a:schemeClr val="accent1"/>
+          </a:effectRef>
+          <a:fontRef idx="minor">
+            <a:schemeClr val="lt1"/>
+          </a:fontRef>
+        </p:style>
+        <p:txBody>
+          <a:bodyPr rtlCol="0" anchor="ctr"/>
+          <a:lstStyle/>
+          <a:p>
+            <a:pPr algn="ctr"/>
+          </a:p>
+        </p:txBody>
+      </p:sp>
+      <p:sp>
+        <p:nvSpPr>
+          <p:cNvPr id="92" name="Oval 91"/>
+          <p:cNvSpPr/>
           <p:nvPr/>
         </p:nvSpPr>
         <p:spPr>
           <a:xfrm>
             <a:off x="8366760" y="2450592"/>
-            <a:ext cx="384048" cy="384048"/>
-          </a:xfrm>
-          <a:prstGeom prst="rect">
-            <a:avLst/>
-          </a:prstGeom>
-          <a:noFill/>
-        </p:spPr>
-        <p:txBody>
-          <a:bodyPr wrap="square" lIns="36000" rIns="36000" tIns="18000" bIns="18000" anchor="ctr">
-            <a:spAutoFit/>
-          </a:bodyPr>
-          <a:lstStyle/>
-          <a:p>
-            <a:pPr algn="ctr"/>
-            <a:r>
-              <a:rPr sz="1500" b="1" i="0" u="none">
-                <a:solidFill>
-                  <a:srgbClr val="FFFFFF"/>
-                </a:solidFill>
-                <a:latin typeface="Calibri"/>
-              </a:rPr>
-              <a:t>1</a:t>
-            </a:r>
-          </a:p>
-        </p:txBody>
-      </p:sp>
-      <p:sp>
-        <p:nvSpPr>
-          <p:cNvPr id="85" name="TextBox 84"/>
-          <p:cNvSpPr txBox="1"/>
-          <p:nvPr/>
-        </p:nvSpPr>
-        <p:spPr>
-          <a:xfrm>
-            <a:off x="8869680" y="2404872"/>
-            <a:ext cx="2834640" cy="656539"/>
-          </a:xfrm>
-          <a:prstGeom prst="rect">
-            <a:avLst/>
-          </a:prstGeom>
-          <a:noFill/>
-        </p:spPr>
-        <p:txBody>
-          <a:bodyPr wrap="square" lIns="36000" rIns="36000" tIns="0" bIns="0">
-            <a:spAutoFit/>
-          </a:bodyPr>
-          <a:lstStyle/>
-          <a:p>
-            <a:pPr algn="l"/>
-            <a:r>
-              <a:rPr sz="1100" b="1">
-                <a:solidFill>
-                  <a:srgbClr val="333333"/>
-                </a:solidFill>
-                <a:latin typeface="Calibri"/>
-              </a:rPr>
-              <a:t>Mengengeruest 1 Woche: </a:t>
-            </a:r>
-            <a:r>
-              <a:rPr sz="1100">
-                <a:solidFill>
-                  <a:srgbClr val="333333"/>
-                </a:solidFill>
-                <a:latin typeface="Calibri"/>
-              </a:rPr>
-              <a:t>5.034 Mails, Vollerhebung 13.–20.04.2026; 94 % ueber ein Sammel-Postfach. Hochrechnung ~260.000 / Jahr.</a:t>
-            </a:r>
-          </a:p>
-        </p:txBody>
-      </p:sp>
-      <p:sp>
-        <p:nvSpPr>
-          <p:cNvPr id="86" name="Oval 85"/>
-          <p:cNvSpPr/>
-          <p:nvPr/>
-        </p:nvSpPr>
-        <p:spPr>
-          <a:xfrm>
-            <a:off x="8366760" y="3107131"/>
             <a:ext cx="384048" cy="384048"/>
           </a:xfrm>
           <a:prstGeom prst="ellipse">
@@ -6340,92 +6537,92 @@
       </p:sp>
       <p:sp>
         <p:nvSpPr>
-          <p:cNvPr id="87" name="TextBox 86"/>
-          <p:cNvSpPr txBox="1"/>
+          <p:cNvPr id="93" name="TextBox 92"/>
+          <p:cNvSpPr txBox="1"/>
+          <p:nvPr/>
+        </p:nvSpPr>
+        <p:spPr>
+          <a:xfrm>
+            <a:off x="8366760" y="2450592"/>
+            <a:ext cx="384048" cy="384048"/>
+          </a:xfrm>
+          <a:prstGeom prst="rect">
+            <a:avLst/>
+          </a:prstGeom>
+          <a:noFill/>
+        </p:spPr>
+        <p:txBody>
+          <a:bodyPr wrap="square" lIns="36000" rIns="36000" tIns="18000" bIns="18000" anchor="ctr">
+            <a:spAutoFit/>
+          </a:bodyPr>
+          <a:lstStyle/>
+          <a:p>
+            <a:pPr algn="ctr"/>
+            <a:r>
+              <a:rPr sz="1500" b="1" i="0" u="none">
+                <a:solidFill>
+                  <a:srgbClr val="FFFFFF"/>
+                </a:solidFill>
+                <a:latin typeface="Calibri"/>
+              </a:rPr>
+              <a:t>1</a:t>
+            </a:r>
+          </a:p>
+        </p:txBody>
+      </p:sp>
+      <p:sp>
+        <p:nvSpPr>
+          <p:cNvPr id="94" name="TextBox 93"/>
+          <p:cNvSpPr txBox="1"/>
+          <p:nvPr/>
+        </p:nvSpPr>
+        <p:spPr>
+          <a:xfrm>
+            <a:off x="8869680" y="2404872"/>
+            <a:ext cx="2834640" cy="656539"/>
+          </a:xfrm>
+          <a:prstGeom prst="rect">
+            <a:avLst/>
+          </a:prstGeom>
+          <a:noFill/>
+        </p:spPr>
+        <p:txBody>
+          <a:bodyPr wrap="square" lIns="36000" rIns="36000" tIns="0" bIns="0">
+            <a:spAutoFit/>
+          </a:bodyPr>
+          <a:lstStyle/>
+          <a:p>
+            <a:pPr algn="l"/>
+            <a:r>
+              <a:rPr sz="1100" b="1">
+                <a:solidFill>
+                  <a:srgbClr val="333333"/>
+                </a:solidFill>
+                <a:latin typeface="Calibri"/>
+              </a:rPr>
+              <a:t>Mengengeruest 1 Woche: </a:t>
+            </a:r>
+            <a:r>
+              <a:rPr sz="1100">
+                <a:solidFill>
+                  <a:srgbClr val="333333"/>
+                </a:solidFill>
+                <a:latin typeface="Calibri"/>
+              </a:rPr>
+              <a:t>5.034 Mails, Vollerhebung 13.–20.04.2026; 94 % ueber ein Sammel-Postfach. Hochrechnung ~260.000 / Jahr.</a:t>
+            </a:r>
+          </a:p>
+        </p:txBody>
+      </p:sp>
+      <p:sp>
+        <p:nvSpPr>
+          <p:cNvPr id="95" name="Oval 94"/>
+          <p:cNvSpPr/>
           <p:nvPr/>
         </p:nvSpPr>
         <p:spPr>
           <a:xfrm>
             <a:off x="8366760" y="3107131"/>
-            <a:ext cx="384048" cy="384048"/>
-          </a:xfrm>
-          <a:prstGeom prst="rect">
-            <a:avLst/>
-          </a:prstGeom>
-          <a:noFill/>
-        </p:spPr>
-        <p:txBody>
-          <a:bodyPr wrap="square" lIns="36000" rIns="36000" tIns="18000" bIns="18000" anchor="ctr">
-            <a:spAutoFit/>
-          </a:bodyPr>
-          <a:lstStyle/>
-          <a:p>
-            <a:pPr algn="ctr"/>
-            <a:r>
-              <a:rPr sz="1500" b="1" i="0" u="none">
-                <a:solidFill>
-                  <a:srgbClr val="FFFFFF"/>
-                </a:solidFill>
-                <a:latin typeface="Calibri"/>
-              </a:rPr>
-              <a:t>2</a:t>
-            </a:r>
-          </a:p>
-        </p:txBody>
-      </p:sp>
-      <p:sp>
-        <p:nvSpPr>
-          <p:cNvPr id="88" name="TextBox 87"/>
-          <p:cNvSpPr txBox="1"/>
-          <p:nvPr/>
-        </p:nvSpPr>
-        <p:spPr>
-          <a:xfrm>
-            <a:off x="8869680" y="3061411"/>
-            <a:ext cx="2834640" cy="656539"/>
-          </a:xfrm>
-          <a:prstGeom prst="rect">
-            <a:avLst/>
-          </a:prstGeom>
-          <a:noFill/>
-        </p:spPr>
-        <p:txBody>
-          <a:bodyPr wrap="square" lIns="36000" rIns="36000" tIns="0" bIns="0">
-            <a:spAutoFit/>
-          </a:bodyPr>
-          <a:lstStyle/>
-          <a:p>
-            <a:pPr algn="l"/>
-            <a:r>
-              <a:rPr sz="1100" b="1">
-                <a:solidFill>
-                  <a:srgbClr val="333333"/>
-                </a:solidFill>
-                <a:latin typeface="Calibri"/>
-              </a:rPr>
-              <a:t>Strukturierte Extraktion: </a:t>
-            </a:r>
-            <a:r>
-              <a:rPr sz="1100">
-                <a:solidFill>
-                  <a:srgbClr val="333333"/>
-                </a:solidFill>
-                <a:latin typeface="Calibri"/>
-              </a:rPr>
-              <a:t>KI erstellt je Mail ein Beiblatt mit 50 Feldern – VNR, Sparte, Pool, Status, Vorgangs-Cluster immer gleich.</a:t>
-            </a:r>
-          </a:p>
-        </p:txBody>
-      </p:sp>
-      <p:sp>
-        <p:nvSpPr>
-          <p:cNvPr id="89" name="Oval 88"/>
-          <p:cNvSpPr/>
-          <p:nvPr/>
-        </p:nvSpPr>
-        <p:spPr>
-          <a:xfrm>
-            <a:off x="8366760" y="3763670"/>
             <a:ext cx="384048" cy="384048"/>
           </a:xfrm>
           <a:prstGeom prst="ellipse">
@@ -6463,92 +6660,92 @@
       </p:sp>
       <p:sp>
         <p:nvSpPr>
-          <p:cNvPr id="90" name="TextBox 89"/>
-          <p:cNvSpPr txBox="1"/>
+          <p:cNvPr id="96" name="TextBox 95"/>
+          <p:cNvSpPr txBox="1"/>
+          <p:nvPr/>
+        </p:nvSpPr>
+        <p:spPr>
+          <a:xfrm>
+            <a:off x="8366760" y="3107131"/>
+            <a:ext cx="384048" cy="384048"/>
+          </a:xfrm>
+          <a:prstGeom prst="rect">
+            <a:avLst/>
+          </a:prstGeom>
+          <a:noFill/>
+        </p:spPr>
+        <p:txBody>
+          <a:bodyPr wrap="square" lIns="36000" rIns="36000" tIns="18000" bIns="18000" anchor="ctr">
+            <a:spAutoFit/>
+          </a:bodyPr>
+          <a:lstStyle/>
+          <a:p>
+            <a:pPr algn="ctr"/>
+            <a:r>
+              <a:rPr sz="1500" b="1" i="0" u="none">
+                <a:solidFill>
+                  <a:srgbClr val="FFFFFF"/>
+                </a:solidFill>
+                <a:latin typeface="Calibri"/>
+              </a:rPr>
+              <a:t>2</a:t>
+            </a:r>
+          </a:p>
+        </p:txBody>
+      </p:sp>
+      <p:sp>
+        <p:nvSpPr>
+          <p:cNvPr id="97" name="TextBox 96"/>
+          <p:cNvSpPr txBox="1"/>
+          <p:nvPr/>
+        </p:nvSpPr>
+        <p:spPr>
+          <a:xfrm>
+            <a:off x="8869680" y="3061411"/>
+            <a:ext cx="2834640" cy="656539"/>
+          </a:xfrm>
+          <a:prstGeom prst="rect">
+            <a:avLst/>
+          </a:prstGeom>
+          <a:noFill/>
+        </p:spPr>
+        <p:txBody>
+          <a:bodyPr wrap="square" lIns="36000" rIns="36000" tIns="0" bIns="0">
+            <a:spAutoFit/>
+          </a:bodyPr>
+          <a:lstStyle/>
+          <a:p>
+            <a:pPr algn="l"/>
+            <a:r>
+              <a:rPr sz="1100" b="1">
+                <a:solidFill>
+                  <a:srgbClr val="333333"/>
+                </a:solidFill>
+                <a:latin typeface="Calibri"/>
+              </a:rPr>
+              <a:t>Strukturierte Extraktion: </a:t>
+            </a:r>
+            <a:r>
+              <a:rPr sz="1100">
+                <a:solidFill>
+                  <a:srgbClr val="333333"/>
+                </a:solidFill>
+                <a:latin typeface="Calibri"/>
+              </a:rPr>
+              <a:t>KI erstellt je Mail ein Beiblatt mit 50 Feldern – VNR, Sparte, Pool, Status, Vorgangs-Cluster immer gleich.</a:t>
+            </a:r>
+          </a:p>
+        </p:txBody>
+      </p:sp>
+      <p:sp>
+        <p:nvSpPr>
+          <p:cNvPr id="98" name="Oval 97"/>
+          <p:cNvSpPr/>
           <p:nvPr/>
         </p:nvSpPr>
         <p:spPr>
           <a:xfrm>
             <a:off x="8366760" y="3763670"/>
-            <a:ext cx="384048" cy="384048"/>
-          </a:xfrm>
-          <a:prstGeom prst="rect">
-            <a:avLst/>
-          </a:prstGeom>
-          <a:noFill/>
-        </p:spPr>
-        <p:txBody>
-          <a:bodyPr wrap="square" lIns="36000" rIns="36000" tIns="18000" bIns="18000" anchor="ctr">
-            <a:spAutoFit/>
-          </a:bodyPr>
-          <a:lstStyle/>
-          <a:p>
-            <a:pPr algn="ctr"/>
-            <a:r>
-              <a:rPr sz="1500" b="1" i="0" u="none">
-                <a:solidFill>
-                  <a:srgbClr val="FFFFFF"/>
-                </a:solidFill>
-                <a:latin typeface="Calibri"/>
-              </a:rPr>
-              <a:t>3</a:t>
-            </a:r>
-          </a:p>
-        </p:txBody>
-      </p:sp>
-      <p:sp>
-        <p:nvSpPr>
-          <p:cNvPr id="91" name="TextBox 90"/>
-          <p:cNvSpPr txBox="1"/>
-          <p:nvPr/>
-        </p:nvSpPr>
-        <p:spPr>
-          <a:xfrm>
-            <a:off x="8869680" y="3717950"/>
-            <a:ext cx="2834640" cy="656539"/>
-          </a:xfrm>
-          <a:prstGeom prst="rect">
-            <a:avLst/>
-          </a:prstGeom>
-          <a:noFill/>
-        </p:spPr>
-        <p:txBody>
-          <a:bodyPr wrap="square" lIns="36000" rIns="36000" tIns="0" bIns="0">
-            <a:spAutoFit/>
-          </a:bodyPr>
-          <a:lstStyle/>
-          <a:p>
-            <a:pPr algn="l"/>
-            <a:r>
-              <a:rPr sz="1100" b="1">
-                <a:solidFill>
-                  <a:srgbClr val="333333"/>
-                </a:solidFill>
-                <a:latin typeface="Calibri"/>
-              </a:rPr>
-              <a:t>Ableitung Hebel 1: </a:t>
-            </a:r>
-            <a:r>
-              <a:rPr sz="1100">
-                <a:solidFill>
-                  <a:srgbClr val="333333"/>
-                </a:solidFill>
-                <a:latin typeface="Calibri"/>
-              </a:rPr>
-              <a:t>1.034 Mails sind keine neue BÜ; 240 haengen eine MV an und werden durch die Regel 'MV → BÜ' falsch angelegt.</a:t>
-            </a:r>
-          </a:p>
-        </p:txBody>
-      </p:sp>
-      <p:sp>
-        <p:nvSpPr>
-          <p:cNvPr id="92" name="Oval 91"/>
-          <p:cNvSpPr/>
-          <p:nvPr/>
-        </p:nvSpPr>
-        <p:spPr>
-          <a:xfrm>
-            <a:off x="8366760" y="4420209"/>
             <a:ext cx="384048" cy="384048"/>
           </a:xfrm>
           <a:prstGeom prst="ellipse">
@@ -6586,92 +6783,92 @@
       </p:sp>
       <p:sp>
         <p:nvSpPr>
-          <p:cNvPr id="93" name="TextBox 92"/>
-          <p:cNvSpPr txBox="1"/>
+          <p:cNvPr id="99" name="TextBox 98"/>
+          <p:cNvSpPr txBox="1"/>
+          <p:nvPr/>
+        </p:nvSpPr>
+        <p:spPr>
+          <a:xfrm>
+            <a:off x="8366760" y="3763670"/>
+            <a:ext cx="384048" cy="384048"/>
+          </a:xfrm>
+          <a:prstGeom prst="rect">
+            <a:avLst/>
+          </a:prstGeom>
+          <a:noFill/>
+        </p:spPr>
+        <p:txBody>
+          <a:bodyPr wrap="square" lIns="36000" rIns="36000" tIns="18000" bIns="18000" anchor="ctr">
+            <a:spAutoFit/>
+          </a:bodyPr>
+          <a:lstStyle/>
+          <a:p>
+            <a:pPr algn="ctr"/>
+            <a:r>
+              <a:rPr sz="1500" b="1" i="0" u="none">
+                <a:solidFill>
+                  <a:srgbClr val="FFFFFF"/>
+                </a:solidFill>
+                <a:latin typeface="Calibri"/>
+              </a:rPr>
+              <a:t>3</a:t>
+            </a:r>
+          </a:p>
+        </p:txBody>
+      </p:sp>
+      <p:sp>
+        <p:nvSpPr>
+          <p:cNvPr id="100" name="TextBox 99"/>
+          <p:cNvSpPr txBox="1"/>
+          <p:nvPr/>
+        </p:nvSpPr>
+        <p:spPr>
+          <a:xfrm>
+            <a:off x="8869680" y="3717950"/>
+            <a:ext cx="2834640" cy="656539"/>
+          </a:xfrm>
+          <a:prstGeom prst="rect">
+            <a:avLst/>
+          </a:prstGeom>
+          <a:noFill/>
+        </p:spPr>
+        <p:txBody>
+          <a:bodyPr wrap="square" lIns="36000" rIns="36000" tIns="0" bIns="0">
+            <a:spAutoFit/>
+          </a:bodyPr>
+          <a:lstStyle/>
+          <a:p>
+            <a:pPr algn="l"/>
+            <a:r>
+              <a:rPr sz="1100" b="1">
+                <a:solidFill>
+                  <a:srgbClr val="333333"/>
+                </a:solidFill>
+                <a:latin typeface="Calibri"/>
+              </a:rPr>
+              <a:t>Ableitung Hebel 1: </a:t>
+            </a:r>
+            <a:r>
+              <a:rPr sz="1100">
+                <a:solidFill>
+                  <a:srgbClr val="333333"/>
+                </a:solidFill>
+                <a:latin typeface="Calibri"/>
+              </a:rPr>
+              <a:t>1.034 Mails sind keine neue BÜ; 240 haengen eine MV an und werden durch die Regel 'MV → BÜ' falsch angelegt.</a:t>
+            </a:r>
+          </a:p>
+        </p:txBody>
+      </p:sp>
+      <p:sp>
+        <p:nvSpPr>
+          <p:cNvPr id="101" name="Oval 100"/>
+          <p:cNvSpPr/>
           <p:nvPr/>
         </p:nvSpPr>
         <p:spPr>
           <a:xfrm>
             <a:off x="8366760" y="4420209"/>
-            <a:ext cx="384048" cy="384048"/>
-          </a:xfrm>
-          <a:prstGeom prst="rect">
-            <a:avLst/>
-          </a:prstGeom>
-          <a:noFill/>
-        </p:spPr>
-        <p:txBody>
-          <a:bodyPr wrap="square" lIns="36000" rIns="36000" tIns="18000" bIns="18000" anchor="ctr">
-            <a:spAutoFit/>
-          </a:bodyPr>
-          <a:lstStyle/>
-          <a:p>
-            <a:pPr algn="ctr"/>
-            <a:r>
-              <a:rPr sz="1500" b="1" i="0" u="none">
-                <a:solidFill>
-                  <a:srgbClr val="FFFFFF"/>
-                </a:solidFill>
-                <a:latin typeface="Calibri"/>
-              </a:rPr>
-              <a:t>4</a:t>
-            </a:r>
-          </a:p>
-        </p:txBody>
-      </p:sp>
-      <p:sp>
-        <p:nvSpPr>
-          <p:cNvPr id="94" name="TextBox 93"/>
-          <p:cNvSpPr txBox="1"/>
-          <p:nvPr/>
-        </p:nvSpPr>
-        <p:spPr>
-          <a:xfrm>
-            <a:off x="8869680" y="4374489"/>
-            <a:ext cx="2834640" cy="656539"/>
-          </a:xfrm>
-          <a:prstGeom prst="rect">
-            <a:avLst/>
-          </a:prstGeom>
-          <a:noFill/>
-        </p:spPr>
-        <p:txBody>
-          <a:bodyPr wrap="square" lIns="36000" rIns="36000" tIns="0" bIns="0">
-            <a:spAutoFit/>
-          </a:bodyPr>
-          <a:lstStyle/>
-          <a:p>
-            <a:pPr algn="l"/>
-            <a:r>
-              <a:rPr sz="1100" b="1">
-                <a:solidFill>
-                  <a:srgbClr val="333333"/>
-                </a:solidFill>
-                <a:latin typeface="Calibri"/>
-              </a:rPr>
-              <a:t>Ableitung Hebel 2: </a:t>
-            </a:r>
-            <a:r>
-              <a:rPr sz="1100">
-                <a:solidFill>
-                  <a:srgbClr val="333333"/>
-                </a:solidFill>
-                <a:latin typeface="Calibri"/>
-              </a:rPr>
-              <a:t>4.000 BÜ-Mails verteilen sich auf nur 2.495 Vorgaenge → Buendelung / Steuerung moeglich.</a:t>
-            </a:r>
-          </a:p>
-        </p:txBody>
-      </p:sp>
-      <p:sp>
-        <p:nvSpPr>
-          <p:cNvPr id="95" name="Oval 94"/>
-          <p:cNvSpPr/>
-          <p:nvPr/>
-        </p:nvSpPr>
-        <p:spPr>
-          <a:xfrm>
-            <a:off x="8366760" y="5076748"/>
             <a:ext cx="384048" cy="384048"/>
           </a:xfrm>
           <a:prstGeom prst="ellipse">
@@ -6709,8 +6906,87 @@
       </p:sp>
       <p:sp>
         <p:nvSpPr>
-          <p:cNvPr id="96" name="TextBox 95"/>
-          <p:cNvSpPr txBox="1"/>
+          <p:cNvPr id="102" name="TextBox 101"/>
+          <p:cNvSpPr txBox="1"/>
+          <p:nvPr/>
+        </p:nvSpPr>
+        <p:spPr>
+          <a:xfrm>
+            <a:off x="8366760" y="4420209"/>
+            <a:ext cx="384048" cy="384048"/>
+          </a:xfrm>
+          <a:prstGeom prst="rect">
+            <a:avLst/>
+          </a:prstGeom>
+          <a:noFill/>
+        </p:spPr>
+        <p:txBody>
+          <a:bodyPr wrap="square" lIns="36000" rIns="36000" tIns="18000" bIns="18000" anchor="ctr">
+            <a:spAutoFit/>
+          </a:bodyPr>
+          <a:lstStyle/>
+          <a:p>
+            <a:pPr algn="ctr"/>
+            <a:r>
+              <a:rPr sz="1500" b="1" i="0" u="none">
+                <a:solidFill>
+                  <a:srgbClr val="FFFFFF"/>
+                </a:solidFill>
+                <a:latin typeface="Calibri"/>
+              </a:rPr>
+              <a:t>4</a:t>
+            </a:r>
+          </a:p>
+        </p:txBody>
+      </p:sp>
+      <p:sp>
+        <p:nvSpPr>
+          <p:cNvPr id="103" name="TextBox 102"/>
+          <p:cNvSpPr txBox="1"/>
+          <p:nvPr/>
+        </p:nvSpPr>
+        <p:spPr>
+          <a:xfrm>
+            <a:off x="8869680" y="4374489"/>
+            <a:ext cx="2834640" cy="656539"/>
+          </a:xfrm>
+          <a:prstGeom prst="rect">
+            <a:avLst/>
+          </a:prstGeom>
+          <a:noFill/>
+        </p:spPr>
+        <p:txBody>
+          <a:bodyPr wrap="square" lIns="36000" rIns="36000" tIns="0" bIns="0">
+            <a:spAutoFit/>
+          </a:bodyPr>
+          <a:lstStyle/>
+          <a:p>
+            <a:pPr algn="l"/>
+            <a:r>
+              <a:rPr sz="1100" b="1">
+                <a:solidFill>
+                  <a:srgbClr val="333333"/>
+                </a:solidFill>
+                <a:latin typeface="Calibri"/>
+              </a:rPr>
+              <a:t>Ableitung Hebel 2: </a:t>
+            </a:r>
+            <a:r>
+              <a:rPr sz="1100">
+                <a:solidFill>
+                  <a:srgbClr val="333333"/>
+                </a:solidFill>
+                <a:latin typeface="Calibri"/>
+              </a:rPr>
+              <a:t>4.000 BÜ-Mails verteilen sich auf nur 2.495 Vorgaenge → Buendelung / Steuerung moeglich.</a:t>
+            </a:r>
+          </a:p>
+        </p:txBody>
+      </p:sp>
+      <p:sp>
+        <p:nvSpPr>
+          <p:cNvPr id="104" name="Oval 103"/>
+          <p:cNvSpPr/>
           <p:nvPr/>
         </p:nvSpPr>
         <p:spPr>
@@ -6718,6 +6994,50 @@
             <a:off x="8366760" y="5076748"/>
             <a:ext cx="384048" cy="384048"/>
           </a:xfrm>
+          <a:prstGeom prst="ellipse">
+            <a:avLst/>
+          </a:prstGeom>
+          <a:solidFill>
+            <a:srgbClr val="008793"/>
+          </a:solidFill>
+          <a:ln>
+            <a:noFill/>
+          </a:ln>
+          <a:effectLst/>
+        </p:spPr>
+        <p:style>
+          <a:lnRef idx="1">
+            <a:schemeClr val="accent1"/>
+          </a:lnRef>
+          <a:fillRef idx="3">
+            <a:schemeClr val="accent1"/>
+          </a:fillRef>
+          <a:effectRef idx="2">
+            <a:schemeClr val="accent1"/>
+          </a:effectRef>
+          <a:fontRef idx="minor">
+            <a:schemeClr val="lt1"/>
+          </a:fontRef>
+        </p:style>
+        <p:txBody>
+          <a:bodyPr rtlCol="0" anchor="ctr"/>
+          <a:lstStyle/>
+          <a:p>
+            <a:pPr algn="ctr"/>
+          </a:p>
+        </p:txBody>
+      </p:sp>
+      <p:sp>
+        <p:nvSpPr>
+          <p:cNvPr id="105" name="TextBox 104"/>
+          <p:cNvSpPr txBox="1"/>
+          <p:nvPr/>
+        </p:nvSpPr>
+        <p:spPr>
+          <a:xfrm>
+            <a:off x="8366760" y="5076748"/>
+            <a:ext cx="384048" cy="384048"/>
+          </a:xfrm>
           <a:prstGeom prst="rect">
             <a:avLst/>
           </a:prstGeom>
@@ -6744,7 +7064,7 @@
       </p:sp>
       <p:sp>
         <p:nvSpPr>
-          <p:cNvPr id="97" name="TextBox 96"/>
+          <p:cNvPr id="106" name="TextBox 105"/>
           <p:cNvSpPr txBox="1"/>
           <p:nvPr/>
         </p:nvSpPr>
@@ -6788,7 +7108,7 @@
       </p:sp>
       <p:sp>
         <p:nvSpPr>
-          <p:cNvPr id="98" name="TextBox 97"/>
+          <p:cNvPr id="107" name="TextBox 106"/>
           <p:cNvSpPr txBox="1"/>
           <p:nvPr/>
         </p:nvSpPr>
@@ -6823,7 +7143,7 @@
       </p:sp>
       <p:sp>
         <p:nvSpPr>
-          <p:cNvPr id="99" name="Rectangle 98"/>
+          <p:cNvPr id="108" name="Rectangle 107"/>
           <p:cNvSpPr/>
           <p:nvPr/>
         </p:nvSpPr>
@@ -6867,7 +7187,7 @@
       </p:sp>
       <p:sp>
         <p:nvSpPr>
-          <p:cNvPr id="100" name="TextBox 99"/>
+          <p:cNvPr id="109" name="TextBox 108"/>
           <p:cNvSpPr txBox="1"/>
           <p:nvPr/>
         </p:nvSpPr>

</xml_diff>

<commit_message>
PPTX Folie 11: Spalte 'Sonstige' ergaenzt (Summen stimmen jetzt)
Gesamt 5.034 = KV 1.308 + Komposit 2.502 + Leben 755 + Sonstige 469.
Sonstige je Zeile: Keine BÜ 346 (davon MV 1) | Reminder 21 (MV 6) |
Neue BÜ 102 | Top-5 2% | inCluster 9%.
Sonstige = Sparte unklar / Spam (346 Keine-BÜ ohne MV) - Fussnote ergaenzt.
Spaltenbreiten auf 6 Spalten angepasst.

https://claude.ai/code/session_01UknXtYp2XECsQDonCZuxSt
</commit_message>
<xml_diff>
--- a/ERGO-Mengengeruest-2Slides-Berichtslook.pptx
+++ b/ERGO-Mengengeruest-2Slides-Berichtslook.pptx
@@ -4362,7 +4362,7 @@
         <p:spPr>
           <a:xfrm>
             <a:off x="411480" y="3008376"/>
-            <a:ext cx="2788920" cy="329184"/>
+            <a:ext cx="2606040" cy="329184"/>
           </a:xfrm>
           <a:prstGeom prst="rect">
             <a:avLst/>
@@ -4396,8 +4396,8 @@
         </p:nvSpPr>
         <p:spPr>
           <a:xfrm>
-            <a:off x="3200400" y="3008376"/>
-            <a:ext cx="1234440" cy="329184"/>
+            <a:off x="3017520" y="3008376"/>
+            <a:ext cx="1051560" cy="329184"/>
           </a:xfrm>
           <a:prstGeom prst="rect">
             <a:avLst/>
@@ -4431,8 +4431,8 @@
         </p:nvSpPr>
         <p:spPr>
           <a:xfrm>
-            <a:off x="4434840" y="3008376"/>
-            <a:ext cx="1188720" cy="329184"/>
+            <a:off x="4069080" y="3008376"/>
+            <a:ext cx="960120" cy="329184"/>
           </a:xfrm>
           <a:prstGeom prst="rect">
             <a:avLst/>
@@ -4466,8 +4466,8 @@
         </p:nvSpPr>
         <p:spPr>
           <a:xfrm>
-            <a:off x="5623560" y="3008376"/>
-            <a:ext cx="1371600" cy="329184"/>
+            <a:off x="5029200" y="3008376"/>
+            <a:ext cx="1143000" cy="329184"/>
           </a:xfrm>
           <a:prstGeom prst="rect">
             <a:avLst/>
@@ -4501,8 +4501,8 @@
         </p:nvSpPr>
         <p:spPr>
           <a:xfrm>
-            <a:off x="6995160" y="3008376"/>
-            <a:ext cx="1051560" cy="329184"/>
+            <a:off x="6172200" y="3008376"/>
+            <a:ext cx="914400" cy="329184"/>
           </a:xfrm>
           <a:prstGeom prst="rect">
             <a:avLst/>
@@ -4530,7 +4530,42 @@
       </p:sp>
       <p:sp>
         <p:nvSpPr>
-          <p:cNvPr id="39" name="Rectangle 38"/>
+          <p:cNvPr id="39" name="TextBox 38"/>
+          <p:cNvSpPr txBox="1"/>
+          <p:nvPr/>
+        </p:nvSpPr>
+        <p:spPr>
+          <a:xfrm>
+            <a:off x="7086600" y="3008376"/>
+            <a:ext cx="960120" cy="329184"/>
+          </a:xfrm>
+          <a:prstGeom prst="rect">
+            <a:avLst/>
+          </a:prstGeom>
+          <a:noFill/>
+        </p:spPr>
+        <p:txBody>
+          <a:bodyPr wrap="square" lIns="36000" rIns="36000" tIns="18000" bIns="18000" anchor="ctr">
+            <a:spAutoFit/>
+          </a:bodyPr>
+          <a:lstStyle/>
+          <a:p>
+            <a:pPr algn="ctr"/>
+            <a:r>
+              <a:rPr sz="1100" b="1" i="0" u="none">
+                <a:solidFill>
+                  <a:srgbClr val="FFFFFF"/>
+                </a:solidFill>
+                <a:latin typeface="Calibri"/>
+              </a:rPr>
+              <a:t>Sonstige</a:t>
+            </a:r>
+          </a:p>
+        </p:txBody>
+      </p:sp>
+      <p:sp>
+        <p:nvSpPr>
+          <p:cNvPr id="40" name="Rectangle 39"/>
           <p:cNvSpPr/>
           <p:nvPr/>
         </p:nvSpPr>
@@ -4574,14 +4609,14 @@
       </p:sp>
       <p:sp>
         <p:nvSpPr>
-          <p:cNvPr id="40" name="TextBox 39"/>
+          <p:cNvPr id="41" name="TextBox 40"/>
           <p:cNvSpPr txBox="1"/>
           <p:nvPr/>
         </p:nvSpPr>
         <p:spPr>
           <a:xfrm>
             <a:off x="521208" y="3337560"/>
-            <a:ext cx="2679192" cy="278892"/>
+            <a:ext cx="2496312" cy="278892"/>
           </a:xfrm>
           <a:prstGeom prst="rect">
             <a:avLst/>
@@ -4609,14 +4644,14 @@
       </p:sp>
       <p:sp>
         <p:nvSpPr>
-          <p:cNvPr id="41" name="TextBox 40"/>
-          <p:cNvSpPr txBox="1"/>
-          <p:nvPr/>
-        </p:nvSpPr>
-        <p:spPr>
-          <a:xfrm>
-            <a:off x="3200400" y="3337560"/>
-            <a:ext cx="1234440" cy="278892"/>
+          <p:cNvPr id="42" name="TextBox 41"/>
+          <p:cNvSpPr txBox="1"/>
+          <p:nvPr/>
+        </p:nvSpPr>
+        <p:spPr>
+          <a:xfrm>
+            <a:off x="3017520" y="3337560"/>
+            <a:ext cx="1051560" cy="278892"/>
           </a:xfrm>
           <a:prstGeom prst="rect">
             <a:avLst/>
@@ -4644,14 +4679,14 @@
       </p:sp>
       <p:sp>
         <p:nvSpPr>
-          <p:cNvPr id="42" name="TextBox 41"/>
-          <p:cNvSpPr txBox="1"/>
-          <p:nvPr/>
-        </p:nvSpPr>
-        <p:spPr>
-          <a:xfrm>
-            <a:off x="4434840" y="3337560"/>
-            <a:ext cx="1188720" cy="278892"/>
+          <p:cNvPr id="43" name="TextBox 42"/>
+          <p:cNvSpPr txBox="1"/>
+          <p:nvPr/>
+        </p:nvSpPr>
+        <p:spPr>
+          <a:xfrm>
+            <a:off x="4069080" y="3337560"/>
+            <a:ext cx="960120" cy="278892"/>
           </a:xfrm>
           <a:prstGeom prst="rect">
             <a:avLst/>
@@ -4679,14 +4714,14 @@
       </p:sp>
       <p:sp>
         <p:nvSpPr>
-          <p:cNvPr id="43" name="TextBox 42"/>
-          <p:cNvSpPr txBox="1"/>
-          <p:nvPr/>
-        </p:nvSpPr>
-        <p:spPr>
-          <a:xfrm>
-            <a:off x="5623560" y="3337560"/>
-            <a:ext cx="1371600" cy="278892"/>
+          <p:cNvPr id="44" name="TextBox 43"/>
+          <p:cNvSpPr txBox="1"/>
+          <p:nvPr/>
+        </p:nvSpPr>
+        <p:spPr>
+          <a:xfrm>
+            <a:off x="5029200" y="3337560"/>
+            <a:ext cx="1143000" cy="278892"/>
           </a:xfrm>
           <a:prstGeom prst="rect">
             <a:avLst/>
@@ -4714,14 +4749,14 @@
       </p:sp>
       <p:sp>
         <p:nvSpPr>
-          <p:cNvPr id="44" name="TextBox 43"/>
-          <p:cNvSpPr txBox="1"/>
-          <p:nvPr/>
-        </p:nvSpPr>
-        <p:spPr>
-          <a:xfrm>
-            <a:off x="6995160" y="3337560"/>
-            <a:ext cx="1051560" cy="278892"/>
+          <p:cNvPr id="45" name="TextBox 44"/>
+          <p:cNvSpPr txBox="1"/>
+          <p:nvPr/>
+        </p:nvSpPr>
+        <p:spPr>
+          <a:xfrm>
+            <a:off x="6172200" y="3337560"/>
+            <a:ext cx="914400" cy="278892"/>
           </a:xfrm>
           <a:prstGeom prst="rect">
             <a:avLst/>
@@ -4749,7 +4784,42 @@
       </p:sp>
       <p:sp>
         <p:nvSpPr>
-          <p:cNvPr id="45" name="Rectangle 44"/>
+          <p:cNvPr id="46" name="TextBox 45"/>
+          <p:cNvSpPr txBox="1"/>
+          <p:nvPr/>
+        </p:nvSpPr>
+        <p:spPr>
+          <a:xfrm>
+            <a:off x="7086600" y="3337560"/>
+            <a:ext cx="960120" cy="278892"/>
+          </a:xfrm>
+          <a:prstGeom prst="rect">
+            <a:avLst/>
+          </a:prstGeom>
+          <a:noFill/>
+        </p:spPr>
+        <p:txBody>
+          <a:bodyPr wrap="square" lIns="36000" rIns="36000" tIns="18000" bIns="18000" anchor="ctr">
+            <a:spAutoFit/>
+          </a:bodyPr>
+          <a:lstStyle/>
+          <a:p>
+            <a:pPr algn="ctr"/>
+            <a:r>
+              <a:rPr sz="1100" b="1" i="0" u="none">
+                <a:solidFill>
+                  <a:srgbClr val="333333"/>
+                </a:solidFill>
+                <a:latin typeface="Calibri"/>
+              </a:rPr>
+              <a:t>469</a:t>
+            </a:r>
+          </a:p>
+        </p:txBody>
+      </p:sp>
+      <p:sp>
+        <p:nvSpPr>
+          <p:cNvPr id="47" name="Rectangle 46"/>
           <p:cNvSpPr/>
           <p:nvPr/>
         </p:nvSpPr>
@@ -4793,14 +4863,14 @@
       </p:sp>
       <p:sp>
         <p:nvSpPr>
-          <p:cNvPr id="46" name="TextBox 45"/>
+          <p:cNvPr id="48" name="TextBox 47"/>
           <p:cNvSpPr txBox="1"/>
           <p:nvPr/>
         </p:nvSpPr>
         <p:spPr>
           <a:xfrm>
             <a:off x="521208" y="3616452"/>
-            <a:ext cx="2679192" cy="278892"/>
+            <a:ext cx="2496312" cy="278892"/>
           </a:xfrm>
           <a:prstGeom prst="rect">
             <a:avLst/>
@@ -4828,14 +4898,14 @@
       </p:sp>
       <p:sp>
         <p:nvSpPr>
-          <p:cNvPr id="47" name="TextBox 46"/>
-          <p:cNvSpPr txBox="1"/>
-          <p:nvPr/>
-        </p:nvSpPr>
-        <p:spPr>
-          <a:xfrm>
-            <a:off x="3200400" y="3616452"/>
-            <a:ext cx="1234440" cy="278892"/>
+          <p:cNvPr id="49" name="TextBox 48"/>
+          <p:cNvSpPr txBox="1"/>
+          <p:nvPr/>
+        </p:nvSpPr>
+        <p:spPr>
+          <a:xfrm>
+            <a:off x="3017520" y="3616452"/>
+            <a:ext cx="1051560" cy="278892"/>
           </a:xfrm>
           <a:prstGeom prst="rect">
             <a:avLst/>
@@ -4863,14 +4933,14 @@
       </p:sp>
       <p:sp>
         <p:nvSpPr>
-          <p:cNvPr id="48" name="TextBox 47"/>
-          <p:cNvSpPr txBox="1"/>
-          <p:nvPr/>
-        </p:nvSpPr>
-        <p:spPr>
-          <a:xfrm>
-            <a:off x="4434840" y="3616452"/>
-            <a:ext cx="1188720" cy="278892"/>
+          <p:cNvPr id="50" name="TextBox 49"/>
+          <p:cNvSpPr txBox="1"/>
+          <p:nvPr/>
+        </p:nvSpPr>
+        <p:spPr>
+          <a:xfrm>
+            <a:off x="4069080" y="3616452"/>
+            <a:ext cx="960120" cy="278892"/>
           </a:xfrm>
           <a:prstGeom prst="rect">
             <a:avLst/>
@@ -4898,14 +4968,14 @@
       </p:sp>
       <p:sp>
         <p:nvSpPr>
-          <p:cNvPr id="49" name="TextBox 48"/>
-          <p:cNvSpPr txBox="1"/>
-          <p:nvPr/>
-        </p:nvSpPr>
-        <p:spPr>
-          <a:xfrm>
-            <a:off x="5623560" y="3616452"/>
-            <a:ext cx="1371600" cy="278892"/>
+          <p:cNvPr id="51" name="TextBox 50"/>
+          <p:cNvSpPr txBox="1"/>
+          <p:nvPr/>
+        </p:nvSpPr>
+        <p:spPr>
+          <a:xfrm>
+            <a:off x="5029200" y="3616452"/>
+            <a:ext cx="1143000" cy="278892"/>
           </a:xfrm>
           <a:prstGeom prst="rect">
             <a:avLst/>
@@ -4933,14 +5003,14 @@
       </p:sp>
       <p:sp>
         <p:nvSpPr>
-          <p:cNvPr id="50" name="TextBox 49"/>
-          <p:cNvSpPr txBox="1"/>
-          <p:nvPr/>
-        </p:nvSpPr>
-        <p:spPr>
-          <a:xfrm>
-            <a:off x="6995160" y="3616452"/>
-            <a:ext cx="1051560" cy="278892"/>
+          <p:cNvPr id="52" name="TextBox 51"/>
+          <p:cNvSpPr txBox="1"/>
+          <p:nvPr/>
+        </p:nvSpPr>
+        <p:spPr>
+          <a:xfrm>
+            <a:off x="6172200" y="3616452"/>
+            <a:ext cx="914400" cy="278892"/>
           </a:xfrm>
           <a:prstGeom prst="rect">
             <a:avLst/>
@@ -4968,7 +5038,42 @@
       </p:sp>
       <p:sp>
         <p:nvSpPr>
-          <p:cNvPr id="51" name="Rectangle 50"/>
+          <p:cNvPr id="53" name="TextBox 52"/>
+          <p:cNvSpPr txBox="1"/>
+          <p:nvPr/>
+        </p:nvSpPr>
+        <p:spPr>
+          <a:xfrm>
+            <a:off x="7086600" y="3616452"/>
+            <a:ext cx="960120" cy="278892"/>
+          </a:xfrm>
+          <a:prstGeom prst="rect">
+            <a:avLst/>
+          </a:prstGeom>
+          <a:noFill/>
+        </p:spPr>
+        <p:txBody>
+          <a:bodyPr wrap="square" lIns="36000" rIns="36000" tIns="18000" bIns="18000" anchor="ctr">
+            <a:spAutoFit/>
+          </a:bodyPr>
+          <a:lstStyle/>
+          <a:p>
+            <a:pPr algn="ctr"/>
+            <a:r>
+              <a:rPr sz="1100" b="0" i="0" u="none">
+                <a:solidFill>
+                  <a:srgbClr val="333333"/>
+                </a:solidFill>
+                <a:latin typeface="Calibri"/>
+              </a:rPr>
+              <a:t>346</a:t>
+            </a:r>
+          </a:p>
+        </p:txBody>
+      </p:sp>
+      <p:sp>
+        <p:nvSpPr>
+          <p:cNvPr id="54" name="Rectangle 53"/>
           <p:cNvSpPr/>
           <p:nvPr/>
         </p:nvSpPr>
@@ -5012,7 +5117,7 @@
       </p:sp>
       <p:sp>
         <p:nvSpPr>
-          <p:cNvPr id="52" name="Rectangle 51"/>
+          <p:cNvPr id="55" name="Rectangle 54"/>
           <p:cNvSpPr/>
           <p:nvPr/>
         </p:nvSpPr>
@@ -5056,14 +5161,14 @@
       </p:sp>
       <p:sp>
         <p:nvSpPr>
-          <p:cNvPr id="53" name="TextBox 52"/>
+          <p:cNvPr id="56" name="TextBox 55"/>
           <p:cNvSpPr txBox="1"/>
           <p:nvPr/>
         </p:nvSpPr>
         <p:spPr>
           <a:xfrm>
             <a:off x="521208" y="3895344"/>
-            <a:ext cx="2679192" cy="278892"/>
+            <a:ext cx="2496312" cy="278892"/>
           </a:xfrm>
           <a:prstGeom prst="rect">
             <a:avLst/>
@@ -5091,14 +5196,14 @@
       </p:sp>
       <p:sp>
         <p:nvSpPr>
-          <p:cNvPr id="54" name="TextBox 53"/>
-          <p:cNvSpPr txBox="1"/>
-          <p:nvPr/>
-        </p:nvSpPr>
-        <p:spPr>
-          <a:xfrm>
-            <a:off x="3200400" y="3895344"/>
-            <a:ext cx="1234440" cy="278892"/>
+          <p:cNvPr id="57" name="TextBox 56"/>
+          <p:cNvSpPr txBox="1"/>
+          <p:nvPr/>
+        </p:nvSpPr>
+        <p:spPr>
+          <a:xfrm>
+            <a:off x="3017520" y="3895344"/>
+            <a:ext cx="1051560" cy="278892"/>
           </a:xfrm>
           <a:prstGeom prst="rect">
             <a:avLst/>
@@ -5126,14 +5231,14 @@
       </p:sp>
       <p:sp>
         <p:nvSpPr>
-          <p:cNvPr id="55" name="TextBox 54"/>
-          <p:cNvSpPr txBox="1"/>
-          <p:nvPr/>
-        </p:nvSpPr>
-        <p:spPr>
-          <a:xfrm>
-            <a:off x="4434840" y="3895344"/>
-            <a:ext cx="1188720" cy="278892"/>
+          <p:cNvPr id="58" name="TextBox 57"/>
+          <p:cNvSpPr txBox="1"/>
+          <p:nvPr/>
+        </p:nvSpPr>
+        <p:spPr>
+          <a:xfrm>
+            <a:off x="4069080" y="3895344"/>
+            <a:ext cx="960120" cy="278892"/>
           </a:xfrm>
           <a:prstGeom prst="rect">
             <a:avLst/>
@@ -5161,14 +5266,14 @@
       </p:sp>
       <p:sp>
         <p:nvSpPr>
-          <p:cNvPr id="56" name="TextBox 55"/>
-          <p:cNvSpPr txBox="1"/>
-          <p:nvPr/>
-        </p:nvSpPr>
-        <p:spPr>
-          <a:xfrm>
-            <a:off x="5623560" y="3895344"/>
-            <a:ext cx="1371600" cy="278892"/>
+          <p:cNvPr id="59" name="TextBox 58"/>
+          <p:cNvSpPr txBox="1"/>
+          <p:nvPr/>
+        </p:nvSpPr>
+        <p:spPr>
+          <a:xfrm>
+            <a:off x="5029200" y="3895344"/>
+            <a:ext cx="1143000" cy="278892"/>
           </a:xfrm>
           <a:prstGeom prst="rect">
             <a:avLst/>
@@ -5196,14 +5301,14 @@
       </p:sp>
       <p:sp>
         <p:nvSpPr>
-          <p:cNvPr id="57" name="TextBox 56"/>
-          <p:cNvSpPr txBox="1"/>
-          <p:nvPr/>
-        </p:nvSpPr>
-        <p:spPr>
-          <a:xfrm>
-            <a:off x="6995160" y="3895344"/>
-            <a:ext cx="1051560" cy="278892"/>
+          <p:cNvPr id="60" name="TextBox 59"/>
+          <p:cNvSpPr txBox="1"/>
+          <p:nvPr/>
+        </p:nvSpPr>
+        <p:spPr>
+          <a:xfrm>
+            <a:off x="6172200" y="3895344"/>
+            <a:ext cx="914400" cy="278892"/>
           </a:xfrm>
           <a:prstGeom prst="rect">
             <a:avLst/>
@@ -5231,7 +5336,42 @@
       </p:sp>
       <p:sp>
         <p:nvSpPr>
-          <p:cNvPr id="58" name="Rectangle 57"/>
+          <p:cNvPr id="61" name="TextBox 60"/>
+          <p:cNvSpPr txBox="1"/>
+          <p:nvPr/>
+        </p:nvSpPr>
+        <p:spPr>
+          <a:xfrm>
+            <a:off x="7086600" y="3895344"/>
+            <a:ext cx="960120" cy="278892"/>
+          </a:xfrm>
+          <a:prstGeom prst="rect">
+            <a:avLst/>
+          </a:prstGeom>
+          <a:noFill/>
+        </p:spPr>
+        <p:txBody>
+          <a:bodyPr wrap="square" lIns="36000" rIns="36000" tIns="18000" bIns="18000" anchor="ctr">
+            <a:spAutoFit/>
+          </a:bodyPr>
+          <a:lstStyle/>
+          <a:p>
+            <a:pPr algn="ctr"/>
+            <a:r>
+              <a:rPr sz="1100" b="1" i="1" u="none">
+                <a:solidFill>
+                  <a:srgbClr val="C86E10"/>
+                </a:solidFill>
+                <a:latin typeface="Calibri"/>
+              </a:rPr>
+              <a:t>1</a:t>
+            </a:r>
+          </a:p>
+        </p:txBody>
+      </p:sp>
+      <p:sp>
+        <p:nvSpPr>
+          <p:cNvPr id="62" name="Rectangle 61"/>
           <p:cNvSpPr/>
           <p:nvPr/>
         </p:nvSpPr>
@@ -5275,14 +5415,14 @@
       </p:sp>
       <p:sp>
         <p:nvSpPr>
-          <p:cNvPr id="59" name="TextBox 58"/>
+          <p:cNvPr id="63" name="TextBox 62"/>
           <p:cNvSpPr txBox="1"/>
           <p:nvPr/>
         </p:nvSpPr>
         <p:spPr>
           <a:xfrm>
             <a:off x="521208" y="4174236"/>
-            <a:ext cx="2679192" cy="278892"/>
+            <a:ext cx="2496312" cy="278892"/>
           </a:xfrm>
           <a:prstGeom prst="rect">
             <a:avLst/>
@@ -5310,14 +5450,14 @@
       </p:sp>
       <p:sp>
         <p:nvSpPr>
-          <p:cNvPr id="60" name="TextBox 59"/>
-          <p:cNvSpPr txBox="1"/>
-          <p:nvPr/>
-        </p:nvSpPr>
-        <p:spPr>
-          <a:xfrm>
-            <a:off x="3200400" y="4174236"/>
-            <a:ext cx="1234440" cy="278892"/>
+          <p:cNvPr id="64" name="TextBox 63"/>
+          <p:cNvSpPr txBox="1"/>
+          <p:nvPr/>
+        </p:nvSpPr>
+        <p:spPr>
+          <a:xfrm>
+            <a:off x="3017520" y="4174236"/>
+            <a:ext cx="1051560" cy="278892"/>
           </a:xfrm>
           <a:prstGeom prst="rect">
             <a:avLst/>
@@ -5345,14 +5485,14 @@
       </p:sp>
       <p:sp>
         <p:nvSpPr>
-          <p:cNvPr id="61" name="TextBox 60"/>
-          <p:cNvSpPr txBox="1"/>
-          <p:nvPr/>
-        </p:nvSpPr>
-        <p:spPr>
-          <a:xfrm>
-            <a:off x="4434840" y="4174236"/>
-            <a:ext cx="1188720" cy="278892"/>
+          <p:cNvPr id="65" name="TextBox 64"/>
+          <p:cNvSpPr txBox="1"/>
+          <p:nvPr/>
+        </p:nvSpPr>
+        <p:spPr>
+          <a:xfrm>
+            <a:off x="4069080" y="4174236"/>
+            <a:ext cx="960120" cy="278892"/>
           </a:xfrm>
           <a:prstGeom prst="rect">
             <a:avLst/>
@@ -5380,14 +5520,14 @@
       </p:sp>
       <p:sp>
         <p:nvSpPr>
-          <p:cNvPr id="62" name="TextBox 61"/>
-          <p:cNvSpPr txBox="1"/>
-          <p:nvPr/>
-        </p:nvSpPr>
-        <p:spPr>
-          <a:xfrm>
-            <a:off x="5623560" y="4174236"/>
-            <a:ext cx="1371600" cy="278892"/>
+          <p:cNvPr id="66" name="TextBox 65"/>
+          <p:cNvSpPr txBox="1"/>
+          <p:nvPr/>
+        </p:nvSpPr>
+        <p:spPr>
+          <a:xfrm>
+            <a:off x="5029200" y="4174236"/>
+            <a:ext cx="1143000" cy="278892"/>
           </a:xfrm>
           <a:prstGeom prst="rect">
             <a:avLst/>
@@ -5415,14 +5555,14 @@
       </p:sp>
       <p:sp>
         <p:nvSpPr>
-          <p:cNvPr id="63" name="TextBox 62"/>
-          <p:cNvSpPr txBox="1"/>
-          <p:nvPr/>
-        </p:nvSpPr>
-        <p:spPr>
-          <a:xfrm>
-            <a:off x="6995160" y="4174236"/>
-            <a:ext cx="1051560" cy="278892"/>
+          <p:cNvPr id="67" name="TextBox 66"/>
+          <p:cNvSpPr txBox="1"/>
+          <p:nvPr/>
+        </p:nvSpPr>
+        <p:spPr>
+          <a:xfrm>
+            <a:off x="6172200" y="4174236"/>
+            <a:ext cx="914400" cy="278892"/>
           </a:xfrm>
           <a:prstGeom prst="rect">
             <a:avLst/>
@@ -5450,7 +5590,42 @@
       </p:sp>
       <p:sp>
         <p:nvSpPr>
-          <p:cNvPr id="64" name="Rectangle 63"/>
+          <p:cNvPr id="68" name="TextBox 67"/>
+          <p:cNvSpPr txBox="1"/>
+          <p:nvPr/>
+        </p:nvSpPr>
+        <p:spPr>
+          <a:xfrm>
+            <a:off x="7086600" y="4174236"/>
+            <a:ext cx="960120" cy="278892"/>
+          </a:xfrm>
+          <a:prstGeom prst="rect">
+            <a:avLst/>
+          </a:prstGeom>
+          <a:noFill/>
+        </p:spPr>
+        <p:txBody>
+          <a:bodyPr wrap="square" lIns="36000" rIns="36000" tIns="18000" bIns="18000" anchor="ctr">
+            <a:spAutoFit/>
+          </a:bodyPr>
+          <a:lstStyle/>
+          <a:p>
+            <a:pPr algn="ctr"/>
+            <a:r>
+              <a:rPr sz="1100" b="0" i="0" u="none">
+                <a:solidFill>
+                  <a:srgbClr val="333333"/>
+                </a:solidFill>
+                <a:latin typeface="Calibri"/>
+              </a:rPr>
+              <a:t>21</a:t>
+            </a:r>
+          </a:p>
+        </p:txBody>
+      </p:sp>
+      <p:sp>
+        <p:nvSpPr>
+          <p:cNvPr id="69" name="Rectangle 68"/>
           <p:cNvSpPr/>
           <p:nvPr/>
         </p:nvSpPr>
@@ -5494,7 +5669,7 @@
       </p:sp>
       <p:sp>
         <p:nvSpPr>
-          <p:cNvPr id="65" name="Rectangle 64"/>
+          <p:cNvPr id="70" name="Rectangle 69"/>
           <p:cNvSpPr/>
           <p:nvPr/>
         </p:nvSpPr>
@@ -5538,14 +5713,14 @@
       </p:sp>
       <p:sp>
         <p:nvSpPr>
-          <p:cNvPr id="66" name="TextBox 65"/>
+          <p:cNvPr id="71" name="TextBox 70"/>
           <p:cNvSpPr txBox="1"/>
           <p:nvPr/>
         </p:nvSpPr>
         <p:spPr>
           <a:xfrm>
             <a:off x="521208" y="4453128"/>
-            <a:ext cx="2679192" cy="278892"/>
+            <a:ext cx="2496312" cy="278892"/>
           </a:xfrm>
           <a:prstGeom prst="rect">
             <a:avLst/>
@@ -5573,14 +5748,14 @@
       </p:sp>
       <p:sp>
         <p:nvSpPr>
-          <p:cNvPr id="67" name="TextBox 66"/>
-          <p:cNvSpPr txBox="1"/>
-          <p:nvPr/>
-        </p:nvSpPr>
-        <p:spPr>
-          <a:xfrm>
-            <a:off x="3200400" y="4453128"/>
-            <a:ext cx="1234440" cy="278892"/>
+          <p:cNvPr id="72" name="TextBox 71"/>
+          <p:cNvSpPr txBox="1"/>
+          <p:nvPr/>
+        </p:nvSpPr>
+        <p:spPr>
+          <a:xfrm>
+            <a:off x="3017520" y="4453128"/>
+            <a:ext cx="1051560" cy="278892"/>
           </a:xfrm>
           <a:prstGeom prst="rect">
             <a:avLst/>
@@ -5608,14 +5783,14 @@
       </p:sp>
       <p:sp>
         <p:nvSpPr>
-          <p:cNvPr id="68" name="TextBox 67"/>
-          <p:cNvSpPr txBox="1"/>
-          <p:nvPr/>
-        </p:nvSpPr>
-        <p:spPr>
-          <a:xfrm>
-            <a:off x="4434840" y="4453128"/>
-            <a:ext cx="1188720" cy="278892"/>
+          <p:cNvPr id="73" name="TextBox 72"/>
+          <p:cNvSpPr txBox="1"/>
+          <p:nvPr/>
+        </p:nvSpPr>
+        <p:spPr>
+          <a:xfrm>
+            <a:off x="4069080" y="4453128"/>
+            <a:ext cx="960120" cy="278892"/>
           </a:xfrm>
           <a:prstGeom prst="rect">
             <a:avLst/>
@@ -5643,14 +5818,14 @@
       </p:sp>
       <p:sp>
         <p:nvSpPr>
-          <p:cNvPr id="69" name="TextBox 68"/>
-          <p:cNvSpPr txBox="1"/>
-          <p:nvPr/>
-        </p:nvSpPr>
-        <p:spPr>
-          <a:xfrm>
-            <a:off x="5623560" y="4453128"/>
-            <a:ext cx="1371600" cy="278892"/>
+          <p:cNvPr id="74" name="TextBox 73"/>
+          <p:cNvSpPr txBox="1"/>
+          <p:nvPr/>
+        </p:nvSpPr>
+        <p:spPr>
+          <a:xfrm>
+            <a:off x="5029200" y="4453128"/>
+            <a:ext cx="1143000" cy="278892"/>
           </a:xfrm>
           <a:prstGeom prst="rect">
             <a:avLst/>
@@ -5678,14 +5853,14 @@
       </p:sp>
       <p:sp>
         <p:nvSpPr>
-          <p:cNvPr id="70" name="TextBox 69"/>
-          <p:cNvSpPr txBox="1"/>
-          <p:nvPr/>
-        </p:nvSpPr>
-        <p:spPr>
-          <a:xfrm>
-            <a:off x="6995160" y="4453128"/>
-            <a:ext cx="1051560" cy="278892"/>
+          <p:cNvPr id="75" name="TextBox 74"/>
+          <p:cNvSpPr txBox="1"/>
+          <p:nvPr/>
+        </p:nvSpPr>
+        <p:spPr>
+          <a:xfrm>
+            <a:off x="6172200" y="4453128"/>
+            <a:ext cx="914400" cy="278892"/>
           </a:xfrm>
           <a:prstGeom prst="rect">
             <a:avLst/>
@@ -5713,7 +5888,42 @@
       </p:sp>
       <p:sp>
         <p:nvSpPr>
-          <p:cNvPr id="71" name="Rectangle 70"/>
+          <p:cNvPr id="76" name="TextBox 75"/>
+          <p:cNvSpPr txBox="1"/>
+          <p:nvPr/>
+        </p:nvSpPr>
+        <p:spPr>
+          <a:xfrm>
+            <a:off x="7086600" y="4453128"/>
+            <a:ext cx="960120" cy="278892"/>
+          </a:xfrm>
+          <a:prstGeom prst="rect">
+            <a:avLst/>
+          </a:prstGeom>
+          <a:noFill/>
+        </p:spPr>
+        <p:txBody>
+          <a:bodyPr wrap="square" lIns="36000" rIns="36000" tIns="18000" bIns="18000" anchor="ctr">
+            <a:spAutoFit/>
+          </a:bodyPr>
+          <a:lstStyle/>
+          <a:p>
+            <a:pPr algn="ctr"/>
+            <a:r>
+              <a:rPr sz="1100" b="1" i="1" u="none">
+                <a:solidFill>
+                  <a:srgbClr val="C86E10"/>
+                </a:solidFill>
+                <a:latin typeface="Calibri"/>
+              </a:rPr>
+              <a:t>6</a:t>
+            </a:r>
+          </a:p>
+        </p:txBody>
+      </p:sp>
+      <p:sp>
+        <p:nvSpPr>
+          <p:cNvPr id="77" name="Rectangle 76"/>
           <p:cNvSpPr/>
           <p:nvPr/>
         </p:nvSpPr>
@@ -5757,7 +5967,7 @@
       </p:sp>
       <p:sp>
         <p:nvSpPr>
-          <p:cNvPr id="72" name="Rectangle 71"/>
+          <p:cNvPr id="78" name="Rectangle 77"/>
           <p:cNvSpPr/>
           <p:nvPr/>
         </p:nvSpPr>
@@ -5801,14 +6011,14 @@
       </p:sp>
       <p:sp>
         <p:nvSpPr>
-          <p:cNvPr id="73" name="TextBox 72"/>
+          <p:cNvPr id="79" name="TextBox 78"/>
           <p:cNvSpPr txBox="1"/>
           <p:nvPr/>
         </p:nvSpPr>
         <p:spPr>
           <a:xfrm>
             <a:off x="521208" y="4732020"/>
-            <a:ext cx="2679192" cy="278892"/>
+            <a:ext cx="2496312" cy="278892"/>
           </a:xfrm>
           <a:prstGeom prst="rect">
             <a:avLst/>
@@ -5836,14 +6046,14 @@
       </p:sp>
       <p:sp>
         <p:nvSpPr>
-          <p:cNvPr id="74" name="TextBox 73"/>
-          <p:cNvSpPr txBox="1"/>
-          <p:nvPr/>
-        </p:nvSpPr>
-        <p:spPr>
-          <a:xfrm>
-            <a:off x="3200400" y="4732020"/>
-            <a:ext cx="1234440" cy="278892"/>
+          <p:cNvPr id="80" name="TextBox 79"/>
+          <p:cNvSpPr txBox="1"/>
+          <p:nvPr/>
+        </p:nvSpPr>
+        <p:spPr>
+          <a:xfrm>
+            <a:off x="3017520" y="4732020"/>
+            <a:ext cx="1051560" cy="278892"/>
           </a:xfrm>
           <a:prstGeom prst="rect">
             <a:avLst/>
@@ -5871,14 +6081,14 @@
       </p:sp>
       <p:sp>
         <p:nvSpPr>
-          <p:cNvPr id="75" name="TextBox 74"/>
-          <p:cNvSpPr txBox="1"/>
-          <p:nvPr/>
-        </p:nvSpPr>
-        <p:spPr>
-          <a:xfrm>
-            <a:off x="4434840" y="4732020"/>
-            <a:ext cx="1188720" cy="278892"/>
+          <p:cNvPr id="81" name="TextBox 80"/>
+          <p:cNvSpPr txBox="1"/>
+          <p:nvPr/>
+        </p:nvSpPr>
+        <p:spPr>
+          <a:xfrm>
+            <a:off x="4069080" y="4732020"/>
+            <a:ext cx="960120" cy="278892"/>
           </a:xfrm>
           <a:prstGeom prst="rect">
             <a:avLst/>
@@ -5906,14 +6116,14 @@
       </p:sp>
       <p:sp>
         <p:nvSpPr>
-          <p:cNvPr id="76" name="TextBox 75"/>
-          <p:cNvSpPr txBox="1"/>
-          <p:nvPr/>
-        </p:nvSpPr>
-        <p:spPr>
-          <a:xfrm>
-            <a:off x="5623560" y="4732020"/>
-            <a:ext cx="1371600" cy="278892"/>
+          <p:cNvPr id="82" name="TextBox 81"/>
+          <p:cNvSpPr txBox="1"/>
+          <p:nvPr/>
+        </p:nvSpPr>
+        <p:spPr>
+          <a:xfrm>
+            <a:off x="5029200" y="4732020"/>
+            <a:ext cx="1143000" cy="278892"/>
           </a:xfrm>
           <a:prstGeom prst="rect">
             <a:avLst/>
@@ -5941,14 +6151,14 @@
       </p:sp>
       <p:sp>
         <p:nvSpPr>
-          <p:cNvPr id="77" name="TextBox 76"/>
-          <p:cNvSpPr txBox="1"/>
-          <p:nvPr/>
-        </p:nvSpPr>
-        <p:spPr>
-          <a:xfrm>
-            <a:off x="6995160" y="4732020"/>
-            <a:ext cx="1051560" cy="278892"/>
+          <p:cNvPr id="83" name="TextBox 82"/>
+          <p:cNvSpPr txBox="1"/>
+          <p:nvPr/>
+        </p:nvSpPr>
+        <p:spPr>
+          <a:xfrm>
+            <a:off x="6172200" y="4732020"/>
+            <a:ext cx="914400" cy="278892"/>
           </a:xfrm>
           <a:prstGeom prst="rect">
             <a:avLst/>
@@ -5976,7 +6186,42 @@
       </p:sp>
       <p:sp>
         <p:nvSpPr>
-          <p:cNvPr id="78" name="Rectangle 77"/>
+          <p:cNvPr id="84" name="TextBox 83"/>
+          <p:cNvSpPr txBox="1"/>
+          <p:nvPr/>
+        </p:nvSpPr>
+        <p:spPr>
+          <a:xfrm>
+            <a:off x="7086600" y="4732020"/>
+            <a:ext cx="960120" cy="278892"/>
+          </a:xfrm>
+          <a:prstGeom prst="rect">
+            <a:avLst/>
+          </a:prstGeom>
+          <a:noFill/>
+        </p:spPr>
+        <p:txBody>
+          <a:bodyPr wrap="square" lIns="36000" rIns="36000" tIns="18000" bIns="18000" anchor="ctr">
+            <a:spAutoFit/>
+          </a:bodyPr>
+          <a:lstStyle/>
+          <a:p>
+            <a:pPr algn="ctr"/>
+            <a:r>
+              <a:rPr sz="1100" b="1" i="0" u="none">
+                <a:solidFill>
+                  <a:srgbClr val="006B77"/>
+                </a:solidFill>
+                <a:latin typeface="Calibri"/>
+              </a:rPr>
+              <a:t>102</a:t>
+            </a:r>
+          </a:p>
+        </p:txBody>
+      </p:sp>
+      <p:sp>
+        <p:nvSpPr>
+          <p:cNvPr id="85" name="Rectangle 84"/>
           <p:cNvSpPr/>
           <p:nvPr/>
         </p:nvSpPr>
@@ -6020,14 +6265,14 @@
       </p:sp>
       <p:sp>
         <p:nvSpPr>
-          <p:cNvPr id="79" name="TextBox 78"/>
+          <p:cNvPr id="86" name="TextBox 85"/>
           <p:cNvSpPr txBox="1"/>
           <p:nvPr/>
         </p:nvSpPr>
         <p:spPr>
           <a:xfrm>
             <a:off x="521208" y="5010912"/>
-            <a:ext cx="2679192" cy="278892"/>
+            <a:ext cx="2496312" cy="278892"/>
           </a:xfrm>
           <a:prstGeom prst="rect">
             <a:avLst/>
@@ -6055,14 +6300,14 @@
       </p:sp>
       <p:sp>
         <p:nvSpPr>
-          <p:cNvPr id="80" name="TextBox 79"/>
-          <p:cNvSpPr txBox="1"/>
-          <p:nvPr/>
-        </p:nvSpPr>
-        <p:spPr>
-          <a:xfrm>
-            <a:off x="3200400" y="5010912"/>
-            <a:ext cx="1234440" cy="278892"/>
+          <p:cNvPr id="87" name="TextBox 86"/>
+          <p:cNvSpPr txBox="1"/>
+          <p:nvPr/>
+        </p:nvSpPr>
+        <p:spPr>
+          <a:xfrm>
+            <a:off x="3017520" y="5010912"/>
+            <a:ext cx="1051560" cy="278892"/>
           </a:xfrm>
           <a:prstGeom prst="rect">
             <a:avLst/>
@@ -6090,14 +6335,14 @@
       </p:sp>
       <p:sp>
         <p:nvSpPr>
-          <p:cNvPr id="81" name="TextBox 80"/>
-          <p:cNvSpPr txBox="1"/>
-          <p:nvPr/>
-        </p:nvSpPr>
-        <p:spPr>
-          <a:xfrm>
-            <a:off x="4434840" y="5010912"/>
-            <a:ext cx="1188720" cy="278892"/>
+          <p:cNvPr id="88" name="TextBox 87"/>
+          <p:cNvSpPr txBox="1"/>
+          <p:nvPr/>
+        </p:nvSpPr>
+        <p:spPr>
+          <a:xfrm>
+            <a:off x="4069080" y="5010912"/>
+            <a:ext cx="960120" cy="278892"/>
           </a:xfrm>
           <a:prstGeom prst="rect">
             <a:avLst/>
@@ -6125,14 +6370,14 @@
       </p:sp>
       <p:sp>
         <p:nvSpPr>
-          <p:cNvPr id="82" name="TextBox 81"/>
-          <p:cNvSpPr txBox="1"/>
-          <p:nvPr/>
-        </p:nvSpPr>
-        <p:spPr>
-          <a:xfrm>
-            <a:off x="5623560" y="5010912"/>
-            <a:ext cx="1371600" cy="278892"/>
+          <p:cNvPr id="89" name="TextBox 88"/>
+          <p:cNvSpPr txBox="1"/>
+          <p:nvPr/>
+        </p:nvSpPr>
+        <p:spPr>
+          <a:xfrm>
+            <a:off x="5029200" y="5010912"/>
+            <a:ext cx="1143000" cy="278892"/>
           </a:xfrm>
           <a:prstGeom prst="rect">
             <a:avLst/>
@@ -6160,14 +6405,14 @@
       </p:sp>
       <p:sp>
         <p:nvSpPr>
-          <p:cNvPr id="83" name="TextBox 82"/>
-          <p:cNvSpPr txBox="1"/>
-          <p:nvPr/>
-        </p:nvSpPr>
-        <p:spPr>
-          <a:xfrm>
-            <a:off x="6995160" y="5010912"/>
-            <a:ext cx="1051560" cy="278892"/>
+          <p:cNvPr id="90" name="TextBox 89"/>
+          <p:cNvSpPr txBox="1"/>
+          <p:nvPr/>
+        </p:nvSpPr>
+        <p:spPr>
+          <a:xfrm>
+            <a:off x="6172200" y="5010912"/>
+            <a:ext cx="914400" cy="278892"/>
           </a:xfrm>
           <a:prstGeom prst="rect">
             <a:avLst/>
@@ -6195,7 +6440,42 @@
       </p:sp>
       <p:sp>
         <p:nvSpPr>
-          <p:cNvPr id="84" name="Rectangle 83"/>
+          <p:cNvPr id="91" name="TextBox 90"/>
+          <p:cNvSpPr txBox="1"/>
+          <p:nvPr/>
+        </p:nvSpPr>
+        <p:spPr>
+          <a:xfrm>
+            <a:off x="7086600" y="5010912"/>
+            <a:ext cx="960120" cy="278892"/>
+          </a:xfrm>
+          <a:prstGeom prst="rect">
+            <a:avLst/>
+          </a:prstGeom>
+          <a:noFill/>
+        </p:spPr>
+        <p:txBody>
+          <a:bodyPr wrap="square" lIns="36000" rIns="36000" tIns="18000" bIns="18000" anchor="ctr">
+            <a:spAutoFit/>
+          </a:bodyPr>
+          <a:lstStyle/>
+          <a:p>
+            <a:pPr algn="ctr"/>
+            <a:r>
+              <a:rPr sz="1100" b="0" i="1" u="none">
+                <a:solidFill>
+                  <a:srgbClr val="666666"/>
+                </a:solidFill>
+                <a:latin typeface="Calibri"/>
+              </a:rPr>
+              <a:t>2 %</a:t>
+            </a:r>
+          </a:p>
+        </p:txBody>
+      </p:sp>
+      <p:sp>
+        <p:nvSpPr>
+          <p:cNvPr id="92" name="Rectangle 91"/>
           <p:cNvSpPr/>
           <p:nvPr/>
         </p:nvSpPr>
@@ -6239,14 +6519,14 @@
       </p:sp>
       <p:sp>
         <p:nvSpPr>
-          <p:cNvPr id="85" name="TextBox 84"/>
+          <p:cNvPr id="93" name="TextBox 92"/>
           <p:cNvSpPr txBox="1"/>
           <p:nvPr/>
         </p:nvSpPr>
         <p:spPr>
           <a:xfrm>
             <a:off x="521208" y="5289804"/>
-            <a:ext cx="2679192" cy="278892"/>
+            <a:ext cx="2496312" cy="278892"/>
           </a:xfrm>
           <a:prstGeom prst="rect">
             <a:avLst/>
@@ -6274,14 +6554,14 @@
       </p:sp>
       <p:sp>
         <p:nvSpPr>
-          <p:cNvPr id="86" name="TextBox 85"/>
-          <p:cNvSpPr txBox="1"/>
-          <p:nvPr/>
-        </p:nvSpPr>
-        <p:spPr>
-          <a:xfrm>
-            <a:off x="3200400" y="5289804"/>
-            <a:ext cx="1234440" cy="278892"/>
+          <p:cNvPr id="94" name="TextBox 93"/>
+          <p:cNvSpPr txBox="1"/>
+          <p:nvPr/>
+        </p:nvSpPr>
+        <p:spPr>
+          <a:xfrm>
+            <a:off x="3017520" y="5289804"/>
+            <a:ext cx="1051560" cy="278892"/>
           </a:xfrm>
           <a:prstGeom prst="rect">
             <a:avLst/>
@@ -6309,14 +6589,14 @@
       </p:sp>
       <p:sp>
         <p:nvSpPr>
-          <p:cNvPr id="87" name="TextBox 86"/>
-          <p:cNvSpPr txBox="1"/>
-          <p:nvPr/>
-        </p:nvSpPr>
-        <p:spPr>
-          <a:xfrm>
-            <a:off x="4434840" y="5289804"/>
-            <a:ext cx="1188720" cy="278892"/>
+          <p:cNvPr id="95" name="TextBox 94"/>
+          <p:cNvSpPr txBox="1"/>
+          <p:nvPr/>
+        </p:nvSpPr>
+        <p:spPr>
+          <a:xfrm>
+            <a:off x="4069080" y="5289804"/>
+            <a:ext cx="960120" cy="278892"/>
           </a:xfrm>
           <a:prstGeom prst="rect">
             <a:avLst/>
@@ -6344,14 +6624,14 @@
       </p:sp>
       <p:sp>
         <p:nvSpPr>
-          <p:cNvPr id="88" name="TextBox 87"/>
-          <p:cNvSpPr txBox="1"/>
-          <p:nvPr/>
-        </p:nvSpPr>
-        <p:spPr>
-          <a:xfrm>
-            <a:off x="5623560" y="5289804"/>
-            <a:ext cx="1371600" cy="278892"/>
+          <p:cNvPr id="96" name="TextBox 95"/>
+          <p:cNvSpPr txBox="1"/>
+          <p:nvPr/>
+        </p:nvSpPr>
+        <p:spPr>
+          <a:xfrm>
+            <a:off x="5029200" y="5289804"/>
+            <a:ext cx="1143000" cy="278892"/>
           </a:xfrm>
           <a:prstGeom prst="rect">
             <a:avLst/>
@@ -6379,14 +6659,14 @@
       </p:sp>
       <p:sp>
         <p:nvSpPr>
-          <p:cNvPr id="89" name="TextBox 88"/>
-          <p:cNvSpPr txBox="1"/>
-          <p:nvPr/>
-        </p:nvSpPr>
-        <p:spPr>
-          <a:xfrm>
-            <a:off x="6995160" y="5289804"/>
-            <a:ext cx="1051560" cy="278892"/>
+          <p:cNvPr id="97" name="TextBox 96"/>
+          <p:cNvSpPr txBox="1"/>
+          <p:nvPr/>
+        </p:nvSpPr>
+        <p:spPr>
+          <a:xfrm>
+            <a:off x="6172200" y="5289804"/>
+            <a:ext cx="914400" cy="278892"/>
           </a:xfrm>
           <a:prstGeom prst="rect">
             <a:avLst/>
@@ -6414,7 +6694,42 @@
       </p:sp>
       <p:sp>
         <p:nvSpPr>
-          <p:cNvPr id="90" name="TextBox 89"/>
+          <p:cNvPr id="98" name="TextBox 97"/>
+          <p:cNvSpPr txBox="1"/>
+          <p:nvPr/>
+        </p:nvSpPr>
+        <p:spPr>
+          <a:xfrm>
+            <a:off x="7086600" y="5289804"/>
+            <a:ext cx="960120" cy="278892"/>
+          </a:xfrm>
+          <a:prstGeom prst="rect">
+            <a:avLst/>
+          </a:prstGeom>
+          <a:noFill/>
+        </p:spPr>
+        <p:txBody>
+          <a:bodyPr wrap="square" lIns="36000" rIns="36000" tIns="18000" bIns="18000" anchor="ctr">
+            <a:spAutoFit/>
+          </a:bodyPr>
+          <a:lstStyle/>
+          <a:p>
+            <a:pPr algn="ctr"/>
+            <a:r>
+              <a:rPr sz="1100" b="0" i="1" u="none">
+                <a:solidFill>
+                  <a:srgbClr val="666666"/>
+                </a:solidFill>
+                <a:latin typeface="Calibri"/>
+              </a:rPr>
+              <a:t>9 %</a:t>
+            </a:r>
+          </a:p>
+        </p:txBody>
+      </p:sp>
+      <p:sp>
+        <p:nvSpPr>
+          <p:cNvPr id="99" name="TextBox 98"/>
           <p:cNvSpPr txBox="1"/>
           <p:nvPr/>
         </p:nvSpPr>
@@ -6442,14 +6757,14 @@
                 </a:solidFill>
                 <a:latin typeface="Calibri"/>
               </a:rPr>
-              <a:t>* MV im Anhang ohne neue BÜ = potentielles Falschrouting (240 / Wo → Hebel 1, 11a).  Cluster-Anteil &amp; Top-5-Makler → Hebel 2 (Arbeitsvorrats-Steuerung, 11b).</a:t>
-            </a:r>
-          </a:p>
-        </p:txBody>
-      </p:sp>
-      <p:sp>
-        <p:nvSpPr>
-          <p:cNvPr id="91" name="Rectangle 90"/>
+              <a:t>* MV im Anhang ohne neue BÜ = potentielles Falschrouting (240 / Wo → Hebel 1, 11a).  Cluster-Anteil &amp; Top-5-Makler → Hebel 2 (11b).  Sonstige = Sparte unklar / Spam (346 der Keine-BÜ ohne MV).</a:t>
+            </a:r>
+          </a:p>
+        </p:txBody>
+      </p:sp>
+      <p:sp>
+        <p:nvSpPr>
+          <p:cNvPr id="100" name="Rectangle 99"/>
           <p:cNvSpPr/>
           <p:nvPr/>
         </p:nvSpPr>
@@ -6493,7 +6808,7 @@
       </p:sp>
       <p:sp>
         <p:nvSpPr>
-          <p:cNvPr id="92" name="Oval 91"/>
+          <p:cNvPr id="101" name="Oval 100"/>
           <p:cNvSpPr/>
           <p:nvPr/>
         </p:nvSpPr>
@@ -6537,7 +6852,7 @@
       </p:sp>
       <p:sp>
         <p:nvSpPr>
-          <p:cNvPr id="93" name="TextBox 92"/>
+          <p:cNvPr id="102" name="TextBox 101"/>
           <p:cNvSpPr txBox="1"/>
           <p:nvPr/>
         </p:nvSpPr>
@@ -6572,7 +6887,7 @@
       </p:sp>
       <p:sp>
         <p:nvSpPr>
-          <p:cNvPr id="94" name="TextBox 93"/>
+          <p:cNvPr id="103" name="TextBox 102"/>
           <p:cNvSpPr txBox="1"/>
           <p:nvPr/>
         </p:nvSpPr>
@@ -6616,7 +6931,7 @@
       </p:sp>
       <p:sp>
         <p:nvSpPr>
-          <p:cNvPr id="95" name="Oval 94"/>
+          <p:cNvPr id="104" name="Oval 103"/>
           <p:cNvSpPr/>
           <p:nvPr/>
         </p:nvSpPr>
@@ -6660,7 +6975,7 @@
       </p:sp>
       <p:sp>
         <p:nvSpPr>
-          <p:cNvPr id="96" name="TextBox 95"/>
+          <p:cNvPr id="105" name="TextBox 104"/>
           <p:cNvSpPr txBox="1"/>
           <p:nvPr/>
         </p:nvSpPr>
@@ -6695,7 +7010,7 @@
       </p:sp>
       <p:sp>
         <p:nvSpPr>
-          <p:cNvPr id="97" name="TextBox 96"/>
+          <p:cNvPr id="106" name="TextBox 105"/>
           <p:cNvSpPr txBox="1"/>
           <p:nvPr/>
         </p:nvSpPr>
@@ -6739,7 +7054,7 @@
       </p:sp>
       <p:sp>
         <p:nvSpPr>
-          <p:cNvPr id="98" name="Oval 97"/>
+          <p:cNvPr id="107" name="Oval 106"/>
           <p:cNvSpPr/>
           <p:nvPr/>
         </p:nvSpPr>
@@ -6783,7 +7098,7 @@
       </p:sp>
       <p:sp>
         <p:nvSpPr>
-          <p:cNvPr id="99" name="TextBox 98"/>
+          <p:cNvPr id="108" name="TextBox 107"/>
           <p:cNvSpPr txBox="1"/>
           <p:nvPr/>
         </p:nvSpPr>
@@ -6818,7 +7133,7 @@
       </p:sp>
       <p:sp>
         <p:nvSpPr>
-          <p:cNvPr id="100" name="TextBox 99"/>
+          <p:cNvPr id="109" name="TextBox 108"/>
           <p:cNvSpPr txBox="1"/>
           <p:nvPr/>
         </p:nvSpPr>
@@ -6862,7 +7177,7 @@
       </p:sp>
       <p:sp>
         <p:nvSpPr>
-          <p:cNvPr id="101" name="Oval 100"/>
+          <p:cNvPr id="110" name="Oval 109"/>
           <p:cNvSpPr/>
           <p:nvPr/>
         </p:nvSpPr>
@@ -6906,7 +7221,7 @@
       </p:sp>
       <p:sp>
         <p:nvSpPr>
-          <p:cNvPr id="102" name="TextBox 101"/>
+          <p:cNvPr id="111" name="TextBox 110"/>
           <p:cNvSpPr txBox="1"/>
           <p:nvPr/>
         </p:nvSpPr>
@@ -6941,7 +7256,7 @@
       </p:sp>
       <p:sp>
         <p:nvSpPr>
-          <p:cNvPr id="103" name="TextBox 102"/>
+          <p:cNvPr id="112" name="TextBox 111"/>
           <p:cNvSpPr txBox="1"/>
           <p:nvPr/>
         </p:nvSpPr>
@@ -6985,7 +7300,7 @@
       </p:sp>
       <p:sp>
         <p:nvSpPr>
-          <p:cNvPr id="104" name="Oval 103"/>
+          <p:cNvPr id="113" name="Oval 112"/>
           <p:cNvSpPr/>
           <p:nvPr/>
         </p:nvSpPr>
@@ -7029,7 +7344,7 @@
       </p:sp>
       <p:sp>
         <p:nvSpPr>
-          <p:cNvPr id="105" name="TextBox 104"/>
+          <p:cNvPr id="114" name="TextBox 113"/>
           <p:cNvSpPr txBox="1"/>
           <p:nvPr/>
         </p:nvSpPr>
@@ -7064,7 +7379,7 @@
       </p:sp>
       <p:sp>
         <p:nvSpPr>
-          <p:cNvPr id="106" name="TextBox 105"/>
+          <p:cNvPr id="115" name="TextBox 114"/>
           <p:cNvSpPr txBox="1"/>
           <p:nvPr/>
         </p:nvSpPr>
@@ -7108,7 +7423,7 @@
       </p:sp>
       <p:sp>
         <p:nvSpPr>
-          <p:cNvPr id="107" name="TextBox 106"/>
+          <p:cNvPr id="116" name="TextBox 115"/>
           <p:cNvSpPr txBox="1"/>
           <p:nvPr/>
         </p:nvSpPr>
@@ -7143,7 +7458,7 @@
       </p:sp>
       <p:sp>
         <p:nvSpPr>
-          <p:cNvPr id="108" name="Rectangle 107"/>
+          <p:cNvPr id="117" name="Rectangle 116"/>
           <p:cNvSpPr/>
           <p:nvPr/>
         </p:nvSpPr>
@@ -7187,7 +7502,7 @@
       </p:sp>
       <p:sp>
         <p:nvSpPr>
-          <p:cNvPr id="109" name="TextBox 108"/>
+          <p:cNvPr id="118" name="TextBox 117"/>
           <p:cNvSpPr txBox="1"/>
           <p:nvPr/>
         </p:nvSpPr>

</xml_diff>

<commit_message>
PPTX Folie 11: Top-5-Makler & Cluster-Anteil mit Absolutwerten
Beide Ergaenzungs-Zeilen jetzt absolut + Prozent:
  Top-5-Makler: 2.890(57%) | KV 886(68%) | Komp 1.489(60%) | Leben 505(67%) | Sonst 10(2%)
  in Cluster:   2.370(47%) | KV 399(31%) | Komp 1.573(63%) | Leben 357(47%) | Sonst 41(9%)
Font in Ergaenzungs-Zeilen auf 9pt fuer Platz.

https://claude.ai/code/session_01UknXtYp2XECsQDonCZuxSt
</commit_message>
<xml_diff>
--- a/ERGO-Mengengeruest-2Slides-Berichtslook.pptx
+++ b/ERGO-Mengengeruest-2Slides-Berichtslook.pptx
@@ -6287,7 +6287,7 @@
           <a:p>
             <a:pPr algn="l"/>
             <a:r>
-              <a:rPr sz="1000" b="0" i="1" u="none">
+              <a:rPr sz="900" b="0" i="1" u="none">
                 <a:solidFill>
                   <a:srgbClr val="666666"/>
                 </a:solidFill>
@@ -6322,13 +6322,13 @@
           <a:p>
             <a:pPr algn="ctr"/>
             <a:r>
-              <a:rPr sz="1100" b="1" i="1" u="none">
+              <a:rPr sz="900" b="1" i="1" u="none">
                 <a:solidFill>
                   <a:srgbClr val="666666"/>
                 </a:solidFill>
                 <a:latin typeface="Calibri"/>
               </a:rPr>
-              <a:t>57 %</a:t>
+              <a:t>2.890 (57 %)</a:t>
             </a:r>
           </a:p>
         </p:txBody>
@@ -6357,13 +6357,13 @@
           <a:p>
             <a:pPr algn="ctr"/>
             <a:r>
-              <a:rPr sz="1100" b="0" i="1" u="none">
+              <a:rPr sz="900" b="0" i="1" u="none">
                 <a:solidFill>
                   <a:srgbClr val="666666"/>
                 </a:solidFill>
                 <a:latin typeface="Calibri"/>
               </a:rPr>
-              <a:t>68 %</a:t>
+              <a:t>886 (68 %)</a:t>
             </a:r>
           </a:p>
         </p:txBody>
@@ -6392,13 +6392,13 @@
           <a:p>
             <a:pPr algn="ctr"/>
             <a:r>
-              <a:rPr sz="1100" b="0" i="1" u="none">
+              <a:rPr sz="900" b="0" i="1" u="none">
                 <a:solidFill>
                   <a:srgbClr val="666666"/>
                 </a:solidFill>
                 <a:latin typeface="Calibri"/>
               </a:rPr>
-              <a:t>60 %</a:t>
+              <a:t>1.489 (60 %)</a:t>
             </a:r>
           </a:p>
         </p:txBody>
@@ -6427,13 +6427,13 @@
           <a:p>
             <a:pPr algn="ctr"/>
             <a:r>
-              <a:rPr sz="1100" b="0" i="1" u="none">
+              <a:rPr sz="900" b="0" i="1" u="none">
                 <a:solidFill>
                   <a:srgbClr val="666666"/>
                 </a:solidFill>
                 <a:latin typeface="Calibri"/>
               </a:rPr>
-              <a:t>67 %</a:t>
+              <a:t>505 (67 %)</a:t>
             </a:r>
           </a:p>
         </p:txBody>
@@ -6462,13 +6462,13 @@
           <a:p>
             <a:pPr algn="ctr"/>
             <a:r>
-              <a:rPr sz="1100" b="0" i="1" u="none">
+              <a:rPr sz="900" b="0" i="1" u="none">
                 <a:solidFill>
                   <a:srgbClr val="666666"/>
                 </a:solidFill>
                 <a:latin typeface="Calibri"/>
               </a:rPr>
-              <a:t>2 %</a:t>
+              <a:t>10 (2 %)</a:t>
             </a:r>
           </a:p>
         </p:txBody>
@@ -6541,7 +6541,7 @@
           <a:p>
             <a:pPr algn="l"/>
             <a:r>
-              <a:rPr sz="1000" b="0" i="1" u="none">
+              <a:rPr sz="900" b="0" i="1" u="none">
                 <a:solidFill>
                   <a:srgbClr val="666666"/>
                 </a:solidFill>
@@ -6576,13 +6576,13 @@
           <a:p>
             <a:pPr algn="ctr"/>
             <a:r>
-              <a:rPr sz="1100" b="1" i="1" u="none">
+              <a:rPr sz="900" b="1" i="1" u="none">
                 <a:solidFill>
                   <a:srgbClr val="666666"/>
                 </a:solidFill>
                 <a:latin typeface="Calibri"/>
               </a:rPr>
-              <a:t>47 %</a:t>
+              <a:t>2.370 (47 %)</a:t>
             </a:r>
           </a:p>
         </p:txBody>
@@ -6611,13 +6611,13 @@
           <a:p>
             <a:pPr algn="ctr"/>
             <a:r>
-              <a:rPr sz="1100" b="0" i="1" u="none">
+              <a:rPr sz="900" b="0" i="1" u="none">
                 <a:solidFill>
                   <a:srgbClr val="666666"/>
                 </a:solidFill>
                 <a:latin typeface="Calibri"/>
               </a:rPr>
-              <a:t>31 %</a:t>
+              <a:t>399 (31 %)</a:t>
             </a:r>
           </a:p>
         </p:txBody>
@@ -6646,13 +6646,13 @@
           <a:p>
             <a:pPr algn="ctr"/>
             <a:r>
-              <a:rPr sz="1100" b="0" i="1" u="none">
+              <a:rPr sz="900" b="0" i="1" u="none">
                 <a:solidFill>
                   <a:srgbClr val="666666"/>
                 </a:solidFill>
                 <a:latin typeface="Calibri"/>
               </a:rPr>
-              <a:t>63 %</a:t>
+              <a:t>1.573 (63 %)</a:t>
             </a:r>
           </a:p>
         </p:txBody>
@@ -6681,13 +6681,13 @@
           <a:p>
             <a:pPr algn="ctr"/>
             <a:r>
-              <a:rPr sz="1100" b="0" i="1" u="none">
+              <a:rPr sz="900" b="0" i="1" u="none">
                 <a:solidFill>
                   <a:srgbClr val="666666"/>
                 </a:solidFill>
                 <a:latin typeface="Calibri"/>
               </a:rPr>
-              <a:t>47 %</a:t>
+              <a:t>357 (47 %)</a:t>
             </a:r>
           </a:p>
         </p:txBody>
@@ -6716,13 +6716,13 @@
           <a:p>
             <a:pPr algn="ctr"/>
             <a:r>
-              <a:rPr sz="1100" b="0" i="1" u="none">
+              <a:rPr sz="900" b="0" i="1" u="none">
                 <a:solidFill>
                   <a:srgbClr val="666666"/>
                 </a:solidFill>
                 <a:latin typeface="Calibri"/>
               </a:rPr>
-              <a:t>9 %</a:t>
+              <a:t>41 (9 %)</a:t>
             </a:r>
           </a:p>
         </p:txBody>

</xml_diff>

<commit_message>
PPTX: Folgefolien Herausforderung (12) + Loesung (13) ergaenzt
Aufbauend auf Folie 11 (IST/Mengengeruest), gleicher Berichts-Look,
durchgaengiger A/B-Faden (Routing / Clustering).

Folie 12 HERAUSFORDERUNG:
- Tab/Mini-Header + left_label 'HERAUSFORDERUNG'
- Problem-Wirkung-Tabelle: MV→BÜ (240 Fehlanlagen) / keine Cluster-Sicht
  (2.370 einzeln) / keine einheitlichen Felder (keine Prio-Steuerung)
- Kernaussagen A (Routing-Herausforderung) + B (Steuerungs-Herausforderung)
  mit A/B-Marker-Kreisen (rot/teal)

Folie 13 LÖSUNG:
- left_label 'LÖSUNG'
- Wirkkette-Box (Mail → KI-Strukturierung → Beiblatt 50 Felder) +
  3 Anwendungs-Kacheln (Routing / Vorgangs-Steuerung / autom. Pruefung)
- Kernaussagen A (Loesung Routing) + B (Loesung Steuerung)
- Take-away: Beiblatt loest Routing+Steuerung und ist Pflicht-Basis Bot-Pruefung

Neue Helfer: ab_circle (A/B-Marker), ab_kernaussagen, prob_table.
ergo_frame um Parameter left_label erweitert.

https://claude.ai/code/session_01UknXtYp2XECsQDonCZuxSt
</commit_message>
<xml_diff>
--- a/ERGO-Mengengeruest-2Slides-Berichtslook.pptx
+++ b/ERGO-Mengengeruest-2Slides-Berichtslook.pptx
@@ -8,6 +8,8 @@
     <p:sldId id="256" r:id="rId7"/>
     <p:sldId id="257" r:id="rId8"/>
     <p:sldId id="258" r:id="rId9"/>
+    <p:sldId id="259" r:id="rId10"/>
+    <p:sldId id="260" r:id="rId11"/>
   </p:sldIdLst>
   <p:sldSz cx="12191695" cy="6858000" type="screen4x3"/>
   <p:notesSz cx="6858000" cy="9144000"/>
@@ -13762,6 +13764,3172 @@
                 <a:latin typeface="Calibri"/>
               </a:rPr>
               <a:t>TAKE-AWAY:  Groesster Cluster-Hebel ist KV: dort fehlt heute die Vorgangs-Buendelung (jede Mail = ein Vorgang). Strukturierte Daten ermoeglichen Arbeitsvorrats-Steuerung nach Prio-Fall und Prio-Makler.</a:t>
+            </a:r>
+          </a:p>
+        </p:txBody>
+      </p:sp>
+    </p:spTree>
+  </p:cSld>
+  <p:clrMapOvr>
+    <a:masterClrMapping/>
+  </p:clrMapOvr>
+</p:sld>
+</file>
+
+<file path=ppt/slides/slide4.xml><?xml version="1.0" encoding="utf-8"?>
+<p:sld xmlns:a="http://schemas.openxmlformats.org/drawingml/2006/main" xmlns:p="http://schemas.openxmlformats.org/presentationml/2006/main" xmlns:r="http://schemas.openxmlformats.org/officeDocument/2006/relationships">
+  <p:cSld>
+    <p:spTree>
+      <p:nvGrpSpPr>
+        <p:cNvPr id="1" name=""/>
+        <p:cNvGrpSpPr/>
+        <p:nvPr/>
+      </p:nvGrpSpPr>
+      <p:grpSpPr/>
+      <p:sp>
+        <p:nvSpPr>
+          <p:cNvPr id="2" name="Pentagon 1"/>
+          <p:cNvSpPr/>
+          <p:nvPr/>
+        </p:nvSpPr>
+        <p:spPr>
+          <a:xfrm>
+            <a:off x="5120640" y="137160"/>
+            <a:ext cx="530352" cy="292608"/>
+          </a:xfrm>
+          <a:prstGeom prst="homePlate">
+            <a:avLst/>
+          </a:prstGeom>
+          <a:solidFill>
+            <a:srgbClr val="888888"/>
+          </a:solidFill>
+          <a:ln>
+            <a:noFill/>
+          </a:ln>
+          <a:effectLst/>
+        </p:spPr>
+        <p:style>
+          <a:lnRef idx="1">
+            <a:schemeClr val="accent1"/>
+          </a:lnRef>
+          <a:fillRef idx="3">
+            <a:schemeClr val="accent1"/>
+          </a:fillRef>
+          <a:effectRef idx="2">
+            <a:schemeClr val="accent1"/>
+          </a:effectRef>
+          <a:fontRef idx="minor">
+            <a:schemeClr val="lt1"/>
+          </a:fontRef>
+        </p:style>
+        <p:txBody>
+          <a:bodyPr rtlCol="0" anchor="ctr"/>
+          <a:lstStyle/>
+          <a:p>
+            <a:pPr algn="ctr"/>
+          </a:p>
+        </p:txBody>
+      </p:sp>
+      <p:sp>
+        <p:nvSpPr>
+          <p:cNvPr id="3" name="Pentagon 2"/>
+          <p:cNvSpPr/>
+          <p:nvPr/>
+        </p:nvSpPr>
+        <p:spPr>
+          <a:xfrm>
+            <a:off x="5687568" y="137160"/>
+            <a:ext cx="530352" cy="292608"/>
+          </a:xfrm>
+          <a:prstGeom prst="homePlate">
+            <a:avLst/>
+          </a:prstGeom>
+          <a:solidFill>
+            <a:srgbClr val="008793"/>
+          </a:solidFill>
+          <a:ln>
+            <a:noFill/>
+          </a:ln>
+          <a:effectLst/>
+        </p:spPr>
+        <p:style>
+          <a:lnRef idx="1">
+            <a:schemeClr val="accent1"/>
+          </a:lnRef>
+          <a:fillRef idx="3">
+            <a:schemeClr val="accent1"/>
+          </a:fillRef>
+          <a:effectRef idx="2">
+            <a:schemeClr val="accent1"/>
+          </a:effectRef>
+          <a:fontRef idx="minor">
+            <a:schemeClr val="lt1"/>
+          </a:fontRef>
+        </p:style>
+        <p:txBody>
+          <a:bodyPr rtlCol="0" anchor="ctr"/>
+          <a:lstStyle/>
+          <a:p>
+            <a:pPr algn="ctr"/>
+          </a:p>
+        </p:txBody>
+      </p:sp>
+      <p:sp>
+        <p:nvSpPr>
+          <p:cNvPr id="4" name="Pentagon 3"/>
+          <p:cNvSpPr/>
+          <p:nvPr/>
+        </p:nvSpPr>
+        <p:spPr>
+          <a:xfrm>
+            <a:off x="6254496" y="137160"/>
+            <a:ext cx="530352" cy="292608"/>
+          </a:xfrm>
+          <a:prstGeom prst="homePlate">
+            <a:avLst/>
+          </a:prstGeom>
+          <a:solidFill>
+            <a:srgbClr val="CC4D8C"/>
+          </a:solidFill>
+          <a:ln>
+            <a:noFill/>
+          </a:ln>
+          <a:effectLst/>
+        </p:spPr>
+        <p:style>
+          <a:lnRef idx="1">
+            <a:schemeClr val="accent1"/>
+          </a:lnRef>
+          <a:fillRef idx="3">
+            <a:schemeClr val="accent1"/>
+          </a:fillRef>
+          <a:effectRef idx="2">
+            <a:schemeClr val="accent1"/>
+          </a:effectRef>
+          <a:fontRef idx="minor">
+            <a:schemeClr val="lt1"/>
+          </a:fontRef>
+        </p:style>
+        <p:txBody>
+          <a:bodyPr rtlCol="0" anchor="ctr"/>
+          <a:lstStyle/>
+          <a:p>
+            <a:pPr algn="ctr"/>
+          </a:p>
+        </p:txBody>
+      </p:sp>
+      <p:sp>
+        <p:nvSpPr>
+          <p:cNvPr id="5" name="Pentagon 4"/>
+          <p:cNvSpPr/>
+          <p:nvPr/>
+        </p:nvSpPr>
+        <p:spPr>
+          <a:xfrm>
+            <a:off x="6821424" y="137160"/>
+            <a:ext cx="530352" cy="292608"/>
+          </a:xfrm>
+          <a:prstGeom prst="homePlate">
+            <a:avLst/>
+          </a:prstGeom>
+          <a:solidFill>
+            <a:srgbClr val="6FC0C6"/>
+          </a:solidFill>
+          <a:ln>
+            <a:noFill/>
+          </a:ln>
+          <a:effectLst/>
+        </p:spPr>
+        <p:style>
+          <a:lnRef idx="1">
+            <a:schemeClr val="accent1"/>
+          </a:lnRef>
+          <a:fillRef idx="3">
+            <a:schemeClr val="accent1"/>
+          </a:fillRef>
+          <a:effectRef idx="2">
+            <a:schemeClr val="accent1"/>
+          </a:effectRef>
+          <a:fontRef idx="minor">
+            <a:schemeClr val="lt1"/>
+          </a:fontRef>
+        </p:style>
+        <p:txBody>
+          <a:bodyPr rtlCol="0" anchor="ctr"/>
+          <a:lstStyle/>
+          <a:p>
+            <a:pPr algn="ctr"/>
+          </a:p>
+        </p:txBody>
+      </p:sp>
+      <p:sp>
+        <p:nvSpPr>
+          <p:cNvPr id="6" name="Pentagon 5"/>
+          <p:cNvSpPr/>
+          <p:nvPr/>
+        </p:nvSpPr>
+        <p:spPr>
+          <a:xfrm>
+            <a:off x="7388352" y="137160"/>
+            <a:ext cx="530352" cy="292608"/>
+          </a:xfrm>
+          <a:prstGeom prst="homePlate">
+            <a:avLst/>
+          </a:prstGeom>
+          <a:solidFill>
+            <a:srgbClr val="E8C43A"/>
+          </a:solidFill>
+          <a:ln>
+            <a:noFill/>
+          </a:ln>
+          <a:effectLst/>
+        </p:spPr>
+        <p:style>
+          <a:lnRef idx="1">
+            <a:schemeClr val="accent1"/>
+          </a:lnRef>
+          <a:fillRef idx="3">
+            <a:schemeClr val="accent1"/>
+          </a:fillRef>
+          <a:effectRef idx="2">
+            <a:schemeClr val="accent1"/>
+          </a:effectRef>
+          <a:fontRef idx="minor">
+            <a:schemeClr val="lt1"/>
+          </a:fontRef>
+        </p:style>
+        <p:txBody>
+          <a:bodyPr rtlCol="0" anchor="ctr"/>
+          <a:lstStyle/>
+          <a:p>
+            <a:pPr algn="ctr"/>
+          </a:p>
+        </p:txBody>
+      </p:sp>
+      <p:sp>
+        <p:nvSpPr>
+          <p:cNvPr id="7" name="TextBox 6"/>
+          <p:cNvSpPr txBox="1"/>
+          <p:nvPr/>
+        </p:nvSpPr>
+        <p:spPr>
+          <a:xfrm>
+            <a:off x="10561320" y="182880"/>
+            <a:ext cx="1463040" cy="502920"/>
+          </a:xfrm>
+          <a:prstGeom prst="rect">
+            <a:avLst/>
+          </a:prstGeom>
+          <a:noFill/>
+        </p:spPr>
+        <p:txBody>
+          <a:bodyPr wrap="square" lIns="36000" rIns="36000" tIns="18000" bIns="18000" anchor="t">
+            <a:spAutoFit/>
+          </a:bodyPr>
+          <a:lstStyle/>
+          <a:p>
+            <a:pPr algn="l"/>
+            <a:r>
+              <a:rPr sz="3200" b="1" i="0" u="none">
+                <a:solidFill>
+                  <a:srgbClr val="E30613"/>
+                </a:solidFill>
+                <a:latin typeface="Calibri"/>
+              </a:rPr>
+              <a:t>ERGO</a:t>
+            </a:r>
+          </a:p>
+        </p:txBody>
+      </p:sp>
+      <p:sp>
+        <p:nvSpPr>
+          <p:cNvPr id="8" name="TextBox 7"/>
+          <p:cNvSpPr txBox="1"/>
+          <p:nvPr/>
+        </p:nvSpPr>
+        <p:spPr>
+          <a:xfrm>
+            <a:off x="10561320" y="731520"/>
+            <a:ext cx="1463040" cy="274320"/>
+          </a:xfrm>
+          <a:prstGeom prst="rect">
+            <a:avLst/>
+          </a:prstGeom>
+          <a:noFill/>
+        </p:spPr>
+        <p:txBody>
+          <a:bodyPr wrap="square" lIns="36000" rIns="36000" tIns="18000" bIns="18000" anchor="t">
+            <a:spAutoFit/>
+          </a:bodyPr>
+          <a:lstStyle/>
+          <a:p>
+            <a:pPr algn="l"/>
+            <a:r>
+              <a:rPr sz="800" b="0" i="0" u="none">
+                <a:solidFill>
+                  <a:srgbClr val="333333"/>
+                </a:solidFill>
+                <a:latin typeface="Calibri"/>
+              </a:rPr>
+              <a:t>A Munich Re company</a:t>
+            </a:r>
+          </a:p>
+        </p:txBody>
+      </p:sp>
+      <p:sp>
+        <p:nvSpPr>
+          <p:cNvPr id="9" name="TextBox 8"/>
+          <p:cNvSpPr txBox="1"/>
+          <p:nvPr/>
+        </p:nvSpPr>
+        <p:spPr>
+          <a:xfrm>
+            <a:off x="411480" y="228600"/>
+            <a:ext cx="6400800" cy="292608"/>
+          </a:xfrm>
+          <a:prstGeom prst="rect">
+            <a:avLst/>
+          </a:prstGeom>
+          <a:noFill/>
+        </p:spPr>
+        <p:txBody>
+          <a:bodyPr wrap="square" lIns="36000" rIns="36000" tIns="18000" bIns="18000" anchor="t">
+            <a:spAutoFit/>
+          </a:bodyPr>
+          <a:lstStyle/>
+          <a:p>
+            <a:pPr algn="l"/>
+            <a:r>
+              <a:rPr sz="1200" b="0" i="0" u="none">
+                <a:solidFill>
+                  <a:srgbClr val="333333"/>
+                </a:solidFill>
+                <a:latin typeface="Calibri"/>
+              </a:rPr>
+              <a:t>STRUKTURIERUNG  |  HERAUSFORDERUNG</a:t>
+            </a:r>
+          </a:p>
+        </p:txBody>
+      </p:sp>
+      <p:sp>
+        <p:nvSpPr>
+          <p:cNvPr id="10" name="TextBox 9"/>
+          <p:cNvSpPr txBox="1"/>
+          <p:nvPr/>
+        </p:nvSpPr>
+        <p:spPr>
+          <a:xfrm>
+            <a:off x="411480" y="594360"/>
+            <a:ext cx="10058400" cy="502920"/>
+          </a:xfrm>
+          <a:prstGeom prst="rect">
+            <a:avLst/>
+          </a:prstGeom>
+          <a:noFill/>
+        </p:spPr>
+        <p:txBody>
+          <a:bodyPr wrap="square" lIns="36000" rIns="36000" tIns="18000" bIns="18000" anchor="t">
+            <a:spAutoFit/>
+          </a:bodyPr>
+          <a:lstStyle/>
+          <a:p>
+            <a:pPr algn="l"/>
+            <a:r>
+              <a:rPr sz="2000" b="1" i="0" u="none">
+                <a:solidFill>
+                  <a:srgbClr val="E30613"/>
+                </a:solidFill>
+                <a:latin typeface="Calibri"/>
+              </a:rPr>
+              <a:t>Ohne strukturierte Datenbasis laesst sich der Posteingang weder korrekt routen noch steuern —</a:t>
+            </a:r>
+          </a:p>
+        </p:txBody>
+      </p:sp>
+      <p:sp>
+        <p:nvSpPr>
+          <p:cNvPr id="11" name="TextBox 10"/>
+          <p:cNvSpPr txBox="1"/>
+          <p:nvPr/>
+        </p:nvSpPr>
+        <p:spPr>
+          <a:xfrm>
+            <a:off x="411480" y="1078992"/>
+            <a:ext cx="10058400" cy="502920"/>
+          </a:xfrm>
+          <a:prstGeom prst="rect">
+            <a:avLst/>
+          </a:prstGeom>
+          <a:noFill/>
+        </p:spPr>
+        <p:txBody>
+          <a:bodyPr wrap="square" lIns="36000" rIns="36000" tIns="18000" bIns="18000" anchor="t">
+            <a:spAutoFit/>
+          </a:bodyPr>
+          <a:lstStyle/>
+          <a:p>
+            <a:pPr algn="l"/>
+            <a:r>
+              <a:rPr sz="2000" b="1" i="0" u="none">
+                <a:solidFill>
+                  <a:srgbClr val="E30613"/>
+                </a:solidFill>
+                <a:latin typeface="Calibri"/>
+              </a:rPr>
+              <a:t>die Folgen treffen vor allem KV, wo heute jede Vorgangs-Sicht fehlt</a:t>
+            </a:r>
+          </a:p>
+        </p:txBody>
+      </p:sp>
+      <p:sp>
+        <p:nvSpPr>
+          <p:cNvPr id="12" name="TextBox 11"/>
+          <p:cNvSpPr txBox="1"/>
+          <p:nvPr/>
+        </p:nvSpPr>
+        <p:spPr>
+          <a:xfrm>
+            <a:off x="411480" y="1920240"/>
+            <a:ext cx="7315200" cy="320040"/>
+          </a:xfrm>
+          <a:prstGeom prst="rect">
+            <a:avLst/>
+          </a:prstGeom>
+          <a:noFill/>
+        </p:spPr>
+        <p:txBody>
+          <a:bodyPr wrap="square" lIns="36000" rIns="36000" tIns="18000" bIns="18000" anchor="t">
+            <a:spAutoFit/>
+          </a:bodyPr>
+          <a:lstStyle/>
+          <a:p>
+            <a:pPr algn="l"/>
+            <a:r>
+              <a:rPr sz="1300" b="1" i="0" u="none">
+                <a:solidFill>
+                  <a:srgbClr val="333333"/>
+                </a:solidFill>
+                <a:latin typeface="Calibri"/>
+              </a:rPr>
+              <a:t>HERAUSFORDERUNG</a:t>
+            </a:r>
+          </a:p>
+        </p:txBody>
+      </p:sp>
+      <p:sp>
+        <p:nvSpPr>
+          <p:cNvPr id="13" name="TextBox 12"/>
+          <p:cNvSpPr txBox="1"/>
+          <p:nvPr/>
+        </p:nvSpPr>
+        <p:spPr>
+          <a:xfrm>
+            <a:off x="8229600" y="1920240"/>
+            <a:ext cx="3657600" cy="320040"/>
+          </a:xfrm>
+          <a:prstGeom prst="rect">
+            <a:avLst/>
+          </a:prstGeom>
+          <a:noFill/>
+        </p:spPr>
+        <p:txBody>
+          <a:bodyPr wrap="square" lIns="36000" rIns="36000" tIns="18000" bIns="18000" anchor="t">
+            <a:spAutoFit/>
+          </a:bodyPr>
+          <a:lstStyle/>
+          <a:p>
+            <a:pPr algn="l"/>
+            <a:r>
+              <a:rPr sz="1300" b="1" i="0" u="none">
+                <a:solidFill>
+                  <a:srgbClr val="333333"/>
+                </a:solidFill>
+                <a:latin typeface="Calibri"/>
+              </a:rPr>
+              <a:t>KERNAUSSAGEN</a:t>
+            </a:r>
+          </a:p>
+        </p:txBody>
+      </p:sp>
+      <p:sp>
+        <p:nvSpPr>
+          <p:cNvPr id="14" name="Rectangle 13"/>
+          <p:cNvSpPr/>
+          <p:nvPr/>
+        </p:nvSpPr>
+        <p:spPr>
+          <a:xfrm>
+            <a:off x="411480" y="6446520"/>
+            <a:ext cx="11338560" cy="9525"/>
+          </a:xfrm>
+          <a:prstGeom prst="rect">
+            <a:avLst/>
+          </a:prstGeom>
+          <a:solidFill>
+            <a:srgbClr val="CCCCCC"/>
+          </a:solidFill>
+          <a:ln>
+            <a:noFill/>
+          </a:ln>
+          <a:effectLst/>
+        </p:spPr>
+        <p:style>
+          <a:lnRef idx="1">
+            <a:schemeClr val="accent1"/>
+          </a:lnRef>
+          <a:fillRef idx="3">
+            <a:schemeClr val="accent1"/>
+          </a:fillRef>
+          <a:effectRef idx="2">
+            <a:schemeClr val="accent1"/>
+          </a:effectRef>
+          <a:fontRef idx="minor">
+            <a:schemeClr val="lt1"/>
+          </a:fontRef>
+        </p:style>
+        <p:txBody>
+          <a:bodyPr rtlCol="0" anchor="ctr"/>
+          <a:lstStyle/>
+          <a:p>
+            <a:pPr algn="ctr"/>
+          </a:p>
+        </p:txBody>
+      </p:sp>
+      <p:sp>
+        <p:nvSpPr>
+          <p:cNvPr id="15" name="TextBox 14"/>
+          <p:cNvSpPr txBox="1"/>
+          <p:nvPr/>
+        </p:nvSpPr>
+        <p:spPr>
+          <a:xfrm>
+            <a:off x="411480" y="6510528"/>
+            <a:ext cx="10058400" cy="274320"/>
+          </a:xfrm>
+          <a:prstGeom prst="rect">
+            <a:avLst/>
+          </a:prstGeom>
+          <a:noFill/>
+        </p:spPr>
+        <p:txBody>
+          <a:bodyPr wrap="square" lIns="36000" rIns="36000" tIns="18000" bIns="18000" anchor="t">
+            <a:spAutoFit/>
+          </a:bodyPr>
+          <a:lstStyle/>
+          <a:p>
+            <a:pPr algn="l"/>
+            <a:r>
+              <a:rPr sz="900" b="0" i="0" u="none">
+                <a:solidFill>
+                  <a:srgbClr val="666666"/>
+                </a:solidFill>
+                <a:latin typeface="Calibri"/>
+              </a:rPr>
+              <a:t>ERGO | Makler BUe meets KI – Zwischenbericht Phase 1 - 10.06.2026</a:t>
+            </a:r>
+          </a:p>
+        </p:txBody>
+      </p:sp>
+      <p:sp>
+        <p:nvSpPr>
+          <p:cNvPr id="16" name="TextBox 15"/>
+          <p:cNvSpPr txBox="1"/>
+          <p:nvPr/>
+        </p:nvSpPr>
+        <p:spPr>
+          <a:xfrm>
+            <a:off x="11338560" y="6510528"/>
+            <a:ext cx="457200" cy="274320"/>
+          </a:xfrm>
+          <a:prstGeom prst="rect">
+            <a:avLst/>
+          </a:prstGeom>
+          <a:noFill/>
+        </p:spPr>
+        <p:txBody>
+          <a:bodyPr wrap="square" lIns="36000" rIns="36000" tIns="18000" bIns="18000" anchor="t">
+            <a:spAutoFit/>
+          </a:bodyPr>
+          <a:lstStyle/>
+          <a:p>
+            <a:pPr algn="r"/>
+            <a:r>
+              <a:rPr sz="900" b="0" i="0" u="none">
+                <a:solidFill>
+                  <a:srgbClr val="666666"/>
+                </a:solidFill>
+                <a:latin typeface="Calibri"/>
+              </a:rPr>
+              <a:t>12</a:t>
+            </a:r>
+          </a:p>
+        </p:txBody>
+      </p:sp>
+      <p:sp>
+        <p:nvSpPr>
+          <p:cNvPr id="17" name="Rectangle 16"/>
+          <p:cNvSpPr/>
+          <p:nvPr/>
+        </p:nvSpPr>
+        <p:spPr>
+          <a:xfrm>
+            <a:off x="411480" y="2331720"/>
+            <a:ext cx="7635240" cy="384048"/>
+          </a:xfrm>
+          <a:prstGeom prst="rect">
+            <a:avLst/>
+          </a:prstGeom>
+          <a:solidFill>
+            <a:srgbClr val="006B77"/>
+          </a:solidFill>
+          <a:ln>
+            <a:noFill/>
+          </a:ln>
+          <a:effectLst/>
+        </p:spPr>
+        <p:style>
+          <a:lnRef idx="1">
+            <a:schemeClr val="accent1"/>
+          </a:lnRef>
+          <a:fillRef idx="3">
+            <a:schemeClr val="accent1"/>
+          </a:fillRef>
+          <a:effectRef idx="2">
+            <a:schemeClr val="accent1"/>
+          </a:effectRef>
+          <a:fontRef idx="minor">
+            <a:schemeClr val="lt1"/>
+          </a:fontRef>
+        </p:style>
+        <p:txBody>
+          <a:bodyPr rtlCol="0" anchor="ctr"/>
+          <a:lstStyle/>
+          <a:p>
+            <a:pPr algn="ctr"/>
+          </a:p>
+        </p:txBody>
+      </p:sp>
+      <p:sp>
+        <p:nvSpPr>
+          <p:cNvPr id="18" name="TextBox 17"/>
+          <p:cNvSpPr txBox="1"/>
+          <p:nvPr/>
+        </p:nvSpPr>
+        <p:spPr>
+          <a:xfrm>
+            <a:off x="411480" y="2331720"/>
+            <a:ext cx="2926080" cy="384048"/>
+          </a:xfrm>
+          <a:prstGeom prst="rect">
+            <a:avLst/>
+          </a:prstGeom>
+          <a:noFill/>
+        </p:spPr>
+        <p:txBody>
+          <a:bodyPr wrap="square" lIns="36000" rIns="36000" tIns="18000" bIns="18000" anchor="ctr">
+            <a:spAutoFit/>
+          </a:bodyPr>
+          <a:lstStyle/>
+          <a:p>
+            <a:pPr algn="l"/>
+            <a:r>
+              <a:rPr sz="1100" b="1" i="0" u="none">
+                <a:solidFill>
+                  <a:srgbClr val="FFFFFF"/>
+                </a:solidFill>
+                <a:latin typeface="Calibri"/>
+              </a:rPr>
+              <a:t>Beobachtung (IST)</a:t>
+            </a:r>
+          </a:p>
+        </p:txBody>
+      </p:sp>
+      <p:sp>
+        <p:nvSpPr>
+          <p:cNvPr id="19" name="TextBox 18"/>
+          <p:cNvSpPr txBox="1"/>
+          <p:nvPr/>
+        </p:nvSpPr>
+        <p:spPr>
+          <a:xfrm>
+            <a:off x="3337560" y="2331720"/>
+            <a:ext cx="4709160" cy="384048"/>
+          </a:xfrm>
+          <a:prstGeom prst="rect">
+            <a:avLst/>
+          </a:prstGeom>
+          <a:noFill/>
+        </p:spPr>
+        <p:txBody>
+          <a:bodyPr wrap="square" lIns="36000" rIns="36000" tIns="18000" bIns="18000" anchor="ctr">
+            <a:spAutoFit/>
+          </a:bodyPr>
+          <a:lstStyle/>
+          <a:p>
+            <a:pPr algn="l"/>
+            <a:r>
+              <a:rPr sz="1100" b="1" i="0" u="none">
+                <a:solidFill>
+                  <a:srgbClr val="FFFFFF"/>
+                </a:solidFill>
+                <a:latin typeface="Calibri"/>
+              </a:rPr>
+              <a:t>Wirkung heute</a:t>
+            </a:r>
+          </a:p>
+        </p:txBody>
+      </p:sp>
+      <p:sp>
+        <p:nvSpPr>
+          <p:cNvPr id="20" name="Rectangle 19"/>
+          <p:cNvSpPr/>
+          <p:nvPr/>
+        </p:nvSpPr>
+        <p:spPr>
+          <a:xfrm>
+            <a:off x="411480" y="2715768"/>
+            <a:ext cx="7635240" cy="868680"/>
+          </a:xfrm>
+          <a:prstGeom prst="rect">
+            <a:avLst/>
+          </a:prstGeom>
+          <a:solidFill>
+            <a:srgbClr val="FFFFFF"/>
+          </a:solidFill>
+          <a:ln>
+            <a:noFill/>
+          </a:ln>
+          <a:effectLst/>
+        </p:spPr>
+        <p:style>
+          <a:lnRef idx="1">
+            <a:schemeClr val="accent1"/>
+          </a:lnRef>
+          <a:fillRef idx="3">
+            <a:schemeClr val="accent1"/>
+          </a:fillRef>
+          <a:effectRef idx="2">
+            <a:schemeClr val="accent1"/>
+          </a:effectRef>
+          <a:fontRef idx="minor">
+            <a:schemeClr val="lt1"/>
+          </a:fontRef>
+        </p:style>
+        <p:txBody>
+          <a:bodyPr rtlCol="0" anchor="ctr"/>
+          <a:lstStyle/>
+          <a:p>
+            <a:pPr algn="ctr"/>
+          </a:p>
+        </p:txBody>
+      </p:sp>
+      <p:sp>
+        <p:nvSpPr>
+          <p:cNvPr id="21" name="TextBox 20"/>
+          <p:cNvSpPr txBox="1"/>
+          <p:nvPr/>
+        </p:nvSpPr>
+        <p:spPr>
+          <a:xfrm>
+            <a:off x="502920" y="2715768"/>
+            <a:ext cx="2788920" cy="868680"/>
+          </a:xfrm>
+          <a:prstGeom prst="rect">
+            <a:avLst/>
+          </a:prstGeom>
+          <a:noFill/>
+        </p:spPr>
+        <p:txBody>
+          <a:bodyPr wrap="square" lIns="36000" rIns="36000" tIns="18000" bIns="18000" anchor="ctr">
+            <a:spAutoFit/>
+          </a:bodyPr>
+          <a:lstStyle/>
+          <a:p>
+            <a:pPr algn="l"/>
+            <a:r>
+              <a:rPr sz="1100" b="1" i="0" u="none">
+                <a:solidFill>
+                  <a:srgbClr val="333333"/>
+                </a:solidFill>
+                <a:latin typeface="Calibri"/>
+              </a:rPr>
+              <a:t>Regel 'MV im Anhang → BÜ'</a:t>
+            </a:r>
+          </a:p>
+        </p:txBody>
+      </p:sp>
+      <p:sp>
+        <p:nvSpPr>
+          <p:cNvPr id="22" name="TextBox 21"/>
+          <p:cNvSpPr txBox="1"/>
+          <p:nvPr/>
+        </p:nvSpPr>
+        <p:spPr>
+          <a:xfrm>
+            <a:off x="3429000" y="2715768"/>
+            <a:ext cx="4572000" cy="868680"/>
+          </a:xfrm>
+          <a:prstGeom prst="rect">
+            <a:avLst/>
+          </a:prstGeom>
+          <a:noFill/>
+        </p:spPr>
+        <p:txBody>
+          <a:bodyPr wrap="square" lIns="36000" rIns="36000" tIns="18000" bIns="18000" anchor="ctr">
+            <a:spAutoFit/>
+          </a:bodyPr>
+          <a:lstStyle/>
+          <a:p>
+            <a:pPr algn="l"/>
+            <a:r>
+              <a:rPr sz="1100" b="0" i="0" u="none">
+                <a:solidFill>
+                  <a:srgbClr val="333333"/>
+                </a:solidFill>
+                <a:latin typeface="Calibri"/>
+              </a:rPr>
+              <a:t>240 Fehl-/Dublettenanlagen pro Woche; manueller Such- und Korrekturaufwand im Postkorb</a:t>
+            </a:r>
+          </a:p>
+        </p:txBody>
+      </p:sp>
+      <p:sp>
+        <p:nvSpPr>
+          <p:cNvPr id="23" name="Rectangle 22"/>
+          <p:cNvSpPr/>
+          <p:nvPr/>
+        </p:nvSpPr>
+        <p:spPr>
+          <a:xfrm>
+            <a:off x="411480" y="3584448"/>
+            <a:ext cx="7635240" cy="868680"/>
+          </a:xfrm>
+          <a:prstGeom prst="rect">
+            <a:avLst/>
+          </a:prstGeom>
+          <a:solidFill>
+            <a:srgbClr val="F1F1F1"/>
+          </a:solidFill>
+          <a:ln>
+            <a:noFill/>
+          </a:ln>
+          <a:effectLst/>
+        </p:spPr>
+        <p:style>
+          <a:lnRef idx="1">
+            <a:schemeClr val="accent1"/>
+          </a:lnRef>
+          <a:fillRef idx="3">
+            <a:schemeClr val="accent1"/>
+          </a:fillRef>
+          <a:effectRef idx="2">
+            <a:schemeClr val="accent1"/>
+          </a:effectRef>
+          <a:fontRef idx="minor">
+            <a:schemeClr val="lt1"/>
+          </a:fontRef>
+        </p:style>
+        <p:txBody>
+          <a:bodyPr rtlCol="0" anchor="ctr"/>
+          <a:lstStyle/>
+          <a:p>
+            <a:pPr algn="ctr"/>
+          </a:p>
+        </p:txBody>
+      </p:sp>
+      <p:sp>
+        <p:nvSpPr>
+          <p:cNvPr id="24" name="TextBox 23"/>
+          <p:cNvSpPr txBox="1"/>
+          <p:nvPr/>
+        </p:nvSpPr>
+        <p:spPr>
+          <a:xfrm>
+            <a:off x="502920" y="3584448"/>
+            <a:ext cx="2788920" cy="868680"/>
+          </a:xfrm>
+          <a:prstGeom prst="rect">
+            <a:avLst/>
+          </a:prstGeom>
+          <a:noFill/>
+        </p:spPr>
+        <p:txBody>
+          <a:bodyPr wrap="square" lIns="36000" rIns="36000" tIns="18000" bIns="18000" anchor="ctr">
+            <a:spAutoFit/>
+          </a:bodyPr>
+          <a:lstStyle/>
+          <a:p>
+            <a:pPr algn="l"/>
+            <a:r>
+              <a:rPr sz="1100" b="1" i="0" u="none">
+                <a:solidFill>
+                  <a:srgbClr val="333333"/>
+                </a:solidFill>
+                <a:latin typeface="Calibri"/>
+              </a:rPr>
+              <a:t>Keine Vorgangs-/Cluster-Sicht</a:t>
+            </a:r>
+          </a:p>
+        </p:txBody>
+      </p:sp>
+      <p:sp>
+        <p:nvSpPr>
+          <p:cNvPr id="25" name="TextBox 24"/>
+          <p:cNvSpPr txBox="1"/>
+          <p:nvPr/>
+        </p:nvSpPr>
+        <p:spPr>
+          <a:xfrm>
+            <a:off x="3429000" y="3584448"/>
+            <a:ext cx="4572000" cy="868680"/>
+          </a:xfrm>
+          <a:prstGeom prst="rect">
+            <a:avLst/>
+          </a:prstGeom>
+          <a:noFill/>
+        </p:spPr>
+        <p:txBody>
+          <a:bodyPr wrap="square" lIns="36000" rIns="36000" tIns="18000" bIns="18000" anchor="ctr">
+            <a:spAutoFit/>
+          </a:bodyPr>
+          <a:lstStyle/>
+          <a:p>
+            <a:pPr algn="l"/>
+            <a:r>
+              <a:rPr sz="1100" b="0" i="0" u="none">
+                <a:solidFill>
+                  <a:srgbClr val="333333"/>
+                </a:solidFill>
+                <a:latin typeface="Calibri"/>
+              </a:rPr>
+              <a:t>2.370 zusammengehoerige Mails werden einzeln angefasst; in KV ist jede Mail ein eigener Vorgang</a:t>
+            </a:r>
+          </a:p>
+        </p:txBody>
+      </p:sp>
+      <p:sp>
+        <p:nvSpPr>
+          <p:cNvPr id="26" name="Rectangle 25"/>
+          <p:cNvSpPr/>
+          <p:nvPr/>
+        </p:nvSpPr>
+        <p:spPr>
+          <a:xfrm>
+            <a:off x="411480" y="4453128"/>
+            <a:ext cx="7635240" cy="868680"/>
+          </a:xfrm>
+          <a:prstGeom prst="rect">
+            <a:avLst/>
+          </a:prstGeom>
+          <a:solidFill>
+            <a:srgbClr val="FFFFFF"/>
+          </a:solidFill>
+          <a:ln>
+            <a:noFill/>
+          </a:ln>
+          <a:effectLst/>
+        </p:spPr>
+        <p:style>
+          <a:lnRef idx="1">
+            <a:schemeClr val="accent1"/>
+          </a:lnRef>
+          <a:fillRef idx="3">
+            <a:schemeClr val="accent1"/>
+          </a:fillRef>
+          <a:effectRef idx="2">
+            <a:schemeClr val="accent1"/>
+          </a:effectRef>
+          <a:fontRef idx="minor">
+            <a:schemeClr val="lt1"/>
+          </a:fontRef>
+        </p:style>
+        <p:txBody>
+          <a:bodyPr rtlCol="0" anchor="ctr"/>
+          <a:lstStyle/>
+          <a:p>
+            <a:pPr algn="ctr"/>
+          </a:p>
+        </p:txBody>
+      </p:sp>
+      <p:sp>
+        <p:nvSpPr>
+          <p:cNvPr id="27" name="TextBox 26"/>
+          <p:cNvSpPr txBox="1"/>
+          <p:nvPr/>
+        </p:nvSpPr>
+        <p:spPr>
+          <a:xfrm>
+            <a:off x="502920" y="4453128"/>
+            <a:ext cx="2788920" cy="868680"/>
+          </a:xfrm>
+          <a:prstGeom prst="rect">
+            <a:avLst/>
+          </a:prstGeom>
+          <a:noFill/>
+        </p:spPr>
+        <p:txBody>
+          <a:bodyPr wrap="square" lIns="36000" rIns="36000" tIns="18000" bIns="18000" anchor="ctr">
+            <a:spAutoFit/>
+          </a:bodyPr>
+          <a:lstStyle/>
+          <a:p>
+            <a:pPr algn="l"/>
+            <a:r>
+              <a:rPr sz="1100" b="1" i="0" u="none">
+                <a:solidFill>
+                  <a:srgbClr val="333333"/>
+                </a:solidFill>
+                <a:latin typeface="Calibri"/>
+              </a:rPr>
+              <a:t>Keine einheitlichen Datenfelder</a:t>
+            </a:r>
+          </a:p>
+        </p:txBody>
+      </p:sp>
+      <p:sp>
+        <p:nvSpPr>
+          <p:cNvPr id="28" name="TextBox 27"/>
+          <p:cNvSpPr txBox="1"/>
+          <p:nvPr/>
+        </p:nvSpPr>
+        <p:spPr>
+          <a:xfrm>
+            <a:off x="3429000" y="4453128"/>
+            <a:ext cx="4572000" cy="868680"/>
+          </a:xfrm>
+          <a:prstGeom prst="rect">
+            <a:avLst/>
+          </a:prstGeom>
+          <a:noFill/>
+        </p:spPr>
+        <p:txBody>
+          <a:bodyPr wrap="square" lIns="36000" rIns="36000" tIns="18000" bIns="18000" anchor="ctr">
+            <a:spAutoFit/>
+          </a:bodyPr>
+          <a:lstStyle/>
+          <a:p>
+            <a:pPr algn="l"/>
+            <a:r>
+              <a:rPr sz="1100" b="0" i="0" u="none">
+                <a:solidFill>
+                  <a:srgbClr val="333333"/>
+                </a:solidFill>
+                <a:latin typeface="Calibri"/>
+              </a:rPr>
+              <a:t>keine Filter nach Prio-Fall / Prio-Makler; kein Fundament fuer eine automatisierte Pruefung</a:t>
+            </a:r>
+          </a:p>
+        </p:txBody>
+      </p:sp>
+      <p:sp>
+        <p:nvSpPr>
+          <p:cNvPr id="29" name="Rectangle 28"/>
+          <p:cNvSpPr/>
+          <p:nvPr/>
+        </p:nvSpPr>
+        <p:spPr>
+          <a:xfrm>
+            <a:off x="8229600" y="2240280"/>
+            <a:ext cx="3611880" cy="3611880"/>
+          </a:xfrm>
+          <a:prstGeom prst="rect">
+            <a:avLst/>
+          </a:prstGeom>
+          <a:solidFill>
+            <a:srgbClr val="CFE6E9"/>
+          </a:solidFill>
+          <a:ln>
+            <a:noFill/>
+          </a:ln>
+          <a:effectLst/>
+        </p:spPr>
+        <p:style>
+          <a:lnRef idx="1">
+            <a:schemeClr val="accent1"/>
+          </a:lnRef>
+          <a:fillRef idx="3">
+            <a:schemeClr val="accent1"/>
+          </a:fillRef>
+          <a:effectRef idx="2">
+            <a:schemeClr val="accent1"/>
+          </a:effectRef>
+          <a:fontRef idx="minor">
+            <a:schemeClr val="lt1"/>
+          </a:fontRef>
+        </p:style>
+        <p:txBody>
+          <a:bodyPr rtlCol="0" anchor="ctr"/>
+          <a:lstStyle/>
+          <a:p>
+            <a:pPr algn="ctr"/>
+          </a:p>
+        </p:txBody>
+      </p:sp>
+      <p:sp>
+        <p:nvSpPr>
+          <p:cNvPr id="30" name="Oval 29"/>
+          <p:cNvSpPr/>
+          <p:nvPr/>
+        </p:nvSpPr>
+        <p:spPr>
+          <a:xfrm>
+            <a:off x="8394192" y="2441448"/>
+            <a:ext cx="384048" cy="384048"/>
+          </a:xfrm>
+          <a:prstGeom prst="ellipse">
+            <a:avLst/>
+          </a:prstGeom>
+          <a:solidFill>
+            <a:srgbClr val="FFFFFF"/>
+          </a:solidFill>
+          <a:ln w="22225">
+            <a:solidFill>
+              <a:srgbClr val="E30613"/>
+            </a:solidFill>
+          </a:ln>
+          <a:effectLst/>
+        </p:spPr>
+        <p:style>
+          <a:lnRef idx="1">
+            <a:schemeClr val="accent1"/>
+          </a:lnRef>
+          <a:fillRef idx="3">
+            <a:schemeClr val="accent1"/>
+          </a:fillRef>
+          <a:effectRef idx="2">
+            <a:schemeClr val="accent1"/>
+          </a:effectRef>
+          <a:fontRef idx="minor">
+            <a:schemeClr val="lt1"/>
+          </a:fontRef>
+        </p:style>
+        <p:txBody>
+          <a:bodyPr rtlCol="0" anchor="ctr"/>
+          <a:lstStyle/>
+          <a:p>
+            <a:pPr algn="ctr"/>
+          </a:p>
+        </p:txBody>
+      </p:sp>
+      <p:sp>
+        <p:nvSpPr>
+          <p:cNvPr id="31" name="TextBox 30"/>
+          <p:cNvSpPr txBox="1"/>
+          <p:nvPr/>
+        </p:nvSpPr>
+        <p:spPr>
+          <a:xfrm>
+            <a:off x="8394192" y="2441448"/>
+            <a:ext cx="384048" cy="384048"/>
+          </a:xfrm>
+          <a:prstGeom prst="rect">
+            <a:avLst/>
+          </a:prstGeom>
+          <a:noFill/>
+        </p:spPr>
+        <p:txBody>
+          <a:bodyPr wrap="square" lIns="36000" rIns="36000" tIns="18000" bIns="18000" anchor="ctr">
+            <a:spAutoFit/>
+          </a:bodyPr>
+          <a:lstStyle/>
+          <a:p>
+            <a:pPr algn="ctr"/>
+            <a:r>
+              <a:rPr sz="1500" b="1" i="0" u="none">
+                <a:solidFill>
+                  <a:srgbClr val="E30613"/>
+                </a:solidFill>
+                <a:latin typeface="Calibri"/>
+              </a:rPr>
+              <a:t>A</a:t>
+            </a:r>
+          </a:p>
+        </p:txBody>
+      </p:sp>
+      <p:sp>
+        <p:nvSpPr>
+          <p:cNvPr id="32" name="TextBox 31"/>
+          <p:cNvSpPr txBox="1"/>
+          <p:nvPr/>
+        </p:nvSpPr>
+        <p:spPr>
+          <a:xfrm>
+            <a:off x="8887968" y="2404872"/>
+            <a:ext cx="2834640" cy="292608"/>
+          </a:xfrm>
+          <a:prstGeom prst="rect">
+            <a:avLst/>
+          </a:prstGeom>
+          <a:noFill/>
+        </p:spPr>
+        <p:txBody>
+          <a:bodyPr wrap="square" lIns="36000" rIns="36000" tIns="18000" bIns="18000" anchor="t">
+            <a:spAutoFit/>
+          </a:bodyPr>
+          <a:lstStyle/>
+          <a:p>
+            <a:pPr algn="l"/>
+            <a:r>
+              <a:rPr sz="1300" b="1" i="0" u="none">
+                <a:solidFill>
+                  <a:srgbClr val="333333"/>
+                </a:solidFill>
+                <a:latin typeface="Calibri"/>
+              </a:rPr>
+              <a:t>Routing-Herausforderung</a:t>
+            </a:r>
+          </a:p>
+        </p:txBody>
+      </p:sp>
+      <p:sp>
+        <p:nvSpPr>
+          <p:cNvPr id="33" name="TextBox 32"/>
+          <p:cNvSpPr txBox="1"/>
+          <p:nvPr/>
+        </p:nvSpPr>
+        <p:spPr>
+          <a:xfrm>
+            <a:off x="8887968" y="2697480"/>
+            <a:ext cx="2788920" cy="1376172"/>
+          </a:xfrm>
+          <a:prstGeom prst="rect">
+            <a:avLst/>
+          </a:prstGeom>
+          <a:noFill/>
+        </p:spPr>
+        <p:txBody>
+          <a:bodyPr wrap="square" lIns="36000" rIns="36000" tIns="18000" bIns="18000" anchor="t">
+            <a:spAutoFit/>
+          </a:bodyPr>
+          <a:lstStyle/>
+          <a:p>
+            <a:pPr algn="l"/>
+            <a:r>
+              <a:rPr sz="1100" b="0" i="0" u="none">
+                <a:solidFill>
+                  <a:srgbClr val="333333"/>
+                </a:solidFill>
+                <a:latin typeface="Calibri"/>
+              </a:rPr>
+              <a:t>Das Eingangsmanagement kann Reminder und fachfremde Mails nicht von echten Neuanlagen unterscheiden, solange nur die MV im Anhang als Ausloeser dient → 240 Fehlanlagen / Woche, Dubletten und Korrekturaufwand.</a:t>
+            </a:r>
+          </a:p>
+        </p:txBody>
+      </p:sp>
+      <p:sp>
+        <p:nvSpPr>
+          <p:cNvPr id="34" name="Oval 33"/>
+          <p:cNvSpPr/>
+          <p:nvPr/>
+        </p:nvSpPr>
+        <p:spPr>
+          <a:xfrm>
+            <a:off x="8394192" y="4110228"/>
+            <a:ext cx="384048" cy="384048"/>
+          </a:xfrm>
+          <a:prstGeom prst="ellipse">
+            <a:avLst/>
+          </a:prstGeom>
+          <a:solidFill>
+            <a:srgbClr val="FFFFFF"/>
+          </a:solidFill>
+          <a:ln w="22225">
+            <a:solidFill>
+              <a:srgbClr val="008793"/>
+            </a:solidFill>
+          </a:ln>
+          <a:effectLst/>
+        </p:spPr>
+        <p:style>
+          <a:lnRef idx="1">
+            <a:schemeClr val="accent1"/>
+          </a:lnRef>
+          <a:fillRef idx="3">
+            <a:schemeClr val="accent1"/>
+          </a:fillRef>
+          <a:effectRef idx="2">
+            <a:schemeClr val="accent1"/>
+          </a:effectRef>
+          <a:fontRef idx="minor">
+            <a:schemeClr val="lt1"/>
+          </a:fontRef>
+        </p:style>
+        <p:txBody>
+          <a:bodyPr rtlCol="0" anchor="ctr"/>
+          <a:lstStyle/>
+          <a:p>
+            <a:pPr algn="ctr"/>
+          </a:p>
+        </p:txBody>
+      </p:sp>
+      <p:sp>
+        <p:nvSpPr>
+          <p:cNvPr id="35" name="TextBox 34"/>
+          <p:cNvSpPr txBox="1"/>
+          <p:nvPr/>
+        </p:nvSpPr>
+        <p:spPr>
+          <a:xfrm>
+            <a:off x="8394192" y="4110228"/>
+            <a:ext cx="384048" cy="384048"/>
+          </a:xfrm>
+          <a:prstGeom prst="rect">
+            <a:avLst/>
+          </a:prstGeom>
+          <a:noFill/>
+        </p:spPr>
+        <p:txBody>
+          <a:bodyPr wrap="square" lIns="36000" rIns="36000" tIns="18000" bIns="18000" anchor="ctr">
+            <a:spAutoFit/>
+          </a:bodyPr>
+          <a:lstStyle/>
+          <a:p>
+            <a:pPr algn="ctr"/>
+            <a:r>
+              <a:rPr sz="1500" b="1" i="0" u="none">
+                <a:solidFill>
+                  <a:srgbClr val="008793"/>
+                </a:solidFill>
+                <a:latin typeface="Calibri"/>
+              </a:rPr>
+              <a:t>B</a:t>
+            </a:r>
+          </a:p>
+        </p:txBody>
+      </p:sp>
+      <p:sp>
+        <p:nvSpPr>
+          <p:cNvPr id="36" name="TextBox 35"/>
+          <p:cNvSpPr txBox="1"/>
+          <p:nvPr/>
+        </p:nvSpPr>
+        <p:spPr>
+          <a:xfrm>
+            <a:off x="8887968" y="4073652"/>
+            <a:ext cx="2834640" cy="292608"/>
+          </a:xfrm>
+          <a:prstGeom prst="rect">
+            <a:avLst/>
+          </a:prstGeom>
+          <a:noFill/>
+        </p:spPr>
+        <p:txBody>
+          <a:bodyPr wrap="square" lIns="36000" rIns="36000" tIns="18000" bIns="18000" anchor="t">
+            <a:spAutoFit/>
+          </a:bodyPr>
+          <a:lstStyle/>
+          <a:p>
+            <a:pPr algn="l"/>
+            <a:r>
+              <a:rPr sz="1300" b="1" i="0" u="none">
+                <a:solidFill>
+                  <a:srgbClr val="333333"/>
+                </a:solidFill>
+                <a:latin typeface="Calibri"/>
+              </a:rPr>
+              <a:t>Steuerungs-Herausforderung</a:t>
+            </a:r>
+          </a:p>
+        </p:txBody>
+      </p:sp>
+      <p:sp>
+        <p:nvSpPr>
+          <p:cNvPr id="37" name="TextBox 36"/>
+          <p:cNvSpPr txBox="1"/>
+          <p:nvPr/>
+        </p:nvSpPr>
+        <p:spPr>
+          <a:xfrm>
+            <a:off x="8887968" y="4366260"/>
+            <a:ext cx="2788920" cy="1376172"/>
+          </a:xfrm>
+          <a:prstGeom prst="rect">
+            <a:avLst/>
+          </a:prstGeom>
+          <a:noFill/>
+        </p:spPr>
+        <p:txBody>
+          <a:bodyPr wrap="square" lIns="36000" rIns="36000" tIns="18000" bIns="18000" anchor="t">
+            <a:spAutoFit/>
+          </a:bodyPr>
+          <a:lstStyle/>
+          <a:p>
+            <a:pPr algn="l"/>
+            <a:r>
+              <a:rPr sz="1100" b="0" i="0" u="none">
+                <a:solidFill>
+                  <a:srgbClr val="333333"/>
+                </a:solidFill>
+                <a:latin typeface="Calibri"/>
+              </a:rPr>
+              <a:t>Sachbearbeiter arbeiten den Postkorb unsortiert ab. Zusammengehoerige Mails (47 %) werden mehrfach einzeln angefasst, in KV ist jede Mail ein eigener Vorgang — Priorisierung nach Fall-Alter oder Makler ist nicht moeglich.</a:t>
+            </a:r>
+          </a:p>
+        </p:txBody>
+      </p:sp>
+      <p:sp>
+        <p:nvSpPr>
+          <p:cNvPr id="38" name="TextBox 37"/>
+          <p:cNvSpPr txBox="1"/>
+          <p:nvPr/>
+        </p:nvSpPr>
+        <p:spPr>
+          <a:xfrm>
+            <a:off x="411480" y="5760720"/>
+            <a:ext cx="11338560" cy="182880"/>
+          </a:xfrm>
+          <a:prstGeom prst="rect">
+            <a:avLst/>
+          </a:prstGeom>
+          <a:noFill/>
+        </p:spPr>
+        <p:txBody>
+          <a:bodyPr wrap="square" lIns="36000" rIns="36000" tIns="18000" bIns="18000" anchor="t">
+            <a:spAutoFit/>
+          </a:bodyPr>
+          <a:lstStyle/>
+          <a:p>
+            <a:pPr algn="l"/>
+            <a:r>
+              <a:rPr sz="800" b="0" i="1" u="none">
+                <a:solidFill>
+                  <a:srgbClr val="666666"/>
+                </a:solidFill>
+                <a:latin typeface="Calibri"/>
+              </a:rPr>
+              <a:t>Datenbasis: 5.034 Mails  |  Mo 13.04. – Mo 20.04.2026 (eine Kalenderwoche)  |  Eingangs-Postfaecher: 'Service Team Maklerauftraege' (94 %), 'Bestandsuebertragungen' (5 %), 12 weitere &lt;1 %  |  Analyse-Stand: 27.05.2026 (KI-Auswertung mit Claude Opus 4.7, 99 von 5.034 Mails mit Analyse-Fehler/Timeout)</a:t>
+            </a:r>
+          </a:p>
+        </p:txBody>
+      </p:sp>
+      <p:sp>
+        <p:nvSpPr>
+          <p:cNvPr id="39" name="Rectangle 38"/>
+          <p:cNvSpPr/>
+          <p:nvPr/>
+        </p:nvSpPr>
+        <p:spPr>
+          <a:xfrm>
+            <a:off x="411480" y="5989320"/>
+            <a:ext cx="11338560" cy="384048"/>
+          </a:xfrm>
+          <a:prstGeom prst="rect">
+            <a:avLst/>
+          </a:prstGeom>
+          <a:solidFill>
+            <a:srgbClr val="E30613"/>
+          </a:solidFill>
+          <a:ln>
+            <a:noFill/>
+          </a:ln>
+          <a:effectLst/>
+        </p:spPr>
+        <p:style>
+          <a:lnRef idx="1">
+            <a:schemeClr val="accent1"/>
+          </a:lnRef>
+          <a:fillRef idx="3">
+            <a:schemeClr val="accent1"/>
+          </a:fillRef>
+          <a:effectRef idx="2">
+            <a:schemeClr val="accent1"/>
+          </a:effectRef>
+          <a:fontRef idx="minor">
+            <a:schemeClr val="lt1"/>
+          </a:fontRef>
+        </p:style>
+        <p:txBody>
+          <a:bodyPr rtlCol="0" anchor="ctr"/>
+          <a:lstStyle/>
+          <a:p>
+            <a:pPr algn="ctr"/>
+          </a:p>
+        </p:txBody>
+      </p:sp>
+      <p:sp>
+        <p:nvSpPr>
+          <p:cNvPr id="40" name="TextBox 39"/>
+          <p:cNvSpPr txBox="1"/>
+          <p:nvPr/>
+        </p:nvSpPr>
+        <p:spPr>
+          <a:xfrm>
+            <a:off x="594360" y="5989320"/>
+            <a:ext cx="10972800" cy="384048"/>
+          </a:xfrm>
+          <a:prstGeom prst="rect">
+            <a:avLst/>
+          </a:prstGeom>
+          <a:noFill/>
+        </p:spPr>
+        <p:txBody>
+          <a:bodyPr wrap="square" lIns="36000" rIns="36000" tIns="18000" bIns="18000" anchor="ctr">
+            <a:spAutoFit/>
+          </a:bodyPr>
+          <a:lstStyle/>
+          <a:p>
+            <a:pPr algn="l"/>
+            <a:r>
+              <a:rPr sz="1200" b="1" i="0" u="none">
+                <a:solidFill>
+                  <a:srgbClr val="FFFFFF"/>
+                </a:solidFill>
+                <a:latin typeface="Calibri"/>
+              </a:rPr>
+              <a:t>TAKE-AWAY:  Kern-Herausforderung: Ohne strukturierte Daten bleibt der Posteingang nicht routbar und nicht steuerbar — Fehl-Routing (240/Wo) und unverbundene Einzelbearbeitung (47 %) sind die direkten Folgen.</a:t>
+            </a:r>
+          </a:p>
+        </p:txBody>
+      </p:sp>
+    </p:spTree>
+  </p:cSld>
+  <p:clrMapOvr>
+    <a:masterClrMapping/>
+  </p:clrMapOvr>
+</p:sld>
+</file>
+
+<file path=ppt/slides/slide5.xml><?xml version="1.0" encoding="utf-8"?>
+<p:sld xmlns:a="http://schemas.openxmlformats.org/drawingml/2006/main" xmlns:p="http://schemas.openxmlformats.org/presentationml/2006/main" xmlns:r="http://schemas.openxmlformats.org/officeDocument/2006/relationships">
+  <p:cSld>
+    <p:spTree>
+      <p:nvGrpSpPr>
+        <p:cNvPr id="1" name=""/>
+        <p:cNvGrpSpPr/>
+        <p:nvPr/>
+      </p:nvGrpSpPr>
+      <p:grpSpPr/>
+      <p:sp>
+        <p:nvSpPr>
+          <p:cNvPr id="2" name="Pentagon 1"/>
+          <p:cNvSpPr/>
+          <p:nvPr/>
+        </p:nvSpPr>
+        <p:spPr>
+          <a:xfrm>
+            <a:off x="5120640" y="137160"/>
+            <a:ext cx="530352" cy="292608"/>
+          </a:xfrm>
+          <a:prstGeom prst="homePlate">
+            <a:avLst/>
+          </a:prstGeom>
+          <a:solidFill>
+            <a:srgbClr val="888888"/>
+          </a:solidFill>
+          <a:ln>
+            <a:noFill/>
+          </a:ln>
+          <a:effectLst/>
+        </p:spPr>
+        <p:style>
+          <a:lnRef idx="1">
+            <a:schemeClr val="accent1"/>
+          </a:lnRef>
+          <a:fillRef idx="3">
+            <a:schemeClr val="accent1"/>
+          </a:fillRef>
+          <a:effectRef idx="2">
+            <a:schemeClr val="accent1"/>
+          </a:effectRef>
+          <a:fontRef idx="minor">
+            <a:schemeClr val="lt1"/>
+          </a:fontRef>
+        </p:style>
+        <p:txBody>
+          <a:bodyPr rtlCol="0" anchor="ctr"/>
+          <a:lstStyle/>
+          <a:p>
+            <a:pPr algn="ctr"/>
+          </a:p>
+        </p:txBody>
+      </p:sp>
+      <p:sp>
+        <p:nvSpPr>
+          <p:cNvPr id="3" name="Pentagon 2"/>
+          <p:cNvSpPr/>
+          <p:nvPr/>
+        </p:nvSpPr>
+        <p:spPr>
+          <a:xfrm>
+            <a:off x="5687568" y="137160"/>
+            <a:ext cx="530352" cy="292608"/>
+          </a:xfrm>
+          <a:prstGeom prst="homePlate">
+            <a:avLst/>
+          </a:prstGeom>
+          <a:solidFill>
+            <a:srgbClr val="008793"/>
+          </a:solidFill>
+          <a:ln>
+            <a:noFill/>
+          </a:ln>
+          <a:effectLst/>
+        </p:spPr>
+        <p:style>
+          <a:lnRef idx="1">
+            <a:schemeClr val="accent1"/>
+          </a:lnRef>
+          <a:fillRef idx="3">
+            <a:schemeClr val="accent1"/>
+          </a:fillRef>
+          <a:effectRef idx="2">
+            <a:schemeClr val="accent1"/>
+          </a:effectRef>
+          <a:fontRef idx="minor">
+            <a:schemeClr val="lt1"/>
+          </a:fontRef>
+        </p:style>
+        <p:txBody>
+          <a:bodyPr rtlCol="0" anchor="ctr"/>
+          <a:lstStyle/>
+          <a:p>
+            <a:pPr algn="ctr"/>
+          </a:p>
+        </p:txBody>
+      </p:sp>
+      <p:sp>
+        <p:nvSpPr>
+          <p:cNvPr id="4" name="Pentagon 3"/>
+          <p:cNvSpPr/>
+          <p:nvPr/>
+        </p:nvSpPr>
+        <p:spPr>
+          <a:xfrm>
+            <a:off x="6254496" y="137160"/>
+            <a:ext cx="530352" cy="292608"/>
+          </a:xfrm>
+          <a:prstGeom prst="homePlate">
+            <a:avLst/>
+          </a:prstGeom>
+          <a:solidFill>
+            <a:srgbClr val="CC4D8C"/>
+          </a:solidFill>
+          <a:ln>
+            <a:noFill/>
+          </a:ln>
+          <a:effectLst/>
+        </p:spPr>
+        <p:style>
+          <a:lnRef idx="1">
+            <a:schemeClr val="accent1"/>
+          </a:lnRef>
+          <a:fillRef idx="3">
+            <a:schemeClr val="accent1"/>
+          </a:fillRef>
+          <a:effectRef idx="2">
+            <a:schemeClr val="accent1"/>
+          </a:effectRef>
+          <a:fontRef idx="minor">
+            <a:schemeClr val="lt1"/>
+          </a:fontRef>
+        </p:style>
+        <p:txBody>
+          <a:bodyPr rtlCol="0" anchor="ctr"/>
+          <a:lstStyle/>
+          <a:p>
+            <a:pPr algn="ctr"/>
+          </a:p>
+        </p:txBody>
+      </p:sp>
+      <p:sp>
+        <p:nvSpPr>
+          <p:cNvPr id="5" name="Pentagon 4"/>
+          <p:cNvSpPr/>
+          <p:nvPr/>
+        </p:nvSpPr>
+        <p:spPr>
+          <a:xfrm>
+            <a:off x="6821424" y="137160"/>
+            <a:ext cx="530352" cy="292608"/>
+          </a:xfrm>
+          <a:prstGeom prst="homePlate">
+            <a:avLst/>
+          </a:prstGeom>
+          <a:solidFill>
+            <a:srgbClr val="6FC0C6"/>
+          </a:solidFill>
+          <a:ln>
+            <a:noFill/>
+          </a:ln>
+          <a:effectLst/>
+        </p:spPr>
+        <p:style>
+          <a:lnRef idx="1">
+            <a:schemeClr val="accent1"/>
+          </a:lnRef>
+          <a:fillRef idx="3">
+            <a:schemeClr val="accent1"/>
+          </a:fillRef>
+          <a:effectRef idx="2">
+            <a:schemeClr val="accent1"/>
+          </a:effectRef>
+          <a:fontRef idx="minor">
+            <a:schemeClr val="lt1"/>
+          </a:fontRef>
+        </p:style>
+        <p:txBody>
+          <a:bodyPr rtlCol="0" anchor="ctr"/>
+          <a:lstStyle/>
+          <a:p>
+            <a:pPr algn="ctr"/>
+          </a:p>
+        </p:txBody>
+      </p:sp>
+      <p:sp>
+        <p:nvSpPr>
+          <p:cNvPr id="6" name="Pentagon 5"/>
+          <p:cNvSpPr/>
+          <p:nvPr/>
+        </p:nvSpPr>
+        <p:spPr>
+          <a:xfrm>
+            <a:off x="7388352" y="137160"/>
+            <a:ext cx="530352" cy="292608"/>
+          </a:xfrm>
+          <a:prstGeom prst="homePlate">
+            <a:avLst/>
+          </a:prstGeom>
+          <a:solidFill>
+            <a:srgbClr val="E8C43A"/>
+          </a:solidFill>
+          <a:ln>
+            <a:noFill/>
+          </a:ln>
+          <a:effectLst/>
+        </p:spPr>
+        <p:style>
+          <a:lnRef idx="1">
+            <a:schemeClr val="accent1"/>
+          </a:lnRef>
+          <a:fillRef idx="3">
+            <a:schemeClr val="accent1"/>
+          </a:fillRef>
+          <a:effectRef idx="2">
+            <a:schemeClr val="accent1"/>
+          </a:effectRef>
+          <a:fontRef idx="minor">
+            <a:schemeClr val="lt1"/>
+          </a:fontRef>
+        </p:style>
+        <p:txBody>
+          <a:bodyPr rtlCol="0" anchor="ctr"/>
+          <a:lstStyle/>
+          <a:p>
+            <a:pPr algn="ctr"/>
+          </a:p>
+        </p:txBody>
+      </p:sp>
+      <p:sp>
+        <p:nvSpPr>
+          <p:cNvPr id="7" name="TextBox 6"/>
+          <p:cNvSpPr txBox="1"/>
+          <p:nvPr/>
+        </p:nvSpPr>
+        <p:spPr>
+          <a:xfrm>
+            <a:off x="10561320" y="182880"/>
+            <a:ext cx="1463040" cy="502920"/>
+          </a:xfrm>
+          <a:prstGeom prst="rect">
+            <a:avLst/>
+          </a:prstGeom>
+          <a:noFill/>
+        </p:spPr>
+        <p:txBody>
+          <a:bodyPr wrap="square" lIns="36000" rIns="36000" tIns="18000" bIns="18000" anchor="t">
+            <a:spAutoFit/>
+          </a:bodyPr>
+          <a:lstStyle/>
+          <a:p>
+            <a:pPr algn="l"/>
+            <a:r>
+              <a:rPr sz="3200" b="1" i="0" u="none">
+                <a:solidFill>
+                  <a:srgbClr val="E30613"/>
+                </a:solidFill>
+                <a:latin typeface="Calibri"/>
+              </a:rPr>
+              <a:t>ERGO</a:t>
+            </a:r>
+          </a:p>
+        </p:txBody>
+      </p:sp>
+      <p:sp>
+        <p:nvSpPr>
+          <p:cNvPr id="8" name="TextBox 7"/>
+          <p:cNvSpPr txBox="1"/>
+          <p:nvPr/>
+        </p:nvSpPr>
+        <p:spPr>
+          <a:xfrm>
+            <a:off x="10561320" y="731520"/>
+            <a:ext cx="1463040" cy="274320"/>
+          </a:xfrm>
+          <a:prstGeom prst="rect">
+            <a:avLst/>
+          </a:prstGeom>
+          <a:noFill/>
+        </p:spPr>
+        <p:txBody>
+          <a:bodyPr wrap="square" lIns="36000" rIns="36000" tIns="18000" bIns="18000" anchor="t">
+            <a:spAutoFit/>
+          </a:bodyPr>
+          <a:lstStyle/>
+          <a:p>
+            <a:pPr algn="l"/>
+            <a:r>
+              <a:rPr sz="800" b="0" i="0" u="none">
+                <a:solidFill>
+                  <a:srgbClr val="333333"/>
+                </a:solidFill>
+                <a:latin typeface="Calibri"/>
+              </a:rPr>
+              <a:t>A Munich Re company</a:t>
+            </a:r>
+          </a:p>
+        </p:txBody>
+      </p:sp>
+      <p:sp>
+        <p:nvSpPr>
+          <p:cNvPr id="9" name="TextBox 8"/>
+          <p:cNvSpPr txBox="1"/>
+          <p:nvPr/>
+        </p:nvSpPr>
+        <p:spPr>
+          <a:xfrm>
+            <a:off x="411480" y="228600"/>
+            <a:ext cx="6400800" cy="292608"/>
+          </a:xfrm>
+          <a:prstGeom prst="rect">
+            <a:avLst/>
+          </a:prstGeom>
+          <a:noFill/>
+        </p:spPr>
+        <p:txBody>
+          <a:bodyPr wrap="square" lIns="36000" rIns="36000" tIns="18000" bIns="18000" anchor="t">
+            <a:spAutoFit/>
+          </a:bodyPr>
+          <a:lstStyle/>
+          <a:p>
+            <a:pPr algn="l"/>
+            <a:r>
+              <a:rPr sz="1200" b="0" i="0" u="none">
+                <a:solidFill>
+                  <a:srgbClr val="333333"/>
+                </a:solidFill>
+                <a:latin typeface="Calibri"/>
+              </a:rPr>
+              <a:t>STRUKTURIERUNG  |  LÖSUNG</a:t>
+            </a:r>
+          </a:p>
+        </p:txBody>
+      </p:sp>
+      <p:sp>
+        <p:nvSpPr>
+          <p:cNvPr id="10" name="TextBox 9"/>
+          <p:cNvSpPr txBox="1"/>
+          <p:nvPr/>
+        </p:nvSpPr>
+        <p:spPr>
+          <a:xfrm>
+            <a:off x="411480" y="594360"/>
+            <a:ext cx="10058400" cy="502920"/>
+          </a:xfrm>
+          <a:prstGeom prst="rect">
+            <a:avLst/>
+          </a:prstGeom>
+          <a:noFill/>
+        </p:spPr>
+        <p:txBody>
+          <a:bodyPr wrap="square" lIns="36000" rIns="36000" tIns="18000" bIns="18000" anchor="t">
+            <a:spAutoFit/>
+          </a:bodyPr>
+          <a:lstStyle/>
+          <a:p>
+            <a:pPr algn="l"/>
+            <a:r>
+              <a:rPr sz="2000" b="1" i="0" u="none">
+                <a:solidFill>
+                  <a:srgbClr val="E30613"/>
+                </a:solidFill>
+                <a:latin typeface="Calibri"/>
+              </a:rPr>
+              <a:t>KI-Vorqualifizierung erstellt je Mail ein strukturiertes Beiblatt — loest Routing und Steuerung</a:t>
+            </a:r>
+          </a:p>
+        </p:txBody>
+      </p:sp>
+      <p:sp>
+        <p:nvSpPr>
+          <p:cNvPr id="11" name="TextBox 10"/>
+          <p:cNvSpPr txBox="1"/>
+          <p:nvPr/>
+        </p:nvSpPr>
+        <p:spPr>
+          <a:xfrm>
+            <a:off x="411480" y="1078992"/>
+            <a:ext cx="10058400" cy="502920"/>
+          </a:xfrm>
+          <a:prstGeom prst="rect">
+            <a:avLst/>
+          </a:prstGeom>
+          <a:noFill/>
+        </p:spPr>
+        <p:txBody>
+          <a:bodyPr wrap="square" lIns="36000" rIns="36000" tIns="18000" bIns="18000" anchor="t">
+            <a:spAutoFit/>
+          </a:bodyPr>
+          <a:lstStyle/>
+          <a:p>
+            <a:pPr algn="l"/>
+            <a:r>
+              <a:rPr sz="2000" b="1" i="0" u="none">
+                <a:solidFill>
+                  <a:srgbClr val="E30613"/>
+                </a:solidFill>
+                <a:latin typeface="Calibri"/>
+              </a:rPr>
+              <a:t>und ist zugleich die Grundvoraussetzung fuer die automatisierte BÜ-Pruefung (Bot)</a:t>
+            </a:r>
+          </a:p>
+        </p:txBody>
+      </p:sp>
+      <p:sp>
+        <p:nvSpPr>
+          <p:cNvPr id="12" name="TextBox 11"/>
+          <p:cNvSpPr txBox="1"/>
+          <p:nvPr/>
+        </p:nvSpPr>
+        <p:spPr>
+          <a:xfrm>
+            <a:off x="411480" y="1920240"/>
+            <a:ext cx="7315200" cy="320040"/>
+          </a:xfrm>
+          <a:prstGeom prst="rect">
+            <a:avLst/>
+          </a:prstGeom>
+          <a:noFill/>
+        </p:spPr>
+        <p:txBody>
+          <a:bodyPr wrap="square" lIns="36000" rIns="36000" tIns="18000" bIns="18000" anchor="t">
+            <a:spAutoFit/>
+          </a:bodyPr>
+          <a:lstStyle/>
+          <a:p>
+            <a:pPr algn="l"/>
+            <a:r>
+              <a:rPr sz="1300" b="1" i="0" u="none">
+                <a:solidFill>
+                  <a:srgbClr val="333333"/>
+                </a:solidFill>
+                <a:latin typeface="Calibri"/>
+              </a:rPr>
+              <a:t>LÖSUNG</a:t>
+            </a:r>
+          </a:p>
+        </p:txBody>
+      </p:sp>
+      <p:sp>
+        <p:nvSpPr>
+          <p:cNvPr id="13" name="TextBox 12"/>
+          <p:cNvSpPr txBox="1"/>
+          <p:nvPr/>
+        </p:nvSpPr>
+        <p:spPr>
+          <a:xfrm>
+            <a:off x="8229600" y="1920240"/>
+            <a:ext cx="3657600" cy="320040"/>
+          </a:xfrm>
+          <a:prstGeom prst="rect">
+            <a:avLst/>
+          </a:prstGeom>
+          <a:noFill/>
+        </p:spPr>
+        <p:txBody>
+          <a:bodyPr wrap="square" lIns="36000" rIns="36000" tIns="18000" bIns="18000" anchor="t">
+            <a:spAutoFit/>
+          </a:bodyPr>
+          <a:lstStyle/>
+          <a:p>
+            <a:pPr algn="l"/>
+            <a:r>
+              <a:rPr sz="1300" b="1" i="0" u="none">
+                <a:solidFill>
+                  <a:srgbClr val="333333"/>
+                </a:solidFill>
+                <a:latin typeface="Calibri"/>
+              </a:rPr>
+              <a:t>KERNAUSSAGEN</a:t>
+            </a:r>
+          </a:p>
+        </p:txBody>
+      </p:sp>
+      <p:sp>
+        <p:nvSpPr>
+          <p:cNvPr id="14" name="Rectangle 13"/>
+          <p:cNvSpPr/>
+          <p:nvPr/>
+        </p:nvSpPr>
+        <p:spPr>
+          <a:xfrm>
+            <a:off x="411480" y="6446520"/>
+            <a:ext cx="11338560" cy="9525"/>
+          </a:xfrm>
+          <a:prstGeom prst="rect">
+            <a:avLst/>
+          </a:prstGeom>
+          <a:solidFill>
+            <a:srgbClr val="CCCCCC"/>
+          </a:solidFill>
+          <a:ln>
+            <a:noFill/>
+          </a:ln>
+          <a:effectLst/>
+        </p:spPr>
+        <p:style>
+          <a:lnRef idx="1">
+            <a:schemeClr val="accent1"/>
+          </a:lnRef>
+          <a:fillRef idx="3">
+            <a:schemeClr val="accent1"/>
+          </a:fillRef>
+          <a:effectRef idx="2">
+            <a:schemeClr val="accent1"/>
+          </a:effectRef>
+          <a:fontRef idx="minor">
+            <a:schemeClr val="lt1"/>
+          </a:fontRef>
+        </p:style>
+        <p:txBody>
+          <a:bodyPr rtlCol="0" anchor="ctr"/>
+          <a:lstStyle/>
+          <a:p>
+            <a:pPr algn="ctr"/>
+          </a:p>
+        </p:txBody>
+      </p:sp>
+      <p:sp>
+        <p:nvSpPr>
+          <p:cNvPr id="15" name="TextBox 14"/>
+          <p:cNvSpPr txBox="1"/>
+          <p:nvPr/>
+        </p:nvSpPr>
+        <p:spPr>
+          <a:xfrm>
+            <a:off x="411480" y="6510528"/>
+            <a:ext cx="10058400" cy="274320"/>
+          </a:xfrm>
+          <a:prstGeom prst="rect">
+            <a:avLst/>
+          </a:prstGeom>
+          <a:noFill/>
+        </p:spPr>
+        <p:txBody>
+          <a:bodyPr wrap="square" lIns="36000" rIns="36000" tIns="18000" bIns="18000" anchor="t">
+            <a:spAutoFit/>
+          </a:bodyPr>
+          <a:lstStyle/>
+          <a:p>
+            <a:pPr algn="l"/>
+            <a:r>
+              <a:rPr sz="900" b="0" i="0" u="none">
+                <a:solidFill>
+                  <a:srgbClr val="666666"/>
+                </a:solidFill>
+                <a:latin typeface="Calibri"/>
+              </a:rPr>
+              <a:t>ERGO | Makler BUe meets KI – Zwischenbericht Phase 1 - 10.06.2026</a:t>
+            </a:r>
+          </a:p>
+        </p:txBody>
+      </p:sp>
+      <p:sp>
+        <p:nvSpPr>
+          <p:cNvPr id="16" name="TextBox 15"/>
+          <p:cNvSpPr txBox="1"/>
+          <p:nvPr/>
+        </p:nvSpPr>
+        <p:spPr>
+          <a:xfrm>
+            <a:off x="11338560" y="6510528"/>
+            <a:ext cx="457200" cy="274320"/>
+          </a:xfrm>
+          <a:prstGeom prst="rect">
+            <a:avLst/>
+          </a:prstGeom>
+          <a:noFill/>
+        </p:spPr>
+        <p:txBody>
+          <a:bodyPr wrap="square" lIns="36000" rIns="36000" tIns="18000" bIns="18000" anchor="t">
+            <a:spAutoFit/>
+          </a:bodyPr>
+          <a:lstStyle/>
+          <a:p>
+            <a:pPr algn="r"/>
+            <a:r>
+              <a:rPr sz="900" b="0" i="0" u="none">
+                <a:solidFill>
+                  <a:srgbClr val="666666"/>
+                </a:solidFill>
+                <a:latin typeface="Calibri"/>
+              </a:rPr>
+              <a:t>13</a:t>
+            </a:r>
+          </a:p>
+        </p:txBody>
+      </p:sp>
+      <p:sp>
+        <p:nvSpPr>
+          <p:cNvPr id="17" name="Rectangle 16"/>
+          <p:cNvSpPr/>
+          <p:nvPr/>
+        </p:nvSpPr>
+        <p:spPr>
+          <a:xfrm>
+            <a:off x="411480" y="2331720"/>
+            <a:ext cx="7635240" cy="960120"/>
+          </a:xfrm>
+          <a:prstGeom prst="rect">
+            <a:avLst/>
+          </a:prstGeom>
+          <a:solidFill>
+            <a:srgbClr val="CFE6E9"/>
+          </a:solidFill>
+          <a:ln w="12700">
+            <a:solidFill>
+              <a:srgbClr val="008793"/>
+            </a:solidFill>
+          </a:ln>
+          <a:effectLst/>
+        </p:spPr>
+        <p:style>
+          <a:lnRef idx="1">
+            <a:schemeClr val="accent1"/>
+          </a:lnRef>
+          <a:fillRef idx="3">
+            <a:schemeClr val="accent1"/>
+          </a:fillRef>
+          <a:effectRef idx="2">
+            <a:schemeClr val="accent1"/>
+          </a:effectRef>
+          <a:fontRef idx="minor">
+            <a:schemeClr val="lt1"/>
+          </a:fontRef>
+        </p:style>
+        <p:txBody>
+          <a:bodyPr rtlCol="0" anchor="ctr"/>
+          <a:lstStyle/>
+          <a:p>
+            <a:pPr algn="ctr"/>
+          </a:p>
+        </p:txBody>
+      </p:sp>
+      <p:sp>
+        <p:nvSpPr>
+          <p:cNvPr id="18" name="TextBox 17"/>
+          <p:cNvSpPr txBox="1"/>
+          <p:nvPr/>
+        </p:nvSpPr>
+        <p:spPr>
+          <a:xfrm>
+            <a:off x="594360" y="2423160"/>
+            <a:ext cx="7269480" cy="310896"/>
+          </a:xfrm>
+          <a:prstGeom prst="rect">
+            <a:avLst/>
+          </a:prstGeom>
+          <a:noFill/>
+        </p:spPr>
+        <p:txBody>
+          <a:bodyPr wrap="square" lIns="36000" rIns="36000" tIns="18000" bIns="18000" anchor="t">
+            <a:spAutoFit/>
+          </a:bodyPr>
+          <a:lstStyle/>
+          <a:p>
+            <a:pPr algn="l"/>
+            <a:r>
+              <a:rPr sz="1300" b="1" i="0" u="none">
+                <a:solidFill>
+                  <a:srgbClr val="006B77"/>
+                </a:solidFill>
+                <a:latin typeface="Calibri"/>
+              </a:rPr>
+              <a:t>Wirkkette: jede Eingangsmail → KI-Strukturierung → einheitliches Beiblatt</a:t>
+            </a:r>
+          </a:p>
+        </p:txBody>
+      </p:sp>
+      <p:sp>
+        <p:nvSpPr>
+          <p:cNvPr id="19" name="TextBox 18"/>
+          <p:cNvSpPr txBox="1"/>
+          <p:nvPr/>
+        </p:nvSpPr>
+        <p:spPr>
+          <a:xfrm>
+            <a:off x="594360" y="2770632"/>
+            <a:ext cx="7269480" cy="457200"/>
+          </a:xfrm>
+          <a:prstGeom prst="rect">
+            <a:avLst/>
+          </a:prstGeom>
+          <a:noFill/>
+        </p:spPr>
+        <p:txBody>
+          <a:bodyPr wrap="square" lIns="36000" rIns="36000" tIns="18000" bIns="18000" anchor="t">
+            <a:spAutoFit/>
+          </a:bodyPr>
+          <a:lstStyle/>
+          <a:p>
+            <a:pPr algn="l"/>
+            <a:r>
+              <a:rPr sz="1100" b="0" i="0" u="none">
+                <a:solidFill>
+                  <a:srgbClr val="333333"/>
+                </a:solidFill>
+                <a:latin typeface="Calibri"/>
+              </a:rPr>
+              <a:t>50 Felder immer an gleicher Stelle: Status · MV-Kontext · Makler · Kunde · Versicherungsnummer · Vorgangs-Cluster</a:t>
+            </a:r>
+          </a:p>
+        </p:txBody>
+      </p:sp>
+      <p:sp>
+        <p:nvSpPr>
+          <p:cNvPr id="20" name="Rectangle 19"/>
+          <p:cNvSpPr/>
+          <p:nvPr/>
+        </p:nvSpPr>
+        <p:spPr>
+          <a:xfrm>
+            <a:off x="411480" y="3474720"/>
+            <a:ext cx="2423160" cy="1783080"/>
+          </a:xfrm>
+          <a:prstGeom prst="rect">
+            <a:avLst/>
+          </a:prstGeom>
+          <a:solidFill>
+            <a:srgbClr val="FFFFFF"/>
+          </a:solidFill>
+          <a:ln w="15875">
+            <a:solidFill>
+              <a:srgbClr val="E30613"/>
+            </a:solidFill>
+          </a:ln>
+          <a:effectLst/>
+        </p:spPr>
+        <p:style>
+          <a:lnRef idx="1">
+            <a:schemeClr val="accent1"/>
+          </a:lnRef>
+          <a:fillRef idx="3">
+            <a:schemeClr val="accent1"/>
+          </a:fillRef>
+          <a:effectRef idx="2">
+            <a:schemeClr val="accent1"/>
+          </a:effectRef>
+          <a:fontRef idx="minor">
+            <a:schemeClr val="lt1"/>
+          </a:fontRef>
+        </p:style>
+        <p:txBody>
+          <a:bodyPr rtlCol="0" anchor="ctr"/>
+          <a:lstStyle/>
+          <a:p>
+            <a:pPr algn="ctr"/>
+          </a:p>
+        </p:txBody>
+      </p:sp>
+      <p:sp>
+        <p:nvSpPr>
+          <p:cNvPr id="21" name="Rectangle 20"/>
+          <p:cNvSpPr/>
+          <p:nvPr/>
+        </p:nvSpPr>
+        <p:spPr>
+          <a:xfrm>
+            <a:off x="411480" y="3474720"/>
+            <a:ext cx="2423160" cy="54864"/>
+          </a:xfrm>
+          <a:prstGeom prst="rect">
+            <a:avLst/>
+          </a:prstGeom>
+          <a:solidFill>
+            <a:srgbClr val="E30613"/>
+          </a:solidFill>
+          <a:ln>
+            <a:noFill/>
+          </a:ln>
+          <a:effectLst/>
+        </p:spPr>
+        <p:style>
+          <a:lnRef idx="1">
+            <a:schemeClr val="accent1"/>
+          </a:lnRef>
+          <a:fillRef idx="3">
+            <a:schemeClr val="accent1"/>
+          </a:fillRef>
+          <a:effectRef idx="2">
+            <a:schemeClr val="accent1"/>
+          </a:effectRef>
+          <a:fontRef idx="minor">
+            <a:schemeClr val="lt1"/>
+          </a:fontRef>
+        </p:style>
+        <p:txBody>
+          <a:bodyPr rtlCol="0" anchor="ctr"/>
+          <a:lstStyle/>
+          <a:p>
+            <a:pPr algn="ctr"/>
+          </a:p>
+        </p:txBody>
+      </p:sp>
+      <p:sp>
+        <p:nvSpPr>
+          <p:cNvPr id="22" name="TextBox 21"/>
+          <p:cNvSpPr txBox="1"/>
+          <p:nvPr/>
+        </p:nvSpPr>
+        <p:spPr>
+          <a:xfrm>
+            <a:off x="521208" y="3602736"/>
+            <a:ext cx="2203704" cy="365760"/>
+          </a:xfrm>
+          <a:prstGeom prst="rect">
+            <a:avLst/>
+          </a:prstGeom>
+          <a:noFill/>
+        </p:spPr>
+        <p:txBody>
+          <a:bodyPr wrap="square" lIns="36000" rIns="36000" tIns="18000" bIns="18000" anchor="t">
+            <a:spAutoFit/>
+          </a:bodyPr>
+          <a:lstStyle/>
+          <a:p>
+            <a:pPr algn="l"/>
+            <a:r>
+              <a:rPr sz="1200" b="1" i="0" u="none">
+                <a:solidFill>
+                  <a:srgbClr val="E30613"/>
+                </a:solidFill>
+                <a:latin typeface="Calibri"/>
+              </a:rPr>
+              <a:t>1  Korrektes Routing</a:t>
+            </a:r>
+          </a:p>
+        </p:txBody>
+      </p:sp>
+      <p:sp>
+        <p:nvSpPr>
+          <p:cNvPr id="23" name="TextBox 22"/>
+          <p:cNvSpPr txBox="1"/>
+          <p:nvPr/>
+        </p:nvSpPr>
+        <p:spPr>
+          <a:xfrm>
+            <a:off x="521208" y="4005072"/>
+            <a:ext cx="2203704" cy="1179576"/>
+          </a:xfrm>
+          <a:prstGeom prst="rect">
+            <a:avLst/>
+          </a:prstGeom>
+          <a:noFill/>
+        </p:spPr>
+        <p:txBody>
+          <a:bodyPr wrap="square" lIns="36000" rIns="36000" tIns="18000" bIns="18000" anchor="t">
+            <a:spAutoFit/>
+          </a:bodyPr>
+          <a:lstStyle/>
+          <a:p>
+            <a:pPr algn="l"/>
+            <a:r>
+              <a:rPr sz="1000" b="0" i="0" u="none">
+                <a:solidFill>
+                  <a:srgbClr val="333333"/>
+                </a:solidFill>
+                <a:latin typeface="Calibri"/>
+              </a:rPr>
+              <a:t>Status (Reminder / Keine BÜ) wird trotz MV erkannt → Mail landet im richtigen Postfach. 240 Fehlanlagen / Woche entfallen.</a:t>
+            </a:r>
+          </a:p>
+        </p:txBody>
+      </p:sp>
+      <p:sp>
+        <p:nvSpPr>
+          <p:cNvPr id="24" name="Rectangle 23"/>
+          <p:cNvSpPr/>
+          <p:nvPr/>
+        </p:nvSpPr>
+        <p:spPr>
+          <a:xfrm>
+            <a:off x="3017520" y="3474720"/>
+            <a:ext cx="2423160" cy="1783080"/>
+          </a:xfrm>
+          <a:prstGeom prst="rect">
+            <a:avLst/>
+          </a:prstGeom>
+          <a:solidFill>
+            <a:srgbClr val="FFFFFF"/>
+          </a:solidFill>
+          <a:ln w="15875">
+            <a:solidFill>
+              <a:srgbClr val="008793"/>
+            </a:solidFill>
+          </a:ln>
+          <a:effectLst/>
+        </p:spPr>
+        <p:style>
+          <a:lnRef idx="1">
+            <a:schemeClr val="accent1"/>
+          </a:lnRef>
+          <a:fillRef idx="3">
+            <a:schemeClr val="accent1"/>
+          </a:fillRef>
+          <a:effectRef idx="2">
+            <a:schemeClr val="accent1"/>
+          </a:effectRef>
+          <a:fontRef idx="minor">
+            <a:schemeClr val="lt1"/>
+          </a:fontRef>
+        </p:style>
+        <p:txBody>
+          <a:bodyPr rtlCol="0" anchor="ctr"/>
+          <a:lstStyle/>
+          <a:p>
+            <a:pPr algn="ctr"/>
+          </a:p>
+        </p:txBody>
+      </p:sp>
+      <p:sp>
+        <p:nvSpPr>
+          <p:cNvPr id="25" name="Rectangle 24"/>
+          <p:cNvSpPr/>
+          <p:nvPr/>
+        </p:nvSpPr>
+        <p:spPr>
+          <a:xfrm>
+            <a:off x="3017520" y="3474720"/>
+            <a:ext cx="2423160" cy="54864"/>
+          </a:xfrm>
+          <a:prstGeom prst="rect">
+            <a:avLst/>
+          </a:prstGeom>
+          <a:solidFill>
+            <a:srgbClr val="008793"/>
+          </a:solidFill>
+          <a:ln>
+            <a:noFill/>
+          </a:ln>
+          <a:effectLst/>
+        </p:spPr>
+        <p:style>
+          <a:lnRef idx="1">
+            <a:schemeClr val="accent1"/>
+          </a:lnRef>
+          <a:fillRef idx="3">
+            <a:schemeClr val="accent1"/>
+          </a:fillRef>
+          <a:effectRef idx="2">
+            <a:schemeClr val="accent1"/>
+          </a:effectRef>
+          <a:fontRef idx="minor">
+            <a:schemeClr val="lt1"/>
+          </a:fontRef>
+        </p:style>
+        <p:txBody>
+          <a:bodyPr rtlCol="0" anchor="ctr"/>
+          <a:lstStyle/>
+          <a:p>
+            <a:pPr algn="ctr"/>
+          </a:p>
+        </p:txBody>
+      </p:sp>
+      <p:sp>
+        <p:nvSpPr>
+          <p:cNvPr id="26" name="TextBox 25"/>
+          <p:cNvSpPr txBox="1"/>
+          <p:nvPr/>
+        </p:nvSpPr>
+        <p:spPr>
+          <a:xfrm>
+            <a:off x="3127248" y="3602736"/>
+            <a:ext cx="2203704" cy="365760"/>
+          </a:xfrm>
+          <a:prstGeom prst="rect">
+            <a:avLst/>
+          </a:prstGeom>
+          <a:noFill/>
+        </p:spPr>
+        <p:txBody>
+          <a:bodyPr wrap="square" lIns="36000" rIns="36000" tIns="18000" bIns="18000" anchor="t">
+            <a:spAutoFit/>
+          </a:bodyPr>
+          <a:lstStyle/>
+          <a:p>
+            <a:pPr algn="l"/>
+            <a:r>
+              <a:rPr sz="1200" b="1" i="0" u="none">
+                <a:solidFill>
+                  <a:srgbClr val="008793"/>
+                </a:solidFill>
+                <a:latin typeface="Calibri"/>
+              </a:rPr>
+              <a:t>2  Vorgangs-Steuerung</a:t>
+            </a:r>
+          </a:p>
+        </p:txBody>
+      </p:sp>
+      <p:sp>
+        <p:nvSpPr>
+          <p:cNvPr id="27" name="TextBox 26"/>
+          <p:cNvSpPr txBox="1"/>
+          <p:nvPr/>
+        </p:nvSpPr>
+        <p:spPr>
+          <a:xfrm>
+            <a:off x="3127248" y="4005072"/>
+            <a:ext cx="2203704" cy="1179576"/>
+          </a:xfrm>
+          <a:prstGeom prst="rect">
+            <a:avLst/>
+          </a:prstGeom>
+          <a:noFill/>
+        </p:spPr>
+        <p:txBody>
+          <a:bodyPr wrap="square" lIns="36000" rIns="36000" tIns="18000" bIns="18000" anchor="t">
+            <a:spAutoFit/>
+          </a:bodyPr>
+          <a:lstStyle/>
+          <a:p>
+            <a:pPr algn="l"/>
+            <a:r>
+              <a:rPr sz="1000" b="0" i="0" u="none">
+                <a:solidFill>
+                  <a:srgbClr val="333333"/>
+                </a:solidFill>
+                <a:latin typeface="Calibri"/>
+              </a:rPr>
+              <a:t>Makler + Kunde + VNR buendeln Mails automatisch zu Vorgaengen → gebuendeltes Abarbeiten, Filter nach Prio-Fall und Prio-Makler.</a:t>
+            </a:r>
+          </a:p>
+        </p:txBody>
+      </p:sp>
+      <p:sp>
+        <p:nvSpPr>
+          <p:cNvPr id="28" name="Rectangle 27"/>
+          <p:cNvSpPr/>
+          <p:nvPr/>
+        </p:nvSpPr>
+        <p:spPr>
+          <a:xfrm>
+            <a:off x="5623560" y="3474720"/>
+            <a:ext cx="2423160" cy="1783080"/>
+          </a:xfrm>
+          <a:prstGeom prst="rect">
+            <a:avLst/>
+          </a:prstGeom>
+          <a:solidFill>
+            <a:srgbClr val="FFFFFF"/>
+          </a:solidFill>
+          <a:ln w="15875">
+            <a:solidFill>
+              <a:srgbClr val="333333"/>
+            </a:solidFill>
+          </a:ln>
+          <a:effectLst/>
+        </p:spPr>
+        <p:style>
+          <a:lnRef idx="1">
+            <a:schemeClr val="accent1"/>
+          </a:lnRef>
+          <a:fillRef idx="3">
+            <a:schemeClr val="accent1"/>
+          </a:fillRef>
+          <a:effectRef idx="2">
+            <a:schemeClr val="accent1"/>
+          </a:effectRef>
+          <a:fontRef idx="minor">
+            <a:schemeClr val="lt1"/>
+          </a:fontRef>
+        </p:style>
+        <p:txBody>
+          <a:bodyPr rtlCol="0" anchor="ctr"/>
+          <a:lstStyle/>
+          <a:p>
+            <a:pPr algn="ctr"/>
+          </a:p>
+        </p:txBody>
+      </p:sp>
+      <p:sp>
+        <p:nvSpPr>
+          <p:cNvPr id="29" name="Rectangle 28"/>
+          <p:cNvSpPr/>
+          <p:nvPr/>
+        </p:nvSpPr>
+        <p:spPr>
+          <a:xfrm>
+            <a:off x="5623560" y="3474720"/>
+            <a:ext cx="2423160" cy="54864"/>
+          </a:xfrm>
+          <a:prstGeom prst="rect">
+            <a:avLst/>
+          </a:prstGeom>
+          <a:solidFill>
+            <a:srgbClr val="333333"/>
+          </a:solidFill>
+          <a:ln>
+            <a:noFill/>
+          </a:ln>
+          <a:effectLst/>
+        </p:spPr>
+        <p:style>
+          <a:lnRef idx="1">
+            <a:schemeClr val="accent1"/>
+          </a:lnRef>
+          <a:fillRef idx="3">
+            <a:schemeClr val="accent1"/>
+          </a:fillRef>
+          <a:effectRef idx="2">
+            <a:schemeClr val="accent1"/>
+          </a:effectRef>
+          <a:fontRef idx="minor">
+            <a:schemeClr val="lt1"/>
+          </a:fontRef>
+        </p:style>
+        <p:txBody>
+          <a:bodyPr rtlCol="0" anchor="ctr"/>
+          <a:lstStyle/>
+          <a:p>
+            <a:pPr algn="ctr"/>
+          </a:p>
+        </p:txBody>
+      </p:sp>
+      <p:sp>
+        <p:nvSpPr>
+          <p:cNvPr id="30" name="TextBox 29"/>
+          <p:cNvSpPr txBox="1"/>
+          <p:nvPr/>
+        </p:nvSpPr>
+        <p:spPr>
+          <a:xfrm>
+            <a:off x="5733288" y="3602736"/>
+            <a:ext cx="2203704" cy="365760"/>
+          </a:xfrm>
+          <a:prstGeom prst="rect">
+            <a:avLst/>
+          </a:prstGeom>
+          <a:noFill/>
+        </p:spPr>
+        <p:txBody>
+          <a:bodyPr wrap="square" lIns="36000" rIns="36000" tIns="18000" bIns="18000" anchor="t">
+            <a:spAutoFit/>
+          </a:bodyPr>
+          <a:lstStyle/>
+          <a:p>
+            <a:pPr algn="l"/>
+            <a:r>
+              <a:rPr sz="1200" b="1" i="0" u="none">
+                <a:solidFill>
+                  <a:srgbClr val="333333"/>
+                </a:solidFill>
+                <a:latin typeface="Calibri"/>
+              </a:rPr>
+              <a:t>3  Automatisierte Pruefung</a:t>
+            </a:r>
+          </a:p>
+        </p:txBody>
+      </p:sp>
+      <p:sp>
+        <p:nvSpPr>
+          <p:cNvPr id="31" name="TextBox 30"/>
+          <p:cNvSpPr txBox="1"/>
+          <p:nvPr/>
+        </p:nvSpPr>
+        <p:spPr>
+          <a:xfrm>
+            <a:off x="5733288" y="4005072"/>
+            <a:ext cx="2203704" cy="1179576"/>
+          </a:xfrm>
+          <a:prstGeom prst="rect">
+            <a:avLst/>
+          </a:prstGeom>
+          <a:noFill/>
+        </p:spPr>
+        <p:txBody>
+          <a:bodyPr wrap="square" lIns="36000" rIns="36000" tIns="18000" bIns="18000" anchor="t">
+            <a:spAutoFit/>
+          </a:bodyPr>
+          <a:lstStyle/>
+          <a:p>
+            <a:pPr algn="l"/>
+            <a:r>
+              <a:rPr sz="1000" b="0" i="0" u="none">
+                <a:solidFill>
+                  <a:srgbClr val="333333"/>
+                </a:solidFill>
+                <a:latin typeface="Calibri"/>
+              </a:rPr>
+              <a:t>Der Bot liest die standardisierten Felder (VNR, MV-Status, Unterschriften) → Voraussetzung fuer Dunkelverarbeitung.</a:t>
+            </a:r>
+          </a:p>
+        </p:txBody>
+      </p:sp>
+      <p:sp>
+        <p:nvSpPr>
+          <p:cNvPr id="32" name="Rectangle 31"/>
+          <p:cNvSpPr/>
+          <p:nvPr/>
+        </p:nvSpPr>
+        <p:spPr>
+          <a:xfrm>
+            <a:off x="8229600" y="2240280"/>
+            <a:ext cx="3611880" cy="3611880"/>
+          </a:xfrm>
+          <a:prstGeom prst="rect">
+            <a:avLst/>
+          </a:prstGeom>
+          <a:solidFill>
+            <a:srgbClr val="CFE6E9"/>
+          </a:solidFill>
+          <a:ln>
+            <a:noFill/>
+          </a:ln>
+          <a:effectLst/>
+        </p:spPr>
+        <p:style>
+          <a:lnRef idx="1">
+            <a:schemeClr val="accent1"/>
+          </a:lnRef>
+          <a:fillRef idx="3">
+            <a:schemeClr val="accent1"/>
+          </a:fillRef>
+          <a:effectRef idx="2">
+            <a:schemeClr val="accent1"/>
+          </a:effectRef>
+          <a:fontRef idx="minor">
+            <a:schemeClr val="lt1"/>
+          </a:fontRef>
+        </p:style>
+        <p:txBody>
+          <a:bodyPr rtlCol="0" anchor="ctr"/>
+          <a:lstStyle/>
+          <a:p>
+            <a:pPr algn="ctr"/>
+          </a:p>
+        </p:txBody>
+      </p:sp>
+      <p:sp>
+        <p:nvSpPr>
+          <p:cNvPr id="33" name="Oval 32"/>
+          <p:cNvSpPr/>
+          <p:nvPr/>
+        </p:nvSpPr>
+        <p:spPr>
+          <a:xfrm>
+            <a:off x="8394192" y="2441448"/>
+            <a:ext cx="384048" cy="384048"/>
+          </a:xfrm>
+          <a:prstGeom prst="ellipse">
+            <a:avLst/>
+          </a:prstGeom>
+          <a:solidFill>
+            <a:srgbClr val="FFFFFF"/>
+          </a:solidFill>
+          <a:ln w="22225">
+            <a:solidFill>
+              <a:srgbClr val="E30613"/>
+            </a:solidFill>
+          </a:ln>
+          <a:effectLst/>
+        </p:spPr>
+        <p:style>
+          <a:lnRef idx="1">
+            <a:schemeClr val="accent1"/>
+          </a:lnRef>
+          <a:fillRef idx="3">
+            <a:schemeClr val="accent1"/>
+          </a:fillRef>
+          <a:effectRef idx="2">
+            <a:schemeClr val="accent1"/>
+          </a:effectRef>
+          <a:fontRef idx="minor">
+            <a:schemeClr val="lt1"/>
+          </a:fontRef>
+        </p:style>
+        <p:txBody>
+          <a:bodyPr rtlCol="0" anchor="ctr"/>
+          <a:lstStyle/>
+          <a:p>
+            <a:pPr algn="ctr"/>
+          </a:p>
+        </p:txBody>
+      </p:sp>
+      <p:sp>
+        <p:nvSpPr>
+          <p:cNvPr id="34" name="TextBox 33"/>
+          <p:cNvSpPr txBox="1"/>
+          <p:nvPr/>
+        </p:nvSpPr>
+        <p:spPr>
+          <a:xfrm>
+            <a:off x="8394192" y="2441448"/>
+            <a:ext cx="384048" cy="384048"/>
+          </a:xfrm>
+          <a:prstGeom prst="rect">
+            <a:avLst/>
+          </a:prstGeom>
+          <a:noFill/>
+        </p:spPr>
+        <p:txBody>
+          <a:bodyPr wrap="square" lIns="36000" rIns="36000" tIns="18000" bIns="18000" anchor="ctr">
+            <a:spAutoFit/>
+          </a:bodyPr>
+          <a:lstStyle/>
+          <a:p>
+            <a:pPr algn="ctr"/>
+            <a:r>
+              <a:rPr sz="1500" b="1" i="0" u="none">
+                <a:solidFill>
+                  <a:srgbClr val="E30613"/>
+                </a:solidFill>
+                <a:latin typeface="Calibri"/>
+              </a:rPr>
+              <a:t>A</a:t>
+            </a:r>
+          </a:p>
+        </p:txBody>
+      </p:sp>
+      <p:sp>
+        <p:nvSpPr>
+          <p:cNvPr id="35" name="TextBox 34"/>
+          <p:cNvSpPr txBox="1"/>
+          <p:nvPr/>
+        </p:nvSpPr>
+        <p:spPr>
+          <a:xfrm>
+            <a:off x="8887968" y="2404872"/>
+            <a:ext cx="2834640" cy="292608"/>
+          </a:xfrm>
+          <a:prstGeom prst="rect">
+            <a:avLst/>
+          </a:prstGeom>
+          <a:noFill/>
+        </p:spPr>
+        <p:txBody>
+          <a:bodyPr wrap="square" lIns="36000" rIns="36000" tIns="18000" bIns="18000" anchor="t">
+            <a:spAutoFit/>
+          </a:bodyPr>
+          <a:lstStyle/>
+          <a:p>
+            <a:pPr algn="l"/>
+            <a:r>
+              <a:rPr sz="1300" b="1" i="0" u="none">
+                <a:solidFill>
+                  <a:srgbClr val="333333"/>
+                </a:solidFill>
+                <a:latin typeface="Calibri"/>
+              </a:rPr>
+              <a:t>Loesung Routing</a:t>
+            </a:r>
+          </a:p>
+        </p:txBody>
+      </p:sp>
+      <p:sp>
+        <p:nvSpPr>
+          <p:cNvPr id="36" name="TextBox 35"/>
+          <p:cNvSpPr txBox="1"/>
+          <p:nvPr/>
+        </p:nvSpPr>
+        <p:spPr>
+          <a:xfrm>
+            <a:off x="8887968" y="2697480"/>
+            <a:ext cx="2788920" cy="1376172"/>
+          </a:xfrm>
+          <a:prstGeom prst="rect">
+            <a:avLst/>
+          </a:prstGeom>
+          <a:noFill/>
+        </p:spPr>
+        <p:txBody>
+          <a:bodyPr wrap="square" lIns="36000" rIns="36000" tIns="18000" bIns="18000" anchor="t">
+            <a:spAutoFit/>
+          </a:bodyPr>
+          <a:lstStyle/>
+          <a:p>
+            <a:pPr algn="l"/>
+            <a:r>
+              <a:rPr sz="1100" b="0" i="0" u="none">
+                <a:solidFill>
+                  <a:srgbClr val="333333"/>
+                </a:solidFill>
+                <a:latin typeface="Calibri"/>
+              </a:rPr>
+              <a:t>Die Strukturierung liest den tatsaechlichen Status unabhaengig von der MV → Mails werden korrekt zugestellt, 240 Fehlanlagen / Woche entfallen, keine Dubletten.</a:t>
+            </a:r>
+          </a:p>
+        </p:txBody>
+      </p:sp>
+      <p:sp>
+        <p:nvSpPr>
+          <p:cNvPr id="37" name="Oval 36"/>
+          <p:cNvSpPr/>
+          <p:nvPr/>
+        </p:nvSpPr>
+        <p:spPr>
+          <a:xfrm>
+            <a:off x="8394192" y="4110228"/>
+            <a:ext cx="384048" cy="384048"/>
+          </a:xfrm>
+          <a:prstGeom prst="ellipse">
+            <a:avLst/>
+          </a:prstGeom>
+          <a:solidFill>
+            <a:srgbClr val="FFFFFF"/>
+          </a:solidFill>
+          <a:ln w="22225">
+            <a:solidFill>
+              <a:srgbClr val="008793"/>
+            </a:solidFill>
+          </a:ln>
+          <a:effectLst/>
+        </p:spPr>
+        <p:style>
+          <a:lnRef idx="1">
+            <a:schemeClr val="accent1"/>
+          </a:lnRef>
+          <a:fillRef idx="3">
+            <a:schemeClr val="accent1"/>
+          </a:fillRef>
+          <a:effectRef idx="2">
+            <a:schemeClr val="accent1"/>
+          </a:effectRef>
+          <a:fontRef idx="minor">
+            <a:schemeClr val="lt1"/>
+          </a:fontRef>
+        </p:style>
+        <p:txBody>
+          <a:bodyPr rtlCol="0" anchor="ctr"/>
+          <a:lstStyle/>
+          <a:p>
+            <a:pPr algn="ctr"/>
+          </a:p>
+        </p:txBody>
+      </p:sp>
+      <p:sp>
+        <p:nvSpPr>
+          <p:cNvPr id="38" name="TextBox 37"/>
+          <p:cNvSpPr txBox="1"/>
+          <p:nvPr/>
+        </p:nvSpPr>
+        <p:spPr>
+          <a:xfrm>
+            <a:off x="8394192" y="4110228"/>
+            <a:ext cx="384048" cy="384048"/>
+          </a:xfrm>
+          <a:prstGeom prst="rect">
+            <a:avLst/>
+          </a:prstGeom>
+          <a:noFill/>
+        </p:spPr>
+        <p:txBody>
+          <a:bodyPr wrap="square" lIns="36000" rIns="36000" tIns="18000" bIns="18000" anchor="ctr">
+            <a:spAutoFit/>
+          </a:bodyPr>
+          <a:lstStyle/>
+          <a:p>
+            <a:pPr algn="ctr"/>
+            <a:r>
+              <a:rPr sz="1500" b="1" i="0" u="none">
+                <a:solidFill>
+                  <a:srgbClr val="008793"/>
+                </a:solidFill>
+                <a:latin typeface="Calibri"/>
+              </a:rPr>
+              <a:t>B</a:t>
+            </a:r>
+          </a:p>
+        </p:txBody>
+      </p:sp>
+      <p:sp>
+        <p:nvSpPr>
+          <p:cNvPr id="39" name="TextBox 38"/>
+          <p:cNvSpPr txBox="1"/>
+          <p:nvPr/>
+        </p:nvSpPr>
+        <p:spPr>
+          <a:xfrm>
+            <a:off x="8887968" y="4073652"/>
+            <a:ext cx="2834640" cy="292608"/>
+          </a:xfrm>
+          <a:prstGeom prst="rect">
+            <a:avLst/>
+          </a:prstGeom>
+          <a:noFill/>
+        </p:spPr>
+        <p:txBody>
+          <a:bodyPr wrap="square" lIns="36000" rIns="36000" tIns="18000" bIns="18000" anchor="t">
+            <a:spAutoFit/>
+          </a:bodyPr>
+          <a:lstStyle/>
+          <a:p>
+            <a:pPr algn="l"/>
+            <a:r>
+              <a:rPr sz="1300" b="1" i="0" u="none">
+                <a:solidFill>
+                  <a:srgbClr val="333333"/>
+                </a:solidFill>
+                <a:latin typeface="Calibri"/>
+              </a:rPr>
+              <a:t>Loesung Steuerung</a:t>
+            </a:r>
+          </a:p>
+        </p:txBody>
+      </p:sp>
+      <p:sp>
+        <p:nvSpPr>
+          <p:cNvPr id="40" name="TextBox 39"/>
+          <p:cNvSpPr txBox="1"/>
+          <p:nvPr/>
+        </p:nvSpPr>
+        <p:spPr>
+          <a:xfrm>
+            <a:off x="8887968" y="4366260"/>
+            <a:ext cx="2788920" cy="1376172"/>
+          </a:xfrm>
+          <a:prstGeom prst="rect">
+            <a:avLst/>
+          </a:prstGeom>
+          <a:noFill/>
+        </p:spPr>
+        <p:txBody>
+          <a:bodyPr wrap="square" lIns="36000" rIns="36000" tIns="18000" bIns="18000" anchor="t">
+            <a:spAutoFit/>
+          </a:bodyPr>
+          <a:lstStyle/>
+          <a:p>
+            <a:pPr algn="l"/>
+            <a:r>
+              <a:rPr sz="1100" b="0" i="0" u="none">
+                <a:solidFill>
+                  <a:srgbClr val="333333"/>
+                </a:solidFill>
+                <a:latin typeface="Calibri"/>
+              </a:rPr>
+              <a:t>Einheitliche Felder (Makler + Kunde + VNR) fuehren Mails automatisch zu Vorgaengen zusammen → Arbeitsvorrats-Steuerung nach Prio-Fall und Prio-Makler (Top-5 = 57 % des Volumens).</a:t>
+            </a:r>
+          </a:p>
+        </p:txBody>
+      </p:sp>
+      <p:sp>
+        <p:nvSpPr>
+          <p:cNvPr id="41" name="TextBox 40"/>
+          <p:cNvSpPr txBox="1"/>
+          <p:nvPr/>
+        </p:nvSpPr>
+        <p:spPr>
+          <a:xfrm>
+            <a:off x="411480" y="5760720"/>
+            <a:ext cx="11338560" cy="182880"/>
+          </a:xfrm>
+          <a:prstGeom prst="rect">
+            <a:avLst/>
+          </a:prstGeom>
+          <a:noFill/>
+        </p:spPr>
+        <p:txBody>
+          <a:bodyPr wrap="square" lIns="36000" rIns="36000" tIns="18000" bIns="18000" anchor="t">
+            <a:spAutoFit/>
+          </a:bodyPr>
+          <a:lstStyle/>
+          <a:p>
+            <a:pPr algn="l"/>
+            <a:r>
+              <a:rPr sz="800" b="0" i="1" u="none">
+                <a:solidFill>
+                  <a:srgbClr val="666666"/>
+                </a:solidFill>
+                <a:latin typeface="Calibri"/>
+              </a:rPr>
+              <a:t>Datenbasis: 5.034 Mails  |  Mo 13.04. – Mo 20.04.2026 (eine Kalenderwoche)  |  Eingangs-Postfaecher: 'Service Team Maklerauftraege' (94 %), 'Bestandsuebertragungen' (5 %), 12 weitere &lt;1 %  |  Analyse-Stand: 27.05.2026 (KI-Auswertung mit Claude Opus 4.7, 99 von 5.034 Mails mit Analyse-Fehler/Timeout)</a:t>
+            </a:r>
+          </a:p>
+        </p:txBody>
+      </p:sp>
+      <p:sp>
+        <p:nvSpPr>
+          <p:cNvPr id="42" name="Rectangle 41"/>
+          <p:cNvSpPr/>
+          <p:nvPr/>
+        </p:nvSpPr>
+        <p:spPr>
+          <a:xfrm>
+            <a:off x="411480" y="5989320"/>
+            <a:ext cx="11338560" cy="384048"/>
+          </a:xfrm>
+          <a:prstGeom prst="rect">
+            <a:avLst/>
+          </a:prstGeom>
+          <a:solidFill>
+            <a:srgbClr val="E30613"/>
+          </a:solidFill>
+          <a:ln>
+            <a:noFill/>
+          </a:ln>
+          <a:effectLst/>
+        </p:spPr>
+        <p:style>
+          <a:lnRef idx="1">
+            <a:schemeClr val="accent1"/>
+          </a:lnRef>
+          <a:fillRef idx="3">
+            <a:schemeClr val="accent1"/>
+          </a:fillRef>
+          <a:effectRef idx="2">
+            <a:schemeClr val="accent1"/>
+          </a:effectRef>
+          <a:fontRef idx="minor">
+            <a:schemeClr val="lt1"/>
+          </a:fontRef>
+        </p:style>
+        <p:txBody>
+          <a:bodyPr rtlCol="0" anchor="ctr"/>
+          <a:lstStyle/>
+          <a:p>
+            <a:pPr algn="ctr"/>
+          </a:p>
+        </p:txBody>
+      </p:sp>
+      <p:sp>
+        <p:nvSpPr>
+          <p:cNvPr id="43" name="TextBox 42"/>
+          <p:cNvSpPr txBox="1"/>
+          <p:nvPr/>
+        </p:nvSpPr>
+        <p:spPr>
+          <a:xfrm>
+            <a:off x="594360" y="5989320"/>
+            <a:ext cx="10972800" cy="384048"/>
+          </a:xfrm>
+          <a:prstGeom prst="rect">
+            <a:avLst/>
+          </a:prstGeom>
+          <a:noFill/>
+        </p:spPr>
+        <p:txBody>
+          <a:bodyPr wrap="square" lIns="36000" rIns="36000" tIns="18000" bIns="18000" anchor="ctr">
+            <a:spAutoFit/>
+          </a:bodyPr>
+          <a:lstStyle/>
+          <a:p>
+            <a:pPr algn="l"/>
+            <a:r>
+              <a:rPr sz="1200" b="1" i="0" u="none">
+                <a:solidFill>
+                  <a:srgbClr val="FFFFFF"/>
+                </a:solidFill>
+                <a:latin typeface="Calibri"/>
+              </a:rPr>
+              <a:t>TAKE-AWAY:  Das standardisierte KI-Beiblatt loest Routing und Steuerung sofort — und ist zugleich die Pflicht-Basis fuer die automatisierte BÜ-Pruefung: der Bot kann nur pruefen, was strukturiert vorliegt.</a:t>
             </a:r>
           </a:p>
         </p:txBody>

</xml_diff>

<commit_message>
PPTX Folie 12: echte Umlaute + Makler-Tabelle umgebaut (Gesamt/Sonstige)
- Durchgaengig echte Umlaute (Vorgänge, ermöglichen, zusammenhängende,
  Möglichkeit, gebündelt, Postfächer, Bestandsübertragungen ...)
- Makler-Tabelle klarer: Spalten Maklerpool | Mails/Woche | Vorgänge |
  Ø Mails/Vorgang  (statt schwer lesbarem 'Mails in Cluster')
  + Erklaerzeile 'Vorgang = ein Makler+Kunde-Fall; Ø>1 = Cluster'
- Neue Zeilen: Summe Top-5 | Sonstige Makler (Long-Tail) | Gesamt
    Gesamt 5.034 Mails / 3.345 Vorgänge / Ø 1,50
    Sonstige 2.144 / 1.678 / Ø 1,28
- Cluster-Gesamt-Box weiter darunter (2.370 / 681)

https://claude.ai/code/session_01UknXtYp2XECsQDonCZuxSt
</commit_message>
<xml_diff>
--- a/ERGO-Mengengeruest-2Slides-Berichtslook.pptx
+++ b/ERGO-Mengengeruest-2Slides-Berichtslook.pptx
@@ -7450,7 +7450,7 @@
                 </a:solidFill>
                 <a:latin typeface="Calibri"/>
               </a:rPr>
-              <a:t>Datenbasis: 5.034 Mails  |  Mo 13.04. – Mo 20.04.2026 (eine Kalenderwoche)  |  Eingangs-Postfaecher: 'Service Team Maklerauftraege' (94 %), 'Bestandsuebertragungen' (5 %), 12 weitere &lt;1 %  |  Analyse-Stand: 27.05.2026 (KI-Auswertung mit Claude Opus 4.7, 99 von 5.034 Mails mit Analyse-Fehler/Timeout)</a:t>
+              <a:t>Datenbasis: 5.034 Mails  |  Mo 13.04. – Mo 20.04.2026 (eine Kalenderwoche)  |  Eingangs-Postfächer: 'Service Team Makleraufträge' (94 %), 'Bestandsübertragungen' (5 %), 12 weitere &lt;1 %  |  Analyse-Stand: 27.05.2026 (KI-Auswertung mit Claude Opus 4.7, 99 von 5.034 Mails mit Analyse-Fehler/Timeout)</a:t>
             </a:r>
           </a:p>
         </p:txBody>
@@ -7907,7 +7907,7 @@
                 </a:solidFill>
                 <a:latin typeface="Calibri"/>
               </a:rPr>
-              <a:t>Wenige Makler und viele zusammenhaengende Vorgaenge — heute im Postkorb nicht auffindbar</a:t>
+              <a:t>Wenige Makler, viele zusammenhängende Vorgänge — heute im Postkorb nicht auffindbar</a:t>
             </a:r>
           </a:p>
         </p:txBody>
@@ -7942,7 +7942,7 @@
                 </a:solidFill>
                 <a:latin typeface="Calibri"/>
               </a:rPr>
-              <a:t>Strukturierung + Excel ermoeglichen gezieltes Abarbeiten (Prio-Makler, Cluster) statt blindem Postkorb</a:t>
+              <a:t>Strukturierung + Excel ermöglichen gezieltes Abarbeiten (Prio-Makler, Cluster) statt blindem Postkorb</a:t>
             </a:r>
           </a:p>
         </p:txBody>
@@ -7977,7 +7977,7 @@
                 </a:solidFill>
                 <a:latin typeface="Calibri"/>
               </a:rPr>
-              <a:t>MENGENGERÜSTE: MAKLER &amp; CLUSTER</a:t>
+              <a:t>MENGENGERÜST: MAKLER &amp; CLUSTER</a:t>
             </a:r>
           </a:p>
         </p:txBody>
@@ -8155,13 +8155,13 @@
           <a:p>
             <a:pPr algn="l"/>
             <a:r>
-              <a:rPr sz="1200" b="1" i="0" u="none">
-                <a:solidFill>
-                  <a:srgbClr val="006B77"/>
-                </a:solidFill>
-                <a:latin typeface="Calibri"/>
-              </a:rPr>
-              <a:t>Top-5-Makler = 2.890 Mails (57 %) — hohe Konzentration</a:t>
+              <a:rPr sz="1100" b="0" i="1" u="none">
+                <a:solidFill>
+                  <a:srgbClr val="666666"/>
+                </a:solidFill>
+                <a:latin typeface="Calibri"/>
+              </a:rPr>
+              <a:t>Vorgang = ein Makler-+-Kunde-Fall.  Ø Mails/Vorgang &gt; 1 → mehrere Mails zum selben Fall (Cluster).</a:t>
             </a:r>
           </a:p>
         </p:txBody>
@@ -8175,7 +8175,7 @@
         <p:spPr>
           <a:xfrm>
             <a:off x="411480" y="2606040"/>
-            <a:ext cx="7635240" cy="310896"/>
+            <a:ext cx="7635240" cy="329184"/>
           </a:xfrm>
           <a:prstGeom prst="rect">
             <a:avLst/>
@@ -8219,7 +8219,7 @@
         <p:spPr>
           <a:xfrm>
             <a:off x="411480" y="2606040"/>
-            <a:ext cx="2788920" cy="310896"/>
+            <a:ext cx="3063240" cy="329184"/>
           </a:xfrm>
           <a:prstGeom prst="rect">
             <a:avLst/>
@@ -8253,8 +8253,8 @@
         </p:nvSpPr>
         <p:spPr>
           <a:xfrm>
-            <a:off x="3200400" y="2606040"/>
-            <a:ext cx="1463040" cy="310896"/>
+            <a:off x="3474720" y="2606040"/>
+            <a:ext cx="1508760" cy="329184"/>
           </a:xfrm>
           <a:prstGeom prst="rect">
             <a:avLst/>
@@ -8275,7 +8275,7 @@
                 </a:solidFill>
                 <a:latin typeface="Calibri"/>
               </a:rPr>
-              <a:t>Mails / Wo</a:t>
+              <a:t>Mails / Woche</a:t>
             </a:r>
           </a:p>
         </p:txBody>
@@ -8288,8 +8288,8 @@
         </p:nvSpPr>
         <p:spPr>
           <a:xfrm>
-            <a:off x="4663440" y="2606040"/>
-            <a:ext cx="1554480" cy="310896"/>
+            <a:off x="4983480" y="2606040"/>
+            <a:ext cx="1508760" cy="329184"/>
           </a:xfrm>
           <a:prstGeom prst="rect">
             <a:avLst/>
@@ -8310,7 +8310,7 @@
                 </a:solidFill>
                 <a:latin typeface="Calibri"/>
               </a:rPr>
-              <a:t>Vorgaenge</a:t>
+              <a:t>Vorgänge</a:t>
             </a:r>
           </a:p>
         </p:txBody>
@@ -8323,8 +8323,8 @@
         </p:nvSpPr>
         <p:spPr>
           <a:xfrm>
-            <a:off x="6217920" y="2606040"/>
-            <a:ext cx="1828800" cy="310896"/>
+            <a:off x="6492240" y="2606040"/>
+            <a:ext cx="1554480" cy="329184"/>
           </a:xfrm>
           <a:prstGeom prst="rect">
             <a:avLst/>
@@ -8345,7 +8345,7 @@
                 </a:solidFill>
                 <a:latin typeface="Calibri"/>
               </a:rPr>
-              <a:t>Mails in Cluster</a:t>
+              <a:t>Ø Mails / Vorgang</a:t>
             </a:r>
           </a:p>
         </p:txBody>
@@ -8358,8 +8358,8 @@
         </p:nvSpPr>
         <p:spPr>
           <a:xfrm>
-            <a:off x="411480" y="2916936"/>
-            <a:ext cx="7635240" cy="274320"/>
+            <a:off x="411480" y="2935224"/>
+            <a:ext cx="7635240" cy="278892"/>
           </a:xfrm>
           <a:prstGeom prst="rect">
             <a:avLst/>
@@ -8402,8 +8402,8 @@
         </p:nvSpPr>
         <p:spPr>
           <a:xfrm>
-            <a:off x="521208" y="2916936"/>
-            <a:ext cx="2679192" cy="274320"/>
+            <a:off x="521208" y="2935224"/>
+            <a:ext cx="2953512" cy="278892"/>
           </a:xfrm>
           <a:prstGeom prst="rect">
             <a:avLst/>
@@ -8437,8 +8437,8 @@
         </p:nvSpPr>
         <p:spPr>
           <a:xfrm>
-            <a:off x="3200400" y="2916936"/>
-            <a:ext cx="1463040" cy="274320"/>
+            <a:off x="3474720" y="2935224"/>
+            <a:ext cx="1508760" cy="278892"/>
           </a:xfrm>
           <a:prstGeom prst="rect">
             <a:avLst/>
@@ -8472,8 +8472,8 @@
         </p:nvSpPr>
         <p:spPr>
           <a:xfrm>
-            <a:off x="4663440" y="2916936"/>
-            <a:ext cx="1554480" cy="274320"/>
+            <a:off x="4983480" y="2935224"/>
+            <a:ext cx="1508760" cy="278892"/>
           </a:xfrm>
           <a:prstGeom prst="rect">
             <a:avLst/>
@@ -8507,8 +8507,8 @@
         </p:nvSpPr>
         <p:spPr>
           <a:xfrm>
-            <a:off x="6217920" y="2916936"/>
-            <a:ext cx="1828800" cy="274320"/>
+            <a:off x="6492240" y="2935224"/>
+            <a:ext cx="1554480" cy="278892"/>
           </a:xfrm>
           <a:prstGeom prst="rect">
             <a:avLst/>
@@ -8529,7 +8529,7 @@
                 </a:solidFill>
                 <a:latin typeface="Calibri"/>
               </a:rPr>
-              <a:t>1.040</a:t>
+              <a:t>1,75</a:t>
             </a:r>
           </a:p>
         </p:txBody>
@@ -8542,8 +8542,8 @@
         </p:nvSpPr>
         <p:spPr>
           <a:xfrm>
-            <a:off x="411480" y="3191256"/>
-            <a:ext cx="7635240" cy="274320"/>
+            <a:off x="411480" y="3214116"/>
+            <a:ext cx="7635240" cy="278892"/>
           </a:xfrm>
           <a:prstGeom prst="rect">
             <a:avLst/>
@@ -8586,8 +8586,8 @@
         </p:nvSpPr>
         <p:spPr>
           <a:xfrm>
-            <a:off x="521208" y="3191256"/>
-            <a:ext cx="2679192" cy="274320"/>
+            <a:off x="521208" y="3214116"/>
+            <a:ext cx="2953512" cy="278892"/>
           </a:xfrm>
           <a:prstGeom prst="rect">
             <a:avLst/>
@@ -8621,8 +8621,8 @@
         </p:nvSpPr>
         <p:spPr>
           <a:xfrm>
-            <a:off x="3200400" y="3191256"/>
-            <a:ext cx="1463040" cy="274320"/>
+            <a:off x="3474720" y="3214116"/>
+            <a:ext cx="1508760" cy="278892"/>
           </a:xfrm>
           <a:prstGeom prst="rect">
             <a:avLst/>
@@ -8656,8 +8656,8 @@
         </p:nvSpPr>
         <p:spPr>
           <a:xfrm>
-            <a:off x="4663440" y="3191256"/>
-            <a:ext cx="1554480" cy="274320"/>
+            <a:off x="4983480" y="3214116"/>
+            <a:ext cx="1508760" cy="278892"/>
           </a:xfrm>
           <a:prstGeom prst="rect">
             <a:avLst/>
@@ -8691,8 +8691,8 @@
         </p:nvSpPr>
         <p:spPr>
           <a:xfrm>
-            <a:off x="6217920" y="3191256"/>
-            <a:ext cx="1828800" cy="274320"/>
+            <a:off x="6492240" y="3214116"/>
+            <a:ext cx="1554480" cy="278892"/>
           </a:xfrm>
           <a:prstGeom prst="rect">
             <a:avLst/>
@@ -8713,7 +8713,7 @@
                 </a:solidFill>
                 <a:latin typeface="Calibri"/>
               </a:rPr>
-              <a:t>420</a:t>
+              <a:t>2,08</a:t>
             </a:r>
           </a:p>
         </p:txBody>
@@ -8726,8 +8726,8 @@
         </p:nvSpPr>
         <p:spPr>
           <a:xfrm>
-            <a:off x="411480" y="3465576"/>
-            <a:ext cx="7635240" cy="274320"/>
+            <a:off x="411480" y="3493008"/>
+            <a:ext cx="7635240" cy="278892"/>
           </a:xfrm>
           <a:prstGeom prst="rect">
             <a:avLst/>
@@ -8770,8 +8770,8 @@
         </p:nvSpPr>
         <p:spPr>
           <a:xfrm>
-            <a:off x="521208" y="3465576"/>
-            <a:ext cx="2679192" cy="274320"/>
+            <a:off x="521208" y="3493008"/>
+            <a:ext cx="2953512" cy="278892"/>
           </a:xfrm>
           <a:prstGeom prst="rect">
             <a:avLst/>
@@ -8805,8 +8805,8 @@
         </p:nvSpPr>
         <p:spPr>
           <a:xfrm>
-            <a:off x="3200400" y="3465576"/>
-            <a:ext cx="1463040" cy="274320"/>
+            <a:off x="3474720" y="3493008"/>
+            <a:ext cx="1508760" cy="278892"/>
           </a:xfrm>
           <a:prstGeom prst="rect">
             <a:avLst/>
@@ -8840,8 +8840,8 @@
         </p:nvSpPr>
         <p:spPr>
           <a:xfrm>
-            <a:off x="4663440" y="3465576"/>
-            <a:ext cx="1554480" cy="274320"/>
+            <a:off x="4983480" y="3493008"/>
+            <a:ext cx="1508760" cy="278892"/>
           </a:xfrm>
           <a:prstGeom prst="rect">
             <a:avLst/>
@@ -8875,8 +8875,8 @@
         </p:nvSpPr>
         <p:spPr>
           <a:xfrm>
-            <a:off x="6217920" y="3465576"/>
-            <a:ext cx="1828800" cy="274320"/>
+            <a:off x="6492240" y="3493008"/>
+            <a:ext cx="1554480" cy="278892"/>
           </a:xfrm>
           <a:prstGeom prst="rect">
             <a:avLst/>
@@ -8897,7 +8897,7 @@
                 </a:solidFill>
                 <a:latin typeface="Calibri"/>
               </a:rPr>
-              <a:t>117</a:t>
+              <a:t>1,42</a:t>
             </a:r>
           </a:p>
         </p:txBody>
@@ -8910,8 +8910,8 @@
         </p:nvSpPr>
         <p:spPr>
           <a:xfrm>
-            <a:off x="411480" y="3739896"/>
-            <a:ext cx="7635240" cy="274320"/>
+            <a:off x="411480" y="3771900"/>
+            <a:ext cx="7635240" cy="278892"/>
           </a:xfrm>
           <a:prstGeom prst="rect">
             <a:avLst/>
@@ -8954,8 +8954,8 @@
         </p:nvSpPr>
         <p:spPr>
           <a:xfrm>
-            <a:off x="521208" y="3739896"/>
-            <a:ext cx="2679192" cy="274320"/>
+            <a:off x="521208" y="3771900"/>
+            <a:ext cx="2953512" cy="278892"/>
           </a:xfrm>
           <a:prstGeom prst="rect">
             <a:avLst/>
@@ -8989,8 +8989,8 @@
         </p:nvSpPr>
         <p:spPr>
           <a:xfrm>
-            <a:off x="3200400" y="3739896"/>
-            <a:ext cx="1463040" cy="274320"/>
+            <a:off x="3474720" y="3771900"/>
+            <a:ext cx="1508760" cy="278892"/>
           </a:xfrm>
           <a:prstGeom prst="rect">
             <a:avLst/>
@@ -9024,8 +9024,8 @@
         </p:nvSpPr>
         <p:spPr>
           <a:xfrm>
-            <a:off x="4663440" y="3739896"/>
-            <a:ext cx="1554480" cy="274320"/>
+            <a:off x="4983480" y="3771900"/>
+            <a:ext cx="1508760" cy="278892"/>
           </a:xfrm>
           <a:prstGeom prst="rect">
             <a:avLst/>
@@ -9059,8 +9059,8 @@
         </p:nvSpPr>
         <p:spPr>
           <a:xfrm>
-            <a:off x="6217920" y="3739896"/>
-            <a:ext cx="1828800" cy="274320"/>
+            <a:off x="6492240" y="3771900"/>
+            <a:ext cx="1554480" cy="278892"/>
           </a:xfrm>
           <a:prstGeom prst="rect">
             <a:avLst/>
@@ -9081,7 +9081,7 @@
                 </a:solidFill>
                 <a:latin typeface="Calibri"/>
               </a:rPr>
-              <a:t>55</a:t>
+              <a:t>1,27</a:t>
             </a:r>
           </a:p>
         </p:txBody>
@@ -9094,8 +9094,8 @@
         </p:nvSpPr>
         <p:spPr>
           <a:xfrm>
-            <a:off x="411480" y="4014216"/>
-            <a:ext cx="7635240" cy="274320"/>
+            <a:off x="411480" y="4050792"/>
+            <a:ext cx="7635240" cy="278892"/>
           </a:xfrm>
           <a:prstGeom prst="rect">
             <a:avLst/>
@@ -9138,8 +9138,8 @@
         </p:nvSpPr>
         <p:spPr>
           <a:xfrm>
-            <a:off x="521208" y="4014216"/>
-            <a:ext cx="2679192" cy="274320"/>
+            <a:off x="521208" y="4050792"/>
+            <a:ext cx="2953512" cy="278892"/>
           </a:xfrm>
           <a:prstGeom prst="rect">
             <a:avLst/>
@@ -9173,8 +9173,8 @@
         </p:nvSpPr>
         <p:spPr>
           <a:xfrm>
-            <a:off x="3200400" y="4014216"/>
-            <a:ext cx="1463040" cy="274320"/>
+            <a:off x="3474720" y="4050792"/>
+            <a:ext cx="1508760" cy="278892"/>
           </a:xfrm>
           <a:prstGeom prst="rect">
             <a:avLst/>
@@ -9208,8 +9208,8 @@
         </p:nvSpPr>
         <p:spPr>
           <a:xfrm>
-            <a:off x="4663440" y="4014216"/>
-            <a:ext cx="1554480" cy="274320"/>
+            <a:off x="4983480" y="4050792"/>
+            <a:ext cx="1508760" cy="278892"/>
           </a:xfrm>
           <a:prstGeom prst="rect">
             <a:avLst/>
@@ -9243,8 +9243,8 @@
         </p:nvSpPr>
         <p:spPr>
           <a:xfrm>
-            <a:off x="6217920" y="4014216"/>
-            <a:ext cx="1828800" cy="274320"/>
+            <a:off x="6492240" y="4050792"/>
+            <a:ext cx="1554480" cy="278892"/>
           </a:xfrm>
           <a:prstGeom prst="rect">
             <a:avLst/>
@@ -9265,7 +9265,7 @@
                 </a:solidFill>
                 <a:latin typeface="Calibri"/>
               </a:rPr>
-              <a:t>53</a:t>
+              <a:t>1,51</a:t>
             </a:r>
           </a:p>
         </p:txBody>
@@ -9278,8 +9278,376 @@
         </p:nvSpPr>
         <p:spPr>
           <a:xfrm>
-            <a:off x="411480" y="4288536"/>
-            <a:ext cx="7635240" cy="274320"/>
+            <a:off x="411480" y="4329684"/>
+            <a:ext cx="7635240" cy="278892"/>
+          </a:xfrm>
+          <a:prstGeom prst="rect">
+            <a:avLst/>
+          </a:prstGeom>
+          <a:solidFill>
+            <a:srgbClr val="CFE6E9"/>
+          </a:solidFill>
+          <a:ln>
+            <a:noFill/>
+          </a:ln>
+          <a:effectLst/>
+        </p:spPr>
+        <p:style>
+          <a:lnRef idx="1">
+            <a:schemeClr val="accent1"/>
+          </a:lnRef>
+          <a:fillRef idx="3">
+            <a:schemeClr val="accent1"/>
+          </a:fillRef>
+          <a:effectRef idx="2">
+            <a:schemeClr val="accent1"/>
+          </a:effectRef>
+          <a:fontRef idx="minor">
+            <a:schemeClr val="lt1"/>
+          </a:fontRef>
+        </p:style>
+        <p:txBody>
+          <a:bodyPr rtlCol="0" anchor="ctr"/>
+          <a:lstStyle/>
+          <a:p>
+            <a:pPr algn="ctr"/>
+          </a:p>
+        </p:txBody>
+      </p:sp>
+      <p:sp>
+        <p:nvSpPr>
+          <p:cNvPr id="49" name="TextBox 48"/>
+          <p:cNvSpPr txBox="1"/>
+          <p:nvPr/>
+        </p:nvSpPr>
+        <p:spPr>
+          <a:xfrm>
+            <a:off x="521208" y="4329684"/>
+            <a:ext cx="2953512" cy="278892"/>
+          </a:xfrm>
+          <a:prstGeom prst="rect">
+            <a:avLst/>
+          </a:prstGeom>
+          <a:noFill/>
+        </p:spPr>
+        <p:txBody>
+          <a:bodyPr wrap="square" lIns="36000" rIns="36000" tIns="18000" bIns="18000" anchor="ctr">
+            <a:spAutoFit/>
+          </a:bodyPr>
+          <a:lstStyle/>
+          <a:p>
+            <a:pPr algn="l"/>
+            <a:r>
+              <a:rPr sz="1100" b="1" i="0" u="none">
+                <a:solidFill>
+                  <a:srgbClr val="333333"/>
+                </a:solidFill>
+                <a:latin typeface="Calibri"/>
+              </a:rPr>
+              <a:t>Summe Top-5-Makler  (57 % der Mails)</a:t>
+            </a:r>
+          </a:p>
+        </p:txBody>
+      </p:sp>
+      <p:sp>
+        <p:nvSpPr>
+          <p:cNvPr id="50" name="TextBox 49"/>
+          <p:cNvSpPr txBox="1"/>
+          <p:nvPr/>
+        </p:nvSpPr>
+        <p:spPr>
+          <a:xfrm>
+            <a:off x="3474720" y="4329684"/>
+            <a:ext cx="1508760" cy="278892"/>
+          </a:xfrm>
+          <a:prstGeom prst="rect">
+            <a:avLst/>
+          </a:prstGeom>
+          <a:noFill/>
+        </p:spPr>
+        <p:txBody>
+          <a:bodyPr wrap="square" lIns="36000" rIns="36000" tIns="18000" bIns="18000" anchor="ctr">
+            <a:spAutoFit/>
+          </a:bodyPr>
+          <a:lstStyle/>
+          <a:p>
+            <a:pPr algn="ctr"/>
+            <a:r>
+              <a:rPr sz="1100" b="1" i="0" u="none">
+                <a:solidFill>
+                  <a:srgbClr val="333333"/>
+                </a:solidFill>
+                <a:latin typeface="Calibri"/>
+              </a:rPr>
+              <a:t>2.890</a:t>
+            </a:r>
+          </a:p>
+        </p:txBody>
+      </p:sp>
+      <p:sp>
+        <p:nvSpPr>
+          <p:cNvPr id="51" name="TextBox 50"/>
+          <p:cNvSpPr txBox="1"/>
+          <p:nvPr/>
+        </p:nvSpPr>
+        <p:spPr>
+          <a:xfrm>
+            <a:off x="4983480" y="4329684"/>
+            <a:ext cx="1508760" cy="278892"/>
+          </a:xfrm>
+          <a:prstGeom prst="rect">
+            <a:avLst/>
+          </a:prstGeom>
+          <a:noFill/>
+        </p:spPr>
+        <p:txBody>
+          <a:bodyPr wrap="square" lIns="36000" rIns="36000" tIns="18000" bIns="18000" anchor="ctr">
+            <a:spAutoFit/>
+          </a:bodyPr>
+          <a:lstStyle/>
+          <a:p>
+            <a:pPr algn="ctr"/>
+            <a:r>
+              <a:rPr sz="1100" b="1" i="0" u="none">
+                <a:solidFill>
+                  <a:srgbClr val="333333"/>
+                </a:solidFill>
+                <a:latin typeface="Calibri"/>
+              </a:rPr>
+              <a:t>1.676</a:t>
+            </a:r>
+          </a:p>
+        </p:txBody>
+      </p:sp>
+      <p:sp>
+        <p:nvSpPr>
+          <p:cNvPr id="52" name="TextBox 51"/>
+          <p:cNvSpPr txBox="1"/>
+          <p:nvPr/>
+        </p:nvSpPr>
+        <p:spPr>
+          <a:xfrm>
+            <a:off x="6492240" y="4329684"/>
+            <a:ext cx="1554480" cy="278892"/>
+          </a:xfrm>
+          <a:prstGeom prst="rect">
+            <a:avLst/>
+          </a:prstGeom>
+          <a:noFill/>
+        </p:spPr>
+        <p:txBody>
+          <a:bodyPr wrap="square" lIns="36000" rIns="36000" tIns="18000" bIns="18000" anchor="ctr">
+            <a:spAutoFit/>
+          </a:bodyPr>
+          <a:lstStyle/>
+          <a:p>
+            <a:pPr algn="ctr"/>
+            <a:r>
+              <a:rPr sz="1100" b="1" i="0" u="none">
+                <a:solidFill>
+                  <a:srgbClr val="333333"/>
+                </a:solidFill>
+                <a:latin typeface="Calibri"/>
+              </a:rPr>
+              <a:t>1,72</a:t>
+            </a:r>
+          </a:p>
+        </p:txBody>
+      </p:sp>
+      <p:sp>
+        <p:nvSpPr>
+          <p:cNvPr id="53" name="Rectangle 52"/>
+          <p:cNvSpPr/>
+          <p:nvPr/>
+        </p:nvSpPr>
+        <p:spPr>
+          <a:xfrm>
+            <a:off x="411480" y="4608576"/>
+            <a:ext cx="7635240" cy="278892"/>
+          </a:xfrm>
+          <a:prstGeom prst="rect">
+            <a:avLst/>
+          </a:prstGeom>
+          <a:solidFill>
+            <a:srgbClr val="FFFFFF"/>
+          </a:solidFill>
+          <a:ln>
+            <a:noFill/>
+          </a:ln>
+          <a:effectLst/>
+        </p:spPr>
+        <p:style>
+          <a:lnRef idx="1">
+            <a:schemeClr val="accent1"/>
+          </a:lnRef>
+          <a:fillRef idx="3">
+            <a:schemeClr val="accent1"/>
+          </a:fillRef>
+          <a:effectRef idx="2">
+            <a:schemeClr val="accent1"/>
+          </a:effectRef>
+          <a:fontRef idx="minor">
+            <a:schemeClr val="lt1"/>
+          </a:fontRef>
+        </p:style>
+        <p:txBody>
+          <a:bodyPr rtlCol="0" anchor="ctr"/>
+          <a:lstStyle/>
+          <a:p>
+            <a:pPr algn="ctr"/>
+          </a:p>
+        </p:txBody>
+      </p:sp>
+      <p:sp>
+        <p:nvSpPr>
+          <p:cNvPr id="54" name="TextBox 53"/>
+          <p:cNvSpPr txBox="1"/>
+          <p:nvPr/>
+        </p:nvSpPr>
+        <p:spPr>
+          <a:xfrm>
+            <a:off x="521208" y="4608576"/>
+            <a:ext cx="2953512" cy="278892"/>
+          </a:xfrm>
+          <a:prstGeom prst="rect">
+            <a:avLst/>
+          </a:prstGeom>
+          <a:noFill/>
+        </p:spPr>
+        <p:txBody>
+          <a:bodyPr wrap="square" lIns="36000" rIns="36000" tIns="18000" bIns="18000" anchor="ctr">
+            <a:spAutoFit/>
+          </a:bodyPr>
+          <a:lstStyle/>
+          <a:p>
+            <a:pPr algn="l"/>
+            <a:r>
+              <a:rPr sz="1100" b="1" i="0" u="none">
+                <a:solidFill>
+                  <a:srgbClr val="333333"/>
+                </a:solidFill>
+                <a:latin typeface="Calibri"/>
+              </a:rPr>
+              <a:t>Sonstige Makler (Long-Tail)</a:t>
+            </a:r>
+          </a:p>
+        </p:txBody>
+      </p:sp>
+      <p:sp>
+        <p:nvSpPr>
+          <p:cNvPr id="55" name="TextBox 54"/>
+          <p:cNvSpPr txBox="1"/>
+          <p:nvPr/>
+        </p:nvSpPr>
+        <p:spPr>
+          <a:xfrm>
+            <a:off x="3474720" y="4608576"/>
+            <a:ext cx="1508760" cy="278892"/>
+          </a:xfrm>
+          <a:prstGeom prst="rect">
+            <a:avLst/>
+          </a:prstGeom>
+          <a:noFill/>
+        </p:spPr>
+        <p:txBody>
+          <a:bodyPr wrap="square" lIns="36000" rIns="36000" tIns="18000" bIns="18000" anchor="ctr">
+            <a:spAutoFit/>
+          </a:bodyPr>
+          <a:lstStyle/>
+          <a:p>
+            <a:pPr algn="ctr"/>
+            <a:r>
+              <a:rPr sz="1100" b="0" i="0" u="none">
+                <a:solidFill>
+                  <a:srgbClr val="333333"/>
+                </a:solidFill>
+                <a:latin typeface="Calibri"/>
+              </a:rPr>
+              <a:t>2.144</a:t>
+            </a:r>
+          </a:p>
+        </p:txBody>
+      </p:sp>
+      <p:sp>
+        <p:nvSpPr>
+          <p:cNvPr id="56" name="TextBox 55"/>
+          <p:cNvSpPr txBox="1"/>
+          <p:nvPr/>
+        </p:nvSpPr>
+        <p:spPr>
+          <a:xfrm>
+            <a:off x="4983480" y="4608576"/>
+            <a:ext cx="1508760" cy="278892"/>
+          </a:xfrm>
+          <a:prstGeom prst="rect">
+            <a:avLst/>
+          </a:prstGeom>
+          <a:noFill/>
+        </p:spPr>
+        <p:txBody>
+          <a:bodyPr wrap="square" lIns="36000" rIns="36000" tIns="18000" bIns="18000" anchor="ctr">
+            <a:spAutoFit/>
+          </a:bodyPr>
+          <a:lstStyle/>
+          <a:p>
+            <a:pPr algn="ctr"/>
+            <a:r>
+              <a:rPr sz="1100" b="0" i="0" u="none">
+                <a:solidFill>
+                  <a:srgbClr val="333333"/>
+                </a:solidFill>
+                <a:latin typeface="Calibri"/>
+              </a:rPr>
+              <a:t>1.678</a:t>
+            </a:r>
+          </a:p>
+        </p:txBody>
+      </p:sp>
+      <p:sp>
+        <p:nvSpPr>
+          <p:cNvPr id="57" name="TextBox 56"/>
+          <p:cNvSpPr txBox="1"/>
+          <p:nvPr/>
+        </p:nvSpPr>
+        <p:spPr>
+          <a:xfrm>
+            <a:off x="6492240" y="4608576"/>
+            <a:ext cx="1554480" cy="278892"/>
+          </a:xfrm>
+          <a:prstGeom prst="rect">
+            <a:avLst/>
+          </a:prstGeom>
+          <a:noFill/>
+        </p:spPr>
+        <p:txBody>
+          <a:bodyPr wrap="square" lIns="36000" rIns="36000" tIns="18000" bIns="18000" anchor="ctr">
+            <a:spAutoFit/>
+          </a:bodyPr>
+          <a:lstStyle/>
+          <a:p>
+            <a:pPr algn="ctr"/>
+            <a:r>
+              <a:rPr sz="1100" b="0" i="0" u="none">
+                <a:solidFill>
+                  <a:srgbClr val="333333"/>
+                </a:solidFill>
+                <a:latin typeface="Calibri"/>
+              </a:rPr>
+              <a:t>1,28</a:t>
+            </a:r>
+          </a:p>
+        </p:txBody>
+      </p:sp>
+      <p:sp>
+        <p:nvSpPr>
+          <p:cNvPr id="58" name="Rectangle 57"/>
+          <p:cNvSpPr/>
+          <p:nvPr/>
+        </p:nvSpPr>
+        <p:spPr>
+          <a:xfrm>
+            <a:off x="411480" y="4887468"/>
+            <a:ext cx="7635240" cy="278892"/>
           </a:xfrm>
           <a:prstGeom prst="rect">
             <a:avLst/>
@@ -9316,14 +9684,14 @@
       </p:sp>
       <p:sp>
         <p:nvSpPr>
-          <p:cNvPr id="49" name="TextBox 48"/>
-          <p:cNvSpPr txBox="1"/>
-          <p:nvPr/>
-        </p:nvSpPr>
-        <p:spPr>
-          <a:xfrm>
-            <a:off x="521208" y="4288536"/>
-            <a:ext cx="2679192" cy="274320"/>
+          <p:cNvPr id="59" name="TextBox 58"/>
+          <p:cNvSpPr txBox="1"/>
+          <p:nvPr/>
+        </p:nvSpPr>
+        <p:spPr>
+          <a:xfrm>
+            <a:off x="521208" y="4887468"/>
+            <a:ext cx="2953512" cy="278892"/>
           </a:xfrm>
           <a:prstGeom prst="rect">
             <a:avLst/>
@@ -9344,21 +9712,21 @@
                 </a:solidFill>
                 <a:latin typeface="Calibri"/>
               </a:rPr>
-              <a:t>Summe Top-5</a:t>
-            </a:r>
-          </a:p>
-        </p:txBody>
-      </p:sp>
-      <p:sp>
-        <p:nvSpPr>
-          <p:cNvPr id="50" name="TextBox 49"/>
-          <p:cNvSpPr txBox="1"/>
-          <p:nvPr/>
-        </p:nvSpPr>
-        <p:spPr>
-          <a:xfrm>
-            <a:off x="3200400" y="4288536"/>
-            <a:ext cx="1463040" cy="274320"/>
+              <a:t>Gesamt</a:t>
+            </a:r>
+          </a:p>
+        </p:txBody>
+      </p:sp>
+      <p:sp>
+        <p:nvSpPr>
+          <p:cNvPr id="60" name="TextBox 59"/>
+          <p:cNvSpPr txBox="1"/>
+          <p:nvPr/>
+        </p:nvSpPr>
+        <p:spPr>
+          <a:xfrm>
+            <a:off x="3474720" y="4887468"/>
+            <a:ext cx="1508760" cy="278892"/>
           </a:xfrm>
           <a:prstGeom prst="rect">
             <a:avLst/>
@@ -9379,21 +9747,21 @@
                 </a:solidFill>
                 <a:latin typeface="Calibri"/>
               </a:rPr>
-              <a:t>2.890</a:t>
-            </a:r>
-          </a:p>
-        </p:txBody>
-      </p:sp>
-      <p:sp>
-        <p:nvSpPr>
-          <p:cNvPr id="51" name="TextBox 50"/>
-          <p:cNvSpPr txBox="1"/>
-          <p:nvPr/>
-        </p:nvSpPr>
-        <p:spPr>
-          <a:xfrm>
-            <a:off x="4663440" y="4288536"/>
-            <a:ext cx="1554480" cy="274320"/>
+              <a:t>5.034</a:t>
+            </a:r>
+          </a:p>
+        </p:txBody>
+      </p:sp>
+      <p:sp>
+        <p:nvSpPr>
+          <p:cNvPr id="61" name="TextBox 60"/>
+          <p:cNvSpPr txBox="1"/>
+          <p:nvPr/>
+        </p:nvSpPr>
+        <p:spPr>
+          <a:xfrm>
+            <a:off x="4983480" y="4887468"/>
+            <a:ext cx="1508760" cy="278892"/>
           </a:xfrm>
           <a:prstGeom prst="rect">
             <a:avLst/>
@@ -9414,21 +9782,21 @@
                 </a:solidFill>
                 <a:latin typeface="Calibri"/>
               </a:rPr>
-              <a:t>1.676</a:t>
-            </a:r>
-          </a:p>
-        </p:txBody>
-      </p:sp>
-      <p:sp>
-        <p:nvSpPr>
-          <p:cNvPr id="52" name="TextBox 51"/>
-          <p:cNvSpPr txBox="1"/>
-          <p:nvPr/>
-        </p:nvSpPr>
-        <p:spPr>
-          <a:xfrm>
-            <a:off x="6217920" y="4288536"/>
-            <a:ext cx="1828800" cy="274320"/>
+              <a:t>3.345</a:t>
+            </a:r>
+          </a:p>
+        </p:txBody>
+      </p:sp>
+      <p:sp>
+        <p:nvSpPr>
+          <p:cNvPr id="62" name="TextBox 61"/>
+          <p:cNvSpPr txBox="1"/>
+          <p:nvPr/>
+        </p:nvSpPr>
+        <p:spPr>
+          <a:xfrm>
+            <a:off x="6492240" y="4887468"/>
+            <a:ext cx="1554480" cy="278892"/>
           </a:xfrm>
           <a:prstGeom prst="rect">
             <a:avLst/>
@@ -9449,20 +9817,20 @@
                 </a:solidFill>
                 <a:latin typeface="Calibri"/>
               </a:rPr>
-              <a:t>1.685</a:t>
-            </a:r>
-          </a:p>
-        </p:txBody>
-      </p:sp>
-      <p:sp>
-        <p:nvSpPr>
-          <p:cNvPr id="53" name="Rectangle 52"/>
+              <a:t>1,50</a:t>
+            </a:r>
+          </a:p>
+        </p:txBody>
+      </p:sp>
+      <p:sp>
+        <p:nvSpPr>
+          <p:cNvPr id="63" name="Rectangle 62"/>
           <p:cNvSpPr/>
           <p:nvPr/>
         </p:nvSpPr>
         <p:spPr>
           <a:xfrm>
-            <a:off x="411480" y="4727448"/>
+            <a:off x="411480" y="5312664"/>
             <a:ext cx="7635240" cy="841248"/>
           </a:xfrm>
           <a:prstGeom prst="rect">
@@ -9502,13 +9870,13 @@
       </p:sp>
       <p:sp>
         <p:nvSpPr>
-          <p:cNvPr id="54" name="TextBox 53"/>
-          <p:cNvSpPr txBox="1"/>
-          <p:nvPr/>
-        </p:nvSpPr>
-        <p:spPr>
-          <a:xfrm>
-            <a:off x="594360" y="4800600"/>
+          <p:cNvPr id="64" name="TextBox 63"/>
+          <p:cNvSpPr txBox="1"/>
+          <p:nvPr/>
+        </p:nvSpPr>
+        <p:spPr>
+          <a:xfrm>
+            <a:off x="594360" y="5385816"/>
             <a:ext cx="7269480" cy="292608"/>
           </a:xfrm>
           <a:prstGeom prst="rect">
@@ -9530,20 +9898,20 @@
                 </a:solidFill>
                 <a:latin typeface="Calibri"/>
               </a:rPr>
-              <a:t>Cluster gesamt: 2.370 Mails (47 %) in 681 Mehrfach-Mail-Vorgaengen (selber Makler + Kunde)</a:t>
-            </a:r>
-          </a:p>
-        </p:txBody>
-      </p:sp>
-      <p:sp>
-        <p:nvSpPr>
-          <p:cNvPr id="55" name="TextBox 54"/>
-          <p:cNvSpPr txBox="1"/>
-          <p:nvPr/>
-        </p:nvSpPr>
-        <p:spPr>
-          <a:xfrm>
-            <a:off x="594360" y="5129784"/>
+              <a:t>Cluster gesamt: 2.370 Mails (47 %) in 681 Mehrfach-Mail-Vorgängen (selber Makler + Kunde)</a:t>
+            </a:r>
+          </a:p>
+        </p:txBody>
+      </p:sp>
+      <p:sp>
+        <p:nvSpPr>
+          <p:cNvPr id="65" name="TextBox 64"/>
+          <p:cNvSpPr txBox="1"/>
+          <p:nvPr/>
+        </p:nvSpPr>
+        <p:spPr>
+          <a:xfrm>
+            <a:off x="594360" y="5715000"/>
             <a:ext cx="7269480" cy="402336"/>
           </a:xfrm>
           <a:prstGeom prst="rect">
@@ -9572,7 +9940,7 @@
       </p:sp>
       <p:sp>
         <p:nvSpPr>
-          <p:cNvPr id="56" name="Rectangle 55"/>
+          <p:cNvPr id="66" name="Rectangle 65"/>
           <p:cNvSpPr/>
           <p:nvPr/>
         </p:nvSpPr>
@@ -9616,7 +9984,7 @@
       </p:sp>
       <p:sp>
         <p:nvSpPr>
-          <p:cNvPr id="57" name="Oval 56"/>
+          <p:cNvPr id="67" name="Oval 66"/>
           <p:cNvSpPr/>
           <p:nvPr/>
         </p:nvSpPr>
@@ -9662,7 +10030,7 @@
       </p:sp>
       <p:sp>
         <p:nvSpPr>
-          <p:cNvPr id="58" name="TextBox 57"/>
+          <p:cNvPr id="68" name="TextBox 67"/>
           <p:cNvSpPr txBox="1"/>
           <p:nvPr/>
         </p:nvSpPr>
@@ -9697,7 +10065,7 @@
       </p:sp>
       <p:sp>
         <p:nvSpPr>
-          <p:cNvPr id="59" name="TextBox 58"/>
+          <p:cNvPr id="69" name="TextBox 68"/>
           <p:cNvSpPr txBox="1"/>
           <p:nvPr/>
         </p:nvSpPr>
@@ -9732,7 +10100,7 @@
       </p:sp>
       <p:sp>
         <p:nvSpPr>
-          <p:cNvPr id="60" name="TextBox 59"/>
+          <p:cNvPr id="70" name="TextBox 69"/>
           <p:cNvSpPr txBox="1"/>
           <p:nvPr/>
         </p:nvSpPr>
@@ -9760,14 +10128,14 @@
                 </a:solidFill>
                 <a:latin typeface="Calibri"/>
               </a:rPr>
-              <a:t>Zusammenhaengende Vorgaenge (selber Makler / Kunde) und die Last je Makler lassen sich im Postkorb heute nicht gezielt finden — Sachbearbeiter arbeiten unsortiert Mail fuer Mail ab.</a:t>
-            </a:r>
-          </a:p>
-        </p:txBody>
-      </p:sp>
-      <p:sp>
-        <p:nvSpPr>
-          <p:cNvPr id="61" name="Oval 60"/>
+              <a:t>Zusammenhängende Vorgänge (selber Makler / Kunde) und die Last je Makler lassen sich im Postkorb heute nicht gezielt finden — Sachbearbeiter arbeiten unsortiert Mail für Mail ab.</a:t>
+            </a:r>
+          </a:p>
+        </p:txBody>
+      </p:sp>
+      <p:sp>
+        <p:nvSpPr>
+          <p:cNvPr id="71" name="Oval 70"/>
           <p:cNvSpPr/>
           <p:nvPr/>
         </p:nvSpPr>
@@ -9813,7 +10181,7 @@
       </p:sp>
       <p:sp>
         <p:nvSpPr>
-          <p:cNvPr id="62" name="TextBox 61"/>
+          <p:cNvPr id="72" name="TextBox 71"/>
           <p:cNvSpPr txBox="1"/>
           <p:nvPr/>
         </p:nvSpPr>
@@ -9848,7 +10216,7 @@
       </p:sp>
       <p:sp>
         <p:nvSpPr>
-          <p:cNvPr id="63" name="TextBox 62"/>
+          <p:cNvPr id="73" name="TextBox 72"/>
           <p:cNvSpPr txBox="1"/>
           <p:nvPr/>
         </p:nvSpPr>
@@ -9876,14 +10244,14 @@
                 </a:solidFill>
                 <a:latin typeface="Calibri"/>
               </a:rPr>
-              <a:t>Moeglichkeit: gezielt abarbeiten</a:t>
-            </a:r>
-          </a:p>
-        </p:txBody>
-      </p:sp>
-      <p:sp>
-        <p:nvSpPr>
-          <p:cNvPr id="64" name="TextBox 63"/>
+              <a:t>Möglichkeit: gezielt abarbeiten</a:t>
+            </a:r>
+          </a:p>
+        </p:txBody>
+      </p:sp>
+      <p:sp>
+        <p:nvSpPr>
+          <p:cNvPr id="74" name="TextBox 73"/>
           <p:cNvSpPr txBox="1"/>
           <p:nvPr/>
         </p:nvSpPr>
@@ -9911,14 +10279,14 @@
                 </a:solidFill>
                 <a:latin typeface="Calibri"/>
               </a:rPr>
-              <a:t>Strukturierung + Excel erlauben Arbeitsvorrats-Steuerung: z. B. alle Vorgaenge eines Prio-Maklers (Top-5 = 57 %) oder alle Vorgaenge mit Cluster gebuendelt abarbeiten.</a:t>
-            </a:r>
-          </a:p>
-        </p:txBody>
-      </p:sp>
-      <p:sp>
-        <p:nvSpPr>
-          <p:cNvPr id="65" name="TextBox 64"/>
+              <a:t>Strukturierung + Excel erlauben Arbeitsvorrats-Steuerung: z. B. alle Vorgänge eines Prio-Maklers (Top-5 = 57 %) oder alle Vorgänge mit Cluster gebündelt abarbeiten.</a:t>
+            </a:r>
+          </a:p>
+        </p:txBody>
+      </p:sp>
+      <p:sp>
+        <p:nvSpPr>
+          <p:cNvPr id="75" name="TextBox 74"/>
           <p:cNvSpPr txBox="1"/>
           <p:nvPr/>
         </p:nvSpPr>
@@ -9946,14 +10314,14 @@
                 </a:solidFill>
                 <a:latin typeface="Calibri"/>
               </a:rPr>
-              <a:t>Datenbasis: 5.034 Mails  |  Mo 13.04. – Mo 20.04.2026 (eine Kalenderwoche)  |  Eingangs-Postfaecher: 'Service Team Maklerauftraege' (94 %), 'Bestandsuebertragungen' (5 %), 12 weitere &lt;1 %  |  Analyse-Stand: 27.05.2026 (KI-Auswertung mit Claude Opus 4.7, 99 von 5.034 Mails mit Analyse-Fehler/Timeout)</a:t>
-            </a:r>
-          </a:p>
-        </p:txBody>
-      </p:sp>
-      <p:sp>
-        <p:nvSpPr>
-          <p:cNvPr id="66" name="Rectangle 65"/>
+              <a:t>Datenbasis: 5.034 Mails  |  Mo 13.04. – Mo 20.04.2026 (eine Kalenderwoche)  |  Eingangs-Postfächer: 'Service Team Makleraufträge' (94 %), 'Bestandsübertragungen' (5 %), 12 weitere &lt;1 %  |  Analyse-Stand: 27.05.2026 (KI-Auswertung mit Claude Opus 4.7, 99 von 5.034 Mails mit Analyse-Fehler/Timeout)</a:t>
+            </a:r>
+          </a:p>
+        </p:txBody>
+      </p:sp>
+      <p:sp>
+        <p:nvSpPr>
+          <p:cNvPr id="76" name="Rectangle 75"/>
           <p:cNvSpPr/>
           <p:nvPr/>
         </p:nvSpPr>
@@ -9997,7 +10365,7 @@
       </p:sp>
       <p:sp>
         <p:nvSpPr>
-          <p:cNvPr id="67" name="TextBox 66"/>
+          <p:cNvPr id="77" name="TextBox 76"/>
           <p:cNvSpPr txBox="1"/>
           <p:nvPr/>
         </p:nvSpPr>
@@ -10025,7 +10393,7 @@
                 </a:solidFill>
                 <a:latin typeface="Calibri"/>
               </a:rPr>
-              <a:t>TAKE-AWAY:  57 % der Mails kommen von 5 Maklern, 47 % haengen in Clustern — heute im Postkorb nicht auffindbar. Strukturierung + Excel ermoeglichen gezieltes Abarbeiten nach Prio-Makler und Cluster.</a:t>
+              <a:t>TAKE-AWAY:  57 % der Mails kommen von 5 Maklern, 47 % hängen in Clustern — heute im Postkorb nicht auffindbar. Strukturierung + Excel ermöglichen gezieltes Abarbeiten nach Prio-Makler und Cluster.</a:t>
             </a:r>
           </a:p>
         </p:txBody>

</xml_diff>

<commit_message>
PPTX: Folie 12 auf BÜ-Anfrage-Basis + Segment-Split rechts; Folie 11 Header-Fussnote
Folie 12:
- Makler-Tabelle jetzt 'BÜ-Anfragen / Wo' (nur Status Neue BÜ) statt aller Mails:
  JDC 1.538/913/1,68 | Fonds Finanz 612/291/2,10 | blau direkt 255/180/1,42 |
  DEMA 114/80/1,43 | vfm 75/55/1,36 | Summe Top-5 2.594/1.519 (65%) |
  Sonstige 1.406/982 | Gesamt 4.000/2.495/1,60
- Cluster-Box auf BÜ-Basis: 2.117 BÜ-Anfragen (53 %) in 612 Vorgängen
- NEU rechts: Segment-Split-Tabelle (Sparte | BÜ-Anfr | in Cluster):
  KV 1.147/354(31%) [rot, kein VNR-Mapping] | Komposit 2.089/1.405(67%) |
  Leben 662/325(49%) | Sonstige 102/33 | Gesamt 4.000/2.117
  + kompakte Erkenntnis(!)/Möglichkeit(→)-Bloecke

Folie 11 (Archiv): '*' an Header 'MENGENGERÜSTE AUS ANALYSE ...*' +
Fussnotenzeile (Vollerhebung, KI-strukturiert, MV/Cluster-Definition).

https://claude.ai/code/session_01UknXtYp2XECsQDonCZuxSt
</commit_message>
<xml_diff>
--- a/ERGO-Mengengeruest-2Slides-Berichtslook.pptx
+++ b/ERGO-Mengengeruest-2Slides-Berichtslook.pptx
@@ -3514,7 +3514,7 @@
                 </a:solidFill>
                 <a:latin typeface="Calibri"/>
               </a:rPr>
-              <a:t>MENGENGERÜSTE AUS ANALYSE 13.04. – 20.04.</a:t>
+              <a:t>MENGENGERÜSTE AUS ANALYSE 13.04. – 20.04.*</a:t>
             </a:r>
           </a:p>
         </p:txBody>
@@ -3670,7 +3670,42 @@
       </p:sp>
       <p:sp>
         <p:nvSpPr>
-          <p:cNvPr id="17" name="Rectangle 16"/>
+          <p:cNvPr id="17" name="TextBox 16"/>
+          <p:cNvSpPr txBox="1"/>
+          <p:nvPr/>
+        </p:nvSpPr>
+        <p:spPr>
+          <a:xfrm>
+            <a:off x="411480" y="5559552"/>
+            <a:ext cx="7635240" cy="365760"/>
+          </a:xfrm>
+          <a:prstGeom prst="rect">
+            <a:avLst/>
+          </a:prstGeom>
+          <a:noFill/>
+        </p:spPr>
+        <p:txBody>
+          <a:bodyPr wrap="square" lIns="36000" rIns="36000" tIns="18000" bIns="18000" anchor="t">
+            <a:spAutoFit/>
+          </a:bodyPr>
+          <a:lstStyle/>
+          <a:p>
+            <a:pPr algn="l"/>
+            <a:r>
+              <a:rPr sz="800" b="0" i="1" u="none">
+                <a:solidFill>
+                  <a:srgbClr val="666666"/>
+                </a:solidFill>
+                <a:latin typeface="Calibri"/>
+              </a:rPr>
+              <a:t>* Vollerhebung BÜ-Posteingang einer Kalenderwoche: 5.034 Mails, KI-strukturiert (Claude Opus); 99 Mails mit Analyse-Fehler/Timeout.  MV = Maklervollmacht im Anhang.  Cluster = weitere Mails desselben Maklers zum selben Kunden.</a:t>
+            </a:r>
+          </a:p>
+        </p:txBody>
+      </p:sp>
+      <p:sp>
+        <p:nvSpPr>
+          <p:cNvPr id="18" name="Rectangle 17"/>
           <p:cNvSpPr/>
           <p:nvPr/>
         </p:nvSpPr>
@@ -3716,7 +3751,7 @@
       </p:sp>
       <p:sp>
         <p:nvSpPr>
-          <p:cNvPr id="18" name="Rectangle 17"/>
+          <p:cNvPr id="19" name="Rectangle 18"/>
           <p:cNvSpPr/>
           <p:nvPr/>
         </p:nvSpPr>
@@ -3760,7 +3795,7 @@
       </p:sp>
       <p:sp>
         <p:nvSpPr>
-          <p:cNvPr id="19" name="TextBox 18"/>
+          <p:cNvPr id="20" name="TextBox 19"/>
           <p:cNvSpPr txBox="1"/>
           <p:nvPr/>
         </p:nvSpPr>
@@ -3795,7 +3830,7 @@
       </p:sp>
       <p:sp>
         <p:nvSpPr>
-          <p:cNvPr id="20" name="TextBox 19"/>
+          <p:cNvPr id="21" name="TextBox 20"/>
           <p:cNvSpPr txBox="1"/>
           <p:nvPr/>
         </p:nvSpPr>
@@ -3830,7 +3865,7 @@
       </p:sp>
       <p:sp>
         <p:nvSpPr>
-          <p:cNvPr id="21" name="Rectangle 20"/>
+          <p:cNvPr id="22" name="Rectangle 21"/>
           <p:cNvSpPr/>
           <p:nvPr/>
         </p:nvSpPr>
@@ -3876,7 +3911,7 @@
       </p:sp>
       <p:sp>
         <p:nvSpPr>
-          <p:cNvPr id="22" name="Rectangle 21"/>
+          <p:cNvPr id="23" name="Rectangle 22"/>
           <p:cNvSpPr/>
           <p:nvPr/>
         </p:nvSpPr>
@@ -3920,7 +3955,7 @@
       </p:sp>
       <p:sp>
         <p:nvSpPr>
-          <p:cNvPr id="23" name="TextBox 22"/>
+          <p:cNvPr id="24" name="TextBox 23"/>
           <p:cNvSpPr txBox="1"/>
           <p:nvPr/>
         </p:nvSpPr>
@@ -3955,7 +3990,7 @@
       </p:sp>
       <p:sp>
         <p:nvSpPr>
-          <p:cNvPr id="24" name="TextBox 23"/>
+          <p:cNvPr id="25" name="TextBox 24"/>
           <p:cNvSpPr txBox="1"/>
           <p:nvPr/>
         </p:nvSpPr>
@@ -3990,7 +4025,7 @@
       </p:sp>
       <p:sp>
         <p:nvSpPr>
-          <p:cNvPr id="25" name="Rectangle 24"/>
+          <p:cNvPr id="26" name="Rectangle 25"/>
           <p:cNvSpPr/>
           <p:nvPr/>
         </p:nvSpPr>
@@ -4036,7 +4071,7 @@
       </p:sp>
       <p:sp>
         <p:nvSpPr>
-          <p:cNvPr id="26" name="Rectangle 25"/>
+          <p:cNvPr id="27" name="Rectangle 26"/>
           <p:cNvSpPr/>
           <p:nvPr/>
         </p:nvSpPr>
@@ -4080,7 +4115,7 @@
       </p:sp>
       <p:sp>
         <p:nvSpPr>
-          <p:cNvPr id="27" name="TextBox 26"/>
+          <p:cNvPr id="28" name="TextBox 27"/>
           <p:cNvSpPr txBox="1"/>
           <p:nvPr/>
         </p:nvSpPr>
@@ -4115,7 +4150,7 @@
       </p:sp>
       <p:sp>
         <p:nvSpPr>
-          <p:cNvPr id="28" name="TextBox 27"/>
+          <p:cNvPr id="29" name="TextBox 28"/>
           <p:cNvSpPr txBox="1"/>
           <p:nvPr/>
         </p:nvSpPr>
@@ -4150,7 +4185,7 @@
       </p:sp>
       <p:sp>
         <p:nvSpPr>
-          <p:cNvPr id="29" name="Rectangle 28"/>
+          <p:cNvPr id="30" name="Rectangle 29"/>
           <p:cNvSpPr/>
           <p:nvPr/>
         </p:nvSpPr>
@@ -4196,7 +4231,7 @@
       </p:sp>
       <p:sp>
         <p:nvSpPr>
-          <p:cNvPr id="30" name="Rectangle 29"/>
+          <p:cNvPr id="31" name="Rectangle 30"/>
           <p:cNvSpPr/>
           <p:nvPr/>
         </p:nvSpPr>
@@ -4240,7 +4275,7 @@
       </p:sp>
       <p:sp>
         <p:nvSpPr>
-          <p:cNvPr id="31" name="TextBox 30"/>
+          <p:cNvPr id="32" name="TextBox 31"/>
           <p:cNvSpPr txBox="1"/>
           <p:nvPr/>
         </p:nvSpPr>
@@ -4275,7 +4310,7 @@
       </p:sp>
       <p:sp>
         <p:nvSpPr>
-          <p:cNvPr id="32" name="TextBox 31"/>
+          <p:cNvPr id="33" name="TextBox 32"/>
           <p:cNvSpPr txBox="1"/>
           <p:nvPr/>
         </p:nvSpPr>
@@ -4310,7 +4345,7 @@
       </p:sp>
       <p:sp>
         <p:nvSpPr>
-          <p:cNvPr id="33" name="Rectangle 32"/>
+          <p:cNvPr id="34" name="Rectangle 33"/>
           <p:cNvSpPr/>
           <p:nvPr/>
         </p:nvSpPr>
@@ -4354,7 +4389,7 @@
       </p:sp>
       <p:sp>
         <p:nvSpPr>
-          <p:cNvPr id="34" name="TextBox 33"/>
+          <p:cNvPr id="35" name="TextBox 34"/>
           <p:cNvSpPr txBox="1"/>
           <p:nvPr/>
         </p:nvSpPr>
@@ -4389,7 +4424,7 @@
       </p:sp>
       <p:sp>
         <p:nvSpPr>
-          <p:cNvPr id="35" name="TextBox 34"/>
+          <p:cNvPr id="36" name="TextBox 35"/>
           <p:cNvSpPr txBox="1"/>
           <p:nvPr/>
         </p:nvSpPr>
@@ -4424,7 +4459,7 @@
       </p:sp>
       <p:sp>
         <p:nvSpPr>
-          <p:cNvPr id="36" name="TextBox 35"/>
+          <p:cNvPr id="37" name="TextBox 36"/>
           <p:cNvSpPr txBox="1"/>
           <p:nvPr/>
         </p:nvSpPr>
@@ -4459,7 +4494,7 @@
       </p:sp>
       <p:sp>
         <p:nvSpPr>
-          <p:cNvPr id="37" name="TextBox 36"/>
+          <p:cNvPr id="38" name="TextBox 37"/>
           <p:cNvSpPr txBox="1"/>
           <p:nvPr/>
         </p:nvSpPr>
@@ -4494,7 +4529,7 @@
       </p:sp>
       <p:sp>
         <p:nvSpPr>
-          <p:cNvPr id="38" name="TextBox 37"/>
+          <p:cNvPr id="39" name="TextBox 38"/>
           <p:cNvSpPr txBox="1"/>
           <p:nvPr/>
         </p:nvSpPr>
@@ -4529,7 +4564,7 @@
       </p:sp>
       <p:sp>
         <p:nvSpPr>
-          <p:cNvPr id="39" name="TextBox 38"/>
+          <p:cNvPr id="40" name="TextBox 39"/>
           <p:cNvSpPr txBox="1"/>
           <p:nvPr/>
         </p:nvSpPr>
@@ -4564,7 +4599,7 @@
       </p:sp>
       <p:sp>
         <p:nvSpPr>
-          <p:cNvPr id="40" name="Rectangle 39"/>
+          <p:cNvPr id="41" name="Rectangle 40"/>
           <p:cNvSpPr/>
           <p:nvPr/>
         </p:nvSpPr>
@@ -4608,7 +4643,7 @@
       </p:sp>
       <p:sp>
         <p:nvSpPr>
-          <p:cNvPr id="41" name="TextBox 40"/>
+          <p:cNvPr id="42" name="TextBox 41"/>
           <p:cNvSpPr txBox="1"/>
           <p:nvPr/>
         </p:nvSpPr>
@@ -4643,7 +4678,7 @@
       </p:sp>
       <p:sp>
         <p:nvSpPr>
-          <p:cNvPr id="42" name="TextBox 41"/>
+          <p:cNvPr id="43" name="TextBox 42"/>
           <p:cNvSpPr txBox="1"/>
           <p:nvPr/>
         </p:nvSpPr>
@@ -4678,7 +4713,7 @@
       </p:sp>
       <p:sp>
         <p:nvSpPr>
-          <p:cNvPr id="43" name="TextBox 42"/>
+          <p:cNvPr id="44" name="TextBox 43"/>
           <p:cNvSpPr txBox="1"/>
           <p:nvPr/>
         </p:nvSpPr>
@@ -4713,7 +4748,7 @@
       </p:sp>
       <p:sp>
         <p:nvSpPr>
-          <p:cNvPr id="44" name="TextBox 43"/>
+          <p:cNvPr id="45" name="TextBox 44"/>
           <p:cNvSpPr txBox="1"/>
           <p:nvPr/>
         </p:nvSpPr>
@@ -4748,7 +4783,7 @@
       </p:sp>
       <p:sp>
         <p:nvSpPr>
-          <p:cNvPr id="45" name="TextBox 44"/>
+          <p:cNvPr id="46" name="TextBox 45"/>
           <p:cNvSpPr txBox="1"/>
           <p:nvPr/>
         </p:nvSpPr>
@@ -4783,7 +4818,7 @@
       </p:sp>
       <p:sp>
         <p:nvSpPr>
-          <p:cNvPr id="46" name="TextBox 45"/>
+          <p:cNvPr id="47" name="TextBox 46"/>
           <p:cNvSpPr txBox="1"/>
           <p:nvPr/>
         </p:nvSpPr>
@@ -4818,7 +4853,7 @@
       </p:sp>
       <p:sp>
         <p:nvSpPr>
-          <p:cNvPr id="47" name="Rectangle 46"/>
+          <p:cNvPr id="48" name="Rectangle 47"/>
           <p:cNvSpPr/>
           <p:nvPr/>
         </p:nvSpPr>
@@ -4862,7 +4897,7 @@
       </p:sp>
       <p:sp>
         <p:nvSpPr>
-          <p:cNvPr id="48" name="TextBox 47"/>
+          <p:cNvPr id="49" name="TextBox 48"/>
           <p:cNvSpPr txBox="1"/>
           <p:nvPr/>
         </p:nvSpPr>
@@ -4897,7 +4932,7 @@
       </p:sp>
       <p:sp>
         <p:nvSpPr>
-          <p:cNvPr id="49" name="TextBox 48"/>
+          <p:cNvPr id="50" name="TextBox 49"/>
           <p:cNvSpPr txBox="1"/>
           <p:nvPr/>
         </p:nvSpPr>
@@ -4932,7 +4967,7 @@
       </p:sp>
       <p:sp>
         <p:nvSpPr>
-          <p:cNvPr id="50" name="TextBox 49"/>
+          <p:cNvPr id="51" name="TextBox 50"/>
           <p:cNvSpPr txBox="1"/>
           <p:nvPr/>
         </p:nvSpPr>
@@ -4967,7 +5002,7 @@
       </p:sp>
       <p:sp>
         <p:nvSpPr>
-          <p:cNvPr id="51" name="TextBox 50"/>
+          <p:cNvPr id="52" name="TextBox 51"/>
           <p:cNvSpPr txBox="1"/>
           <p:nvPr/>
         </p:nvSpPr>
@@ -5002,7 +5037,7 @@
       </p:sp>
       <p:sp>
         <p:nvSpPr>
-          <p:cNvPr id="52" name="TextBox 51"/>
+          <p:cNvPr id="53" name="TextBox 52"/>
           <p:cNvSpPr txBox="1"/>
           <p:nvPr/>
         </p:nvSpPr>
@@ -5037,7 +5072,7 @@
       </p:sp>
       <p:sp>
         <p:nvSpPr>
-          <p:cNvPr id="53" name="TextBox 52"/>
+          <p:cNvPr id="54" name="TextBox 53"/>
           <p:cNvSpPr txBox="1"/>
           <p:nvPr/>
         </p:nvSpPr>
@@ -5072,7 +5107,7 @@
       </p:sp>
       <p:sp>
         <p:nvSpPr>
-          <p:cNvPr id="54" name="Rectangle 53"/>
+          <p:cNvPr id="55" name="Rectangle 54"/>
           <p:cNvSpPr/>
           <p:nvPr/>
         </p:nvSpPr>
@@ -5116,7 +5151,7 @@
       </p:sp>
       <p:sp>
         <p:nvSpPr>
-          <p:cNvPr id="55" name="Rectangle 54"/>
+          <p:cNvPr id="56" name="Rectangle 55"/>
           <p:cNvSpPr/>
           <p:nvPr/>
         </p:nvSpPr>
@@ -5160,7 +5195,7 @@
       </p:sp>
       <p:sp>
         <p:nvSpPr>
-          <p:cNvPr id="56" name="TextBox 55"/>
+          <p:cNvPr id="57" name="TextBox 56"/>
           <p:cNvSpPr txBox="1"/>
           <p:nvPr/>
         </p:nvSpPr>
@@ -5195,7 +5230,7 @@
       </p:sp>
       <p:sp>
         <p:nvSpPr>
-          <p:cNvPr id="57" name="TextBox 56"/>
+          <p:cNvPr id="58" name="TextBox 57"/>
           <p:cNvSpPr txBox="1"/>
           <p:nvPr/>
         </p:nvSpPr>
@@ -5230,7 +5265,7 @@
       </p:sp>
       <p:sp>
         <p:nvSpPr>
-          <p:cNvPr id="58" name="TextBox 57"/>
+          <p:cNvPr id="59" name="TextBox 58"/>
           <p:cNvSpPr txBox="1"/>
           <p:nvPr/>
         </p:nvSpPr>
@@ -5265,7 +5300,7 @@
       </p:sp>
       <p:sp>
         <p:nvSpPr>
-          <p:cNvPr id="59" name="TextBox 58"/>
+          <p:cNvPr id="60" name="TextBox 59"/>
           <p:cNvSpPr txBox="1"/>
           <p:nvPr/>
         </p:nvSpPr>
@@ -5300,7 +5335,7 @@
       </p:sp>
       <p:sp>
         <p:nvSpPr>
-          <p:cNvPr id="60" name="TextBox 59"/>
+          <p:cNvPr id="61" name="TextBox 60"/>
           <p:cNvSpPr txBox="1"/>
           <p:nvPr/>
         </p:nvSpPr>
@@ -5335,7 +5370,7 @@
       </p:sp>
       <p:sp>
         <p:nvSpPr>
-          <p:cNvPr id="61" name="TextBox 60"/>
+          <p:cNvPr id="62" name="TextBox 61"/>
           <p:cNvSpPr txBox="1"/>
           <p:nvPr/>
         </p:nvSpPr>
@@ -5370,7 +5405,7 @@
       </p:sp>
       <p:sp>
         <p:nvSpPr>
-          <p:cNvPr id="62" name="Rectangle 61"/>
+          <p:cNvPr id="63" name="Rectangle 62"/>
           <p:cNvSpPr/>
           <p:nvPr/>
         </p:nvSpPr>
@@ -5414,7 +5449,7 @@
       </p:sp>
       <p:sp>
         <p:nvSpPr>
-          <p:cNvPr id="63" name="TextBox 62"/>
+          <p:cNvPr id="64" name="TextBox 63"/>
           <p:cNvSpPr txBox="1"/>
           <p:nvPr/>
         </p:nvSpPr>
@@ -5449,7 +5484,7 @@
       </p:sp>
       <p:sp>
         <p:nvSpPr>
-          <p:cNvPr id="64" name="TextBox 63"/>
+          <p:cNvPr id="65" name="TextBox 64"/>
           <p:cNvSpPr txBox="1"/>
           <p:nvPr/>
         </p:nvSpPr>
@@ -5484,7 +5519,7 @@
       </p:sp>
       <p:sp>
         <p:nvSpPr>
-          <p:cNvPr id="65" name="TextBox 64"/>
+          <p:cNvPr id="66" name="TextBox 65"/>
           <p:cNvSpPr txBox="1"/>
           <p:nvPr/>
         </p:nvSpPr>
@@ -5519,7 +5554,7 @@
       </p:sp>
       <p:sp>
         <p:nvSpPr>
-          <p:cNvPr id="66" name="TextBox 65"/>
+          <p:cNvPr id="67" name="TextBox 66"/>
           <p:cNvSpPr txBox="1"/>
           <p:nvPr/>
         </p:nvSpPr>
@@ -5554,7 +5589,7 @@
       </p:sp>
       <p:sp>
         <p:nvSpPr>
-          <p:cNvPr id="67" name="TextBox 66"/>
+          <p:cNvPr id="68" name="TextBox 67"/>
           <p:cNvSpPr txBox="1"/>
           <p:nvPr/>
         </p:nvSpPr>
@@ -5589,7 +5624,7 @@
       </p:sp>
       <p:sp>
         <p:nvSpPr>
-          <p:cNvPr id="68" name="TextBox 67"/>
+          <p:cNvPr id="69" name="TextBox 68"/>
           <p:cNvSpPr txBox="1"/>
           <p:nvPr/>
         </p:nvSpPr>
@@ -5624,7 +5659,7 @@
       </p:sp>
       <p:sp>
         <p:nvSpPr>
-          <p:cNvPr id="69" name="Rectangle 68"/>
+          <p:cNvPr id="70" name="Rectangle 69"/>
           <p:cNvSpPr/>
           <p:nvPr/>
         </p:nvSpPr>
@@ -5668,7 +5703,7 @@
       </p:sp>
       <p:sp>
         <p:nvSpPr>
-          <p:cNvPr id="70" name="Rectangle 69"/>
+          <p:cNvPr id="71" name="Rectangle 70"/>
           <p:cNvSpPr/>
           <p:nvPr/>
         </p:nvSpPr>
@@ -5712,7 +5747,7 @@
       </p:sp>
       <p:sp>
         <p:nvSpPr>
-          <p:cNvPr id="71" name="TextBox 70"/>
+          <p:cNvPr id="72" name="TextBox 71"/>
           <p:cNvSpPr txBox="1"/>
           <p:nvPr/>
         </p:nvSpPr>
@@ -5747,7 +5782,7 @@
       </p:sp>
       <p:sp>
         <p:nvSpPr>
-          <p:cNvPr id="72" name="TextBox 71"/>
+          <p:cNvPr id="73" name="TextBox 72"/>
           <p:cNvSpPr txBox="1"/>
           <p:nvPr/>
         </p:nvSpPr>
@@ -5782,7 +5817,7 @@
       </p:sp>
       <p:sp>
         <p:nvSpPr>
-          <p:cNvPr id="73" name="TextBox 72"/>
+          <p:cNvPr id="74" name="TextBox 73"/>
           <p:cNvSpPr txBox="1"/>
           <p:nvPr/>
         </p:nvSpPr>
@@ -5817,7 +5852,7 @@
       </p:sp>
       <p:sp>
         <p:nvSpPr>
-          <p:cNvPr id="74" name="TextBox 73"/>
+          <p:cNvPr id="75" name="TextBox 74"/>
           <p:cNvSpPr txBox="1"/>
           <p:nvPr/>
         </p:nvSpPr>
@@ -5852,7 +5887,7 @@
       </p:sp>
       <p:sp>
         <p:nvSpPr>
-          <p:cNvPr id="75" name="TextBox 74"/>
+          <p:cNvPr id="76" name="TextBox 75"/>
           <p:cNvSpPr txBox="1"/>
           <p:nvPr/>
         </p:nvSpPr>
@@ -5887,7 +5922,7 @@
       </p:sp>
       <p:sp>
         <p:nvSpPr>
-          <p:cNvPr id="76" name="TextBox 75"/>
+          <p:cNvPr id="77" name="TextBox 76"/>
           <p:cNvSpPr txBox="1"/>
           <p:nvPr/>
         </p:nvSpPr>
@@ -5922,7 +5957,7 @@
       </p:sp>
       <p:sp>
         <p:nvSpPr>
-          <p:cNvPr id="77" name="Rectangle 76"/>
+          <p:cNvPr id="78" name="Rectangle 77"/>
           <p:cNvSpPr/>
           <p:nvPr/>
         </p:nvSpPr>
@@ -5966,7 +6001,7 @@
       </p:sp>
       <p:sp>
         <p:nvSpPr>
-          <p:cNvPr id="78" name="Rectangle 77"/>
+          <p:cNvPr id="79" name="Rectangle 78"/>
           <p:cNvSpPr/>
           <p:nvPr/>
         </p:nvSpPr>
@@ -6010,7 +6045,7 @@
       </p:sp>
       <p:sp>
         <p:nvSpPr>
-          <p:cNvPr id="79" name="TextBox 78"/>
+          <p:cNvPr id="80" name="TextBox 79"/>
           <p:cNvSpPr txBox="1"/>
           <p:nvPr/>
         </p:nvSpPr>
@@ -6045,7 +6080,7 @@
       </p:sp>
       <p:sp>
         <p:nvSpPr>
-          <p:cNvPr id="80" name="TextBox 79"/>
+          <p:cNvPr id="81" name="TextBox 80"/>
           <p:cNvSpPr txBox="1"/>
           <p:nvPr/>
         </p:nvSpPr>
@@ -6080,7 +6115,7 @@
       </p:sp>
       <p:sp>
         <p:nvSpPr>
-          <p:cNvPr id="81" name="TextBox 80"/>
+          <p:cNvPr id="82" name="TextBox 81"/>
           <p:cNvSpPr txBox="1"/>
           <p:nvPr/>
         </p:nvSpPr>
@@ -6115,7 +6150,7 @@
       </p:sp>
       <p:sp>
         <p:nvSpPr>
-          <p:cNvPr id="82" name="TextBox 81"/>
+          <p:cNvPr id="83" name="TextBox 82"/>
           <p:cNvSpPr txBox="1"/>
           <p:nvPr/>
         </p:nvSpPr>
@@ -6150,7 +6185,7 @@
       </p:sp>
       <p:sp>
         <p:nvSpPr>
-          <p:cNvPr id="83" name="TextBox 82"/>
+          <p:cNvPr id="84" name="TextBox 83"/>
           <p:cNvSpPr txBox="1"/>
           <p:nvPr/>
         </p:nvSpPr>
@@ -6185,7 +6220,7 @@
       </p:sp>
       <p:sp>
         <p:nvSpPr>
-          <p:cNvPr id="84" name="TextBox 83"/>
+          <p:cNvPr id="85" name="TextBox 84"/>
           <p:cNvSpPr txBox="1"/>
           <p:nvPr/>
         </p:nvSpPr>
@@ -6220,7 +6255,7 @@
       </p:sp>
       <p:sp>
         <p:nvSpPr>
-          <p:cNvPr id="85" name="Rectangle 84"/>
+          <p:cNvPr id="86" name="Rectangle 85"/>
           <p:cNvSpPr/>
           <p:nvPr/>
         </p:nvSpPr>
@@ -6264,7 +6299,7 @@
       </p:sp>
       <p:sp>
         <p:nvSpPr>
-          <p:cNvPr id="86" name="TextBox 85"/>
+          <p:cNvPr id="87" name="TextBox 86"/>
           <p:cNvSpPr txBox="1"/>
           <p:nvPr/>
         </p:nvSpPr>
@@ -6299,7 +6334,7 @@
       </p:sp>
       <p:sp>
         <p:nvSpPr>
-          <p:cNvPr id="87" name="TextBox 86"/>
+          <p:cNvPr id="88" name="TextBox 87"/>
           <p:cNvSpPr txBox="1"/>
           <p:nvPr/>
         </p:nvSpPr>
@@ -6334,7 +6369,7 @@
       </p:sp>
       <p:sp>
         <p:nvSpPr>
-          <p:cNvPr id="88" name="TextBox 87"/>
+          <p:cNvPr id="89" name="TextBox 88"/>
           <p:cNvSpPr txBox="1"/>
           <p:nvPr/>
         </p:nvSpPr>
@@ -6369,7 +6404,7 @@
       </p:sp>
       <p:sp>
         <p:nvSpPr>
-          <p:cNvPr id="89" name="TextBox 88"/>
+          <p:cNvPr id="90" name="TextBox 89"/>
           <p:cNvSpPr txBox="1"/>
           <p:nvPr/>
         </p:nvSpPr>
@@ -6404,7 +6439,7 @@
       </p:sp>
       <p:sp>
         <p:nvSpPr>
-          <p:cNvPr id="90" name="TextBox 89"/>
+          <p:cNvPr id="91" name="TextBox 90"/>
           <p:cNvSpPr txBox="1"/>
           <p:nvPr/>
         </p:nvSpPr>
@@ -6439,7 +6474,7 @@
       </p:sp>
       <p:sp>
         <p:nvSpPr>
-          <p:cNvPr id="91" name="TextBox 90"/>
+          <p:cNvPr id="92" name="TextBox 91"/>
           <p:cNvSpPr txBox="1"/>
           <p:nvPr/>
         </p:nvSpPr>
@@ -6474,7 +6509,7 @@
       </p:sp>
       <p:sp>
         <p:nvSpPr>
-          <p:cNvPr id="92" name="Rectangle 91"/>
+          <p:cNvPr id="93" name="Rectangle 92"/>
           <p:cNvSpPr/>
           <p:nvPr/>
         </p:nvSpPr>
@@ -6518,7 +6553,7 @@
       </p:sp>
       <p:sp>
         <p:nvSpPr>
-          <p:cNvPr id="93" name="TextBox 92"/>
+          <p:cNvPr id="94" name="TextBox 93"/>
           <p:cNvSpPr txBox="1"/>
           <p:nvPr/>
         </p:nvSpPr>
@@ -6553,7 +6588,7 @@
       </p:sp>
       <p:sp>
         <p:nvSpPr>
-          <p:cNvPr id="94" name="TextBox 93"/>
+          <p:cNvPr id="95" name="TextBox 94"/>
           <p:cNvSpPr txBox="1"/>
           <p:nvPr/>
         </p:nvSpPr>
@@ -6588,7 +6623,7 @@
       </p:sp>
       <p:sp>
         <p:nvSpPr>
-          <p:cNvPr id="95" name="TextBox 94"/>
+          <p:cNvPr id="96" name="TextBox 95"/>
           <p:cNvSpPr txBox="1"/>
           <p:nvPr/>
         </p:nvSpPr>
@@ -6623,7 +6658,7 @@
       </p:sp>
       <p:sp>
         <p:nvSpPr>
-          <p:cNvPr id="96" name="TextBox 95"/>
+          <p:cNvPr id="97" name="TextBox 96"/>
           <p:cNvSpPr txBox="1"/>
           <p:nvPr/>
         </p:nvSpPr>
@@ -6658,7 +6693,7 @@
       </p:sp>
       <p:sp>
         <p:nvSpPr>
-          <p:cNvPr id="97" name="TextBox 96"/>
+          <p:cNvPr id="98" name="TextBox 97"/>
           <p:cNvSpPr txBox="1"/>
           <p:nvPr/>
         </p:nvSpPr>
@@ -6693,7 +6728,7 @@
       </p:sp>
       <p:sp>
         <p:nvSpPr>
-          <p:cNvPr id="98" name="TextBox 97"/>
+          <p:cNvPr id="99" name="TextBox 98"/>
           <p:cNvSpPr txBox="1"/>
           <p:nvPr/>
         </p:nvSpPr>
@@ -6728,7 +6763,7 @@
       </p:sp>
       <p:sp>
         <p:nvSpPr>
-          <p:cNvPr id="99" name="TextBox 98"/>
+          <p:cNvPr id="100" name="TextBox 99"/>
           <p:cNvSpPr txBox="1"/>
           <p:nvPr/>
         </p:nvSpPr>
@@ -6763,7 +6798,7 @@
       </p:sp>
       <p:sp>
         <p:nvSpPr>
-          <p:cNvPr id="100" name="Rectangle 99"/>
+          <p:cNvPr id="101" name="Rectangle 100"/>
           <p:cNvSpPr/>
           <p:nvPr/>
         </p:nvSpPr>
@@ -6807,7 +6842,7 @@
       </p:sp>
       <p:sp>
         <p:nvSpPr>
-          <p:cNvPr id="101" name="Oval 100"/>
+          <p:cNvPr id="102" name="Oval 101"/>
           <p:cNvSpPr/>
           <p:nvPr/>
         </p:nvSpPr>
@@ -6851,7 +6886,7 @@
       </p:sp>
       <p:sp>
         <p:nvSpPr>
-          <p:cNvPr id="102" name="TextBox 101"/>
+          <p:cNvPr id="103" name="TextBox 102"/>
           <p:cNvSpPr txBox="1"/>
           <p:nvPr/>
         </p:nvSpPr>
@@ -6886,7 +6921,7 @@
       </p:sp>
       <p:sp>
         <p:nvSpPr>
-          <p:cNvPr id="103" name="TextBox 102"/>
+          <p:cNvPr id="104" name="TextBox 103"/>
           <p:cNvSpPr txBox="1"/>
           <p:nvPr/>
         </p:nvSpPr>
@@ -6930,7 +6965,7 @@
       </p:sp>
       <p:sp>
         <p:nvSpPr>
-          <p:cNvPr id="104" name="Oval 103"/>
+          <p:cNvPr id="105" name="Oval 104"/>
           <p:cNvSpPr/>
           <p:nvPr/>
         </p:nvSpPr>
@@ -6974,7 +7009,7 @@
       </p:sp>
       <p:sp>
         <p:nvSpPr>
-          <p:cNvPr id="105" name="TextBox 104"/>
+          <p:cNvPr id="106" name="TextBox 105"/>
           <p:cNvSpPr txBox="1"/>
           <p:nvPr/>
         </p:nvSpPr>
@@ -7009,7 +7044,7 @@
       </p:sp>
       <p:sp>
         <p:nvSpPr>
-          <p:cNvPr id="106" name="TextBox 105"/>
+          <p:cNvPr id="107" name="TextBox 106"/>
           <p:cNvSpPr txBox="1"/>
           <p:nvPr/>
         </p:nvSpPr>
@@ -7053,7 +7088,7 @@
       </p:sp>
       <p:sp>
         <p:nvSpPr>
-          <p:cNvPr id="107" name="Oval 106"/>
+          <p:cNvPr id="108" name="Oval 107"/>
           <p:cNvSpPr/>
           <p:nvPr/>
         </p:nvSpPr>
@@ -7097,7 +7132,7 @@
       </p:sp>
       <p:sp>
         <p:nvSpPr>
-          <p:cNvPr id="108" name="TextBox 107"/>
+          <p:cNvPr id="109" name="TextBox 108"/>
           <p:cNvSpPr txBox="1"/>
           <p:nvPr/>
         </p:nvSpPr>
@@ -7132,7 +7167,7 @@
       </p:sp>
       <p:sp>
         <p:nvSpPr>
-          <p:cNvPr id="109" name="TextBox 108"/>
+          <p:cNvPr id="110" name="TextBox 109"/>
           <p:cNvSpPr txBox="1"/>
           <p:nvPr/>
         </p:nvSpPr>
@@ -7176,7 +7211,7 @@
       </p:sp>
       <p:sp>
         <p:nvSpPr>
-          <p:cNvPr id="110" name="Oval 109"/>
+          <p:cNvPr id="111" name="Oval 110"/>
           <p:cNvSpPr/>
           <p:nvPr/>
         </p:nvSpPr>
@@ -7220,7 +7255,7 @@
       </p:sp>
       <p:sp>
         <p:nvSpPr>
-          <p:cNvPr id="111" name="TextBox 110"/>
+          <p:cNvPr id="112" name="TextBox 111"/>
           <p:cNvSpPr txBox="1"/>
           <p:nvPr/>
         </p:nvSpPr>
@@ -7255,7 +7290,7 @@
       </p:sp>
       <p:sp>
         <p:nvSpPr>
-          <p:cNvPr id="112" name="TextBox 111"/>
+          <p:cNvPr id="113" name="TextBox 112"/>
           <p:cNvSpPr txBox="1"/>
           <p:nvPr/>
         </p:nvSpPr>
@@ -7299,7 +7334,7 @@
       </p:sp>
       <p:sp>
         <p:nvSpPr>
-          <p:cNvPr id="113" name="Oval 112"/>
+          <p:cNvPr id="114" name="Oval 113"/>
           <p:cNvSpPr/>
           <p:nvPr/>
         </p:nvSpPr>
@@ -7343,7 +7378,7 @@
       </p:sp>
       <p:sp>
         <p:nvSpPr>
-          <p:cNvPr id="114" name="TextBox 113"/>
+          <p:cNvPr id="115" name="TextBox 114"/>
           <p:cNvSpPr txBox="1"/>
           <p:nvPr/>
         </p:nvSpPr>
@@ -7378,7 +7413,7 @@
       </p:sp>
       <p:sp>
         <p:nvSpPr>
-          <p:cNvPr id="115" name="TextBox 114"/>
+          <p:cNvPr id="116" name="TextBox 115"/>
           <p:cNvSpPr txBox="1"/>
           <p:nvPr/>
         </p:nvSpPr>
@@ -7422,7 +7457,7 @@
       </p:sp>
       <p:sp>
         <p:nvSpPr>
-          <p:cNvPr id="116" name="TextBox 115"/>
+          <p:cNvPr id="117" name="TextBox 116"/>
           <p:cNvSpPr txBox="1"/>
           <p:nvPr/>
         </p:nvSpPr>
@@ -7457,7 +7492,7 @@
       </p:sp>
       <p:sp>
         <p:nvSpPr>
-          <p:cNvPr id="117" name="Rectangle 116"/>
+          <p:cNvPr id="118" name="Rectangle 117"/>
           <p:cNvSpPr/>
           <p:nvPr/>
         </p:nvSpPr>
@@ -7501,7 +7536,7 @@
       </p:sp>
       <p:sp>
         <p:nvSpPr>
-          <p:cNvPr id="118" name="TextBox 117"/>
+          <p:cNvPr id="119" name="TextBox 118"/>
           <p:cNvSpPr txBox="1"/>
           <p:nvPr/>
         </p:nvSpPr>
@@ -8275,7 +8310,7 @@
                 </a:solidFill>
                 <a:latin typeface="Calibri"/>
               </a:rPr>
-              <a:t>Mails / Woche</a:t>
+              <a:t>BÜ-Anfragen / Wo</a:t>
             </a:r>
           </a:p>
         </p:txBody>
@@ -8459,7 +8494,7 @@
                 </a:solidFill>
                 <a:latin typeface="Calibri"/>
               </a:rPr>
-              <a:t>1.743</a:t>
+              <a:t>1.538</a:t>
             </a:r>
           </a:p>
         </p:txBody>
@@ -8494,7 +8529,7 @@
                 </a:solidFill>
                 <a:latin typeface="Calibri"/>
               </a:rPr>
-              <a:t>998</a:t>
+              <a:t>913</a:t>
             </a:r>
           </a:p>
         </p:txBody>
@@ -8529,7 +8564,7 @@
                 </a:solidFill>
                 <a:latin typeface="Calibri"/>
               </a:rPr>
-              <a:t>1,75</a:t>
+              <a:t>1,68</a:t>
             </a:r>
           </a:p>
         </p:txBody>
@@ -8643,7 +8678,7 @@
                 </a:solidFill>
                 <a:latin typeface="Calibri"/>
               </a:rPr>
-              <a:t>618</a:t>
+              <a:t>612</a:t>
             </a:r>
           </a:p>
         </p:txBody>
@@ -8678,7 +8713,7 @@
                 </a:solidFill>
                 <a:latin typeface="Calibri"/>
               </a:rPr>
-              <a:t>297</a:t>
+              <a:t>291</a:t>
             </a:r>
           </a:p>
         </p:txBody>
@@ -8713,7 +8748,7 @@
                 </a:solidFill>
                 <a:latin typeface="Calibri"/>
               </a:rPr>
-              <a:t>2,08</a:t>
+              <a:t>2,10</a:t>
             </a:r>
           </a:p>
         </p:txBody>
@@ -9011,7 +9046,7 @@
                 </a:solidFill>
                 <a:latin typeface="Calibri"/>
               </a:rPr>
-              <a:t>158</a:t>
+              <a:t>114</a:t>
             </a:r>
           </a:p>
         </p:txBody>
@@ -9046,7 +9081,7 @@
                 </a:solidFill>
                 <a:latin typeface="Calibri"/>
               </a:rPr>
-              <a:t>124</a:t>
+              <a:t>80</a:t>
             </a:r>
           </a:p>
         </p:txBody>
@@ -9081,7 +9116,7 @@
                 </a:solidFill>
                 <a:latin typeface="Calibri"/>
               </a:rPr>
-              <a:t>1,27</a:t>
+              <a:t>1,43</a:t>
             </a:r>
           </a:p>
         </p:txBody>
@@ -9195,7 +9230,7 @@
                 </a:solidFill>
                 <a:latin typeface="Calibri"/>
               </a:rPr>
-              <a:t>116</a:t>
+              <a:t>75</a:t>
             </a:r>
           </a:p>
         </p:txBody>
@@ -9230,7 +9265,7 @@
                 </a:solidFill>
                 <a:latin typeface="Calibri"/>
               </a:rPr>
-              <a:t>77</a:t>
+              <a:t>55</a:t>
             </a:r>
           </a:p>
         </p:txBody>
@@ -9265,7 +9300,7 @@
                 </a:solidFill>
                 <a:latin typeface="Calibri"/>
               </a:rPr>
-              <a:t>1,51</a:t>
+              <a:t>1,36</a:t>
             </a:r>
           </a:p>
         </p:txBody>
@@ -9344,7 +9379,7 @@
                 </a:solidFill>
                 <a:latin typeface="Calibri"/>
               </a:rPr>
-              <a:t>Summe Top-5-Makler  (57 % der Mails)</a:t>
+              <a:t>Summe Top-5-Makler  (65 % der BÜ-Anfragen)</a:t>
             </a:r>
           </a:p>
         </p:txBody>
@@ -9379,7 +9414,7 @@
                 </a:solidFill>
                 <a:latin typeface="Calibri"/>
               </a:rPr>
-              <a:t>2.890</a:t>
+              <a:t>2.594</a:t>
             </a:r>
           </a:p>
         </p:txBody>
@@ -9414,7 +9449,7 @@
                 </a:solidFill>
                 <a:latin typeface="Calibri"/>
               </a:rPr>
-              <a:t>1.676</a:t>
+              <a:t>1.519</a:t>
             </a:r>
           </a:p>
         </p:txBody>
@@ -9449,7 +9484,7 @@
                 </a:solidFill>
                 <a:latin typeface="Calibri"/>
               </a:rPr>
-              <a:t>1,72</a:t>
+              <a:t>1,71</a:t>
             </a:r>
           </a:p>
         </p:txBody>
@@ -9563,7 +9598,7 @@
                 </a:solidFill>
                 <a:latin typeface="Calibri"/>
               </a:rPr>
-              <a:t>2.144</a:t>
+              <a:t>1.406</a:t>
             </a:r>
           </a:p>
         </p:txBody>
@@ -9598,7 +9633,7 @@
                 </a:solidFill>
                 <a:latin typeface="Calibri"/>
               </a:rPr>
-              <a:t>1.678</a:t>
+              <a:t>982</a:t>
             </a:r>
           </a:p>
         </p:txBody>
@@ -9633,7 +9668,7 @@
                 </a:solidFill>
                 <a:latin typeface="Calibri"/>
               </a:rPr>
-              <a:t>1,28</a:t>
+              <a:t>1,43</a:t>
             </a:r>
           </a:p>
         </p:txBody>
@@ -9747,7 +9782,7 @@
                 </a:solidFill>
                 <a:latin typeface="Calibri"/>
               </a:rPr>
-              <a:t>5.034</a:t>
+              <a:t>4.000</a:t>
             </a:r>
           </a:p>
         </p:txBody>
@@ -9782,7 +9817,7 @@
                 </a:solidFill>
                 <a:latin typeface="Calibri"/>
               </a:rPr>
-              <a:t>3.345</a:t>
+              <a:t>2.495</a:t>
             </a:r>
           </a:p>
         </p:txBody>
@@ -9817,7 +9852,7 @@
                 </a:solidFill>
                 <a:latin typeface="Calibri"/>
               </a:rPr>
-              <a:t>1,50</a:t>
+              <a:t>1,60</a:t>
             </a:r>
           </a:p>
         </p:txBody>
@@ -9831,7 +9866,7 @@
         <p:spPr>
           <a:xfrm>
             <a:off x="411480" y="5312664"/>
-            <a:ext cx="7635240" cy="841248"/>
+            <a:ext cx="7635240" cy="640080"/>
           </a:xfrm>
           <a:prstGeom prst="rect">
             <a:avLst/>
@@ -9876,8 +9911,8 @@
         </p:nvSpPr>
         <p:spPr>
           <a:xfrm>
-            <a:off x="594360" y="5385816"/>
-            <a:ext cx="7269480" cy="292608"/>
+            <a:off x="594360" y="5367528"/>
+            <a:ext cx="7269480" cy="274320"/>
           </a:xfrm>
           <a:prstGeom prst="rect">
             <a:avLst/>
@@ -9898,7 +9933,7 @@
                 </a:solidFill>
                 <a:latin typeface="Calibri"/>
               </a:rPr>
-              <a:t>Cluster gesamt: 2.370 Mails (47 %) in 681 Mehrfach-Mail-Vorgängen (selber Makler + Kunde)</a:t>
+              <a:t>Cluster gesamt: 2.117 BÜ-Anfragen (53 %) in 612 Mehrfach-Mail-Vorgängen (selber Makler + Kunde)</a:t>
             </a:r>
           </a:p>
         </p:txBody>
@@ -9911,8 +9946,8 @@
         </p:nvSpPr>
         <p:spPr>
           <a:xfrm>
-            <a:off x="594360" y="5715000"/>
-            <a:ext cx="7269480" cy="402336"/>
+            <a:off x="594360" y="5660136"/>
+            <a:ext cx="7269480" cy="274320"/>
           </a:xfrm>
           <a:prstGeom prst="rect">
             <a:avLst/>
@@ -9933,7 +9968,7 @@
                 </a:solidFill>
                 <a:latin typeface="Calibri"/>
               </a:rPr>
-              <a:t>Schwerpunkt Komposit (1.573) &amp; Leben (357); in KV 399 — dort ist heute jede Mail ein eigener Vorgang, ohne VNR-Mapping.</a:t>
+              <a:t>Heute im Postkorb nicht gezielt auffindbar — Sachbearbeiter arbeiten unsortiert Mail für Mail ab.</a:t>
             </a:r>
           </a:p>
         </p:txBody>
@@ -9984,13 +10019,1021 @@
       </p:sp>
       <p:sp>
         <p:nvSpPr>
-          <p:cNvPr id="67" name="Oval 66"/>
+          <p:cNvPr id="67" name="TextBox 66"/>
+          <p:cNvSpPr txBox="1"/>
+          <p:nvPr/>
+        </p:nvSpPr>
+        <p:spPr>
+          <a:xfrm>
+            <a:off x="8339328" y="2331720"/>
+            <a:ext cx="3392424" cy="256032"/>
+          </a:xfrm>
+          <a:prstGeom prst="rect">
+            <a:avLst/>
+          </a:prstGeom>
+          <a:noFill/>
+        </p:spPr>
+        <p:txBody>
+          <a:bodyPr wrap="square" lIns="36000" rIns="36000" tIns="18000" bIns="18000" anchor="t">
+            <a:spAutoFit/>
+          </a:bodyPr>
+          <a:lstStyle/>
+          <a:p>
+            <a:pPr algn="l"/>
+            <a:r>
+              <a:rPr sz="1100" b="1" i="0" u="none">
+                <a:solidFill>
+                  <a:srgbClr val="006B77"/>
+                </a:solidFill>
+                <a:latin typeface="Calibri"/>
+              </a:rPr>
+              <a:t>Split nach Segment (BÜ-Anfragen)</a:t>
+            </a:r>
+          </a:p>
+        </p:txBody>
+      </p:sp>
+      <p:sp>
+        <p:nvSpPr>
+          <p:cNvPr id="68" name="Rectangle 67"/>
           <p:cNvSpPr/>
           <p:nvPr/>
         </p:nvSpPr>
         <p:spPr>
           <a:xfrm>
-            <a:off x="8394192" y="2441448"/>
+            <a:off x="8321040" y="2606040"/>
+            <a:ext cx="3429000" cy="274320"/>
+          </a:xfrm>
+          <a:prstGeom prst="rect">
+            <a:avLst/>
+          </a:prstGeom>
+          <a:solidFill>
+            <a:srgbClr val="006B77"/>
+          </a:solidFill>
+          <a:ln>
+            <a:noFill/>
+          </a:ln>
+          <a:effectLst/>
+        </p:spPr>
+        <p:style>
+          <a:lnRef idx="1">
+            <a:schemeClr val="accent1"/>
+          </a:lnRef>
+          <a:fillRef idx="3">
+            <a:schemeClr val="accent1"/>
+          </a:fillRef>
+          <a:effectRef idx="2">
+            <a:schemeClr val="accent1"/>
+          </a:effectRef>
+          <a:fontRef idx="minor">
+            <a:schemeClr val="lt1"/>
+          </a:fontRef>
+        </p:style>
+        <p:txBody>
+          <a:bodyPr rtlCol="0" anchor="ctr"/>
+          <a:lstStyle/>
+          <a:p>
+            <a:pPr algn="ctr"/>
+          </a:p>
+        </p:txBody>
+      </p:sp>
+      <p:sp>
+        <p:nvSpPr>
+          <p:cNvPr id="69" name="TextBox 68"/>
+          <p:cNvSpPr txBox="1"/>
+          <p:nvPr/>
+        </p:nvSpPr>
+        <p:spPr>
+          <a:xfrm>
+            <a:off x="8321040" y="2606040"/>
+            <a:ext cx="1143000" cy="274320"/>
+          </a:xfrm>
+          <a:prstGeom prst="rect">
+            <a:avLst/>
+          </a:prstGeom>
+          <a:noFill/>
+        </p:spPr>
+        <p:txBody>
+          <a:bodyPr wrap="square" lIns="36000" rIns="36000" tIns="18000" bIns="18000" anchor="ctr">
+            <a:spAutoFit/>
+          </a:bodyPr>
+          <a:lstStyle/>
+          <a:p>
+            <a:pPr algn="l"/>
+            <a:r>
+              <a:rPr sz="900" b="1" i="0" u="none">
+                <a:solidFill>
+                  <a:srgbClr val="FFFFFF"/>
+                </a:solidFill>
+                <a:latin typeface="Calibri"/>
+              </a:rPr>
+              <a:t>Sparte</a:t>
+            </a:r>
+          </a:p>
+        </p:txBody>
+      </p:sp>
+      <p:sp>
+        <p:nvSpPr>
+          <p:cNvPr id="70" name="TextBox 69"/>
+          <p:cNvSpPr txBox="1"/>
+          <p:nvPr/>
+        </p:nvSpPr>
+        <p:spPr>
+          <a:xfrm>
+            <a:off x="9464040" y="2606040"/>
+            <a:ext cx="1143000" cy="274320"/>
+          </a:xfrm>
+          <a:prstGeom prst="rect">
+            <a:avLst/>
+          </a:prstGeom>
+          <a:noFill/>
+        </p:spPr>
+        <p:txBody>
+          <a:bodyPr wrap="square" lIns="36000" rIns="36000" tIns="18000" bIns="18000" anchor="ctr">
+            <a:spAutoFit/>
+          </a:bodyPr>
+          <a:lstStyle/>
+          <a:p>
+            <a:pPr algn="ctr"/>
+            <a:r>
+              <a:rPr sz="900" b="1" i="0" u="none">
+                <a:solidFill>
+                  <a:srgbClr val="FFFFFF"/>
+                </a:solidFill>
+                <a:latin typeface="Calibri"/>
+              </a:rPr>
+              <a:t>BÜ-Anfr.</a:t>
+            </a:r>
+          </a:p>
+        </p:txBody>
+      </p:sp>
+      <p:sp>
+        <p:nvSpPr>
+          <p:cNvPr id="71" name="TextBox 70"/>
+          <p:cNvSpPr txBox="1"/>
+          <p:nvPr/>
+        </p:nvSpPr>
+        <p:spPr>
+          <a:xfrm>
+            <a:off x="10607040" y="2606040"/>
+            <a:ext cx="1143000" cy="274320"/>
+          </a:xfrm>
+          <a:prstGeom prst="rect">
+            <a:avLst/>
+          </a:prstGeom>
+          <a:noFill/>
+        </p:spPr>
+        <p:txBody>
+          <a:bodyPr wrap="square" lIns="36000" rIns="36000" tIns="18000" bIns="18000" anchor="ctr">
+            <a:spAutoFit/>
+          </a:bodyPr>
+          <a:lstStyle/>
+          <a:p>
+            <a:pPr algn="ctr"/>
+            <a:r>
+              <a:rPr sz="900" b="1" i="0" u="none">
+                <a:solidFill>
+                  <a:srgbClr val="FFFFFF"/>
+                </a:solidFill>
+                <a:latin typeface="Calibri"/>
+              </a:rPr>
+              <a:t>in Cluster</a:t>
+            </a:r>
+          </a:p>
+        </p:txBody>
+      </p:sp>
+      <p:sp>
+        <p:nvSpPr>
+          <p:cNvPr id="72" name="Rectangle 71"/>
+          <p:cNvSpPr/>
+          <p:nvPr/>
+        </p:nvSpPr>
+        <p:spPr>
+          <a:xfrm>
+            <a:off x="8321040" y="2880360"/>
+            <a:ext cx="3429000" cy="274320"/>
+          </a:xfrm>
+          <a:prstGeom prst="rect">
+            <a:avLst/>
+          </a:prstGeom>
+          <a:solidFill>
+            <a:srgbClr val="FDE2C4"/>
+          </a:solidFill>
+          <a:ln>
+            <a:noFill/>
+          </a:ln>
+          <a:effectLst/>
+        </p:spPr>
+        <p:style>
+          <a:lnRef idx="1">
+            <a:schemeClr val="accent1"/>
+          </a:lnRef>
+          <a:fillRef idx="3">
+            <a:schemeClr val="accent1"/>
+          </a:fillRef>
+          <a:effectRef idx="2">
+            <a:schemeClr val="accent1"/>
+          </a:effectRef>
+          <a:fontRef idx="minor">
+            <a:schemeClr val="lt1"/>
+          </a:fontRef>
+        </p:style>
+        <p:txBody>
+          <a:bodyPr rtlCol="0" anchor="ctr"/>
+          <a:lstStyle/>
+          <a:p>
+            <a:pPr algn="ctr"/>
+          </a:p>
+        </p:txBody>
+      </p:sp>
+      <p:sp>
+        <p:nvSpPr>
+          <p:cNvPr id="73" name="Rectangle 72"/>
+          <p:cNvSpPr/>
+          <p:nvPr/>
+        </p:nvSpPr>
+        <p:spPr>
+          <a:xfrm>
+            <a:off x="8321040" y="2880360"/>
+            <a:ext cx="73152" cy="274320"/>
+          </a:xfrm>
+          <a:prstGeom prst="rect">
+            <a:avLst/>
+          </a:prstGeom>
+          <a:solidFill>
+            <a:srgbClr val="E30613"/>
+          </a:solidFill>
+          <a:ln>
+            <a:noFill/>
+          </a:ln>
+          <a:effectLst/>
+        </p:spPr>
+        <p:style>
+          <a:lnRef idx="1">
+            <a:schemeClr val="accent1"/>
+          </a:lnRef>
+          <a:fillRef idx="3">
+            <a:schemeClr val="accent1"/>
+          </a:fillRef>
+          <a:effectRef idx="2">
+            <a:schemeClr val="accent1"/>
+          </a:effectRef>
+          <a:fontRef idx="minor">
+            <a:schemeClr val="lt1"/>
+          </a:fontRef>
+        </p:style>
+        <p:txBody>
+          <a:bodyPr rtlCol="0" anchor="ctr"/>
+          <a:lstStyle/>
+          <a:p>
+            <a:pPr algn="ctr"/>
+          </a:p>
+        </p:txBody>
+      </p:sp>
+      <p:sp>
+        <p:nvSpPr>
+          <p:cNvPr id="74" name="TextBox 73"/>
+          <p:cNvSpPr txBox="1"/>
+          <p:nvPr/>
+        </p:nvSpPr>
+        <p:spPr>
+          <a:xfrm>
+            <a:off x="8412480" y="2880360"/>
+            <a:ext cx="1051560" cy="274320"/>
+          </a:xfrm>
+          <a:prstGeom prst="rect">
+            <a:avLst/>
+          </a:prstGeom>
+          <a:noFill/>
+        </p:spPr>
+        <p:txBody>
+          <a:bodyPr wrap="square" lIns="36000" rIns="36000" tIns="18000" bIns="18000" anchor="ctr">
+            <a:spAutoFit/>
+          </a:bodyPr>
+          <a:lstStyle/>
+          <a:p>
+            <a:pPr algn="l"/>
+            <a:r>
+              <a:rPr sz="900" b="1" i="0" u="none">
+                <a:solidFill>
+                  <a:srgbClr val="9C060F"/>
+                </a:solidFill>
+                <a:latin typeface="Calibri"/>
+              </a:rPr>
+              <a:t>KV</a:t>
+            </a:r>
+          </a:p>
+        </p:txBody>
+      </p:sp>
+      <p:sp>
+        <p:nvSpPr>
+          <p:cNvPr id="75" name="TextBox 74"/>
+          <p:cNvSpPr txBox="1"/>
+          <p:nvPr/>
+        </p:nvSpPr>
+        <p:spPr>
+          <a:xfrm>
+            <a:off x="9464040" y="2880360"/>
+            <a:ext cx="1143000" cy="274320"/>
+          </a:xfrm>
+          <a:prstGeom prst="rect">
+            <a:avLst/>
+          </a:prstGeom>
+          <a:noFill/>
+        </p:spPr>
+        <p:txBody>
+          <a:bodyPr wrap="square" lIns="36000" rIns="36000" tIns="18000" bIns="18000" anchor="ctr">
+            <a:spAutoFit/>
+          </a:bodyPr>
+          <a:lstStyle/>
+          <a:p>
+            <a:pPr algn="ctr"/>
+            <a:r>
+              <a:rPr sz="900" b="1" i="0" u="none">
+                <a:solidFill>
+                  <a:srgbClr val="9C060F"/>
+                </a:solidFill>
+                <a:latin typeface="Calibri"/>
+              </a:rPr>
+              <a:t>1.147</a:t>
+            </a:r>
+          </a:p>
+        </p:txBody>
+      </p:sp>
+      <p:sp>
+        <p:nvSpPr>
+          <p:cNvPr id="76" name="TextBox 75"/>
+          <p:cNvSpPr txBox="1"/>
+          <p:nvPr/>
+        </p:nvSpPr>
+        <p:spPr>
+          <a:xfrm>
+            <a:off x="10607040" y="2880360"/>
+            <a:ext cx="1143000" cy="274320"/>
+          </a:xfrm>
+          <a:prstGeom prst="rect">
+            <a:avLst/>
+          </a:prstGeom>
+          <a:noFill/>
+        </p:spPr>
+        <p:txBody>
+          <a:bodyPr wrap="square" lIns="36000" rIns="36000" tIns="18000" bIns="18000" anchor="ctr">
+            <a:spAutoFit/>
+          </a:bodyPr>
+          <a:lstStyle/>
+          <a:p>
+            <a:pPr algn="ctr"/>
+            <a:r>
+              <a:rPr sz="900" b="1" i="0" u="none">
+                <a:solidFill>
+                  <a:srgbClr val="9C060F"/>
+                </a:solidFill>
+                <a:latin typeface="Calibri"/>
+              </a:rPr>
+              <a:t>354 (31 %)</a:t>
+            </a:r>
+          </a:p>
+        </p:txBody>
+      </p:sp>
+      <p:sp>
+        <p:nvSpPr>
+          <p:cNvPr id="77" name="Rectangle 76"/>
+          <p:cNvSpPr/>
+          <p:nvPr/>
+        </p:nvSpPr>
+        <p:spPr>
+          <a:xfrm>
+            <a:off x="8321040" y="3154680"/>
+            <a:ext cx="3429000" cy="274320"/>
+          </a:xfrm>
+          <a:prstGeom prst="rect">
+            <a:avLst/>
+          </a:prstGeom>
+          <a:solidFill>
+            <a:srgbClr val="E3ECEE"/>
+          </a:solidFill>
+          <a:ln>
+            <a:noFill/>
+          </a:ln>
+          <a:effectLst/>
+        </p:spPr>
+        <p:style>
+          <a:lnRef idx="1">
+            <a:schemeClr val="accent1"/>
+          </a:lnRef>
+          <a:fillRef idx="3">
+            <a:schemeClr val="accent1"/>
+          </a:fillRef>
+          <a:effectRef idx="2">
+            <a:schemeClr val="accent1"/>
+          </a:effectRef>
+          <a:fontRef idx="minor">
+            <a:schemeClr val="lt1"/>
+          </a:fontRef>
+        </p:style>
+        <p:txBody>
+          <a:bodyPr rtlCol="0" anchor="ctr"/>
+          <a:lstStyle/>
+          <a:p>
+            <a:pPr algn="ctr"/>
+          </a:p>
+        </p:txBody>
+      </p:sp>
+      <p:sp>
+        <p:nvSpPr>
+          <p:cNvPr id="78" name="TextBox 77"/>
+          <p:cNvSpPr txBox="1"/>
+          <p:nvPr/>
+        </p:nvSpPr>
+        <p:spPr>
+          <a:xfrm>
+            <a:off x="8412480" y="3154680"/>
+            <a:ext cx="1051560" cy="274320"/>
+          </a:xfrm>
+          <a:prstGeom prst="rect">
+            <a:avLst/>
+          </a:prstGeom>
+          <a:noFill/>
+        </p:spPr>
+        <p:txBody>
+          <a:bodyPr wrap="square" lIns="36000" rIns="36000" tIns="18000" bIns="18000" anchor="ctr">
+            <a:spAutoFit/>
+          </a:bodyPr>
+          <a:lstStyle/>
+          <a:p>
+            <a:pPr algn="l"/>
+            <a:r>
+              <a:rPr sz="900" b="1" i="0" u="none">
+                <a:solidFill>
+                  <a:srgbClr val="333333"/>
+                </a:solidFill>
+                <a:latin typeface="Calibri"/>
+              </a:rPr>
+              <a:t>Komposit</a:t>
+            </a:r>
+          </a:p>
+        </p:txBody>
+      </p:sp>
+      <p:sp>
+        <p:nvSpPr>
+          <p:cNvPr id="79" name="TextBox 78"/>
+          <p:cNvSpPr txBox="1"/>
+          <p:nvPr/>
+        </p:nvSpPr>
+        <p:spPr>
+          <a:xfrm>
+            <a:off x="9464040" y="3154680"/>
+            <a:ext cx="1143000" cy="274320"/>
+          </a:xfrm>
+          <a:prstGeom prst="rect">
+            <a:avLst/>
+          </a:prstGeom>
+          <a:noFill/>
+        </p:spPr>
+        <p:txBody>
+          <a:bodyPr wrap="square" lIns="36000" rIns="36000" tIns="18000" bIns="18000" anchor="ctr">
+            <a:spAutoFit/>
+          </a:bodyPr>
+          <a:lstStyle/>
+          <a:p>
+            <a:pPr algn="ctr"/>
+            <a:r>
+              <a:rPr sz="900" b="0" i="0" u="none">
+                <a:solidFill>
+                  <a:srgbClr val="333333"/>
+                </a:solidFill>
+                <a:latin typeface="Calibri"/>
+              </a:rPr>
+              <a:t>2.089</a:t>
+            </a:r>
+          </a:p>
+        </p:txBody>
+      </p:sp>
+      <p:sp>
+        <p:nvSpPr>
+          <p:cNvPr id="80" name="TextBox 79"/>
+          <p:cNvSpPr txBox="1"/>
+          <p:nvPr/>
+        </p:nvSpPr>
+        <p:spPr>
+          <a:xfrm>
+            <a:off x="10607040" y="3154680"/>
+            <a:ext cx="1143000" cy="274320"/>
+          </a:xfrm>
+          <a:prstGeom prst="rect">
+            <a:avLst/>
+          </a:prstGeom>
+          <a:noFill/>
+        </p:spPr>
+        <p:txBody>
+          <a:bodyPr wrap="square" lIns="36000" rIns="36000" tIns="18000" bIns="18000" anchor="ctr">
+            <a:spAutoFit/>
+          </a:bodyPr>
+          <a:lstStyle/>
+          <a:p>
+            <a:pPr algn="ctr"/>
+            <a:r>
+              <a:rPr sz="900" b="0" i="0" u="none">
+                <a:solidFill>
+                  <a:srgbClr val="333333"/>
+                </a:solidFill>
+                <a:latin typeface="Calibri"/>
+              </a:rPr>
+              <a:t>1.405 (67 %)</a:t>
+            </a:r>
+          </a:p>
+        </p:txBody>
+      </p:sp>
+      <p:sp>
+        <p:nvSpPr>
+          <p:cNvPr id="81" name="Rectangle 80"/>
+          <p:cNvSpPr/>
+          <p:nvPr/>
+        </p:nvSpPr>
+        <p:spPr>
+          <a:xfrm>
+            <a:off x="8321040" y="3429000"/>
+            <a:ext cx="3429000" cy="274320"/>
+          </a:xfrm>
+          <a:prstGeom prst="rect">
+            <a:avLst/>
+          </a:prstGeom>
+          <a:solidFill>
+            <a:srgbClr val="FFFFFF"/>
+          </a:solidFill>
+          <a:ln>
+            <a:noFill/>
+          </a:ln>
+          <a:effectLst/>
+        </p:spPr>
+        <p:style>
+          <a:lnRef idx="1">
+            <a:schemeClr val="accent1"/>
+          </a:lnRef>
+          <a:fillRef idx="3">
+            <a:schemeClr val="accent1"/>
+          </a:fillRef>
+          <a:effectRef idx="2">
+            <a:schemeClr val="accent1"/>
+          </a:effectRef>
+          <a:fontRef idx="minor">
+            <a:schemeClr val="lt1"/>
+          </a:fontRef>
+        </p:style>
+        <p:txBody>
+          <a:bodyPr rtlCol="0" anchor="ctr"/>
+          <a:lstStyle/>
+          <a:p>
+            <a:pPr algn="ctr"/>
+          </a:p>
+        </p:txBody>
+      </p:sp>
+      <p:sp>
+        <p:nvSpPr>
+          <p:cNvPr id="82" name="TextBox 81"/>
+          <p:cNvSpPr txBox="1"/>
+          <p:nvPr/>
+        </p:nvSpPr>
+        <p:spPr>
+          <a:xfrm>
+            <a:off x="8412480" y="3429000"/>
+            <a:ext cx="1051560" cy="274320"/>
+          </a:xfrm>
+          <a:prstGeom prst="rect">
+            <a:avLst/>
+          </a:prstGeom>
+          <a:noFill/>
+        </p:spPr>
+        <p:txBody>
+          <a:bodyPr wrap="square" lIns="36000" rIns="36000" tIns="18000" bIns="18000" anchor="ctr">
+            <a:spAutoFit/>
+          </a:bodyPr>
+          <a:lstStyle/>
+          <a:p>
+            <a:pPr algn="l"/>
+            <a:r>
+              <a:rPr sz="900" b="1" i="0" u="none">
+                <a:solidFill>
+                  <a:srgbClr val="333333"/>
+                </a:solidFill>
+                <a:latin typeface="Calibri"/>
+              </a:rPr>
+              <a:t>Leben</a:t>
+            </a:r>
+          </a:p>
+        </p:txBody>
+      </p:sp>
+      <p:sp>
+        <p:nvSpPr>
+          <p:cNvPr id="83" name="TextBox 82"/>
+          <p:cNvSpPr txBox="1"/>
+          <p:nvPr/>
+        </p:nvSpPr>
+        <p:spPr>
+          <a:xfrm>
+            <a:off x="9464040" y="3429000"/>
+            <a:ext cx="1143000" cy="274320"/>
+          </a:xfrm>
+          <a:prstGeom prst="rect">
+            <a:avLst/>
+          </a:prstGeom>
+          <a:noFill/>
+        </p:spPr>
+        <p:txBody>
+          <a:bodyPr wrap="square" lIns="36000" rIns="36000" tIns="18000" bIns="18000" anchor="ctr">
+            <a:spAutoFit/>
+          </a:bodyPr>
+          <a:lstStyle/>
+          <a:p>
+            <a:pPr algn="ctr"/>
+            <a:r>
+              <a:rPr sz="900" b="0" i="0" u="none">
+                <a:solidFill>
+                  <a:srgbClr val="333333"/>
+                </a:solidFill>
+                <a:latin typeface="Calibri"/>
+              </a:rPr>
+              <a:t>662</a:t>
+            </a:r>
+          </a:p>
+        </p:txBody>
+      </p:sp>
+      <p:sp>
+        <p:nvSpPr>
+          <p:cNvPr id="84" name="TextBox 83"/>
+          <p:cNvSpPr txBox="1"/>
+          <p:nvPr/>
+        </p:nvSpPr>
+        <p:spPr>
+          <a:xfrm>
+            <a:off x="10607040" y="3429000"/>
+            <a:ext cx="1143000" cy="274320"/>
+          </a:xfrm>
+          <a:prstGeom prst="rect">
+            <a:avLst/>
+          </a:prstGeom>
+          <a:noFill/>
+        </p:spPr>
+        <p:txBody>
+          <a:bodyPr wrap="square" lIns="36000" rIns="36000" tIns="18000" bIns="18000" anchor="ctr">
+            <a:spAutoFit/>
+          </a:bodyPr>
+          <a:lstStyle/>
+          <a:p>
+            <a:pPr algn="ctr"/>
+            <a:r>
+              <a:rPr sz="900" b="0" i="0" u="none">
+                <a:solidFill>
+                  <a:srgbClr val="333333"/>
+                </a:solidFill>
+                <a:latin typeface="Calibri"/>
+              </a:rPr>
+              <a:t>325 (49 %)</a:t>
+            </a:r>
+          </a:p>
+        </p:txBody>
+      </p:sp>
+      <p:sp>
+        <p:nvSpPr>
+          <p:cNvPr id="85" name="Rectangle 84"/>
+          <p:cNvSpPr/>
+          <p:nvPr/>
+        </p:nvSpPr>
+        <p:spPr>
+          <a:xfrm>
+            <a:off x="8321040" y="3703320"/>
+            <a:ext cx="3429000" cy="274320"/>
+          </a:xfrm>
+          <a:prstGeom prst="rect">
+            <a:avLst/>
+          </a:prstGeom>
+          <a:solidFill>
+            <a:srgbClr val="E3ECEE"/>
+          </a:solidFill>
+          <a:ln>
+            <a:noFill/>
+          </a:ln>
+          <a:effectLst/>
+        </p:spPr>
+        <p:style>
+          <a:lnRef idx="1">
+            <a:schemeClr val="accent1"/>
+          </a:lnRef>
+          <a:fillRef idx="3">
+            <a:schemeClr val="accent1"/>
+          </a:fillRef>
+          <a:effectRef idx="2">
+            <a:schemeClr val="accent1"/>
+          </a:effectRef>
+          <a:fontRef idx="minor">
+            <a:schemeClr val="lt1"/>
+          </a:fontRef>
+        </p:style>
+        <p:txBody>
+          <a:bodyPr rtlCol="0" anchor="ctr"/>
+          <a:lstStyle/>
+          <a:p>
+            <a:pPr algn="ctr"/>
+          </a:p>
+        </p:txBody>
+      </p:sp>
+      <p:sp>
+        <p:nvSpPr>
+          <p:cNvPr id="86" name="TextBox 85"/>
+          <p:cNvSpPr txBox="1"/>
+          <p:nvPr/>
+        </p:nvSpPr>
+        <p:spPr>
+          <a:xfrm>
+            <a:off x="8412480" y="3703320"/>
+            <a:ext cx="1051560" cy="274320"/>
+          </a:xfrm>
+          <a:prstGeom prst="rect">
+            <a:avLst/>
+          </a:prstGeom>
+          <a:noFill/>
+        </p:spPr>
+        <p:txBody>
+          <a:bodyPr wrap="square" lIns="36000" rIns="36000" tIns="18000" bIns="18000" anchor="ctr">
+            <a:spAutoFit/>
+          </a:bodyPr>
+          <a:lstStyle/>
+          <a:p>
+            <a:pPr algn="l"/>
+            <a:r>
+              <a:rPr sz="900" b="1" i="0" u="none">
+                <a:solidFill>
+                  <a:srgbClr val="333333"/>
+                </a:solidFill>
+                <a:latin typeface="Calibri"/>
+              </a:rPr>
+              <a:t>Sonstige</a:t>
+            </a:r>
+          </a:p>
+        </p:txBody>
+      </p:sp>
+      <p:sp>
+        <p:nvSpPr>
+          <p:cNvPr id="87" name="TextBox 86"/>
+          <p:cNvSpPr txBox="1"/>
+          <p:nvPr/>
+        </p:nvSpPr>
+        <p:spPr>
+          <a:xfrm>
+            <a:off x="9464040" y="3703320"/>
+            <a:ext cx="1143000" cy="274320"/>
+          </a:xfrm>
+          <a:prstGeom prst="rect">
+            <a:avLst/>
+          </a:prstGeom>
+          <a:noFill/>
+        </p:spPr>
+        <p:txBody>
+          <a:bodyPr wrap="square" lIns="36000" rIns="36000" tIns="18000" bIns="18000" anchor="ctr">
+            <a:spAutoFit/>
+          </a:bodyPr>
+          <a:lstStyle/>
+          <a:p>
+            <a:pPr algn="ctr"/>
+            <a:r>
+              <a:rPr sz="900" b="0" i="0" u="none">
+                <a:solidFill>
+                  <a:srgbClr val="333333"/>
+                </a:solidFill>
+                <a:latin typeface="Calibri"/>
+              </a:rPr>
+              <a:t>102</a:t>
+            </a:r>
+          </a:p>
+        </p:txBody>
+      </p:sp>
+      <p:sp>
+        <p:nvSpPr>
+          <p:cNvPr id="88" name="TextBox 87"/>
+          <p:cNvSpPr txBox="1"/>
+          <p:nvPr/>
+        </p:nvSpPr>
+        <p:spPr>
+          <a:xfrm>
+            <a:off x="10607040" y="3703320"/>
+            <a:ext cx="1143000" cy="274320"/>
+          </a:xfrm>
+          <a:prstGeom prst="rect">
+            <a:avLst/>
+          </a:prstGeom>
+          <a:noFill/>
+        </p:spPr>
+        <p:txBody>
+          <a:bodyPr wrap="square" lIns="36000" rIns="36000" tIns="18000" bIns="18000" anchor="ctr">
+            <a:spAutoFit/>
+          </a:bodyPr>
+          <a:lstStyle/>
+          <a:p>
+            <a:pPr algn="ctr"/>
+            <a:r>
+              <a:rPr sz="900" b="0" i="0" u="none">
+                <a:solidFill>
+                  <a:srgbClr val="333333"/>
+                </a:solidFill>
+                <a:latin typeface="Calibri"/>
+              </a:rPr>
+              <a:t>33 (32 %)</a:t>
+            </a:r>
+          </a:p>
+        </p:txBody>
+      </p:sp>
+      <p:sp>
+        <p:nvSpPr>
+          <p:cNvPr id="89" name="Rectangle 88"/>
+          <p:cNvSpPr/>
+          <p:nvPr/>
+        </p:nvSpPr>
+        <p:spPr>
+          <a:xfrm>
+            <a:off x="8321040" y="3977640"/>
+            <a:ext cx="3429000" cy="274320"/>
+          </a:xfrm>
+          <a:prstGeom prst="rect">
+            <a:avLst/>
+          </a:prstGeom>
+          <a:solidFill>
+            <a:srgbClr val="E9EFF1"/>
+          </a:solidFill>
+          <a:ln>
+            <a:noFill/>
+          </a:ln>
+          <a:effectLst/>
+        </p:spPr>
+        <p:style>
+          <a:lnRef idx="1">
+            <a:schemeClr val="accent1"/>
+          </a:lnRef>
+          <a:fillRef idx="3">
+            <a:schemeClr val="accent1"/>
+          </a:fillRef>
+          <a:effectRef idx="2">
+            <a:schemeClr val="accent1"/>
+          </a:effectRef>
+          <a:fontRef idx="minor">
+            <a:schemeClr val="lt1"/>
+          </a:fontRef>
+        </p:style>
+        <p:txBody>
+          <a:bodyPr rtlCol="0" anchor="ctr"/>
+          <a:lstStyle/>
+          <a:p>
+            <a:pPr algn="ctr"/>
+          </a:p>
+        </p:txBody>
+      </p:sp>
+      <p:sp>
+        <p:nvSpPr>
+          <p:cNvPr id="90" name="TextBox 89"/>
+          <p:cNvSpPr txBox="1"/>
+          <p:nvPr/>
+        </p:nvSpPr>
+        <p:spPr>
+          <a:xfrm>
+            <a:off x="8412480" y="3977640"/>
+            <a:ext cx="1051560" cy="274320"/>
+          </a:xfrm>
+          <a:prstGeom prst="rect">
+            <a:avLst/>
+          </a:prstGeom>
+          <a:noFill/>
+        </p:spPr>
+        <p:txBody>
+          <a:bodyPr wrap="square" lIns="36000" rIns="36000" tIns="18000" bIns="18000" anchor="ctr">
+            <a:spAutoFit/>
+          </a:bodyPr>
+          <a:lstStyle/>
+          <a:p>
+            <a:pPr algn="l"/>
+            <a:r>
+              <a:rPr sz="900" b="1" i="0" u="none">
+                <a:solidFill>
+                  <a:srgbClr val="333333"/>
+                </a:solidFill>
+                <a:latin typeface="Calibri"/>
+              </a:rPr>
+              <a:t>Gesamt</a:t>
+            </a:r>
+          </a:p>
+        </p:txBody>
+      </p:sp>
+      <p:sp>
+        <p:nvSpPr>
+          <p:cNvPr id="91" name="TextBox 90"/>
+          <p:cNvSpPr txBox="1"/>
+          <p:nvPr/>
+        </p:nvSpPr>
+        <p:spPr>
+          <a:xfrm>
+            <a:off x="9464040" y="3977640"/>
+            <a:ext cx="1143000" cy="274320"/>
+          </a:xfrm>
+          <a:prstGeom prst="rect">
+            <a:avLst/>
+          </a:prstGeom>
+          <a:noFill/>
+        </p:spPr>
+        <p:txBody>
+          <a:bodyPr wrap="square" lIns="36000" rIns="36000" tIns="18000" bIns="18000" anchor="ctr">
+            <a:spAutoFit/>
+          </a:bodyPr>
+          <a:lstStyle/>
+          <a:p>
+            <a:pPr algn="ctr"/>
+            <a:r>
+              <a:rPr sz="900" b="1" i="0" u="none">
+                <a:solidFill>
+                  <a:srgbClr val="333333"/>
+                </a:solidFill>
+                <a:latin typeface="Calibri"/>
+              </a:rPr>
+              <a:t>4.000</a:t>
+            </a:r>
+          </a:p>
+        </p:txBody>
+      </p:sp>
+      <p:sp>
+        <p:nvSpPr>
+          <p:cNvPr id="92" name="TextBox 91"/>
+          <p:cNvSpPr txBox="1"/>
+          <p:nvPr/>
+        </p:nvSpPr>
+        <p:spPr>
+          <a:xfrm>
+            <a:off x="10607040" y="3977640"/>
+            <a:ext cx="1143000" cy="274320"/>
+          </a:xfrm>
+          <a:prstGeom prst="rect">
+            <a:avLst/>
+          </a:prstGeom>
+          <a:noFill/>
+        </p:spPr>
+        <p:txBody>
+          <a:bodyPr wrap="square" lIns="36000" rIns="36000" tIns="18000" bIns="18000" anchor="ctr">
+            <a:spAutoFit/>
+          </a:bodyPr>
+          <a:lstStyle/>
+          <a:p>
+            <a:pPr algn="ctr"/>
+            <a:r>
+              <a:rPr sz="900" b="1" i="0" u="none">
+                <a:solidFill>
+                  <a:srgbClr val="333333"/>
+                </a:solidFill>
+                <a:latin typeface="Calibri"/>
+              </a:rPr>
+              <a:t>2.117 (53 %)</a:t>
+            </a:r>
+          </a:p>
+        </p:txBody>
+      </p:sp>
+      <p:sp>
+        <p:nvSpPr>
+          <p:cNvPr id="93" name="TextBox 92"/>
+          <p:cNvSpPr txBox="1"/>
+          <p:nvPr/>
+        </p:nvSpPr>
+        <p:spPr>
+          <a:xfrm>
+            <a:off x="8339328" y="4270248"/>
+            <a:ext cx="3392424" cy="256032"/>
+          </a:xfrm>
+          <a:prstGeom prst="rect">
+            <a:avLst/>
+          </a:prstGeom>
+          <a:noFill/>
+        </p:spPr>
+        <p:txBody>
+          <a:bodyPr wrap="square" lIns="36000" rIns="36000" tIns="18000" bIns="18000" anchor="t">
+            <a:spAutoFit/>
+          </a:bodyPr>
+          <a:lstStyle/>
+          <a:p>
+            <a:pPr algn="l"/>
+            <a:r>
+              <a:rPr sz="900" b="0" i="1" u="none">
+                <a:solidFill>
+                  <a:srgbClr val="9C060F"/>
+                </a:solidFill>
+                <a:latin typeface="Calibri"/>
+              </a:rPr>
+              <a:t>KV: kein VNR-Mapping → jede Mail = eigener Vorgang</a:t>
+            </a:r>
+          </a:p>
+        </p:txBody>
+      </p:sp>
+      <p:sp>
+        <p:nvSpPr>
+          <p:cNvPr id="94" name="Oval 93"/>
+          <p:cNvSpPr/>
+          <p:nvPr/>
+        </p:nvSpPr>
+        <p:spPr>
+          <a:xfrm>
+            <a:off x="8366760" y="4617720"/>
             <a:ext cx="384048" cy="384048"/>
           </a:xfrm>
           <a:prstGeom prst="ellipse">
@@ -10030,13 +11073,13 @@
       </p:sp>
       <p:sp>
         <p:nvSpPr>
-          <p:cNvPr id="68" name="TextBox 67"/>
-          <p:cNvSpPr txBox="1"/>
-          <p:nvPr/>
-        </p:nvSpPr>
-        <p:spPr>
-          <a:xfrm>
-            <a:off x="8394192" y="2441448"/>
+          <p:cNvPr id="95" name="TextBox 94"/>
+          <p:cNvSpPr txBox="1"/>
+          <p:nvPr/>
+        </p:nvSpPr>
+        <p:spPr>
+          <a:xfrm>
+            <a:off x="8366760" y="4617720"/>
             <a:ext cx="384048" cy="384048"/>
           </a:xfrm>
           <a:prstGeom prst="rect">
@@ -10065,14 +11108,14 @@
       </p:sp>
       <p:sp>
         <p:nvSpPr>
-          <p:cNvPr id="69" name="TextBox 68"/>
-          <p:cNvSpPr txBox="1"/>
-          <p:nvPr/>
-        </p:nvSpPr>
-        <p:spPr>
-          <a:xfrm>
-            <a:off x="8887968" y="2404872"/>
-            <a:ext cx="2834640" cy="292608"/>
+          <p:cNvPr id="96" name="TextBox 95"/>
+          <p:cNvSpPr txBox="1"/>
+          <p:nvPr/>
+        </p:nvSpPr>
+        <p:spPr>
+          <a:xfrm>
+            <a:off x="8851392" y="4599432"/>
+            <a:ext cx="2880360" cy="256032"/>
           </a:xfrm>
           <a:prstGeom prst="rect">
             <a:avLst/>
@@ -10087,27 +11130,27 @@
           <a:p>
             <a:pPr algn="l"/>
             <a:r>
-              <a:rPr sz="1300" b="1" i="0" u="none">
+              <a:rPr sz="1200" b="1" i="0" u="none">
                 <a:solidFill>
                   <a:srgbClr val="333333"/>
                 </a:solidFill>
                 <a:latin typeface="Calibri"/>
               </a:rPr>
-              <a:t>Erkenntnis: heute nicht auffindbar</a:t>
-            </a:r>
-          </a:p>
-        </p:txBody>
-      </p:sp>
-      <p:sp>
-        <p:nvSpPr>
-          <p:cNvPr id="70" name="TextBox 69"/>
-          <p:cNvSpPr txBox="1"/>
-          <p:nvPr/>
-        </p:nvSpPr>
-        <p:spPr>
-          <a:xfrm>
-            <a:off x="8887968" y="2697480"/>
-            <a:ext cx="2788920" cy="1376172"/>
+              <a:t>Erkenntnis</a:t>
+            </a:r>
+          </a:p>
+        </p:txBody>
+      </p:sp>
+      <p:sp>
+        <p:nvSpPr>
+          <p:cNvPr id="97" name="TextBox 96"/>
+          <p:cNvSpPr txBox="1"/>
+          <p:nvPr/>
+        </p:nvSpPr>
+        <p:spPr>
+          <a:xfrm>
+            <a:off x="8851392" y="4855464"/>
+            <a:ext cx="2834640" cy="502920"/>
           </a:xfrm>
           <a:prstGeom prst="rect">
             <a:avLst/>
@@ -10122,26 +11165,26 @@
           <a:p>
             <a:pPr algn="l"/>
             <a:r>
-              <a:rPr sz="1100" b="0" i="0" u="none">
+              <a:rPr sz="1000" b="0" i="0" u="none">
                 <a:solidFill>
                   <a:srgbClr val="333333"/>
                 </a:solidFill>
                 <a:latin typeface="Calibri"/>
               </a:rPr>
-              <a:t>Zusammenhängende Vorgänge (selber Makler / Kunde) und die Last je Makler lassen sich im Postkorb heute nicht gezielt finden — Sachbearbeiter arbeiten unsortiert Mail für Mail ab.</a:t>
-            </a:r>
-          </a:p>
-        </p:txBody>
-      </p:sp>
-      <p:sp>
-        <p:nvSpPr>
-          <p:cNvPr id="71" name="Oval 70"/>
+              <a:t>Diese Vorgänge sind im Postkorb heute nicht auffindbar.</a:t>
+            </a:r>
+          </a:p>
+        </p:txBody>
+      </p:sp>
+      <p:sp>
+        <p:nvSpPr>
+          <p:cNvPr id="98" name="Oval 97"/>
           <p:cNvSpPr/>
           <p:nvPr/>
         </p:nvSpPr>
         <p:spPr>
           <a:xfrm>
-            <a:off x="8394192" y="4110228"/>
+            <a:off x="8366760" y="5394960"/>
             <a:ext cx="384048" cy="384048"/>
           </a:xfrm>
           <a:prstGeom prst="ellipse">
@@ -10181,13 +11224,13 @@
       </p:sp>
       <p:sp>
         <p:nvSpPr>
-          <p:cNvPr id="72" name="TextBox 71"/>
-          <p:cNvSpPr txBox="1"/>
-          <p:nvPr/>
-        </p:nvSpPr>
-        <p:spPr>
-          <a:xfrm>
-            <a:off x="8394192" y="4110228"/>
+          <p:cNvPr id="99" name="TextBox 98"/>
+          <p:cNvSpPr txBox="1"/>
+          <p:nvPr/>
+        </p:nvSpPr>
+        <p:spPr>
+          <a:xfrm>
+            <a:off x="8366760" y="5394960"/>
             <a:ext cx="384048" cy="384048"/>
           </a:xfrm>
           <a:prstGeom prst="rect">
@@ -10216,14 +11259,14 @@
       </p:sp>
       <p:sp>
         <p:nvSpPr>
-          <p:cNvPr id="73" name="TextBox 72"/>
-          <p:cNvSpPr txBox="1"/>
-          <p:nvPr/>
-        </p:nvSpPr>
-        <p:spPr>
-          <a:xfrm>
-            <a:off x="8887968" y="4073652"/>
-            <a:ext cx="2834640" cy="292608"/>
+          <p:cNvPr id="100" name="TextBox 99"/>
+          <p:cNvSpPr txBox="1"/>
+          <p:nvPr/>
+        </p:nvSpPr>
+        <p:spPr>
+          <a:xfrm>
+            <a:off x="8851392" y="5376672"/>
+            <a:ext cx="2880360" cy="256032"/>
           </a:xfrm>
           <a:prstGeom prst="rect">
             <a:avLst/>
@@ -10238,27 +11281,27 @@
           <a:p>
             <a:pPr algn="l"/>
             <a:r>
-              <a:rPr sz="1300" b="1" i="0" u="none">
+              <a:rPr sz="1200" b="1" i="0" u="none">
                 <a:solidFill>
                   <a:srgbClr val="333333"/>
                 </a:solidFill>
                 <a:latin typeface="Calibri"/>
               </a:rPr>
-              <a:t>Möglichkeit: gezielt abarbeiten</a:t>
-            </a:r>
-          </a:p>
-        </p:txBody>
-      </p:sp>
-      <p:sp>
-        <p:nvSpPr>
-          <p:cNvPr id="74" name="TextBox 73"/>
-          <p:cNvSpPr txBox="1"/>
-          <p:nvPr/>
-        </p:nvSpPr>
-        <p:spPr>
-          <a:xfrm>
-            <a:off x="8887968" y="4366260"/>
-            <a:ext cx="2788920" cy="1376172"/>
+              <a:t>Möglichkeit</a:t>
+            </a:r>
+          </a:p>
+        </p:txBody>
+      </p:sp>
+      <p:sp>
+        <p:nvSpPr>
+          <p:cNvPr id="101" name="TextBox 100"/>
+          <p:cNvSpPr txBox="1"/>
+          <p:nvPr/>
+        </p:nvSpPr>
+        <p:spPr>
+          <a:xfrm>
+            <a:off x="8851392" y="5632704"/>
+            <a:ext cx="2834640" cy="685800"/>
           </a:xfrm>
           <a:prstGeom prst="rect">
             <a:avLst/>
@@ -10273,20 +11316,20 @@
           <a:p>
             <a:pPr algn="l"/>
             <a:r>
-              <a:rPr sz="1100" b="0" i="0" u="none">
+              <a:rPr sz="1000" b="0" i="0" u="none">
                 <a:solidFill>
                   <a:srgbClr val="333333"/>
                 </a:solidFill>
                 <a:latin typeface="Calibri"/>
               </a:rPr>
-              <a:t>Strukturierung + Excel erlauben Arbeitsvorrats-Steuerung: z. B. alle Vorgänge eines Prio-Maklers (Top-5 = 57 %) oder alle Vorgänge mit Cluster gebündelt abarbeiten.</a:t>
-            </a:r>
-          </a:p>
-        </p:txBody>
-      </p:sp>
-      <p:sp>
-        <p:nvSpPr>
-          <p:cNvPr id="75" name="TextBox 74"/>
+              <a:t>Strukturierung + Excel: gezielt alle Vorgänge eines Prio-Maklers oder alle mit Cluster gebündelt abarbeiten.</a:t>
+            </a:r>
+          </a:p>
+        </p:txBody>
+      </p:sp>
+      <p:sp>
+        <p:nvSpPr>
+          <p:cNvPr id="102" name="TextBox 101"/>
           <p:cNvSpPr txBox="1"/>
           <p:nvPr/>
         </p:nvSpPr>
@@ -10321,7 +11364,7 @@
       </p:sp>
       <p:sp>
         <p:nvSpPr>
-          <p:cNvPr id="76" name="Rectangle 75"/>
+          <p:cNvPr id="103" name="Rectangle 102"/>
           <p:cNvSpPr/>
           <p:nvPr/>
         </p:nvSpPr>
@@ -10365,7 +11408,7 @@
       </p:sp>
       <p:sp>
         <p:nvSpPr>
-          <p:cNvPr id="77" name="TextBox 76"/>
+          <p:cNvPr id="104" name="TextBox 103"/>
           <p:cNvSpPr txBox="1"/>
           <p:nvPr/>
         </p:nvSpPr>
@@ -10393,7 +11436,7 @@
                 </a:solidFill>
                 <a:latin typeface="Calibri"/>
               </a:rPr>
-              <a:t>TAKE-AWAY:  57 % der Mails kommen von 5 Maklern, 47 % hängen in Clustern — heute im Postkorb nicht auffindbar. Strukturierung + Excel ermöglichen gezieltes Abarbeiten nach Prio-Makler und Cluster.</a:t>
+              <a:t>TAKE-AWAY:  65 % der BÜ-Anfragen kommen von 5 Maklern, 53 % hängen in Clustern (KV ohne VNR-Mapping) — heute nicht auffindbar. Strukturierung + Excel ermöglichen gezieltes Abarbeiten nach Prio-Makler und Cluster.</a:t>
             </a:r>
           </a:p>
         </p:txBody>

</xml_diff>

<commit_message>
PPTX Folie 12: echte PowerPoint-Tabellen statt gemalter Rechtecke
Vorher: Tabelle aus einzelnen Boxen + Text-Frames -> beim Bearbeiten
verschiebbare Einzelelemente, keine echte Tabellenstruktur.
Jetzt: native slide.shapes.add_table(...) fuer beide Tabellen:
- Makler-Tabelle links (9 Zeilen x 4 Spalten):
  Top-5 + Summe + Long-Tail + Gesamt mit echter Tabellen-Auszeichnung
- Segment-Split-Tabelle rechts (6 Zeilen x 3 Spalten):
  KV (rot hervorgehoben) | Komposit | Leben | Sonstige | Gesamt
Helper add_real_table() mit Spaltenbreiten, Header-Fill (Teal),
Zellen-Styles (Header / Summe / Hervorhebung / Gesamt).

Beide Tabellen sind in PPT jetzt als Tabellen editierbar (Zellen ziehen,
Spaltenbreiten anpassen, Daten direkt eingeben).

https://claude.ai/code/session_01UknXtYp2XECsQDonCZuxSt
</commit_message>
<xml_diff>
--- a/ERGO-Mengengeruest-2Slides-Berichtslook.pptx
+++ b/ERGO-Mengengeruest-2Slides-Berichtslook.pptx
@@ -8012,7 +8012,7 @@
                 </a:solidFill>
                 <a:latin typeface="Calibri"/>
               </a:rPr>
-              <a:t>MENGENGERÜST: MAKLER &amp; CLUSTER</a:t>
+              <a:t>MENGENGERÜST: MAKLER &amp; CLUSTER*</a:t>
             </a:r>
           </a:p>
         </p:txBody>
@@ -8174,8 +8174,8 @@
         </p:nvSpPr>
         <p:spPr>
           <a:xfrm>
-            <a:off x="411480" y="2286000"/>
-            <a:ext cx="7635240" cy="274320"/>
+            <a:off x="411480" y="2331720"/>
+            <a:ext cx="7635240" cy="237744"/>
           </a:xfrm>
           <a:prstGeom prst="rect">
             <a:avLst/>
@@ -8190,7 +8190,7 @@
           <a:p>
             <a:pPr algn="l"/>
             <a:r>
-              <a:rPr sz="1100" b="0" i="1" u="none">
+              <a:rPr sz="1000" b="0" i="1" u="none">
                 <a:solidFill>
                   <a:srgbClr val="666666"/>
                 </a:solidFill>
@@ -8201,1672 +8201,794 @@
           </a:p>
         </p:txBody>
       </p:sp>
-      <p:sp>
-        <p:nvSpPr>
-          <p:cNvPr id="18" name="Rectangle 17"/>
+      <p:graphicFrame>
+        <p:nvGraphicFramePr>
+          <p:cNvPr id="18" name="Table 17"/>
+          <p:cNvGraphicFramePr>
+            <a:graphicFrameLocks noGrp="1"/>
+          </p:cNvGraphicFramePr>
+          <p:nvPr/>
+        </p:nvGraphicFramePr>
+        <p:xfrm>
+          <a:off x="411480" y="2587752"/>
+          <a:ext cx="7635240" cy="2505456"/>
+        </p:xfrm>
+        <a:graphic>
+          <a:graphicData uri="http://schemas.openxmlformats.org/drawingml/2006/table">
+            <a:tbl>
+              <a:tblPr bandRow="1">
+                <a:tableStyleId>{5C22544A-7EE6-4342-B048-85BDC9FD1C3A}</a:tableStyleId>
+              </a:tblPr>
+              <a:tblGrid>
+                <a:gridCol w="3063240"/>
+                <a:gridCol w="1508760"/>
+                <a:gridCol w="1508760"/>
+                <a:gridCol w="1554480"/>
+              </a:tblGrid>
+              <a:tr h="310896">
+                <a:tc>
+                  <a:txBody>
+                    <a:bodyPr lIns="36000" rIns="36000" tIns="18000" bIns="18000"/>
+                    <a:lstStyle/>
+                    <a:p>
+                      <a:pPr algn="l"/>
+                      <a:r>
+                        <a:rPr sz="1000" b="1" i="0">
+                          <a:solidFill>
+                            <a:srgbClr val="FFFFFF"/>
+                          </a:solidFill>
+                          <a:latin typeface="Calibri"/>
+                        </a:rPr>
+                        <a:t>Maklerpool</a:t>
+                      </a:r>
+                    </a:p>
+                  </a:txBody>
+                  <a:tcPr anchor="ctr">
+                    <a:solidFill>
+                      <a:srgbClr val="006B77"/>
+                    </a:solidFill>
+                  </a:tcPr>
+                </a:tc>
+                <a:tc>
+                  <a:txBody>
+                    <a:bodyPr lIns="36000" rIns="36000" tIns="18000" bIns="18000"/>
+                    <a:lstStyle/>
+                    <a:p>
+                      <a:pPr algn="ctr"/>
+                      <a:r>
+                        <a:rPr sz="1000" b="1" i="0">
+                          <a:solidFill>
+                            <a:srgbClr val="FFFFFF"/>
+                          </a:solidFill>
+                          <a:latin typeface="Calibri"/>
+                        </a:rPr>
+                        <a:t>BÜ-Anfragen / Wo</a:t>
+                      </a:r>
+                    </a:p>
+                  </a:txBody>
+                  <a:tcPr anchor="ctr">
+                    <a:solidFill>
+                      <a:srgbClr val="006B77"/>
+                    </a:solidFill>
+                  </a:tcPr>
+                </a:tc>
+                <a:tc>
+                  <a:txBody>
+                    <a:bodyPr lIns="36000" rIns="36000" tIns="18000" bIns="18000"/>
+                    <a:lstStyle/>
+                    <a:p>
+                      <a:pPr algn="ctr"/>
+                      <a:r>
+                        <a:rPr sz="1000" b="1" i="0">
+                          <a:solidFill>
+                            <a:srgbClr val="FFFFFF"/>
+                          </a:solidFill>
+                          <a:latin typeface="Calibri"/>
+                        </a:rPr>
+                        <a:t>Vorgänge</a:t>
+                      </a:r>
+                    </a:p>
+                  </a:txBody>
+                  <a:tcPr anchor="ctr">
+                    <a:solidFill>
+                      <a:srgbClr val="006B77"/>
+                    </a:solidFill>
+                  </a:tcPr>
+                </a:tc>
+                <a:tc>
+                  <a:txBody>
+                    <a:bodyPr lIns="36000" rIns="36000" tIns="18000" bIns="18000"/>
+                    <a:lstStyle/>
+                    <a:p>
+                      <a:pPr algn="ctr"/>
+                      <a:r>
+                        <a:rPr sz="1000" b="1" i="0">
+                          <a:solidFill>
+                            <a:srgbClr val="FFFFFF"/>
+                          </a:solidFill>
+                          <a:latin typeface="Calibri"/>
+                        </a:rPr>
+                        <a:t>Ø Mails / Vorgang</a:t>
+                      </a:r>
+                    </a:p>
+                  </a:txBody>
+                  <a:tcPr anchor="ctr">
+                    <a:solidFill>
+                      <a:srgbClr val="006B77"/>
+                    </a:solidFill>
+                  </a:tcPr>
+                </a:tc>
+              </a:tr>
+              <a:tr h="274320">
+                <a:tc>
+                  <a:txBody>
+                    <a:bodyPr lIns="36000" rIns="36000" tIns="18000" bIns="18000"/>
+                    <a:lstStyle/>
+                    <a:p>
+                      <a:pPr algn="l"/>
+                      <a:r>
+                        <a:rPr sz="1100" b="1" i="0">
+                          <a:solidFill>
+                            <a:srgbClr val="333333"/>
+                          </a:solidFill>
+                          <a:latin typeface="Calibri"/>
+                        </a:rPr>
+                        <a:t>JDC / Jung, DMS &amp; Cie.</a:t>
+                      </a:r>
+                    </a:p>
+                  </a:txBody>
+                  <a:tcPr anchor="ctr"/>
+                </a:tc>
+                <a:tc>
+                  <a:txBody>
+                    <a:bodyPr lIns="36000" rIns="36000" tIns="18000" bIns="18000"/>
+                    <a:lstStyle/>
+                    <a:p>
+                      <a:pPr algn="ctr"/>
+                      <a:r>
+                        <a:rPr sz="1100" b="0" i="0">
+                          <a:solidFill>
+                            <a:srgbClr val="333333"/>
+                          </a:solidFill>
+                          <a:latin typeface="Calibri"/>
+                        </a:rPr>
+                        <a:t>1.538</a:t>
+                      </a:r>
+                    </a:p>
+                  </a:txBody>
+                  <a:tcPr anchor="ctr"/>
+                </a:tc>
+                <a:tc>
+                  <a:txBody>
+                    <a:bodyPr lIns="36000" rIns="36000" tIns="18000" bIns="18000"/>
+                    <a:lstStyle/>
+                    <a:p>
+                      <a:pPr algn="ctr"/>
+                      <a:r>
+                        <a:rPr sz="1100" b="0" i="0">
+                          <a:solidFill>
+                            <a:srgbClr val="333333"/>
+                          </a:solidFill>
+                          <a:latin typeface="Calibri"/>
+                        </a:rPr>
+                        <a:t>913</a:t>
+                      </a:r>
+                    </a:p>
+                  </a:txBody>
+                  <a:tcPr anchor="ctr"/>
+                </a:tc>
+                <a:tc>
+                  <a:txBody>
+                    <a:bodyPr lIns="36000" rIns="36000" tIns="18000" bIns="18000"/>
+                    <a:lstStyle/>
+                    <a:p>
+                      <a:pPr algn="ctr"/>
+                      <a:r>
+                        <a:rPr sz="1100" b="0" i="0">
+                          <a:solidFill>
+                            <a:srgbClr val="333333"/>
+                          </a:solidFill>
+                          <a:latin typeface="Calibri"/>
+                        </a:rPr>
+                        <a:t>1,68</a:t>
+                      </a:r>
+                    </a:p>
+                  </a:txBody>
+                  <a:tcPr anchor="ctr"/>
+                </a:tc>
+              </a:tr>
+              <a:tr h="274320">
+                <a:tc>
+                  <a:txBody>
+                    <a:bodyPr lIns="36000" rIns="36000" tIns="18000" bIns="18000"/>
+                    <a:lstStyle/>
+                    <a:p>
+                      <a:pPr algn="l"/>
+                      <a:r>
+                        <a:rPr sz="1100" b="1" i="0">
+                          <a:solidFill>
+                            <a:srgbClr val="333333"/>
+                          </a:solidFill>
+                          <a:latin typeface="Calibri"/>
+                        </a:rPr>
+                        <a:t>Fonds Finanz</a:t>
+                      </a:r>
+                    </a:p>
+                  </a:txBody>
+                  <a:tcPr anchor="ctr"/>
+                </a:tc>
+                <a:tc>
+                  <a:txBody>
+                    <a:bodyPr lIns="36000" rIns="36000" tIns="18000" bIns="18000"/>
+                    <a:lstStyle/>
+                    <a:p>
+                      <a:pPr algn="ctr"/>
+                      <a:r>
+                        <a:rPr sz="1100" b="0" i="0">
+                          <a:solidFill>
+                            <a:srgbClr val="333333"/>
+                          </a:solidFill>
+                          <a:latin typeface="Calibri"/>
+                        </a:rPr>
+                        <a:t>612</a:t>
+                      </a:r>
+                    </a:p>
+                  </a:txBody>
+                  <a:tcPr anchor="ctr"/>
+                </a:tc>
+                <a:tc>
+                  <a:txBody>
+                    <a:bodyPr lIns="36000" rIns="36000" tIns="18000" bIns="18000"/>
+                    <a:lstStyle/>
+                    <a:p>
+                      <a:pPr algn="ctr"/>
+                      <a:r>
+                        <a:rPr sz="1100" b="0" i="0">
+                          <a:solidFill>
+                            <a:srgbClr val="333333"/>
+                          </a:solidFill>
+                          <a:latin typeface="Calibri"/>
+                        </a:rPr>
+                        <a:t>291</a:t>
+                      </a:r>
+                    </a:p>
+                  </a:txBody>
+                  <a:tcPr anchor="ctr"/>
+                </a:tc>
+                <a:tc>
+                  <a:txBody>
+                    <a:bodyPr lIns="36000" rIns="36000" tIns="18000" bIns="18000"/>
+                    <a:lstStyle/>
+                    <a:p>
+                      <a:pPr algn="ctr"/>
+                      <a:r>
+                        <a:rPr sz="1100" b="0" i="0">
+                          <a:solidFill>
+                            <a:srgbClr val="333333"/>
+                          </a:solidFill>
+                          <a:latin typeface="Calibri"/>
+                        </a:rPr>
+                        <a:t>2,10</a:t>
+                      </a:r>
+                    </a:p>
+                  </a:txBody>
+                  <a:tcPr anchor="ctr"/>
+                </a:tc>
+              </a:tr>
+              <a:tr h="274320">
+                <a:tc>
+                  <a:txBody>
+                    <a:bodyPr lIns="36000" rIns="36000" tIns="18000" bIns="18000"/>
+                    <a:lstStyle/>
+                    <a:p>
+                      <a:pPr algn="l"/>
+                      <a:r>
+                        <a:rPr sz="1100" b="1" i="0">
+                          <a:solidFill>
+                            <a:srgbClr val="333333"/>
+                          </a:solidFill>
+                          <a:latin typeface="Calibri"/>
+                        </a:rPr>
+                        <a:t>blau direkt</a:t>
+                      </a:r>
+                    </a:p>
+                  </a:txBody>
+                  <a:tcPr anchor="ctr"/>
+                </a:tc>
+                <a:tc>
+                  <a:txBody>
+                    <a:bodyPr lIns="36000" rIns="36000" tIns="18000" bIns="18000"/>
+                    <a:lstStyle/>
+                    <a:p>
+                      <a:pPr algn="ctr"/>
+                      <a:r>
+                        <a:rPr sz="1100" b="0" i="0">
+                          <a:solidFill>
+                            <a:srgbClr val="333333"/>
+                          </a:solidFill>
+                          <a:latin typeface="Calibri"/>
+                        </a:rPr>
+                        <a:t>255</a:t>
+                      </a:r>
+                    </a:p>
+                  </a:txBody>
+                  <a:tcPr anchor="ctr"/>
+                </a:tc>
+                <a:tc>
+                  <a:txBody>
+                    <a:bodyPr lIns="36000" rIns="36000" tIns="18000" bIns="18000"/>
+                    <a:lstStyle/>
+                    <a:p>
+                      <a:pPr algn="ctr"/>
+                      <a:r>
+                        <a:rPr sz="1100" b="0" i="0">
+                          <a:solidFill>
+                            <a:srgbClr val="333333"/>
+                          </a:solidFill>
+                          <a:latin typeface="Calibri"/>
+                        </a:rPr>
+                        <a:t>180</a:t>
+                      </a:r>
+                    </a:p>
+                  </a:txBody>
+                  <a:tcPr anchor="ctr"/>
+                </a:tc>
+                <a:tc>
+                  <a:txBody>
+                    <a:bodyPr lIns="36000" rIns="36000" tIns="18000" bIns="18000"/>
+                    <a:lstStyle/>
+                    <a:p>
+                      <a:pPr algn="ctr"/>
+                      <a:r>
+                        <a:rPr sz="1100" b="0" i="0">
+                          <a:solidFill>
+                            <a:srgbClr val="333333"/>
+                          </a:solidFill>
+                          <a:latin typeface="Calibri"/>
+                        </a:rPr>
+                        <a:t>1,42</a:t>
+                      </a:r>
+                    </a:p>
+                  </a:txBody>
+                  <a:tcPr anchor="ctr"/>
+                </a:tc>
+              </a:tr>
+              <a:tr h="274320">
+                <a:tc>
+                  <a:txBody>
+                    <a:bodyPr lIns="36000" rIns="36000" tIns="18000" bIns="18000"/>
+                    <a:lstStyle/>
+                    <a:p>
+                      <a:pPr algn="l"/>
+                      <a:r>
+                        <a:rPr sz="1100" b="1" i="0">
+                          <a:solidFill>
+                            <a:srgbClr val="333333"/>
+                          </a:solidFill>
+                          <a:latin typeface="Calibri"/>
+                        </a:rPr>
+                        <a:t>DEMA</a:t>
+                      </a:r>
+                    </a:p>
+                  </a:txBody>
+                  <a:tcPr anchor="ctr"/>
+                </a:tc>
+                <a:tc>
+                  <a:txBody>
+                    <a:bodyPr lIns="36000" rIns="36000" tIns="18000" bIns="18000"/>
+                    <a:lstStyle/>
+                    <a:p>
+                      <a:pPr algn="ctr"/>
+                      <a:r>
+                        <a:rPr sz="1100" b="0" i="0">
+                          <a:solidFill>
+                            <a:srgbClr val="333333"/>
+                          </a:solidFill>
+                          <a:latin typeface="Calibri"/>
+                        </a:rPr>
+                        <a:t>158</a:t>
+                      </a:r>
+                    </a:p>
+                  </a:txBody>
+                  <a:tcPr anchor="ctr"/>
+                </a:tc>
+                <a:tc>
+                  <a:txBody>
+                    <a:bodyPr lIns="36000" rIns="36000" tIns="18000" bIns="18000"/>
+                    <a:lstStyle/>
+                    <a:p>
+                      <a:pPr algn="ctr"/>
+                      <a:r>
+                        <a:rPr sz="1100" b="0" i="0">
+                          <a:solidFill>
+                            <a:srgbClr val="333333"/>
+                          </a:solidFill>
+                          <a:latin typeface="Calibri"/>
+                        </a:rPr>
+                        <a:t>124</a:t>
+                      </a:r>
+                    </a:p>
+                  </a:txBody>
+                  <a:tcPr anchor="ctr"/>
+                </a:tc>
+                <a:tc>
+                  <a:txBody>
+                    <a:bodyPr lIns="36000" rIns="36000" tIns="18000" bIns="18000"/>
+                    <a:lstStyle/>
+                    <a:p>
+                      <a:pPr algn="ctr"/>
+                      <a:r>
+                        <a:rPr sz="1100" b="0" i="0">
+                          <a:solidFill>
+                            <a:srgbClr val="333333"/>
+                          </a:solidFill>
+                          <a:latin typeface="Calibri"/>
+                        </a:rPr>
+                        <a:t>1,27</a:t>
+                      </a:r>
+                    </a:p>
+                  </a:txBody>
+                  <a:tcPr anchor="ctr"/>
+                </a:tc>
+              </a:tr>
+              <a:tr h="274320">
+                <a:tc>
+                  <a:txBody>
+                    <a:bodyPr lIns="36000" rIns="36000" tIns="18000" bIns="18000"/>
+                    <a:lstStyle/>
+                    <a:p>
+                      <a:pPr algn="l"/>
+                      <a:r>
+                        <a:rPr sz="1100" b="1" i="0">
+                          <a:solidFill>
+                            <a:srgbClr val="333333"/>
+                          </a:solidFill>
+                          <a:latin typeface="Calibri"/>
+                        </a:rPr>
+                        <a:t>vfm Service</a:t>
+                      </a:r>
+                    </a:p>
+                  </a:txBody>
+                  <a:tcPr anchor="ctr"/>
+                </a:tc>
+                <a:tc>
+                  <a:txBody>
+                    <a:bodyPr lIns="36000" rIns="36000" tIns="18000" bIns="18000"/>
+                    <a:lstStyle/>
+                    <a:p>
+                      <a:pPr algn="ctr"/>
+                      <a:r>
+                        <a:rPr sz="1100" b="0" i="0">
+                          <a:solidFill>
+                            <a:srgbClr val="333333"/>
+                          </a:solidFill>
+                          <a:latin typeface="Calibri"/>
+                        </a:rPr>
+                        <a:t>116</a:t>
+                      </a:r>
+                    </a:p>
+                  </a:txBody>
+                  <a:tcPr anchor="ctr"/>
+                </a:tc>
+                <a:tc>
+                  <a:txBody>
+                    <a:bodyPr lIns="36000" rIns="36000" tIns="18000" bIns="18000"/>
+                    <a:lstStyle/>
+                    <a:p>
+                      <a:pPr algn="ctr"/>
+                      <a:r>
+                        <a:rPr sz="1100" b="0" i="0">
+                          <a:solidFill>
+                            <a:srgbClr val="333333"/>
+                          </a:solidFill>
+                          <a:latin typeface="Calibri"/>
+                        </a:rPr>
+                        <a:t>77</a:t>
+                      </a:r>
+                    </a:p>
+                  </a:txBody>
+                  <a:tcPr anchor="ctr"/>
+                </a:tc>
+                <a:tc>
+                  <a:txBody>
+                    <a:bodyPr lIns="36000" rIns="36000" tIns="18000" bIns="18000"/>
+                    <a:lstStyle/>
+                    <a:p>
+                      <a:pPr algn="ctr"/>
+                      <a:r>
+                        <a:rPr sz="1100" b="0" i="0">
+                          <a:solidFill>
+                            <a:srgbClr val="333333"/>
+                          </a:solidFill>
+                          <a:latin typeface="Calibri"/>
+                        </a:rPr>
+                        <a:t>1,51</a:t>
+                      </a:r>
+                    </a:p>
+                  </a:txBody>
+                  <a:tcPr anchor="ctr"/>
+                </a:tc>
+              </a:tr>
+              <a:tr h="274320">
+                <a:tc>
+                  <a:txBody>
+                    <a:bodyPr lIns="36000" rIns="36000" tIns="18000" bIns="18000"/>
+                    <a:lstStyle/>
+                    <a:p>
+                      <a:pPr algn="l"/>
+                      <a:r>
+                        <a:rPr sz="1100" b="1" i="0">
+                          <a:solidFill>
+                            <a:srgbClr val="333333"/>
+                          </a:solidFill>
+                          <a:latin typeface="Calibri"/>
+                        </a:rPr>
+                        <a:t>Summe Top-5-Makler  (65 % der BÜ-Anfragen)</a:t>
+                      </a:r>
+                    </a:p>
+                  </a:txBody>
+                  <a:tcPr anchor="ctr">
+                    <a:solidFill>
+                      <a:srgbClr val="CFE6E9"/>
+                    </a:solidFill>
+                  </a:tcPr>
+                </a:tc>
+                <a:tc>
+                  <a:txBody>
+                    <a:bodyPr lIns="36000" rIns="36000" tIns="18000" bIns="18000"/>
+                    <a:lstStyle/>
+                    <a:p>
+                      <a:pPr algn="ctr"/>
+                      <a:r>
+                        <a:rPr sz="1100" b="1" i="0">
+                          <a:solidFill>
+                            <a:srgbClr val="333333"/>
+                          </a:solidFill>
+                          <a:latin typeface="Calibri"/>
+                        </a:rPr>
+                        <a:t>2.594</a:t>
+                      </a:r>
+                    </a:p>
+                  </a:txBody>
+                  <a:tcPr anchor="ctr">
+                    <a:solidFill>
+                      <a:srgbClr val="CFE6E9"/>
+                    </a:solidFill>
+                  </a:tcPr>
+                </a:tc>
+                <a:tc>
+                  <a:txBody>
+                    <a:bodyPr lIns="36000" rIns="36000" tIns="18000" bIns="18000"/>
+                    <a:lstStyle/>
+                    <a:p>
+                      <a:pPr algn="ctr"/>
+                      <a:r>
+                        <a:rPr sz="1100" b="1" i="0">
+                          <a:solidFill>
+                            <a:srgbClr val="333333"/>
+                          </a:solidFill>
+                          <a:latin typeface="Calibri"/>
+                        </a:rPr>
+                        <a:t>1.519</a:t>
+                      </a:r>
+                    </a:p>
+                  </a:txBody>
+                  <a:tcPr anchor="ctr">
+                    <a:solidFill>
+                      <a:srgbClr val="CFE6E9"/>
+                    </a:solidFill>
+                  </a:tcPr>
+                </a:tc>
+                <a:tc>
+                  <a:txBody>
+                    <a:bodyPr lIns="36000" rIns="36000" tIns="18000" bIns="18000"/>
+                    <a:lstStyle/>
+                    <a:p>
+                      <a:pPr algn="ctr"/>
+                      <a:r>
+                        <a:rPr sz="1100" b="1" i="0">
+                          <a:solidFill>
+                            <a:srgbClr val="333333"/>
+                          </a:solidFill>
+                          <a:latin typeface="Calibri"/>
+                        </a:rPr>
+                        <a:t>1,71</a:t>
+                      </a:r>
+                    </a:p>
+                  </a:txBody>
+                  <a:tcPr anchor="ctr">
+                    <a:solidFill>
+                      <a:srgbClr val="CFE6E9"/>
+                    </a:solidFill>
+                  </a:tcPr>
+                </a:tc>
+              </a:tr>
+              <a:tr h="274320">
+                <a:tc>
+                  <a:txBody>
+                    <a:bodyPr lIns="36000" rIns="36000" tIns="18000" bIns="18000"/>
+                    <a:lstStyle/>
+                    <a:p>
+                      <a:pPr algn="l"/>
+                      <a:r>
+                        <a:rPr sz="1100" b="1" i="0">
+                          <a:solidFill>
+                            <a:srgbClr val="333333"/>
+                          </a:solidFill>
+                          <a:latin typeface="Calibri"/>
+                        </a:rPr>
+                        <a:t>Sonstige Makler (Long-Tail)</a:t>
+                      </a:r>
+                    </a:p>
+                  </a:txBody>
+                  <a:tcPr anchor="ctr"/>
+                </a:tc>
+                <a:tc>
+                  <a:txBody>
+                    <a:bodyPr lIns="36000" rIns="36000" tIns="18000" bIns="18000"/>
+                    <a:lstStyle/>
+                    <a:p>
+                      <a:pPr algn="ctr"/>
+                      <a:r>
+                        <a:rPr sz="1100" b="0" i="0">
+                          <a:solidFill>
+                            <a:srgbClr val="333333"/>
+                          </a:solidFill>
+                          <a:latin typeface="Calibri"/>
+                        </a:rPr>
+                        <a:t>1.406</a:t>
+                      </a:r>
+                    </a:p>
+                  </a:txBody>
+                  <a:tcPr anchor="ctr"/>
+                </a:tc>
+                <a:tc>
+                  <a:txBody>
+                    <a:bodyPr lIns="36000" rIns="36000" tIns="18000" bIns="18000"/>
+                    <a:lstStyle/>
+                    <a:p>
+                      <a:pPr algn="ctr"/>
+                      <a:r>
+                        <a:rPr sz="1100" b="0" i="0">
+                          <a:solidFill>
+                            <a:srgbClr val="333333"/>
+                          </a:solidFill>
+                          <a:latin typeface="Calibri"/>
+                        </a:rPr>
+                        <a:t>982</a:t>
+                      </a:r>
+                    </a:p>
+                  </a:txBody>
+                  <a:tcPr anchor="ctr"/>
+                </a:tc>
+                <a:tc>
+                  <a:txBody>
+                    <a:bodyPr lIns="36000" rIns="36000" tIns="18000" bIns="18000"/>
+                    <a:lstStyle/>
+                    <a:p>
+                      <a:pPr algn="ctr"/>
+                      <a:r>
+                        <a:rPr sz="1100" b="0" i="0">
+                          <a:solidFill>
+                            <a:srgbClr val="333333"/>
+                          </a:solidFill>
+                          <a:latin typeface="Calibri"/>
+                        </a:rPr>
+                        <a:t>1,43</a:t>
+                      </a:r>
+                    </a:p>
+                  </a:txBody>
+                  <a:tcPr anchor="ctr"/>
+                </a:tc>
+              </a:tr>
+              <a:tr h="274320">
+                <a:tc>
+                  <a:txBody>
+                    <a:bodyPr lIns="36000" rIns="36000" tIns="18000" bIns="18000"/>
+                    <a:lstStyle/>
+                    <a:p>
+                      <a:pPr algn="l"/>
+                      <a:r>
+                        <a:rPr sz="1100" b="1" i="0">
+                          <a:solidFill>
+                            <a:srgbClr val="333333"/>
+                          </a:solidFill>
+                          <a:latin typeface="Calibri"/>
+                        </a:rPr>
+                        <a:t>Gesamt</a:t>
+                      </a:r>
+                    </a:p>
+                  </a:txBody>
+                  <a:tcPr anchor="ctr">
+                    <a:solidFill>
+                      <a:srgbClr val="E9EFF1"/>
+                    </a:solidFill>
+                  </a:tcPr>
+                </a:tc>
+                <a:tc>
+                  <a:txBody>
+                    <a:bodyPr lIns="36000" rIns="36000" tIns="18000" bIns="18000"/>
+                    <a:lstStyle/>
+                    <a:p>
+                      <a:pPr algn="ctr"/>
+                      <a:r>
+                        <a:rPr sz="1100" b="1" i="0">
+                          <a:solidFill>
+                            <a:srgbClr val="333333"/>
+                          </a:solidFill>
+                          <a:latin typeface="Calibri"/>
+                        </a:rPr>
+                        <a:t>4.000</a:t>
+                      </a:r>
+                    </a:p>
+                  </a:txBody>
+                  <a:tcPr anchor="ctr">
+                    <a:solidFill>
+                      <a:srgbClr val="E9EFF1"/>
+                    </a:solidFill>
+                  </a:tcPr>
+                </a:tc>
+                <a:tc>
+                  <a:txBody>
+                    <a:bodyPr lIns="36000" rIns="36000" tIns="18000" bIns="18000"/>
+                    <a:lstStyle/>
+                    <a:p>
+                      <a:pPr algn="ctr"/>
+                      <a:r>
+                        <a:rPr sz="1100" b="1" i="0">
+                          <a:solidFill>
+                            <a:srgbClr val="333333"/>
+                          </a:solidFill>
+                          <a:latin typeface="Calibri"/>
+                        </a:rPr>
+                        <a:t>2.495</a:t>
+                      </a:r>
+                    </a:p>
+                  </a:txBody>
+                  <a:tcPr anchor="ctr">
+                    <a:solidFill>
+                      <a:srgbClr val="E9EFF1"/>
+                    </a:solidFill>
+                  </a:tcPr>
+                </a:tc>
+                <a:tc>
+                  <a:txBody>
+                    <a:bodyPr lIns="36000" rIns="36000" tIns="18000" bIns="18000"/>
+                    <a:lstStyle/>
+                    <a:p>
+                      <a:pPr algn="ctr"/>
+                      <a:r>
+                        <a:rPr sz="1100" b="1" i="0">
+                          <a:solidFill>
+                            <a:srgbClr val="333333"/>
+                          </a:solidFill>
+                          <a:latin typeface="Calibri"/>
+                        </a:rPr>
+                        <a:t>1,60</a:t>
+                      </a:r>
+                    </a:p>
+                  </a:txBody>
+                  <a:tcPr anchor="ctr">
+                    <a:solidFill>
+                      <a:srgbClr val="E9EFF1"/>
+                    </a:solidFill>
+                  </a:tcPr>
+                </a:tc>
+              </a:tr>
+            </a:tbl>
+          </a:graphicData>
+        </a:graphic>
+      </p:graphicFrame>
+      <p:sp>
+        <p:nvSpPr>
+          <p:cNvPr id="19" name="Rectangle 18"/>
           <p:cNvSpPr/>
           <p:nvPr/>
         </p:nvSpPr>
         <p:spPr>
           <a:xfrm>
-            <a:off x="411480" y="2606040"/>
-            <a:ext cx="7635240" cy="329184"/>
-          </a:xfrm>
-          <a:prstGeom prst="rect">
-            <a:avLst/>
-          </a:prstGeom>
-          <a:solidFill>
-            <a:srgbClr val="006B77"/>
-          </a:solidFill>
-          <a:ln>
-            <a:noFill/>
-          </a:ln>
-          <a:effectLst/>
-        </p:spPr>
-        <p:style>
-          <a:lnRef idx="1">
-            <a:schemeClr val="accent1"/>
-          </a:lnRef>
-          <a:fillRef idx="3">
-            <a:schemeClr val="accent1"/>
-          </a:fillRef>
-          <a:effectRef idx="2">
-            <a:schemeClr val="accent1"/>
-          </a:effectRef>
-          <a:fontRef idx="minor">
-            <a:schemeClr val="lt1"/>
-          </a:fontRef>
-        </p:style>
-        <p:txBody>
-          <a:bodyPr rtlCol="0" anchor="ctr"/>
-          <a:lstStyle/>
-          <a:p>
-            <a:pPr algn="ctr"/>
-          </a:p>
-        </p:txBody>
-      </p:sp>
-      <p:sp>
-        <p:nvSpPr>
-          <p:cNvPr id="19" name="TextBox 18"/>
-          <p:cNvSpPr txBox="1"/>
-          <p:nvPr/>
-        </p:nvSpPr>
-        <p:spPr>
-          <a:xfrm>
-            <a:off x="411480" y="2606040"/>
-            <a:ext cx="3063240" cy="329184"/>
-          </a:xfrm>
-          <a:prstGeom prst="rect">
-            <a:avLst/>
-          </a:prstGeom>
-          <a:noFill/>
-        </p:spPr>
-        <p:txBody>
-          <a:bodyPr wrap="square" lIns="36000" rIns="36000" tIns="18000" bIns="18000" anchor="ctr">
-            <a:spAutoFit/>
-          </a:bodyPr>
-          <a:lstStyle/>
-          <a:p>
-            <a:pPr algn="l"/>
-            <a:r>
-              <a:rPr sz="1000" b="1" i="0" u="none">
-                <a:solidFill>
-                  <a:srgbClr val="FFFFFF"/>
-                </a:solidFill>
-                <a:latin typeface="Calibri"/>
-              </a:rPr>
-              <a:t>Maklerpool</a:t>
-            </a:r>
-          </a:p>
-        </p:txBody>
-      </p:sp>
-      <p:sp>
-        <p:nvSpPr>
-          <p:cNvPr id="20" name="TextBox 19"/>
-          <p:cNvSpPr txBox="1"/>
-          <p:nvPr/>
-        </p:nvSpPr>
-        <p:spPr>
-          <a:xfrm>
-            <a:off x="3474720" y="2606040"/>
-            <a:ext cx="1508760" cy="329184"/>
-          </a:xfrm>
-          <a:prstGeom prst="rect">
-            <a:avLst/>
-          </a:prstGeom>
-          <a:noFill/>
-        </p:spPr>
-        <p:txBody>
-          <a:bodyPr wrap="square" lIns="36000" rIns="36000" tIns="18000" bIns="18000" anchor="ctr">
-            <a:spAutoFit/>
-          </a:bodyPr>
-          <a:lstStyle/>
-          <a:p>
-            <a:pPr algn="ctr"/>
-            <a:r>
-              <a:rPr sz="1000" b="1" i="0" u="none">
-                <a:solidFill>
-                  <a:srgbClr val="FFFFFF"/>
-                </a:solidFill>
-                <a:latin typeface="Calibri"/>
-              </a:rPr>
-              <a:t>BÜ-Anfragen / Wo</a:t>
-            </a:r>
-          </a:p>
-        </p:txBody>
-      </p:sp>
-      <p:sp>
-        <p:nvSpPr>
-          <p:cNvPr id="21" name="TextBox 20"/>
-          <p:cNvSpPr txBox="1"/>
-          <p:nvPr/>
-        </p:nvSpPr>
-        <p:spPr>
-          <a:xfrm>
-            <a:off x="4983480" y="2606040"/>
-            <a:ext cx="1508760" cy="329184"/>
-          </a:xfrm>
-          <a:prstGeom prst="rect">
-            <a:avLst/>
-          </a:prstGeom>
-          <a:noFill/>
-        </p:spPr>
-        <p:txBody>
-          <a:bodyPr wrap="square" lIns="36000" rIns="36000" tIns="18000" bIns="18000" anchor="ctr">
-            <a:spAutoFit/>
-          </a:bodyPr>
-          <a:lstStyle/>
-          <a:p>
-            <a:pPr algn="ctr"/>
-            <a:r>
-              <a:rPr sz="1000" b="1" i="0" u="none">
-                <a:solidFill>
-                  <a:srgbClr val="FFFFFF"/>
-                </a:solidFill>
-                <a:latin typeface="Calibri"/>
-              </a:rPr>
-              <a:t>Vorgänge</a:t>
-            </a:r>
-          </a:p>
-        </p:txBody>
-      </p:sp>
-      <p:sp>
-        <p:nvSpPr>
-          <p:cNvPr id="22" name="TextBox 21"/>
-          <p:cNvSpPr txBox="1"/>
-          <p:nvPr/>
-        </p:nvSpPr>
-        <p:spPr>
-          <a:xfrm>
-            <a:off x="6492240" y="2606040"/>
-            <a:ext cx="1554480" cy="329184"/>
-          </a:xfrm>
-          <a:prstGeom prst="rect">
-            <a:avLst/>
-          </a:prstGeom>
-          <a:noFill/>
-        </p:spPr>
-        <p:txBody>
-          <a:bodyPr wrap="square" lIns="36000" rIns="36000" tIns="18000" bIns="18000" anchor="ctr">
-            <a:spAutoFit/>
-          </a:bodyPr>
-          <a:lstStyle/>
-          <a:p>
-            <a:pPr algn="ctr"/>
-            <a:r>
-              <a:rPr sz="1000" b="1" i="0" u="none">
-                <a:solidFill>
-                  <a:srgbClr val="FFFFFF"/>
-                </a:solidFill>
-                <a:latin typeface="Calibri"/>
-              </a:rPr>
-              <a:t>Ø Mails / Vorgang</a:t>
-            </a:r>
-          </a:p>
-        </p:txBody>
-      </p:sp>
-      <p:sp>
-        <p:nvSpPr>
-          <p:cNvPr id="23" name="Rectangle 22"/>
-          <p:cNvSpPr/>
-          <p:nvPr/>
-        </p:nvSpPr>
-        <p:spPr>
-          <a:xfrm>
-            <a:off x="411480" y="2935224"/>
-            <a:ext cx="7635240" cy="278892"/>
-          </a:xfrm>
-          <a:prstGeom prst="rect">
-            <a:avLst/>
-          </a:prstGeom>
-          <a:solidFill>
-            <a:srgbClr val="FFFFFF"/>
-          </a:solidFill>
-          <a:ln>
-            <a:noFill/>
-          </a:ln>
-          <a:effectLst/>
-        </p:spPr>
-        <p:style>
-          <a:lnRef idx="1">
-            <a:schemeClr val="accent1"/>
-          </a:lnRef>
-          <a:fillRef idx="3">
-            <a:schemeClr val="accent1"/>
-          </a:fillRef>
-          <a:effectRef idx="2">
-            <a:schemeClr val="accent1"/>
-          </a:effectRef>
-          <a:fontRef idx="minor">
-            <a:schemeClr val="lt1"/>
-          </a:fontRef>
-        </p:style>
-        <p:txBody>
-          <a:bodyPr rtlCol="0" anchor="ctr"/>
-          <a:lstStyle/>
-          <a:p>
-            <a:pPr algn="ctr"/>
-          </a:p>
-        </p:txBody>
-      </p:sp>
-      <p:sp>
-        <p:nvSpPr>
-          <p:cNvPr id="24" name="TextBox 23"/>
-          <p:cNvSpPr txBox="1"/>
-          <p:nvPr/>
-        </p:nvSpPr>
-        <p:spPr>
-          <a:xfrm>
-            <a:off x="521208" y="2935224"/>
-            <a:ext cx="2953512" cy="278892"/>
-          </a:xfrm>
-          <a:prstGeom prst="rect">
-            <a:avLst/>
-          </a:prstGeom>
-          <a:noFill/>
-        </p:spPr>
-        <p:txBody>
-          <a:bodyPr wrap="square" lIns="36000" rIns="36000" tIns="18000" bIns="18000" anchor="ctr">
-            <a:spAutoFit/>
-          </a:bodyPr>
-          <a:lstStyle/>
-          <a:p>
-            <a:pPr algn="l"/>
-            <a:r>
-              <a:rPr sz="1100" b="1" i="0" u="none">
-                <a:solidFill>
-                  <a:srgbClr val="333333"/>
-                </a:solidFill>
-                <a:latin typeface="Calibri"/>
-              </a:rPr>
-              <a:t>JDC / Jung, DMS &amp; Cie.</a:t>
-            </a:r>
-          </a:p>
-        </p:txBody>
-      </p:sp>
-      <p:sp>
-        <p:nvSpPr>
-          <p:cNvPr id="25" name="TextBox 24"/>
-          <p:cNvSpPr txBox="1"/>
-          <p:nvPr/>
-        </p:nvSpPr>
-        <p:spPr>
-          <a:xfrm>
-            <a:off x="3474720" y="2935224"/>
-            <a:ext cx="1508760" cy="278892"/>
-          </a:xfrm>
-          <a:prstGeom prst="rect">
-            <a:avLst/>
-          </a:prstGeom>
-          <a:noFill/>
-        </p:spPr>
-        <p:txBody>
-          <a:bodyPr wrap="square" lIns="36000" rIns="36000" tIns="18000" bIns="18000" anchor="ctr">
-            <a:spAutoFit/>
-          </a:bodyPr>
-          <a:lstStyle/>
-          <a:p>
-            <a:pPr algn="ctr"/>
-            <a:r>
-              <a:rPr sz="1100" b="0" i="0" u="none">
-                <a:solidFill>
-                  <a:srgbClr val="333333"/>
-                </a:solidFill>
-                <a:latin typeface="Calibri"/>
-              </a:rPr>
-              <a:t>1.538</a:t>
-            </a:r>
-          </a:p>
-        </p:txBody>
-      </p:sp>
-      <p:sp>
-        <p:nvSpPr>
-          <p:cNvPr id="26" name="TextBox 25"/>
-          <p:cNvSpPr txBox="1"/>
-          <p:nvPr/>
-        </p:nvSpPr>
-        <p:spPr>
-          <a:xfrm>
-            <a:off x="4983480" y="2935224"/>
-            <a:ext cx="1508760" cy="278892"/>
-          </a:xfrm>
-          <a:prstGeom prst="rect">
-            <a:avLst/>
-          </a:prstGeom>
-          <a:noFill/>
-        </p:spPr>
-        <p:txBody>
-          <a:bodyPr wrap="square" lIns="36000" rIns="36000" tIns="18000" bIns="18000" anchor="ctr">
-            <a:spAutoFit/>
-          </a:bodyPr>
-          <a:lstStyle/>
-          <a:p>
-            <a:pPr algn="ctr"/>
-            <a:r>
-              <a:rPr sz="1100" b="0" i="0" u="none">
-                <a:solidFill>
-                  <a:srgbClr val="333333"/>
-                </a:solidFill>
-                <a:latin typeface="Calibri"/>
-              </a:rPr>
-              <a:t>913</a:t>
-            </a:r>
-          </a:p>
-        </p:txBody>
-      </p:sp>
-      <p:sp>
-        <p:nvSpPr>
-          <p:cNvPr id="27" name="TextBox 26"/>
-          <p:cNvSpPr txBox="1"/>
-          <p:nvPr/>
-        </p:nvSpPr>
-        <p:spPr>
-          <a:xfrm>
-            <a:off x="6492240" y="2935224"/>
-            <a:ext cx="1554480" cy="278892"/>
-          </a:xfrm>
-          <a:prstGeom prst="rect">
-            <a:avLst/>
-          </a:prstGeom>
-          <a:noFill/>
-        </p:spPr>
-        <p:txBody>
-          <a:bodyPr wrap="square" lIns="36000" rIns="36000" tIns="18000" bIns="18000" anchor="ctr">
-            <a:spAutoFit/>
-          </a:bodyPr>
-          <a:lstStyle/>
-          <a:p>
-            <a:pPr algn="ctr"/>
-            <a:r>
-              <a:rPr sz="1100" b="0" i="0" u="none">
-                <a:solidFill>
-                  <a:srgbClr val="333333"/>
-                </a:solidFill>
-                <a:latin typeface="Calibri"/>
-              </a:rPr>
-              <a:t>1,68</a:t>
-            </a:r>
-          </a:p>
-        </p:txBody>
-      </p:sp>
-      <p:sp>
-        <p:nvSpPr>
-          <p:cNvPr id="28" name="Rectangle 27"/>
-          <p:cNvSpPr/>
-          <p:nvPr/>
-        </p:nvSpPr>
-        <p:spPr>
-          <a:xfrm>
-            <a:off x="411480" y="3214116"/>
-            <a:ext cx="7635240" cy="278892"/>
-          </a:xfrm>
-          <a:prstGeom prst="rect">
-            <a:avLst/>
-          </a:prstGeom>
-          <a:solidFill>
-            <a:srgbClr val="F1F1F1"/>
-          </a:solidFill>
-          <a:ln>
-            <a:noFill/>
-          </a:ln>
-          <a:effectLst/>
-        </p:spPr>
-        <p:style>
-          <a:lnRef idx="1">
-            <a:schemeClr val="accent1"/>
-          </a:lnRef>
-          <a:fillRef idx="3">
-            <a:schemeClr val="accent1"/>
-          </a:fillRef>
-          <a:effectRef idx="2">
-            <a:schemeClr val="accent1"/>
-          </a:effectRef>
-          <a:fontRef idx="minor">
-            <a:schemeClr val="lt1"/>
-          </a:fontRef>
-        </p:style>
-        <p:txBody>
-          <a:bodyPr rtlCol="0" anchor="ctr"/>
-          <a:lstStyle/>
-          <a:p>
-            <a:pPr algn="ctr"/>
-          </a:p>
-        </p:txBody>
-      </p:sp>
-      <p:sp>
-        <p:nvSpPr>
-          <p:cNvPr id="29" name="TextBox 28"/>
-          <p:cNvSpPr txBox="1"/>
-          <p:nvPr/>
-        </p:nvSpPr>
-        <p:spPr>
-          <a:xfrm>
-            <a:off x="521208" y="3214116"/>
-            <a:ext cx="2953512" cy="278892"/>
-          </a:xfrm>
-          <a:prstGeom prst="rect">
-            <a:avLst/>
-          </a:prstGeom>
-          <a:noFill/>
-        </p:spPr>
-        <p:txBody>
-          <a:bodyPr wrap="square" lIns="36000" rIns="36000" tIns="18000" bIns="18000" anchor="ctr">
-            <a:spAutoFit/>
-          </a:bodyPr>
-          <a:lstStyle/>
-          <a:p>
-            <a:pPr algn="l"/>
-            <a:r>
-              <a:rPr sz="1100" b="1" i="0" u="none">
-                <a:solidFill>
-                  <a:srgbClr val="333333"/>
-                </a:solidFill>
-                <a:latin typeface="Calibri"/>
-              </a:rPr>
-              <a:t>Fonds Finanz</a:t>
-            </a:r>
-          </a:p>
-        </p:txBody>
-      </p:sp>
-      <p:sp>
-        <p:nvSpPr>
-          <p:cNvPr id="30" name="TextBox 29"/>
-          <p:cNvSpPr txBox="1"/>
-          <p:nvPr/>
-        </p:nvSpPr>
-        <p:spPr>
-          <a:xfrm>
-            <a:off x="3474720" y="3214116"/>
-            <a:ext cx="1508760" cy="278892"/>
-          </a:xfrm>
-          <a:prstGeom prst="rect">
-            <a:avLst/>
-          </a:prstGeom>
-          <a:noFill/>
-        </p:spPr>
-        <p:txBody>
-          <a:bodyPr wrap="square" lIns="36000" rIns="36000" tIns="18000" bIns="18000" anchor="ctr">
-            <a:spAutoFit/>
-          </a:bodyPr>
-          <a:lstStyle/>
-          <a:p>
-            <a:pPr algn="ctr"/>
-            <a:r>
-              <a:rPr sz="1100" b="0" i="0" u="none">
-                <a:solidFill>
-                  <a:srgbClr val="333333"/>
-                </a:solidFill>
-                <a:latin typeface="Calibri"/>
-              </a:rPr>
-              <a:t>612</a:t>
-            </a:r>
-          </a:p>
-        </p:txBody>
-      </p:sp>
-      <p:sp>
-        <p:nvSpPr>
-          <p:cNvPr id="31" name="TextBox 30"/>
-          <p:cNvSpPr txBox="1"/>
-          <p:nvPr/>
-        </p:nvSpPr>
-        <p:spPr>
-          <a:xfrm>
-            <a:off x="4983480" y="3214116"/>
-            <a:ext cx="1508760" cy="278892"/>
-          </a:xfrm>
-          <a:prstGeom prst="rect">
-            <a:avLst/>
-          </a:prstGeom>
-          <a:noFill/>
-        </p:spPr>
-        <p:txBody>
-          <a:bodyPr wrap="square" lIns="36000" rIns="36000" tIns="18000" bIns="18000" anchor="ctr">
-            <a:spAutoFit/>
-          </a:bodyPr>
-          <a:lstStyle/>
-          <a:p>
-            <a:pPr algn="ctr"/>
-            <a:r>
-              <a:rPr sz="1100" b="0" i="0" u="none">
-                <a:solidFill>
-                  <a:srgbClr val="333333"/>
-                </a:solidFill>
-                <a:latin typeface="Calibri"/>
-              </a:rPr>
-              <a:t>291</a:t>
-            </a:r>
-          </a:p>
-        </p:txBody>
-      </p:sp>
-      <p:sp>
-        <p:nvSpPr>
-          <p:cNvPr id="32" name="TextBox 31"/>
-          <p:cNvSpPr txBox="1"/>
-          <p:nvPr/>
-        </p:nvSpPr>
-        <p:spPr>
-          <a:xfrm>
-            <a:off x="6492240" y="3214116"/>
-            <a:ext cx="1554480" cy="278892"/>
-          </a:xfrm>
-          <a:prstGeom prst="rect">
-            <a:avLst/>
-          </a:prstGeom>
-          <a:noFill/>
-        </p:spPr>
-        <p:txBody>
-          <a:bodyPr wrap="square" lIns="36000" rIns="36000" tIns="18000" bIns="18000" anchor="ctr">
-            <a:spAutoFit/>
-          </a:bodyPr>
-          <a:lstStyle/>
-          <a:p>
-            <a:pPr algn="ctr"/>
-            <a:r>
-              <a:rPr sz="1100" b="0" i="0" u="none">
-                <a:solidFill>
-                  <a:srgbClr val="333333"/>
-                </a:solidFill>
-                <a:latin typeface="Calibri"/>
-              </a:rPr>
-              <a:t>2,10</a:t>
-            </a:r>
-          </a:p>
-        </p:txBody>
-      </p:sp>
-      <p:sp>
-        <p:nvSpPr>
-          <p:cNvPr id="33" name="Rectangle 32"/>
-          <p:cNvSpPr/>
-          <p:nvPr/>
-        </p:nvSpPr>
-        <p:spPr>
-          <a:xfrm>
-            <a:off x="411480" y="3493008"/>
-            <a:ext cx="7635240" cy="278892"/>
-          </a:xfrm>
-          <a:prstGeom prst="rect">
-            <a:avLst/>
-          </a:prstGeom>
-          <a:solidFill>
-            <a:srgbClr val="FFFFFF"/>
-          </a:solidFill>
-          <a:ln>
-            <a:noFill/>
-          </a:ln>
-          <a:effectLst/>
-        </p:spPr>
-        <p:style>
-          <a:lnRef idx="1">
-            <a:schemeClr val="accent1"/>
-          </a:lnRef>
-          <a:fillRef idx="3">
-            <a:schemeClr val="accent1"/>
-          </a:fillRef>
-          <a:effectRef idx="2">
-            <a:schemeClr val="accent1"/>
-          </a:effectRef>
-          <a:fontRef idx="minor">
-            <a:schemeClr val="lt1"/>
-          </a:fontRef>
-        </p:style>
-        <p:txBody>
-          <a:bodyPr rtlCol="0" anchor="ctr"/>
-          <a:lstStyle/>
-          <a:p>
-            <a:pPr algn="ctr"/>
-          </a:p>
-        </p:txBody>
-      </p:sp>
-      <p:sp>
-        <p:nvSpPr>
-          <p:cNvPr id="34" name="TextBox 33"/>
-          <p:cNvSpPr txBox="1"/>
-          <p:nvPr/>
-        </p:nvSpPr>
-        <p:spPr>
-          <a:xfrm>
-            <a:off x="521208" y="3493008"/>
-            <a:ext cx="2953512" cy="278892"/>
-          </a:xfrm>
-          <a:prstGeom prst="rect">
-            <a:avLst/>
-          </a:prstGeom>
-          <a:noFill/>
-        </p:spPr>
-        <p:txBody>
-          <a:bodyPr wrap="square" lIns="36000" rIns="36000" tIns="18000" bIns="18000" anchor="ctr">
-            <a:spAutoFit/>
-          </a:bodyPr>
-          <a:lstStyle/>
-          <a:p>
-            <a:pPr algn="l"/>
-            <a:r>
-              <a:rPr sz="1100" b="1" i="0" u="none">
-                <a:solidFill>
-                  <a:srgbClr val="333333"/>
-                </a:solidFill>
-                <a:latin typeface="Calibri"/>
-              </a:rPr>
-              <a:t>blau direkt</a:t>
-            </a:r>
-          </a:p>
-        </p:txBody>
-      </p:sp>
-      <p:sp>
-        <p:nvSpPr>
-          <p:cNvPr id="35" name="TextBox 34"/>
-          <p:cNvSpPr txBox="1"/>
-          <p:nvPr/>
-        </p:nvSpPr>
-        <p:spPr>
-          <a:xfrm>
-            <a:off x="3474720" y="3493008"/>
-            <a:ext cx="1508760" cy="278892"/>
-          </a:xfrm>
-          <a:prstGeom prst="rect">
-            <a:avLst/>
-          </a:prstGeom>
-          <a:noFill/>
-        </p:spPr>
-        <p:txBody>
-          <a:bodyPr wrap="square" lIns="36000" rIns="36000" tIns="18000" bIns="18000" anchor="ctr">
-            <a:spAutoFit/>
-          </a:bodyPr>
-          <a:lstStyle/>
-          <a:p>
-            <a:pPr algn="ctr"/>
-            <a:r>
-              <a:rPr sz="1100" b="0" i="0" u="none">
-                <a:solidFill>
-                  <a:srgbClr val="333333"/>
-                </a:solidFill>
-                <a:latin typeface="Calibri"/>
-              </a:rPr>
-              <a:t>255</a:t>
-            </a:r>
-          </a:p>
-        </p:txBody>
-      </p:sp>
-      <p:sp>
-        <p:nvSpPr>
-          <p:cNvPr id="36" name="TextBox 35"/>
-          <p:cNvSpPr txBox="1"/>
-          <p:nvPr/>
-        </p:nvSpPr>
-        <p:spPr>
-          <a:xfrm>
-            <a:off x="4983480" y="3493008"/>
-            <a:ext cx="1508760" cy="278892"/>
-          </a:xfrm>
-          <a:prstGeom prst="rect">
-            <a:avLst/>
-          </a:prstGeom>
-          <a:noFill/>
-        </p:spPr>
-        <p:txBody>
-          <a:bodyPr wrap="square" lIns="36000" rIns="36000" tIns="18000" bIns="18000" anchor="ctr">
-            <a:spAutoFit/>
-          </a:bodyPr>
-          <a:lstStyle/>
-          <a:p>
-            <a:pPr algn="ctr"/>
-            <a:r>
-              <a:rPr sz="1100" b="0" i="0" u="none">
-                <a:solidFill>
-                  <a:srgbClr val="333333"/>
-                </a:solidFill>
-                <a:latin typeface="Calibri"/>
-              </a:rPr>
-              <a:t>180</a:t>
-            </a:r>
-          </a:p>
-        </p:txBody>
-      </p:sp>
-      <p:sp>
-        <p:nvSpPr>
-          <p:cNvPr id="37" name="TextBox 36"/>
-          <p:cNvSpPr txBox="1"/>
-          <p:nvPr/>
-        </p:nvSpPr>
-        <p:spPr>
-          <a:xfrm>
-            <a:off x="6492240" y="3493008"/>
-            <a:ext cx="1554480" cy="278892"/>
-          </a:xfrm>
-          <a:prstGeom prst="rect">
-            <a:avLst/>
-          </a:prstGeom>
-          <a:noFill/>
-        </p:spPr>
-        <p:txBody>
-          <a:bodyPr wrap="square" lIns="36000" rIns="36000" tIns="18000" bIns="18000" anchor="ctr">
-            <a:spAutoFit/>
-          </a:bodyPr>
-          <a:lstStyle/>
-          <a:p>
-            <a:pPr algn="ctr"/>
-            <a:r>
-              <a:rPr sz="1100" b="0" i="0" u="none">
-                <a:solidFill>
-                  <a:srgbClr val="333333"/>
-                </a:solidFill>
-                <a:latin typeface="Calibri"/>
-              </a:rPr>
-              <a:t>1,42</a:t>
-            </a:r>
-          </a:p>
-        </p:txBody>
-      </p:sp>
-      <p:sp>
-        <p:nvSpPr>
-          <p:cNvPr id="38" name="Rectangle 37"/>
-          <p:cNvSpPr/>
-          <p:nvPr/>
-        </p:nvSpPr>
-        <p:spPr>
-          <a:xfrm>
-            <a:off x="411480" y="3771900"/>
-            <a:ext cx="7635240" cy="278892"/>
-          </a:xfrm>
-          <a:prstGeom prst="rect">
-            <a:avLst/>
-          </a:prstGeom>
-          <a:solidFill>
-            <a:srgbClr val="F1F1F1"/>
-          </a:solidFill>
-          <a:ln>
-            <a:noFill/>
-          </a:ln>
-          <a:effectLst/>
-        </p:spPr>
-        <p:style>
-          <a:lnRef idx="1">
-            <a:schemeClr val="accent1"/>
-          </a:lnRef>
-          <a:fillRef idx="3">
-            <a:schemeClr val="accent1"/>
-          </a:fillRef>
-          <a:effectRef idx="2">
-            <a:schemeClr val="accent1"/>
-          </a:effectRef>
-          <a:fontRef idx="minor">
-            <a:schemeClr val="lt1"/>
-          </a:fontRef>
-        </p:style>
-        <p:txBody>
-          <a:bodyPr rtlCol="0" anchor="ctr"/>
-          <a:lstStyle/>
-          <a:p>
-            <a:pPr algn="ctr"/>
-          </a:p>
-        </p:txBody>
-      </p:sp>
-      <p:sp>
-        <p:nvSpPr>
-          <p:cNvPr id="39" name="TextBox 38"/>
-          <p:cNvSpPr txBox="1"/>
-          <p:nvPr/>
-        </p:nvSpPr>
-        <p:spPr>
-          <a:xfrm>
-            <a:off x="521208" y="3771900"/>
-            <a:ext cx="2953512" cy="278892"/>
-          </a:xfrm>
-          <a:prstGeom prst="rect">
-            <a:avLst/>
-          </a:prstGeom>
-          <a:noFill/>
-        </p:spPr>
-        <p:txBody>
-          <a:bodyPr wrap="square" lIns="36000" rIns="36000" tIns="18000" bIns="18000" anchor="ctr">
-            <a:spAutoFit/>
-          </a:bodyPr>
-          <a:lstStyle/>
-          <a:p>
-            <a:pPr algn="l"/>
-            <a:r>
-              <a:rPr sz="1100" b="1" i="0" u="none">
-                <a:solidFill>
-                  <a:srgbClr val="333333"/>
-                </a:solidFill>
-                <a:latin typeface="Calibri"/>
-              </a:rPr>
-              <a:t>DEMA</a:t>
-            </a:r>
-          </a:p>
-        </p:txBody>
-      </p:sp>
-      <p:sp>
-        <p:nvSpPr>
-          <p:cNvPr id="40" name="TextBox 39"/>
-          <p:cNvSpPr txBox="1"/>
-          <p:nvPr/>
-        </p:nvSpPr>
-        <p:spPr>
-          <a:xfrm>
-            <a:off x="3474720" y="3771900"/>
-            <a:ext cx="1508760" cy="278892"/>
-          </a:xfrm>
-          <a:prstGeom prst="rect">
-            <a:avLst/>
-          </a:prstGeom>
-          <a:noFill/>
-        </p:spPr>
-        <p:txBody>
-          <a:bodyPr wrap="square" lIns="36000" rIns="36000" tIns="18000" bIns="18000" anchor="ctr">
-            <a:spAutoFit/>
-          </a:bodyPr>
-          <a:lstStyle/>
-          <a:p>
-            <a:pPr algn="ctr"/>
-            <a:r>
-              <a:rPr sz="1100" b="0" i="0" u="none">
-                <a:solidFill>
-                  <a:srgbClr val="333333"/>
-                </a:solidFill>
-                <a:latin typeface="Calibri"/>
-              </a:rPr>
-              <a:t>114</a:t>
-            </a:r>
-          </a:p>
-        </p:txBody>
-      </p:sp>
-      <p:sp>
-        <p:nvSpPr>
-          <p:cNvPr id="41" name="TextBox 40"/>
-          <p:cNvSpPr txBox="1"/>
-          <p:nvPr/>
-        </p:nvSpPr>
-        <p:spPr>
-          <a:xfrm>
-            <a:off x="4983480" y="3771900"/>
-            <a:ext cx="1508760" cy="278892"/>
-          </a:xfrm>
-          <a:prstGeom prst="rect">
-            <a:avLst/>
-          </a:prstGeom>
-          <a:noFill/>
-        </p:spPr>
-        <p:txBody>
-          <a:bodyPr wrap="square" lIns="36000" rIns="36000" tIns="18000" bIns="18000" anchor="ctr">
-            <a:spAutoFit/>
-          </a:bodyPr>
-          <a:lstStyle/>
-          <a:p>
-            <a:pPr algn="ctr"/>
-            <a:r>
-              <a:rPr sz="1100" b="0" i="0" u="none">
-                <a:solidFill>
-                  <a:srgbClr val="333333"/>
-                </a:solidFill>
-                <a:latin typeface="Calibri"/>
-              </a:rPr>
-              <a:t>80</a:t>
-            </a:r>
-          </a:p>
-        </p:txBody>
-      </p:sp>
-      <p:sp>
-        <p:nvSpPr>
-          <p:cNvPr id="42" name="TextBox 41"/>
-          <p:cNvSpPr txBox="1"/>
-          <p:nvPr/>
-        </p:nvSpPr>
-        <p:spPr>
-          <a:xfrm>
-            <a:off x="6492240" y="3771900"/>
-            <a:ext cx="1554480" cy="278892"/>
-          </a:xfrm>
-          <a:prstGeom prst="rect">
-            <a:avLst/>
-          </a:prstGeom>
-          <a:noFill/>
-        </p:spPr>
-        <p:txBody>
-          <a:bodyPr wrap="square" lIns="36000" rIns="36000" tIns="18000" bIns="18000" anchor="ctr">
-            <a:spAutoFit/>
-          </a:bodyPr>
-          <a:lstStyle/>
-          <a:p>
-            <a:pPr algn="ctr"/>
-            <a:r>
-              <a:rPr sz="1100" b="0" i="0" u="none">
-                <a:solidFill>
-                  <a:srgbClr val="333333"/>
-                </a:solidFill>
-                <a:latin typeface="Calibri"/>
-              </a:rPr>
-              <a:t>1,43</a:t>
-            </a:r>
-          </a:p>
-        </p:txBody>
-      </p:sp>
-      <p:sp>
-        <p:nvSpPr>
-          <p:cNvPr id="43" name="Rectangle 42"/>
-          <p:cNvSpPr/>
-          <p:nvPr/>
-        </p:nvSpPr>
-        <p:spPr>
-          <a:xfrm>
-            <a:off x="411480" y="4050792"/>
-            <a:ext cx="7635240" cy="278892"/>
-          </a:xfrm>
-          <a:prstGeom prst="rect">
-            <a:avLst/>
-          </a:prstGeom>
-          <a:solidFill>
-            <a:srgbClr val="FFFFFF"/>
-          </a:solidFill>
-          <a:ln>
-            <a:noFill/>
-          </a:ln>
-          <a:effectLst/>
-        </p:spPr>
-        <p:style>
-          <a:lnRef idx="1">
-            <a:schemeClr val="accent1"/>
-          </a:lnRef>
-          <a:fillRef idx="3">
-            <a:schemeClr val="accent1"/>
-          </a:fillRef>
-          <a:effectRef idx="2">
-            <a:schemeClr val="accent1"/>
-          </a:effectRef>
-          <a:fontRef idx="minor">
-            <a:schemeClr val="lt1"/>
-          </a:fontRef>
-        </p:style>
-        <p:txBody>
-          <a:bodyPr rtlCol="0" anchor="ctr"/>
-          <a:lstStyle/>
-          <a:p>
-            <a:pPr algn="ctr"/>
-          </a:p>
-        </p:txBody>
-      </p:sp>
-      <p:sp>
-        <p:nvSpPr>
-          <p:cNvPr id="44" name="TextBox 43"/>
-          <p:cNvSpPr txBox="1"/>
-          <p:nvPr/>
-        </p:nvSpPr>
-        <p:spPr>
-          <a:xfrm>
-            <a:off x="521208" y="4050792"/>
-            <a:ext cx="2953512" cy="278892"/>
-          </a:xfrm>
-          <a:prstGeom prst="rect">
-            <a:avLst/>
-          </a:prstGeom>
-          <a:noFill/>
-        </p:spPr>
-        <p:txBody>
-          <a:bodyPr wrap="square" lIns="36000" rIns="36000" tIns="18000" bIns="18000" anchor="ctr">
-            <a:spAutoFit/>
-          </a:bodyPr>
-          <a:lstStyle/>
-          <a:p>
-            <a:pPr algn="l"/>
-            <a:r>
-              <a:rPr sz="1100" b="1" i="0" u="none">
-                <a:solidFill>
-                  <a:srgbClr val="333333"/>
-                </a:solidFill>
-                <a:latin typeface="Calibri"/>
-              </a:rPr>
-              <a:t>vfm Service</a:t>
-            </a:r>
-          </a:p>
-        </p:txBody>
-      </p:sp>
-      <p:sp>
-        <p:nvSpPr>
-          <p:cNvPr id="45" name="TextBox 44"/>
-          <p:cNvSpPr txBox="1"/>
-          <p:nvPr/>
-        </p:nvSpPr>
-        <p:spPr>
-          <a:xfrm>
-            <a:off x="3474720" y="4050792"/>
-            <a:ext cx="1508760" cy="278892"/>
-          </a:xfrm>
-          <a:prstGeom prst="rect">
-            <a:avLst/>
-          </a:prstGeom>
-          <a:noFill/>
-        </p:spPr>
-        <p:txBody>
-          <a:bodyPr wrap="square" lIns="36000" rIns="36000" tIns="18000" bIns="18000" anchor="ctr">
-            <a:spAutoFit/>
-          </a:bodyPr>
-          <a:lstStyle/>
-          <a:p>
-            <a:pPr algn="ctr"/>
-            <a:r>
-              <a:rPr sz="1100" b="0" i="0" u="none">
-                <a:solidFill>
-                  <a:srgbClr val="333333"/>
-                </a:solidFill>
-                <a:latin typeface="Calibri"/>
-              </a:rPr>
-              <a:t>75</a:t>
-            </a:r>
-          </a:p>
-        </p:txBody>
-      </p:sp>
-      <p:sp>
-        <p:nvSpPr>
-          <p:cNvPr id="46" name="TextBox 45"/>
-          <p:cNvSpPr txBox="1"/>
-          <p:nvPr/>
-        </p:nvSpPr>
-        <p:spPr>
-          <a:xfrm>
-            <a:off x="4983480" y="4050792"/>
-            <a:ext cx="1508760" cy="278892"/>
-          </a:xfrm>
-          <a:prstGeom prst="rect">
-            <a:avLst/>
-          </a:prstGeom>
-          <a:noFill/>
-        </p:spPr>
-        <p:txBody>
-          <a:bodyPr wrap="square" lIns="36000" rIns="36000" tIns="18000" bIns="18000" anchor="ctr">
-            <a:spAutoFit/>
-          </a:bodyPr>
-          <a:lstStyle/>
-          <a:p>
-            <a:pPr algn="ctr"/>
-            <a:r>
-              <a:rPr sz="1100" b="0" i="0" u="none">
-                <a:solidFill>
-                  <a:srgbClr val="333333"/>
-                </a:solidFill>
-                <a:latin typeface="Calibri"/>
-              </a:rPr>
-              <a:t>55</a:t>
-            </a:r>
-          </a:p>
-        </p:txBody>
-      </p:sp>
-      <p:sp>
-        <p:nvSpPr>
-          <p:cNvPr id="47" name="TextBox 46"/>
-          <p:cNvSpPr txBox="1"/>
-          <p:nvPr/>
-        </p:nvSpPr>
-        <p:spPr>
-          <a:xfrm>
-            <a:off x="6492240" y="4050792"/>
-            <a:ext cx="1554480" cy="278892"/>
-          </a:xfrm>
-          <a:prstGeom prst="rect">
-            <a:avLst/>
-          </a:prstGeom>
-          <a:noFill/>
-        </p:spPr>
-        <p:txBody>
-          <a:bodyPr wrap="square" lIns="36000" rIns="36000" tIns="18000" bIns="18000" anchor="ctr">
-            <a:spAutoFit/>
-          </a:bodyPr>
-          <a:lstStyle/>
-          <a:p>
-            <a:pPr algn="ctr"/>
-            <a:r>
-              <a:rPr sz="1100" b="0" i="0" u="none">
-                <a:solidFill>
-                  <a:srgbClr val="333333"/>
-                </a:solidFill>
-                <a:latin typeface="Calibri"/>
-              </a:rPr>
-              <a:t>1,36</a:t>
-            </a:r>
-          </a:p>
-        </p:txBody>
-      </p:sp>
-      <p:sp>
-        <p:nvSpPr>
-          <p:cNvPr id="48" name="Rectangle 47"/>
-          <p:cNvSpPr/>
-          <p:nvPr/>
-        </p:nvSpPr>
-        <p:spPr>
-          <a:xfrm>
-            <a:off x="411480" y="4329684"/>
-            <a:ext cx="7635240" cy="278892"/>
-          </a:xfrm>
-          <a:prstGeom prst="rect">
-            <a:avLst/>
-          </a:prstGeom>
-          <a:solidFill>
-            <a:srgbClr val="CFE6E9"/>
-          </a:solidFill>
-          <a:ln>
-            <a:noFill/>
-          </a:ln>
-          <a:effectLst/>
-        </p:spPr>
-        <p:style>
-          <a:lnRef idx="1">
-            <a:schemeClr val="accent1"/>
-          </a:lnRef>
-          <a:fillRef idx="3">
-            <a:schemeClr val="accent1"/>
-          </a:fillRef>
-          <a:effectRef idx="2">
-            <a:schemeClr val="accent1"/>
-          </a:effectRef>
-          <a:fontRef idx="minor">
-            <a:schemeClr val="lt1"/>
-          </a:fontRef>
-        </p:style>
-        <p:txBody>
-          <a:bodyPr rtlCol="0" anchor="ctr"/>
-          <a:lstStyle/>
-          <a:p>
-            <a:pPr algn="ctr"/>
-          </a:p>
-        </p:txBody>
-      </p:sp>
-      <p:sp>
-        <p:nvSpPr>
-          <p:cNvPr id="49" name="TextBox 48"/>
-          <p:cNvSpPr txBox="1"/>
-          <p:nvPr/>
-        </p:nvSpPr>
-        <p:spPr>
-          <a:xfrm>
-            <a:off x="521208" y="4329684"/>
-            <a:ext cx="2953512" cy="278892"/>
-          </a:xfrm>
-          <a:prstGeom prst="rect">
-            <a:avLst/>
-          </a:prstGeom>
-          <a:noFill/>
-        </p:spPr>
-        <p:txBody>
-          <a:bodyPr wrap="square" lIns="36000" rIns="36000" tIns="18000" bIns="18000" anchor="ctr">
-            <a:spAutoFit/>
-          </a:bodyPr>
-          <a:lstStyle/>
-          <a:p>
-            <a:pPr algn="l"/>
-            <a:r>
-              <a:rPr sz="1100" b="1" i="0" u="none">
-                <a:solidFill>
-                  <a:srgbClr val="333333"/>
-                </a:solidFill>
-                <a:latin typeface="Calibri"/>
-              </a:rPr>
-              <a:t>Summe Top-5-Makler  (65 % der BÜ-Anfragen)</a:t>
-            </a:r>
-          </a:p>
-        </p:txBody>
-      </p:sp>
-      <p:sp>
-        <p:nvSpPr>
-          <p:cNvPr id="50" name="TextBox 49"/>
-          <p:cNvSpPr txBox="1"/>
-          <p:nvPr/>
-        </p:nvSpPr>
-        <p:spPr>
-          <a:xfrm>
-            <a:off x="3474720" y="4329684"/>
-            <a:ext cx="1508760" cy="278892"/>
-          </a:xfrm>
-          <a:prstGeom prst="rect">
-            <a:avLst/>
-          </a:prstGeom>
-          <a:noFill/>
-        </p:spPr>
-        <p:txBody>
-          <a:bodyPr wrap="square" lIns="36000" rIns="36000" tIns="18000" bIns="18000" anchor="ctr">
-            <a:spAutoFit/>
-          </a:bodyPr>
-          <a:lstStyle/>
-          <a:p>
-            <a:pPr algn="ctr"/>
-            <a:r>
-              <a:rPr sz="1100" b="1" i="0" u="none">
-                <a:solidFill>
-                  <a:srgbClr val="333333"/>
-                </a:solidFill>
-                <a:latin typeface="Calibri"/>
-              </a:rPr>
-              <a:t>2.594</a:t>
-            </a:r>
-          </a:p>
-        </p:txBody>
-      </p:sp>
-      <p:sp>
-        <p:nvSpPr>
-          <p:cNvPr id="51" name="TextBox 50"/>
-          <p:cNvSpPr txBox="1"/>
-          <p:nvPr/>
-        </p:nvSpPr>
-        <p:spPr>
-          <a:xfrm>
-            <a:off x="4983480" y="4329684"/>
-            <a:ext cx="1508760" cy="278892"/>
-          </a:xfrm>
-          <a:prstGeom prst="rect">
-            <a:avLst/>
-          </a:prstGeom>
-          <a:noFill/>
-        </p:spPr>
-        <p:txBody>
-          <a:bodyPr wrap="square" lIns="36000" rIns="36000" tIns="18000" bIns="18000" anchor="ctr">
-            <a:spAutoFit/>
-          </a:bodyPr>
-          <a:lstStyle/>
-          <a:p>
-            <a:pPr algn="ctr"/>
-            <a:r>
-              <a:rPr sz="1100" b="1" i="0" u="none">
-                <a:solidFill>
-                  <a:srgbClr val="333333"/>
-                </a:solidFill>
-                <a:latin typeface="Calibri"/>
-              </a:rPr>
-              <a:t>1.519</a:t>
-            </a:r>
-          </a:p>
-        </p:txBody>
-      </p:sp>
-      <p:sp>
-        <p:nvSpPr>
-          <p:cNvPr id="52" name="TextBox 51"/>
-          <p:cNvSpPr txBox="1"/>
-          <p:nvPr/>
-        </p:nvSpPr>
-        <p:spPr>
-          <a:xfrm>
-            <a:off x="6492240" y="4329684"/>
-            <a:ext cx="1554480" cy="278892"/>
-          </a:xfrm>
-          <a:prstGeom prst="rect">
-            <a:avLst/>
-          </a:prstGeom>
-          <a:noFill/>
-        </p:spPr>
-        <p:txBody>
-          <a:bodyPr wrap="square" lIns="36000" rIns="36000" tIns="18000" bIns="18000" anchor="ctr">
-            <a:spAutoFit/>
-          </a:bodyPr>
-          <a:lstStyle/>
-          <a:p>
-            <a:pPr algn="ctr"/>
-            <a:r>
-              <a:rPr sz="1100" b="1" i="0" u="none">
-                <a:solidFill>
-                  <a:srgbClr val="333333"/>
-                </a:solidFill>
-                <a:latin typeface="Calibri"/>
-              </a:rPr>
-              <a:t>1,71</a:t>
-            </a:r>
-          </a:p>
-        </p:txBody>
-      </p:sp>
-      <p:sp>
-        <p:nvSpPr>
-          <p:cNvPr id="53" name="Rectangle 52"/>
-          <p:cNvSpPr/>
-          <p:nvPr/>
-        </p:nvSpPr>
-        <p:spPr>
-          <a:xfrm>
-            <a:off x="411480" y="4608576"/>
-            <a:ext cx="7635240" cy="278892"/>
-          </a:xfrm>
-          <a:prstGeom prst="rect">
-            <a:avLst/>
-          </a:prstGeom>
-          <a:solidFill>
-            <a:srgbClr val="FFFFFF"/>
-          </a:solidFill>
-          <a:ln>
-            <a:noFill/>
-          </a:ln>
-          <a:effectLst/>
-        </p:spPr>
-        <p:style>
-          <a:lnRef idx="1">
-            <a:schemeClr val="accent1"/>
-          </a:lnRef>
-          <a:fillRef idx="3">
-            <a:schemeClr val="accent1"/>
-          </a:fillRef>
-          <a:effectRef idx="2">
-            <a:schemeClr val="accent1"/>
-          </a:effectRef>
-          <a:fontRef idx="minor">
-            <a:schemeClr val="lt1"/>
-          </a:fontRef>
-        </p:style>
-        <p:txBody>
-          <a:bodyPr rtlCol="0" anchor="ctr"/>
-          <a:lstStyle/>
-          <a:p>
-            <a:pPr algn="ctr"/>
-          </a:p>
-        </p:txBody>
-      </p:sp>
-      <p:sp>
-        <p:nvSpPr>
-          <p:cNvPr id="54" name="TextBox 53"/>
-          <p:cNvSpPr txBox="1"/>
-          <p:nvPr/>
-        </p:nvSpPr>
-        <p:spPr>
-          <a:xfrm>
-            <a:off x="521208" y="4608576"/>
-            <a:ext cx="2953512" cy="278892"/>
-          </a:xfrm>
-          <a:prstGeom prst="rect">
-            <a:avLst/>
-          </a:prstGeom>
-          <a:noFill/>
-        </p:spPr>
-        <p:txBody>
-          <a:bodyPr wrap="square" lIns="36000" rIns="36000" tIns="18000" bIns="18000" anchor="ctr">
-            <a:spAutoFit/>
-          </a:bodyPr>
-          <a:lstStyle/>
-          <a:p>
-            <a:pPr algn="l"/>
-            <a:r>
-              <a:rPr sz="1100" b="1" i="0" u="none">
-                <a:solidFill>
-                  <a:srgbClr val="333333"/>
-                </a:solidFill>
-                <a:latin typeface="Calibri"/>
-              </a:rPr>
-              <a:t>Sonstige Makler (Long-Tail)</a:t>
-            </a:r>
-          </a:p>
-        </p:txBody>
-      </p:sp>
-      <p:sp>
-        <p:nvSpPr>
-          <p:cNvPr id="55" name="TextBox 54"/>
-          <p:cNvSpPr txBox="1"/>
-          <p:nvPr/>
-        </p:nvSpPr>
-        <p:spPr>
-          <a:xfrm>
-            <a:off x="3474720" y="4608576"/>
-            <a:ext cx="1508760" cy="278892"/>
-          </a:xfrm>
-          <a:prstGeom prst="rect">
-            <a:avLst/>
-          </a:prstGeom>
-          <a:noFill/>
-        </p:spPr>
-        <p:txBody>
-          <a:bodyPr wrap="square" lIns="36000" rIns="36000" tIns="18000" bIns="18000" anchor="ctr">
-            <a:spAutoFit/>
-          </a:bodyPr>
-          <a:lstStyle/>
-          <a:p>
-            <a:pPr algn="ctr"/>
-            <a:r>
-              <a:rPr sz="1100" b="0" i="0" u="none">
-                <a:solidFill>
-                  <a:srgbClr val="333333"/>
-                </a:solidFill>
-                <a:latin typeface="Calibri"/>
-              </a:rPr>
-              <a:t>1.406</a:t>
-            </a:r>
-          </a:p>
-        </p:txBody>
-      </p:sp>
-      <p:sp>
-        <p:nvSpPr>
-          <p:cNvPr id="56" name="TextBox 55"/>
-          <p:cNvSpPr txBox="1"/>
-          <p:nvPr/>
-        </p:nvSpPr>
-        <p:spPr>
-          <a:xfrm>
-            <a:off x="4983480" y="4608576"/>
-            <a:ext cx="1508760" cy="278892"/>
-          </a:xfrm>
-          <a:prstGeom prst="rect">
-            <a:avLst/>
-          </a:prstGeom>
-          <a:noFill/>
-        </p:spPr>
-        <p:txBody>
-          <a:bodyPr wrap="square" lIns="36000" rIns="36000" tIns="18000" bIns="18000" anchor="ctr">
-            <a:spAutoFit/>
-          </a:bodyPr>
-          <a:lstStyle/>
-          <a:p>
-            <a:pPr algn="ctr"/>
-            <a:r>
-              <a:rPr sz="1100" b="0" i="0" u="none">
-                <a:solidFill>
-                  <a:srgbClr val="333333"/>
-                </a:solidFill>
-                <a:latin typeface="Calibri"/>
-              </a:rPr>
-              <a:t>982</a:t>
-            </a:r>
-          </a:p>
-        </p:txBody>
-      </p:sp>
-      <p:sp>
-        <p:nvSpPr>
-          <p:cNvPr id="57" name="TextBox 56"/>
-          <p:cNvSpPr txBox="1"/>
-          <p:nvPr/>
-        </p:nvSpPr>
-        <p:spPr>
-          <a:xfrm>
-            <a:off x="6492240" y="4608576"/>
-            <a:ext cx="1554480" cy="278892"/>
-          </a:xfrm>
-          <a:prstGeom prst="rect">
-            <a:avLst/>
-          </a:prstGeom>
-          <a:noFill/>
-        </p:spPr>
-        <p:txBody>
-          <a:bodyPr wrap="square" lIns="36000" rIns="36000" tIns="18000" bIns="18000" anchor="ctr">
-            <a:spAutoFit/>
-          </a:bodyPr>
-          <a:lstStyle/>
-          <a:p>
-            <a:pPr algn="ctr"/>
-            <a:r>
-              <a:rPr sz="1100" b="0" i="0" u="none">
-                <a:solidFill>
-                  <a:srgbClr val="333333"/>
-                </a:solidFill>
-                <a:latin typeface="Calibri"/>
-              </a:rPr>
-              <a:t>1,43</a:t>
-            </a:r>
-          </a:p>
-        </p:txBody>
-      </p:sp>
-      <p:sp>
-        <p:nvSpPr>
-          <p:cNvPr id="58" name="Rectangle 57"/>
-          <p:cNvSpPr/>
-          <p:nvPr/>
-        </p:nvSpPr>
-        <p:spPr>
-          <a:xfrm>
-            <a:off x="411480" y="4887468"/>
-            <a:ext cx="7635240" cy="278892"/>
-          </a:xfrm>
-          <a:prstGeom prst="rect">
-            <a:avLst/>
-          </a:prstGeom>
-          <a:solidFill>
-            <a:srgbClr val="E9EFF1"/>
-          </a:solidFill>
-          <a:ln>
-            <a:noFill/>
-          </a:ln>
-          <a:effectLst/>
-        </p:spPr>
-        <p:style>
-          <a:lnRef idx="1">
-            <a:schemeClr val="accent1"/>
-          </a:lnRef>
-          <a:fillRef idx="3">
-            <a:schemeClr val="accent1"/>
-          </a:fillRef>
-          <a:effectRef idx="2">
-            <a:schemeClr val="accent1"/>
-          </a:effectRef>
-          <a:fontRef idx="minor">
-            <a:schemeClr val="lt1"/>
-          </a:fontRef>
-        </p:style>
-        <p:txBody>
-          <a:bodyPr rtlCol="0" anchor="ctr"/>
-          <a:lstStyle/>
-          <a:p>
-            <a:pPr algn="ctr"/>
-          </a:p>
-        </p:txBody>
-      </p:sp>
-      <p:sp>
-        <p:nvSpPr>
-          <p:cNvPr id="59" name="TextBox 58"/>
-          <p:cNvSpPr txBox="1"/>
-          <p:nvPr/>
-        </p:nvSpPr>
-        <p:spPr>
-          <a:xfrm>
-            <a:off x="521208" y="4887468"/>
-            <a:ext cx="2953512" cy="278892"/>
-          </a:xfrm>
-          <a:prstGeom prst="rect">
-            <a:avLst/>
-          </a:prstGeom>
-          <a:noFill/>
-        </p:spPr>
-        <p:txBody>
-          <a:bodyPr wrap="square" lIns="36000" rIns="36000" tIns="18000" bIns="18000" anchor="ctr">
-            <a:spAutoFit/>
-          </a:bodyPr>
-          <a:lstStyle/>
-          <a:p>
-            <a:pPr algn="l"/>
-            <a:r>
-              <a:rPr sz="1100" b="1" i="0" u="none">
-                <a:solidFill>
-                  <a:srgbClr val="333333"/>
-                </a:solidFill>
-                <a:latin typeface="Calibri"/>
-              </a:rPr>
-              <a:t>Gesamt</a:t>
-            </a:r>
-          </a:p>
-        </p:txBody>
-      </p:sp>
-      <p:sp>
-        <p:nvSpPr>
-          <p:cNvPr id="60" name="TextBox 59"/>
-          <p:cNvSpPr txBox="1"/>
-          <p:nvPr/>
-        </p:nvSpPr>
-        <p:spPr>
-          <a:xfrm>
-            <a:off x="3474720" y="4887468"/>
-            <a:ext cx="1508760" cy="278892"/>
-          </a:xfrm>
-          <a:prstGeom prst="rect">
-            <a:avLst/>
-          </a:prstGeom>
-          <a:noFill/>
-        </p:spPr>
-        <p:txBody>
-          <a:bodyPr wrap="square" lIns="36000" rIns="36000" tIns="18000" bIns="18000" anchor="ctr">
-            <a:spAutoFit/>
-          </a:bodyPr>
-          <a:lstStyle/>
-          <a:p>
-            <a:pPr algn="ctr"/>
-            <a:r>
-              <a:rPr sz="1100" b="1" i="0" u="none">
-                <a:solidFill>
-                  <a:srgbClr val="333333"/>
-                </a:solidFill>
-                <a:latin typeface="Calibri"/>
-              </a:rPr>
-              <a:t>4.000</a:t>
-            </a:r>
-          </a:p>
-        </p:txBody>
-      </p:sp>
-      <p:sp>
-        <p:nvSpPr>
-          <p:cNvPr id="61" name="TextBox 60"/>
-          <p:cNvSpPr txBox="1"/>
-          <p:nvPr/>
-        </p:nvSpPr>
-        <p:spPr>
-          <a:xfrm>
-            <a:off x="4983480" y="4887468"/>
-            <a:ext cx="1508760" cy="278892"/>
-          </a:xfrm>
-          <a:prstGeom prst="rect">
-            <a:avLst/>
-          </a:prstGeom>
-          <a:noFill/>
-        </p:spPr>
-        <p:txBody>
-          <a:bodyPr wrap="square" lIns="36000" rIns="36000" tIns="18000" bIns="18000" anchor="ctr">
-            <a:spAutoFit/>
-          </a:bodyPr>
-          <a:lstStyle/>
-          <a:p>
-            <a:pPr algn="ctr"/>
-            <a:r>
-              <a:rPr sz="1100" b="1" i="0" u="none">
-                <a:solidFill>
-                  <a:srgbClr val="333333"/>
-                </a:solidFill>
-                <a:latin typeface="Calibri"/>
-              </a:rPr>
-              <a:t>2.495</a:t>
-            </a:r>
-          </a:p>
-        </p:txBody>
-      </p:sp>
-      <p:sp>
-        <p:nvSpPr>
-          <p:cNvPr id="62" name="TextBox 61"/>
-          <p:cNvSpPr txBox="1"/>
-          <p:nvPr/>
-        </p:nvSpPr>
-        <p:spPr>
-          <a:xfrm>
-            <a:off x="6492240" y="4887468"/>
-            <a:ext cx="1554480" cy="278892"/>
-          </a:xfrm>
-          <a:prstGeom prst="rect">
-            <a:avLst/>
-          </a:prstGeom>
-          <a:noFill/>
-        </p:spPr>
-        <p:txBody>
-          <a:bodyPr wrap="square" lIns="36000" rIns="36000" tIns="18000" bIns="18000" anchor="ctr">
-            <a:spAutoFit/>
-          </a:bodyPr>
-          <a:lstStyle/>
-          <a:p>
-            <a:pPr algn="ctr"/>
-            <a:r>
-              <a:rPr sz="1100" b="1" i="0" u="none">
-                <a:solidFill>
-                  <a:srgbClr val="333333"/>
-                </a:solidFill>
-                <a:latin typeface="Calibri"/>
-              </a:rPr>
-              <a:t>1,60</a:t>
-            </a:r>
-          </a:p>
-        </p:txBody>
-      </p:sp>
-      <p:sp>
-        <p:nvSpPr>
-          <p:cNvPr id="63" name="Rectangle 62"/>
-          <p:cNvSpPr/>
-          <p:nvPr/>
-        </p:nvSpPr>
-        <p:spPr>
-          <a:xfrm>
-            <a:off x="411480" y="5312664"/>
-            <a:ext cx="7635240" cy="640080"/>
+            <a:off x="411480" y="5276088"/>
+            <a:ext cx="7635240" cy="566928"/>
           </a:xfrm>
           <a:prstGeom prst="rect">
             <a:avLst/>
@@ -9905,13 +9027,13 @@
       </p:sp>
       <p:sp>
         <p:nvSpPr>
-          <p:cNvPr id="64" name="TextBox 63"/>
-          <p:cNvSpPr txBox="1"/>
-          <p:nvPr/>
-        </p:nvSpPr>
-        <p:spPr>
-          <a:xfrm>
-            <a:off x="594360" y="5367528"/>
+          <p:cNvPr id="20" name="TextBox 19"/>
+          <p:cNvSpPr txBox="1"/>
+          <p:nvPr/>
+        </p:nvSpPr>
+        <p:spPr>
+          <a:xfrm>
+            <a:off x="594360" y="5312664"/>
             <a:ext cx="7269480" cy="274320"/>
           </a:xfrm>
           <a:prstGeom prst="rect">
@@ -9927,7 +9049,7 @@
           <a:p>
             <a:pPr algn="l"/>
             <a:r>
-              <a:rPr sz="1200" b="1" i="0" u="none">
+              <a:rPr sz="1100" b="1" i="0" u="none">
                 <a:solidFill>
                   <a:srgbClr val="006B77"/>
                 </a:solidFill>
@@ -9940,14 +9062,14 @@
       </p:sp>
       <p:sp>
         <p:nvSpPr>
-          <p:cNvPr id="65" name="TextBox 64"/>
-          <p:cNvSpPr txBox="1"/>
-          <p:nvPr/>
-        </p:nvSpPr>
-        <p:spPr>
-          <a:xfrm>
-            <a:off x="594360" y="5660136"/>
-            <a:ext cx="7269480" cy="274320"/>
+          <p:cNvPr id="21" name="TextBox 20"/>
+          <p:cNvSpPr txBox="1"/>
+          <p:nvPr/>
+        </p:nvSpPr>
+        <p:spPr>
+          <a:xfrm>
+            <a:off x="594360" y="5568696"/>
+            <a:ext cx="7269480" cy="256032"/>
           </a:xfrm>
           <a:prstGeom prst="rect">
             <a:avLst/>
@@ -9962,7 +9084,7 @@
           <a:p>
             <a:pPr algn="l"/>
             <a:r>
-              <a:rPr sz="1100" b="0" i="0" u="none">
+              <a:rPr sz="1000" b="0" i="0" u="none">
                 <a:solidFill>
                   <a:srgbClr val="333333"/>
                 </a:solidFill>
@@ -9975,7 +9097,7 @@
       </p:sp>
       <p:sp>
         <p:nvSpPr>
-          <p:cNvPr id="66" name="Rectangle 65"/>
+          <p:cNvPr id="22" name="Rectangle 21"/>
           <p:cNvSpPr/>
           <p:nvPr/>
         </p:nvSpPr>
@@ -10019,13 +9141,13 @@
       </p:sp>
       <p:sp>
         <p:nvSpPr>
-          <p:cNvPr id="67" name="TextBox 66"/>
-          <p:cNvSpPr txBox="1"/>
-          <p:nvPr/>
-        </p:nvSpPr>
-        <p:spPr>
-          <a:xfrm>
-            <a:off x="8339328" y="2331720"/>
+          <p:cNvPr id="23" name="TextBox 22"/>
+          <p:cNvSpPr txBox="1"/>
+          <p:nvPr/>
+        </p:nvSpPr>
+        <p:spPr>
+          <a:xfrm>
+            <a:off x="8339328" y="2304288"/>
             <a:ext cx="3392424" cy="256032"/>
           </a:xfrm>
           <a:prstGeom prst="rect">
@@ -10052,988 +9174,467 @@
           </a:p>
         </p:txBody>
       </p:sp>
-      <p:sp>
-        <p:nvSpPr>
-          <p:cNvPr id="68" name="Rectangle 67"/>
+      <p:graphicFrame>
+        <p:nvGraphicFramePr>
+          <p:cNvPr id="24" name="Table 23"/>
+          <p:cNvGraphicFramePr>
+            <a:graphicFrameLocks noGrp="1"/>
+          </p:cNvGraphicFramePr>
+          <p:nvPr/>
+        </p:nvGraphicFramePr>
+        <p:xfrm>
+          <a:off x="8321040" y="2606040"/>
+          <a:ext cx="3429000" cy="1554480"/>
+        </p:xfrm>
+        <a:graphic>
+          <a:graphicData uri="http://schemas.openxmlformats.org/drawingml/2006/table">
+            <a:tbl>
+              <a:tblPr bandRow="1">
+                <a:tableStyleId>{5C22544A-7EE6-4342-B048-85BDC9FD1C3A}</a:tableStyleId>
+              </a:tblPr>
+              <a:tblGrid>
+                <a:gridCol w="1143000"/>
+                <a:gridCol w="1097280"/>
+                <a:gridCol w="1188720"/>
+              </a:tblGrid>
+              <a:tr h="274320">
+                <a:tc>
+                  <a:txBody>
+                    <a:bodyPr lIns="36000" rIns="36000" tIns="18000" bIns="18000"/>
+                    <a:lstStyle/>
+                    <a:p>
+                      <a:pPr algn="l"/>
+                      <a:r>
+                        <a:rPr sz="1000" b="1" i="0">
+                          <a:solidFill>
+                            <a:srgbClr val="FFFFFF"/>
+                          </a:solidFill>
+                          <a:latin typeface="Calibri"/>
+                        </a:rPr>
+                        <a:t>Sparte</a:t>
+                      </a:r>
+                    </a:p>
+                  </a:txBody>
+                  <a:tcPr anchor="ctr">
+                    <a:solidFill>
+                      <a:srgbClr val="006B77"/>
+                    </a:solidFill>
+                  </a:tcPr>
+                </a:tc>
+                <a:tc>
+                  <a:txBody>
+                    <a:bodyPr lIns="36000" rIns="36000" tIns="18000" bIns="18000"/>
+                    <a:lstStyle/>
+                    <a:p>
+                      <a:pPr algn="ctr"/>
+                      <a:r>
+                        <a:rPr sz="1000" b="1" i="0">
+                          <a:solidFill>
+                            <a:srgbClr val="FFFFFF"/>
+                          </a:solidFill>
+                          <a:latin typeface="Calibri"/>
+                        </a:rPr>
+                        <a:t>BÜ-Anfr.</a:t>
+                      </a:r>
+                    </a:p>
+                  </a:txBody>
+                  <a:tcPr anchor="ctr">
+                    <a:solidFill>
+                      <a:srgbClr val="006B77"/>
+                    </a:solidFill>
+                  </a:tcPr>
+                </a:tc>
+                <a:tc>
+                  <a:txBody>
+                    <a:bodyPr lIns="36000" rIns="36000" tIns="18000" bIns="18000"/>
+                    <a:lstStyle/>
+                    <a:p>
+                      <a:pPr algn="ctr"/>
+                      <a:r>
+                        <a:rPr sz="1000" b="1" i="0">
+                          <a:solidFill>
+                            <a:srgbClr val="FFFFFF"/>
+                          </a:solidFill>
+                          <a:latin typeface="Calibri"/>
+                        </a:rPr>
+                        <a:t>in Cluster</a:t>
+                      </a:r>
+                    </a:p>
+                  </a:txBody>
+                  <a:tcPr anchor="ctr">
+                    <a:solidFill>
+                      <a:srgbClr val="006B77"/>
+                    </a:solidFill>
+                  </a:tcPr>
+                </a:tc>
+              </a:tr>
+              <a:tr h="256032">
+                <a:tc>
+                  <a:txBody>
+                    <a:bodyPr lIns="36000" rIns="36000" tIns="18000" bIns="18000"/>
+                    <a:lstStyle/>
+                    <a:p>
+                      <a:pPr algn="l"/>
+                      <a:r>
+                        <a:rPr sz="1000" b="1" i="0">
+                          <a:solidFill>
+                            <a:srgbClr val="9C060F"/>
+                          </a:solidFill>
+                          <a:latin typeface="Calibri"/>
+                        </a:rPr>
+                        <a:t>KV</a:t>
+                      </a:r>
+                    </a:p>
+                  </a:txBody>
+                  <a:tcPr anchor="ctr">
+                    <a:solidFill>
+                      <a:srgbClr val="FDE2C4"/>
+                    </a:solidFill>
+                  </a:tcPr>
+                </a:tc>
+                <a:tc>
+                  <a:txBody>
+                    <a:bodyPr lIns="36000" rIns="36000" tIns="18000" bIns="18000"/>
+                    <a:lstStyle/>
+                    <a:p>
+                      <a:pPr algn="ctr"/>
+                      <a:r>
+                        <a:rPr sz="1000" b="1" i="0">
+                          <a:solidFill>
+                            <a:srgbClr val="9C060F"/>
+                          </a:solidFill>
+                          <a:latin typeface="Calibri"/>
+                        </a:rPr>
+                        <a:t>1.147</a:t>
+                      </a:r>
+                    </a:p>
+                  </a:txBody>
+                  <a:tcPr anchor="ctr">
+                    <a:solidFill>
+                      <a:srgbClr val="FDE2C4"/>
+                    </a:solidFill>
+                  </a:tcPr>
+                </a:tc>
+                <a:tc>
+                  <a:txBody>
+                    <a:bodyPr lIns="36000" rIns="36000" tIns="18000" bIns="18000"/>
+                    <a:lstStyle/>
+                    <a:p>
+                      <a:pPr algn="ctr"/>
+                      <a:r>
+                        <a:rPr sz="1000" b="1" i="0">
+                          <a:solidFill>
+                            <a:srgbClr val="9C060F"/>
+                          </a:solidFill>
+                          <a:latin typeface="Calibri"/>
+                        </a:rPr>
+                        <a:t>354 (31 %)</a:t>
+                      </a:r>
+                    </a:p>
+                  </a:txBody>
+                  <a:tcPr anchor="ctr">
+                    <a:solidFill>
+                      <a:srgbClr val="FDE2C4"/>
+                    </a:solidFill>
+                  </a:tcPr>
+                </a:tc>
+              </a:tr>
+              <a:tr h="256032">
+                <a:tc>
+                  <a:txBody>
+                    <a:bodyPr lIns="36000" rIns="36000" tIns="18000" bIns="18000"/>
+                    <a:lstStyle/>
+                    <a:p>
+                      <a:pPr algn="l"/>
+                      <a:r>
+                        <a:rPr sz="1000" b="0" i="0">
+                          <a:solidFill>
+                            <a:srgbClr val="333333"/>
+                          </a:solidFill>
+                          <a:latin typeface="Calibri"/>
+                        </a:rPr>
+                        <a:t>Komposit</a:t>
+                      </a:r>
+                    </a:p>
+                  </a:txBody>
+                  <a:tcPr anchor="ctr"/>
+                </a:tc>
+                <a:tc>
+                  <a:txBody>
+                    <a:bodyPr lIns="36000" rIns="36000" tIns="18000" bIns="18000"/>
+                    <a:lstStyle/>
+                    <a:p>
+                      <a:pPr algn="ctr"/>
+                      <a:r>
+                        <a:rPr sz="1000" b="0" i="0">
+                          <a:solidFill>
+                            <a:srgbClr val="333333"/>
+                          </a:solidFill>
+                          <a:latin typeface="Calibri"/>
+                        </a:rPr>
+                        <a:t>2.089</a:t>
+                      </a:r>
+                    </a:p>
+                  </a:txBody>
+                  <a:tcPr anchor="ctr"/>
+                </a:tc>
+                <a:tc>
+                  <a:txBody>
+                    <a:bodyPr lIns="36000" rIns="36000" tIns="18000" bIns="18000"/>
+                    <a:lstStyle/>
+                    <a:p>
+                      <a:pPr algn="ctr"/>
+                      <a:r>
+                        <a:rPr sz="1000" b="0" i="0">
+                          <a:solidFill>
+                            <a:srgbClr val="333333"/>
+                          </a:solidFill>
+                          <a:latin typeface="Calibri"/>
+                        </a:rPr>
+                        <a:t>1.405 (67 %)</a:t>
+                      </a:r>
+                    </a:p>
+                  </a:txBody>
+                  <a:tcPr anchor="ctr"/>
+                </a:tc>
+              </a:tr>
+              <a:tr h="256032">
+                <a:tc>
+                  <a:txBody>
+                    <a:bodyPr lIns="36000" rIns="36000" tIns="18000" bIns="18000"/>
+                    <a:lstStyle/>
+                    <a:p>
+                      <a:pPr algn="l"/>
+                      <a:r>
+                        <a:rPr sz="1000" b="0" i="0">
+                          <a:solidFill>
+                            <a:srgbClr val="333333"/>
+                          </a:solidFill>
+                          <a:latin typeface="Calibri"/>
+                        </a:rPr>
+                        <a:t>Leben</a:t>
+                      </a:r>
+                    </a:p>
+                  </a:txBody>
+                  <a:tcPr anchor="ctr"/>
+                </a:tc>
+                <a:tc>
+                  <a:txBody>
+                    <a:bodyPr lIns="36000" rIns="36000" tIns="18000" bIns="18000"/>
+                    <a:lstStyle/>
+                    <a:p>
+                      <a:pPr algn="ctr"/>
+                      <a:r>
+                        <a:rPr sz="1000" b="0" i="0">
+                          <a:solidFill>
+                            <a:srgbClr val="333333"/>
+                          </a:solidFill>
+                          <a:latin typeface="Calibri"/>
+                        </a:rPr>
+                        <a:t>662</a:t>
+                      </a:r>
+                    </a:p>
+                  </a:txBody>
+                  <a:tcPr anchor="ctr"/>
+                </a:tc>
+                <a:tc>
+                  <a:txBody>
+                    <a:bodyPr lIns="36000" rIns="36000" tIns="18000" bIns="18000"/>
+                    <a:lstStyle/>
+                    <a:p>
+                      <a:pPr algn="ctr"/>
+                      <a:r>
+                        <a:rPr sz="1000" b="0" i="0">
+                          <a:solidFill>
+                            <a:srgbClr val="333333"/>
+                          </a:solidFill>
+                          <a:latin typeface="Calibri"/>
+                        </a:rPr>
+                        <a:t>325 (49 %)</a:t>
+                      </a:r>
+                    </a:p>
+                  </a:txBody>
+                  <a:tcPr anchor="ctr"/>
+                </a:tc>
+              </a:tr>
+              <a:tr h="256032">
+                <a:tc>
+                  <a:txBody>
+                    <a:bodyPr lIns="36000" rIns="36000" tIns="18000" bIns="18000"/>
+                    <a:lstStyle/>
+                    <a:p>
+                      <a:pPr algn="l"/>
+                      <a:r>
+                        <a:rPr sz="1000" b="0" i="0">
+                          <a:solidFill>
+                            <a:srgbClr val="333333"/>
+                          </a:solidFill>
+                          <a:latin typeface="Calibri"/>
+                        </a:rPr>
+                        <a:t>Sonstige</a:t>
+                      </a:r>
+                    </a:p>
+                  </a:txBody>
+                  <a:tcPr anchor="ctr"/>
+                </a:tc>
+                <a:tc>
+                  <a:txBody>
+                    <a:bodyPr lIns="36000" rIns="36000" tIns="18000" bIns="18000"/>
+                    <a:lstStyle/>
+                    <a:p>
+                      <a:pPr algn="ctr"/>
+                      <a:r>
+                        <a:rPr sz="1000" b="0" i="0">
+                          <a:solidFill>
+                            <a:srgbClr val="333333"/>
+                          </a:solidFill>
+                          <a:latin typeface="Calibri"/>
+                        </a:rPr>
+                        <a:t>102</a:t>
+                      </a:r>
+                    </a:p>
+                  </a:txBody>
+                  <a:tcPr anchor="ctr"/>
+                </a:tc>
+                <a:tc>
+                  <a:txBody>
+                    <a:bodyPr lIns="36000" rIns="36000" tIns="18000" bIns="18000"/>
+                    <a:lstStyle/>
+                    <a:p>
+                      <a:pPr algn="ctr"/>
+                      <a:r>
+                        <a:rPr sz="1000" b="0" i="0">
+                          <a:solidFill>
+                            <a:srgbClr val="333333"/>
+                          </a:solidFill>
+                          <a:latin typeface="Calibri"/>
+                        </a:rPr>
+                        <a:t>33 (32 %)</a:t>
+                      </a:r>
+                    </a:p>
+                  </a:txBody>
+                  <a:tcPr anchor="ctr"/>
+                </a:tc>
+              </a:tr>
+              <a:tr h="256032">
+                <a:tc>
+                  <a:txBody>
+                    <a:bodyPr lIns="36000" rIns="36000" tIns="18000" bIns="18000"/>
+                    <a:lstStyle/>
+                    <a:p>
+                      <a:pPr algn="l"/>
+                      <a:r>
+                        <a:rPr sz="1000" b="1" i="0">
+                          <a:solidFill>
+                            <a:srgbClr val="333333"/>
+                          </a:solidFill>
+                          <a:latin typeface="Calibri"/>
+                        </a:rPr>
+                        <a:t>Gesamt</a:t>
+                      </a:r>
+                    </a:p>
+                  </a:txBody>
+                  <a:tcPr anchor="ctr">
+                    <a:solidFill>
+                      <a:srgbClr val="E9EFF1"/>
+                    </a:solidFill>
+                  </a:tcPr>
+                </a:tc>
+                <a:tc>
+                  <a:txBody>
+                    <a:bodyPr lIns="36000" rIns="36000" tIns="18000" bIns="18000"/>
+                    <a:lstStyle/>
+                    <a:p>
+                      <a:pPr algn="ctr"/>
+                      <a:r>
+                        <a:rPr sz="1000" b="1" i="0">
+                          <a:solidFill>
+                            <a:srgbClr val="333333"/>
+                          </a:solidFill>
+                          <a:latin typeface="Calibri"/>
+                        </a:rPr>
+                        <a:t>4.000</a:t>
+                      </a:r>
+                    </a:p>
+                  </a:txBody>
+                  <a:tcPr anchor="ctr">
+                    <a:solidFill>
+                      <a:srgbClr val="E9EFF1"/>
+                    </a:solidFill>
+                  </a:tcPr>
+                </a:tc>
+                <a:tc>
+                  <a:txBody>
+                    <a:bodyPr lIns="36000" rIns="36000" tIns="18000" bIns="18000"/>
+                    <a:lstStyle/>
+                    <a:p>
+                      <a:pPr algn="ctr"/>
+                      <a:r>
+                        <a:rPr sz="1000" b="1" i="0">
+                          <a:solidFill>
+                            <a:srgbClr val="333333"/>
+                          </a:solidFill>
+                          <a:latin typeface="Calibri"/>
+                        </a:rPr>
+                        <a:t>2.117 (53 %)</a:t>
+                      </a:r>
+                    </a:p>
+                  </a:txBody>
+                  <a:tcPr anchor="ctr">
+                    <a:solidFill>
+                      <a:srgbClr val="E9EFF1"/>
+                    </a:solidFill>
+                  </a:tcPr>
+                </a:tc>
+              </a:tr>
+            </a:tbl>
+          </a:graphicData>
+        </a:graphic>
+      </p:graphicFrame>
+      <p:sp>
+        <p:nvSpPr>
+          <p:cNvPr id="25" name="TextBox 24"/>
+          <p:cNvSpPr txBox="1"/>
+          <p:nvPr/>
+        </p:nvSpPr>
+        <p:spPr>
+          <a:xfrm>
+            <a:off x="8339328" y="4206240"/>
+            <a:ext cx="3392424" cy="256032"/>
+          </a:xfrm>
+          <a:prstGeom prst="rect">
+            <a:avLst/>
+          </a:prstGeom>
+          <a:noFill/>
+        </p:spPr>
+        <p:txBody>
+          <a:bodyPr wrap="square" lIns="36000" rIns="36000" tIns="18000" bIns="18000" anchor="t">
+            <a:spAutoFit/>
+          </a:bodyPr>
+          <a:lstStyle/>
+          <a:p>
+            <a:pPr algn="l"/>
+            <a:r>
+              <a:rPr sz="900" b="0" i="1" u="none">
+                <a:solidFill>
+                  <a:srgbClr val="9C060F"/>
+                </a:solidFill>
+                <a:latin typeface="Calibri"/>
+              </a:rPr>
+              <a:t>KV: kein VNR-Mapping → jede Mail = eigener Vorgang</a:t>
+            </a:r>
+          </a:p>
+        </p:txBody>
+      </p:sp>
+      <p:sp>
+        <p:nvSpPr>
+          <p:cNvPr id="26" name="Oval 25"/>
           <p:cNvSpPr/>
           <p:nvPr/>
         </p:nvSpPr>
         <p:spPr>
           <a:xfrm>
-            <a:off x="8321040" y="2606040"/>
-            <a:ext cx="3429000" cy="274320"/>
-          </a:xfrm>
-          <a:prstGeom prst="rect">
-            <a:avLst/>
-          </a:prstGeom>
-          <a:solidFill>
-            <a:srgbClr val="006B77"/>
-          </a:solidFill>
-          <a:ln>
-            <a:noFill/>
-          </a:ln>
-          <a:effectLst/>
-        </p:spPr>
-        <p:style>
-          <a:lnRef idx="1">
-            <a:schemeClr val="accent1"/>
-          </a:lnRef>
-          <a:fillRef idx="3">
-            <a:schemeClr val="accent1"/>
-          </a:fillRef>
-          <a:effectRef idx="2">
-            <a:schemeClr val="accent1"/>
-          </a:effectRef>
-          <a:fontRef idx="minor">
-            <a:schemeClr val="lt1"/>
-          </a:fontRef>
-        </p:style>
-        <p:txBody>
-          <a:bodyPr rtlCol="0" anchor="ctr"/>
-          <a:lstStyle/>
-          <a:p>
-            <a:pPr algn="ctr"/>
-          </a:p>
-        </p:txBody>
-      </p:sp>
-      <p:sp>
-        <p:nvSpPr>
-          <p:cNvPr id="69" name="TextBox 68"/>
-          <p:cNvSpPr txBox="1"/>
-          <p:nvPr/>
-        </p:nvSpPr>
-        <p:spPr>
-          <a:xfrm>
-            <a:off x="8321040" y="2606040"/>
-            <a:ext cx="1143000" cy="274320"/>
-          </a:xfrm>
-          <a:prstGeom prst="rect">
-            <a:avLst/>
-          </a:prstGeom>
-          <a:noFill/>
-        </p:spPr>
-        <p:txBody>
-          <a:bodyPr wrap="square" lIns="36000" rIns="36000" tIns="18000" bIns="18000" anchor="ctr">
-            <a:spAutoFit/>
-          </a:bodyPr>
-          <a:lstStyle/>
-          <a:p>
-            <a:pPr algn="l"/>
-            <a:r>
-              <a:rPr sz="900" b="1" i="0" u="none">
-                <a:solidFill>
-                  <a:srgbClr val="FFFFFF"/>
-                </a:solidFill>
-                <a:latin typeface="Calibri"/>
-              </a:rPr>
-              <a:t>Sparte</a:t>
-            </a:r>
-          </a:p>
-        </p:txBody>
-      </p:sp>
-      <p:sp>
-        <p:nvSpPr>
-          <p:cNvPr id="70" name="TextBox 69"/>
-          <p:cNvSpPr txBox="1"/>
-          <p:nvPr/>
-        </p:nvSpPr>
-        <p:spPr>
-          <a:xfrm>
-            <a:off x="9464040" y="2606040"/>
-            <a:ext cx="1143000" cy="274320"/>
-          </a:xfrm>
-          <a:prstGeom prst="rect">
-            <a:avLst/>
-          </a:prstGeom>
-          <a:noFill/>
-        </p:spPr>
-        <p:txBody>
-          <a:bodyPr wrap="square" lIns="36000" rIns="36000" tIns="18000" bIns="18000" anchor="ctr">
-            <a:spAutoFit/>
-          </a:bodyPr>
-          <a:lstStyle/>
-          <a:p>
-            <a:pPr algn="ctr"/>
-            <a:r>
-              <a:rPr sz="900" b="1" i="0" u="none">
-                <a:solidFill>
-                  <a:srgbClr val="FFFFFF"/>
-                </a:solidFill>
-                <a:latin typeface="Calibri"/>
-              </a:rPr>
-              <a:t>BÜ-Anfr.</a:t>
-            </a:r>
-          </a:p>
-        </p:txBody>
-      </p:sp>
-      <p:sp>
-        <p:nvSpPr>
-          <p:cNvPr id="71" name="TextBox 70"/>
-          <p:cNvSpPr txBox="1"/>
-          <p:nvPr/>
-        </p:nvSpPr>
-        <p:spPr>
-          <a:xfrm>
-            <a:off x="10607040" y="2606040"/>
-            <a:ext cx="1143000" cy="274320"/>
-          </a:xfrm>
-          <a:prstGeom prst="rect">
-            <a:avLst/>
-          </a:prstGeom>
-          <a:noFill/>
-        </p:spPr>
-        <p:txBody>
-          <a:bodyPr wrap="square" lIns="36000" rIns="36000" tIns="18000" bIns="18000" anchor="ctr">
-            <a:spAutoFit/>
-          </a:bodyPr>
-          <a:lstStyle/>
-          <a:p>
-            <a:pPr algn="ctr"/>
-            <a:r>
-              <a:rPr sz="900" b="1" i="0" u="none">
-                <a:solidFill>
-                  <a:srgbClr val="FFFFFF"/>
-                </a:solidFill>
-                <a:latin typeface="Calibri"/>
-              </a:rPr>
-              <a:t>in Cluster</a:t>
-            </a:r>
-          </a:p>
-        </p:txBody>
-      </p:sp>
-      <p:sp>
-        <p:nvSpPr>
-          <p:cNvPr id="72" name="Rectangle 71"/>
-          <p:cNvSpPr/>
-          <p:nvPr/>
-        </p:nvSpPr>
-        <p:spPr>
-          <a:xfrm>
-            <a:off x="8321040" y="2880360"/>
-            <a:ext cx="3429000" cy="274320"/>
-          </a:xfrm>
-          <a:prstGeom prst="rect">
-            <a:avLst/>
-          </a:prstGeom>
-          <a:solidFill>
-            <a:srgbClr val="FDE2C4"/>
-          </a:solidFill>
-          <a:ln>
-            <a:noFill/>
-          </a:ln>
-          <a:effectLst/>
-        </p:spPr>
-        <p:style>
-          <a:lnRef idx="1">
-            <a:schemeClr val="accent1"/>
-          </a:lnRef>
-          <a:fillRef idx="3">
-            <a:schemeClr val="accent1"/>
-          </a:fillRef>
-          <a:effectRef idx="2">
-            <a:schemeClr val="accent1"/>
-          </a:effectRef>
-          <a:fontRef idx="minor">
-            <a:schemeClr val="lt1"/>
-          </a:fontRef>
-        </p:style>
-        <p:txBody>
-          <a:bodyPr rtlCol="0" anchor="ctr"/>
-          <a:lstStyle/>
-          <a:p>
-            <a:pPr algn="ctr"/>
-          </a:p>
-        </p:txBody>
-      </p:sp>
-      <p:sp>
-        <p:nvSpPr>
-          <p:cNvPr id="73" name="Rectangle 72"/>
-          <p:cNvSpPr/>
-          <p:nvPr/>
-        </p:nvSpPr>
-        <p:spPr>
-          <a:xfrm>
-            <a:off x="8321040" y="2880360"/>
-            <a:ext cx="73152" cy="274320"/>
-          </a:xfrm>
-          <a:prstGeom prst="rect">
-            <a:avLst/>
-          </a:prstGeom>
-          <a:solidFill>
-            <a:srgbClr val="E30613"/>
-          </a:solidFill>
-          <a:ln>
-            <a:noFill/>
-          </a:ln>
-          <a:effectLst/>
-        </p:spPr>
-        <p:style>
-          <a:lnRef idx="1">
-            <a:schemeClr val="accent1"/>
-          </a:lnRef>
-          <a:fillRef idx="3">
-            <a:schemeClr val="accent1"/>
-          </a:fillRef>
-          <a:effectRef idx="2">
-            <a:schemeClr val="accent1"/>
-          </a:effectRef>
-          <a:fontRef idx="minor">
-            <a:schemeClr val="lt1"/>
-          </a:fontRef>
-        </p:style>
-        <p:txBody>
-          <a:bodyPr rtlCol="0" anchor="ctr"/>
-          <a:lstStyle/>
-          <a:p>
-            <a:pPr algn="ctr"/>
-          </a:p>
-        </p:txBody>
-      </p:sp>
-      <p:sp>
-        <p:nvSpPr>
-          <p:cNvPr id="74" name="TextBox 73"/>
-          <p:cNvSpPr txBox="1"/>
-          <p:nvPr/>
-        </p:nvSpPr>
-        <p:spPr>
-          <a:xfrm>
-            <a:off x="8412480" y="2880360"/>
-            <a:ext cx="1051560" cy="274320"/>
-          </a:xfrm>
-          <a:prstGeom prst="rect">
-            <a:avLst/>
-          </a:prstGeom>
-          <a:noFill/>
-        </p:spPr>
-        <p:txBody>
-          <a:bodyPr wrap="square" lIns="36000" rIns="36000" tIns="18000" bIns="18000" anchor="ctr">
-            <a:spAutoFit/>
-          </a:bodyPr>
-          <a:lstStyle/>
-          <a:p>
-            <a:pPr algn="l"/>
-            <a:r>
-              <a:rPr sz="900" b="1" i="0" u="none">
-                <a:solidFill>
-                  <a:srgbClr val="9C060F"/>
-                </a:solidFill>
-                <a:latin typeface="Calibri"/>
-              </a:rPr>
-              <a:t>KV</a:t>
-            </a:r>
-          </a:p>
-        </p:txBody>
-      </p:sp>
-      <p:sp>
-        <p:nvSpPr>
-          <p:cNvPr id="75" name="TextBox 74"/>
-          <p:cNvSpPr txBox="1"/>
-          <p:nvPr/>
-        </p:nvSpPr>
-        <p:spPr>
-          <a:xfrm>
-            <a:off x="9464040" y="2880360"/>
-            <a:ext cx="1143000" cy="274320"/>
-          </a:xfrm>
-          <a:prstGeom prst="rect">
-            <a:avLst/>
-          </a:prstGeom>
-          <a:noFill/>
-        </p:spPr>
-        <p:txBody>
-          <a:bodyPr wrap="square" lIns="36000" rIns="36000" tIns="18000" bIns="18000" anchor="ctr">
-            <a:spAutoFit/>
-          </a:bodyPr>
-          <a:lstStyle/>
-          <a:p>
-            <a:pPr algn="ctr"/>
-            <a:r>
-              <a:rPr sz="900" b="1" i="0" u="none">
-                <a:solidFill>
-                  <a:srgbClr val="9C060F"/>
-                </a:solidFill>
-                <a:latin typeface="Calibri"/>
-              </a:rPr>
-              <a:t>1.147</a:t>
-            </a:r>
-          </a:p>
-        </p:txBody>
-      </p:sp>
-      <p:sp>
-        <p:nvSpPr>
-          <p:cNvPr id="76" name="TextBox 75"/>
-          <p:cNvSpPr txBox="1"/>
-          <p:nvPr/>
-        </p:nvSpPr>
-        <p:spPr>
-          <a:xfrm>
-            <a:off x="10607040" y="2880360"/>
-            <a:ext cx="1143000" cy="274320"/>
-          </a:xfrm>
-          <a:prstGeom prst="rect">
-            <a:avLst/>
-          </a:prstGeom>
-          <a:noFill/>
-        </p:spPr>
-        <p:txBody>
-          <a:bodyPr wrap="square" lIns="36000" rIns="36000" tIns="18000" bIns="18000" anchor="ctr">
-            <a:spAutoFit/>
-          </a:bodyPr>
-          <a:lstStyle/>
-          <a:p>
-            <a:pPr algn="ctr"/>
-            <a:r>
-              <a:rPr sz="900" b="1" i="0" u="none">
-                <a:solidFill>
-                  <a:srgbClr val="9C060F"/>
-                </a:solidFill>
-                <a:latin typeface="Calibri"/>
-              </a:rPr>
-              <a:t>354 (31 %)</a:t>
-            </a:r>
-          </a:p>
-        </p:txBody>
-      </p:sp>
-      <p:sp>
-        <p:nvSpPr>
-          <p:cNvPr id="77" name="Rectangle 76"/>
-          <p:cNvSpPr/>
-          <p:nvPr/>
-        </p:nvSpPr>
-        <p:spPr>
-          <a:xfrm>
-            <a:off x="8321040" y="3154680"/>
-            <a:ext cx="3429000" cy="274320"/>
-          </a:xfrm>
-          <a:prstGeom prst="rect">
-            <a:avLst/>
-          </a:prstGeom>
-          <a:solidFill>
-            <a:srgbClr val="E3ECEE"/>
-          </a:solidFill>
-          <a:ln>
-            <a:noFill/>
-          </a:ln>
-          <a:effectLst/>
-        </p:spPr>
-        <p:style>
-          <a:lnRef idx="1">
-            <a:schemeClr val="accent1"/>
-          </a:lnRef>
-          <a:fillRef idx="3">
-            <a:schemeClr val="accent1"/>
-          </a:fillRef>
-          <a:effectRef idx="2">
-            <a:schemeClr val="accent1"/>
-          </a:effectRef>
-          <a:fontRef idx="minor">
-            <a:schemeClr val="lt1"/>
-          </a:fontRef>
-        </p:style>
-        <p:txBody>
-          <a:bodyPr rtlCol="0" anchor="ctr"/>
-          <a:lstStyle/>
-          <a:p>
-            <a:pPr algn="ctr"/>
-          </a:p>
-        </p:txBody>
-      </p:sp>
-      <p:sp>
-        <p:nvSpPr>
-          <p:cNvPr id="78" name="TextBox 77"/>
-          <p:cNvSpPr txBox="1"/>
-          <p:nvPr/>
-        </p:nvSpPr>
-        <p:spPr>
-          <a:xfrm>
-            <a:off x="8412480" y="3154680"/>
-            <a:ext cx="1051560" cy="274320"/>
-          </a:xfrm>
-          <a:prstGeom prst="rect">
-            <a:avLst/>
-          </a:prstGeom>
-          <a:noFill/>
-        </p:spPr>
-        <p:txBody>
-          <a:bodyPr wrap="square" lIns="36000" rIns="36000" tIns="18000" bIns="18000" anchor="ctr">
-            <a:spAutoFit/>
-          </a:bodyPr>
-          <a:lstStyle/>
-          <a:p>
-            <a:pPr algn="l"/>
-            <a:r>
-              <a:rPr sz="900" b="1" i="0" u="none">
-                <a:solidFill>
-                  <a:srgbClr val="333333"/>
-                </a:solidFill>
-                <a:latin typeface="Calibri"/>
-              </a:rPr>
-              <a:t>Komposit</a:t>
-            </a:r>
-          </a:p>
-        </p:txBody>
-      </p:sp>
-      <p:sp>
-        <p:nvSpPr>
-          <p:cNvPr id="79" name="TextBox 78"/>
-          <p:cNvSpPr txBox="1"/>
-          <p:nvPr/>
-        </p:nvSpPr>
-        <p:spPr>
-          <a:xfrm>
-            <a:off x="9464040" y="3154680"/>
-            <a:ext cx="1143000" cy="274320"/>
-          </a:xfrm>
-          <a:prstGeom prst="rect">
-            <a:avLst/>
-          </a:prstGeom>
-          <a:noFill/>
-        </p:spPr>
-        <p:txBody>
-          <a:bodyPr wrap="square" lIns="36000" rIns="36000" tIns="18000" bIns="18000" anchor="ctr">
-            <a:spAutoFit/>
-          </a:bodyPr>
-          <a:lstStyle/>
-          <a:p>
-            <a:pPr algn="ctr"/>
-            <a:r>
-              <a:rPr sz="900" b="0" i="0" u="none">
-                <a:solidFill>
-                  <a:srgbClr val="333333"/>
-                </a:solidFill>
-                <a:latin typeface="Calibri"/>
-              </a:rPr>
-              <a:t>2.089</a:t>
-            </a:r>
-          </a:p>
-        </p:txBody>
-      </p:sp>
-      <p:sp>
-        <p:nvSpPr>
-          <p:cNvPr id="80" name="TextBox 79"/>
-          <p:cNvSpPr txBox="1"/>
-          <p:nvPr/>
-        </p:nvSpPr>
-        <p:spPr>
-          <a:xfrm>
-            <a:off x="10607040" y="3154680"/>
-            <a:ext cx="1143000" cy="274320"/>
-          </a:xfrm>
-          <a:prstGeom prst="rect">
-            <a:avLst/>
-          </a:prstGeom>
-          <a:noFill/>
-        </p:spPr>
-        <p:txBody>
-          <a:bodyPr wrap="square" lIns="36000" rIns="36000" tIns="18000" bIns="18000" anchor="ctr">
-            <a:spAutoFit/>
-          </a:bodyPr>
-          <a:lstStyle/>
-          <a:p>
-            <a:pPr algn="ctr"/>
-            <a:r>
-              <a:rPr sz="900" b="0" i="0" u="none">
-                <a:solidFill>
-                  <a:srgbClr val="333333"/>
-                </a:solidFill>
-                <a:latin typeface="Calibri"/>
-              </a:rPr>
-              <a:t>1.405 (67 %)</a:t>
-            </a:r>
-          </a:p>
-        </p:txBody>
-      </p:sp>
-      <p:sp>
-        <p:nvSpPr>
-          <p:cNvPr id="81" name="Rectangle 80"/>
-          <p:cNvSpPr/>
-          <p:nvPr/>
-        </p:nvSpPr>
-        <p:spPr>
-          <a:xfrm>
-            <a:off x="8321040" y="3429000"/>
-            <a:ext cx="3429000" cy="274320"/>
-          </a:xfrm>
-          <a:prstGeom prst="rect">
-            <a:avLst/>
-          </a:prstGeom>
-          <a:solidFill>
-            <a:srgbClr val="FFFFFF"/>
-          </a:solidFill>
-          <a:ln>
-            <a:noFill/>
-          </a:ln>
-          <a:effectLst/>
-        </p:spPr>
-        <p:style>
-          <a:lnRef idx="1">
-            <a:schemeClr val="accent1"/>
-          </a:lnRef>
-          <a:fillRef idx="3">
-            <a:schemeClr val="accent1"/>
-          </a:fillRef>
-          <a:effectRef idx="2">
-            <a:schemeClr val="accent1"/>
-          </a:effectRef>
-          <a:fontRef idx="minor">
-            <a:schemeClr val="lt1"/>
-          </a:fontRef>
-        </p:style>
-        <p:txBody>
-          <a:bodyPr rtlCol="0" anchor="ctr"/>
-          <a:lstStyle/>
-          <a:p>
-            <a:pPr algn="ctr"/>
-          </a:p>
-        </p:txBody>
-      </p:sp>
-      <p:sp>
-        <p:nvSpPr>
-          <p:cNvPr id="82" name="TextBox 81"/>
-          <p:cNvSpPr txBox="1"/>
-          <p:nvPr/>
-        </p:nvSpPr>
-        <p:spPr>
-          <a:xfrm>
-            <a:off x="8412480" y="3429000"/>
-            <a:ext cx="1051560" cy="274320"/>
-          </a:xfrm>
-          <a:prstGeom prst="rect">
-            <a:avLst/>
-          </a:prstGeom>
-          <a:noFill/>
-        </p:spPr>
-        <p:txBody>
-          <a:bodyPr wrap="square" lIns="36000" rIns="36000" tIns="18000" bIns="18000" anchor="ctr">
-            <a:spAutoFit/>
-          </a:bodyPr>
-          <a:lstStyle/>
-          <a:p>
-            <a:pPr algn="l"/>
-            <a:r>
-              <a:rPr sz="900" b="1" i="0" u="none">
-                <a:solidFill>
-                  <a:srgbClr val="333333"/>
-                </a:solidFill>
-                <a:latin typeface="Calibri"/>
-              </a:rPr>
-              <a:t>Leben</a:t>
-            </a:r>
-          </a:p>
-        </p:txBody>
-      </p:sp>
-      <p:sp>
-        <p:nvSpPr>
-          <p:cNvPr id="83" name="TextBox 82"/>
-          <p:cNvSpPr txBox="1"/>
-          <p:nvPr/>
-        </p:nvSpPr>
-        <p:spPr>
-          <a:xfrm>
-            <a:off x="9464040" y="3429000"/>
-            <a:ext cx="1143000" cy="274320"/>
-          </a:xfrm>
-          <a:prstGeom prst="rect">
-            <a:avLst/>
-          </a:prstGeom>
-          <a:noFill/>
-        </p:spPr>
-        <p:txBody>
-          <a:bodyPr wrap="square" lIns="36000" rIns="36000" tIns="18000" bIns="18000" anchor="ctr">
-            <a:spAutoFit/>
-          </a:bodyPr>
-          <a:lstStyle/>
-          <a:p>
-            <a:pPr algn="ctr"/>
-            <a:r>
-              <a:rPr sz="900" b="0" i="0" u="none">
-                <a:solidFill>
-                  <a:srgbClr val="333333"/>
-                </a:solidFill>
-                <a:latin typeface="Calibri"/>
-              </a:rPr>
-              <a:t>662</a:t>
-            </a:r>
-          </a:p>
-        </p:txBody>
-      </p:sp>
-      <p:sp>
-        <p:nvSpPr>
-          <p:cNvPr id="84" name="TextBox 83"/>
-          <p:cNvSpPr txBox="1"/>
-          <p:nvPr/>
-        </p:nvSpPr>
-        <p:spPr>
-          <a:xfrm>
-            <a:off x="10607040" y="3429000"/>
-            <a:ext cx="1143000" cy="274320"/>
-          </a:xfrm>
-          <a:prstGeom prst="rect">
-            <a:avLst/>
-          </a:prstGeom>
-          <a:noFill/>
-        </p:spPr>
-        <p:txBody>
-          <a:bodyPr wrap="square" lIns="36000" rIns="36000" tIns="18000" bIns="18000" anchor="ctr">
-            <a:spAutoFit/>
-          </a:bodyPr>
-          <a:lstStyle/>
-          <a:p>
-            <a:pPr algn="ctr"/>
-            <a:r>
-              <a:rPr sz="900" b="0" i="0" u="none">
-                <a:solidFill>
-                  <a:srgbClr val="333333"/>
-                </a:solidFill>
-                <a:latin typeface="Calibri"/>
-              </a:rPr>
-              <a:t>325 (49 %)</a:t>
-            </a:r>
-          </a:p>
-        </p:txBody>
-      </p:sp>
-      <p:sp>
-        <p:nvSpPr>
-          <p:cNvPr id="85" name="Rectangle 84"/>
-          <p:cNvSpPr/>
-          <p:nvPr/>
-        </p:nvSpPr>
-        <p:spPr>
-          <a:xfrm>
-            <a:off x="8321040" y="3703320"/>
-            <a:ext cx="3429000" cy="274320"/>
-          </a:xfrm>
-          <a:prstGeom prst="rect">
-            <a:avLst/>
-          </a:prstGeom>
-          <a:solidFill>
-            <a:srgbClr val="E3ECEE"/>
-          </a:solidFill>
-          <a:ln>
-            <a:noFill/>
-          </a:ln>
-          <a:effectLst/>
-        </p:spPr>
-        <p:style>
-          <a:lnRef idx="1">
-            <a:schemeClr val="accent1"/>
-          </a:lnRef>
-          <a:fillRef idx="3">
-            <a:schemeClr val="accent1"/>
-          </a:fillRef>
-          <a:effectRef idx="2">
-            <a:schemeClr val="accent1"/>
-          </a:effectRef>
-          <a:fontRef idx="minor">
-            <a:schemeClr val="lt1"/>
-          </a:fontRef>
-        </p:style>
-        <p:txBody>
-          <a:bodyPr rtlCol="0" anchor="ctr"/>
-          <a:lstStyle/>
-          <a:p>
-            <a:pPr algn="ctr"/>
-          </a:p>
-        </p:txBody>
-      </p:sp>
-      <p:sp>
-        <p:nvSpPr>
-          <p:cNvPr id="86" name="TextBox 85"/>
-          <p:cNvSpPr txBox="1"/>
-          <p:nvPr/>
-        </p:nvSpPr>
-        <p:spPr>
-          <a:xfrm>
-            <a:off x="8412480" y="3703320"/>
-            <a:ext cx="1051560" cy="274320"/>
-          </a:xfrm>
-          <a:prstGeom prst="rect">
-            <a:avLst/>
-          </a:prstGeom>
-          <a:noFill/>
-        </p:spPr>
-        <p:txBody>
-          <a:bodyPr wrap="square" lIns="36000" rIns="36000" tIns="18000" bIns="18000" anchor="ctr">
-            <a:spAutoFit/>
-          </a:bodyPr>
-          <a:lstStyle/>
-          <a:p>
-            <a:pPr algn="l"/>
-            <a:r>
-              <a:rPr sz="900" b="1" i="0" u="none">
-                <a:solidFill>
-                  <a:srgbClr val="333333"/>
-                </a:solidFill>
-                <a:latin typeface="Calibri"/>
-              </a:rPr>
-              <a:t>Sonstige</a:t>
-            </a:r>
-          </a:p>
-        </p:txBody>
-      </p:sp>
-      <p:sp>
-        <p:nvSpPr>
-          <p:cNvPr id="87" name="TextBox 86"/>
-          <p:cNvSpPr txBox="1"/>
-          <p:nvPr/>
-        </p:nvSpPr>
-        <p:spPr>
-          <a:xfrm>
-            <a:off x="9464040" y="3703320"/>
-            <a:ext cx="1143000" cy="274320"/>
-          </a:xfrm>
-          <a:prstGeom prst="rect">
-            <a:avLst/>
-          </a:prstGeom>
-          <a:noFill/>
-        </p:spPr>
-        <p:txBody>
-          <a:bodyPr wrap="square" lIns="36000" rIns="36000" tIns="18000" bIns="18000" anchor="ctr">
-            <a:spAutoFit/>
-          </a:bodyPr>
-          <a:lstStyle/>
-          <a:p>
-            <a:pPr algn="ctr"/>
-            <a:r>
-              <a:rPr sz="900" b="0" i="0" u="none">
-                <a:solidFill>
-                  <a:srgbClr val="333333"/>
-                </a:solidFill>
-                <a:latin typeface="Calibri"/>
-              </a:rPr>
-              <a:t>102</a:t>
-            </a:r>
-          </a:p>
-        </p:txBody>
-      </p:sp>
-      <p:sp>
-        <p:nvSpPr>
-          <p:cNvPr id="88" name="TextBox 87"/>
-          <p:cNvSpPr txBox="1"/>
-          <p:nvPr/>
-        </p:nvSpPr>
-        <p:spPr>
-          <a:xfrm>
-            <a:off x="10607040" y="3703320"/>
-            <a:ext cx="1143000" cy="274320"/>
-          </a:xfrm>
-          <a:prstGeom prst="rect">
-            <a:avLst/>
-          </a:prstGeom>
-          <a:noFill/>
-        </p:spPr>
-        <p:txBody>
-          <a:bodyPr wrap="square" lIns="36000" rIns="36000" tIns="18000" bIns="18000" anchor="ctr">
-            <a:spAutoFit/>
-          </a:bodyPr>
-          <a:lstStyle/>
-          <a:p>
-            <a:pPr algn="ctr"/>
-            <a:r>
-              <a:rPr sz="900" b="0" i="0" u="none">
-                <a:solidFill>
-                  <a:srgbClr val="333333"/>
-                </a:solidFill>
-                <a:latin typeface="Calibri"/>
-              </a:rPr>
-              <a:t>33 (32 %)</a:t>
-            </a:r>
-          </a:p>
-        </p:txBody>
-      </p:sp>
-      <p:sp>
-        <p:nvSpPr>
-          <p:cNvPr id="89" name="Rectangle 88"/>
-          <p:cNvSpPr/>
-          <p:nvPr/>
-        </p:nvSpPr>
-        <p:spPr>
-          <a:xfrm>
-            <a:off x="8321040" y="3977640"/>
-            <a:ext cx="3429000" cy="274320"/>
-          </a:xfrm>
-          <a:prstGeom prst="rect">
-            <a:avLst/>
-          </a:prstGeom>
-          <a:solidFill>
-            <a:srgbClr val="E9EFF1"/>
-          </a:solidFill>
-          <a:ln>
-            <a:noFill/>
-          </a:ln>
-          <a:effectLst/>
-        </p:spPr>
-        <p:style>
-          <a:lnRef idx="1">
-            <a:schemeClr val="accent1"/>
-          </a:lnRef>
-          <a:fillRef idx="3">
-            <a:schemeClr val="accent1"/>
-          </a:fillRef>
-          <a:effectRef idx="2">
-            <a:schemeClr val="accent1"/>
-          </a:effectRef>
-          <a:fontRef idx="minor">
-            <a:schemeClr val="lt1"/>
-          </a:fontRef>
-        </p:style>
-        <p:txBody>
-          <a:bodyPr rtlCol="0" anchor="ctr"/>
-          <a:lstStyle/>
-          <a:p>
-            <a:pPr algn="ctr"/>
-          </a:p>
-        </p:txBody>
-      </p:sp>
-      <p:sp>
-        <p:nvSpPr>
-          <p:cNvPr id="90" name="TextBox 89"/>
-          <p:cNvSpPr txBox="1"/>
-          <p:nvPr/>
-        </p:nvSpPr>
-        <p:spPr>
-          <a:xfrm>
-            <a:off x="8412480" y="3977640"/>
-            <a:ext cx="1051560" cy="274320"/>
-          </a:xfrm>
-          <a:prstGeom prst="rect">
-            <a:avLst/>
-          </a:prstGeom>
-          <a:noFill/>
-        </p:spPr>
-        <p:txBody>
-          <a:bodyPr wrap="square" lIns="36000" rIns="36000" tIns="18000" bIns="18000" anchor="ctr">
-            <a:spAutoFit/>
-          </a:bodyPr>
-          <a:lstStyle/>
-          <a:p>
-            <a:pPr algn="l"/>
-            <a:r>
-              <a:rPr sz="900" b="1" i="0" u="none">
-                <a:solidFill>
-                  <a:srgbClr val="333333"/>
-                </a:solidFill>
-                <a:latin typeface="Calibri"/>
-              </a:rPr>
-              <a:t>Gesamt</a:t>
-            </a:r>
-          </a:p>
-        </p:txBody>
-      </p:sp>
-      <p:sp>
-        <p:nvSpPr>
-          <p:cNvPr id="91" name="TextBox 90"/>
-          <p:cNvSpPr txBox="1"/>
-          <p:nvPr/>
-        </p:nvSpPr>
-        <p:spPr>
-          <a:xfrm>
-            <a:off x="9464040" y="3977640"/>
-            <a:ext cx="1143000" cy="274320"/>
-          </a:xfrm>
-          <a:prstGeom prst="rect">
-            <a:avLst/>
-          </a:prstGeom>
-          <a:noFill/>
-        </p:spPr>
-        <p:txBody>
-          <a:bodyPr wrap="square" lIns="36000" rIns="36000" tIns="18000" bIns="18000" anchor="ctr">
-            <a:spAutoFit/>
-          </a:bodyPr>
-          <a:lstStyle/>
-          <a:p>
-            <a:pPr algn="ctr"/>
-            <a:r>
-              <a:rPr sz="900" b="1" i="0" u="none">
-                <a:solidFill>
-                  <a:srgbClr val="333333"/>
-                </a:solidFill>
-                <a:latin typeface="Calibri"/>
-              </a:rPr>
-              <a:t>4.000</a:t>
-            </a:r>
-          </a:p>
-        </p:txBody>
-      </p:sp>
-      <p:sp>
-        <p:nvSpPr>
-          <p:cNvPr id="92" name="TextBox 91"/>
-          <p:cNvSpPr txBox="1"/>
-          <p:nvPr/>
-        </p:nvSpPr>
-        <p:spPr>
-          <a:xfrm>
-            <a:off x="10607040" y="3977640"/>
-            <a:ext cx="1143000" cy="274320"/>
-          </a:xfrm>
-          <a:prstGeom prst="rect">
-            <a:avLst/>
-          </a:prstGeom>
-          <a:noFill/>
-        </p:spPr>
-        <p:txBody>
-          <a:bodyPr wrap="square" lIns="36000" rIns="36000" tIns="18000" bIns="18000" anchor="ctr">
-            <a:spAutoFit/>
-          </a:bodyPr>
-          <a:lstStyle/>
-          <a:p>
-            <a:pPr algn="ctr"/>
-            <a:r>
-              <a:rPr sz="900" b="1" i="0" u="none">
-                <a:solidFill>
-                  <a:srgbClr val="333333"/>
-                </a:solidFill>
-                <a:latin typeface="Calibri"/>
-              </a:rPr>
-              <a:t>2.117 (53 %)</a:t>
-            </a:r>
-          </a:p>
-        </p:txBody>
-      </p:sp>
-      <p:sp>
-        <p:nvSpPr>
-          <p:cNvPr id="93" name="TextBox 92"/>
-          <p:cNvSpPr txBox="1"/>
-          <p:nvPr/>
-        </p:nvSpPr>
-        <p:spPr>
-          <a:xfrm>
-            <a:off x="8339328" y="4270248"/>
-            <a:ext cx="3392424" cy="256032"/>
-          </a:xfrm>
-          <a:prstGeom prst="rect">
-            <a:avLst/>
-          </a:prstGeom>
-          <a:noFill/>
-        </p:spPr>
-        <p:txBody>
-          <a:bodyPr wrap="square" lIns="36000" rIns="36000" tIns="18000" bIns="18000" anchor="t">
-            <a:spAutoFit/>
-          </a:bodyPr>
-          <a:lstStyle/>
-          <a:p>
-            <a:pPr algn="l"/>
-            <a:r>
-              <a:rPr sz="900" b="0" i="1" u="none">
-                <a:solidFill>
-                  <a:srgbClr val="9C060F"/>
-                </a:solidFill>
-                <a:latin typeface="Calibri"/>
-              </a:rPr>
-              <a:t>KV: kein VNR-Mapping → jede Mail = eigener Vorgang</a:t>
-            </a:r>
-          </a:p>
-        </p:txBody>
-      </p:sp>
-      <p:sp>
-        <p:nvSpPr>
-          <p:cNvPr id="94" name="Oval 93"/>
-          <p:cNvSpPr/>
-          <p:nvPr/>
-        </p:nvSpPr>
-        <p:spPr>
-          <a:xfrm>
-            <a:off x="8366760" y="4617720"/>
+            <a:off x="8366760" y="4535424"/>
             <a:ext cx="384048" cy="384048"/>
           </a:xfrm>
           <a:prstGeom prst="ellipse">
@@ -11073,13 +9674,13 @@
       </p:sp>
       <p:sp>
         <p:nvSpPr>
-          <p:cNvPr id="95" name="TextBox 94"/>
-          <p:cNvSpPr txBox="1"/>
-          <p:nvPr/>
-        </p:nvSpPr>
-        <p:spPr>
-          <a:xfrm>
-            <a:off x="8366760" y="4617720"/>
+          <p:cNvPr id="27" name="TextBox 26"/>
+          <p:cNvSpPr txBox="1"/>
+          <p:nvPr/>
+        </p:nvSpPr>
+        <p:spPr>
+          <a:xfrm>
+            <a:off x="8366760" y="4535424"/>
             <a:ext cx="384048" cy="384048"/>
           </a:xfrm>
           <a:prstGeom prst="rect">
@@ -11108,13 +9709,13 @@
       </p:sp>
       <p:sp>
         <p:nvSpPr>
-          <p:cNvPr id="96" name="TextBox 95"/>
-          <p:cNvSpPr txBox="1"/>
-          <p:nvPr/>
-        </p:nvSpPr>
-        <p:spPr>
-          <a:xfrm>
-            <a:off x="8851392" y="4599432"/>
+          <p:cNvPr id="28" name="TextBox 27"/>
+          <p:cNvSpPr txBox="1"/>
+          <p:nvPr/>
+        </p:nvSpPr>
+        <p:spPr>
+          <a:xfrm>
+            <a:off x="8851392" y="4517136"/>
             <a:ext cx="2880360" cy="256032"/>
           </a:xfrm>
           <a:prstGeom prst="rect">
@@ -11143,14 +9744,14 @@
       </p:sp>
       <p:sp>
         <p:nvSpPr>
-          <p:cNvPr id="97" name="TextBox 96"/>
-          <p:cNvSpPr txBox="1"/>
-          <p:nvPr/>
-        </p:nvSpPr>
-        <p:spPr>
-          <a:xfrm>
-            <a:off x="8851392" y="4855464"/>
-            <a:ext cx="2834640" cy="502920"/>
+          <p:cNvPr id="29" name="TextBox 28"/>
+          <p:cNvSpPr txBox="1"/>
+          <p:nvPr/>
+        </p:nvSpPr>
+        <p:spPr>
+          <a:xfrm>
+            <a:off x="8851392" y="4773168"/>
+            <a:ext cx="2834640" cy="457200"/>
           </a:xfrm>
           <a:prstGeom prst="rect">
             <a:avLst/>
@@ -11178,13 +9779,13 @@
       </p:sp>
       <p:sp>
         <p:nvSpPr>
-          <p:cNvPr id="98" name="Oval 97"/>
+          <p:cNvPr id="30" name="Oval 29"/>
           <p:cNvSpPr/>
           <p:nvPr/>
         </p:nvSpPr>
         <p:spPr>
           <a:xfrm>
-            <a:off x="8366760" y="5394960"/>
+            <a:off x="8366760" y="5212080"/>
             <a:ext cx="384048" cy="384048"/>
           </a:xfrm>
           <a:prstGeom prst="ellipse">
@@ -11224,13 +9825,13 @@
       </p:sp>
       <p:sp>
         <p:nvSpPr>
-          <p:cNvPr id="99" name="TextBox 98"/>
-          <p:cNvSpPr txBox="1"/>
-          <p:nvPr/>
-        </p:nvSpPr>
-        <p:spPr>
-          <a:xfrm>
-            <a:off x="8366760" y="5394960"/>
+          <p:cNvPr id="31" name="TextBox 30"/>
+          <p:cNvSpPr txBox="1"/>
+          <p:nvPr/>
+        </p:nvSpPr>
+        <p:spPr>
+          <a:xfrm>
+            <a:off x="8366760" y="5212080"/>
             <a:ext cx="384048" cy="384048"/>
           </a:xfrm>
           <a:prstGeom prst="rect">
@@ -11259,13 +9860,13 @@
       </p:sp>
       <p:sp>
         <p:nvSpPr>
-          <p:cNvPr id="100" name="TextBox 99"/>
-          <p:cNvSpPr txBox="1"/>
-          <p:nvPr/>
-        </p:nvSpPr>
-        <p:spPr>
-          <a:xfrm>
-            <a:off x="8851392" y="5376672"/>
+          <p:cNvPr id="32" name="TextBox 31"/>
+          <p:cNvSpPr txBox="1"/>
+          <p:nvPr/>
+        </p:nvSpPr>
+        <p:spPr>
+          <a:xfrm>
+            <a:off x="8851392" y="5193792"/>
             <a:ext cx="2880360" cy="256032"/>
           </a:xfrm>
           <a:prstGeom prst="rect">
@@ -11294,14 +9895,14 @@
       </p:sp>
       <p:sp>
         <p:nvSpPr>
-          <p:cNvPr id="101" name="TextBox 100"/>
-          <p:cNvSpPr txBox="1"/>
-          <p:nvPr/>
-        </p:nvSpPr>
-        <p:spPr>
-          <a:xfrm>
-            <a:off x="8851392" y="5632704"/>
-            <a:ext cx="2834640" cy="685800"/>
+          <p:cNvPr id="33" name="TextBox 32"/>
+          <p:cNvSpPr txBox="1"/>
+          <p:nvPr/>
+        </p:nvSpPr>
+        <p:spPr>
+          <a:xfrm>
+            <a:off x="8851392" y="5449824"/>
+            <a:ext cx="2834640" cy="603504"/>
           </a:xfrm>
           <a:prstGeom prst="rect">
             <a:avLst/>
@@ -11329,7 +9930,42 @@
       </p:sp>
       <p:sp>
         <p:nvSpPr>
-          <p:cNvPr id="102" name="TextBox 101"/>
+          <p:cNvPr id="34" name="TextBox 33"/>
+          <p:cNvSpPr txBox="1"/>
+          <p:nvPr/>
+        </p:nvSpPr>
+        <p:spPr>
+          <a:xfrm>
+            <a:off x="411480" y="5559552"/>
+            <a:ext cx="11338560" cy="182880"/>
+          </a:xfrm>
+          <a:prstGeom prst="rect">
+            <a:avLst/>
+          </a:prstGeom>
+          <a:noFill/>
+        </p:spPr>
+        <p:txBody>
+          <a:bodyPr wrap="square" lIns="36000" rIns="36000" tIns="18000" bIns="18000" anchor="t">
+            <a:spAutoFit/>
+          </a:bodyPr>
+          <a:lstStyle/>
+          <a:p>
+            <a:pPr algn="l"/>
+            <a:r>
+              <a:rPr sz="800" b="0" i="1" u="none">
+                <a:solidFill>
+                  <a:srgbClr val="666666"/>
+                </a:solidFill>
+                <a:latin typeface="Calibri"/>
+              </a:rPr>
+              <a:t>* BÜ-Anfragen = Mails mit Status 'Neue BÜ' (4.000 / Wo). Vorgang = eindeutige Kombination Makler + Kunde. Cluster = Vorgang mit &gt; 1 BÜ-Anfrage-Mail in derselben Woche.</a:t>
+            </a:r>
+          </a:p>
+        </p:txBody>
+      </p:sp>
+      <p:sp>
+        <p:nvSpPr>
+          <p:cNvPr id="35" name="TextBox 34"/>
           <p:cNvSpPr txBox="1"/>
           <p:nvPr/>
         </p:nvSpPr>
@@ -11364,7 +10000,7 @@
       </p:sp>
       <p:sp>
         <p:nvSpPr>
-          <p:cNvPr id="103" name="Rectangle 102"/>
+          <p:cNvPr id="36" name="Rectangle 35"/>
           <p:cNvSpPr/>
           <p:nvPr/>
         </p:nvSpPr>
@@ -11408,7 +10044,7 @@
       </p:sp>
       <p:sp>
         <p:nvSpPr>
-          <p:cNvPr id="104" name="TextBox 103"/>
+          <p:cNvPr id="37" name="TextBox 36"/>
           <p:cNvSpPr txBox="1"/>
           <p:nvPr/>
         </p:nvSpPr>

</xml_diff>

<commit_message>
PPTX Folie 12: Cluster-Box als klare Aufteilung 4.000 = 1.883 + 2.117
Box jetzt mit zwei Bullets statt einer langen Zeile:
  Die 4.000 BÜ-Anfragen teilen sich auf in:
  • 1.883 Einzelmails (47 %) — je ein einzelner Vorgang
  • 2.117 Mails (53 %) zu nur 612 Vorgängen — selber Makler schreibt
    mehrfach zum selben Kunden (Cluster)

Klare Aufteilung Singletons vs. Cluster, beide Mailzahlen ausgewiesen,
612 als Cluster-Vorgaenge-Anzahl konsistent zur Makler-Tabelle.

https://claude.ai/code/session_01UknXtYp2XECsQDonCZuxSt
</commit_message>
<xml_diff>
--- a/ERGO-Mengengeruest-2Slides-Berichtslook.pptx
+++ b/ERGO-Mengengeruest-2Slides-Berichtslook.pptx
@@ -8988,7 +8988,7 @@
         <p:spPr>
           <a:xfrm>
             <a:off x="411480" y="5276088"/>
-            <a:ext cx="7635240" cy="566928"/>
+            <a:ext cx="7635240" cy="868680"/>
           </a:xfrm>
           <a:prstGeom prst="rect">
             <a:avLst/>
@@ -9033,7 +9033,7 @@
         </p:nvSpPr>
         <p:spPr>
           <a:xfrm>
-            <a:off x="594360" y="5312664"/>
+            <a:off x="594360" y="5330952"/>
             <a:ext cx="7269480" cy="274320"/>
           </a:xfrm>
           <a:prstGeom prst="rect">
@@ -9055,7 +9055,7 @@
                 </a:solidFill>
                 <a:latin typeface="Calibri"/>
               </a:rPr>
-              <a:t>Cluster: 612 von 2.495 Vorgängen (25 %) bestehen aus mehreren Mails — zusammen 2.117 Mails (53 % aller BÜ-Anfragen)</a:t>
+              <a:t>Die 4.000 BÜ-Anfragen teilen sich auf in:</a:t>
             </a:r>
           </a:p>
         </p:txBody>
@@ -9068,8 +9068,8 @@
         </p:nvSpPr>
         <p:spPr>
           <a:xfrm>
-            <a:off x="594360" y="5568696"/>
-            <a:ext cx="7269480" cy="256032"/>
+            <a:off x="777240" y="5605272"/>
+            <a:ext cx="7086600" cy="237744"/>
           </a:xfrm>
           <a:prstGeom prst="rect">
             <a:avLst/>
@@ -9084,20 +9084,55 @@
           <a:p>
             <a:pPr algn="l"/>
             <a:r>
-              <a:rPr sz="1000" b="0" i="0" u="none">
+              <a:rPr sz="1100" b="0" i="0" u="none">
                 <a:solidFill>
                   <a:srgbClr val="333333"/>
                 </a:solidFill>
                 <a:latin typeface="Calibri"/>
               </a:rPr>
-              <a:t>Heute im Postkorb nicht gezielt auffindbar — Sachbearbeiter arbeiten unsortiert Mail für Mail ab.</a:t>
-            </a:r>
-          </a:p>
-        </p:txBody>
-      </p:sp>
-      <p:sp>
-        <p:nvSpPr>
-          <p:cNvPr id="22" name="Rectangle 21"/>
+              <a:t>• 1.883 Einzelmails (47 %) — je ein einzelner Vorgang</a:t>
+            </a:r>
+          </a:p>
+        </p:txBody>
+      </p:sp>
+      <p:sp>
+        <p:nvSpPr>
+          <p:cNvPr id="22" name="TextBox 21"/>
+          <p:cNvSpPr txBox="1"/>
+          <p:nvPr/>
+        </p:nvSpPr>
+        <p:spPr>
+          <a:xfrm>
+            <a:off x="777240" y="5861304"/>
+            <a:ext cx="7086600" cy="237744"/>
+          </a:xfrm>
+          <a:prstGeom prst="rect">
+            <a:avLst/>
+          </a:prstGeom>
+          <a:noFill/>
+        </p:spPr>
+        <p:txBody>
+          <a:bodyPr wrap="square" lIns="36000" rIns="36000" tIns="18000" bIns="18000" anchor="t">
+            <a:spAutoFit/>
+          </a:bodyPr>
+          <a:lstStyle/>
+          <a:p>
+            <a:pPr algn="l"/>
+            <a:r>
+              <a:rPr sz="1100" b="0" i="0" u="none">
+                <a:solidFill>
+                  <a:srgbClr val="333333"/>
+                </a:solidFill>
+                <a:latin typeface="Calibri"/>
+              </a:rPr>
+              <a:t>• 2.117 Mails (53 %) zu nur 612 Vorgängen — selber Makler schreibt mehrfach zum selben Kunden (Cluster)</a:t>
+            </a:r>
+          </a:p>
+        </p:txBody>
+      </p:sp>
+      <p:sp>
+        <p:nvSpPr>
+          <p:cNvPr id="23" name="Rectangle 22"/>
           <p:cNvSpPr/>
           <p:nvPr/>
         </p:nvSpPr>
@@ -9141,7 +9176,7 @@
       </p:sp>
       <p:sp>
         <p:nvSpPr>
-          <p:cNvPr id="23" name="TextBox 22"/>
+          <p:cNvPr id="24" name="TextBox 23"/>
           <p:cNvSpPr txBox="1"/>
           <p:nvPr/>
         </p:nvSpPr>
@@ -9176,7 +9211,7 @@
       </p:sp>
       <p:graphicFrame>
         <p:nvGraphicFramePr>
-          <p:cNvPr id="24" name="Table 23"/>
+          <p:cNvPr id="25" name="Table 24"/>
           <p:cNvGraphicFramePr>
             <a:graphicFrameLocks noGrp="1"/>
           </p:cNvGraphicFramePr>
@@ -9593,7 +9628,7 @@
       </p:graphicFrame>
       <p:sp>
         <p:nvSpPr>
-          <p:cNvPr id="25" name="TextBox 24"/>
+          <p:cNvPr id="26" name="TextBox 25"/>
           <p:cNvSpPr txBox="1"/>
           <p:nvPr/>
         </p:nvSpPr>
@@ -9628,7 +9663,7 @@
       </p:sp>
       <p:sp>
         <p:nvSpPr>
-          <p:cNvPr id="26" name="Oval 25"/>
+          <p:cNvPr id="27" name="Oval 26"/>
           <p:cNvSpPr/>
           <p:nvPr/>
         </p:nvSpPr>
@@ -9674,7 +9709,7 @@
       </p:sp>
       <p:sp>
         <p:nvSpPr>
-          <p:cNvPr id="27" name="TextBox 26"/>
+          <p:cNvPr id="28" name="TextBox 27"/>
           <p:cNvSpPr txBox="1"/>
           <p:nvPr/>
         </p:nvSpPr>
@@ -9709,7 +9744,7 @@
       </p:sp>
       <p:sp>
         <p:nvSpPr>
-          <p:cNvPr id="28" name="TextBox 27"/>
+          <p:cNvPr id="29" name="TextBox 28"/>
           <p:cNvSpPr txBox="1"/>
           <p:nvPr/>
         </p:nvSpPr>
@@ -9744,7 +9779,7 @@
       </p:sp>
       <p:sp>
         <p:nvSpPr>
-          <p:cNvPr id="29" name="TextBox 28"/>
+          <p:cNvPr id="30" name="TextBox 29"/>
           <p:cNvSpPr txBox="1"/>
           <p:nvPr/>
         </p:nvSpPr>
@@ -9779,7 +9814,7 @@
       </p:sp>
       <p:sp>
         <p:nvSpPr>
-          <p:cNvPr id="30" name="Oval 29"/>
+          <p:cNvPr id="31" name="Oval 30"/>
           <p:cNvSpPr/>
           <p:nvPr/>
         </p:nvSpPr>
@@ -9825,7 +9860,7 @@
       </p:sp>
       <p:sp>
         <p:nvSpPr>
-          <p:cNvPr id="31" name="TextBox 30"/>
+          <p:cNvPr id="32" name="TextBox 31"/>
           <p:cNvSpPr txBox="1"/>
           <p:nvPr/>
         </p:nvSpPr>
@@ -9860,7 +9895,7 @@
       </p:sp>
       <p:sp>
         <p:nvSpPr>
-          <p:cNvPr id="32" name="TextBox 31"/>
+          <p:cNvPr id="33" name="TextBox 32"/>
           <p:cNvSpPr txBox="1"/>
           <p:nvPr/>
         </p:nvSpPr>
@@ -9895,7 +9930,7 @@
       </p:sp>
       <p:sp>
         <p:nvSpPr>
-          <p:cNvPr id="33" name="TextBox 32"/>
+          <p:cNvPr id="34" name="TextBox 33"/>
           <p:cNvSpPr txBox="1"/>
           <p:nvPr/>
         </p:nvSpPr>
@@ -9930,7 +9965,7 @@
       </p:sp>
       <p:sp>
         <p:nvSpPr>
-          <p:cNvPr id="34" name="TextBox 33"/>
+          <p:cNvPr id="35" name="TextBox 34"/>
           <p:cNvSpPr txBox="1"/>
           <p:nvPr/>
         </p:nvSpPr>
@@ -9965,7 +10000,7 @@
       </p:sp>
       <p:sp>
         <p:nvSpPr>
-          <p:cNvPr id="35" name="TextBox 34"/>
+          <p:cNvPr id="36" name="TextBox 35"/>
           <p:cNvSpPr txBox="1"/>
           <p:nvPr/>
         </p:nvSpPr>
@@ -10000,7 +10035,7 @@
       </p:sp>
       <p:sp>
         <p:nvSpPr>
-          <p:cNvPr id="36" name="Rectangle 35"/>
+          <p:cNvPr id="37" name="Rectangle 36"/>
           <p:cNvSpPr/>
           <p:nvPr/>
         </p:nvSpPr>
@@ -10044,7 +10079,7 @@
       </p:sp>
       <p:sp>
         <p:nvSpPr>
-          <p:cNvPr id="37" name="TextBox 36"/>
+          <p:cNvPr id="38" name="TextBox 37"/>
           <p:cNvSpPr txBox="1"/>
           <p:nvPr/>
         </p:nvSpPr>

</xml_diff>

<commit_message>
PPTX Folie 12: Take-Away-Box rechts unter KV-Notiz
Statt zweier kleiner Erkenntnis/Moeglichkeit-Bloecke jetzt eine
zusammenhaengende Take-Away-Box rechts (Teal-Rahmen + Teal-Header):

  Viele dieser Vorgaenge haben Gemeinsamkeiten (selber Makler, Cluster,
  Prio-Fall) und wuerden sich fuer eine Priorisierung eignen — in der
  heutigen Postkorb-Welt sind sie aber nicht filterbar.

  Mit strukturierten Daten + Excel koennen Sachbearbeiter gezielt nach
  Prio-Makler oder Cluster filtern und gebuendelt abarbeiten, statt
  unsortiert Mail fuer Mail.

https://claude.ai/code/session_01UknXtYp2XECsQDonCZuxSt
</commit_message>
<xml_diff>
--- a/ERGO-Mengengeruest-2Slides-Berichtslook.pptx
+++ b/ERGO-Mengengeruest-2Slides-Berichtslook.pptx
@@ -9663,24 +9663,24 @@
       </p:sp>
       <p:sp>
         <p:nvSpPr>
-          <p:cNvPr id="27" name="Oval 26"/>
+          <p:cNvPr id="27" name="Rectangle 26"/>
           <p:cNvSpPr/>
           <p:nvPr/>
         </p:nvSpPr>
         <p:spPr>
           <a:xfrm>
-            <a:off x="8366760" y="4535424"/>
-            <a:ext cx="384048" cy="384048"/>
-          </a:xfrm>
-          <a:prstGeom prst="ellipse">
+            <a:off x="8321040" y="4535424"/>
+            <a:ext cx="3429000" cy="2011680"/>
+          </a:xfrm>
+          <a:prstGeom prst="rect">
             <a:avLst/>
           </a:prstGeom>
           <a:solidFill>
             <a:srgbClr val="FFFFFF"/>
           </a:solidFill>
-          <a:ln w="22225">
+          <a:ln w="15875">
             <a:solidFill>
-              <a:srgbClr val="C86E10"/>
+              <a:srgbClr val="008793"/>
             </a:solidFill>
           </a:ln>
           <a:effectLst/>
@@ -9709,130 +9709,23 @@
       </p:sp>
       <p:sp>
         <p:nvSpPr>
-          <p:cNvPr id="28" name="TextBox 27"/>
-          <p:cNvSpPr txBox="1"/>
-          <p:nvPr/>
-        </p:nvSpPr>
-        <p:spPr>
-          <a:xfrm>
-            <a:off x="8366760" y="4535424"/>
-            <a:ext cx="384048" cy="384048"/>
-          </a:xfrm>
-          <a:prstGeom prst="rect">
-            <a:avLst/>
-          </a:prstGeom>
-          <a:noFill/>
-        </p:spPr>
-        <p:txBody>
-          <a:bodyPr wrap="square" lIns="36000" rIns="36000" tIns="18000" bIns="18000" anchor="ctr">
-            <a:spAutoFit/>
-          </a:bodyPr>
-          <a:lstStyle/>
-          <a:p>
-            <a:pPr algn="ctr"/>
-            <a:r>
-              <a:rPr sz="1500" b="1" i="0" u="none">
-                <a:solidFill>
-                  <a:srgbClr val="C86E10"/>
-                </a:solidFill>
-                <a:latin typeface="Calibri"/>
-              </a:rPr>
-              <a:t>!</a:t>
-            </a:r>
-          </a:p>
-        </p:txBody>
-      </p:sp>
-      <p:sp>
-        <p:nvSpPr>
-          <p:cNvPr id="29" name="TextBox 28"/>
-          <p:cNvSpPr txBox="1"/>
-          <p:nvPr/>
-        </p:nvSpPr>
-        <p:spPr>
-          <a:xfrm>
-            <a:off x="8851392" y="4517136"/>
-            <a:ext cx="2880360" cy="256032"/>
-          </a:xfrm>
-          <a:prstGeom prst="rect">
-            <a:avLst/>
-          </a:prstGeom>
-          <a:noFill/>
-        </p:spPr>
-        <p:txBody>
-          <a:bodyPr wrap="square" lIns="36000" rIns="36000" tIns="18000" bIns="18000" anchor="t">
-            <a:spAutoFit/>
-          </a:bodyPr>
-          <a:lstStyle/>
-          <a:p>
-            <a:pPr algn="l"/>
-            <a:r>
-              <a:rPr sz="1200" b="1" i="0" u="none">
-                <a:solidFill>
-                  <a:srgbClr val="333333"/>
-                </a:solidFill>
-                <a:latin typeface="Calibri"/>
-              </a:rPr>
-              <a:t>Erkenntnis</a:t>
-            </a:r>
-          </a:p>
-        </p:txBody>
-      </p:sp>
-      <p:sp>
-        <p:nvSpPr>
-          <p:cNvPr id="30" name="TextBox 29"/>
-          <p:cNvSpPr txBox="1"/>
-          <p:nvPr/>
-        </p:nvSpPr>
-        <p:spPr>
-          <a:xfrm>
-            <a:off x="8851392" y="4773168"/>
-            <a:ext cx="2834640" cy="457200"/>
-          </a:xfrm>
-          <a:prstGeom prst="rect">
-            <a:avLst/>
-          </a:prstGeom>
-          <a:noFill/>
-        </p:spPr>
-        <p:txBody>
-          <a:bodyPr wrap="square" lIns="36000" rIns="36000" tIns="18000" bIns="18000" anchor="t">
-            <a:spAutoFit/>
-          </a:bodyPr>
-          <a:lstStyle/>
-          <a:p>
-            <a:pPr algn="l"/>
-            <a:r>
-              <a:rPr sz="1000" b="0" i="0" u="none">
-                <a:solidFill>
-                  <a:srgbClr val="333333"/>
-                </a:solidFill>
-                <a:latin typeface="Calibri"/>
-              </a:rPr>
-              <a:t>Diese Vorgänge sind im Postkorb heute nicht auffindbar.</a:t>
-            </a:r>
-          </a:p>
-        </p:txBody>
-      </p:sp>
-      <p:sp>
-        <p:nvSpPr>
-          <p:cNvPr id="31" name="Oval 30"/>
+          <p:cNvPr id="28" name="Rectangle 27"/>
           <p:cNvSpPr/>
           <p:nvPr/>
         </p:nvSpPr>
         <p:spPr>
           <a:xfrm>
-            <a:off x="8366760" y="5212080"/>
-            <a:ext cx="384048" cy="384048"/>
-          </a:xfrm>
-          <a:prstGeom prst="ellipse">
+            <a:off x="8321040" y="4535424"/>
+            <a:ext cx="3429000" cy="310896"/>
+          </a:xfrm>
+          <a:prstGeom prst="rect">
             <a:avLst/>
           </a:prstGeom>
           <a:solidFill>
-            <a:srgbClr val="FFFFFF"/>
+            <a:srgbClr val="008793"/>
           </a:solidFill>
-          <a:ln w="22225">
-            <a:solidFill>
-              <a:srgbClr val="008793"/>
-            </a:solidFill>
+          <a:ln>
+            <a:noFill/>
           </a:ln>
           <a:effectLst/>
         </p:spPr>
@@ -9860,14 +9753,14 @@
       </p:sp>
       <p:sp>
         <p:nvSpPr>
-          <p:cNvPr id="32" name="TextBox 31"/>
-          <p:cNvSpPr txBox="1"/>
-          <p:nvPr/>
-        </p:nvSpPr>
-        <p:spPr>
-          <a:xfrm>
-            <a:off x="8366760" y="5212080"/>
-            <a:ext cx="384048" cy="384048"/>
+          <p:cNvPr id="29" name="TextBox 28"/>
+          <p:cNvSpPr txBox="1"/>
+          <p:nvPr/>
+        </p:nvSpPr>
+        <p:spPr>
+          <a:xfrm>
+            <a:off x="8430768" y="4535424"/>
+            <a:ext cx="3246120" cy="310896"/>
           </a:xfrm>
           <a:prstGeom prst="rect">
             <a:avLst/>
@@ -9880,29 +9773,29 @@
           </a:bodyPr>
           <a:lstStyle/>
           <a:p>
-            <a:pPr algn="ctr"/>
-            <a:r>
-              <a:rPr sz="1500" b="1" i="0" u="none">
-                <a:solidFill>
-                  <a:srgbClr val="008793"/>
-                </a:solidFill>
-                <a:latin typeface="Calibri"/>
-              </a:rPr>
-              <a:t>→</a:t>
-            </a:r>
-          </a:p>
-        </p:txBody>
-      </p:sp>
-      <p:sp>
-        <p:nvSpPr>
-          <p:cNvPr id="33" name="TextBox 32"/>
-          <p:cNvSpPr txBox="1"/>
-          <p:nvPr/>
-        </p:nvSpPr>
-        <p:spPr>
-          <a:xfrm>
-            <a:off x="8851392" y="5193792"/>
-            <a:ext cx="2880360" cy="256032"/>
+            <a:pPr algn="l"/>
+            <a:r>
+              <a:rPr sz="1200" b="1" i="0" u="none">
+                <a:solidFill>
+                  <a:srgbClr val="FFFFFF"/>
+                </a:solidFill>
+                <a:latin typeface="Calibri"/>
+              </a:rPr>
+              <a:t>Take-Away</a:t>
+            </a:r>
+          </a:p>
+        </p:txBody>
+      </p:sp>
+      <p:sp>
+        <p:nvSpPr>
+          <p:cNvPr id="30" name="TextBox 29"/>
+          <p:cNvSpPr txBox="1"/>
+          <p:nvPr/>
+        </p:nvSpPr>
+        <p:spPr>
+          <a:xfrm>
+            <a:off x="8430768" y="4919472"/>
+            <a:ext cx="3209544" cy="1554480"/>
           </a:xfrm>
           <a:prstGeom prst="rect">
             <a:avLst/>
@@ -9917,38 +9810,15 @@
           <a:p>
             <a:pPr algn="l"/>
             <a:r>
-              <a:rPr sz="1200" b="1" i="0" u="none">
+              <a:rPr sz="1000" b="0" i="0" u="none">
                 <a:solidFill>
                   <a:srgbClr val="333333"/>
                 </a:solidFill>
                 <a:latin typeface="Calibri"/>
               </a:rPr>
-              <a:t>Möglichkeit</a:t>
-            </a:r>
-          </a:p>
-        </p:txBody>
-      </p:sp>
-      <p:sp>
-        <p:nvSpPr>
-          <p:cNvPr id="34" name="TextBox 33"/>
-          <p:cNvSpPr txBox="1"/>
-          <p:nvPr/>
-        </p:nvSpPr>
-        <p:spPr>
-          <a:xfrm>
-            <a:off x="8851392" y="5449824"/>
-            <a:ext cx="2834640" cy="603504"/>
-          </a:xfrm>
-          <a:prstGeom prst="rect">
-            <a:avLst/>
-          </a:prstGeom>
-          <a:noFill/>
-        </p:spPr>
-        <p:txBody>
-          <a:bodyPr wrap="square" lIns="36000" rIns="36000" tIns="18000" bIns="18000" anchor="t">
-            <a:spAutoFit/>
-          </a:bodyPr>
-          <a:lstStyle/>
+              <a:t>Viele dieser Vorgänge haben Gemeinsamkeiten (selber Makler, Cluster, Prio-Fall) und würden sich für eine Priorisierung eignen — in der heutigen Postkorb-Welt sind sie aber nicht filterbar.</a:t>
+            </a:r>
+          </a:p>
           <a:p>
             <a:pPr algn="l"/>
             <a:r>
@@ -9958,14 +9828,26 @@
                 </a:solidFill>
                 <a:latin typeface="Calibri"/>
               </a:rPr>
-              <a:t>Strukturierung + Excel: gezielt alle Vorgänge eines Prio-Maklers oder alle mit Cluster gebündelt abarbeiten.</a:t>
-            </a:r>
-          </a:p>
-        </p:txBody>
-      </p:sp>
-      <p:sp>
-        <p:nvSpPr>
-          <p:cNvPr id="35" name="TextBox 34"/>
+              <a:t/>
+            </a:r>
+          </a:p>
+          <a:p>
+            <a:pPr algn="l"/>
+            <a:r>
+              <a:rPr sz="1000" b="0" i="0" u="none">
+                <a:solidFill>
+                  <a:srgbClr val="333333"/>
+                </a:solidFill>
+                <a:latin typeface="Calibri"/>
+              </a:rPr>
+              <a:t>Mit strukturierten Daten + Excel können Sachbearbeiter gezielt nach Prio-Makler oder Cluster filtern und gebündelt abarbeiten, statt unsortiert Mail für Mail.</a:t>
+            </a:r>
+          </a:p>
+        </p:txBody>
+      </p:sp>
+      <p:sp>
+        <p:nvSpPr>
+          <p:cNvPr id="31" name="TextBox 30"/>
           <p:cNvSpPr txBox="1"/>
           <p:nvPr/>
         </p:nvSpPr>
@@ -10000,7 +9882,7 @@
       </p:sp>
       <p:sp>
         <p:nvSpPr>
-          <p:cNvPr id="36" name="TextBox 35"/>
+          <p:cNvPr id="32" name="TextBox 31"/>
           <p:cNvSpPr txBox="1"/>
           <p:nvPr/>
         </p:nvSpPr>
@@ -10035,7 +9917,7 @@
       </p:sp>
       <p:sp>
         <p:nvSpPr>
-          <p:cNvPr id="37" name="Rectangle 36"/>
+          <p:cNvPr id="33" name="Rectangle 32"/>
           <p:cNvSpPr/>
           <p:nvPr/>
         </p:nvSpPr>
@@ -10079,7 +9961,7 @@
       </p:sp>
       <p:sp>
         <p:nvSpPr>
-          <p:cNvPr id="38" name="TextBox 37"/>
+          <p:cNvPr id="34" name="TextBox 33"/>
           <p:cNvSpPr txBox="1"/>
           <p:nvPr/>
         </p:nvSpPr>

</xml_diff>